<commit_message>
feat: the rest of the CLI in English and Russian (0.6.4)
- Commander's own messages (missing argument, unknown command or option,
  "did you mean") follow the locale.
- Every command's --help is translated: titles, the description of every
  option, -h and -V. English output is byte-identical; the JSON help
  catalog stays English.
- The init wizard passes translated key hints to its prompts.
- The Russian catalog no longer leaves English words in its messages; a test
  keeps it that way.
- CONTRIBUTING.md explains how to add a language.
</commit_message>
<xml_diff>
--- a/docs/demo/sdlc-calculator-demo.en.pptx
+++ b/docs/demo/sdlc-calculator-demo.en.pptx
@@ -6565,7 +6565,7 @@
                 <a:ea typeface="Courier New" pitchFamily="34" charset="-122"/>
                 <a:cs typeface="Courier New" pitchFamily="34" charset="-120"/>
               </a:rPr>
-              <a:t>  code-owner (e9d5638215e4)</a:t>
+              <a:t>  code-owner (00ccae023886)</a:t>
             </a:r>
             <a:endParaRPr lang="en-US" sz="1000" dirty="0"/>
           </a:p>
@@ -7246,7 +7246,7 @@
                 <a:ea typeface="Courier New" pitchFamily="34" charset="-122"/>
                 <a:cs typeface="Courier New" pitchFamily="34" charset="-120"/>
               </a:rPr>
-              <a:t>  release-manager (e9d5638215e4)</a:t>
+              <a:t>  release-manager (00ccae023886)</a:t>
             </a:r>
             <a:endParaRPr lang="en-US" sz="1000" dirty="0"/>
           </a:p>
@@ -7546,7 +7546,7 @@
                 <a:ea typeface="Courier New" pitchFamily="34" charset="-122"/>
                 <a:cs typeface="Courier New" pitchFamily="34" charset="-120"/>
               </a:rPr>
-              <a:t>✓ basic-arithmetic/intent alice valid 8bd3f527</a:t>
+              <a:t>✓ basic-arithmetic/intent alice valid fc081258</a:t>
             </a:r>
             <a:endParaRPr lang="en-US" sz="1000" dirty="0"/>
           </a:p>
@@ -7563,7 +7563,7 @@
                 <a:ea typeface="Courier New" pitchFamily="34" charset="-122"/>
                 <a:cs typeface="Courier New" pitchFamily="34" charset="-120"/>
               </a:rPr>
-              <a:t>✓ basic-arithmetic/spec alice valid 8bd3f527</a:t>
+              <a:t>✓ basic-arithmetic/spec alice valid fc081258</a:t>
             </a:r>
             <a:endParaRPr lang="en-US" sz="1000" dirty="0"/>
           </a:p>
@@ -7580,7 +7580,7 @@
                 <a:ea typeface="Courier New" pitchFamily="34" charset="-122"/>
                 <a:cs typeface="Courier New" pitchFamily="34" charset="-120"/>
               </a:rPr>
-              <a:t>✗ basic-arithmetic/plan bob unsigned 9d267f10</a:t>
+              <a:t>✗ basic-arithmetic/plan bob unsigned 877b0c71</a:t>
             </a:r>
             <a:endParaRPr lang="en-US" sz="1000" dirty="0"/>
           </a:p>
@@ -7597,7 +7597,7 @@
                 <a:ea typeface="Courier New" pitchFamily="34" charset="-122"/>
                 <a:cs typeface="Courier New" pitchFamily="34" charset="-120"/>
               </a:rPr>
-              <a:t>✓ basic-arithmetic/review carol valid 2a0a0907</a:t>
+              <a:t>✓ basic-arithmetic/review carol valid b69c6383</a:t>
             </a:r>
             <a:endParaRPr lang="en-US" sz="1000" dirty="0"/>
           </a:p>
@@ -7614,7 +7614,7 @@
                 <a:ea typeface="Courier New" pitchFamily="34" charset="-122"/>
                 <a:cs typeface="Courier New" pitchFamily="34" charset="-120"/>
               </a:rPr>
-              <a:t>✓ basic-arithmetic/release alice valid ced6aada</a:t>
+              <a:t>✓ basic-arithmetic/release alice valid 59187a67</a:t>
             </a:r>
             <a:endParaRPr lang="en-US" sz="1000" dirty="0"/>
           </a:p>
@@ -7631,7 +7631,7 @@
                 <a:ea typeface="Courier New" pitchFamily="34" charset="-122"/>
                 <a:cs typeface="Courier New" pitchFamily="34" charset="-120"/>
               </a:rPr>
-              <a:t>✓ openspec/roles.yaml alice@calc.example valid ef669d1c</a:t>
+              <a:t>✓ openspec/roles.yaml alice@calc.example valid 226803bd</a:t>
             </a:r>
             <a:endParaRPr lang="en-US" sz="1000" dirty="0"/>
           </a:p>
@@ -13460,7 +13460,7 @@
                 <a:ea typeface="Courier New" pitchFamily="34" charset="-122"/>
                 <a:cs typeface="Courier New" pitchFamily="34" charset="-120"/>
               </a:rPr>
-              <a:t>  archived) · sdlc 0.6.3, license:</a:t>
+              <a:t>  archived) · sdlc 0.6.4, license:</a:t>
             </a:r>
             <a:endParaRPr lang="en-US" sz="1000" dirty="0"/>
           </a:p>
@@ -13596,7 +13596,7 @@
                 <a:ea typeface="Courier New" pitchFamily="34" charset="-122"/>
                 <a:cs typeface="Courier New" pitchFamily="34" charset="-120"/>
               </a:rPr>
-              <a:t>  recorded with sdlc 0.6.3; licenses:</a:t>
+              <a:t>  recorded with sdlc 0.6.4; licenses:</a:t>
             </a:r>
             <a:endParaRPr lang="en-US" sz="1000" dirty="0"/>
           </a:p>
@@ -13913,7 +13913,7 @@
                 <a:ea typeface="Courier New" pitchFamily="34" charset="-122"/>
                 <a:cs typeface="Courier New" pitchFamily="34" charset="-120"/>
               </a:rPr>
-              <a:t>2026-10-04T19:50:38.766Z  deferred.added   </a:t>
+              <a:t>2026-10-04T21:06:15.602Z  deferred.added   </a:t>
             </a:r>
             <a:endParaRPr lang="en-US" sz="1000" dirty="0"/>
           </a:p>
@@ -13964,7 +13964,7 @@
                 <a:ea typeface="Courier New" pitchFamily="34" charset="-122"/>
                 <a:cs typeface="Courier New" pitchFamily="34" charset="-120"/>
               </a:rPr>
-              <a:t>  shows an error [sdlc 0.6.3 · community]</a:t>
+              <a:t>  shows an error [sdlc 0.6.4 · community]</a:t>
             </a:r>
             <a:endParaRPr lang="en-US" sz="1000" dirty="0"/>
           </a:p>
@@ -13981,7 +13981,7 @@
                 <a:ea typeface="Courier New" pitchFamily="34" charset="-122"/>
                 <a:cs typeface="Courier New" pitchFamily="34" charset="-120"/>
               </a:rPr>
-              <a:t>2026-10-04T19:50:44.549Z  gate.review.appro</a:t>
+              <a:t>2026-10-04T21:06:21.055Z  gate.review.appro</a:t>
             </a:r>
             <a:endParaRPr lang="en-US" sz="1000" dirty="0"/>
           </a:p>
@@ -14032,7 +14032,7 @@
                 <a:ea typeface="Courier New" pitchFamily="34" charset="-122"/>
                 <a:cs typeface="Courier New" pitchFamily="34" charset="-120"/>
               </a:rPr>
-              <a:t>  [sdlc 0.6.3 · community]</a:t>
+              <a:t>  [sdlc 0.6.4 · community]</a:t>
             </a:r>
             <a:endParaRPr lang="en-US" sz="1000" dirty="0"/>
           </a:p>
@@ -14049,7 +14049,7 @@
                 <a:ea typeface="Courier New" pitchFamily="34" charset="-122"/>
                 <a:cs typeface="Courier New" pitchFamily="34" charset="-120"/>
               </a:rPr>
-              <a:t>2026-10-04T19:50:47.563Z  gate.release.appr</a:t>
+              <a:t>2026-10-04T21:06:23.917Z  gate.release.appr</a:t>
             </a:r>
             <a:endParaRPr lang="en-US" sz="1000" dirty="0"/>
           </a:p>
@@ -14100,7 +14100,7 @@
                 <a:ea typeface="Courier New" pitchFamily="34" charset="-122"/>
                 <a:cs typeface="Courier New" pitchFamily="34" charset="-120"/>
               </a:rPr>
-              <a:t>  release-manager [sdlc 0.6.3 · community]</a:t>
+              <a:t>  release-manager [sdlc 0.6.4 · community]</a:t>
             </a:r>
             <a:endParaRPr lang="en-US" sz="1000" dirty="0"/>
           </a:p>
@@ -14117,7 +14117,7 @@
                 <a:ea typeface="Courier New" pitchFamily="34" charset="-122"/>
                 <a:cs typeface="Courier New" pitchFamily="34" charset="-120"/>
               </a:rPr>
-              <a:t>2026-10-04T19:50:54.441Z  change.archived  </a:t>
+              <a:t>2026-10-04T21:06:30.564Z  change.archived  </a:t>
             </a:r>
             <a:endParaRPr lang="en-US" sz="1000" dirty="0"/>
           </a:p>
@@ -22808,7 +22808,7 @@
                 <a:ea typeface="Courier New" pitchFamily="34" charset="-122"/>
                 <a:cs typeface="Courier New" pitchFamily="34" charset="-120"/>
               </a:rPr>
-              <a:t>  sdlc 0.6.3, license: community</a:t>
+              <a:t>  sdlc 0.6.4, license: community</a:t>
             </a:r>
             <a:endParaRPr lang="en-US" sz="1000" dirty="0"/>
           </a:p>

</xml_diff>

<commit_message>
feat: sdlc backlog epic edit (0.7.2)
- sdlc backlog epic edit <E-id> changes an epic's title or goal (--title,
  --goal, --clear-goal), for example to retarget an epic to another version.
  Items and their order never change; any actor may run it.
</commit_message>
<xml_diff>
--- a/docs/demo/sdlc-calculator-demo.en.pptx
+++ b/docs/demo/sdlc-calculator-demo.en.pptx
@@ -5018,7 +5018,7 @@
                 <a:ea typeface="Courier New" pitchFamily="34" charset="-122"/>
                 <a:cs typeface="Courier New" pitchFamily="34" charset="-120"/>
               </a:rPr>
-              <a:t>✓ test (1.1s)</a:t>
+              <a:t>✓ test (1.0s)</a:t>
             </a:r>
             <a:endParaRPr lang="en-US" sz="1000" dirty="0"/>
           </a:p>
@@ -6566,7 +6566,7 @@
                 <a:ea typeface="Courier New" pitchFamily="34" charset="-122"/>
                 <a:cs typeface="Courier New" pitchFamily="34" charset="-120"/>
               </a:rPr>
-              <a:t>  code-owner (a2e7bf94c267)</a:t>
+              <a:t>  code-owner (85e76c97d625)</a:t>
             </a:r>
             <a:endParaRPr lang="en-US" sz="1000" dirty="0"/>
           </a:p>
@@ -7247,7 +7247,7 @@
                 <a:ea typeface="Courier New" pitchFamily="34" charset="-122"/>
                 <a:cs typeface="Courier New" pitchFamily="34" charset="-120"/>
               </a:rPr>
-              <a:t>  release-manager (a2e7bf94c267)</a:t>
+              <a:t>  release-manager (85e76c97d625)</a:t>
             </a:r>
             <a:endParaRPr lang="en-US" sz="1000" dirty="0"/>
           </a:p>
@@ -7547,7 +7547,7 @@
                 <a:ea typeface="Courier New" pitchFamily="34" charset="-122"/>
                 <a:cs typeface="Courier New" pitchFamily="34" charset="-120"/>
               </a:rPr>
-              <a:t>✓ basic-arithmetic/intent alice valid b5854efb</a:t>
+              <a:t>✓ basic-arithmetic/intent alice valid adbf5d87</a:t>
             </a:r>
             <a:endParaRPr lang="en-US" sz="1000" dirty="0"/>
           </a:p>
@@ -7564,7 +7564,7 @@
                 <a:ea typeface="Courier New" pitchFamily="34" charset="-122"/>
                 <a:cs typeface="Courier New" pitchFamily="34" charset="-120"/>
               </a:rPr>
-              <a:t>✓ basic-arithmetic/spec alice valid b5854efb</a:t>
+              <a:t>✓ basic-arithmetic/spec alice valid adbf5d87</a:t>
             </a:r>
             <a:endParaRPr lang="en-US" sz="1000" dirty="0"/>
           </a:p>
@@ -7581,7 +7581,7 @@
                 <a:ea typeface="Courier New" pitchFamily="34" charset="-122"/>
                 <a:cs typeface="Courier New" pitchFamily="34" charset="-120"/>
               </a:rPr>
-              <a:t>✗ basic-arithmetic/plan bob unsigned d99862f2</a:t>
+              <a:t>✗ basic-arithmetic/plan bob unsigned 0d7032b7</a:t>
             </a:r>
             <a:endParaRPr lang="en-US" sz="1000" dirty="0"/>
           </a:p>
@@ -7598,7 +7598,7 @@
                 <a:ea typeface="Courier New" pitchFamily="34" charset="-122"/>
                 <a:cs typeface="Courier New" pitchFamily="34" charset="-120"/>
               </a:rPr>
-              <a:t>✓ basic-arithmetic/review carol valid 2e697d7f</a:t>
+              <a:t>✓ basic-arithmetic/review carol valid 126b5c9f</a:t>
             </a:r>
             <a:endParaRPr lang="en-US" sz="1000" dirty="0"/>
           </a:p>
@@ -7615,7 +7615,7 @@
                 <a:ea typeface="Courier New" pitchFamily="34" charset="-122"/>
                 <a:cs typeface="Courier New" pitchFamily="34" charset="-120"/>
               </a:rPr>
-              <a:t>✓ basic-arithmetic/release alice valid 08d27328</a:t>
+              <a:t>✓ basic-arithmetic/release alice valid 65b45c43</a:t>
             </a:r>
             <a:endParaRPr lang="en-US" sz="1000" dirty="0"/>
           </a:p>
@@ -7632,7 +7632,7 @@
                 <a:ea typeface="Courier New" pitchFamily="34" charset="-122"/>
                 <a:cs typeface="Courier New" pitchFamily="34" charset="-120"/>
               </a:rPr>
-              <a:t>✓ openspec/roles.yaml alice@calc.example valid 1765cc16</a:t>
+              <a:t>✓ openspec/roles.yaml alice@calc.example valid b3da9c0c</a:t>
             </a:r>
             <a:endParaRPr lang="en-US" sz="1000" dirty="0"/>
           </a:p>
@@ -13671,7 +13671,7 @@
                 <a:ea typeface="Courier New" pitchFamily="34" charset="-122"/>
                 <a:cs typeface="Courier New" pitchFamily="34" charset="-120"/>
               </a:rPr>
-              <a:t>  archived) · sdlc 0.7.1, license:</a:t>
+              <a:t>  archived) · sdlc 0.7.2, license:</a:t>
             </a:r>
             <a:endParaRPr lang="en-US" sz="1000" dirty="0"/>
           </a:p>
@@ -13807,7 +13807,7 @@
                 <a:ea typeface="Courier New" pitchFamily="34" charset="-122"/>
                 <a:cs typeface="Courier New" pitchFamily="34" charset="-120"/>
               </a:rPr>
-              <a:t>  recorded with sdlc 0.7.1; licenses:</a:t>
+              <a:t>  recorded with sdlc 0.7.2; licenses:</a:t>
             </a:r>
             <a:endParaRPr lang="en-US" sz="1000" dirty="0"/>
           </a:p>
@@ -14090,7 +14090,7 @@
                 <a:ea typeface="Courier New" pitchFamily="34" charset="-122"/>
                 <a:cs typeface="Courier New" pitchFamily="34" charset="-120"/>
               </a:rPr>
-              <a:t>(last 15 of 32 entries; --limit to see</a:t>
+              <a:t>(last 15 of 33 entries; --limit to see</a:t>
             </a:r>
             <a:endParaRPr lang="en-US" sz="1000" dirty="0"/>
           </a:p>
@@ -14124,7 +14124,7 @@
                 <a:ea typeface="Courier New" pitchFamily="34" charset="-122"/>
                 <a:cs typeface="Courier New" pitchFamily="34" charset="-120"/>
               </a:rPr>
-              <a:t>2026-10-05T11:04:50.489Z  deferred.added   </a:t>
+              <a:t>2026-10-05T12:39:34.297Z  deferred.added   </a:t>
             </a:r>
             <a:endParaRPr lang="en-US" sz="1000" dirty="0"/>
           </a:p>
@@ -14175,7 +14175,7 @@
                 <a:ea typeface="Courier New" pitchFamily="34" charset="-122"/>
                 <a:cs typeface="Courier New" pitchFamily="34" charset="-120"/>
               </a:rPr>
-              <a:t>  shows an error [sdlc 0.7.1 · community]</a:t>
+              <a:t>  shows an error [sdlc 0.7.2 · community]</a:t>
             </a:r>
             <a:endParaRPr lang="en-US" sz="1000" dirty="0"/>
           </a:p>
@@ -14192,7 +14192,7 @@
                 <a:ea typeface="Courier New" pitchFamily="34" charset="-122"/>
                 <a:cs typeface="Courier New" pitchFamily="34" charset="-120"/>
               </a:rPr>
-              <a:t>2026-10-05T11:04:56.119Z  gate.review.appro</a:t>
+              <a:t>2026-10-05T12:39:38.980Z  gate.review.appro</a:t>
             </a:r>
             <a:endParaRPr lang="en-US" sz="1000" dirty="0"/>
           </a:p>
@@ -14243,7 +14243,7 @@
                 <a:ea typeface="Courier New" pitchFamily="34" charset="-122"/>
                 <a:cs typeface="Courier New" pitchFamily="34" charset="-120"/>
               </a:rPr>
-              <a:t>  [sdlc 0.7.1 · community]</a:t>
+              <a:t>  [sdlc 0.7.2 · community]</a:t>
             </a:r>
             <a:endParaRPr lang="en-US" sz="1000" dirty="0"/>
           </a:p>
@@ -14260,7 +14260,7 @@
                 <a:ea typeface="Courier New" pitchFamily="34" charset="-122"/>
                 <a:cs typeface="Courier New" pitchFamily="34" charset="-120"/>
               </a:rPr>
-              <a:t>2026-10-05T11:04:58.990Z  gate.release.appr</a:t>
+              <a:t>2026-10-05T12:39:41.022Z  gate.release.appr</a:t>
             </a:r>
             <a:endParaRPr lang="en-US" sz="1000" dirty="0"/>
           </a:p>
@@ -14311,7 +14311,7 @@
                 <a:ea typeface="Courier New" pitchFamily="34" charset="-122"/>
                 <a:cs typeface="Courier New" pitchFamily="34" charset="-120"/>
               </a:rPr>
-              <a:t>  release-manager [sdlc 0.7.1 · community]</a:t>
+              <a:t>  release-manager [sdlc 0.7.2 · community]</a:t>
             </a:r>
             <a:endParaRPr lang="en-US" sz="1000" dirty="0"/>
           </a:p>
@@ -14328,7 +14328,7 @@
                 <a:ea typeface="Courier New" pitchFamily="34" charset="-122"/>
                 <a:cs typeface="Courier New" pitchFamily="34" charset="-120"/>
               </a:rPr>
-              <a:t>2026-10-05T11:05:05.536Z  change.archived  </a:t>
+              <a:t>2026-10-05T12:39:46.317Z  change.archived  </a:t>
             </a:r>
             <a:endParaRPr lang="en-US" sz="1000" dirty="0"/>
           </a:p>
@@ -15061,7 +15061,7 @@
                 <a:ea typeface="Cambria" pitchFamily="34" charset="-122"/>
                 <a:cs typeface="Cambria" pitchFamily="34" charset="-120"/>
               </a:rPr>
-              <a:t>78</a:t>
+              <a:t>79</a:t>
             </a:r>
             <a:endParaRPr lang="en-US" sz="6000" dirty="0"/>
           </a:p>
@@ -15166,7 +15166,7 @@
                 <a:ea typeface="Cambria" pitchFamily="34" charset="-122"/>
                 <a:cs typeface="Cambria" pitchFamily="34" charset="-120"/>
               </a:rPr>
-              <a:t>50</a:t>
+              <a:t>51</a:t>
             </a:r>
             <a:endParaRPr lang="en-US" sz="6000" dirty="0"/>
           </a:p>
@@ -15205,7 +15205,7 @@
                 <a:ea typeface="Calibri" pitchFamily="34" charset="-122"/>
                 <a:cs typeface="Calibri" pitchFamily="34" charset="-120"/>
               </a:rPr>
-              <a:t>of 50 commands</a:t>
+              <a:t>of 51 commands</a:t>
             </a:r>
             <a:endParaRPr lang="en-US" sz="1600" dirty="0"/>
           </a:p>
@@ -15760,7 +15760,7 @@
         <p:spPr>
           <a:xfrm>
             <a:off x="5577840" y="3749040"/>
-            <a:ext cx="945896" cy="256032"/>
+            <a:ext cx="1342136" cy="256032"/>
           </a:xfrm>
           <a:prstGeom prst="roundRect">
             <a:avLst>
@@ -15787,7 +15787,7 @@
         <p:spPr>
           <a:xfrm>
             <a:off x="5577840" y="3749040"/>
-            <a:ext cx="945896" cy="256032"/>
+            <a:ext cx="1342136" cy="256032"/>
           </a:xfrm>
           <a:prstGeom prst="rect">
             <a:avLst/>
@@ -15811,7 +15811,7 @@
                 <a:ea typeface="Calibri" pitchFamily="34" charset="-122"/>
                 <a:cs typeface="Calibri" pitchFamily="34" charset="-120"/>
               </a:rPr>
-              <a:t>backlog add</a:t>
+              <a:t>backlog epic edit</a:t>
             </a:r>
             <a:endParaRPr lang="en-US" sz="1000" dirty="0"/>
           </a:p>
@@ -15825,8 +15825,8 @@
         </p:nvSpPr>
         <p:spPr>
           <a:xfrm>
-            <a:off x="6615176" y="3749040"/>
-            <a:ext cx="1011936" cy="256032"/>
+            <a:off x="7011416" y="3749040"/>
+            <a:ext cx="945896" cy="256032"/>
           </a:xfrm>
           <a:prstGeom prst="roundRect">
             <a:avLst>
@@ -15852,8 +15852,8 @@
         </p:nvSpPr>
         <p:spPr>
           <a:xfrm>
-            <a:off x="6615176" y="3749040"/>
-            <a:ext cx="1011936" cy="256032"/>
+            <a:off x="7011416" y="3749040"/>
+            <a:ext cx="945896" cy="256032"/>
           </a:xfrm>
           <a:prstGeom prst="rect">
             <a:avLst/>
@@ -15877,7 +15877,7 @@
                 <a:ea typeface="Calibri" pitchFamily="34" charset="-122"/>
                 <a:cs typeface="Calibri" pitchFamily="34" charset="-120"/>
               </a:rPr>
-              <a:t>backlog edit</a:t>
+              <a:t>backlog add</a:t>
             </a:r>
             <a:endParaRPr lang="en-US" sz="1000" dirty="0"/>
           </a:p>
@@ -15891,7 +15891,7 @@
         </p:nvSpPr>
         <p:spPr>
           <a:xfrm>
-            <a:off x="7718552" y="3749040"/>
+            <a:off x="8048752" y="3749040"/>
             <a:ext cx="1011936" cy="256032"/>
           </a:xfrm>
           <a:prstGeom prst="roundRect">
@@ -15918,7 +15918,7 @@
         </p:nvSpPr>
         <p:spPr>
           <a:xfrm>
-            <a:off x="7718552" y="3749040"/>
+            <a:off x="8048752" y="3749040"/>
             <a:ext cx="1011936" cy="256032"/>
           </a:xfrm>
           <a:prstGeom prst="rect">
@@ -15943,7 +15943,7 @@
                 <a:ea typeface="Calibri" pitchFamily="34" charset="-122"/>
                 <a:cs typeface="Calibri" pitchFamily="34" charset="-120"/>
               </a:rPr>
-              <a:t>backlog list</a:t>
+              <a:t>backlog edit</a:t>
             </a:r>
             <a:endParaRPr lang="en-US" sz="1000" dirty="0"/>
           </a:p>
@@ -15957,7 +15957,7 @@
         </p:nvSpPr>
         <p:spPr>
           <a:xfrm>
-            <a:off x="8821928" y="3749040"/>
+            <a:off x="9152128" y="3749040"/>
             <a:ext cx="1011936" cy="256032"/>
           </a:xfrm>
           <a:prstGeom prst="roundRect">
@@ -15984,7 +15984,7 @@
         </p:nvSpPr>
         <p:spPr>
           <a:xfrm>
-            <a:off x="8821928" y="3749040"/>
+            <a:off x="9152128" y="3749040"/>
             <a:ext cx="1011936" cy="256032"/>
           </a:xfrm>
           <a:prstGeom prst="rect">
@@ -16009,7 +16009,7 @@
                 <a:ea typeface="Calibri" pitchFamily="34" charset="-122"/>
                 <a:cs typeface="Calibri" pitchFamily="34" charset="-120"/>
               </a:rPr>
-              <a:t>backlog next</a:t>
+              <a:t>backlog list</a:t>
             </a:r>
             <a:endParaRPr lang="en-US" sz="1000" dirty="0"/>
           </a:p>
@@ -16023,8 +16023,8 @@
         </p:nvSpPr>
         <p:spPr>
           <a:xfrm>
-            <a:off x="9925304" y="3749040"/>
-            <a:ext cx="1077976" cy="256032"/>
+            <a:off x="10255504" y="3749040"/>
+            <a:ext cx="1011936" cy="256032"/>
           </a:xfrm>
           <a:prstGeom prst="roundRect">
             <a:avLst>
@@ -16050,8 +16050,8 @@
         </p:nvSpPr>
         <p:spPr>
           <a:xfrm>
-            <a:off x="9925304" y="3749040"/>
-            <a:ext cx="1077976" cy="256032"/>
+            <a:off x="10255504" y="3749040"/>
+            <a:ext cx="1011936" cy="256032"/>
           </a:xfrm>
           <a:prstGeom prst="rect">
             <a:avLst/>
@@ -16075,7 +16075,7 @@
                 <a:ea typeface="Calibri" pitchFamily="34" charset="-122"/>
                 <a:cs typeface="Calibri" pitchFamily="34" charset="-120"/>
               </a:rPr>
-              <a:t>backlog start</a:t>
+              <a:t>backlog next</a:t>
             </a:r>
             <a:endParaRPr lang="en-US" sz="1000" dirty="0"/>
           </a:p>
@@ -16090,7 +16090,7 @@
         <p:spPr>
           <a:xfrm>
             <a:off x="457200" y="4096512"/>
-            <a:ext cx="1011936" cy="256032"/>
+            <a:ext cx="1077976" cy="256032"/>
           </a:xfrm>
           <a:prstGeom prst="roundRect">
             <a:avLst>
@@ -16117,7 +16117,7 @@
         <p:spPr>
           <a:xfrm>
             <a:off x="457200" y="4096512"/>
-            <a:ext cx="1011936" cy="256032"/>
+            <a:ext cx="1077976" cy="256032"/>
           </a:xfrm>
           <a:prstGeom prst="rect">
             <a:avLst/>
@@ -16141,7 +16141,7 @@
                 <a:ea typeface="Calibri" pitchFamily="34" charset="-122"/>
                 <a:cs typeface="Calibri" pitchFamily="34" charset="-120"/>
               </a:rPr>
-              <a:t>backlog move</a:t>
+              <a:t>backlog start</a:t>
             </a:r>
             <a:endParaRPr lang="en-US" sz="1000" dirty="0"/>
           </a:p>
@@ -16155,7 +16155,7 @@
         </p:nvSpPr>
         <p:spPr>
           <a:xfrm>
-            <a:off x="1560576" y="4096512"/>
+            <a:off x="1626616" y="4096512"/>
             <a:ext cx="1011936" cy="256032"/>
           </a:xfrm>
           <a:prstGeom prst="roundRect">
@@ -16182,7 +16182,7 @@
         </p:nvSpPr>
         <p:spPr>
           <a:xfrm>
-            <a:off x="1560576" y="4096512"/>
+            <a:off x="1626616" y="4096512"/>
             <a:ext cx="1011936" cy="256032"/>
           </a:xfrm>
           <a:prstGeom prst="rect">
@@ -16207,7 +16207,7 @@
                 <a:ea typeface="Calibri" pitchFamily="34" charset="-122"/>
                 <a:cs typeface="Calibri" pitchFamily="34" charset="-120"/>
               </a:rPr>
-              <a:t>backlog drop</a:t>
+              <a:t>backlog move</a:t>
             </a:r>
             <a:endParaRPr lang="en-US" sz="1000" dirty="0"/>
           </a:p>
@@ -16221,7 +16221,7 @@
         </p:nvSpPr>
         <p:spPr>
           <a:xfrm>
-            <a:off x="2663952" y="4096512"/>
+            <a:off x="2729992" y="4096512"/>
             <a:ext cx="1011936" cy="256032"/>
           </a:xfrm>
           <a:prstGeom prst="roundRect">
@@ -16248,7 +16248,7 @@
         </p:nvSpPr>
         <p:spPr>
           <a:xfrm>
-            <a:off x="2663952" y="4096512"/>
+            <a:off x="2729992" y="4096512"/>
             <a:ext cx="1011936" cy="256032"/>
           </a:xfrm>
           <a:prstGeom prst="rect">
@@ -16273,7 +16273,7 @@
                 <a:ea typeface="Calibri" pitchFamily="34" charset="-122"/>
                 <a:cs typeface="Calibri" pitchFamily="34" charset="-120"/>
               </a:rPr>
-              <a:t>backlog done</a:t>
+              <a:t>backlog drop</a:t>
             </a:r>
             <a:endParaRPr lang="en-US" sz="1000" dirty="0"/>
           </a:p>
@@ -16287,8 +16287,8 @@
         </p:nvSpPr>
         <p:spPr>
           <a:xfrm>
-            <a:off x="3767328" y="4096512"/>
-            <a:ext cx="813816" cy="256032"/>
+            <a:off x="3833368" y="4096512"/>
+            <a:ext cx="1011936" cy="256032"/>
           </a:xfrm>
           <a:prstGeom prst="roundRect">
             <a:avLst>
@@ -16314,8 +16314,8 @@
         </p:nvSpPr>
         <p:spPr>
           <a:xfrm>
-            <a:off x="3767328" y="4096512"/>
-            <a:ext cx="813816" cy="256032"/>
+            <a:off x="3833368" y="4096512"/>
+            <a:ext cx="1011936" cy="256032"/>
           </a:xfrm>
           <a:prstGeom prst="rect">
             <a:avLst/>
@@ -16339,7 +16339,7 @@
                 <a:ea typeface="Calibri" pitchFamily="34" charset="-122"/>
                 <a:cs typeface="Calibri" pitchFamily="34" charset="-120"/>
               </a:rPr>
-              <a:t>defer add</a:t>
+              <a:t>backlog done</a:t>
             </a:r>
             <a:endParaRPr lang="en-US" sz="1000" dirty="0"/>
           </a:p>
@@ -16353,8 +16353,8 @@
         </p:nvSpPr>
         <p:spPr>
           <a:xfrm>
-            <a:off x="4672584" y="4096512"/>
-            <a:ext cx="879856" cy="256032"/>
+            <a:off x="4936744" y="4096512"/>
+            <a:ext cx="813816" cy="256032"/>
           </a:xfrm>
           <a:prstGeom prst="roundRect">
             <a:avLst>
@@ -16380,8 +16380,8 @@
         </p:nvSpPr>
         <p:spPr>
           <a:xfrm>
-            <a:off x="4672584" y="4096512"/>
-            <a:ext cx="879856" cy="256032"/>
+            <a:off x="4936744" y="4096512"/>
+            <a:ext cx="813816" cy="256032"/>
           </a:xfrm>
           <a:prstGeom prst="rect">
             <a:avLst/>
@@ -16405,7 +16405,7 @@
                 <a:ea typeface="Calibri" pitchFamily="34" charset="-122"/>
                 <a:cs typeface="Calibri" pitchFamily="34" charset="-120"/>
               </a:rPr>
-              <a:t>defer list</a:t>
+              <a:t>defer add</a:t>
             </a:r>
             <a:endParaRPr lang="en-US" sz="1000" dirty="0"/>
           </a:p>
@@ -16419,8 +16419,8 @@
         </p:nvSpPr>
         <p:spPr>
           <a:xfrm>
-            <a:off x="5643880" y="4096512"/>
-            <a:ext cx="945896" cy="256032"/>
+            <a:off x="5842000" y="4096512"/>
+            <a:ext cx="879856" cy="256032"/>
           </a:xfrm>
           <a:prstGeom prst="roundRect">
             <a:avLst>
@@ -16446,8 +16446,8 @@
         </p:nvSpPr>
         <p:spPr>
           <a:xfrm>
-            <a:off x="5643880" y="4096512"/>
-            <a:ext cx="945896" cy="256032"/>
+            <a:off x="5842000" y="4096512"/>
+            <a:ext cx="879856" cy="256032"/>
           </a:xfrm>
           <a:prstGeom prst="rect">
             <a:avLst/>
@@ -16471,7 +16471,7 @@
                 <a:ea typeface="Calibri" pitchFamily="34" charset="-122"/>
                 <a:cs typeface="Calibri" pitchFamily="34" charset="-120"/>
               </a:rPr>
-              <a:t>defer close</a:t>
+              <a:t>defer list</a:t>
             </a:r>
             <a:endParaRPr lang="en-US" sz="1000" dirty="0"/>
           </a:p>
@@ -16485,8 +16485,8 @@
         </p:nvSpPr>
         <p:spPr>
           <a:xfrm>
-            <a:off x="6681216" y="4096512"/>
-            <a:ext cx="1011936" cy="256032"/>
+            <a:off x="6813296" y="4096512"/>
+            <a:ext cx="945896" cy="256032"/>
           </a:xfrm>
           <a:prstGeom prst="roundRect">
             <a:avLst>
@@ -16512,8 +16512,8 @@
         </p:nvSpPr>
         <p:spPr>
           <a:xfrm>
-            <a:off x="6681216" y="4096512"/>
-            <a:ext cx="1011936" cy="256032"/>
+            <a:off x="6813296" y="4096512"/>
+            <a:ext cx="945896" cy="256032"/>
           </a:xfrm>
           <a:prstGeom prst="rect">
             <a:avLst/>
@@ -16537,7 +16537,7 @@
                 <a:ea typeface="Calibri" pitchFamily="34" charset="-122"/>
                 <a:cs typeface="Calibri" pitchFamily="34" charset="-120"/>
               </a:rPr>
-              <a:t>layout check</a:t>
+              <a:t>defer close</a:t>
             </a:r>
             <a:endParaRPr lang="en-US" sz="1000" dirty="0"/>
           </a:p>
@@ -16551,8 +16551,8 @@
         </p:nvSpPr>
         <p:spPr>
           <a:xfrm>
-            <a:off x="7784592" y="4096512"/>
-            <a:ext cx="1210056" cy="256032"/>
+            <a:off x="7850632" y="4096512"/>
+            <a:ext cx="1011936" cy="256032"/>
           </a:xfrm>
           <a:prstGeom prst="roundRect">
             <a:avLst>
@@ -16578,8 +16578,8 @@
         </p:nvSpPr>
         <p:spPr>
           <a:xfrm>
-            <a:off x="7784592" y="4096512"/>
-            <a:ext cx="1210056" cy="256032"/>
+            <a:off x="7850632" y="4096512"/>
+            <a:ext cx="1011936" cy="256032"/>
           </a:xfrm>
           <a:prstGeom prst="rect">
             <a:avLst/>
@@ -16603,7 +16603,7 @@
                 <a:ea typeface="Calibri" pitchFamily="34" charset="-122"/>
                 <a:cs typeface="Calibri" pitchFamily="34" charset="-120"/>
               </a:rPr>
-              <a:t>layout scaffold</a:t>
+              <a:t>layout check</a:t>
             </a:r>
             <a:endParaRPr lang="en-US" sz="1000" dirty="0"/>
           </a:p>
@@ -16617,8 +16617,8 @@
         </p:nvSpPr>
         <p:spPr>
           <a:xfrm>
-            <a:off x="9086088" y="4096512"/>
-            <a:ext cx="1011936" cy="256032"/>
+            <a:off x="8954008" y="4096512"/>
+            <a:ext cx="1210056" cy="256032"/>
           </a:xfrm>
           <a:prstGeom prst="roundRect">
             <a:avLst>
@@ -16644,8 +16644,8 @@
         </p:nvSpPr>
         <p:spPr>
           <a:xfrm>
-            <a:off x="9086088" y="4096512"/>
-            <a:ext cx="1011936" cy="256032"/>
+            <a:off x="8954008" y="4096512"/>
+            <a:ext cx="1210056" cy="256032"/>
           </a:xfrm>
           <a:prstGeom prst="rect">
             <a:avLst/>
@@ -16669,7 +16669,7 @@
                 <a:ea typeface="Calibri" pitchFamily="34" charset="-122"/>
                 <a:cs typeface="Calibri" pitchFamily="34" charset="-120"/>
               </a:rPr>
-              <a:t>layout adapt</a:t>
+              <a:t>layout scaffold</a:t>
             </a:r>
             <a:endParaRPr lang="en-US" sz="1000" dirty="0"/>
           </a:p>
@@ -16683,8 +16683,8 @@
         </p:nvSpPr>
         <p:spPr>
           <a:xfrm>
-            <a:off x="10189464" y="4096512"/>
-            <a:ext cx="1144016" cy="256032"/>
+            <a:off x="10255504" y="4096512"/>
+            <a:ext cx="1011936" cy="256032"/>
           </a:xfrm>
           <a:prstGeom prst="roundRect">
             <a:avLst>
@@ -16710,8 +16710,8 @@
         </p:nvSpPr>
         <p:spPr>
           <a:xfrm>
-            <a:off x="10189464" y="4096512"/>
-            <a:ext cx="1144016" cy="256032"/>
+            <a:off x="10255504" y="4096512"/>
+            <a:ext cx="1011936" cy="256032"/>
           </a:xfrm>
           <a:prstGeom prst="rect">
             <a:avLst/>
@@ -16735,7 +16735,7 @@
                 <a:ea typeface="Calibri" pitchFamily="34" charset="-122"/>
                 <a:cs typeface="Calibri" pitchFamily="34" charset="-120"/>
               </a:rPr>
-              <a:t>layout convert</a:t>
+              <a:t>layout adapt</a:t>
             </a:r>
             <a:endParaRPr lang="en-US" sz="1000" dirty="0"/>
           </a:p>
@@ -16750,7 +16750,7 @@
         <p:spPr>
           <a:xfrm>
             <a:off x="457200" y="4443984"/>
-            <a:ext cx="483616" cy="256032"/>
+            <a:ext cx="1144016" cy="256032"/>
           </a:xfrm>
           <a:prstGeom prst="roundRect">
             <a:avLst>
@@ -16777,7 +16777,7 @@
         <p:spPr>
           <a:xfrm>
             <a:off x="457200" y="4443984"/>
-            <a:ext cx="483616" cy="256032"/>
+            <a:ext cx="1144016" cy="256032"/>
           </a:xfrm>
           <a:prstGeom prst="rect">
             <a:avLst/>
@@ -16801,7 +16801,7 @@
                 <a:ea typeface="Calibri" pitchFamily="34" charset="-122"/>
                 <a:cs typeface="Calibri" pitchFamily="34" charset="-120"/>
               </a:rPr>
-              <a:t>init</a:t>
+              <a:t>layout convert</a:t>
             </a:r>
             <a:endParaRPr lang="en-US" sz="1000" dirty="0"/>
           </a:p>
@@ -16815,8 +16815,8 @@
         </p:nvSpPr>
         <p:spPr>
           <a:xfrm>
-            <a:off x="1032256" y="4443984"/>
-            <a:ext cx="615696" cy="256032"/>
+            <a:off x="1692656" y="4443984"/>
+            <a:ext cx="483616" cy="256032"/>
           </a:xfrm>
           <a:prstGeom prst="roundRect">
             <a:avLst>
@@ -16842,8 +16842,8 @@
         </p:nvSpPr>
         <p:spPr>
           <a:xfrm>
-            <a:off x="1032256" y="4443984"/>
-            <a:ext cx="615696" cy="256032"/>
+            <a:off x="1692656" y="4443984"/>
+            <a:ext cx="483616" cy="256032"/>
           </a:xfrm>
           <a:prstGeom prst="rect">
             <a:avLst/>
@@ -16867,7 +16867,7 @@
                 <a:ea typeface="Calibri" pitchFamily="34" charset="-122"/>
                 <a:cs typeface="Calibri" pitchFamily="34" charset="-120"/>
               </a:rPr>
-              <a:t>update</a:t>
+              <a:t>init</a:t>
             </a:r>
             <a:endParaRPr lang="en-US" sz="1000" dirty="0"/>
           </a:p>
@@ -16881,8 +16881,8 @@
         </p:nvSpPr>
         <p:spPr>
           <a:xfrm>
-            <a:off x="1739392" y="4443984"/>
-            <a:ext cx="813816" cy="256032"/>
+            <a:off x="2267712" y="4443984"/>
+            <a:ext cx="615696" cy="256032"/>
           </a:xfrm>
           <a:prstGeom prst="roundRect">
             <a:avLst>
@@ -16908,8 +16908,8 @@
         </p:nvSpPr>
         <p:spPr>
           <a:xfrm>
-            <a:off x="1739392" y="4443984"/>
-            <a:ext cx="813816" cy="256032"/>
+            <a:off x="2267712" y="4443984"/>
+            <a:ext cx="615696" cy="256032"/>
           </a:xfrm>
           <a:prstGeom prst="rect">
             <a:avLst/>
@@ -16933,7 +16933,7 @@
                 <a:ea typeface="Calibri" pitchFamily="34" charset="-122"/>
                 <a:cs typeface="Calibri" pitchFamily="34" charset="-120"/>
               </a:rPr>
-              <a:t>uninstall</a:t>
+              <a:t>update</a:t>
             </a:r>
             <a:endParaRPr lang="en-US" sz="1000" dirty="0"/>
           </a:p>
@@ -16947,8 +16947,8 @@
         </p:nvSpPr>
         <p:spPr>
           <a:xfrm>
-            <a:off x="2644648" y="4443984"/>
-            <a:ext cx="417576" cy="256032"/>
+            <a:off x="2974848" y="4443984"/>
+            <a:ext cx="813816" cy="256032"/>
           </a:xfrm>
           <a:prstGeom prst="roundRect">
             <a:avLst>
@@ -16974,8 +16974,8 @@
         </p:nvSpPr>
         <p:spPr>
           <a:xfrm>
-            <a:off x="2644648" y="4443984"/>
-            <a:ext cx="417576" cy="256032"/>
+            <a:off x="2974848" y="4443984"/>
+            <a:ext cx="813816" cy="256032"/>
           </a:xfrm>
           <a:prstGeom prst="rect">
             <a:avLst/>
@@ -16999,7 +16999,7 @@
                 <a:ea typeface="Calibri" pitchFamily="34" charset="-122"/>
                 <a:cs typeface="Calibri" pitchFamily="34" charset="-120"/>
               </a:rPr>
-              <a:t>new</a:t>
+              <a:t>uninstall</a:t>
             </a:r>
             <a:endParaRPr lang="en-US" sz="1000" dirty="0"/>
           </a:p>
@@ -17013,8 +17013,8 @@
         </p:nvSpPr>
         <p:spPr>
           <a:xfrm>
-            <a:off x="3153664" y="4443984"/>
-            <a:ext cx="1011936" cy="256032"/>
+            <a:off x="3880104" y="4443984"/>
+            <a:ext cx="417576" cy="256032"/>
           </a:xfrm>
           <a:prstGeom prst="roundRect">
             <a:avLst>
@@ -17040,8 +17040,8 @@
         </p:nvSpPr>
         <p:spPr>
           <a:xfrm>
-            <a:off x="3153664" y="4443984"/>
-            <a:ext cx="1011936" cy="256032"/>
+            <a:off x="3880104" y="4443984"/>
+            <a:ext cx="417576" cy="256032"/>
           </a:xfrm>
           <a:prstGeom prst="rect">
             <a:avLst/>
@@ -17065,7 +17065,7 @@
                 <a:ea typeface="Calibri" pitchFamily="34" charset="-122"/>
                 <a:cs typeface="Calibri" pitchFamily="34" charset="-120"/>
               </a:rPr>
-              <a:t>explore list</a:t>
+              <a:t>new</a:t>
             </a:r>
             <a:endParaRPr lang="en-US" sz="1000" dirty="0"/>
           </a:p>
@@ -17079,8 +17079,8 @@
         </p:nvSpPr>
         <p:spPr>
           <a:xfrm>
-            <a:off x="4257040" y="4443984"/>
-            <a:ext cx="945896" cy="256032"/>
+            <a:off x="4389120" y="4443984"/>
+            <a:ext cx="1011936" cy="256032"/>
           </a:xfrm>
           <a:prstGeom prst="roundRect">
             <a:avLst>
@@ -17106,8 +17106,8 @@
         </p:nvSpPr>
         <p:spPr>
           <a:xfrm>
-            <a:off x="4257040" y="4443984"/>
-            <a:ext cx="945896" cy="256032"/>
+            <a:off x="4389120" y="4443984"/>
+            <a:ext cx="1011936" cy="256032"/>
           </a:xfrm>
           <a:prstGeom prst="rect">
             <a:avLst/>
@@ -17131,7 +17131,7 @@
                 <a:ea typeface="Calibri" pitchFamily="34" charset="-122"/>
                 <a:cs typeface="Calibri" pitchFamily="34" charset="-120"/>
               </a:rPr>
-              <a:t>import bmad</a:t>
+              <a:t>explore list</a:t>
             </a:r>
             <a:endParaRPr lang="en-US" sz="1000" dirty="0"/>
           </a:p>
@@ -17145,8 +17145,8 @@
         </p:nvSpPr>
         <p:spPr>
           <a:xfrm>
-            <a:off x="5294376" y="4443984"/>
-            <a:ext cx="615696" cy="256032"/>
+            <a:off x="5492496" y="4443984"/>
+            <a:ext cx="945896" cy="256032"/>
           </a:xfrm>
           <a:prstGeom prst="roundRect">
             <a:avLst>
@@ -17172,8 +17172,8 @@
         </p:nvSpPr>
         <p:spPr>
           <a:xfrm>
-            <a:off x="5294376" y="4443984"/>
-            <a:ext cx="615696" cy="256032"/>
+            <a:off x="5492496" y="4443984"/>
+            <a:ext cx="945896" cy="256032"/>
           </a:xfrm>
           <a:prstGeom prst="rect">
             <a:avLst/>
@@ -17197,7 +17197,7 @@
                 <a:ea typeface="Calibri" pitchFamily="34" charset="-122"/>
                 <a:cs typeface="Calibri" pitchFamily="34" charset="-120"/>
               </a:rPr>
-              <a:t>status</a:t>
+              <a:t>import bmad</a:t>
             </a:r>
             <a:endParaRPr lang="en-US" sz="1000" dirty="0"/>
           </a:p>
@@ -17211,8 +17211,8 @@
         </p:nvSpPr>
         <p:spPr>
           <a:xfrm>
-            <a:off x="6001512" y="4443984"/>
-            <a:ext cx="483616" cy="256032"/>
+            <a:off x="6529832" y="4443984"/>
+            <a:ext cx="615696" cy="256032"/>
           </a:xfrm>
           <a:prstGeom prst="roundRect">
             <a:avLst>
@@ -17238,8 +17238,8 @@
         </p:nvSpPr>
         <p:spPr>
           <a:xfrm>
-            <a:off x="6001512" y="4443984"/>
-            <a:ext cx="483616" cy="256032"/>
+            <a:off x="6529832" y="4443984"/>
+            <a:ext cx="615696" cy="256032"/>
           </a:xfrm>
           <a:prstGeom prst="rect">
             <a:avLst/>
@@ -17263,7 +17263,7 @@
                 <a:ea typeface="Calibri" pitchFamily="34" charset="-122"/>
                 <a:cs typeface="Calibri" pitchFamily="34" charset="-120"/>
               </a:rPr>
-              <a:t>help</a:t>
+              <a:t>status</a:t>
             </a:r>
             <a:endParaRPr lang="en-US" sz="1000" dirty="0"/>
           </a:p>
@@ -17277,8 +17277,8 @@
         </p:nvSpPr>
         <p:spPr>
           <a:xfrm>
-            <a:off x="6576568" y="4443984"/>
-            <a:ext cx="879856" cy="256032"/>
+            <a:off x="7236968" y="4443984"/>
+            <a:ext cx="483616" cy="256032"/>
           </a:xfrm>
           <a:prstGeom prst="roundRect">
             <a:avLst>
@@ -17304,8 +17304,8 @@
         </p:nvSpPr>
         <p:spPr>
           <a:xfrm>
-            <a:off x="6576568" y="4443984"/>
-            <a:ext cx="879856" cy="256032"/>
+            <a:off x="7236968" y="4443984"/>
+            <a:ext cx="483616" cy="256032"/>
           </a:xfrm>
           <a:prstGeom prst="rect">
             <a:avLst/>
@@ -17329,7 +17329,7 @@
                 <a:ea typeface="Calibri" pitchFamily="34" charset="-122"/>
                 <a:cs typeface="Calibri" pitchFamily="34" charset="-120"/>
               </a:rPr>
-              <a:t>statusline</a:t>
+              <a:t>help</a:t>
             </a:r>
             <a:endParaRPr lang="en-US" sz="1000" dirty="0"/>
           </a:p>
@@ -17343,8 +17343,8 @@
         </p:nvSpPr>
         <p:spPr>
           <a:xfrm>
-            <a:off x="7547864" y="4443984"/>
-            <a:ext cx="813816" cy="256032"/>
+            <a:off x="7812024" y="4443984"/>
+            <a:ext cx="879856" cy="256032"/>
           </a:xfrm>
           <a:prstGeom prst="roundRect">
             <a:avLst>
@@ -17370,8 +17370,8 @@
         </p:nvSpPr>
         <p:spPr>
           <a:xfrm>
-            <a:off x="7547864" y="4443984"/>
-            <a:ext cx="813816" cy="256032"/>
+            <a:off x="7812024" y="4443984"/>
+            <a:ext cx="879856" cy="256032"/>
           </a:xfrm>
           <a:prstGeom prst="rect">
             <a:avLst/>
@@ -17395,7 +17395,7 @@
                 <a:ea typeface="Calibri" pitchFamily="34" charset="-122"/>
                 <a:cs typeface="Calibri" pitchFamily="34" charset="-120"/>
               </a:rPr>
-              <a:t>track set</a:t>
+              <a:t>statusline</a:t>
             </a:r>
             <a:endParaRPr lang="en-US" sz="1000" dirty="0"/>
           </a:p>
@@ -17409,8 +17409,8 @@
         </p:nvSpPr>
         <p:spPr>
           <a:xfrm>
-            <a:off x="8453120" y="4443984"/>
-            <a:ext cx="483616" cy="256032"/>
+            <a:off x="8783320" y="4443984"/>
+            <a:ext cx="813816" cy="256032"/>
           </a:xfrm>
           <a:prstGeom prst="roundRect">
             <a:avLst>
@@ -17436,8 +17436,8 @@
         </p:nvSpPr>
         <p:spPr>
           <a:xfrm>
-            <a:off x="8453120" y="4443984"/>
-            <a:ext cx="483616" cy="256032"/>
+            <a:off x="8783320" y="4443984"/>
+            <a:ext cx="813816" cy="256032"/>
           </a:xfrm>
           <a:prstGeom prst="rect">
             <a:avLst/>
@@ -17461,7 +17461,7 @@
                 <a:ea typeface="Calibri" pitchFamily="34" charset="-122"/>
                 <a:cs typeface="Calibri" pitchFamily="34" charset="-120"/>
               </a:rPr>
-              <a:t>next</a:t>
+              <a:t>track set</a:t>
             </a:r>
             <a:endParaRPr lang="en-US" sz="1000" dirty="0"/>
           </a:p>
@@ -17475,8 +17475,8 @@
         </p:nvSpPr>
         <p:spPr>
           <a:xfrm>
-            <a:off x="9028176" y="4443984"/>
-            <a:ext cx="1011936" cy="256032"/>
+            <a:off x="9688576" y="4443984"/>
+            <a:ext cx="483616" cy="256032"/>
           </a:xfrm>
           <a:prstGeom prst="roundRect">
             <a:avLst>
@@ -17502,8 +17502,8 @@
         </p:nvSpPr>
         <p:spPr>
           <a:xfrm>
-            <a:off x="9028176" y="4443984"/>
-            <a:ext cx="1011936" cy="256032"/>
+            <a:off x="9688576" y="4443984"/>
+            <a:ext cx="483616" cy="256032"/>
           </a:xfrm>
           <a:prstGeom prst="rect">
             <a:avLst/>
@@ -17527,7 +17527,7 @@
                 <a:ea typeface="Calibri" pitchFamily="34" charset="-122"/>
                 <a:cs typeface="Calibri" pitchFamily="34" charset="-120"/>
               </a:rPr>
-              <a:t>instructions</a:t>
+              <a:t>next</a:t>
             </a:r>
             <a:endParaRPr lang="en-US" sz="1000" dirty="0"/>
           </a:p>
@@ -17541,8 +17541,8 @@
         </p:nvSpPr>
         <p:spPr>
           <a:xfrm>
-            <a:off x="10131552" y="4443984"/>
-            <a:ext cx="681736" cy="256032"/>
+            <a:off x="10263632" y="4443984"/>
+            <a:ext cx="1011936" cy="256032"/>
           </a:xfrm>
           <a:prstGeom prst="roundRect">
             <a:avLst>
@@ -17568,8 +17568,8 @@
         </p:nvSpPr>
         <p:spPr>
           <a:xfrm>
-            <a:off x="10131552" y="4443984"/>
-            <a:ext cx="681736" cy="256032"/>
+            <a:off x="10263632" y="4443984"/>
+            <a:ext cx="1011936" cy="256032"/>
           </a:xfrm>
           <a:prstGeom prst="rect">
             <a:avLst/>
@@ -17593,7 +17593,7 @@
                 <a:ea typeface="Calibri" pitchFamily="34" charset="-122"/>
                 <a:cs typeface="Calibri" pitchFamily="34" charset="-120"/>
               </a:rPr>
-              <a:t>approve</a:t>
+              <a:t>instructions</a:t>
             </a:r>
             <a:endParaRPr lang="en-US" sz="1000" dirty="0"/>
           </a:p>
@@ -17607,8 +17607,8 @@
         </p:nvSpPr>
         <p:spPr>
           <a:xfrm>
-            <a:off x="10904728" y="4443984"/>
-            <a:ext cx="615696" cy="256032"/>
+            <a:off x="457200" y="4791456"/>
+            <a:ext cx="681736" cy="256032"/>
           </a:xfrm>
           <a:prstGeom prst="roundRect">
             <a:avLst>
@@ -17634,8 +17634,8 @@
         </p:nvSpPr>
         <p:spPr>
           <a:xfrm>
-            <a:off x="10904728" y="4443984"/>
-            <a:ext cx="615696" cy="256032"/>
+            <a:off x="457200" y="4791456"/>
+            <a:ext cx="681736" cy="256032"/>
           </a:xfrm>
           <a:prstGeom prst="rect">
             <a:avLst/>
@@ -17659,7 +17659,7 @@
                 <a:ea typeface="Calibri" pitchFamily="34" charset="-122"/>
                 <a:cs typeface="Calibri" pitchFamily="34" charset="-120"/>
               </a:rPr>
-              <a:t>reject</a:t>
+              <a:t>approve</a:t>
             </a:r>
             <a:endParaRPr lang="en-US" sz="1000" dirty="0"/>
           </a:p>
@@ -17673,8 +17673,8 @@
         </p:nvSpPr>
         <p:spPr>
           <a:xfrm>
-            <a:off x="457200" y="4791456"/>
-            <a:ext cx="549656" cy="256032"/>
+            <a:off x="1230376" y="4791456"/>
+            <a:ext cx="615696" cy="256032"/>
           </a:xfrm>
           <a:prstGeom prst="roundRect">
             <a:avLst>
@@ -17700,8 +17700,8 @@
         </p:nvSpPr>
         <p:spPr>
           <a:xfrm>
-            <a:off x="457200" y="4791456"/>
-            <a:ext cx="549656" cy="256032"/>
+            <a:off x="1230376" y="4791456"/>
+            <a:ext cx="615696" cy="256032"/>
           </a:xfrm>
           <a:prstGeom prst="rect">
             <a:avLst/>
@@ -17725,7 +17725,7 @@
                 <a:ea typeface="Calibri" pitchFamily="34" charset="-122"/>
                 <a:cs typeface="Calibri" pitchFamily="34" charset="-120"/>
               </a:rPr>
-              <a:t>waive</a:t>
+              <a:t>reject</a:t>
             </a:r>
             <a:endParaRPr lang="en-US" sz="1000" dirty="0"/>
           </a:p>
@@ -17739,8 +17739,8 @@
         </p:nvSpPr>
         <p:spPr>
           <a:xfrm>
-            <a:off x="1098296" y="4791456"/>
-            <a:ext cx="1276096" cy="256032"/>
+            <a:off x="1937512" y="4791456"/>
+            <a:ext cx="549656" cy="256032"/>
           </a:xfrm>
           <a:prstGeom prst="roundRect">
             <a:avLst>
@@ -17766,8 +17766,8 @@
         </p:nvSpPr>
         <p:spPr>
           <a:xfrm>
-            <a:off x="1098296" y="4791456"/>
-            <a:ext cx="1276096" cy="256032"/>
+            <a:off x="1937512" y="4791456"/>
+            <a:ext cx="549656" cy="256032"/>
           </a:xfrm>
           <a:prstGeom prst="rect">
             <a:avLst/>
@@ -17791,7 +17791,7 @@
                 <a:ea typeface="Calibri" pitchFamily="34" charset="-122"/>
                 <a:cs typeface="Calibri" pitchFamily="34" charset="-120"/>
               </a:rPr>
-              <a:t>approvals verify</a:t>
+              <a:t>waive</a:t>
             </a:r>
             <a:endParaRPr lang="en-US" sz="1000" dirty="0"/>
           </a:p>
@@ -17805,8 +17805,8 @@
         </p:nvSpPr>
         <p:spPr>
           <a:xfrm>
-            <a:off x="2465832" y="4791456"/>
-            <a:ext cx="549656" cy="256032"/>
+            <a:off x="2578608" y="4791456"/>
+            <a:ext cx="1276096" cy="256032"/>
           </a:xfrm>
           <a:prstGeom prst="roundRect">
             <a:avLst>
@@ -17832,8 +17832,8 @@
         </p:nvSpPr>
         <p:spPr>
           <a:xfrm>
-            <a:off x="2465832" y="4791456"/>
-            <a:ext cx="549656" cy="256032"/>
+            <a:off x="2578608" y="4791456"/>
+            <a:ext cx="1276096" cy="256032"/>
           </a:xfrm>
           <a:prstGeom prst="rect">
             <a:avLst/>
@@ -17857,7 +17857,7 @@
                 <a:ea typeface="Calibri" pitchFamily="34" charset="-122"/>
                 <a:cs typeface="Calibri" pitchFamily="34" charset="-120"/>
               </a:rPr>
-              <a:t>tests</a:t>
+              <a:t>approvals verify</a:t>
             </a:r>
             <a:endParaRPr lang="en-US" sz="1000" dirty="0"/>
           </a:p>
@@ -17871,8 +17871,8 @@
         </p:nvSpPr>
         <p:spPr>
           <a:xfrm>
-            <a:off x="3106928" y="4791456"/>
-            <a:ext cx="615696" cy="256032"/>
+            <a:off x="3946144" y="4791456"/>
+            <a:ext cx="549656" cy="256032"/>
           </a:xfrm>
           <a:prstGeom prst="roundRect">
             <a:avLst>
@@ -17898,8 +17898,8 @@
         </p:nvSpPr>
         <p:spPr>
           <a:xfrm>
-            <a:off x="3106928" y="4791456"/>
-            <a:ext cx="615696" cy="256032"/>
+            <a:off x="3946144" y="4791456"/>
+            <a:ext cx="549656" cy="256032"/>
           </a:xfrm>
           <a:prstGeom prst="rect">
             <a:avLst/>
@@ -17923,7 +17923,7 @@
                 <a:ea typeface="Calibri" pitchFamily="34" charset="-122"/>
                 <a:cs typeface="Calibri" pitchFamily="34" charset="-120"/>
               </a:rPr>
-              <a:t>verify</a:t>
+              <a:t>tests</a:t>
             </a:r>
             <a:endParaRPr lang="en-US" sz="1000" dirty="0"/>
           </a:p>
@@ -17937,7 +17937,7 @@
         </p:nvSpPr>
         <p:spPr>
           <a:xfrm>
-            <a:off x="3814064" y="4791456"/>
+            <a:off x="4587240" y="4791456"/>
             <a:ext cx="615696" cy="256032"/>
           </a:xfrm>
           <a:prstGeom prst="roundRect">
@@ -17964,7 +17964,7 @@
         </p:nvSpPr>
         <p:spPr>
           <a:xfrm>
-            <a:off x="3814064" y="4791456"/>
+            <a:off x="4587240" y="4791456"/>
             <a:ext cx="615696" cy="256032"/>
           </a:xfrm>
           <a:prstGeom prst="rect">
@@ -17989,7 +17989,7 @@
                 <a:ea typeface="Calibri" pitchFamily="34" charset="-122"/>
                 <a:cs typeface="Calibri" pitchFamily="34" charset="-120"/>
               </a:rPr>
-              <a:t>review</a:t>
+              <a:t>verify</a:t>
             </a:r>
             <a:endParaRPr lang="en-US" sz="1000" dirty="0"/>
           </a:p>
@@ -18003,8 +18003,8 @@
         </p:nvSpPr>
         <p:spPr>
           <a:xfrm>
-            <a:off x="4521200" y="4791456"/>
-            <a:ext cx="747776" cy="256032"/>
+            <a:off x="5294376" y="4791456"/>
+            <a:ext cx="615696" cy="256032"/>
           </a:xfrm>
           <a:prstGeom prst="roundRect">
             <a:avLst>
@@ -18030,8 +18030,8 @@
         </p:nvSpPr>
         <p:spPr>
           <a:xfrm>
-            <a:off x="4521200" y="4791456"/>
-            <a:ext cx="747776" cy="256032"/>
+            <a:off x="5294376" y="4791456"/>
+            <a:ext cx="615696" cy="256032"/>
           </a:xfrm>
           <a:prstGeom prst="rect">
             <a:avLst/>
@@ -18055,7 +18055,7 @@
                 <a:ea typeface="Calibri" pitchFamily="34" charset="-122"/>
                 <a:cs typeface="Calibri" pitchFamily="34" charset="-120"/>
               </a:rPr>
-              <a:t>validate</a:t>
+              <a:t>review</a:t>
             </a:r>
             <a:endParaRPr lang="en-US" sz="1000" dirty="0"/>
           </a:p>
@@ -18069,8 +18069,8 @@
         </p:nvSpPr>
         <p:spPr>
           <a:xfrm>
-            <a:off x="5360416" y="4791456"/>
-            <a:ext cx="681736" cy="256032"/>
+            <a:off x="6001512" y="4791456"/>
+            <a:ext cx="747776" cy="256032"/>
           </a:xfrm>
           <a:prstGeom prst="roundRect">
             <a:avLst>
@@ -18096,8 +18096,8 @@
         </p:nvSpPr>
         <p:spPr>
           <a:xfrm>
-            <a:off x="5360416" y="4791456"/>
-            <a:ext cx="681736" cy="256032"/>
+            <a:off x="6001512" y="4791456"/>
+            <a:ext cx="747776" cy="256032"/>
           </a:xfrm>
           <a:prstGeom prst="rect">
             <a:avLst/>
@@ -18121,7 +18121,7 @@
                 <a:ea typeface="Calibri" pitchFamily="34" charset="-122"/>
                 <a:cs typeface="Calibri" pitchFamily="34" charset="-120"/>
               </a:rPr>
-              <a:t>archive</a:t>
+              <a:t>validate</a:t>
             </a:r>
             <a:endParaRPr lang="en-US" sz="1000" dirty="0"/>
           </a:p>
@@ -18135,8 +18135,8 @@
         </p:nvSpPr>
         <p:spPr>
           <a:xfrm>
-            <a:off x="6133592" y="4791456"/>
-            <a:ext cx="549656" cy="256032"/>
+            <a:off x="6840728" y="4791456"/>
+            <a:ext cx="681736" cy="256032"/>
           </a:xfrm>
           <a:prstGeom prst="roundRect">
             <a:avLst>
@@ -18162,8 +18162,8 @@
         </p:nvSpPr>
         <p:spPr>
           <a:xfrm>
-            <a:off x="6133592" y="4791456"/>
-            <a:ext cx="549656" cy="256032"/>
+            <a:off x="6840728" y="4791456"/>
+            <a:ext cx="681736" cy="256032"/>
           </a:xfrm>
           <a:prstGeom prst="rect">
             <a:avLst/>
@@ -18187,7 +18187,7 @@
                 <a:ea typeface="Calibri" pitchFamily="34" charset="-122"/>
                 <a:cs typeface="Calibri" pitchFamily="34" charset="-120"/>
               </a:rPr>
-              <a:t>audit</a:t>
+              <a:t>archive</a:t>
             </a:r>
             <a:endParaRPr lang="en-US" sz="1000" dirty="0"/>
           </a:p>
@@ -18201,8 +18201,8 @@
         </p:nvSpPr>
         <p:spPr>
           <a:xfrm>
-            <a:off x="6774688" y="4791456"/>
-            <a:ext cx="615696" cy="256032"/>
+            <a:off x="7613904" y="4791456"/>
+            <a:ext cx="549656" cy="256032"/>
           </a:xfrm>
           <a:prstGeom prst="roundRect">
             <a:avLst>
@@ -18228,8 +18228,8 @@
         </p:nvSpPr>
         <p:spPr>
           <a:xfrm>
-            <a:off x="6774688" y="4791456"/>
-            <a:ext cx="615696" cy="256032"/>
+            <a:off x="7613904" y="4791456"/>
+            <a:ext cx="549656" cy="256032"/>
           </a:xfrm>
           <a:prstGeom prst="rect">
             <a:avLst/>
@@ -18253,7 +18253,7 @@
                 <a:ea typeface="Calibri" pitchFamily="34" charset="-122"/>
                 <a:cs typeface="Calibri" pitchFamily="34" charset="-120"/>
               </a:rPr>
-              <a:t>report</a:t>
+              <a:t>audit</a:t>
             </a:r>
             <a:endParaRPr lang="en-US" sz="1000" dirty="0"/>
           </a:p>
@@ -18267,8 +18267,8 @@
         </p:nvSpPr>
         <p:spPr>
           <a:xfrm>
-            <a:off x="7481824" y="4791456"/>
-            <a:ext cx="813816" cy="256032"/>
+            <a:off x="8255000" y="4791456"/>
+            <a:ext cx="615696" cy="256032"/>
           </a:xfrm>
           <a:prstGeom prst="roundRect">
             <a:avLst>
@@ -18294,8 +18294,8 @@
         </p:nvSpPr>
         <p:spPr>
           <a:xfrm>
-            <a:off x="7481824" y="4791456"/>
-            <a:ext cx="813816" cy="256032"/>
+            <a:off x="8255000" y="4791456"/>
+            <a:ext cx="615696" cy="256032"/>
           </a:xfrm>
           <a:prstGeom prst="rect">
             <a:avLst/>
@@ -18319,7 +18319,7 @@
                 <a:ea typeface="Calibri" pitchFamily="34" charset="-122"/>
                 <a:cs typeface="Calibri" pitchFamily="34" charset="-120"/>
               </a:rPr>
-              <a:t>dashboard</a:t>
+              <a:t>report</a:t>
             </a:r>
             <a:endParaRPr lang="en-US" sz="1000" dirty="0"/>
           </a:p>
@@ -18333,8 +18333,8 @@
         </p:nvSpPr>
         <p:spPr>
           <a:xfrm>
-            <a:off x="8387080" y="4791456"/>
-            <a:ext cx="417576" cy="256032"/>
+            <a:off x="8962136" y="4791456"/>
+            <a:ext cx="813816" cy="256032"/>
           </a:xfrm>
           <a:prstGeom prst="roundRect">
             <a:avLst>
@@ -18360,8 +18360,8 @@
         </p:nvSpPr>
         <p:spPr>
           <a:xfrm>
-            <a:off x="8387080" y="4791456"/>
-            <a:ext cx="417576" cy="256032"/>
+            <a:off x="8962136" y="4791456"/>
+            <a:ext cx="813816" cy="256032"/>
           </a:xfrm>
           <a:prstGeom prst="rect">
             <a:avLst/>
@@ -18385,7 +18385,7 @@
                 <a:ea typeface="Calibri" pitchFamily="34" charset="-122"/>
                 <a:cs typeface="Calibri" pitchFamily="34" charset="-120"/>
               </a:rPr>
-              <a:t>log</a:t>
+              <a:t>dashboard</a:t>
             </a:r>
             <a:endParaRPr lang="en-US" sz="1000" dirty="0"/>
           </a:p>
@@ -18399,8 +18399,8 @@
         </p:nvSpPr>
         <p:spPr>
           <a:xfrm>
-            <a:off x="8896096" y="4791456"/>
-            <a:ext cx="681736" cy="256032"/>
+            <a:off x="9867392" y="4791456"/>
+            <a:ext cx="417576" cy="256032"/>
           </a:xfrm>
           <a:prstGeom prst="roundRect">
             <a:avLst>
@@ -18426,8 +18426,8 @@
         </p:nvSpPr>
         <p:spPr>
           <a:xfrm>
-            <a:off x="8896096" y="4791456"/>
-            <a:ext cx="681736" cy="256032"/>
+            <a:off x="9867392" y="4791456"/>
+            <a:ext cx="417576" cy="256032"/>
           </a:xfrm>
           <a:prstGeom prst="rect">
             <a:avLst/>
@@ -18451,7 +18451,7 @@
                 <a:ea typeface="Calibri" pitchFamily="34" charset="-122"/>
                 <a:cs typeface="Calibri" pitchFamily="34" charset="-120"/>
               </a:rPr>
-              <a:t>license</a:t>
+              <a:t>log</a:t>
             </a:r>
             <a:endParaRPr lang="en-US" sz="1000" dirty="0"/>
           </a:p>
@@ -18465,8 +18465,8 @@
         </p:nvSpPr>
         <p:spPr>
           <a:xfrm>
-            <a:off x="9669272" y="4791456"/>
-            <a:ext cx="615696" cy="256032"/>
+            <a:off x="10376408" y="4791456"/>
+            <a:ext cx="681736" cy="256032"/>
           </a:xfrm>
           <a:prstGeom prst="roundRect">
             <a:avLst>
@@ -18492,8 +18492,8 @@
         </p:nvSpPr>
         <p:spPr>
           <a:xfrm>
-            <a:off x="9669272" y="4791456"/>
-            <a:ext cx="615696" cy="256032"/>
+            <a:off x="10376408" y="4791456"/>
+            <a:ext cx="681736" cy="256032"/>
           </a:xfrm>
           <a:prstGeom prst="rect">
             <a:avLst/>
@@ -18517,7 +18517,7 @@
                 <a:ea typeface="Calibri" pitchFamily="34" charset="-122"/>
                 <a:cs typeface="Calibri" pitchFamily="34" charset="-120"/>
               </a:rPr>
-              <a:t>doctor</a:t>
+              <a:t>license</a:t>
             </a:r>
             <a:endParaRPr lang="en-US" sz="1000" dirty="0"/>
           </a:p>
@@ -18531,8 +18531,8 @@
         </p:nvSpPr>
         <p:spPr>
           <a:xfrm>
-            <a:off x="10376408" y="4791456"/>
-            <a:ext cx="1011936" cy="256032"/>
+            <a:off x="457200" y="5138928"/>
+            <a:ext cx="615696" cy="256032"/>
           </a:xfrm>
           <a:prstGeom prst="roundRect">
             <a:avLst>
@@ -18558,8 +18558,8 @@
         </p:nvSpPr>
         <p:spPr>
           <a:xfrm>
-            <a:off x="10376408" y="4791456"/>
-            <a:ext cx="1011936" cy="256032"/>
+            <a:off x="457200" y="5138928"/>
+            <a:ext cx="615696" cy="256032"/>
           </a:xfrm>
           <a:prstGeom prst="rect">
             <a:avLst/>
@@ -18583,7 +18583,7 @@
                 <a:ea typeface="Calibri" pitchFamily="34" charset="-122"/>
                 <a:cs typeface="Calibri" pitchFamily="34" charset="-120"/>
               </a:rPr>
-              <a:t>plugin build</a:t>
+              <a:t>doctor</a:t>
             </a:r>
             <a:endParaRPr lang="en-US" sz="1000" dirty="0"/>
           </a:p>
@@ -18597,8 +18597,8 @@
         </p:nvSpPr>
         <p:spPr>
           <a:xfrm>
-            <a:off x="457200" y="5138928"/>
-            <a:ext cx="483616" cy="256032"/>
+            <a:off x="1164336" y="5138928"/>
+            <a:ext cx="1011936" cy="256032"/>
           </a:xfrm>
           <a:prstGeom prst="roundRect">
             <a:avLst>
@@ -18624,8 +18624,8 @@
         </p:nvSpPr>
         <p:spPr>
           <a:xfrm>
-            <a:off x="457200" y="5138928"/>
-            <a:ext cx="483616" cy="256032"/>
+            <a:off x="1164336" y="5138928"/>
+            <a:ext cx="1011936" cy="256032"/>
           </a:xfrm>
           <a:prstGeom prst="rect">
             <a:avLst/>
@@ -18649,7 +18649,7 @@
                 <a:ea typeface="Calibri" pitchFamily="34" charset="-122"/>
                 <a:cs typeface="Calibri" pitchFamily="34" charset="-120"/>
               </a:rPr>
-              <a:t>hook</a:t>
+              <a:t>plugin build</a:t>
             </a:r>
             <a:endParaRPr lang="en-US" sz="1000" dirty="0"/>
           </a:p>
@@ -18663,8 +18663,8 @@
         </p:nvSpPr>
         <p:spPr>
           <a:xfrm>
-            <a:off x="1032256" y="5138928"/>
-            <a:ext cx="747776" cy="256032"/>
+            <a:off x="2267712" y="5138928"/>
+            <a:ext cx="483616" cy="256032"/>
           </a:xfrm>
           <a:prstGeom prst="roundRect">
             <a:avLst>
@@ -18690,7 +18690,73 @@
         </p:nvSpPr>
         <p:spPr>
           <a:xfrm>
-            <a:off x="1032256" y="5138928"/>
+            <a:off x="2267712" y="5138928"/>
+            <a:ext cx="483616" cy="256032"/>
+          </a:xfrm>
+          <a:prstGeom prst="rect">
+            <a:avLst/>
+          </a:prstGeom>
+          <a:noFill/>
+          <a:ln/>
+        </p:spPr>
+        <p:txBody>
+          <a:bodyPr wrap="square" lIns="0" tIns="0" rIns="0" bIns="0" rtlCol="0" anchor="ctr"/>
+          <a:lstStyle/>
+          <a:p>
+            <a:pPr algn="ctr" indent="0" marL="0">
+              <a:buNone/>
+            </a:pPr>
+            <a:r>
+              <a:rPr lang="en-US" sz="1000" dirty="0">
+                <a:solidFill>
+                  <a:srgbClr val="1F2430"/>
+                </a:solidFill>
+                <a:latin typeface="Calibri" pitchFamily="34" charset="0"/>
+                <a:ea typeface="Calibri" pitchFamily="34" charset="-122"/>
+                <a:cs typeface="Calibri" pitchFamily="34" charset="-120"/>
+              </a:rPr>
+              <a:t>hook</a:t>
+            </a:r>
+            <a:endParaRPr lang="en-US" sz="1000" dirty="0"/>
+          </a:p>
+        </p:txBody>
+      </p:sp>
+      <p:sp>
+        <p:nvSpPr>
+          <p:cNvPr id="116" name="Shape 114"/>
+          <p:cNvSpPr/>
+          <p:nvPr/>
+        </p:nvSpPr>
+        <p:spPr>
+          <a:xfrm>
+            <a:off x="2842768" y="5138928"/>
+            <a:ext cx="747776" cy="256032"/>
+          </a:xfrm>
+          <a:prstGeom prst="roundRect">
+            <a:avLst>
+              <a:gd name="adj" fmla="val 50000"/>
+            </a:avLst>
+          </a:prstGeom>
+          <a:solidFill>
+            <a:srgbClr val="F3F5F8"/>
+          </a:solidFill>
+          <a:ln w="12700">
+            <a:solidFill>
+              <a:srgbClr val="F3F5F8"/>
+            </a:solidFill>
+            <a:prstDash val="solid"/>
+          </a:ln>
+        </p:spPr>
+      </p:sp>
+      <p:sp>
+        <p:nvSpPr>
+          <p:cNvPr id="117" name="Text 115"/>
+          <p:cNvSpPr txBox="1"/>
+          <p:nvPr/>
+        </p:nvSpPr>
+        <p:spPr>
+          <a:xfrm>
+            <a:off x="2842768" y="5138928"/>
             <a:ext cx="747776" cy="256032"/>
           </a:xfrm>
           <a:prstGeom prst="rect">
@@ -23185,7 +23251,7 @@
                 <a:ea typeface="Courier New" pitchFamily="34" charset="-122"/>
                 <a:cs typeface="Courier New" pitchFamily="34" charset="-120"/>
               </a:rPr>
-              <a:t>  sdlc 0.7.1, license: community</a:t>
+              <a:t>  sdlc 0.7.2, license: community</a:t>
             </a:r>
             <a:endParaRPr lang="en-US" sz="1000" dirty="0"/>
           </a:p>
@@ -26505,7 +26571,7 @@
         <p:spPr>
           <a:xfrm>
             <a:off x="3607816" y="6053328"/>
-            <a:ext cx="945896" cy="256032"/>
+            <a:ext cx="1342136" cy="256032"/>
           </a:xfrm>
           <a:prstGeom prst="roundRect">
             <a:avLst>
@@ -26532,7 +26598,7 @@
         <p:spPr>
           <a:xfrm>
             <a:off x="3607816" y="6053328"/>
-            <a:ext cx="945896" cy="256032"/>
+            <a:ext cx="1342136" cy="256032"/>
           </a:xfrm>
           <a:prstGeom prst="rect">
             <a:avLst/>
@@ -26556,7 +26622,7 @@
                 <a:ea typeface="Calibri" pitchFamily="34" charset="-122"/>
                 <a:cs typeface="Calibri" pitchFamily="34" charset="-120"/>
               </a:rPr>
-              <a:t>backlog add</a:t>
+              <a:t>backlog epic edit</a:t>
             </a:r>
             <a:endParaRPr lang="en-US" sz="1000" dirty="0"/>
           </a:p>
@@ -26570,8 +26636,8 @@
         </p:nvSpPr>
         <p:spPr>
           <a:xfrm>
-            <a:off x="4645152" y="6053328"/>
-            <a:ext cx="1011936" cy="256032"/>
+            <a:off x="5041392" y="6053328"/>
+            <a:ext cx="945896" cy="256032"/>
           </a:xfrm>
           <a:prstGeom prst="roundRect">
             <a:avLst>
@@ -26597,8 +26663,8 @@
         </p:nvSpPr>
         <p:spPr>
           <a:xfrm>
-            <a:off x="4645152" y="6053328"/>
-            <a:ext cx="1011936" cy="256032"/>
+            <a:off x="5041392" y="6053328"/>
+            <a:ext cx="945896" cy="256032"/>
           </a:xfrm>
           <a:prstGeom prst="rect">
             <a:avLst/>
@@ -26622,7 +26688,7 @@
                 <a:ea typeface="Calibri" pitchFamily="34" charset="-122"/>
                 <a:cs typeface="Calibri" pitchFamily="34" charset="-120"/>
               </a:rPr>
-              <a:t>backlog move</a:t>
+              <a:t>backlog add</a:t>
             </a:r>
             <a:endParaRPr lang="en-US" sz="1000" dirty="0"/>
           </a:p>
@@ -26636,7 +26702,7 @@
         </p:nvSpPr>
         <p:spPr>
           <a:xfrm>
-            <a:off x="5748528" y="6053328"/>
+            <a:off x="6078728" y="6053328"/>
             <a:ext cx="1011936" cy="256032"/>
           </a:xfrm>
           <a:prstGeom prst="roundRect">
@@ -26663,7 +26729,7 @@
         </p:nvSpPr>
         <p:spPr>
           <a:xfrm>
-            <a:off x="5748528" y="6053328"/>
+            <a:off x="6078728" y="6053328"/>
             <a:ext cx="1011936" cy="256032"/>
           </a:xfrm>
           <a:prstGeom prst="rect">
@@ -26688,7 +26754,7 @@
                 <a:ea typeface="Calibri" pitchFamily="34" charset="-122"/>
                 <a:cs typeface="Calibri" pitchFamily="34" charset="-120"/>
               </a:rPr>
-              <a:t>backlog edit</a:t>
+              <a:t>backlog move</a:t>
             </a:r>
             <a:endParaRPr lang="en-US" sz="1000" dirty="0"/>
           </a:p>
@@ -26702,7 +26768,7 @@
         </p:nvSpPr>
         <p:spPr>
           <a:xfrm>
-            <a:off x="6851904" y="6053328"/>
+            <a:off x="7182104" y="6053328"/>
             <a:ext cx="1011936" cy="256032"/>
           </a:xfrm>
           <a:prstGeom prst="roundRect">
@@ -26729,7 +26795,7 @@
         </p:nvSpPr>
         <p:spPr>
           <a:xfrm>
-            <a:off x="6851904" y="6053328"/>
+            <a:off x="7182104" y="6053328"/>
             <a:ext cx="1011936" cy="256032"/>
           </a:xfrm>
           <a:prstGeom prst="rect">
@@ -26754,7 +26820,7 @@
                 <a:ea typeface="Calibri" pitchFamily="34" charset="-122"/>
                 <a:cs typeface="Calibri" pitchFamily="34" charset="-120"/>
               </a:rPr>
-              <a:t>backlog drop</a:t>
+              <a:t>backlog edit</a:t>
             </a:r>
             <a:endParaRPr lang="en-US" sz="1000" dirty="0"/>
           </a:p>
@@ -26768,7 +26834,7 @@
         </p:nvSpPr>
         <p:spPr>
           <a:xfrm>
-            <a:off x="7955280" y="6053328"/>
+            <a:off x="8285480" y="6053328"/>
             <a:ext cx="1011936" cy="256032"/>
           </a:xfrm>
           <a:prstGeom prst="roundRect">
@@ -26795,7 +26861,73 @@
         </p:nvSpPr>
         <p:spPr>
           <a:xfrm>
-            <a:off x="7955280" y="6053328"/>
+            <a:off x="8285480" y="6053328"/>
+            <a:ext cx="1011936" cy="256032"/>
+          </a:xfrm>
+          <a:prstGeom prst="rect">
+            <a:avLst/>
+          </a:prstGeom>
+          <a:noFill/>
+          <a:ln/>
+        </p:spPr>
+        <p:txBody>
+          <a:bodyPr wrap="square" lIns="0" tIns="0" rIns="0" bIns="0" rtlCol="0" anchor="ctr"/>
+          <a:lstStyle/>
+          <a:p>
+            <a:pPr algn="ctr" indent="0" marL="0">
+              <a:buNone/>
+            </a:pPr>
+            <a:r>
+              <a:rPr lang="en-US" sz="1000" dirty="0">
+                <a:solidFill>
+                  <a:srgbClr val="5B6475"/>
+                </a:solidFill>
+                <a:latin typeface="Calibri" pitchFamily="34" charset="0"/>
+                <a:ea typeface="Calibri" pitchFamily="34" charset="-122"/>
+                <a:cs typeface="Calibri" pitchFamily="34" charset="-120"/>
+              </a:rPr>
+              <a:t>backlog drop</a:t>
+            </a:r>
+            <a:endParaRPr lang="en-US" sz="1000" dirty="0"/>
+          </a:p>
+        </p:txBody>
+      </p:sp>
+      <p:sp>
+        <p:nvSpPr>
+          <p:cNvPr id="38" name="Shape 36"/>
+          <p:cNvSpPr/>
+          <p:nvPr/>
+        </p:nvSpPr>
+        <p:spPr>
+          <a:xfrm>
+            <a:off x="9388856" y="6053328"/>
+            <a:ext cx="1011936" cy="256032"/>
+          </a:xfrm>
+          <a:prstGeom prst="roundRect">
+            <a:avLst>
+              <a:gd name="adj" fmla="val 50000"/>
+            </a:avLst>
+          </a:prstGeom>
+          <a:solidFill>
+            <a:srgbClr val="F3F5F8"/>
+          </a:solidFill>
+          <a:ln w="12700">
+            <a:solidFill>
+              <a:srgbClr val="F3F5F8"/>
+            </a:solidFill>
+            <a:prstDash val="solid"/>
+          </a:ln>
+        </p:spPr>
+      </p:sp>
+      <p:sp>
+        <p:nvSpPr>
+          <p:cNvPr id="39" name="Text 37"/>
+          <p:cNvSpPr txBox="1"/>
+          <p:nvPr/>
+        </p:nvSpPr>
+        <p:spPr>
+          <a:xfrm>
+            <a:off x="9388856" y="6053328"/>
             <a:ext cx="1011936" cy="256032"/>
           </a:xfrm>
           <a:prstGeom prst="rect">

</xml_diff>

<commit_message>
fix: CLI writes keep what people wrote by hand (0.7.3)
- Backlog commands keep notes under items and epics, unknown fields, fenced
  blocks, extra sections and an unknown status in openspec/backlog.md; a
  command changes only its own item or epic.
- Settings writes (adopt --apply, license set, init, layout adapt) keep the
  comments and hand-added keys in openspec/sdlc.yaml; only changed keys are
  written, and a file with nothing new is not touched.
- After sdlc init --layout worktree the output leads with the new worktree.
- The guide and the README describe the path for an existing project, from
  init to an empty backlog.
</commit_message>
<xml_diff>
--- a/docs/demo/sdlc-calculator-demo.en.pptx
+++ b/docs/demo/sdlc-calculator-demo.en.pptx
@@ -6566,7 +6566,7 @@
                 <a:ea typeface="Courier New" pitchFamily="34" charset="-122"/>
                 <a:cs typeface="Courier New" pitchFamily="34" charset="-120"/>
               </a:rPr>
-              <a:t>  code-owner (85e76c97d625)</a:t>
+              <a:t>  code-owner (a229dad94f6b)</a:t>
             </a:r>
             <a:endParaRPr lang="en-US" sz="1000" dirty="0"/>
           </a:p>
@@ -7247,7 +7247,7 @@
                 <a:ea typeface="Courier New" pitchFamily="34" charset="-122"/>
                 <a:cs typeface="Courier New" pitchFamily="34" charset="-120"/>
               </a:rPr>
-              <a:t>  release-manager (85e76c97d625)</a:t>
+              <a:t>  release-manager (a229dad94f6b)</a:t>
             </a:r>
             <a:endParaRPr lang="en-US" sz="1000" dirty="0"/>
           </a:p>
@@ -7547,7 +7547,7 @@
                 <a:ea typeface="Courier New" pitchFamily="34" charset="-122"/>
                 <a:cs typeface="Courier New" pitchFamily="34" charset="-120"/>
               </a:rPr>
-              <a:t>✓ basic-arithmetic/intent alice valid adbf5d87</a:t>
+              <a:t>✓ basic-arithmetic/intent alice valid 6b282762</a:t>
             </a:r>
             <a:endParaRPr lang="en-US" sz="1000" dirty="0"/>
           </a:p>
@@ -7564,7 +7564,7 @@
                 <a:ea typeface="Courier New" pitchFamily="34" charset="-122"/>
                 <a:cs typeface="Courier New" pitchFamily="34" charset="-120"/>
               </a:rPr>
-              <a:t>✓ basic-arithmetic/spec alice valid adbf5d87</a:t>
+              <a:t>✓ basic-arithmetic/spec alice valid 6b282762</a:t>
             </a:r>
             <a:endParaRPr lang="en-US" sz="1000" dirty="0"/>
           </a:p>
@@ -7581,7 +7581,7 @@
                 <a:ea typeface="Courier New" pitchFamily="34" charset="-122"/>
                 <a:cs typeface="Courier New" pitchFamily="34" charset="-120"/>
               </a:rPr>
-              <a:t>✗ basic-arithmetic/plan bob unsigned 0d7032b7</a:t>
+              <a:t>✗ basic-arithmetic/plan bob unsigned 60b4c38b</a:t>
             </a:r>
             <a:endParaRPr lang="en-US" sz="1000" dirty="0"/>
           </a:p>
@@ -7598,7 +7598,7 @@
                 <a:ea typeface="Courier New" pitchFamily="34" charset="-122"/>
                 <a:cs typeface="Courier New" pitchFamily="34" charset="-120"/>
               </a:rPr>
-              <a:t>✓ basic-arithmetic/review carol valid 126b5c9f</a:t>
+              <a:t>✓ basic-arithmetic/review carol valid 79c0bc5e</a:t>
             </a:r>
             <a:endParaRPr lang="en-US" sz="1000" dirty="0"/>
           </a:p>
@@ -7615,7 +7615,7 @@
                 <a:ea typeface="Courier New" pitchFamily="34" charset="-122"/>
                 <a:cs typeface="Courier New" pitchFamily="34" charset="-120"/>
               </a:rPr>
-              <a:t>✓ basic-arithmetic/release alice valid 65b45c43</a:t>
+              <a:t>✓ basic-arithmetic/release alice valid dd3496e0</a:t>
             </a:r>
             <a:endParaRPr lang="en-US" sz="1000" dirty="0"/>
           </a:p>
@@ -7632,7 +7632,7 @@
                 <a:ea typeface="Courier New" pitchFamily="34" charset="-122"/>
                 <a:cs typeface="Courier New" pitchFamily="34" charset="-120"/>
               </a:rPr>
-              <a:t>✓ openspec/roles.yaml alice@calc.example valid b3da9c0c</a:t>
+              <a:t>✓ openspec/roles.yaml alice@calc.example valid 2e59e352</a:t>
             </a:r>
             <a:endParaRPr lang="en-US" sz="1000" dirty="0"/>
           </a:p>
@@ -13671,7 +13671,7 @@
                 <a:ea typeface="Courier New" pitchFamily="34" charset="-122"/>
                 <a:cs typeface="Courier New" pitchFamily="34" charset="-120"/>
               </a:rPr>
-              <a:t>  archived) · sdlc 0.7.2, license:</a:t>
+              <a:t>  archived) · sdlc 0.7.3, license:</a:t>
             </a:r>
             <a:endParaRPr lang="en-US" sz="1000" dirty="0"/>
           </a:p>
@@ -13807,7 +13807,7 @@
                 <a:ea typeface="Courier New" pitchFamily="34" charset="-122"/>
                 <a:cs typeface="Courier New" pitchFamily="34" charset="-120"/>
               </a:rPr>
-              <a:t>  recorded with sdlc 0.7.2; licenses:</a:t>
+              <a:t>  recorded with sdlc 0.7.3; licenses:</a:t>
             </a:r>
             <a:endParaRPr lang="en-US" sz="1000" dirty="0"/>
           </a:p>
@@ -14124,7 +14124,7 @@
                 <a:ea typeface="Courier New" pitchFamily="34" charset="-122"/>
                 <a:cs typeface="Courier New" pitchFamily="34" charset="-120"/>
               </a:rPr>
-              <a:t>2026-10-05T12:39:34.297Z  deferred.added   </a:t>
+              <a:t>2026-10-05T16:50:59.142Z  deferred.added   </a:t>
             </a:r>
             <a:endParaRPr lang="en-US" sz="1000" dirty="0"/>
           </a:p>
@@ -14175,7 +14175,7 @@
                 <a:ea typeface="Courier New" pitchFamily="34" charset="-122"/>
                 <a:cs typeface="Courier New" pitchFamily="34" charset="-120"/>
               </a:rPr>
-              <a:t>  shows an error [sdlc 0.7.2 · community]</a:t>
+              <a:t>  shows an error [sdlc 0.7.3 · community]</a:t>
             </a:r>
             <a:endParaRPr lang="en-US" sz="1000" dirty="0"/>
           </a:p>
@@ -14192,7 +14192,7 @@
                 <a:ea typeface="Courier New" pitchFamily="34" charset="-122"/>
                 <a:cs typeface="Courier New" pitchFamily="34" charset="-120"/>
               </a:rPr>
-              <a:t>2026-10-05T12:39:38.980Z  gate.review.appro</a:t>
+              <a:t>2026-10-05T16:51:04.017Z  gate.review.appro</a:t>
             </a:r>
             <a:endParaRPr lang="en-US" sz="1000" dirty="0"/>
           </a:p>
@@ -14243,7 +14243,7 @@
                 <a:ea typeface="Courier New" pitchFamily="34" charset="-122"/>
                 <a:cs typeface="Courier New" pitchFamily="34" charset="-120"/>
               </a:rPr>
-              <a:t>  [sdlc 0.7.2 · community]</a:t>
+              <a:t>  [sdlc 0.7.3 · community]</a:t>
             </a:r>
             <a:endParaRPr lang="en-US" sz="1000" dirty="0"/>
           </a:p>
@@ -14260,7 +14260,7 @@
                 <a:ea typeface="Courier New" pitchFamily="34" charset="-122"/>
                 <a:cs typeface="Courier New" pitchFamily="34" charset="-120"/>
               </a:rPr>
-              <a:t>2026-10-05T12:39:41.022Z  gate.release.appr</a:t>
+              <a:t>2026-10-05T16:51:06.107Z  gate.release.appr</a:t>
             </a:r>
             <a:endParaRPr lang="en-US" sz="1000" dirty="0"/>
           </a:p>
@@ -14311,7 +14311,7 @@
                 <a:ea typeface="Courier New" pitchFamily="34" charset="-122"/>
                 <a:cs typeface="Courier New" pitchFamily="34" charset="-120"/>
               </a:rPr>
-              <a:t>  release-manager [sdlc 0.7.2 · community]</a:t>
+              <a:t>  release-manager [sdlc 0.7.3 · community]</a:t>
             </a:r>
             <a:endParaRPr lang="en-US" sz="1000" dirty="0"/>
           </a:p>
@@ -14328,7 +14328,7 @@
                 <a:ea typeface="Courier New" pitchFamily="34" charset="-122"/>
                 <a:cs typeface="Courier New" pitchFamily="34" charset="-120"/>
               </a:rPr>
-              <a:t>2026-10-05T12:39:46.317Z  change.archived  </a:t>
+              <a:t>2026-10-05T16:51:11.426Z  change.archived  </a:t>
             </a:r>
             <a:endParaRPr lang="en-US" sz="1000" dirty="0"/>
           </a:p>
@@ -23251,7 +23251,7 @@
                 <a:ea typeface="Courier New" pitchFamily="34" charset="-122"/>
                 <a:cs typeface="Courier New" pitchFamily="34" charset="-120"/>
               </a:rPr>
-              <a:t>  sdlc 0.7.2, license: community</a:t>
+              <a:t>  sdlc 0.7.3, license: community</a:t>
             </a:r>
             <a:endParaRPr lang="en-US" sz="1000" dirty="0"/>
           </a:p>

</xml_diff>

<commit_message>
fix: decision order without clocks; hard links to state files (0.8.1)
- The order of decisions in a change record no longer depends on the clocks
  of the machines that wrote them: every decision carries a sequence number
  and is ordered by it, so an approval from a machine whose clock ran ahead
  stops counting after a later rework, and a skewed rework or rejection no
  longer hides a re-approval. Older records keep the time rule.
- An agent's edit of a hard link to a state file is denied.
</commit_message>
<xml_diff>
--- a/docs/demo/sdlc-calculator-demo.en.pptx
+++ b/docs/demo/sdlc-calculator-demo.en.pptx
@@ -5018,7 +5018,7 @@
                 <a:ea typeface="Courier New" pitchFamily="34" charset="-122"/>
                 <a:cs typeface="Courier New" pitchFamily="34" charset="-120"/>
               </a:rPr>
-              <a:t>✓ test (1.0s)</a:t>
+              <a:t>✓ test (1.1s)</a:t>
             </a:r>
             <a:endParaRPr lang="en-US" sz="1000" dirty="0"/>
           </a:p>
@@ -6566,7 +6566,7 @@
                 <a:ea typeface="Courier New" pitchFamily="34" charset="-122"/>
                 <a:cs typeface="Courier New" pitchFamily="34" charset="-120"/>
               </a:rPr>
-              <a:t>  code-owner (6839dde7b6d0)</a:t>
+              <a:t>  code-owner (5c90e1c6fa00)</a:t>
             </a:r>
             <a:endParaRPr lang="en-US" sz="1000" dirty="0"/>
           </a:p>
@@ -7247,7 +7247,7 @@
                 <a:ea typeface="Courier New" pitchFamily="34" charset="-122"/>
                 <a:cs typeface="Courier New" pitchFamily="34" charset="-120"/>
               </a:rPr>
-              <a:t>  release-manager (6839dde7b6d0)</a:t>
+              <a:t>  release-manager (5c90e1c6fa00)</a:t>
             </a:r>
             <a:endParaRPr lang="en-US" sz="1000" dirty="0"/>
           </a:p>
@@ -7547,7 +7547,7 @@
                 <a:ea typeface="Courier New" pitchFamily="34" charset="-122"/>
                 <a:cs typeface="Courier New" pitchFamily="34" charset="-120"/>
               </a:rPr>
-              <a:t>✓ basic-arithmetic/intent alice valid 7ccff08e</a:t>
+              <a:t>✓ basic-arithmetic/intent alice valid 7228fa65</a:t>
             </a:r>
             <a:endParaRPr lang="en-US" sz="1000" dirty="0"/>
           </a:p>
@@ -7564,7 +7564,7 @@
                 <a:ea typeface="Courier New" pitchFamily="34" charset="-122"/>
                 <a:cs typeface="Courier New" pitchFamily="34" charset="-120"/>
               </a:rPr>
-              <a:t>✓ basic-arithmetic/spec alice valid 371e403b</a:t>
+              <a:t>✓ basic-arithmetic/spec alice valid 2bf3f4be</a:t>
             </a:r>
             <a:endParaRPr lang="en-US" sz="1000" dirty="0"/>
           </a:p>
@@ -7581,7 +7581,7 @@
                 <a:ea typeface="Courier New" pitchFamily="34" charset="-122"/>
                 <a:cs typeface="Courier New" pitchFamily="34" charset="-120"/>
               </a:rPr>
-              <a:t>✗ basic-arithmetic/plan bob wrong-signer 371e403b</a:t>
+              <a:t>✗ basic-arithmetic/plan bob wrong-signer 2bf3f4be</a:t>
             </a:r>
             <a:endParaRPr lang="en-US" sz="1000" dirty="0"/>
           </a:p>
@@ -7598,7 +7598,7 @@
                 <a:ea typeface="Courier New" pitchFamily="34" charset="-122"/>
                 <a:cs typeface="Courier New" pitchFamily="34" charset="-120"/>
               </a:rPr>
-              <a:t>✓ basic-arithmetic/review carol valid ed4cdd83</a:t>
+              <a:t>✓ basic-arithmetic/review carol valid 58210da3</a:t>
             </a:r>
             <a:endParaRPr lang="en-US" sz="1000" dirty="0"/>
           </a:p>
@@ -7615,7 +7615,7 @@
                 <a:ea typeface="Courier New" pitchFamily="34" charset="-122"/>
                 <a:cs typeface="Courier New" pitchFamily="34" charset="-120"/>
               </a:rPr>
-              <a:t>✓ basic-arithmetic/release alice valid 23117b69</a:t>
+              <a:t>✓ basic-arithmetic/release alice valid 5341d847</a:t>
             </a:r>
             <a:endParaRPr lang="en-US" sz="1000" dirty="0"/>
           </a:p>
@@ -7632,7 +7632,7 @@
                 <a:ea typeface="Courier New" pitchFamily="34" charset="-122"/>
                 <a:cs typeface="Courier New" pitchFamily="34" charset="-120"/>
               </a:rPr>
-              <a:t>✓ openspec/roles.yaml alice@calc.example valid 71b79561</a:t>
+              <a:t>✓ openspec/roles.yaml alice@calc.example valid b323bfed</a:t>
             </a:r>
             <a:endParaRPr lang="en-US" sz="1000" dirty="0"/>
           </a:p>
@@ -8093,7 +8093,7 @@
                 <a:ea typeface="Courier New" pitchFamily="34" charset="-122"/>
                 <a:cs typeface="Courier New" pitchFamily="34" charset="-120"/>
               </a:rPr>
-              <a:t>  openspec\changes\archive\2026-10-05-basic</a:t>
+              <a:t>  openspec\changes\archive\2026-10-06-basic</a:t>
             </a:r>
             <a:endParaRPr lang="en-US" sz="1000" dirty="0"/>
           </a:p>
@@ -13737,7 +13737,7 @@
                 <a:ea typeface="Courier New" pitchFamily="34" charset="-122"/>
                 <a:cs typeface="Courier New" pitchFamily="34" charset="-120"/>
               </a:rPr>
-              <a:t>  archived) · sdlc 0.8.0, license:</a:t>
+              <a:t>  archived) · sdlc 0.8.1, license:</a:t>
             </a:r>
             <a:endParaRPr lang="en-US" sz="1000" dirty="0"/>
           </a:p>
@@ -13890,7 +13890,7 @@
                 <a:ea typeface="Courier New" pitchFamily="34" charset="-122"/>
                 <a:cs typeface="Courier New" pitchFamily="34" charset="-120"/>
               </a:rPr>
-              <a:t>  intent 2 · spec 7 · plan 8 · review 2;</a:t>
+              <a:t>  intent 3 · spec 9 · plan 8 · review 3;</a:t>
             </a:r>
             <a:endParaRPr lang="en-US" sz="1000" dirty="0"/>
           </a:p>
@@ -13924,7 +13924,7 @@
                 <a:ea typeface="Courier New" pitchFamily="34" charset="-122"/>
                 <a:cs typeface="Courier New" pitchFamily="34" charset="-120"/>
               </a:rPr>
-              <a:t>  recorded with sdlc 0.8.0; licenses:</a:t>
+              <a:t>  recorded with sdlc 0.8.1; licenses:</a:t>
             </a:r>
             <a:endParaRPr lang="en-US" sz="1000" dirty="0"/>
           </a:p>
@@ -14241,7 +14241,7 @@
                 <a:ea typeface="Courier New" pitchFamily="34" charset="-122"/>
                 <a:cs typeface="Courier New" pitchFamily="34" charset="-120"/>
               </a:rPr>
-              <a:t>2026-10-05T20:31:10.507Z  gate.review.await</a:t>
+              <a:t>2026-10-06T09:41:18.909Z  gate.review.await</a:t>
             </a:r>
             <a:endParaRPr lang="en-US" sz="1000" dirty="0"/>
           </a:p>
@@ -14275,7 +14275,7 @@
                 <a:ea typeface="Courier New" pitchFamily="34" charset="-122"/>
                 <a:cs typeface="Courier New" pitchFamily="34" charset="-120"/>
               </a:rPr>
-              <a:t>  sha256:6839dde7b6d0d2b59ae640509bcfdb2d9c</a:t>
+              <a:t>  sha256:5c90e1c6fa00abfcdc680b0025b647bc90</a:t>
             </a:r>
             <a:endParaRPr lang="en-US" sz="1000" dirty="0"/>
           </a:p>
@@ -14292,7 +14292,7 @@
                 <a:ea typeface="Courier New" pitchFamily="34" charset="-122"/>
                 <a:cs typeface="Courier New" pitchFamily="34" charset="-120"/>
               </a:rPr>
-              <a:t>  c6ee7489b5dcb865f1ed7bc402216b [sdlc</a:t>
+              <a:t>  490a56dcb3f638ca31896d2d865d4c [sdlc</a:t>
             </a:r>
             <a:endParaRPr lang="en-US" sz="1000" dirty="0"/>
           </a:p>
@@ -14309,7 +14309,7 @@
                 <a:ea typeface="Courier New" pitchFamily="34" charset="-122"/>
                 <a:cs typeface="Courier New" pitchFamily="34" charset="-120"/>
               </a:rPr>
-              <a:t>  0.8.0 · community]</a:t>
+              <a:t>  0.8.1 · community]</a:t>
             </a:r>
             <a:endParaRPr lang="en-US" sz="1000" dirty="0"/>
           </a:p>
@@ -14326,7 +14326,7 @@
                 <a:ea typeface="Courier New" pitchFamily="34" charset="-122"/>
                 <a:cs typeface="Courier New" pitchFamily="34" charset="-120"/>
               </a:rPr>
-              <a:t>2026-10-05T20:31:12.907Z  gate.review.appro</a:t>
+              <a:t>2026-10-06T09:41:21.551Z  gate.review.appro</a:t>
             </a:r>
             <a:endParaRPr lang="en-US" sz="1000" dirty="0"/>
           </a:p>
@@ -14377,7 +14377,7 @@
                 <a:ea typeface="Courier New" pitchFamily="34" charset="-122"/>
                 <a:cs typeface="Courier New" pitchFamily="34" charset="-120"/>
               </a:rPr>
-              <a:t>  [sdlc 0.8.0 · community]</a:t>
+              <a:t>  [sdlc 0.8.1 · community]</a:t>
             </a:r>
             <a:endParaRPr lang="en-US" sz="1000" dirty="0"/>
           </a:p>
@@ -14394,7 +14394,7 @@
                 <a:ea typeface="Courier New" pitchFamily="34" charset="-122"/>
                 <a:cs typeface="Courier New" pitchFamily="34" charset="-120"/>
               </a:rPr>
-              <a:t>2026-10-05T20:31:16.013Z  gate.release.appr</a:t>
+              <a:t>2026-10-06T09:41:24.808Z  gate.release.appr</a:t>
             </a:r>
             <a:endParaRPr lang="en-US" sz="1000" dirty="0"/>
           </a:p>
@@ -14445,7 +14445,7 @@
                 <a:ea typeface="Courier New" pitchFamily="34" charset="-122"/>
                 <a:cs typeface="Courier New" pitchFamily="34" charset="-120"/>
               </a:rPr>
-              <a:t>  release-manager [sdlc 0.8.0 · community]</a:t>
+              <a:t>  release-manager [sdlc 0.8.1 · community]</a:t>
             </a:r>
             <a:endParaRPr lang="en-US" sz="1000" dirty="0"/>
           </a:p>
@@ -23632,7 +23632,7 @@
                 <a:ea typeface="Courier New" pitchFamily="34" charset="-122"/>
                 <a:cs typeface="Courier New" pitchFamily="34" charset="-120"/>
               </a:rPr>
-              <a:t>  sdlc 0.8.0, license: community</a:t>
+              <a:t>  sdlc 0.8.1, license: community</a:t>
             </a:r>
             <a:endParaRPr lang="en-US" sz="1000" dirty="0"/>
           </a:p>

</xml_diff>

<commit_message>
fix: an agent can no longer switch the guard off (0.8.2)
- Edits and shell writes of the files that configure the guard are denied
  to agents, also in warn mode: openspec/sdlc.yaml, the Claude Code
  settings, the OpenCode plugin, .mcp.json, opencode.json and the
  manifest, and the user-level agent settings (~/.claude/settings.json,
  the global OpenCode config) that can switch every hook off.
- In an agent session sdlc init and update refuse a lower enforcement
  mode, a dropped tool, --no-hooks and another --cli; sdlc uninstall is a
  person's command. sdlc doctor warns about disableAllHooks.
- The Claude Code hook also checks the PowerShell tool.
</commit_message>
<xml_diff>
--- a/docs/demo/sdlc-calculator-demo.en.pptx
+++ b/docs/demo/sdlc-calculator-demo.en.pptx
@@ -5018,7 +5018,7 @@
                 <a:ea typeface="Courier New" pitchFamily="34" charset="-122"/>
                 <a:cs typeface="Courier New" pitchFamily="34" charset="-120"/>
               </a:rPr>
-              <a:t>✓ test (1.1s)</a:t>
+              <a:t>✓ test (1.0s)</a:t>
             </a:r>
             <a:endParaRPr lang="en-US" sz="1000" dirty="0"/>
           </a:p>
@@ -6566,7 +6566,7 @@
                 <a:ea typeface="Courier New" pitchFamily="34" charset="-122"/>
                 <a:cs typeface="Courier New" pitchFamily="34" charset="-120"/>
               </a:rPr>
-              <a:t>  code-owner (5c90e1c6fa00)</a:t>
+              <a:t>  code-owner (2aedf7802f5b)</a:t>
             </a:r>
             <a:endParaRPr lang="en-US" sz="1000" dirty="0"/>
           </a:p>
@@ -7247,7 +7247,7 @@
                 <a:ea typeface="Courier New" pitchFamily="34" charset="-122"/>
                 <a:cs typeface="Courier New" pitchFamily="34" charset="-120"/>
               </a:rPr>
-              <a:t>  release-manager (5c90e1c6fa00)</a:t>
+              <a:t>  release-manager (2aedf7802f5b)</a:t>
             </a:r>
             <a:endParaRPr lang="en-US" sz="1000" dirty="0"/>
           </a:p>
@@ -7547,7 +7547,7 @@
                 <a:ea typeface="Courier New" pitchFamily="34" charset="-122"/>
                 <a:cs typeface="Courier New" pitchFamily="34" charset="-120"/>
               </a:rPr>
-              <a:t>✓ basic-arithmetic/intent alice valid 7228fa65</a:t>
+              <a:t>✓ basic-arithmetic/intent alice valid 17e3aa0e</a:t>
             </a:r>
             <a:endParaRPr lang="en-US" sz="1000" dirty="0"/>
           </a:p>
@@ -7564,7 +7564,7 @@
                 <a:ea typeface="Courier New" pitchFamily="34" charset="-122"/>
                 <a:cs typeface="Courier New" pitchFamily="34" charset="-120"/>
               </a:rPr>
-              <a:t>✓ basic-arithmetic/spec alice valid 2bf3f4be</a:t>
+              <a:t>✓ basic-arithmetic/spec alice valid fae7f89c</a:t>
             </a:r>
             <a:endParaRPr lang="en-US" sz="1000" dirty="0"/>
           </a:p>
@@ -7581,7 +7581,7 @@
                 <a:ea typeface="Courier New" pitchFamily="34" charset="-122"/>
                 <a:cs typeface="Courier New" pitchFamily="34" charset="-120"/>
               </a:rPr>
-              <a:t>✗ basic-arithmetic/plan bob wrong-signer 2bf3f4be</a:t>
+              <a:t>✗ basic-arithmetic/plan bob wrong-signer fae7f89c</a:t>
             </a:r>
             <a:endParaRPr lang="en-US" sz="1000" dirty="0"/>
           </a:p>
@@ -7598,7 +7598,7 @@
                 <a:ea typeface="Courier New" pitchFamily="34" charset="-122"/>
                 <a:cs typeface="Courier New" pitchFamily="34" charset="-120"/>
               </a:rPr>
-              <a:t>✓ basic-arithmetic/review carol valid 58210da3</a:t>
+              <a:t>✓ basic-arithmetic/review carol valid 1328e601</a:t>
             </a:r>
             <a:endParaRPr lang="en-US" sz="1000" dirty="0"/>
           </a:p>
@@ -7615,7 +7615,7 @@
                 <a:ea typeface="Courier New" pitchFamily="34" charset="-122"/>
                 <a:cs typeface="Courier New" pitchFamily="34" charset="-120"/>
               </a:rPr>
-              <a:t>✓ basic-arithmetic/release alice valid 5341d847</a:t>
+              <a:t>✓ basic-arithmetic/release alice valid 7f1f5d77</a:t>
             </a:r>
             <a:endParaRPr lang="en-US" sz="1000" dirty="0"/>
           </a:p>
@@ -7632,7 +7632,7 @@
                 <a:ea typeface="Courier New" pitchFamily="34" charset="-122"/>
                 <a:cs typeface="Courier New" pitchFamily="34" charset="-120"/>
               </a:rPr>
-              <a:t>✓ openspec/roles.yaml alice@calc.example valid b323bfed</a:t>
+              <a:t>✓ openspec/roles.yaml alice@calc.example valid c2855f48</a:t>
             </a:r>
             <a:endParaRPr lang="en-US" sz="1000" dirty="0"/>
           </a:p>
@@ -13737,7 +13737,7 @@
                 <a:ea typeface="Courier New" pitchFamily="34" charset="-122"/>
                 <a:cs typeface="Courier New" pitchFamily="34" charset="-120"/>
               </a:rPr>
-              <a:t>  archived) · sdlc 0.8.1, license:</a:t>
+              <a:t>  archived) · sdlc 0.8.2, license:</a:t>
             </a:r>
             <a:endParaRPr lang="en-US" sz="1000" dirty="0"/>
           </a:p>
@@ -13890,7 +13890,7 @@
                 <a:ea typeface="Courier New" pitchFamily="34" charset="-122"/>
                 <a:cs typeface="Courier New" pitchFamily="34" charset="-120"/>
               </a:rPr>
-              <a:t>  intent 3 · spec 9 · plan 8 · review 3;</a:t>
+              <a:t>  intent 2 · spec 8 · plan 7 · review 2;</a:t>
             </a:r>
             <a:endParaRPr lang="en-US" sz="1000" dirty="0"/>
           </a:p>
@@ -13924,7 +13924,7 @@
                 <a:ea typeface="Courier New" pitchFamily="34" charset="-122"/>
                 <a:cs typeface="Courier New" pitchFamily="34" charset="-120"/>
               </a:rPr>
-              <a:t>  recorded with sdlc 0.8.1; licenses:</a:t>
+              <a:t>  recorded with sdlc 0.8.2; licenses:</a:t>
             </a:r>
             <a:endParaRPr lang="en-US" sz="1000" dirty="0"/>
           </a:p>
@@ -14241,7 +14241,7 @@
                 <a:ea typeface="Courier New" pitchFamily="34" charset="-122"/>
                 <a:cs typeface="Courier New" pitchFamily="34" charset="-120"/>
               </a:rPr>
-              <a:t>2026-10-06T09:41:18.909Z  gate.review.await</a:t>
+              <a:t>2026-10-06T17:22:56.195Z  gate.review.await</a:t>
             </a:r>
             <a:endParaRPr lang="en-US" sz="1000" dirty="0"/>
           </a:p>
@@ -14275,7 +14275,7 @@
                 <a:ea typeface="Courier New" pitchFamily="34" charset="-122"/>
                 <a:cs typeface="Courier New" pitchFamily="34" charset="-120"/>
               </a:rPr>
-              <a:t>  sha256:5c90e1c6fa00abfcdc680b0025b647bc90</a:t>
+              <a:t>  sha256:2aedf7802f5b11661377b3e5b60d79e70a</a:t>
             </a:r>
             <a:endParaRPr lang="en-US" sz="1000" dirty="0"/>
           </a:p>
@@ -14292,7 +14292,7 @@
                 <a:ea typeface="Courier New" pitchFamily="34" charset="-122"/>
                 <a:cs typeface="Courier New" pitchFamily="34" charset="-120"/>
               </a:rPr>
-              <a:t>  490a56dcb3f638ca31896d2d865d4c [sdlc</a:t>
+              <a:t>  5af3baf498493332918fe82795e330 [sdlc</a:t>
             </a:r>
             <a:endParaRPr lang="en-US" sz="1000" dirty="0"/>
           </a:p>
@@ -14309,7 +14309,7 @@
                 <a:ea typeface="Courier New" pitchFamily="34" charset="-122"/>
                 <a:cs typeface="Courier New" pitchFamily="34" charset="-120"/>
               </a:rPr>
-              <a:t>  0.8.1 · community]</a:t>
+              <a:t>  0.8.2 · community]</a:t>
             </a:r>
             <a:endParaRPr lang="en-US" sz="1000" dirty="0"/>
           </a:p>
@@ -14326,7 +14326,7 @@
                 <a:ea typeface="Courier New" pitchFamily="34" charset="-122"/>
                 <a:cs typeface="Courier New" pitchFamily="34" charset="-120"/>
               </a:rPr>
-              <a:t>2026-10-06T09:41:21.551Z  gate.review.appro</a:t>
+              <a:t>2026-10-06T17:22:58.519Z  gate.review.appro</a:t>
             </a:r>
             <a:endParaRPr lang="en-US" sz="1000" dirty="0"/>
           </a:p>
@@ -14377,7 +14377,7 @@
                 <a:ea typeface="Courier New" pitchFamily="34" charset="-122"/>
                 <a:cs typeface="Courier New" pitchFamily="34" charset="-120"/>
               </a:rPr>
-              <a:t>  [sdlc 0.8.1 · community]</a:t>
+              <a:t>  [sdlc 0.8.2 · community]</a:t>
             </a:r>
             <a:endParaRPr lang="en-US" sz="1000" dirty="0"/>
           </a:p>
@@ -14394,7 +14394,7 @@
                 <a:ea typeface="Courier New" pitchFamily="34" charset="-122"/>
                 <a:cs typeface="Courier New" pitchFamily="34" charset="-120"/>
               </a:rPr>
-              <a:t>2026-10-06T09:41:24.808Z  gate.release.appr</a:t>
+              <a:t>2026-10-06T17:23:01.542Z  gate.release.appr</a:t>
             </a:r>
             <a:endParaRPr lang="en-US" sz="1000" dirty="0"/>
           </a:p>
@@ -14445,7 +14445,7 @@
                 <a:ea typeface="Courier New" pitchFamily="34" charset="-122"/>
                 <a:cs typeface="Courier New" pitchFamily="34" charset="-120"/>
               </a:rPr>
-              <a:t>  release-manager [sdlc 0.8.1 · community]</a:t>
+              <a:t>  release-manager [sdlc 0.8.2 · community]</a:t>
             </a:r>
             <a:endParaRPr lang="en-US" sz="1000" dirty="0"/>
           </a:p>
@@ -23632,7 +23632,7 @@
                 <a:ea typeface="Courier New" pitchFamily="34" charset="-122"/>
                 <a:cs typeface="Courier New" pitchFamily="34" charset="-120"/>
               </a:rPr>
-              <a:t>  sdlc 0.8.1, license: community</a:t>
+              <a:t>  sdlc 0.8.2, license: community</a:t>
             </a:r>
             <a:endParaRPr lang="en-US" sz="1000" dirty="0"/>
           </a:p>

</xml_diff>

<commit_message>
feat: ask the agent how sdlc works; next --me; approve --preview (0.9.1)
- A guide workflow answers how to work with sdlc for the project: stages,
  approvals, roles, tracks, bug fixes, the backlog, rework, verification,
  review, MCP, configuration and hook denials. The material ships with
  sdlc in English and Russian (sdlc guide [topic[#section]]); the session
  start mentions it, every hook denial names the section that explains
  it, and the sdlc MCP server offers it as the guide tool.
- sdlc next --me lists every gate waiting for you, with the command.
- sdlc approve --preview shows what you are about to approve and whether
  you may, without writing anything.
</commit_message>
<xml_diff>
--- a/docs/demo/sdlc-calculator-demo.en.pptx
+++ b/docs/demo/sdlc-calculator-demo.en.pptx
@@ -6658,7 +6658,7 @@
                 <a:ea typeface="Courier New" pitchFamily="34" charset="-122"/>
                 <a:cs typeface="Courier New" pitchFamily="34" charset="-120"/>
               </a:rPr>
-              <a:t>  code-owner (3b46e2724403)</a:t>
+              <a:t>  code-owner (15207f0f3042)</a:t>
             </a:r>
             <a:endParaRPr lang="en-US" sz="1000" dirty="0"/>
           </a:p>
@@ -7339,7 +7339,7 @@
                 <a:ea typeface="Courier New" pitchFamily="34" charset="-122"/>
                 <a:cs typeface="Courier New" pitchFamily="34" charset="-120"/>
               </a:rPr>
-              <a:t>  release-manager (3b46e2724403)</a:t>
+              <a:t>  release-manager (15207f0f3042)</a:t>
             </a:r>
             <a:endParaRPr lang="en-US" sz="1000" dirty="0"/>
           </a:p>
@@ -7639,7 +7639,7 @@
                 <a:ea typeface="Courier New" pitchFamily="34" charset="-122"/>
                 <a:cs typeface="Courier New" pitchFamily="34" charset="-120"/>
               </a:rPr>
-              <a:t>✓ basic-arithmetic/intent alice valid 2d54ab62</a:t>
+              <a:t>✓ basic-arithmetic/intent alice valid 5076f215</a:t>
             </a:r>
             <a:endParaRPr lang="en-US" sz="1000" dirty="0"/>
           </a:p>
@@ -7656,7 +7656,7 @@
                 <a:ea typeface="Courier New" pitchFamily="34" charset="-122"/>
                 <a:cs typeface="Courier New" pitchFamily="34" charset="-120"/>
               </a:rPr>
-              <a:t>✓ basic-arithmetic/spec alice valid 89635bce</a:t>
+              <a:t>✓ basic-arithmetic/spec alice valid 7f9bc81a</a:t>
             </a:r>
             <a:endParaRPr lang="en-US" sz="1000" dirty="0"/>
           </a:p>
@@ -7673,7 +7673,7 @@
                 <a:ea typeface="Courier New" pitchFamily="34" charset="-122"/>
                 <a:cs typeface="Courier New" pitchFamily="34" charset="-120"/>
               </a:rPr>
-              <a:t>✗ basic-arithmetic/plan bob wrong-signer 89635bce</a:t>
+              <a:t>✗ basic-arithmetic/plan bob wrong-signer 7f9bc81a</a:t>
             </a:r>
             <a:endParaRPr lang="en-US" sz="1000" dirty="0"/>
           </a:p>
@@ -7690,7 +7690,7 @@
                 <a:ea typeface="Courier New" pitchFamily="34" charset="-122"/>
                 <a:cs typeface="Courier New" pitchFamily="34" charset="-120"/>
               </a:rPr>
-              <a:t>✓ basic-arithmetic/review carol valid 53ad23b7</a:t>
+              <a:t>✓ basic-arithmetic/review carol valid 016d3b4b</a:t>
             </a:r>
             <a:endParaRPr lang="en-US" sz="1000" dirty="0"/>
           </a:p>
@@ -7707,7 +7707,7 @@
                 <a:ea typeface="Courier New" pitchFamily="34" charset="-122"/>
                 <a:cs typeface="Courier New" pitchFamily="34" charset="-120"/>
               </a:rPr>
-              <a:t>✓ basic-arithmetic/release alice valid b16eadd7</a:t>
+              <a:t>✓ basic-arithmetic/release alice valid 352090ab</a:t>
             </a:r>
             <a:endParaRPr lang="en-US" sz="1000" dirty="0"/>
           </a:p>
@@ -7724,7 +7724,7 @@
                 <a:ea typeface="Courier New" pitchFamily="34" charset="-122"/>
                 <a:cs typeface="Courier New" pitchFamily="34" charset="-120"/>
               </a:rPr>
-              <a:t>✓ openspec/roles.yaml alice@calc.example valid 0d43a659</a:t>
+              <a:t>✓ openspec/roles.yaml alice@calc.example valid bbd1c6b0</a:t>
             </a:r>
             <a:endParaRPr lang="en-US" sz="1000" dirty="0"/>
           </a:p>
@@ -8185,7 +8185,7 @@
                 <a:ea typeface="Courier New" pitchFamily="34" charset="-122"/>
                 <a:cs typeface="Courier New" pitchFamily="34" charset="-120"/>
               </a:rPr>
-              <a:t>  openspec\changes\archive\2026-10-06-basic</a:t>
+              <a:t>  openspec\changes\archive\2026-10-07-basic</a:t>
             </a:r>
             <a:endParaRPr lang="en-US" sz="1000" dirty="0"/>
           </a:p>
@@ -13829,7 +13829,7 @@
                 <a:ea typeface="Courier New" pitchFamily="34" charset="-122"/>
                 <a:cs typeface="Courier New" pitchFamily="34" charset="-120"/>
               </a:rPr>
-              <a:t>  archived) · sdlc 0.9.0, license:</a:t>
+              <a:t>  archived) · sdlc 0.9.1, license:</a:t>
             </a:r>
             <a:endParaRPr lang="en-US" sz="1000" dirty="0"/>
           </a:p>
@@ -14016,7 +14016,7 @@
                 <a:ea typeface="Courier New" pitchFamily="34" charset="-122"/>
                 <a:cs typeface="Courier New" pitchFamily="34" charset="-120"/>
               </a:rPr>
-              <a:t>  recorded with sdlc 0.9.0; licenses:</a:t>
+              <a:t>  recorded with sdlc 0.9.1; licenses:</a:t>
             </a:r>
             <a:endParaRPr lang="en-US" sz="1000" dirty="0"/>
           </a:p>
@@ -14333,7 +14333,7 @@
                 <a:ea typeface="Courier New" pitchFamily="34" charset="-122"/>
                 <a:cs typeface="Courier New" pitchFamily="34" charset="-120"/>
               </a:rPr>
-              <a:t>2026-10-06T22:15:55.514Z  gate.review.await</a:t>
+              <a:t>2026-10-07T10:13:21.903Z  gate.review.await</a:t>
             </a:r>
             <a:endParaRPr lang="en-US" sz="1000" dirty="0"/>
           </a:p>
@@ -14367,7 +14367,7 @@
                 <a:ea typeface="Courier New" pitchFamily="34" charset="-122"/>
                 <a:cs typeface="Courier New" pitchFamily="34" charset="-120"/>
               </a:rPr>
-              <a:t>  sha256:3b46e2724403b29ae43f5c85e743850ea5</a:t>
+              <a:t>  sha256:15207f0f3042ddb9dcece8aec4d12c856b</a:t>
             </a:r>
             <a:endParaRPr lang="en-US" sz="1000" dirty="0"/>
           </a:p>
@@ -14384,7 +14384,7 @@
                 <a:ea typeface="Courier New" pitchFamily="34" charset="-122"/>
                 <a:cs typeface="Courier New" pitchFamily="34" charset="-120"/>
               </a:rPr>
-              <a:t>  f67159dd578fa14d41ee61dd7752bf [sdlc</a:t>
+              <a:t>  747402af622946b7c55efdb406e49b [sdlc</a:t>
             </a:r>
             <a:endParaRPr lang="en-US" sz="1000" dirty="0"/>
           </a:p>
@@ -14401,7 +14401,7 @@
                 <a:ea typeface="Courier New" pitchFamily="34" charset="-122"/>
                 <a:cs typeface="Courier New" pitchFamily="34" charset="-120"/>
               </a:rPr>
-              <a:t>  0.9.0 · community]</a:t>
+              <a:t>  0.9.1 · community]</a:t>
             </a:r>
             <a:endParaRPr lang="en-US" sz="1000" dirty="0"/>
           </a:p>
@@ -14418,7 +14418,7 @@
                 <a:ea typeface="Courier New" pitchFamily="34" charset="-122"/>
                 <a:cs typeface="Courier New" pitchFamily="34" charset="-120"/>
               </a:rPr>
-              <a:t>2026-10-06T22:15:58.571Z  gate.review.appro</a:t>
+              <a:t>2026-10-07T10:13:24.897Z  gate.review.appro</a:t>
             </a:r>
             <a:endParaRPr lang="en-US" sz="1000" dirty="0"/>
           </a:p>
@@ -14469,7 +14469,7 @@
                 <a:ea typeface="Courier New" pitchFamily="34" charset="-122"/>
                 <a:cs typeface="Courier New" pitchFamily="34" charset="-120"/>
               </a:rPr>
-              <a:t>  [sdlc 0.9.0 · community]</a:t>
+              <a:t>  [sdlc 0.9.1 · community]</a:t>
             </a:r>
             <a:endParaRPr lang="en-US" sz="1000" dirty="0"/>
           </a:p>
@@ -14486,7 +14486,7 @@
                 <a:ea typeface="Courier New" pitchFamily="34" charset="-122"/>
                 <a:cs typeface="Courier New" pitchFamily="34" charset="-120"/>
               </a:rPr>
-              <a:t>2026-10-06T22:16:02.163Z  gate.release.appr</a:t>
+              <a:t>2026-10-07T10:13:28.430Z  gate.release.appr</a:t>
             </a:r>
             <a:endParaRPr lang="en-US" sz="1000" dirty="0"/>
           </a:p>
@@ -14537,7 +14537,7 @@
                 <a:ea typeface="Courier New" pitchFamily="34" charset="-122"/>
                 <a:cs typeface="Courier New" pitchFamily="34" charset="-120"/>
               </a:rPr>
-              <a:t>  release-manager [sdlc 0.9.0 · community]</a:t>
+              <a:t>  release-manager [sdlc 0.9.1 · community]</a:t>
             </a:r>
             <a:endParaRPr lang="en-US" sz="1000" dirty="0"/>
           </a:p>
@@ -15714,7 +15714,7 @@
                 <a:ea typeface="Courier New" pitchFamily="34" charset="-122"/>
                 <a:cs typeface="Courier New" pitchFamily="34" charset="-120"/>
               </a:rPr>
-              <a:t>✓ test (1.2s)</a:t>
+              <a:t>✓ test (1.0s)</a:t>
             </a:r>
             <a:endParaRPr lang="en-US" sz="1000" dirty="0"/>
           </a:p>
@@ -15731,7 +15731,7 @@
                 <a:ea typeface="Courier New" pitchFamily="34" charset="-122"/>
                 <a:cs typeface="Courier New" pitchFamily="34" charset="-120"/>
               </a:rPr>
-              <a:t>✓ ci-green (ci/pipeline_status, 0.7s)</a:t>
+              <a:t>✓ ci-green (ci/pipeline_status, 0.5s)</a:t>
             </a:r>
             <a:endParaRPr lang="en-US" sz="1000" dirty="0"/>
           </a:p>
@@ -16167,7 +16167,7 @@
                 <a:ea typeface="Courier New" pitchFamily="34" charset="-122"/>
                 <a:cs typeface="Courier New" pitchFamily="34" charset="-120"/>
               </a:rPr>
-              <a:t>      "id": "20261006T221649892Z-ci-green-0</a:t>
+              <a:t>      "id": "20261007T101406690Z-ci-green-b</a:t>
             </a:r>
             <a:endParaRPr lang="en-US" sz="1000" dirty="0"/>
           </a:p>
@@ -16184,7 +16184,7 @@
                 <a:ea typeface="Courier New" pitchFamily="34" charset="-122"/>
                 <a:cs typeface="Courier New" pitchFamily="34" charset="-120"/>
               </a:rPr>
-              <a:t>  eb8d5",</a:t>
+              <a:t>  80419",</a:t>
             </a:r>
             <a:endParaRPr lang="en-US" sz="1000" dirty="0"/>
           </a:p>
@@ -16320,7 +16320,7 @@
                 <a:ea typeface="Courier New" pitchFamily="34" charset="-122"/>
                 <a:cs typeface="Courier New" pitchFamily="34" charset="-120"/>
               </a:rPr>
-              <a:t>        "ref": "e105b7c63cb4b08e39dc9fa4c2d</a:t>
+              <a:t>        "ref": "2742131fbd21da8c5c880624e29</a:t>
             </a:r>
             <a:endParaRPr lang="en-US" sz="1000" dirty="0"/>
           </a:p>
@@ -16337,7 +16337,7 @@
                 <a:ea typeface="Courier New" pitchFamily="34" charset="-122"/>
                 <a:cs typeface="Courier New" pitchFamily="34" charset="-120"/>
               </a:rPr>
-              <a:t>  bdf6db8c0c381",</a:t>
+              <a:t>  ea2638c4bbb62",</a:t>
             </a:r>
             <a:endParaRPr lang="en-US" sz="1000" dirty="0"/>
           </a:p>
@@ -18581,7 +18581,7 @@
                 <a:ea typeface="Cambria" pitchFamily="34" charset="-122"/>
                 <a:cs typeface="Cambria" pitchFamily="34" charset="-120"/>
               </a:rPr>
-              <a:t>90</a:t>
+              <a:t>91</a:t>
             </a:r>
             <a:endParaRPr lang="en-US" sz="6000" dirty="0"/>
           </a:p>
@@ -18686,7 +18686,7 @@
                 <a:ea typeface="Cambria" pitchFamily="34" charset="-122"/>
                 <a:cs typeface="Cambria" pitchFamily="34" charset="-120"/>
               </a:rPr>
-              <a:t>59</a:t>
+              <a:t>60</a:t>
             </a:r>
             <a:endParaRPr lang="en-US" sz="6000" dirty="0"/>
           </a:p>
@@ -18725,7 +18725,7 @@
                 <a:ea typeface="Calibri" pitchFamily="34" charset="-122"/>
                 <a:cs typeface="Calibri" pitchFamily="34" charset="-120"/>
               </a:rPr>
-              <a:t>of 59 commands</a:t>
+              <a:t>of 60 commands</a:t>
             </a:r>
             <a:endParaRPr lang="en-US" sz="1600" dirty="0"/>
           </a:p>
@@ -20864,7 +20864,7 @@
         <p:spPr>
           <a:xfrm>
             <a:off x="7812024" y="4443984"/>
-            <a:ext cx="879856" cy="256032"/>
+            <a:ext cx="549656" cy="256032"/>
           </a:xfrm>
           <a:prstGeom prst="roundRect">
             <a:avLst>
@@ -20891,7 +20891,7 @@
         <p:spPr>
           <a:xfrm>
             <a:off x="7812024" y="4443984"/>
-            <a:ext cx="879856" cy="256032"/>
+            <a:ext cx="549656" cy="256032"/>
           </a:xfrm>
           <a:prstGeom prst="rect">
             <a:avLst/>
@@ -20915,7 +20915,7 @@
                 <a:ea typeface="Calibri" pitchFamily="34" charset="-122"/>
                 <a:cs typeface="Calibri" pitchFamily="34" charset="-120"/>
               </a:rPr>
-              <a:t>statusline</a:t>
+              <a:t>guide</a:t>
             </a:r>
             <a:endParaRPr lang="en-US" sz="1000" dirty="0"/>
           </a:p>
@@ -20929,8 +20929,8 @@
         </p:nvSpPr>
         <p:spPr>
           <a:xfrm>
-            <a:off x="8783320" y="4443984"/>
-            <a:ext cx="813816" cy="256032"/>
+            <a:off x="8453120" y="4443984"/>
+            <a:ext cx="879856" cy="256032"/>
           </a:xfrm>
           <a:prstGeom prst="roundRect">
             <a:avLst>
@@ -20956,8 +20956,8 @@
         </p:nvSpPr>
         <p:spPr>
           <a:xfrm>
-            <a:off x="8783320" y="4443984"/>
-            <a:ext cx="813816" cy="256032"/>
+            <a:off x="8453120" y="4443984"/>
+            <a:ext cx="879856" cy="256032"/>
           </a:xfrm>
           <a:prstGeom prst="rect">
             <a:avLst/>
@@ -20981,7 +20981,7 @@
                 <a:ea typeface="Calibri" pitchFamily="34" charset="-122"/>
                 <a:cs typeface="Calibri" pitchFamily="34" charset="-120"/>
               </a:rPr>
-              <a:t>mcp serve</a:t>
+              <a:t>statusline</a:t>
             </a:r>
             <a:endParaRPr lang="en-US" sz="1000" dirty="0"/>
           </a:p>
@@ -20995,7 +20995,7 @@
         </p:nvSpPr>
         <p:spPr>
           <a:xfrm>
-            <a:off x="9688576" y="4443984"/>
+            <a:off x="9424416" y="4443984"/>
             <a:ext cx="813816" cy="256032"/>
           </a:xfrm>
           <a:prstGeom prst="roundRect">
@@ -21022,7 +21022,7 @@
         </p:nvSpPr>
         <p:spPr>
           <a:xfrm>
-            <a:off x="9688576" y="4443984"/>
+            <a:off x="9424416" y="4443984"/>
             <a:ext cx="813816" cy="256032"/>
           </a:xfrm>
           <a:prstGeom prst="rect">
@@ -21047,7 +21047,7 @@
                 <a:ea typeface="Calibri" pitchFamily="34" charset="-122"/>
                 <a:cs typeface="Calibri" pitchFamily="34" charset="-120"/>
               </a:rPr>
-              <a:t>mcp check</a:t>
+              <a:t>mcp serve</a:t>
             </a:r>
             <a:endParaRPr lang="en-US" sz="1000" dirty="0"/>
           </a:p>
@@ -21061,8 +21061,8 @@
         </p:nvSpPr>
         <p:spPr>
           <a:xfrm>
-            <a:off x="10593832" y="4443984"/>
-            <a:ext cx="879856" cy="256032"/>
+            <a:off x="10329672" y="4443984"/>
+            <a:ext cx="813816" cy="256032"/>
           </a:xfrm>
           <a:prstGeom prst="roundRect">
             <a:avLst>
@@ -21088,8 +21088,8 @@
         </p:nvSpPr>
         <p:spPr>
           <a:xfrm>
-            <a:off x="10593832" y="4443984"/>
-            <a:ext cx="879856" cy="256032"/>
+            <a:off x="10329672" y="4443984"/>
+            <a:ext cx="813816" cy="256032"/>
           </a:xfrm>
           <a:prstGeom prst="rect">
             <a:avLst/>
@@ -21113,7 +21113,7 @@
                 <a:ea typeface="Calibri" pitchFamily="34" charset="-122"/>
                 <a:cs typeface="Calibri" pitchFamily="34" charset="-120"/>
               </a:rPr>
-              <a:t>inbox list</a:t>
+              <a:t>mcp check</a:t>
             </a:r>
             <a:endParaRPr lang="en-US" sz="1000" dirty="0"/>
           </a:p>
@@ -21179,7 +21179,7 @@
                 <a:ea typeface="Calibri" pitchFamily="34" charset="-122"/>
                 <a:cs typeface="Calibri" pitchFamily="34" charset="-120"/>
               </a:rPr>
-              <a:t>inbox done</a:t>
+              <a:t>inbox list</a:t>
             </a:r>
             <a:endParaRPr lang="en-US" sz="1000" dirty="0"/>
           </a:p>
@@ -21194,7 +21194,7 @@
         <p:spPr>
           <a:xfrm>
             <a:off x="1428496" y="4791456"/>
-            <a:ext cx="813816" cy="256032"/>
+            <a:ext cx="879856" cy="256032"/>
           </a:xfrm>
           <a:prstGeom prst="roundRect">
             <a:avLst>
@@ -21221,7 +21221,7 @@
         <p:spPr>
           <a:xfrm>
             <a:off x="1428496" y="4791456"/>
-            <a:ext cx="813816" cy="256032"/>
+            <a:ext cx="879856" cy="256032"/>
           </a:xfrm>
           <a:prstGeom prst="rect">
             <a:avLst/>
@@ -21245,7 +21245,7 @@
                 <a:ea typeface="Calibri" pitchFamily="34" charset="-122"/>
                 <a:cs typeface="Calibri" pitchFamily="34" charset="-120"/>
               </a:rPr>
-              <a:t>track set</a:t>
+              <a:t>inbox done</a:t>
             </a:r>
             <a:endParaRPr lang="en-US" sz="1000" dirty="0"/>
           </a:p>
@@ -21259,8 +21259,8 @@
         </p:nvSpPr>
         <p:spPr>
           <a:xfrm>
-            <a:off x="2333752" y="4791456"/>
-            <a:ext cx="483616" cy="256032"/>
+            <a:off x="2399792" y="4791456"/>
+            <a:ext cx="813816" cy="256032"/>
           </a:xfrm>
           <a:prstGeom prst="roundRect">
             <a:avLst>
@@ -21286,8 +21286,8 @@
         </p:nvSpPr>
         <p:spPr>
           <a:xfrm>
-            <a:off x="2333752" y="4791456"/>
-            <a:ext cx="483616" cy="256032"/>
+            <a:off x="2399792" y="4791456"/>
+            <a:ext cx="813816" cy="256032"/>
           </a:xfrm>
           <a:prstGeom prst="rect">
             <a:avLst/>
@@ -21311,7 +21311,7 @@
                 <a:ea typeface="Calibri" pitchFamily="34" charset="-122"/>
                 <a:cs typeface="Calibri" pitchFamily="34" charset="-120"/>
               </a:rPr>
-              <a:t>next</a:t>
+              <a:t>track set</a:t>
             </a:r>
             <a:endParaRPr lang="en-US" sz="1000" dirty="0"/>
           </a:p>
@@ -21325,8 +21325,8 @@
         </p:nvSpPr>
         <p:spPr>
           <a:xfrm>
-            <a:off x="2908808" y="4791456"/>
-            <a:ext cx="1011936" cy="256032"/>
+            <a:off x="3305048" y="4791456"/>
+            <a:ext cx="483616" cy="256032"/>
           </a:xfrm>
           <a:prstGeom prst="roundRect">
             <a:avLst>
@@ -21352,8 +21352,8 @@
         </p:nvSpPr>
         <p:spPr>
           <a:xfrm>
-            <a:off x="2908808" y="4791456"/>
-            <a:ext cx="1011936" cy="256032"/>
+            <a:off x="3305048" y="4791456"/>
+            <a:ext cx="483616" cy="256032"/>
           </a:xfrm>
           <a:prstGeom prst="rect">
             <a:avLst/>
@@ -21377,7 +21377,7 @@
                 <a:ea typeface="Calibri" pitchFamily="34" charset="-122"/>
                 <a:cs typeface="Calibri" pitchFamily="34" charset="-120"/>
               </a:rPr>
-              <a:t>instructions</a:t>
+              <a:t>next</a:t>
             </a:r>
             <a:endParaRPr lang="en-US" sz="1000" dirty="0"/>
           </a:p>
@@ -21391,8 +21391,8 @@
         </p:nvSpPr>
         <p:spPr>
           <a:xfrm>
-            <a:off x="4012184" y="4791456"/>
-            <a:ext cx="681736" cy="256032"/>
+            <a:off x="3880104" y="4791456"/>
+            <a:ext cx="1011936" cy="256032"/>
           </a:xfrm>
           <a:prstGeom prst="roundRect">
             <a:avLst>
@@ -21418,8 +21418,8 @@
         </p:nvSpPr>
         <p:spPr>
           <a:xfrm>
-            <a:off x="4012184" y="4791456"/>
-            <a:ext cx="681736" cy="256032"/>
+            <a:off x="3880104" y="4791456"/>
+            <a:ext cx="1011936" cy="256032"/>
           </a:xfrm>
           <a:prstGeom prst="rect">
             <a:avLst/>
@@ -21443,7 +21443,7 @@
                 <a:ea typeface="Calibri" pitchFamily="34" charset="-122"/>
                 <a:cs typeface="Calibri" pitchFamily="34" charset="-120"/>
               </a:rPr>
-              <a:t>approve</a:t>
+              <a:t>instructions</a:t>
             </a:r>
             <a:endParaRPr lang="en-US" sz="1000" dirty="0"/>
           </a:p>
@@ -21457,8 +21457,8 @@
         </p:nvSpPr>
         <p:spPr>
           <a:xfrm>
-            <a:off x="4785360" y="4791456"/>
-            <a:ext cx="615696" cy="256032"/>
+            <a:off x="4983480" y="4791456"/>
+            <a:ext cx="681736" cy="256032"/>
           </a:xfrm>
           <a:prstGeom prst="roundRect">
             <a:avLst>
@@ -21484,8 +21484,8 @@
         </p:nvSpPr>
         <p:spPr>
           <a:xfrm>
-            <a:off x="4785360" y="4791456"/>
-            <a:ext cx="615696" cy="256032"/>
+            <a:off x="4983480" y="4791456"/>
+            <a:ext cx="681736" cy="256032"/>
           </a:xfrm>
           <a:prstGeom prst="rect">
             <a:avLst/>
@@ -21509,7 +21509,7 @@
                 <a:ea typeface="Calibri" pitchFamily="34" charset="-122"/>
                 <a:cs typeface="Calibri" pitchFamily="34" charset="-120"/>
               </a:rPr>
-              <a:t>reject</a:t>
+              <a:t>approve</a:t>
             </a:r>
             <a:endParaRPr lang="en-US" sz="1000" dirty="0"/>
           </a:p>
@@ -21523,8 +21523,8 @@
         </p:nvSpPr>
         <p:spPr>
           <a:xfrm>
-            <a:off x="5492496" y="4791456"/>
-            <a:ext cx="549656" cy="256032"/>
+            <a:off x="5756656" y="4791456"/>
+            <a:ext cx="615696" cy="256032"/>
           </a:xfrm>
           <a:prstGeom prst="roundRect">
             <a:avLst>
@@ -21550,8 +21550,8 @@
         </p:nvSpPr>
         <p:spPr>
           <a:xfrm>
-            <a:off x="5492496" y="4791456"/>
-            <a:ext cx="549656" cy="256032"/>
+            <a:off x="5756656" y="4791456"/>
+            <a:ext cx="615696" cy="256032"/>
           </a:xfrm>
           <a:prstGeom prst="rect">
             <a:avLst/>
@@ -21575,7 +21575,7 @@
                 <a:ea typeface="Calibri" pitchFamily="34" charset="-122"/>
                 <a:cs typeface="Calibri" pitchFamily="34" charset="-120"/>
               </a:rPr>
-              <a:t>waive</a:t>
+              <a:t>reject</a:t>
             </a:r>
             <a:endParaRPr lang="en-US" sz="1000" dirty="0"/>
           </a:p>
@@ -21589,8 +21589,8 @@
         </p:nvSpPr>
         <p:spPr>
           <a:xfrm>
-            <a:off x="6133592" y="4791456"/>
-            <a:ext cx="747776" cy="256032"/>
+            <a:off x="6463792" y="4791456"/>
+            <a:ext cx="549656" cy="256032"/>
           </a:xfrm>
           <a:prstGeom prst="roundRect">
             <a:avLst>
@@ -21616,8 +21616,8 @@
         </p:nvSpPr>
         <p:spPr>
           <a:xfrm>
-            <a:off x="6133592" y="4791456"/>
-            <a:ext cx="747776" cy="256032"/>
+            <a:off x="6463792" y="4791456"/>
+            <a:ext cx="549656" cy="256032"/>
           </a:xfrm>
           <a:prstGeom prst="rect">
             <a:avLst/>
@@ -21641,7 +21641,7 @@
                 <a:ea typeface="Calibri" pitchFamily="34" charset="-122"/>
                 <a:cs typeface="Calibri" pitchFamily="34" charset="-120"/>
               </a:rPr>
-              <a:t>takeover</a:t>
+              <a:t>waive</a:t>
             </a:r>
             <a:endParaRPr lang="en-US" sz="1000" dirty="0"/>
           </a:p>
@@ -21655,8 +21655,8 @@
         </p:nvSpPr>
         <p:spPr>
           <a:xfrm>
-            <a:off x="6972808" y="4791456"/>
-            <a:ext cx="1210056" cy="256032"/>
+            <a:off x="7104888" y="4791456"/>
+            <a:ext cx="747776" cy="256032"/>
           </a:xfrm>
           <a:prstGeom prst="roundRect">
             <a:avLst>
@@ -21682,8 +21682,8 @@
         </p:nvSpPr>
         <p:spPr>
           <a:xfrm>
-            <a:off x="6972808" y="4791456"/>
-            <a:ext cx="1210056" cy="256032"/>
+            <a:off x="7104888" y="4791456"/>
+            <a:ext cx="747776" cy="256032"/>
           </a:xfrm>
           <a:prstGeom prst="rect">
             <a:avLst/>
@@ -21707,7 +21707,7 @@
                 <a:ea typeface="Calibri" pitchFamily="34" charset="-122"/>
                 <a:cs typeface="Calibri" pitchFamily="34" charset="-120"/>
               </a:rPr>
-              <a:t>release-control</a:t>
+              <a:t>takeover</a:t>
             </a:r>
             <a:endParaRPr lang="en-US" sz="1000" dirty="0"/>
           </a:p>
@@ -21721,8 +21721,8 @@
         </p:nvSpPr>
         <p:spPr>
           <a:xfrm>
-            <a:off x="8274304" y="4791456"/>
-            <a:ext cx="615696" cy="256032"/>
+            <a:off x="7944104" y="4791456"/>
+            <a:ext cx="1210056" cy="256032"/>
           </a:xfrm>
           <a:prstGeom prst="roundRect">
             <a:avLst>
@@ -21748,8 +21748,8 @@
         </p:nvSpPr>
         <p:spPr>
           <a:xfrm>
-            <a:off x="8274304" y="4791456"/>
-            <a:ext cx="615696" cy="256032"/>
+            <a:off x="7944104" y="4791456"/>
+            <a:ext cx="1210056" cy="256032"/>
           </a:xfrm>
           <a:prstGeom prst="rect">
             <a:avLst/>
@@ -21773,7 +21773,7 @@
                 <a:ea typeface="Calibri" pitchFamily="34" charset="-122"/>
                 <a:cs typeface="Calibri" pitchFamily="34" charset="-120"/>
               </a:rPr>
-              <a:t>rework</a:t>
+              <a:t>release-control</a:t>
             </a:r>
             <a:endParaRPr lang="en-US" sz="1000" dirty="0"/>
           </a:p>
@@ -21787,8 +21787,8 @@
         </p:nvSpPr>
         <p:spPr>
           <a:xfrm>
-            <a:off x="8981440" y="4791456"/>
-            <a:ext cx="1276096" cy="256032"/>
+            <a:off x="9245600" y="4791456"/>
+            <a:ext cx="615696" cy="256032"/>
           </a:xfrm>
           <a:prstGeom prst="roundRect">
             <a:avLst>
@@ -21814,8 +21814,8 @@
         </p:nvSpPr>
         <p:spPr>
           <a:xfrm>
-            <a:off x="8981440" y="4791456"/>
-            <a:ext cx="1276096" cy="256032"/>
+            <a:off x="9245600" y="4791456"/>
+            <a:ext cx="615696" cy="256032"/>
           </a:xfrm>
           <a:prstGeom prst="rect">
             <a:avLst/>
@@ -21839,7 +21839,7 @@
                 <a:ea typeface="Calibri" pitchFamily="34" charset="-122"/>
                 <a:cs typeface="Calibri" pitchFamily="34" charset="-120"/>
               </a:rPr>
-              <a:t>approvals verify</a:t>
+              <a:t>rework</a:t>
             </a:r>
             <a:endParaRPr lang="en-US" sz="1000" dirty="0"/>
           </a:p>
@@ -21853,8 +21853,8 @@
         </p:nvSpPr>
         <p:spPr>
           <a:xfrm>
-            <a:off x="10348976" y="4791456"/>
-            <a:ext cx="549656" cy="256032"/>
+            <a:off x="9952736" y="4791456"/>
+            <a:ext cx="1276096" cy="256032"/>
           </a:xfrm>
           <a:prstGeom prst="roundRect">
             <a:avLst>
@@ -21880,8 +21880,8 @@
         </p:nvSpPr>
         <p:spPr>
           <a:xfrm>
-            <a:off x="10348976" y="4791456"/>
-            <a:ext cx="549656" cy="256032"/>
+            <a:off x="9952736" y="4791456"/>
+            <a:ext cx="1276096" cy="256032"/>
           </a:xfrm>
           <a:prstGeom prst="rect">
             <a:avLst/>
@@ -21905,7 +21905,7 @@
                 <a:ea typeface="Calibri" pitchFamily="34" charset="-122"/>
                 <a:cs typeface="Calibri" pitchFamily="34" charset="-120"/>
               </a:rPr>
-              <a:t>tests</a:t>
+              <a:t>approvals verify</a:t>
             </a:r>
             <a:endParaRPr lang="en-US" sz="1000" dirty="0"/>
           </a:p>
@@ -21919,8 +21919,8 @@
         </p:nvSpPr>
         <p:spPr>
           <a:xfrm>
-            <a:off x="10990072" y="4791456"/>
-            <a:ext cx="615696" cy="256032"/>
+            <a:off x="457200" y="5138928"/>
+            <a:ext cx="549656" cy="256032"/>
           </a:xfrm>
           <a:prstGeom prst="roundRect">
             <a:avLst>
@@ -21946,8 +21946,8 @@
         </p:nvSpPr>
         <p:spPr>
           <a:xfrm>
-            <a:off x="10990072" y="4791456"/>
-            <a:ext cx="615696" cy="256032"/>
+            <a:off x="457200" y="5138928"/>
+            <a:ext cx="549656" cy="256032"/>
           </a:xfrm>
           <a:prstGeom prst="rect">
             <a:avLst/>
@@ -21971,7 +21971,7 @@
                 <a:ea typeface="Calibri" pitchFamily="34" charset="-122"/>
                 <a:cs typeface="Calibri" pitchFamily="34" charset="-120"/>
               </a:rPr>
-              <a:t>verify</a:t>
+              <a:t>tests</a:t>
             </a:r>
             <a:endParaRPr lang="en-US" sz="1000" dirty="0"/>
           </a:p>
@@ -21985,7 +21985,7 @@
         </p:nvSpPr>
         <p:spPr>
           <a:xfrm>
-            <a:off x="457200" y="5138928"/>
+            <a:off x="1098296" y="5138928"/>
             <a:ext cx="615696" cy="256032"/>
           </a:xfrm>
           <a:prstGeom prst="roundRect">
@@ -22012,7 +22012,7 @@
         </p:nvSpPr>
         <p:spPr>
           <a:xfrm>
-            <a:off x="457200" y="5138928"/>
+            <a:off x="1098296" y="5138928"/>
             <a:ext cx="615696" cy="256032"/>
           </a:xfrm>
           <a:prstGeom prst="rect">
@@ -22037,7 +22037,7 @@
                 <a:ea typeface="Calibri" pitchFamily="34" charset="-122"/>
                 <a:cs typeface="Calibri" pitchFamily="34" charset="-120"/>
               </a:rPr>
-              <a:t>review</a:t>
+              <a:t>verify</a:t>
             </a:r>
             <a:endParaRPr lang="en-US" sz="1000" dirty="0"/>
           </a:p>
@@ -22051,8 +22051,8 @@
         </p:nvSpPr>
         <p:spPr>
           <a:xfrm>
-            <a:off x="1164336" y="5138928"/>
-            <a:ext cx="747776" cy="256032"/>
+            <a:off x="1805432" y="5138928"/>
+            <a:ext cx="615696" cy="256032"/>
           </a:xfrm>
           <a:prstGeom prst="roundRect">
             <a:avLst>
@@ -22078,8 +22078,8 @@
         </p:nvSpPr>
         <p:spPr>
           <a:xfrm>
-            <a:off x="1164336" y="5138928"/>
-            <a:ext cx="747776" cy="256032"/>
+            <a:off x="1805432" y="5138928"/>
+            <a:ext cx="615696" cy="256032"/>
           </a:xfrm>
           <a:prstGeom prst="rect">
             <a:avLst/>
@@ -22103,7 +22103,7 @@
                 <a:ea typeface="Calibri" pitchFamily="34" charset="-122"/>
                 <a:cs typeface="Calibri" pitchFamily="34" charset="-120"/>
               </a:rPr>
-              <a:t>validate</a:t>
+              <a:t>review</a:t>
             </a:r>
             <a:endParaRPr lang="en-US" sz="1000" dirty="0"/>
           </a:p>
@@ -22117,8 +22117,8 @@
         </p:nvSpPr>
         <p:spPr>
           <a:xfrm>
-            <a:off x="2003552" y="5138928"/>
-            <a:ext cx="681736" cy="256032"/>
+            <a:off x="2512568" y="5138928"/>
+            <a:ext cx="747776" cy="256032"/>
           </a:xfrm>
           <a:prstGeom prst="roundRect">
             <a:avLst>
@@ -22144,8 +22144,8 @@
         </p:nvSpPr>
         <p:spPr>
           <a:xfrm>
-            <a:off x="2003552" y="5138928"/>
-            <a:ext cx="681736" cy="256032"/>
+            <a:off x="2512568" y="5138928"/>
+            <a:ext cx="747776" cy="256032"/>
           </a:xfrm>
           <a:prstGeom prst="rect">
             <a:avLst/>
@@ -22169,7 +22169,7 @@
                 <a:ea typeface="Calibri" pitchFamily="34" charset="-122"/>
                 <a:cs typeface="Calibri" pitchFamily="34" charset="-120"/>
               </a:rPr>
-              <a:t>archive</a:t>
+              <a:t>validate</a:t>
             </a:r>
             <a:endParaRPr lang="en-US" sz="1000" dirty="0"/>
           </a:p>
@@ -22183,8 +22183,8 @@
         </p:nvSpPr>
         <p:spPr>
           <a:xfrm>
-            <a:off x="2776728" y="5138928"/>
-            <a:ext cx="549656" cy="256032"/>
+            <a:off x="3351784" y="5138928"/>
+            <a:ext cx="681736" cy="256032"/>
           </a:xfrm>
           <a:prstGeom prst="roundRect">
             <a:avLst>
@@ -22210,8 +22210,8 @@
         </p:nvSpPr>
         <p:spPr>
           <a:xfrm>
-            <a:off x="2776728" y="5138928"/>
-            <a:ext cx="549656" cy="256032"/>
+            <a:off x="3351784" y="5138928"/>
+            <a:ext cx="681736" cy="256032"/>
           </a:xfrm>
           <a:prstGeom prst="rect">
             <a:avLst/>
@@ -22235,7 +22235,7 @@
                 <a:ea typeface="Calibri" pitchFamily="34" charset="-122"/>
                 <a:cs typeface="Calibri" pitchFamily="34" charset="-120"/>
               </a:rPr>
-              <a:t>audit</a:t>
+              <a:t>archive</a:t>
             </a:r>
             <a:endParaRPr lang="en-US" sz="1000" dirty="0"/>
           </a:p>
@@ -22249,8 +22249,8 @@
         </p:nvSpPr>
         <p:spPr>
           <a:xfrm>
-            <a:off x="3417824" y="5138928"/>
-            <a:ext cx="615696" cy="256032"/>
+            <a:off x="4124960" y="5138928"/>
+            <a:ext cx="549656" cy="256032"/>
           </a:xfrm>
           <a:prstGeom prst="roundRect">
             <a:avLst>
@@ -22276,8 +22276,8 @@
         </p:nvSpPr>
         <p:spPr>
           <a:xfrm>
-            <a:off x="3417824" y="5138928"/>
-            <a:ext cx="615696" cy="256032"/>
+            <a:off x="4124960" y="5138928"/>
+            <a:ext cx="549656" cy="256032"/>
           </a:xfrm>
           <a:prstGeom prst="rect">
             <a:avLst/>
@@ -22301,7 +22301,7 @@
                 <a:ea typeface="Calibri" pitchFamily="34" charset="-122"/>
                 <a:cs typeface="Calibri" pitchFamily="34" charset="-120"/>
               </a:rPr>
-              <a:t>report</a:t>
+              <a:t>audit</a:t>
             </a:r>
             <a:endParaRPr lang="en-US" sz="1000" dirty="0"/>
           </a:p>
@@ -22315,8 +22315,8 @@
         </p:nvSpPr>
         <p:spPr>
           <a:xfrm>
-            <a:off x="4124960" y="5138928"/>
-            <a:ext cx="813816" cy="256032"/>
+            <a:off x="4766056" y="5138928"/>
+            <a:ext cx="615696" cy="256032"/>
           </a:xfrm>
           <a:prstGeom prst="roundRect">
             <a:avLst>
@@ -22342,8 +22342,8 @@
         </p:nvSpPr>
         <p:spPr>
           <a:xfrm>
-            <a:off x="4124960" y="5138928"/>
-            <a:ext cx="813816" cy="256032"/>
+            <a:off x="4766056" y="5138928"/>
+            <a:ext cx="615696" cy="256032"/>
           </a:xfrm>
           <a:prstGeom prst="rect">
             <a:avLst/>
@@ -22367,7 +22367,7 @@
                 <a:ea typeface="Calibri" pitchFamily="34" charset="-122"/>
                 <a:cs typeface="Calibri" pitchFamily="34" charset="-120"/>
               </a:rPr>
-              <a:t>dashboard</a:t>
+              <a:t>report</a:t>
             </a:r>
             <a:endParaRPr lang="en-US" sz="1000" dirty="0"/>
           </a:p>
@@ -22381,8 +22381,8 @@
         </p:nvSpPr>
         <p:spPr>
           <a:xfrm>
-            <a:off x="5030216" y="5138928"/>
-            <a:ext cx="417576" cy="256032"/>
+            <a:off x="5473192" y="5138928"/>
+            <a:ext cx="813816" cy="256032"/>
           </a:xfrm>
           <a:prstGeom prst="roundRect">
             <a:avLst>
@@ -22408,8 +22408,8 @@
         </p:nvSpPr>
         <p:spPr>
           <a:xfrm>
-            <a:off x="5030216" y="5138928"/>
-            <a:ext cx="417576" cy="256032"/>
+            <a:off x="5473192" y="5138928"/>
+            <a:ext cx="813816" cy="256032"/>
           </a:xfrm>
           <a:prstGeom prst="rect">
             <a:avLst/>
@@ -22433,7 +22433,7 @@
                 <a:ea typeface="Calibri" pitchFamily="34" charset="-122"/>
                 <a:cs typeface="Calibri" pitchFamily="34" charset="-120"/>
               </a:rPr>
-              <a:t>log</a:t>
+              <a:t>dashboard</a:t>
             </a:r>
             <a:endParaRPr lang="en-US" sz="1000" dirty="0"/>
           </a:p>
@@ -22447,8 +22447,8 @@
         </p:nvSpPr>
         <p:spPr>
           <a:xfrm>
-            <a:off x="5539232" y="5138928"/>
-            <a:ext cx="681736" cy="256032"/>
+            <a:off x="6378448" y="5138928"/>
+            <a:ext cx="417576" cy="256032"/>
           </a:xfrm>
           <a:prstGeom prst="roundRect">
             <a:avLst>
@@ -22474,8 +22474,8 @@
         </p:nvSpPr>
         <p:spPr>
           <a:xfrm>
-            <a:off x="5539232" y="5138928"/>
-            <a:ext cx="681736" cy="256032"/>
+            <a:off x="6378448" y="5138928"/>
+            <a:ext cx="417576" cy="256032"/>
           </a:xfrm>
           <a:prstGeom prst="rect">
             <a:avLst/>
@@ -22499,7 +22499,7 @@
                 <a:ea typeface="Calibri" pitchFamily="34" charset="-122"/>
                 <a:cs typeface="Calibri" pitchFamily="34" charset="-120"/>
               </a:rPr>
-              <a:t>license</a:t>
+              <a:t>log</a:t>
             </a:r>
             <a:endParaRPr lang="en-US" sz="1000" dirty="0"/>
           </a:p>
@@ -22513,8 +22513,8 @@
         </p:nvSpPr>
         <p:spPr>
           <a:xfrm>
-            <a:off x="6312408" y="5138928"/>
-            <a:ext cx="615696" cy="256032"/>
+            <a:off x="6887464" y="5138928"/>
+            <a:ext cx="681736" cy="256032"/>
           </a:xfrm>
           <a:prstGeom prst="roundRect">
             <a:avLst>
@@ -22540,8 +22540,8 @@
         </p:nvSpPr>
         <p:spPr>
           <a:xfrm>
-            <a:off x="6312408" y="5138928"/>
-            <a:ext cx="615696" cy="256032"/>
+            <a:off x="6887464" y="5138928"/>
+            <a:ext cx="681736" cy="256032"/>
           </a:xfrm>
           <a:prstGeom prst="rect">
             <a:avLst/>
@@ -22565,7 +22565,7 @@
                 <a:ea typeface="Calibri" pitchFamily="34" charset="-122"/>
                 <a:cs typeface="Calibri" pitchFamily="34" charset="-120"/>
               </a:rPr>
-              <a:t>doctor</a:t>
+              <a:t>license</a:t>
             </a:r>
             <a:endParaRPr lang="en-US" sz="1000" dirty="0"/>
           </a:p>
@@ -22579,8 +22579,8 @@
         </p:nvSpPr>
         <p:spPr>
           <a:xfrm>
-            <a:off x="7019544" y="5138928"/>
-            <a:ext cx="1011936" cy="256032"/>
+            <a:off x="7660640" y="5138928"/>
+            <a:ext cx="615696" cy="256032"/>
           </a:xfrm>
           <a:prstGeom prst="roundRect">
             <a:avLst>
@@ -22606,8 +22606,8 @@
         </p:nvSpPr>
         <p:spPr>
           <a:xfrm>
-            <a:off x="7019544" y="5138928"/>
-            <a:ext cx="1011936" cy="256032"/>
+            <a:off x="7660640" y="5138928"/>
+            <a:ext cx="615696" cy="256032"/>
           </a:xfrm>
           <a:prstGeom prst="rect">
             <a:avLst/>
@@ -22631,7 +22631,7 @@
                 <a:ea typeface="Calibri" pitchFamily="34" charset="-122"/>
                 <a:cs typeface="Calibri" pitchFamily="34" charset="-120"/>
               </a:rPr>
-              <a:t>plugin build</a:t>
+              <a:t>doctor</a:t>
             </a:r>
             <a:endParaRPr lang="en-US" sz="1000" dirty="0"/>
           </a:p>
@@ -22645,8 +22645,8 @@
         </p:nvSpPr>
         <p:spPr>
           <a:xfrm>
-            <a:off x="8122920" y="5138928"/>
-            <a:ext cx="549656" cy="256032"/>
+            <a:off x="8367776" y="5138928"/>
+            <a:ext cx="1011936" cy="256032"/>
           </a:xfrm>
           <a:prstGeom prst="roundRect">
             <a:avLst>
@@ -22672,8 +22672,8 @@
         </p:nvSpPr>
         <p:spPr>
           <a:xfrm>
-            <a:off x="8122920" y="5138928"/>
-            <a:ext cx="549656" cy="256032"/>
+            <a:off x="8367776" y="5138928"/>
+            <a:ext cx="1011936" cy="256032"/>
           </a:xfrm>
           <a:prstGeom prst="rect">
             <a:avLst/>
@@ -22697,7 +22697,7 @@
                 <a:ea typeface="Calibri" pitchFamily="34" charset="-122"/>
                 <a:cs typeface="Calibri" pitchFamily="34" charset="-120"/>
               </a:rPr>
-              <a:t>trace</a:t>
+              <a:t>plugin build</a:t>
             </a:r>
             <a:endParaRPr lang="en-US" sz="1000" dirty="0"/>
           </a:p>
@@ -22711,8 +22711,8 @@
         </p:nvSpPr>
         <p:spPr>
           <a:xfrm>
-            <a:off x="8764016" y="5138928"/>
-            <a:ext cx="483616" cy="256032"/>
+            <a:off x="9471152" y="5138928"/>
+            <a:ext cx="549656" cy="256032"/>
           </a:xfrm>
           <a:prstGeom prst="roundRect">
             <a:avLst>
@@ -22738,8 +22738,8 @@
         </p:nvSpPr>
         <p:spPr>
           <a:xfrm>
-            <a:off x="8764016" y="5138928"/>
-            <a:ext cx="483616" cy="256032"/>
+            <a:off x="9471152" y="5138928"/>
+            <a:ext cx="549656" cy="256032"/>
           </a:xfrm>
           <a:prstGeom prst="rect">
             <a:avLst/>
@@ -22763,7 +22763,7 @@
                 <a:ea typeface="Calibri" pitchFamily="34" charset="-122"/>
                 <a:cs typeface="Calibri" pitchFamily="34" charset="-120"/>
               </a:rPr>
-              <a:t>hook</a:t>
+              <a:t>trace</a:t>
             </a:r>
             <a:endParaRPr lang="en-US" sz="1000" dirty="0"/>
           </a:p>
@@ -22777,8 +22777,8 @@
         </p:nvSpPr>
         <p:spPr>
           <a:xfrm>
-            <a:off x="9339072" y="5138928"/>
-            <a:ext cx="747776" cy="256032"/>
+            <a:off x="10112248" y="5138928"/>
+            <a:ext cx="483616" cy="256032"/>
           </a:xfrm>
           <a:prstGeom prst="roundRect">
             <a:avLst>
@@ -22804,7 +22804,73 @@
         </p:nvSpPr>
         <p:spPr>
           <a:xfrm>
-            <a:off x="9339072" y="5138928"/>
+            <a:off x="10112248" y="5138928"/>
+            <a:ext cx="483616" cy="256032"/>
+          </a:xfrm>
+          <a:prstGeom prst="rect">
+            <a:avLst/>
+          </a:prstGeom>
+          <a:noFill/>
+          <a:ln/>
+        </p:spPr>
+        <p:txBody>
+          <a:bodyPr wrap="square" lIns="0" tIns="0" rIns="0" bIns="0" rtlCol="0" anchor="ctr"/>
+          <a:lstStyle/>
+          <a:p>
+            <a:pPr algn="ctr" indent="0" marL="0">
+              <a:buNone/>
+            </a:pPr>
+            <a:r>
+              <a:rPr lang="en-US" sz="1000" dirty="0">
+                <a:solidFill>
+                  <a:srgbClr val="1F2430"/>
+                </a:solidFill>
+                <a:latin typeface="Calibri" pitchFamily="34" charset="0"/>
+                <a:ea typeface="Calibri" pitchFamily="34" charset="-122"/>
+                <a:cs typeface="Calibri" pitchFamily="34" charset="-120"/>
+              </a:rPr>
+              <a:t>hook</a:t>
+            </a:r>
+            <a:endParaRPr lang="en-US" sz="1000" dirty="0"/>
+          </a:p>
+        </p:txBody>
+      </p:sp>
+      <p:sp>
+        <p:nvSpPr>
+          <p:cNvPr id="134" name="Shape 132"/>
+          <p:cNvSpPr/>
+          <p:nvPr/>
+        </p:nvSpPr>
+        <p:spPr>
+          <a:xfrm>
+            <a:off x="10687304" y="5138928"/>
+            <a:ext cx="747776" cy="256032"/>
+          </a:xfrm>
+          <a:prstGeom prst="roundRect">
+            <a:avLst>
+              <a:gd name="adj" fmla="val 50000"/>
+            </a:avLst>
+          </a:prstGeom>
+          <a:solidFill>
+            <a:srgbClr val="F3F5F8"/>
+          </a:solidFill>
+          <a:ln w="12700">
+            <a:solidFill>
+              <a:srgbClr val="F3F5F8"/>
+            </a:solidFill>
+            <a:prstDash val="solid"/>
+          </a:ln>
+        </p:spPr>
+      </p:sp>
+      <p:sp>
+        <p:nvSpPr>
+          <p:cNvPr id="135" name="Text 133"/>
+          <p:cNvSpPr txBox="1"/>
+          <p:nvPr/>
+        </p:nvSpPr>
+        <p:spPr>
+          <a:xfrm>
+            <a:off x="10687304" y="5138928"/>
             <a:ext cx="747776" cy="256032"/>
           </a:xfrm>
           <a:prstGeom prst="rect">
@@ -25475,7 +25541,7 @@
                 <a:ea typeface="Courier New" pitchFamily="34" charset="-122"/>
                 <a:cs typeface="Courier New" pitchFamily="34" charset="-120"/>
               </a:rPr>
-              <a:t>  sdlc 0.9.0, license: community</a:t>
+              <a:t>  sdlc 0.9.1, license: community</a:t>
             </a:r>
             <a:endParaRPr lang="en-US" sz="1000" dirty="0"/>
           </a:p>
@@ -25526,7 +25592,7 @@
                 <a:ea typeface="Courier New" pitchFamily="34" charset="-122"/>
                 <a:cs typeface="Courier New" pitchFamily="34" charset="-120"/>
               </a:rPr>
-              <a:t>  files: 61 created, 0 updated, 0</a:t>
+              <a:t>  files: 64 created, 0 updated, 0</a:t>
             </a:r>
             <a:endParaRPr lang="en-US" sz="1000" dirty="0"/>
           </a:p>
@@ -26706,7 +26772,7 @@
         <p:spPr>
           <a:xfrm>
             <a:off x="4295648" y="6053328"/>
-            <a:ext cx="1011936" cy="256032"/>
+            <a:ext cx="549656" cy="256032"/>
           </a:xfrm>
           <a:prstGeom prst="roundRect">
             <a:avLst>
@@ -26733,7 +26799,7 @@
         <p:spPr>
           <a:xfrm>
             <a:off x="4295648" y="6053328"/>
-            <a:ext cx="1011936" cy="256032"/>
+            <a:ext cx="549656" cy="256032"/>
           </a:xfrm>
           <a:prstGeom prst="rect">
             <a:avLst/>
@@ -26757,7 +26823,7 @@
                 <a:ea typeface="Calibri" pitchFamily="34" charset="-122"/>
                 <a:cs typeface="Calibri" pitchFamily="34" charset="-120"/>
               </a:rPr>
-              <a:t>layout adapt</a:t>
+              <a:t>guide</a:t>
             </a:r>
             <a:endParaRPr lang="en-US" sz="1000" dirty="0"/>
           </a:p>
@@ -26771,8 +26837,8 @@
         </p:nvSpPr>
         <p:spPr>
           <a:xfrm>
-            <a:off x="5399024" y="6053328"/>
-            <a:ext cx="1144016" cy="256032"/>
+            <a:off x="4936744" y="6053328"/>
+            <a:ext cx="1011936" cy="256032"/>
           </a:xfrm>
           <a:prstGeom prst="roundRect">
             <a:avLst>
@@ -26798,8 +26864,8 @@
         </p:nvSpPr>
         <p:spPr>
           <a:xfrm>
-            <a:off x="5399024" y="6053328"/>
-            <a:ext cx="1144016" cy="256032"/>
+            <a:off x="4936744" y="6053328"/>
+            <a:ext cx="1011936" cy="256032"/>
           </a:xfrm>
           <a:prstGeom prst="rect">
             <a:avLst/>
@@ -26823,7 +26889,7 @@
                 <a:ea typeface="Calibri" pitchFamily="34" charset="-122"/>
                 <a:cs typeface="Calibri" pitchFamily="34" charset="-120"/>
               </a:rPr>
-              <a:t>layout convert</a:t>
+              <a:t>layout adapt</a:t>
             </a:r>
             <a:endParaRPr lang="en-US" sz="1000" dirty="0"/>
           </a:p>
@@ -26837,8 +26903,8 @@
         </p:nvSpPr>
         <p:spPr>
           <a:xfrm>
-            <a:off x="6634480" y="6053328"/>
-            <a:ext cx="549656" cy="256032"/>
+            <a:off x="6040120" y="6053328"/>
+            <a:ext cx="1144016" cy="256032"/>
           </a:xfrm>
           <a:prstGeom prst="roundRect">
             <a:avLst>
@@ -26864,8 +26930,8 @@
         </p:nvSpPr>
         <p:spPr>
           <a:xfrm>
-            <a:off x="6634480" y="6053328"/>
-            <a:ext cx="549656" cy="256032"/>
+            <a:off x="6040120" y="6053328"/>
+            <a:ext cx="1144016" cy="256032"/>
           </a:xfrm>
           <a:prstGeom prst="rect">
             <a:avLst/>
@@ -26889,7 +26955,7 @@
                 <a:ea typeface="Calibri" pitchFamily="34" charset="-122"/>
                 <a:cs typeface="Calibri" pitchFamily="34" charset="-120"/>
               </a:rPr>
-              <a:t>adopt</a:t>
+              <a:t>layout convert</a:t>
             </a:r>
             <a:endParaRPr lang="en-US" sz="1000" dirty="0"/>
           </a:p>
@@ -26904,7 +26970,7 @@
         <p:spPr>
           <a:xfrm>
             <a:off x="7275576" y="6053328"/>
-            <a:ext cx="615696" cy="256032"/>
+            <a:ext cx="549656" cy="256032"/>
           </a:xfrm>
           <a:prstGeom prst="roundRect">
             <a:avLst>
@@ -26931,6 +26997,72 @@
         <p:spPr>
           <a:xfrm>
             <a:off x="7275576" y="6053328"/>
+            <a:ext cx="549656" cy="256032"/>
+          </a:xfrm>
+          <a:prstGeom prst="rect">
+            <a:avLst/>
+          </a:prstGeom>
+          <a:noFill/>
+          <a:ln/>
+        </p:spPr>
+        <p:txBody>
+          <a:bodyPr wrap="square" lIns="0" tIns="0" rIns="0" bIns="0" rtlCol="0" anchor="ctr"/>
+          <a:lstStyle/>
+          <a:p>
+            <a:pPr algn="ctr" indent="0" marL="0">
+              <a:buNone/>
+            </a:pPr>
+            <a:r>
+              <a:rPr lang="en-US" sz="1000" dirty="0">
+                <a:solidFill>
+                  <a:srgbClr val="5B6475"/>
+                </a:solidFill>
+                <a:latin typeface="Calibri" pitchFamily="34" charset="0"/>
+                <a:ea typeface="Calibri" pitchFamily="34" charset="-122"/>
+                <a:cs typeface="Calibri" pitchFamily="34" charset="-120"/>
+              </a:rPr>
+              <a:t>adopt</a:t>
+            </a:r>
+            <a:endParaRPr lang="en-US" sz="1000" dirty="0"/>
+          </a:p>
+        </p:txBody>
+      </p:sp>
+      <p:sp>
+        <p:nvSpPr>
+          <p:cNvPr id="40" name="Shape 38"/>
+          <p:cNvSpPr/>
+          <p:nvPr/>
+        </p:nvSpPr>
+        <p:spPr>
+          <a:xfrm>
+            <a:off x="7916672" y="6053328"/>
+            <a:ext cx="615696" cy="256032"/>
+          </a:xfrm>
+          <a:prstGeom prst="roundRect">
+            <a:avLst>
+              <a:gd name="adj" fmla="val 50000"/>
+            </a:avLst>
+          </a:prstGeom>
+          <a:solidFill>
+            <a:srgbClr val="F3F5F8"/>
+          </a:solidFill>
+          <a:ln w="12700">
+            <a:solidFill>
+              <a:srgbClr val="F3F5F8"/>
+            </a:solidFill>
+            <a:prstDash val="solid"/>
+          </a:ln>
+        </p:spPr>
+      </p:sp>
+      <p:sp>
+        <p:nvSpPr>
+          <p:cNvPr id="41" name="Text 39"/>
+          <p:cNvSpPr txBox="1"/>
+          <p:nvPr/>
+        </p:nvSpPr>
+        <p:spPr>
+          <a:xfrm>
+            <a:off x="7916672" y="6053328"/>
             <a:ext cx="615696" cy="256032"/>
           </a:xfrm>
           <a:prstGeom prst="rect">

</xml_diff>

<commit_message>
feat: events to other systems, several projects, MCP resources, release checks (0.10.0)
- events in openspec/sdlc.yaml send process events (gates waiting for a
  person, approvals, verification, archives) to an MCP server after each
  command, with the people a gate waits for and never an email; delivery
  never fails a command, and undelivered events wait for the next command
  or sdlc events flush. gates.<g>.overdue_hours raises an overdue event.
- sdlc mcp serve --project serves projects from outside their folders,
  several in one server.
- The sdlc MCP server offers context packs, living specs, change
  artifacts and documents for agents as read-only resources.
- release.mcp checks hold the release approval until an outside system
  agrees; sdlc release check runs them beforehand.
</commit_message>
<xml_diff>
--- a/docs/demo/sdlc-calculator-demo.en.pptx
+++ b/docs/demo/sdlc-calculator-demo.en.pptx
@@ -6658,7 +6658,7 @@
                 <a:ea typeface="Courier New" pitchFamily="34" charset="-122"/>
                 <a:cs typeface="Courier New" pitchFamily="34" charset="-120"/>
               </a:rPr>
-              <a:t>  code-owner (15207f0f3042)</a:t>
+              <a:t>  code-owner (e1ad15ea9d87)</a:t>
             </a:r>
             <a:endParaRPr lang="en-US" sz="1000" dirty="0"/>
           </a:p>
@@ -7127,11 +7127,11 @@
         <p:spPr>
           <a:xfrm>
             <a:off x="457200" y="1645920"/>
-            <a:ext cx="5500116" cy="4206240"/>
+            <a:ext cx="5500116" cy="3749040"/>
           </a:xfrm>
           <a:prstGeom prst="roundRect">
             <a:avLst>
-              <a:gd name="adj" fmla="val 2174"/>
+              <a:gd name="adj" fmla="val 2439"/>
             </a:avLst>
           </a:prstGeom>
           <a:solidFill>
@@ -7298,7 +7298,7 @@
         <p:spPr>
           <a:xfrm>
             <a:off x="594360" y="2468880"/>
-            <a:ext cx="5225796" cy="3246120"/>
+            <a:ext cx="5225796" cy="2788920"/>
           </a:xfrm>
           <a:prstGeom prst="rect">
             <a:avLst/>
@@ -7339,7 +7339,7 @@
                 <a:ea typeface="Courier New" pitchFamily="34" charset="-122"/>
                 <a:cs typeface="Courier New" pitchFamily="34" charset="-120"/>
               </a:rPr>
-              <a:t>  release-manager (15207f0f3042)</a:t>
+              <a:t>  release-manager (e1ad15ea9d87)</a:t>
             </a:r>
             <a:endParaRPr lang="en-US" sz="1000" dirty="0"/>
           </a:p>
@@ -7404,7 +7404,7 @@
         </p:nvSpPr>
         <p:spPr>
           <a:xfrm>
-            <a:off x="457200" y="5925312"/>
+            <a:off x="457200" y="5468112"/>
             <a:ext cx="5500116" cy="384048"/>
           </a:xfrm>
           <a:prstGeom prst="rect">
@@ -7444,11 +7444,11 @@
         <p:spPr>
           <a:xfrm>
             <a:off x="6231636" y="1645920"/>
-            <a:ext cx="5500116" cy="4206240"/>
+            <a:ext cx="5500116" cy="3749040"/>
           </a:xfrm>
           <a:prstGeom prst="roundRect">
             <a:avLst>
-              <a:gd name="adj" fmla="val 2174"/>
+              <a:gd name="adj" fmla="val 2439"/>
             </a:avLst>
           </a:prstGeom>
           <a:solidFill>
@@ -7615,7 +7615,7 @@
         <p:spPr>
           <a:xfrm>
             <a:off x="6368796" y="2468880"/>
-            <a:ext cx="5225796" cy="3246120"/>
+            <a:ext cx="5225796" cy="2788920"/>
           </a:xfrm>
           <a:prstGeom prst="rect">
             <a:avLst/>
@@ -7639,7 +7639,7 @@
                 <a:ea typeface="Courier New" pitchFamily="34" charset="-122"/>
                 <a:cs typeface="Courier New" pitchFamily="34" charset="-120"/>
               </a:rPr>
-              <a:t>✓ basic-arithmetic/intent alice valid 5076f215</a:t>
+              <a:t>✓ basic-arithmetic/intent alice valid c5112f50</a:t>
             </a:r>
             <a:endParaRPr lang="en-US" sz="1000" dirty="0"/>
           </a:p>
@@ -7656,7 +7656,7 @@
                 <a:ea typeface="Courier New" pitchFamily="34" charset="-122"/>
                 <a:cs typeface="Courier New" pitchFamily="34" charset="-120"/>
               </a:rPr>
-              <a:t>✓ basic-arithmetic/spec alice valid 7f9bc81a</a:t>
+              <a:t>✓ basic-arithmetic/spec alice valid e4689e12</a:t>
             </a:r>
             <a:endParaRPr lang="en-US" sz="1000" dirty="0"/>
           </a:p>
@@ -7673,7 +7673,7 @@
                 <a:ea typeface="Courier New" pitchFamily="34" charset="-122"/>
                 <a:cs typeface="Courier New" pitchFamily="34" charset="-120"/>
               </a:rPr>
-              <a:t>✗ basic-arithmetic/plan bob wrong-signer 7f9bc81a</a:t>
+              <a:t>✗ basic-arithmetic/plan bob wrong-signer e4689e12</a:t>
             </a:r>
             <a:endParaRPr lang="en-US" sz="1000" dirty="0"/>
           </a:p>
@@ -7690,7 +7690,7 @@
                 <a:ea typeface="Courier New" pitchFamily="34" charset="-122"/>
                 <a:cs typeface="Courier New" pitchFamily="34" charset="-120"/>
               </a:rPr>
-              <a:t>✓ basic-arithmetic/review carol valid 016d3b4b</a:t>
+              <a:t>✓ basic-arithmetic/review carol valid 91e4cc39</a:t>
             </a:r>
             <a:endParaRPr lang="en-US" sz="1000" dirty="0"/>
           </a:p>
@@ -7707,7 +7707,7 @@
                 <a:ea typeface="Courier New" pitchFamily="34" charset="-122"/>
                 <a:cs typeface="Courier New" pitchFamily="34" charset="-120"/>
               </a:rPr>
-              <a:t>✓ basic-arithmetic/release alice valid 352090ab</a:t>
+              <a:t>✓ basic-arithmetic/release alice valid 2160d122</a:t>
             </a:r>
             <a:endParaRPr lang="en-US" sz="1000" dirty="0"/>
           </a:p>
@@ -7724,7 +7724,7 @@
                 <a:ea typeface="Courier New" pitchFamily="34" charset="-122"/>
                 <a:cs typeface="Courier New" pitchFamily="34" charset="-120"/>
               </a:rPr>
-              <a:t>✓ openspec/roles.yaml alice@calc.example valid bbd1c6b0</a:t>
+              <a:t>✓ openspec/roles.yaml alice@calc.example valid 3894ed3d</a:t>
             </a:r>
             <a:endParaRPr lang="en-US" sz="1000" dirty="0"/>
           </a:p>
@@ -7789,7 +7789,7 @@
         </p:nvSpPr>
         <p:spPr>
           <a:xfrm>
-            <a:off x="6231636" y="5925312"/>
+            <a:off x="6231636" y="5468112"/>
             <a:ext cx="5500116" cy="384048"/>
           </a:xfrm>
           <a:prstGeom prst="rect">
@@ -7834,6 +7834,111 @@
               <a:t>is unsigned, reported but not blocking.</a:t>
             </a:r>
             <a:endParaRPr lang="en-US" sz="1100" dirty="0"/>
+          </a:p>
+        </p:txBody>
+      </p:sp>
+      <p:sp>
+        <p:nvSpPr>
+          <p:cNvPr id="18" name="Text 16"/>
+          <p:cNvSpPr txBox="1"/>
+          <p:nvPr/>
+        </p:nvSpPr>
+        <p:spPr>
+          <a:xfrm>
+            <a:off x="457200" y="6053328"/>
+            <a:ext cx="1737360" cy="256032"/>
+          </a:xfrm>
+          <a:prstGeom prst="rect">
+            <a:avLst/>
+          </a:prstGeom>
+          <a:noFill/>
+          <a:ln/>
+        </p:spPr>
+        <p:txBody>
+          <a:bodyPr wrap="square" lIns="0" tIns="0" rIns="0" bIns="0" rtlCol="0" anchor="ctr"/>
+          <a:lstStyle/>
+          <a:p>
+            <a:pPr indent="0" marL="0">
+              <a:buNone/>
+            </a:pPr>
+            <a:r>
+              <a:rPr lang="en-US" sz="1100" dirty="0">
+                <a:solidFill>
+                  <a:srgbClr val="5B6475"/>
+                </a:solidFill>
+                <a:latin typeface="Calibri" pitchFamily="34" charset="0"/>
+                <a:ea typeface="Calibri" pitchFamily="34" charset="-122"/>
+                <a:cs typeface="Calibri" pitchFamily="34" charset="-120"/>
+              </a:rPr>
+              <a:t>Also in this part:</a:t>
+            </a:r>
+            <a:endParaRPr lang="en-US" sz="1100" dirty="0"/>
+          </a:p>
+        </p:txBody>
+      </p:sp>
+      <p:sp>
+        <p:nvSpPr>
+          <p:cNvPr id="19" name="Shape 17"/>
+          <p:cNvSpPr/>
+          <p:nvPr/>
+        </p:nvSpPr>
+        <p:spPr>
+          <a:xfrm>
+            <a:off x="2240280" y="6053328"/>
+            <a:ext cx="1077976" cy="256032"/>
+          </a:xfrm>
+          <a:prstGeom prst="roundRect">
+            <a:avLst>
+              <a:gd name="adj" fmla="val 50000"/>
+            </a:avLst>
+          </a:prstGeom>
+          <a:solidFill>
+            <a:srgbClr val="F3F5F8"/>
+          </a:solidFill>
+          <a:ln w="12700">
+            <a:solidFill>
+              <a:srgbClr val="F3F5F8"/>
+            </a:solidFill>
+            <a:prstDash val="solid"/>
+          </a:ln>
+        </p:spPr>
+      </p:sp>
+      <p:sp>
+        <p:nvSpPr>
+          <p:cNvPr id="20" name="Text 18"/>
+          <p:cNvSpPr txBox="1"/>
+          <p:nvPr/>
+        </p:nvSpPr>
+        <p:spPr>
+          <a:xfrm>
+            <a:off x="2240280" y="6053328"/>
+            <a:ext cx="1077976" cy="256032"/>
+          </a:xfrm>
+          <a:prstGeom prst="rect">
+            <a:avLst/>
+          </a:prstGeom>
+          <a:noFill/>
+          <a:ln/>
+        </p:spPr>
+        <p:txBody>
+          <a:bodyPr wrap="square" lIns="0" tIns="0" rIns="0" bIns="0" rtlCol="0" anchor="ctr"/>
+          <a:lstStyle/>
+          <a:p>
+            <a:pPr algn="ctr" indent="0" marL="0">
+              <a:buNone/>
+            </a:pPr>
+            <a:r>
+              <a:rPr lang="en-US" sz="1000" dirty="0">
+                <a:solidFill>
+                  <a:srgbClr val="5B6475"/>
+                </a:solidFill>
+                <a:latin typeface="Calibri" pitchFamily="34" charset="0"/>
+                <a:ea typeface="Calibri" pitchFamily="34" charset="-122"/>
+                <a:cs typeface="Calibri" pitchFamily="34" charset="-120"/>
+              </a:rPr>
+              <a:t>release check</a:t>
+            </a:r>
+            <a:endParaRPr lang="en-US" sz="1000" dirty="0"/>
           </a:p>
         </p:txBody>
       </p:sp>
@@ -13829,7 +13934,7 @@
                 <a:ea typeface="Courier New" pitchFamily="34" charset="-122"/>
                 <a:cs typeface="Courier New" pitchFamily="34" charset="-120"/>
               </a:rPr>
-              <a:t>  archived) · sdlc 0.9.1, license:</a:t>
+              <a:t>  archived) · sdlc 0.10.0, license:</a:t>
             </a:r>
             <a:endParaRPr lang="en-US" sz="1000" dirty="0"/>
           </a:p>
@@ -14016,7 +14121,7 @@
                 <a:ea typeface="Courier New" pitchFamily="34" charset="-122"/>
                 <a:cs typeface="Courier New" pitchFamily="34" charset="-120"/>
               </a:rPr>
-              <a:t>  recorded with sdlc 0.9.1; licenses:</a:t>
+              <a:t>  recorded with sdlc 0.10.0; licenses:</a:t>
             </a:r>
             <a:endParaRPr lang="en-US" sz="1000" dirty="0"/>
           </a:p>
@@ -14333,7 +14438,7 @@
                 <a:ea typeface="Courier New" pitchFamily="34" charset="-122"/>
                 <a:cs typeface="Courier New" pitchFamily="34" charset="-120"/>
               </a:rPr>
-              <a:t>2026-10-07T10:13:21.903Z  gate.review.await</a:t>
+              <a:t>2026-10-07T13:36:22.758Z  gate.review.await</a:t>
             </a:r>
             <a:endParaRPr lang="en-US" sz="1000" dirty="0"/>
           </a:p>
@@ -14367,7 +14472,7 @@
                 <a:ea typeface="Courier New" pitchFamily="34" charset="-122"/>
                 <a:cs typeface="Courier New" pitchFamily="34" charset="-120"/>
               </a:rPr>
-              <a:t>  sha256:15207f0f3042ddb9dcece8aec4d12c856b</a:t>
+              <a:t>  sha256:e1ad15ea9d87bf2b7858610d3286b407cf</a:t>
             </a:r>
             <a:endParaRPr lang="en-US" sz="1000" dirty="0"/>
           </a:p>
@@ -14384,7 +14489,7 @@
                 <a:ea typeface="Courier New" pitchFamily="34" charset="-122"/>
                 <a:cs typeface="Courier New" pitchFamily="34" charset="-120"/>
               </a:rPr>
-              <a:t>  747402af622946b7c55efdb406e49b [sdlc</a:t>
+              <a:t>  7dad20136ebebb77a89d1a2b19ffc1 [sdlc</a:t>
             </a:r>
             <a:endParaRPr lang="en-US" sz="1000" dirty="0"/>
           </a:p>
@@ -14401,7 +14506,7 @@
                 <a:ea typeface="Courier New" pitchFamily="34" charset="-122"/>
                 <a:cs typeface="Courier New" pitchFamily="34" charset="-120"/>
               </a:rPr>
-              <a:t>  0.9.1 · community]</a:t>
+              <a:t>  0.10.0 · community]</a:t>
             </a:r>
             <a:endParaRPr lang="en-US" sz="1000" dirty="0"/>
           </a:p>
@@ -14418,7 +14523,7 @@
                 <a:ea typeface="Courier New" pitchFamily="34" charset="-122"/>
                 <a:cs typeface="Courier New" pitchFamily="34" charset="-120"/>
               </a:rPr>
-              <a:t>2026-10-07T10:13:24.897Z  gate.review.appro</a:t>
+              <a:t>2026-10-07T13:36:25.643Z  gate.review.appro</a:t>
             </a:r>
             <a:endParaRPr lang="en-US" sz="1000" dirty="0"/>
           </a:p>
@@ -14469,7 +14574,7 @@
                 <a:ea typeface="Courier New" pitchFamily="34" charset="-122"/>
                 <a:cs typeface="Courier New" pitchFamily="34" charset="-120"/>
               </a:rPr>
-              <a:t>  [sdlc 0.9.1 · community]</a:t>
+              <a:t>  [sdlc 0.10.0 · community]</a:t>
             </a:r>
             <a:endParaRPr lang="en-US" sz="1000" dirty="0"/>
           </a:p>
@@ -14486,7 +14591,7 @@
                 <a:ea typeface="Courier New" pitchFamily="34" charset="-122"/>
                 <a:cs typeface="Courier New" pitchFamily="34" charset="-120"/>
               </a:rPr>
-              <a:t>2026-10-07T10:13:28.430Z  gate.release.appr</a:t>
+              <a:t>2026-10-07T13:36:30.395Z  gate.release.appr</a:t>
             </a:r>
             <a:endParaRPr lang="en-US" sz="1000" dirty="0"/>
           </a:p>
@@ -14537,7 +14642,7 @@
                 <a:ea typeface="Courier New" pitchFamily="34" charset="-122"/>
                 <a:cs typeface="Courier New" pitchFamily="34" charset="-120"/>
               </a:rPr>
-              <a:t>  release-manager [sdlc 0.9.1 · community]</a:t>
+              <a:t>  release-manager [sdlc 0.10.0 · community]</a:t>
             </a:r>
             <a:endParaRPr lang="en-US" sz="1000" dirty="0"/>
           </a:p>
@@ -15714,7 +15819,7 @@
                 <a:ea typeface="Courier New" pitchFamily="34" charset="-122"/>
                 <a:cs typeface="Courier New" pitchFamily="34" charset="-120"/>
               </a:rPr>
-              <a:t>✓ test (1.0s)</a:t>
+              <a:t>✓ test (1.4s)</a:t>
             </a:r>
             <a:endParaRPr lang="en-US" sz="1000" dirty="0"/>
           </a:p>
@@ -15731,7 +15836,7 @@
                 <a:ea typeface="Courier New" pitchFamily="34" charset="-122"/>
                 <a:cs typeface="Courier New" pitchFamily="34" charset="-120"/>
               </a:rPr>
-              <a:t>✓ ci-green (ci/pipeline_status, 0.5s)</a:t>
+              <a:t>✓ ci-green (ci/pipeline_status, 0.8s)</a:t>
             </a:r>
             <a:endParaRPr lang="en-US" sz="1000" dirty="0"/>
           </a:p>
@@ -16167,7 +16272,7 @@
                 <a:ea typeface="Courier New" pitchFamily="34" charset="-122"/>
                 <a:cs typeface="Courier New" pitchFamily="34" charset="-120"/>
               </a:rPr>
-              <a:t>      "id": "20261007T101406690Z-ci-green-b</a:t>
+              <a:t>      "id": "20261007T133720640Z-ci-green-3</a:t>
             </a:r>
             <a:endParaRPr lang="en-US" sz="1000" dirty="0"/>
           </a:p>
@@ -16184,7 +16289,7 @@
                 <a:ea typeface="Courier New" pitchFamily="34" charset="-122"/>
                 <a:cs typeface="Courier New" pitchFamily="34" charset="-120"/>
               </a:rPr>
-              <a:t>  80419",</a:t>
+              <a:t>  67431",</a:t>
             </a:r>
             <a:endParaRPr lang="en-US" sz="1000" dirty="0"/>
           </a:p>
@@ -16320,7 +16425,7 @@
                 <a:ea typeface="Courier New" pitchFamily="34" charset="-122"/>
                 <a:cs typeface="Courier New" pitchFamily="34" charset="-120"/>
               </a:rPr>
-              <a:t>        "ref": "2742131fbd21da8c5c880624e29</a:t>
+              <a:t>        "ref": "981f0bffbaca6272e42788b096b</a:t>
             </a:r>
             <a:endParaRPr lang="en-US" sz="1000" dirty="0"/>
           </a:p>
@@ -16337,7 +16442,7 @@
                 <a:ea typeface="Courier New" pitchFamily="34" charset="-122"/>
                 <a:cs typeface="Courier New" pitchFamily="34" charset="-120"/>
               </a:rPr>
-              <a:t>  ea2638c4bbb62",</a:t>
+              <a:t>  a742e3fa1444e",</a:t>
             </a:r>
             <a:endParaRPr lang="en-US" sz="1000" dirty="0"/>
           </a:p>
@@ -16530,7 +16635,7 @@
         <p:spPr>
           <a:xfrm>
             <a:off x="3211576" y="6053328"/>
-            <a:ext cx="813816" cy="256032"/>
+            <a:ext cx="945896" cy="256032"/>
           </a:xfrm>
           <a:prstGeom prst="roundRect">
             <a:avLst>
@@ -16557,6 +16662,138 @@
         <p:spPr>
           <a:xfrm>
             <a:off x="3211576" y="6053328"/>
+            <a:ext cx="945896" cy="256032"/>
+          </a:xfrm>
+          <a:prstGeom prst="rect">
+            <a:avLst/>
+          </a:prstGeom>
+          <a:noFill/>
+          <a:ln/>
+        </p:spPr>
+        <p:txBody>
+          <a:bodyPr wrap="square" lIns="0" tIns="0" rIns="0" bIns="0" rtlCol="0" anchor="ctr"/>
+          <a:lstStyle/>
+          <a:p>
+            <a:pPr algn="ctr" indent="0" marL="0">
+              <a:buNone/>
+            </a:pPr>
+            <a:r>
+              <a:rPr lang="en-US" sz="1000" dirty="0">
+                <a:solidFill>
+                  <a:srgbClr val="5B6475"/>
+                </a:solidFill>
+                <a:latin typeface="Calibri" pitchFamily="34" charset="0"/>
+                <a:ea typeface="Calibri" pitchFamily="34" charset="-122"/>
+                <a:cs typeface="Calibri" pitchFamily="34" charset="-120"/>
+              </a:rPr>
+              <a:t>events list</a:t>
+            </a:r>
+            <a:endParaRPr lang="en-US" sz="1000" dirty="0"/>
+          </a:p>
+        </p:txBody>
+      </p:sp>
+      <p:sp>
+        <p:nvSpPr>
+          <p:cNvPr id="30" name="Shape 28"/>
+          <p:cNvSpPr/>
+          <p:nvPr/>
+        </p:nvSpPr>
+        <p:spPr>
+          <a:xfrm>
+            <a:off x="4248912" y="6053328"/>
+            <a:ext cx="1011936" cy="256032"/>
+          </a:xfrm>
+          <a:prstGeom prst="roundRect">
+            <a:avLst>
+              <a:gd name="adj" fmla="val 50000"/>
+            </a:avLst>
+          </a:prstGeom>
+          <a:solidFill>
+            <a:srgbClr val="F3F5F8"/>
+          </a:solidFill>
+          <a:ln w="12700">
+            <a:solidFill>
+              <a:srgbClr val="F3F5F8"/>
+            </a:solidFill>
+            <a:prstDash val="solid"/>
+          </a:ln>
+        </p:spPr>
+      </p:sp>
+      <p:sp>
+        <p:nvSpPr>
+          <p:cNvPr id="31" name="Text 29"/>
+          <p:cNvSpPr txBox="1"/>
+          <p:nvPr/>
+        </p:nvSpPr>
+        <p:spPr>
+          <a:xfrm>
+            <a:off x="4248912" y="6053328"/>
+            <a:ext cx="1011936" cy="256032"/>
+          </a:xfrm>
+          <a:prstGeom prst="rect">
+            <a:avLst/>
+          </a:prstGeom>
+          <a:noFill/>
+          <a:ln/>
+        </p:spPr>
+        <p:txBody>
+          <a:bodyPr wrap="square" lIns="0" tIns="0" rIns="0" bIns="0" rtlCol="0" anchor="ctr"/>
+          <a:lstStyle/>
+          <a:p>
+            <a:pPr algn="ctr" indent="0" marL="0">
+              <a:buNone/>
+            </a:pPr>
+            <a:r>
+              <a:rPr lang="en-US" sz="1000" dirty="0">
+                <a:solidFill>
+                  <a:srgbClr val="5B6475"/>
+                </a:solidFill>
+                <a:latin typeface="Calibri" pitchFamily="34" charset="0"/>
+                <a:ea typeface="Calibri" pitchFamily="34" charset="-122"/>
+                <a:cs typeface="Calibri" pitchFamily="34" charset="-120"/>
+              </a:rPr>
+              <a:t>events flush</a:t>
+            </a:r>
+            <a:endParaRPr lang="en-US" sz="1000" dirty="0"/>
+          </a:p>
+        </p:txBody>
+      </p:sp>
+      <p:sp>
+        <p:nvSpPr>
+          <p:cNvPr id="32" name="Shape 30"/>
+          <p:cNvSpPr/>
+          <p:nvPr/>
+        </p:nvSpPr>
+        <p:spPr>
+          <a:xfrm>
+            <a:off x="5352288" y="6053328"/>
+            <a:ext cx="813816" cy="256032"/>
+          </a:xfrm>
+          <a:prstGeom prst="roundRect">
+            <a:avLst>
+              <a:gd name="adj" fmla="val 50000"/>
+            </a:avLst>
+          </a:prstGeom>
+          <a:solidFill>
+            <a:srgbClr val="F3F5F8"/>
+          </a:solidFill>
+          <a:ln w="12700">
+            <a:solidFill>
+              <a:srgbClr val="F3F5F8"/>
+            </a:solidFill>
+            <a:prstDash val="solid"/>
+          </a:ln>
+        </p:spPr>
+      </p:sp>
+      <p:sp>
+        <p:nvSpPr>
+          <p:cNvPr id="33" name="Text 31"/>
+          <p:cNvSpPr txBox="1"/>
+          <p:nvPr/>
+        </p:nvSpPr>
+        <p:spPr>
+          <a:xfrm>
+            <a:off x="5352288" y="6053328"/>
             <a:ext cx="813816" cy="256032"/>
           </a:xfrm>
           <a:prstGeom prst="rect">
@@ -18581,7 +18818,7 @@
                 <a:ea typeface="Cambria" pitchFamily="34" charset="-122"/>
                 <a:cs typeface="Cambria" pitchFamily="34" charset="-120"/>
               </a:rPr>
-              <a:t>91</a:t>
+              <a:t>94</a:t>
             </a:r>
             <a:endParaRPr lang="en-US" sz="6000" dirty="0"/>
           </a:p>
@@ -18686,7 +18923,7 @@
                 <a:ea typeface="Cambria" pitchFamily="34" charset="-122"/>
                 <a:cs typeface="Cambria" pitchFamily="34" charset="-120"/>
               </a:rPr>
-              <a:t>60</a:t>
+              <a:t>63</a:t>
             </a:r>
             <a:endParaRPr lang="en-US" sz="6000" dirty="0"/>
           </a:p>
@@ -18725,7 +18962,7 @@
                 <a:ea typeface="Calibri" pitchFamily="34" charset="-122"/>
                 <a:cs typeface="Calibri" pitchFamily="34" charset="-120"/>
               </a:rPr>
-              <a:t>of 60 commands</a:t>
+              <a:t>of 63 commands</a:t>
             </a:r>
             <a:endParaRPr lang="en-US" sz="1600" dirty="0"/>
           </a:p>
@@ -21260,7 +21497,7 @@
         <p:spPr>
           <a:xfrm>
             <a:off x="2399792" y="4791456"/>
-            <a:ext cx="813816" cy="256032"/>
+            <a:ext cx="945896" cy="256032"/>
           </a:xfrm>
           <a:prstGeom prst="roundRect">
             <a:avLst>
@@ -21287,7 +21524,7 @@
         <p:spPr>
           <a:xfrm>
             <a:off x="2399792" y="4791456"/>
-            <a:ext cx="813816" cy="256032"/>
+            <a:ext cx="945896" cy="256032"/>
           </a:xfrm>
           <a:prstGeom prst="rect">
             <a:avLst/>
@@ -21311,7 +21548,7 @@
                 <a:ea typeface="Calibri" pitchFamily="34" charset="-122"/>
                 <a:cs typeface="Calibri" pitchFamily="34" charset="-120"/>
               </a:rPr>
-              <a:t>track set</a:t>
+              <a:t>events list</a:t>
             </a:r>
             <a:endParaRPr lang="en-US" sz="1000" dirty="0"/>
           </a:p>
@@ -21325,8 +21562,8 @@
         </p:nvSpPr>
         <p:spPr>
           <a:xfrm>
-            <a:off x="3305048" y="4791456"/>
-            <a:ext cx="483616" cy="256032"/>
+            <a:off x="3437128" y="4791456"/>
+            <a:ext cx="1011936" cy="256032"/>
           </a:xfrm>
           <a:prstGeom prst="roundRect">
             <a:avLst>
@@ -21352,8 +21589,8 @@
         </p:nvSpPr>
         <p:spPr>
           <a:xfrm>
-            <a:off x="3305048" y="4791456"/>
-            <a:ext cx="483616" cy="256032"/>
+            <a:off x="3437128" y="4791456"/>
+            <a:ext cx="1011936" cy="256032"/>
           </a:xfrm>
           <a:prstGeom prst="rect">
             <a:avLst/>
@@ -21377,7 +21614,7 @@
                 <a:ea typeface="Calibri" pitchFamily="34" charset="-122"/>
                 <a:cs typeface="Calibri" pitchFamily="34" charset="-120"/>
               </a:rPr>
-              <a:t>next</a:t>
+              <a:t>events flush</a:t>
             </a:r>
             <a:endParaRPr lang="en-US" sz="1000" dirty="0"/>
           </a:p>
@@ -21391,8 +21628,8 @@
         </p:nvSpPr>
         <p:spPr>
           <a:xfrm>
-            <a:off x="3880104" y="4791456"/>
-            <a:ext cx="1011936" cy="256032"/>
+            <a:off x="4540504" y="4791456"/>
+            <a:ext cx="1077976" cy="256032"/>
           </a:xfrm>
           <a:prstGeom prst="roundRect">
             <a:avLst>
@@ -21418,8 +21655,8 @@
         </p:nvSpPr>
         <p:spPr>
           <a:xfrm>
-            <a:off x="3880104" y="4791456"/>
-            <a:ext cx="1011936" cy="256032"/>
+            <a:off x="4540504" y="4791456"/>
+            <a:ext cx="1077976" cy="256032"/>
           </a:xfrm>
           <a:prstGeom prst="rect">
             <a:avLst/>
@@ -21443,7 +21680,7 @@
                 <a:ea typeface="Calibri" pitchFamily="34" charset="-122"/>
                 <a:cs typeface="Calibri" pitchFamily="34" charset="-120"/>
               </a:rPr>
-              <a:t>instructions</a:t>
+              <a:t>release check</a:t>
             </a:r>
             <a:endParaRPr lang="en-US" sz="1000" dirty="0"/>
           </a:p>
@@ -21457,8 +21694,8 @@
         </p:nvSpPr>
         <p:spPr>
           <a:xfrm>
-            <a:off x="4983480" y="4791456"/>
-            <a:ext cx="681736" cy="256032"/>
+            <a:off x="5709920" y="4791456"/>
+            <a:ext cx="813816" cy="256032"/>
           </a:xfrm>
           <a:prstGeom prst="roundRect">
             <a:avLst>
@@ -21484,8 +21721,8 @@
         </p:nvSpPr>
         <p:spPr>
           <a:xfrm>
-            <a:off x="4983480" y="4791456"/>
-            <a:ext cx="681736" cy="256032"/>
+            <a:off x="5709920" y="4791456"/>
+            <a:ext cx="813816" cy="256032"/>
           </a:xfrm>
           <a:prstGeom prst="rect">
             <a:avLst/>
@@ -21509,7 +21746,7 @@
                 <a:ea typeface="Calibri" pitchFamily="34" charset="-122"/>
                 <a:cs typeface="Calibri" pitchFamily="34" charset="-120"/>
               </a:rPr>
-              <a:t>approve</a:t>
+              <a:t>track set</a:t>
             </a:r>
             <a:endParaRPr lang="en-US" sz="1000" dirty="0"/>
           </a:p>
@@ -21523,8 +21760,8 @@
         </p:nvSpPr>
         <p:spPr>
           <a:xfrm>
-            <a:off x="5756656" y="4791456"/>
-            <a:ext cx="615696" cy="256032"/>
+            <a:off x="6615176" y="4791456"/>
+            <a:ext cx="483616" cy="256032"/>
           </a:xfrm>
           <a:prstGeom prst="roundRect">
             <a:avLst>
@@ -21550,8 +21787,8 @@
         </p:nvSpPr>
         <p:spPr>
           <a:xfrm>
-            <a:off x="5756656" y="4791456"/>
-            <a:ext cx="615696" cy="256032"/>
+            <a:off x="6615176" y="4791456"/>
+            <a:ext cx="483616" cy="256032"/>
           </a:xfrm>
           <a:prstGeom prst="rect">
             <a:avLst/>
@@ -21575,7 +21812,7 @@
                 <a:ea typeface="Calibri" pitchFamily="34" charset="-122"/>
                 <a:cs typeface="Calibri" pitchFamily="34" charset="-120"/>
               </a:rPr>
-              <a:t>reject</a:t>
+              <a:t>next</a:t>
             </a:r>
             <a:endParaRPr lang="en-US" sz="1000" dirty="0"/>
           </a:p>
@@ -21589,8 +21826,8 @@
         </p:nvSpPr>
         <p:spPr>
           <a:xfrm>
-            <a:off x="6463792" y="4791456"/>
-            <a:ext cx="549656" cy="256032"/>
+            <a:off x="7190232" y="4791456"/>
+            <a:ext cx="1011936" cy="256032"/>
           </a:xfrm>
           <a:prstGeom prst="roundRect">
             <a:avLst>
@@ -21616,8 +21853,8 @@
         </p:nvSpPr>
         <p:spPr>
           <a:xfrm>
-            <a:off x="6463792" y="4791456"/>
-            <a:ext cx="549656" cy="256032"/>
+            <a:off x="7190232" y="4791456"/>
+            <a:ext cx="1011936" cy="256032"/>
           </a:xfrm>
           <a:prstGeom prst="rect">
             <a:avLst/>
@@ -21641,7 +21878,7 @@
                 <a:ea typeface="Calibri" pitchFamily="34" charset="-122"/>
                 <a:cs typeface="Calibri" pitchFamily="34" charset="-120"/>
               </a:rPr>
-              <a:t>waive</a:t>
+              <a:t>instructions</a:t>
             </a:r>
             <a:endParaRPr lang="en-US" sz="1000" dirty="0"/>
           </a:p>
@@ -21655,8 +21892,8 @@
         </p:nvSpPr>
         <p:spPr>
           <a:xfrm>
-            <a:off x="7104888" y="4791456"/>
-            <a:ext cx="747776" cy="256032"/>
+            <a:off x="8293608" y="4791456"/>
+            <a:ext cx="681736" cy="256032"/>
           </a:xfrm>
           <a:prstGeom prst="roundRect">
             <a:avLst>
@@ -21682,8 +21919,8 @@
         </p:nvSpPr>
         <p:spPr>
           <a:xfrm>
-            <a:off x="7104888" y="4791456"/>
-            <a:ext cx="747776" cy="256032"/>
+            <a:off x="8293608" y="4791456"/>
+            <a:ext cx="681736" cy="256032"/>
           </a:xfrm>
           <a:prstGeom prst="rect">
             <a:avLst/>
@@ -21707,7 +21944,7 @@
                 <a:ea typeface="Calibri" pitchFamily="34" charset="-122"/>
                 <a:cs typeface="Calibri" pitchFamily="34" charset="-120"/>
               </a:rPr>
-              <a:t>takeover</a:t>
+              <a:t>approve</a:t>
             </a:r>
             <a:endParaRPr lang="en-US" sz="1000" dirty="0"/>
           </a:p>
@@ -21721,8 +21958,8 @@
         </p:nvSpPr>
         <p:spPr>
           <a:xfrm>
-            <a:off x="7944104" y="4791456"/>
-            <a:ext cx="1210056" cy="256032"/>
+            <a:off x="9066784" y="4791456"/>
+            <a:ext cx="615696" cy="256032"/>
           </a:xfrm>
           <a:prstGeom prst="roundRect">
             <a:avLst>
@@ -21748,8 +21985,8 @@
         </p:nvSpPr>
         <p:spPr>
           <a:xfrm>
-            <a:off x="7944104" y="4791456"/>
-            <a:ext cx="1210056" cy="256032"/>
+            <a:off x="9066784" y="4791456"/>
+            <a:ext cx="615696" cy="256032"/>
           </a:xfrm>
           <a:prstGeom prst="rect">
             <a:avLst/>
@@ -21773,7 +22010,7 @@
                 <a:ea typeface="Calibri" pitchFamily="34" charset="-122"/>
                 <a:cs typeface="Calibri" pitchFamily="34" charset="-120"/>
               </a:rPr>
-              <a:t>release-control</a:t>
+              <a:t>reject</a:t>
             </a:r>
             <a:endParaRPr lang="en-US" sz="1000" dirty="0"/>
           </a:p>
@@ -21787,8 +22024,8 @@
         </p:nvSpPr>
         <p:spPr>
           <a:xfrm>
-            <a:off x="9245600" y="4791456"/>
-            <a:ext cx="615696" cy="256032"/>
+            <a:off x="9773920" y="4791456"/>
+            <a:ext cx="549656" cy="256032"/>
           </a:xfrm>
           <a:prstGeom prst="roundRect">
             <a:avLst>
@@ -21814,8 +22051,8 @@
         </p:nvSpPr>
         <p:spPr>
           <a:xfrm>
-            <a:off x="9245600" y="4791456"/>
-            <a:ext cx="615696" cy="256032"/>
+            <a:off x="9773920" y="4791456"/>
+            <a:ext cx="549656" cy="256032"/>
           </a:xfrm>
           <a:prstGeom prst="rect">
             <a:avLst/>
@@ -21839,7 +22076,7 @@
                 <a:ea typeface="Calibri" pitchFamily="34" charset="-122"/>
                 <a:cs typeface="Calibri" pitchFamily="34" charset="-120"/>
               </a:rPr>
-              <a:t>rework</a:t>
+              <a:t>waive</a:t>
             </a:r>
             <a:endParaRPr lang="en-US" sz="1000" dirty="0"/>
           </a:p>
@@ -21853,8 +22090,8 @@
         </p:nvSpPr>
         <p:spPr>
           <a:xfrm>
-            <a:off x="9952736" y="4791456"/>
-            <a:ext cx="1276096" cy="256032"/>
+            <a:off x="10415016" y="4791456"/>
+            <a:ext cx="747776" cy="256032"/>
           </a:xfrm>
           <a:prstGeom prst="roundRect">
             <a:avLst>
@@ -21880,8 +22117,8 @@
         </p:nvSpPr>
         <p:spPr>
           <a:xfrm>
-            <a:off x="9952736" y="4791456"/>
-            <a:ext cx="1276096" cy="256032"/>
+            <a:off x="10415016" y="4791456"/>
+            <a:ext cx="747776" cy="256032"/>
           </a:xfrm>
           <a:prstGeom prst="rect">
             <a:avLst/>
@@ -21905,7 +22142,7 @@
                 <a:ea typeface="Calibri" pitchFamily="34" charset="-122"/>
                 <a:cs typeface="Calibri" pitchFamily="34" charset="-120"/>
               </a:rPr>
-              <a:t>approvals verify</a:t>
+              <a:t>takeover</a:t>
             </a:r>
             <a:endParaRPr lang="en-US" sz="1000" dirty="0"/>
           </a:p>
@@ -21920,7 +22157,7 @@
         <p:spPr>
           <a:xfrm>
             <a:off x="457200" y="5138928"/>
-            <a:ext cx="549656" cy="256032"/>
+            <a:ext cx="1210056" cy="256032"/>
           </a:xfrm>
           <a:prstGeom prst="roundRect">
             <a:avLst>
@@ -21947,7 +22184,7 @@
         <p:spPr>
           <a:xfrm>
             <a:off x="457200" y="5138928"/>
-            <a:ext cx="549656" cy="256032"/>
+            <a:ext cx="1210056" cy="256032"/>
           </a:xfrm>
           <a:prstGeom prst="rect">
             <a:avLst/>
@@ -21971,7 +22208,7 @@
                 <a:ea typeface="Calibri" pitchFamily="34" charset="-122"/>
                 <a:cs typeface="Calibri" pitchFamily="34" charset="-120"/>
               </a:rPr>
-              <a:t>tests</a:t>
+              <a:t>release-control</a:t>
             </a:r>
             <a:endParaRPr lang="en-US" sz="1000" dirty="0"/>
           </a:p>
@@ -21985,7 +22222,7 @@
         </p:nvSpPr>
         <p:spPr>
           <a:xfrm>
-            <a:off x="1098296" y="5138928"/>
+            <a:off x="1758696" y="5138928"/>
             <a:ext cx="615696" cy="256032"/>
           </a:xfrm>
           <a:prstGeom prst="roundRect">
@@ -22012,7 +22249,7 @@
         </p:nvSpPr>
         <p:spPr>
           <a:xfrm>
-            <a:off x="1098296" y="5138928"/>
+            <a:off x="1758696" y="5138928"/>
             <a:ext cx="615696" cy="256032"/>
           </a:xfrm>
           <a:prstGeom prst="rect">
@@ -22037,7 +22274,7 @@
                 <a:ea typeface="Calibri" pitchFamily="34" charset="-122"/>
                 <a:cs typeface="Calibri" pitchFamily="34" charset="-120"/>
               </a:rPr>
-              <a:t>verify</a:t>
+              <a:t>rework</a:t>
             </a:r>
             <a:endParaRPr lang="en-US" sz="1000" dirty="0"/>
           </a:p>
@@ -22051,8 +22288,8 @@
         </p:nvSpPr>
         <p:spPr>
           <a:xfrm>
-            <a:off x="1805432" y="5138928"/>
-            <a:ext cx="615696" cy="256032"/>
+            <a:off x="2465832" y="5138928"/>
+            <a:ext cx="1276096" cy="256032"/>
           </a:xfrm>
           <a:prstGeom prst="roundRect">
             <a:avLst>
@@ -22078,8 +22315,8 @@
         </p:nvSpPr>
         <p:spPr>
           <a:xfrm>
-            <a:off x="1805432" y="5138928"/>
-            <a:ext cx="615696" cy="256032"/>
+            <a:off x="2465832" y="5138928"/>
+            <a:ext cx="1276096" cy="256032"/>
           </a:xfrm>
           <a:prstGeom prst="rect">
             <a:avLst/>
@@ -22103,7 +22340,7 @@
                 <a:ea typeface="Calibri" pitchFamily="34" charset="-122"/>
                 <a:cs typeface="Calibri" pitchFamily="34" charset="-120"/>
               </a:rPr>
-              <a:t>review</a:t>
+              <a:t>approvals verify</a:t>
             </a:r>
             <a:endParaRPr lang="en-US" sz="1000" dirty="0"/>
           </a:p>
@@ -22117,8 +22354,8 @@
         </p:nvSpPr>
         <p:spPr>
           <a:xfrm>
-            <a:off x="2512568" y="5138928"/>
-            <a:ext cx="747776" cy="256032"/>
+            <a:off x="3833368" y="5138928"/>
+            <a:ext cx="549656" cy="256032"/>
           </a:xfrm>
           <a:prstGeom prst="roundRect">
             <a:avLst>
@@ -22144,8 +22381,8 @@
         </p:nvSpPr>
         <p:spPr>
           <a:xfrm>
-            <a:off x="2512568" y="5138928"/>
-            <a:ext cx="747776" cy="256032"/>
+            <a:off x="3833368" y="5138928"/>
+            <a:ext cx="549656" cy="256032"/>
           </a:xfrm>
           <a:prstGeom prst="rect">
             <a:avLst/>
@@ -22169,7 +22406,7 @@
                 <a:ea typeface="Calibri" pitchFamily="34" charset="-122"/>
                 <a:cs typeface="Calibri" pitchFamily="34" charset="-120"/>
               </a:rPr>
-              <a:t>validate</a:t>
+              <a:t>tests</a:t>
             </a:r>
             <a:endParaRPr lang="en-US" sz="1000" dirty="0"/>
           </a:p>
@@ -22183,8 +22420,8 @@
         </p:nvSpPr>
         <p:spPr>
           <a:xfrm>
-            <a:off x="3351784" y="5138928"/>
-            <a:ext cx="681736" cy="256032"/>
+            <a:off x="4474464" y="5138928"/>
+            <a:ext cx="615696" cy="256032"/>
           </a:xfrm>
           <a:prstGeom prst="roundRect">
             <a:avLst>
@@ -22210,8 +22447,8 @@
         </p:nvSpPr>
         <p:spPr>
           <a:xfrm>
-            <a:off x="3351784" y="5138928"/>
-            <a:ext cx="681736" cy="256032"/>
+            <a:off x="4474464" y="5138928"/>
+            <a:ext cx="615696" cy="256032"/>
           </a:xfrm>
           <a:prstGeom prst="rect">
             <a:avLst/>
@@ -22235,7 +22472,7 @@
                 <a:ea typeface="Calibri" pitchFamily="34" charset="-122"/>
                 <a:cs typeface="Calibri" pitchFamily="34" charset="-120"/>
               </a:rPr>
-              <a:t>archive</a:t>
+              <a:t>verify</a:t>
             </a:r>
             <a:endParaRPr lang="en-US" sz="1000" dirty="0"/>
           </a:p>
@@ -22249,8 +22486,8 @@
         </p:nvSpPr>
         <p:spPr>
           <a:xfrm>
-            <a:off x="4124960" y="5138928"/>
-            <a:ext cx="549656" cy="256032"/>
+            <a:off x="5181600" y="5138928"/>
+            <a:ext cx="615696" cy="256032"/>
           </a:xfrm>
           <a:prstGeom prst="roundRect">
             <a:avLst>
@@ -22276,8 +22513,8 @@
         </p:nvSpPr>
         <p:spPr>
           <a:xfrm>
-            <a:off x="4124960" y="5138928"/>
-            <a:ext cx="549656" cy="256032"/>
+            <a:off x="5181600" y="5138928"/>
+            <a:ext cx="615696" cy="256032"/>
           </a:xfrm>
           <a:prstGeom prst="rect">
             <a:avLst/>
@@ -22301,7 +22538,7 @@
                 <a:ea typeface="Calibri" pitchFamily="34" charset="-122"/>
                 <a:cs typeface="Calibri" pitchFamily="34" charset="-120"/>
               </a:rPr>
-              <a:t>audit</a:t>
+              <a:t>review</a:t>
             </a:r>
             <a:endParaRPr lang="en-US" sz="1000" dirty="0"/>
           </a:p>
@@ -22315,8 +22552,8 @@
         </p:nvSpPr>
         <p:spPr>
           <a:xfrm>
-            <a:off x="4766056" y="5138928"/>
-            <a:ext cx="615696" cy="256032"/>
+            <a:off x="5888736" y="5138928"/>
+            <a:ext cx="747776" cy="256032"/>
           </a:xfrm>
           <a:prstGeom prst="roundRect">
             <a:avLst>
@@ -22342,8 +22579,8 @@
         </p:nvSpPr>
         <p:spPr>
           <a:xfrm>
-            <a:off x="4766056" y="5138928"/>
-            <a:ext cx="615696" cy="256032"/>
+            <a:off x="5888736" y="5138928"/>
+            <a:ext cx="747776" cy="256032"/>
           </a:xfrm>
           <a:prstGeom prst="rect">
             <a:avLst/>
@@ -22367,7 +22604,7 @@
                 <a:ea typeface="Calibri" pitchFamily="34" charset="-122"/>
                 <a:cs typeface="Calibri" pitchFamily="34" charset="-120"/>
               </a:rPr>
-              <a:t>report</a:t>
+              <a:t>validate</a:t>
             </a:r>
             <a:endParaRPr lang="en-US" sz="1000" dirty="0"/>
           </a:p>
@@ -22381,8 +22618,8 @@
         </p:nvSpPr>
         <p:spPr>
           <a:xfrm>
-            <a:off x="5473192" y="5138928"/>
-            <a:ext cx="813816" cy="256032"/>
+            <a:off x="6727952" y="5138928"/>
+            <a:ext cx="681736" cy="256032"/>
           </a:xfrm>
           <a:prstGeom prst="roundRect">
             <a:avLst>
@@ -22408,8 +22645,8 @@
         </p:nvSpPr>
         <p:spPr>
           <a:xfrm>
-            <a:off x="5473192" y="5138928"/>
-            <a:ext cx="813816" cy="256032"/>
+            <a:off x="6727952" y="5138928"/>
+            <a:ext cx="681736" cy="256032"/>
           </a:xfrm>
           <a:prstGeom prst="rect">
             <a:avLst/>
@@ -22433,7 +22670,7 @@
                 <a:ea typeface="Calibri" pitchFamily="34" charset="-122"/>
                 <a:cs typeface="Calibri" pitchFamily="34" charset="-120"/>
               </a:rPr>
-              <a:t>dashboard</a:t>
+              <a:t>archive</a:t>
             </a:r>
             <a:endParaRPr lang="en-US" sz="1000" dirty="0"/>
           </a:p>
@@ -22447,8 +22684,8 @@
         </p:nvSpPr>
         <p:spPr>
           <a:xfrm>
-            <a:off x="6378448" y="5138928"/>
-            <a:ext cx="417576" cy="256032"/>
+            <a:off x="7501128" y="5138928"/>
+            <a:ext cx="549656" cy="256032"/>
           </a:xfrm>
           <a:prstGeom prst="roundRect">
             <a:avLst>
@@ -22474,8 +22711,8 @@
         </p:nvSpPr>
         <p:spPr>
           <a:xfrm>
-            <a:off x="6378448" y="5138928"/>
-            <a:ext cx="417576" cy="256032"/>
+            <a:off x="7501128" y="5138928"/>
+            <a:ext cx="549656" cy="256032"/>
           </a:xfrm>
           <a:prstGeom prst="rect">
             <a:avLst/>
@@ -22499,7 +22736,7 @@
                 <a:ea typeface="Calibri" pitchFamily="34" charset="-122"/>
                 <a:cs typeface="Calibri" pitchFamily="34" charset="-120"/>
               </a:rPr>
-              <a:t>log</a:t>
+              <a:t>audit</a:t>
             </a:r>
             <a:endParaRPr lang="en-US" sz="1000" dirty="0"/>
           </a:p>
@@ -22513,8 +22750,8 @@
         </p:nvSpPr>
         <p:spPr>
           <a:xfrm>
-            <a:off x="6887464" y="5138928"/>
-            <a:ext cx="681736" cy="256032"/>
+            <a:off x="8142224" y="5138928"/>
+            <a:ext cx="615696" cy="256032"/>
           </a:xfrm>
           <a:prstGeom prst="roundRect">
             <a:avLst>
@@ -22540,8 +22777,8 @@
         </p:nvSpPr>
         <p:spPr>
           <a:xfrm>
-            <a:off x="6887464" y="5138928"/>
-            <a:ext cx="681736" cy="256032"/>
+            <a:off x="8142224" y="5138928"/>
+            <a:ext cx="615696" cy="256032"/>
           </a:xfrm>
           <a:prstGeom prst="rect">
             <a:avLst/>
@@ -22565,7 +22802,7 @@
                 <a:ea typeface="Calibri" pitchFamily="34" charset="-122"/>
                 <a:cs typeface="Calibri" pitchFamily="34" charset="-120"/>
               </a:rPr>
-              <a:t>license</a:t>
+              <a:t>report</a:t>
             </a:r>
             <a:endParaRPr lang="en-US" sz="1000" dirty="0"/>
           </a:p>
@@ -22579,8 +22816,8 @@
         </p:nvSpPr>
         <p:spPr>
           <a:xfrm>
-            <a:off x="7660640" y="5138928"/>
-            <a:ext cx="615696" cy="256032"/>
+            <a:off x="8849360" y="5138928"/>
+            <a:ext cx="813816" cy="256032"/>
           </a:xfrm>
           <a:prstGeom prst="roundRect">
             <a:avLst>
@@ -22606,8 +22843,8 @@
         </p:nvSpPr>
         <p:spPr>
           <a:xfrm>
-            <a:off x="7660640" y="5138928"/>
-            <a:ext cx="615696" cy="256032"/>
+            <a:off x="8849360" y="5138928"/>
+            <a:ext cx="813816" cy="256032"/>
           </a:xfrm>
           <a:prstGeom prst="rect">
             <a:avLst/>
@@ -22631,7 +22868,7 @@
                 <a:ea typeface="Calibri" pitchFamily="34" charset="-122"/>
                 <a:cs typeface="Calibri" pitchFamily="34" charset="-120"/>
               </a:rPr>
-              <a:t>doctor</a:t>
+              <a:t>dashboard</a:t>
             </a:r>
             <a:endParaRPr lang="en-US" sz="1000" dirty="0"/>
           </a:p>
@@ -22645,8 +22882,8 @@
         </p:nvSpPr>
         <p:spPr>
           <a:xfrm>
-            <a:off x="8367776" y="5138928"/>
-            <a:ext cx="1011936" cy="256032"/>
+            <a:off x="9754616" y="5138928"/>
+            <a:ext cx="417576" cy="256032"/>
           </a:xfrm>
           <a:prstGeom prst="roundRect">
             <a:avLst>
@@ -22672,8 +22909,8 @@
         </p:nvSpPr>
         <p:spPr>
           <a:xfrm>
-            <a:off x="8367776" y="5138928"/>
-            <a:ext cx="1011936" cy="256032"/>
+            <a:off x="9754616" y="5138928"/>
+            <a:ext cx="417576" cy="256032"/>
           </a:xfrm>
           <a:prstGeom prst="rect">
             <a:avLst/>
@@ -22697,7 +22934,7 @@
                 <a:ea typeface="Calibri" pitchFamily="34" charset="-122"/>
                 <a:cs typeface="Calibri" pitchFamily="34" charset="-120"/>
               </a:rPr>
-              <a:t>plugin build</a:t>
+              <a:t>log</a:t>
             </a:r>
             <a:endParaRPr lang="en-US" sz="1000" dirty="0"/>
           </a:p>
@@ -22711,8 +22948,8 @@
         </p:nvSpPr>
         <p:spPr>
           <a:xfrm>
-            <a:off x="9471152" y="5138928"/>
-            <a:ext cx="549656" cy="256032"/>
+            <a:off x="10263632" y="5138928"/>
+            <a:ext cx="681736" cy="256032"/>
           </a:xfrm>
           <a:prstGeom prst="roundRect">
             <a:avLst>
@@ -22738,8 +22975,8 @@
         </p:nvSpPr>
         <p:spPr>
           <a:xfrm>
-            <a:off x="9471152" y="5138928"/>
-            <a:ext cx="549656" cy="256032"/>
+            <a:off x="10263632" y="5138928"/>
+            <a:ext cx="681736" cy="256032"/>
           </a:xfrm>
           <a:prstGeom prst="rect">
             <a:avLst/>
@@ -22763,7 +23000,7 @@
                 <a:ea typeface="Calibri" pitchFamily="34" charset="-122"/>
                 <a:cs typeface="Calibri" pitchFamily="34" charset="-120"/>
               </a:rPr>
-              <a:t>trace</a:t>
+              <a:t>license</a:t>
             </a:r>
             <a:endParaRPr lang="en-US" sz="1000" dirty="0"/>
           </a:p>
@@ -22777,8 +23014,8 @@
         </p:nvSpPr>
         <p:spPr>
           <a:xfrm>
-            <a:off x="10112248" y="5138928"/>
-            <a:ext cx="483616" cy="256032"/>
+            <a:off x="11036808" y="5138928"/>
+            <a:ext cx="615696" cy="256032"/>
           </a:xfrm>
           <a:prstGeom prst="roundRect">
             <a:avLst>
@@ -22804,8 +23041,8 @@
         </p:nvSpPr>
         <p:spPr>
           <a:xfrm>
-            <a:off x="10112248" y="5138928"/>
-            <a:ext cx="483616" cy="256032"/>
+            <a:off x="11036808" y="5138928"/>
+            <a:ext cx="615696" cy="256032"/>
           </a:xfrm>
           <a:prstGeom prst="rect">
             <a:avLst/>
@@ -22829,7 +23066,7 @@
                 <a:ea typeface="Calibri" pitchFamily="34" charset="-122"/>
                 <a:cs typeface="Calibri" pitchFamily="34" charset="-120"/>
               </a:rPr>
-              <a:t>hook</a:t>
+              <a:t>doctor</a:t>
             </a:r>
             <a:endParaRPr lang="en-US" sz="1000" dirty="0"/>
           </a:p>
@@ -22843,8 +23080,8 @@
         </p:nvSpPr>
         <p:spPr>
           <a:xfrm>
-            <a:off x="10687304" y="5138928"/>
-            <a:ext cx="747776" cy="256032"/>
+            <a:off x="457200" y="5486400"/>
+            <a:ext cx="1011936" cy="256032"/>
           </a:xfrm>
           <a:prstGeom prst="roundRect">
             <a:avLst>
@@ -22870,7 +23107,205 @@
         </p:nvSpPr>
         <p:spPr>
           <a:xfrm>
-            <a:off x="10687304" y="5138928"/>
+            <a:off x="457200" y="5486400"/>
+            <a:ext cx="1011936" cy="256032"/>
+          </a:xfrm>
+          <a:prstGeom prst="rect">
+            <a:avLst/>
+          </a:prstGeom>
+          <a:noFill/>
+          <a:ln/>
+        </p:spPr>
+        <p:txBody>
+          <a:bodyPr wrap="square" lIns="0" tIns="0" rIns="0" bIns="0" rtlCol="0" anchor="ctr"/>
+          <a:lstStyle/>
+          <a:p>
+            <a:pPr algn="ctr" indent="0" marL="0">
+              <a:buNone/>
+            </a:pPr>
+            <a:r>
+              <a:rPr lang="en-US" sz="1000" dirty="0">
+                <a:solidFill>
+                  <a:srgbClr val="1F2430"/>
+                </a:solidFill>
+                <a:latin typeface="Calibri" pitchFamily="34" charset="0"/>
+                <a:ea typeface="Calibri" pitchFamily="34" charset="-122"/>
+                <a:cs typeface="Calibri" pitchFamily="34" charset="-120"/>
+              </a:rPr>
+              <a:t>plugin build</a:t>
+            </a:r>
+            <a:endParaRPr lang="en-US" sz="1000" dirty="0"/>
+          </a:p>
+        </p:txBody>
+      </p:sp>
+      <p:sp>
+        <p:nvSpPr>
+          <p:cNvPr id="136" name="Shape 134"/>
+          <p:cNvSpPr/>
+          <p:nvPr/>
+        </p:nvSpPr>
+        <p:spPr>
+          <a:xfrm>
+            <a:off x="1560576" y="5486400"/>
+            <a:ext cx="549656" cy="256032"/>
+          </a:xfrm>
+          <a:prstGeom prst="roundRect">
+            <a:avLst>
+              <a:gd name="adj" fmla="val 50000"/>
+            </a:avLst>
+          </a:prstGeom>
+          <a:solidFill>
+            <a:srgbClr val="F3F5F8"/>
+          </a:solidFill>
+          <a:ln w="12700">
+            <a:solidFill>
+              <a:srgbClr val="F3F5F8"/>
+            </a:solidFill>
+            <a:prstDash val="solid"/>
+          </a:ln>
+        </p:spPr>
+      </p:sp>
+      <p:sp>
+        <p:nvSpPr>
+          <p:cNvPr id="137" name="Text 135"/>
+          <p:cNvSpPr txBox="1"/>
+          <p:nvPr/>
+        </p:nvSpPr>
+        <p:spPr>
+          <a:xfrm>
+            <a:off x="1560576" y="5486400"/>
+            <a:ext cx="549656" cy="256032"/>
+          </a:xfrm>
+          <a:prstGeom prst="rect">
+            <a:avLst/>
+          </a:prstGeom>
+          <a:noFill/>
+          <a:ln/>
+        </p:spPr>
+        <p:txBody>
+          <a:bodyPr wrap="square" lIns="0" tIns="0" rIns="0" bIns="0" rtlCol="0" anchor="ctr"/>
+          <a:lstStyle/>
+          <a:p>
+            <a:pPr algn="ctr" indent="0" marL="0">
+              <a:buNone/>
+            </a:pPr>
+            <a:r>
+              <a:rPr lang="en-US" sz="1000" dirty="0">
+                <a:solidFill>
+                  <a:srgbClr val="1F2430"/>
+                </a:solidFill>
+                <a:latin typeface="Calibri" pitchFamily="34" charset="0"/>
+                <a:ea typeface="Calibri" pitchFamily="34" charset="-122"/>
+                <a:cs typeface="Calibri" pitchFamily="34" charset="-120"/>
+              </a:rPr>
+              <a:t>trace</a:t>
+            </a:r>
+            <a:endParaRPr lang="en-US" sz="1000" dirty="0"/>
+          </a:p>
+        </p:txBody>
+      </p:sp>
+      <p:sp>
+        <p:nvSpPr>
+          <p:cNvPr id="138" name="Shape 136"/>
+          <p:cNvSpPr/>
+          <p:nvPr/>
+        </p:nvSpPr>
+        <p:spPr>
+          <a:xfrm>
+            <a:off x="2201672" y="5486400"/>
+            <a:ext cx="483616" cy="256032"/>
+          </a:xfrm>
+          <a:prstGeom prst="roundRect">
+            <a:avLst>
+              <a:gd name="adj" fmla="val 50000"/>
+            </a:avLst>
+          </a:prstGeom>
+          <a:solidFill>
+            <a:srgbClr val="F3F5F8"/>
+          </a:solidFill>
+          <a:ln w="12700">
+            <a:solidFill>
+              <a:srgbClr val="F3F5F8"/>
+            </a:solidFill>
+            <a:prstDash val="solid"/>
+          </a:ln>
+        </p:spPr>
+      </p:sp>
+      <p:sp>
+        <p:nvSpPr>
+          <p:cNvPr id="139" name="Text 137"/>
+          <p:cNvSpPr txBox="1"/>
+          <p:nvPr/>
+        </p:nvSpPr>
+        <p:spPr>
+          <a:xfrm>
+            <a:off x="2201672" y="5486400"/>
+            <a:ext cx="483616" cy="256032"/>
+          </a:xfrm>
+          <a:prstGeom prst="rect">
+            <a:avLst/>
+          </a:prstGeom>
+          <a:noFill/>
+          <a:ln/>
+        </p:spPr>
+        <p:txBody>
+          <a:bodyPr wrap="square" lIns="0" tIns="0" rIns="0" bIns="0" rtlCol="0" anchor="ctr"/>
+          <a:lstStyle/>
+          <a:p>
+            <a:pPr algn="ctr" indent="0" marL="0">
+              <a:buNone/>
+            </a:pPr>
+            <a:r>
+              <a:rPr lang="en-US" sz="1000" dirty="0">
+                <a:solidFill>
+                  <a:srgbClr val="1F2430"/>
+                </a:solidFill>
+                <a:latin typeface="Calibri" pitchFamily="34" charset="0"/>
+                <a:ea typeface="Calibri" pitchFamily="34" charset="-122"/>
+                <a:cs typeface="Calibri" pitchFamily="34" charset="-120"/>
+              </a:rPr>
+              <a:t>hook</a:t>
+            </a:r>
+            <a:endParaRPr lang="en-US" sz="1000" dirty="0"/>
+          </a:p>
+        </p:txBody>
+      </p:sp>
+      <p:sp>
+        <p:nvSpPr>
+          <p:cNvPr id="140" name="Shape 138"/>
+          <p:cNvSpPr/>
+          <p:nvPr/>
+        </p:nvSpPr>
+        <p:spPr>
+          <a:xfrm>
+            <a:off x="2776728" y="5486400"/>
+            <a:ext cx="747776" cy="256032"/>
+          </a:xfrm>
+          <a:prstGeom prst="roundRect">
+            <a:avLst>
+              <a:gd name="adj" fmla="val 50000"/>
+            </a:avLst>
+          </a:prstGeom>
+          <a:solidFill>
+            <a:srgbClr val="F3F5F8"/>
+          </a:solidFill>
+          <a:ln w="12700">
+            <a:solidFill>
+              <a:srgbClr val="F3F5F8"/>
+            </a:solidFill>
+            <a:prstDash val="solid"/>
+          </a:ln>
+        </p:spPr>
+      </p:sp>
+      <p:sp>
+        <p:nvSpPr>
+          <p:cNvPr id="141" name="Text 139"/>
+          <p:cNvSpPr txBox="1"/>
+          <p:nvPr/>
+        </p:nvSpPr>
+        <p:spPr>
+          <a:xfrm>
+            <a:off x="2776728" y="5486400"/>
             <a:ext cx="747776" cy="256032"/>
           </a:xfrm>
           <a:prstGeom prst="rect">
@@ -25541,7 +25976,7 @@
                 <a:ea typeface="Courier New" pitchFamily="34" charset="-122"/>
                 <a:cs typeface="Courier New" pitchFamily="34" charset="-120"/>
               </a:rPr>
-              <a:t>  sdlc 0.9.1, license: community</a:t>
+              <a:t>  sdlc 0.10.0, license: community</a:t>
             </a:r>
             <a:endParaRPr lang="en-US" sz="1000" dirty="0"/>
           </a:p>

</xml_diff>

<commit_message>
feat: the agent team - role agents adapted to the project (0.11.0)
- Role agents (analyst, architect, developer, tester, reviewer) live in
  docs/agents/<role>.md and are generated as subagents for Claude Code
  and OpenCode, wired to their stages. sdlc adds where each role writes
  and the project's facts (checks, protected paths, people, documents),
  so roles follow the project.
- sdlc team sync takes roles and skills from the team's MCP registry,
  then from git or npm packs (no code of a pack runs), then from the
  built-in set, as drafts; /sdlc:team drafts the project's rules into
  each role from the code or the idea.
- sdlc team accept is a person's command; skills install only with a
  matching checksum, those with scripts only after a person accepts them;
  sdlc team check reports every skill.
- Agents can no longer edit the files sdlc generates for them, accepted
  roles or team skills.
</commit_message>
<xml_diff>
--- a/docs/demo/sdlc-calculator-demo.en.pptx
+++ b/docs/demo/sdlc-calculator-demo.en.pptx
@@ -1072,7 +1072,8 @@
 sdlc approve intent --change basic-arithmetic — Bob is not the product owner.
 sdlc validate --change basic-arithmetic — The first draft has a requirement without a scenario: strict validation refuses it.
 sdlc approve review --change basic-arithmetic — Bob is the author: refused.
-sdlc tests unlock --change fix-rounding — Unlocking is a person's decision.</a:t>
+sdlc tests unlock --change fix-rounding — Unlocking is a person's decision.
+sdlc team accept tester — What a role says is a person's decision: refused for the agent.</a:t>
             </a:r>
             <a:endParaRPr lang="en-US" dirty="0"/>
           </a:p>
@@ -6658,7 +6659,7 @@
                 <a:ea typeface="Courier New" pitchFamily="34" charset="-122"/>
                 <a:cs typeface="Courier New" pitchFamily="34" charset="-120"/>
               </a:rPr>
-              <a:t>  code-owner (e1ad15ea9d87)</a:t>
+              <a:t>  code-owner (794602e2105c)</a:t>
             </a:r>
             <a:endParaRPr lang="en-US" sz="1000" dirty="0"/>
           </a:p>
@@ -7339,7 +7340,7 @@
                 <a:ea typeface="Courier New" pitchFamily="34" charset="-122"/>
                 <a:cs typeface="Courier New" pitchFamily="34" charset="-120"/>
               </a:rPr>
-              <a:t>  release-manager (e1ad15ea9d87)</a:t>
+              <a:t>  release-manager (794602e2105c)</a:t>
             </a:r>
             <a:endParaRPr lang="en-US" sz="1000" dirty="0"/>
           </a:p>
@@ -7639,7 +7640,7 @@
                 <a:ea typeface="Courier New" pitchFamily="34" charset="-122"/>
                 <a:cs typeface="Courier New" pitchFamily="34" charset="-120"/>
               </a:rPr>
-              <a:t>✓ basic-arithmetic/intent alice valid c5112f50</a:t>
+              <a:t>✓ basic-arithmetic/intent alice valid 2b809052</a:t>
             </a:r>
             <a:endParaRPr lang="en-US" sz="1000" dirty="0"/>
           </a:p>
@@ -7656,7 +7657,7 @@
                 <a:ea typeface="Courier New" pitchFamily="34" charset="-122"/>
                 <a:cs typeface="Courier New" pitchFamily="34" charset="-120"/>
               </a:rPr>
-              <a:t>✓ basic-arithmetic/spec alice valid e4689e12</a:t>
+              <a:t>✓ basic-arithmetic/spec alice valid 2bef4479</a:t>
             </a:r>
             <a:endParaRPr lang="en-US" sz="1000" dirty="0"/>
           </a:p>
@@ -7673,7 +7674,7 @@
                 <a:ea typeface="Courier New" pitchFamily="34" charset="-122"/>
                 <a:cs typeface="Courier New" pitchFamily="34" charset="-120"/>
               </a:rPr>
-              <a:t>✗ basic-arithmetic/plan bob wrong-signer e4689e12</a:t>
+              <a:t>✗ basic-arithmetic/plan bob wrong-signer 2bef4479</a:t>
             </a:r>
             <a:endParaRPr lang="en-US" sz="1000" dirty="0"/>
           </a:p>
@@ -7690,7 +7691,7 @@
                 <a:ea typeface="Courier New" pitchFamily="34" charset="-122"/>
                 <a:cs typeface="Courier New" pitchFamily="34" charset="-120"/>
               </a:rPr>
-              <a:t>✓ basic-arithmetic/review carol valid 91e4cc39</a:t>
+              <a:t>✓ basic-arithmetic/review carol valid 8f916d32</a:t>
             </a:r>
             <a:endParaRPr lang="en-US" sz="1000" dirty="0"/>
           </a:p>
@@ -7707,7 +7708,7 @@
                 <a:ea typeface="Courier New" pitchFamily="34" charset="-122"/>
                 <a:cs typeface="Courier New" pitchFamily="34" charset="-120"/>
               </a:rPr>
-              <a:t>✓ basic-arithmetic/release alice valid 2160d122</a:t>
+              <a:t>✓ basic-arithmetic/release alice valid ea758646</a:t>
             </a:r>
             <a:endParaRPr lang="en-US" sz="1000" dirty="0"/>
           </a:p>
@@ -7724,7 +7725,7 @@
                 <a:ea typeface="Courier New" pitchFamily="34" charset="-122"/>
                 <a:cs typeface="Courier New" pitchFamily="34" charset="-120"/>
               </a:rPr>
-              <a:t>✓ openspec/roles.yaml alice@calc.example valid 3894ed3d</a:t>
+              <a:t>✓ openspec/roles.yaml alice@calc.example valid 6514c2cc</a:t>
             </a:r>
             <a:endParaRPr lang="en-US" sz="1000" dirty="0"/>
           </a:p>
@@ -11361,6 +11362,216 @@
           </a:p>
         </p:txBody>
       </p:sp>
+      <p:sp>
+        <p:nvSpPr>
+          <p:cNvPr id="58" name="Shape 56"/>
+          <p:cNvSpPr/>
+          <p:nvPr/>
+        </p:nvSpPr>
+        <p:spPr>
+          <a:xfrm>
+            <a:off x="6231636" y="4791456"/>
+            <a:ext cx="5500116" cy="676656"/>
+          </a:xfrm>
+          <a:prstGeom prst="roundRect">
+            <a:avLst>
+              <a:gd name="adj" fmla="val 10811"/>
+            </a:avLst>
+          </a:prstGeom>
+          <a:solidFill>
+            <a:srgbClr val="F3F5F8"/>
+          </a:solidFill>
+          <a:ln w="12700">
+            <a:solidFill>
+              <a:srgbClr val="F3F5F8"/>
+            </a:solidFill>
+            <a:prstDash val="solid"/>
+          </a:ln>
+        </p:spPr>
+      </p:sp>
+      <p:sp>
+        <p:nvSpPr>
+          <p:cNvPr id="59" name="Text 57"/>
+          <p:cNvSpPr txBox="1"/>
+          <p:nvPr/>
+        </p:nvSpPr>
+        <p:spPr>
+          <a:xfrm>
+            <a:off x="6341364" y="4864608"/>
+            <a:ext cx="274320" cy="274320"/>
+          </a:xfrm>
+          <a:prstGeom prst="rect">
+            <a:avLst/>
+          </a:prstGeom>
+          <a:noFill/>
+          <a:ln/>
+        </p:spPr>
+        <p:txBody>
+          <a:bodyPr wrap="square" lIns="0" tIns="0" rIns="0" bIns="0" rtlCol="0" anchor="ctr"/>
+          <a:lstStyle/>
+          <a:p>
+            <a:pPr indent="0" marL="0">
+              <a:buNone/>
+            </a:pPr>
+            <a:r>
+              <a:rPr lang="en-US" sz="1600" b="1" dirty="0">
+                <a:solidFill>
+                  <a:srgbClr val="D64545"/>
+                </a:solidFill>
+                <a:latin typeface="Calibri" pitchFamily="34" charset="0"/>
+                <a:ea typeface="Calibri" pitchFamily="34" charset="-122"/>
+                <a:cs typeface="Calibri" pitchFamily="34" charset="-120"/>
+              </a:rPr>
+              <a:t>✗</a:t>
+            </a:r>
+            <a:endParaRPr lang="en-US" sz="1600" dirty="0"/>
+          </a:p>
+        </p:txBody>
+      </p:sp>
+      <p:sp>
+        <p:nvSpPr>
+          <p:cNvPr id="60" name="Shape 58"/>
+          <p:cNvSpPr/>
+          <p:nvPr/>
+        </p:nvSpPr>
+        <p:spPr>
+          <a:xfrm>
+            <a:off x="6643116" y="4873752"/>
+            <a:ext cx="1097280" cy="256032"/>
+          </a:xfrm>
+          <a:prstGeom prst="roundRect">
+            <a:avLst>
+              <a:gd name="adj" fmla="val 50000"/>
+            </a:avLst>
+          </a:prstGeom>
+          <a:solidFill>
+            <a:srgbClr val="F2A541"/>
+          </a:solidFill>
+          <a:ln w="12700">
+            <a:solidFill>
+              <a:srgbClr val="F2A541"/>
+            </a:solidFill>
+            <a:prstDash val="solid"/>
+          </a:ln>
+        </p:spPr>
+      </p:sp>
+      <p:sp>
+        <p:nvSpPr>
+          <p:cNvPr id="61" name="Text 59"/>
+          <p:cNvSpPr txBox="1"/>
+          <p:nvPr/>
+        </p:nvSpPr>
+        <p:spPr>
+          <a:xfrm>
+            <a:off x="6643116" y="4873752"/>
+            <a:ext cx="1097280" cy="256032"/>
+          </a:xfrm>
+          <a:prstGeom prst="rect">
+            <a:avLst/>
+          </a:prstGeom>
+          <a:noFill/>
+          <a:ln/>
+        </p:spPr>
+        <p:txBody>
+          <a:bodyPr wrap="square" lIns="0" tIns="0" rIns="0" bIns="0" rtlCol="0" anchor="ctr"/>
+          <a:lstStyle/>
+          <a:p>
+            <a:pPr algn="ctr" indent="0" marL="0">
+              <a:buNone/>
+            </a:pPr>
+            <a:r>
+              <a:rPr lang="en-US" sz="1100" b="1" dirty="0">
+                <a:solidFill>
+                  <a:srgbClr val="FFFFFF"/>
+                </a:solidFill>
+                <a:latin typeface="Calibri" pitchFamily="34" charset="0"/>
+                <a:ea typeface="Calibri" pitchFamily="34" charset="-122"/>
+                <a:cs typeface="Calibri" pitchFamily="34" charset="-120"/>
+              </a:rPr>
+              <a:t>AI agent</a:t>
+            </a:r>
+            <a:endParaRPr lang="en-US" sz="1100" dirty="0"/>
+          </a:p>
+        </p:txBody>
+      </p:sp>
+      <p:sp>
+        <p:nvSpPr>
+          <p:cNvPr id="62" name="Text 60"/>
+          <p:cNvSpPr txBox="1"/>
+          <p:nvPr/>
+        </p:nvSpPr>
+        <p:spPr>
+          <a:xfrm>
+            <a:off x="7831836" y="4864608"/>
+            <a:ext cx="3808476" cy="274320"/>
+          </a:xfrm>
+          <a:prstGeom prst="rect">
+            <a:avLst/>
+          </a:prstGeom>
+          <a:noFill/>
+          <a:ln/>
+        </p:spPr>
+        <p:txBody>
+          <a:bodyPr wrap="square" lIns="0" tIns="0" rIns="0" bIns="0" rtlCol="0" anchor="ctr"/>
+          <a:lstStyle/>
+          <a:p>
+            <a:pPr indent="0" marL="0">
+              <a:buNone/>
+            </a:pPr>
+            <a:r>
+              <a:rPr lang="en-US" sz="1100" dirty="0">
+                <a:solidFill>
+                  <a:srgbClr val="1F2430"/>
+                </a:solidFill>
+                <a:latin typeface="Courier New" pitchFamily="34" charset="0"/>
+                <a:ea typeface="Courier New" pitchFamily="34" charset="-122"/>
+                <a:cs typeface="Courier New" pitchFamily="34" charset="-120"/>
+              </a:rPr>
+              <a:t>sdlc team accept tester</a:t>
+            </a:r>
+            <a:endParaRPr lang="en-US" sz="1100" dirty="0"/>
+          </a:p>
+        </p:txBody>
+      </p:sp>
+      <p:sp>
+        <p:nvSpPr>
+          <p:cNvPr id="63" name="Text 61"/>
+          <p:cNvSpPr txBox="1"/>
+          <p:nvPr/>
+        </p:nvSpPr>
+        <p:spPr>
+          <a:xfrm>
+            <a:off x="6643116" y="5175504"/>
+            <a:ext cx="4951476" cy="237744"/>
+          </a:xfrm>
+          <a:prstGeom prst="rect">
+            <a:avLst/>
+          </a:prstGeom>
+          <a:noFill/>
+          <a:ln/>
+        </p:spPr>
+        <p:txBody>
+          <a:bodyPr wrap="square" lIns="0" tIns="0" rIns="0" bIns="0" rtlCol="0" anchor="ctr"/>
+          <a:lstStyle/>
+          <a:p>
+            <a:pPr indent="0" marL="0">
+              <a:buNone/>
+            </a:pPr>
+            <a:r>
+              <a:rPr lang="en-US" sz="1100" dirty="0">
+                <a:solidFill>
+                  <a:srgbClr val="D64545"/>
+                </a:solidFill>
+                <a:latin typeface="Calibri" pitchFamily="34" charset="0"/>
+                <a:ea typeface="Calibri" pitchFamily="34" charset="-122"/>
+                <a:cs typeface="Calibri" pitchFamily="34" charset="-120"/>
+              </a:rPr>
+              <a:t>`sdlc team accept` records a human decision and cannot run inside an …</a:t>
+            </a:r>
+            <a:endParaRPr lang="en-US" sz="1100" dirty="0"/>
+          </a:p>
+        </p:txBody>
+      </p:sp>
     </p:spTree>
   </p:cSld>
   <p:clrMapOvr>
@@ -13934,7 +14145,7 @@
                 <a:ea typeface="Courier New" pitchFamily="34" charset="-122"/>
                 <a:cs typeface="Courier New" pitchFamily="34" charset="-120"/>
               </a:rPr>
-              <a:t>  archived) · sdlc 0.10.0, license:</a:t>
+              <a:t>  archived) · sdlc 0.11.0, license:</a:t>
             </a:r>
             <a:endParaRPr lang="en-US" sz="1000" dirty="0"/>
           </a:p>
@@ -14087,7 +14298,7 @@
                 <a:ea typeface="Courier New" pitchFamily="34" charset="-122"/>
                 <a:cs typeface="Courier New" pitchFamily="34" charset="-120"/>
               </a:rPr>
-              <a:t>  intent 3 · spec 9 · plan 9 · review 3;</a:t>
+              <a:t>  intent 4 · spec 9 · plan 9 · review 3;</a:t>
             </a:r>
             <a:endParaRPr lang="en-US" sz="1000" dirty="0"/>
           </a:p>
@@ -14121,7 +14332,7 @@
                 <a:ea typeface="Courier New" pitchFamily="34" charset="-122"/>
                 <a:cs typeface="Courier New" pitchFamily="34" charset="-120"/>
               </a:rPr>
-              <a:t>  recorded with sdlc 0.10.0; licenses:</a:t>
+              <a:t>  recorded with sdlc 0.11.0; licenses:</a:t>
             </a:r>
             <a:endParaRPr lang="en-US" sz="1000" dirty="0"/>
           </a:p>
@@ -14438,7 +14649,7 @@
                 <a:ea typeface="Courier New" pitchFamily="34" charset="-122"/>
                 <a:cs typeface="Courier New" pitchFamily="34" charset="-120"/>
               </a:rPr>
-              <a:t>2026-10-07T13:36:22.758Z  gate.review.await</a:t>
+              <a:t>2026-10-07T20:04:38.093Z  gate.review.await</a:t>
             </a:r>
             <a:endParaRPr lang="en-US" sz="1000" dirty="0"/>
           </a:p>
@@ -14472,7 +14683,7 @@
                 <a:ea typeface="Courier New" pitchFamily="34" charset="-122"/>
                 <a:cs typeface="Courier New" pitchFamily="34" charset="-120"/>
               </a:rPr>
-              <a:t>  sha256:e1ad15ea9d87bf2b7858610d3286b407cf</a:t>
+              <a:t>  sha256:794602e2105c13b0465c4edcf3dd269ebf</a:t>
             </a:r>
             <a:endParaRPr lang="en-US" sz="1000" dirty="0"/>
           </a:p>
@@ -14489,7 +14700,7 @@
                 <a:ea typeface="Courier New" pitchFamily="34" charset="-122"/>
                 <a:cs typeface="Courier New" pitchFamily="34" charset="-120"/>
               </a:rPr>
-              <a:t>  7dad20136ebebb77a89d1a2b19ffc1 [sdlc</a:t>
+              <a:t>  3d7dc4ac9ee2d9aee4f1ea229023ec [sdlc</a:t>
             </a:r>
             <a:endParaRPr lang="en-US" sz="1000" dirty="0"/>
           </a:p>
@@ -14506,7 +14717,7 @@
                 <a:ea typeface="Courier New" pitchFamily="34" charset="-122"/>
                 <a:cs typeface="Courier New" pitchFamily="34" charset="-120"/>
               </a:rPr>
-              <a:t>  0.10.0 · community]</a:t>
+              <a:t>  0.11.0 · community]</a:t>
             </a:r>
             <a:endParaRPr lang="en-US" sz="1000" dirty="0"/>
           </a:p>
@@ -14523,7 +14734,7 @@
                 <a:ea typeface="Courier New" pitchFamily="34" charset="-122"/>
                 <a:cs typeface="Courier New" pitchFamily="34" charset="-120"/>
               </a:rPr>
-              <a:t>2026-10-07T13:36:25.643Z  gate.review.appro</a:t>
+              <a:t>2026-10-07T20:04:41.234Z  gate.review.appro</a:t>
             </a:r>
             <a:endParaRPr lang="en-US" sz="1000" dirty="0"/>
           </a:p>
@@ -14574,7 +14785,7 @@
                 <a:ea typeface="Courier New" pitchFamily="34" charset="-122"/>
                 <a:cs typeface="Courier New" pitchFamily="34" charset="-120"/>
               </a:rPr>
-              <a:t>  [sdlc 0.10.0 · community]</a:t>
+              <a:t>  [sdlc 0.11.0 · community]</a:t>
             </a:r>
             <a:endParaRPr lang="en-US" sz="1000" dirty="0"/>
           </a:p>
@@ -14591,7 +14802,7 @@
                 <a:ea typeface="Courier New" pitchFamily="34" charset="-122"/>
                 <a:cs typeface="Courier New" pitchFamily="34" charset="-120"/>
               </a:rPr>
-              <a:t>2026-10-07T13:36:30.395Z  gate.release.appr</a:t>
+              <a:t>2026-10-07T20:04:45.854Z  gate.release.appr</a:t>
             </a:r>
             <a:endParaRPr lang="en-US" sz="1000" dirty="0"/>
           </a:p>
@@ -14642,7 +14853,7 @@
                 <a:ea typeface="Courier New" pitchFamily="34" charset="-122"/>
                 <a:cs typeface="Courier New" pitchFamily="34" charset="-120"/>
               </a:rPr>
-              <a:t>  release-manager [sdlc 0.10.0 · community]</a:t>
+              <a:t>  release-manager [sdlc 0.11.0 · community]</a:t>
             </a:r>
             <a:endParaRPr lang="en-US" sz="1000" dirty="0"/>
           </a:p>
@@ -15819,7 +16030,7 @@
                 <a:ea typeface="Courier New" pitchFamily="34" charset="-122"/>
                 <a:cs typeface="Courier New" pitchFamily="34" charset="-120"/>
               </a:rPr>
-              <a:t>✓ test (1.4s)</a:t>
+              <a:t>✓ test (1.1s)</a:t>
             </a:r>
             <a:endParaRPr lang="en-US" sz="1000" dirty="0"/>
           </a:p>
@@ -15836,7 +16047,7 @@
                 <a:ea typeface="Courier New" pitchFamily="34" charset="-122"/>
                 <a:cs typeface="Courier New" pitchFamily="34" charset="-120"/>
               </a:rPr>
-              <a:t>✓ ci-green (ci/pipeline_status, 0.8s)</a:t>
+              <a:t>✓ ci-green (ci/pipeline_status, 0.6s)</a:t>
             </a:r>
             <a:endParaRPr lang="en-US" sz="1000" dirty="0"/>
           </a:p>
@@ -16272,7 +16483,7 @@
                 <a:ea typeface="Courier New" pitchFamily="34" charset="-122"/>
                 <a:cs typeface="Courier New" pitchFamily="34" charset="-120"/>
               </a:rPr>
-              <a:t>      "id": "20261007T133720640Z-ci-green-3</a:t>
+              <a:t>      "id": "20261007T200527818Z-ci-green-a</a:t>
             </a:r>
             <a:endParaRPr lang="en-US" sz="1000" dirty="0"/>
           </a:p>
@@ -16289,7 +16500,7 @@
                 <a:ea typeface="Courier New" pitchFamily="34" charset="-122"/>
                 <a:cs typeface="Courier New" pitchFamily="34" charset="-120"/>
               </a:rPr>
-              <a:t>  67431",</a:t>
+              <a:t>  b5c0d",</a:t>
             </a:r>
             <a:endParaRPr lang="en-US" sz="1000" dirty="0"/>
           </a:p>
@@ -16425,7 +16636,7 @@
                 <a:ea typeface="Courier New" pitchFamily="34" charset="-122"/>
                 <a:cs typeface="Courier New" pitchFamily="34" charset="-120"/>
               </a:rPr>
-              <a:t>        "ref": "981f0bffbaca6272e42788b096b</a:t>
+              <a:t>        "ref": "0b6a530445076524df168fb2551</a:t>
             </a:r>
             <a:endParaRPr lang="en-US" sz="1000" dirty="0"/>
           </a:p>
@@ -16442,7 +16653,7 @@
                 <a:ea typeface="Courier New" pitchFamily="34" charset="-122"/>
                 <a:cs typeface="Courier New" pitchFamily="34" charset="-120"/>
               </a:rPr>
-              <a:t>  a742e3fa1444e",</a:t>
+              <a:t>  fa0504e5a1ac4",</a:t>
             </a:r>
             <a:endParaRPr lang="en-US" sz="1000" dirty="0"/>
           </a:p>
@@ -18818,7 +19029,7 @@
                 <a:ea typeface="Cambria" pitchFamily="34" charset="-122"/>
                 <a:cs typeface="Cambria" pitchFamily="34" charset="-120"/>
               </a:rPr>
-              <a:t>94</a:t>
+              <a:t>99</a:t>
             </a:r>
             <a:endParaRPr lang="en-US" sz="6000" dirty="0"/>
           </a:p>
@@ -18923,7 +19134,7 @@
                 <a:ea typeface="Cambria" pitchFamily="34" charset="-122"/>
                 <a:cs typeface="Cambria" pitchFamily="34" charset="-120"/>
               </a:rPr>
-              <a:t>63</a:t>
+              <a:t>67</a:t>
             </a:r>
             <a:endParaRPr lang="en-US" sz="6000" dirty="0"/>
           </a:p>
@@ -18962,7 +19173,7 @@
                 <a:ea typeface="Calibri" pitchFamily="34" charset="-122"/>
                 <a:cs typeface="Calibri" pitchFamily="34" charset="-120"/>
               </a:rPr>
-              <a:t>of 63 commands</a:t>
+              <a:t>of 67 commands</a:t>
             </a:r>
             <a:endParaRPr lang="en-US" sz="1600" dirty="0"/>
           </a:p>
@@ -19028,7 +19239,7 @@
                 <a:ea typeface="Cambria" pitchFamily="34" charset="-122"/>
                 <a:cs typeface="Cambria" pitchFamily="34" charset="-120"/>
               </a:rPr>
-              <a:t>9</a:t>
+              <a:t>10</a:t>
             </a:r>
             <a:endParaRPr lang="en-US" sz="6000" dirty="0"/>
           </a:p>
@@ -19451,7 +19662,7 @@
         <p:spPr>
           <a:xfrm>
             <a:off x="4210304" y="3749040"/>
-            <a:ext cx="1276096" cy="256032"/>
+            <a:ext cx="813816" cy="256032"/>
           </a:xfrm>
           <a:prstGeom prst="roundRect">
             <a:avLst>
@@ -19478,7 +19689,7 @@
         <p:spPr>
           <a:xfrm>
             <a:off x="4210304" y="3749040"/>
-            <a:ext cx="1276096" cy="256032"/>
+            <a:ext cx="813816" cy="256032"/>
           </a:xfrm>
           <a:prstGeom prst="rect">
             <a:avLst/>
@@ -19502,7 +19713,7 @@
                 <a:ea typeface="Calibri" pitchFamily="34" charset="-122"/>
                 <a:cs typeface="Calibri" pitchFamily="34" charset="-120"/>
               </a:rPr>
-              <a:t>backlog epic add</a:t>
+              <a:t>team sync</a:t>
             </a:r>
             <a:endParaRPr lang="en-US" sz="1000" dirty="0"/>
           </a:p>
@@ -19516,8 +19727,8 @@
         </p:nvSpPr>
         <p:spPr>
           <a:xfrm>
-            <a:off x="5577840" y="3749040"/>
-            <a:ext cx="1342136" cy="256032"/>
+            <a:off x="5115560" y="3749040"/>
+            <a:ext cx="945896" cy="256032"/>
           </a:xfrm>
           <a:prstGeom prst="roundRect">
             <a:avLst>
@@ -19543,8 +19754,8 @@
         </p:nvSpPr>
         <p:spPr>
           <a:xfrm>
-            <a:off x="5577840" y="3749040"/>
-            <a:ext cx="1342136" cy="256032"/>
+            <a:off x="5115560" y="3749040"/>
+            <a:ext cx="945896" cy="256032"/>
           </a:xfrm>
           <a:prstGeom prst="rect">
             <a:avLst/>
@@ -19568,7 +19779,7 @@
                 <a:ea typeface="Calibri" pitchFamily="34" charset="-122"/>
                 <a:cs typeface="Calibri" pitchFamily="34" charset="-120"/>
               </a:rPr>
-              <a:t>backlog epic edit</a:t>
+              <a:t>team accept</a:t>
             </a:r>
             <a:endParaRPr lang="en-US" sz="1000" dirty="0"/>
           </a:p>
@@ -19582,8 +19793,8 @@
         </p:nvSpPr>
         <p:spPr>
           <a:xfrm>
-            <a:off x="7011416" y="3749040"/>
-            <a:ext cx="945896" cy="256032"/>
+            <a:off x="6152896" y="3749040"/>
+            <a:ext cx="813816" cy="256032"/>
           </a:xfrm>
           <a:prstGeom prst="roundRect">
             <a:avLst>
@@ -19609,8 +19820,8 @@
         </p:nvSpPr>
         <p:spPr>
           <a:xfrm>
-            <a:off x="7011416" y="3749040"/>
-            <a:ext cx="945896" cy="256032"/>
+            <a:off x="6152896" y="3749040"/>
+            <a:ext cx="813816" cy="256032"/>
           </a:xfrm>
           <a:prstGeom prst="rect">
             <a:avLst/>
@@ -19634,7 +19845,7 @@
                 <a:ea typeface="Calibri" pitchFamily="34" charset="-122"/>
                 <a:cs typeface="Calibri" pitchFamily="34" charset="-120"/>
               </a:rPr>
-              <a:t>backlog add</a:t>
+              <a:t>team list</a:t>
             </a:r>
             <a:endParaRPr lang="en-US" sz="1000" dirty="0"/>
           </a:p>
@@ -19648,8 +19859,8 @@
         </p:nvSpPr>
         <p:spPr>
           <a:xfrm>
-            <a:off x="8048752" y="3749040"/>
-            <a:ext cx="1011936" cy="256032"/>
+            <a:off x="7058152" y="3749040"/>
+            <a:ext cx="879856" cy="256032"/>
           </a:xfrm>
           <a:prstGeom prst="roundRect">
             <a:avLst>
@@ -19675,8 +19886,8 @@
         </p:nvSpPr>
         <p:spPr>
           <a:xfrm>
-            <a:off x="8048752" y="3749040"/>
-            <a:ext cx="1011936" cy="256032"/>
+            <a:off x="7058152" y="3749040"/>
+            <a:ext cx="879856" cy="256032"/>
           </a:xfrm>
           <a:prstGeom prst="rect">
             <a:avLst/>
@@ -19700,7 +19911,7 @@
                 <a:ea typeface="Calibri" pitchFamily="34" charset="-122"/>
                 <a:cs typeface="Calibri" pitchFamily="34" charset="-120"/>
               </a:rPr>
-              <a:t>backlog edit</a:t>
+              <a:t>team check</a:t>
             </a:r>
             <a:endParaRPr lang="en-US" sz="1000" dirty="0"/>
           </a:p>
@@ -19714,8 +19925,8 @@
         </p:nvSpPr>
         <p:spPr>
           <a:xfrm>
-            <a:off x="9152128" y="3749040"/>
-            <a:ext cx="1011936" cy="256032"/>
+            <a:off x="8029448" y="3749040"/>
+            <a:ext cx="1276096" cy="256032"/>
           </a:xfrm>
           <a:prstGeom prst="roundRect">
             <a:avLst>
@@ -19741,8 +19952,8 @@
         </p:nvSpPr>
         <p:spPr>
           <a:xfrm>
-            <a:off x="9152128" y="3749040"/>
-            <a:ext cx="1011936" cy="256032"/>
+            <a:off x="8029448" y="3749040"/>
+            <a:ext cx="1276096" cy="256032"/>
           </a:xfrm>
           <a:prstGeom prst="rect">
             <a:avLst/>
@@ -19766,7 +19977,7 @@
                 <a:ea typeface="Calibri" pitchFamily="34" charset="-122"/>
                 <a:cs typeface="Calibri" pitchFamily="34" charset="-120"/>
               </a:rPr>
-              <a:t>backlog list</a:t>
+              <a:t>backlog epic add</a:t>
             </a:r>
             <a:endParaRPr lang="en-US" sz="1000" dirty="0"/>
           </a:p>
@@ -19780,8 +19991,8 @@
         </p:nvSpPr>
         <p:spPr>
           <a:xfrm>
-            <a:off x="10255504" y="3749040"/>
-            <a:ext cx="1011936" cy="256032"/>
+            <a:off x="9396984" y="3749040"/>
+            <a:ext cx="1342136" cy="256032"/>
           </a:xfrm>
           <a:prstGeom prst="roundRect">
             <a:avLst>
@@ -19807,8 +20018,8 @@
         </p:nvSpPr>
         <p:spPr>
           <a:xfrm>
-            <a:off x="10255504" y="3749040"/>
-            <a:ext cx="1011936" cy="256032"/>
+            <a:off x="9396984" y="3749040"/>
+            <a:ext cx="1342136" cy="256032"/>
           </a:xfrm>
           <a:prstGeom prst="rect">
             <a:avLst/>
@@ -19832,7 +20043,7 @@
                 <a:ea typeface="Calibri" pitchFamily="34" charset="-122"/>
                 <a:cs typeface="Calibri" pitchFamily="34" charset="-120"/>
               </a:rPr>
-              <a:t>backlog next</a:t>
+              <a:t>backlog epic edit</a:t>
             </a:r>
             <a:endParaRPr lang="en-US" sz="1000" dirty="0"/>
           </a:p>
@@ -19847,7 +20058,7 @@
         <p:spPr>
           <a:xfrm>
             <a:off x="457200" y="4096512"/>
-            <a:ext cx="1077976" cy="256032"/>
+            <a:ext cx="945896" cy="256032"/>
           </a:xfrm>
           <a:prstGeom prst="roundRect">
             <a:avLst>
@@ -19874,7 +20085,7 @@
         <p:spPr>
           <a:xfrm>
             <a:off x="457200" y="4096512"/>
-            <a:ext cx="1077976" cy="256032"/>
+            <a:ext cx="945896" cy="256032"/>
           </a:xfrm>
           <a:prstGeom prst="rect">
             <a:avLst/>
@@ -19898,7 +20109,7 @@
                 <a:ea typeface="Calibri" pitchFamily="34" charset="-122"/>
                 <a:cs typeface="Calibri" pitchFamily="34" charset="-120"/>
               </a:rPr>
-              <a:t>backlog start</a:t>
+              <a:t>backlog add</a:t>
             </a:r>
             <a:endParaRPr lang="en-US" sz="1000" dirty="0"/>
           </a:p>
@@ -19912,7 +20123,7 @@
         </p:nvSpPr>
         <p:spPr>
           <a:xfrm>
-            <a:off x="1626616" y="4096512"/>
+            <a:off x="1494536" y="4096512"/>
             <a:ext cx="1011936" cy="256032"/>
           </a:xfrm>
           <a:prstGeom prst="roundRect">
@@ -19939,7 +20150,7 @@
         </p:nvSpPr>
         <p:spPr>
           <a:xfrm>
-            <a:off x="1626616" y="4096512"/>
+            <a:off x="1494536" y="4096512"/>
             <a:ext cx="1011936" cy="256032"/>
           </a:xfrm>
           <a:prstGeom prst="rect">
@@ -19964,7 +20175,7 @@
                 <a:ea typeface="Calibri" pitchFamily="34" charset="-122"/>
                 <a:cs typeface="Calibri" pitchFamily="34" charset="-120"/>
               </a:rPr>
-              <a:t>backlog move</a:t>
+              <a:t>backlog edit</a:t>
             </a:r>
             <a:endParaRPr lang="en-US" sz="1000" dirty="0"/>
           </a:p>
@@ -19978,7 +20189,7 @@
         </p:nvSpPr>
         <p:spPr>
           <a:xfrm>
-            <a:off x="2729992" y="4096512"/>
+            <a:off x="2597912" y="4096512"/>
             <a:ext cx="1011936" cy="256032"/>
           </a:xfrm>
           <a:prstGeom prst="roundRect">
@@ -20005,7 +20216,7 @@
         </p:nvSpPr>
         <p:spPr>
           <a:xfrm>
-            <a:off x="2729992" y="4096512"/>
+            <a:off x="2597912" y="4096512"/>
             <a:ext cx="1011936" cy="256032"/>
           </a:xfrm>
           <a:prstGeom prst="rect">
@@ -20030,7 +20241,7 @@
                 <a:ea typeface="Calibri" pitchFamily="34" charset="-122"/>
                 <a:cs typeface="Calibri" pitchFamily="34" charset="-120"/>
               </a:rPr>
-              <a:t>backlog drop</a:t>
+              <a:t>backlog list</a:t>
             </a:r>
             <a:endParaRPr lang="en-US" sz="1000" dirty="0"/>
           </a:p>
@@ -20044,7 +20255,7 @@
         </p:nvSpPr>
         <p:spPr>
           <a:xfrm>
-            <a:off x="3833368" y="4096512"/>
+            <a:off x="3701288" y="4096512"/>
             <a:ext cx="1011936" cy="256032"/>
           </a:xfrm>
           <a:prstGeom prst="roundRect">
@@ -20071,7 +20282,7 @@
         </p:nvSpPr>
         <p:spPr>
           <a:xfrm>
-            <a:off x="3833368" y="4096512"/>
+            <a:off x="3701288" y="4096512"/>
             <a:ext cx="1011936" cy="256032"/>
           </a:xfrm>
           <a:prstGeom prst="rect">
@@ -20096,7 +20307,7 @@
                 <a:ea typeface="Calibri" pitchFamily="34" charset="-122"/>
                 <a:cs typeface="Calibri" pitchFamily="34" charset="-120"/>
               </a:rPr>
-              <a:t>backlog done</a:t>
+              <a:t>backlog next</a:t>
             </a:r>
             <a:endParaRPr lang="en-US" sz="1000" dirty="0"/>
           </a:p>
@@ -20110,8 +20321,8 @@
         </p:nvSpPr>
         <p:spPr>
           <a:xfrm>
-            <a:off x="4936744" y="4096512"/>
-            <a:ext cx="813816" cy="256032"/>
+            <a:off x="4804664" y="4096512"/>
+            <a:ext cx="1077976" cy="256032"/>
           </a:xfrm>
           <a:prstGeom prst="roundRect">
             <a:avLst>
@@ -20137,8 +20348,8 @@
         </p:nvSpPr>
         <p:spPr>
           <a:xfrm>
-            <a:off x="4936744" y="4096512"/>
-            <a:ext cx="813816" cy="256032"/>
+            <a:off x="4804664" y="4096512"/>
+            <a:ext cx="1077976" cy="256032"/>
           </a:xfrm>
           <a:prstGeom prst="rect">
             <a:avLst/>
@@ -20162,7 +20373,7 @@
                 <a:ea typeface="Calibri" pitchFamily="34" charset="-122"/>
                 <a:cs typeface="Calibri" pitchFamily="34" charset="-120"/>
               </a:rPr>
-              <a:t>defer add</a:t>
+              <a:t>backlog start</a:t>
             </a:r>
             <a:endParaRPr lang="en-US" sz="1000" dirty="0"/>
           </a:p>
@@ -20176,8 +20387,8 @@
         </p:nvSpPr>
         <p:spPr>
           <a:xfrm>
-            <a:off x="5842000" y="4096512"/>
-            <a:ext cx="879856" cy="256032"/>
+            <a:off x="5974080" y="4096512"/>
+            <a:ext cx="1011936" cy="256032"/>
           </a:xfrm>
           <a:prstGeom prst="roundRect">
             <a:avLst>
@@ -20203,8 +20414,8 @@
         </p:nvSpPr>
         <p:spPr>
           <a:xfrm>
-            <a:off x="5842000" y="4096512"/>
-            <a:ext cx="879856" cy="256032"/>
+            <a:off x="5974080" y="4096512"/>
+            <a:ext cx="1011936" cy="256032"/>
           </a:xfrm>
           <a:prstGeom prst="rect">
             <a:avLst/>
@@ -20228,7 +20439,7 @@
                 <a:ea typeface="Calibri" pitchFamily="34" charset="-122"/>
                 <a:cs typeface="Calibri" pitchFamily="34" charset="-120"/>
               </a:rPr>
-              <a:t>defer list</a:t>
+              <a:t>backlog move</a:t>
             </a:r>
             <a:endParaRPr lang="en-US" sz="1000" dirty="0"/>
           </a:p>
@@ -20242,8 +20453,8 @@
         </p:nvSpPr>
         <p:spPr>
           <a:xfrm>
-            <a:off x="6813296" y="4096512"/>
-            <a:ext cx="945896" cy="256032"/>
+            <a:off x="7077456" y="4096512"/>
+            <a:ext cx="1011936" cy="256032"/>
           </a:xfrm>
           <a:prstGeom prst="roundRect">
             <a:avLst>
@@ -20269,8 +20480,8 @@
         </p:nvSpPr>
         <p:spPr>
           <a:xfrm>
-            <a:off x="6813296" y="4096512"/>
-            <a:ext cx="945896" cy="256032"/>
+            <a:off x="7077456" y="4096512"/>
+            <a:ext cx="1011936" cy="256032"/>
           </a:xfrm>
           <a:prstGeom prst="rect">
             <a:avLst/>
@@ -20294,7 +20505,7 @@
                 <a:ea typeface="Calibri" pitchFamily="34" charset="-122"/>
                 <a:cs typeface="Calibri" pitchFamily="34" charset="-120"/>
               </a:rPr>
-              <a:t>defer close</a:t>
+              <a:t>backlog drop</a:t>
             </a:r>
             <a:endParaRPr lang="en-US" sz="1000" dirty="0"/>
           </a:p>
@@ -20308,7 +20519,7 @@
         </p:nvSpPr>
         <p:spPr>
           <a:xfrm>
-            <a:off x="7850632" y="4096512"/>
+            <a:off x="8180832" y="4096512"/>
             <a:ext cx="1011936" cy="256032"/>
           </a:xfrm>
           <a:prstGeom prst="roundRect">
@@ -20335,7 +20546,7 @@
         </p:nvSpPr>
         <p:spPr>
           <a:xfrm>
-            <a:off x="7850632" y="4096512"/>
+            <a:off x="8180832" y="4096512"/>
             <a:ext cx="1011936" cy="256032"/>
           </a:xfrm>
           <a:prstGeom prst="rect">
@@ -20360,7 +20571,7 @@
                 <a:ea typeface="Calibri" pitchFamily="34" charset="-122"/>
                 <a:cs typeface="Calibri" pitchFamily="34" charset="-120"/>
               </a:rPr>
-              <a:t>layout check</a:t>
+              <a:t>backlog done</a:t>
             </a:r>
             <a:endParaRPr lang="en-US" sz="1000" dirty="0"/>
           </a:p>
@@ -20374,8 +20585,8 @@
         </p:nvSpPr>
         <p:spPr>
           <a:xfrm>
-            <a:off x="8954008" y="4096512"/>
-            <a:ext cx="1210056" cy="256032"/>
+            <a:off x="9284208" y="4096512"/>
+            <a:ext cx="813816" cy="256032"/>
           </a:xfrm>
           <a:prstGeom prst="roundRect">
             <a:avLst>
@@ -20401,8 +20612,8 @@
         </p:nvSpPr>
         <p:spPr>
           <a:xfrm>
-            <a:off x="8954008" y="4096512"/>
-            <a:ext cx="1210056" cy="256032"/>
+            <a:off x="9284208" y="4096512"/>
+            <a:ext cx="813816" cy="256032"/>
           </a:xfrm>
           <a:prstGeom prst="rect">
             <a:avLst/>
@@ -20426,7 +20637,7 @@
                 <a:ea typeface="Calibri" pitchFamily="34" charset="-122"/>
                 <a:cs typeface="Calibri" pitchFamily="34" charset="-120"/>
               </a:rPr>
-              <a:t>layout scaffold</a:t>
+              <a:t>defer add</a:t>
             </a:r>
             <a:endParaRPr lang="en-US" sz="1000" dirty="0"/>
           </a:p>
@@ -20440,8 +20651,8 @@
         </p:nvSpPr>
         <p:spPr>
           <a:xfrm>
-            <a:off x="10255504" y="4096512"/>
-            <a:ext cx="1011936" cy="256032"/>
+            <a:off x="10189464" y="4096512"/>
+            <a:ext cx="879856" cy="256032"/>
           </a:xfrm>
           <a:prstGeom prst="roundRect">
             <a:avLst>
@@ -20467,8 +20678,8 @@
         </p:nvSpPr>
         <p:spPr>
           <a:xfrm>
-            <a:off x="10255504" y="4096512"/>
-            <a:ext cx="1011936" cy="256032"/>
+            <a:off x="10189464" y="4096512"/>
+            <a:ext cx="879856" cy="256032"/>
           </a:xfrm>
           <a:prstGeom prst="rect">
             <a:avLst/>
@@ -20492,7 +20703,7 @@
                 <a:ea typeface="Calibri" pitchFamily="34" charset="-122"/>
                 <a:cs typeface="Calibri" pitchFamily="34" charset="-120"/>
               </a:rPr>
-              <a:t>layout adapt</a:t>
+              <a:t>defer list</a:t>
             </a:r>
             <a:endParaRPr lang="en-US" sz="1000" dirty="0"/>
           </a:p>
@@ -20507,7 +20718,7 @@
         <p:spPr>
           <a:xfrm>
             <a:off x="457200" y="4443984"/>
-            <a:ext cx="1144016" cy="256032"/>
+            <a:ext cx="945896" cy="256032"/>
           </a:xfrm>
           <a:prstGeom prst="roundRect">
             <a:avLst>
@@ -20534,7 +20745,7 @@
         <p:spPr>
           <a:xfrm>
             <a:off x="457200" y="4443984"/>
-            <a:ext cx="1144016" cy="256032"/>
+            <a:ext cx="945896" cy="256032"/>
           </a:xfrm>
           <a:prstGeom prst="rect">
             <a:avLst/>
@@ -20558,7 +20769,7 @@
                 <a:ea typeface="Calibri" pitchFamily="34" charset="-122"/>
                 <a:cs typeface="Calibri" pitchFamily="34" charset="-120"/>
               </a:rPr>
-              <a:t>layout convert</a:t>
+              <a:t>defer close</a:t>
             </a:r>
             <a:endParaRPr lang="en-US" sz="1000" dirty="0"/>
           </a:p>
@@ -20572,8 +20783,8 @@
         </p:nvSpPr>
         <p:spPr>
           <a:xfrm>
-            <a:off x="1692656" y="4443984"/>
-            <a:ext cx="483616" cy="256032"/>
+            <a:off x="1494536" y="4443984"/>
+            <a:ext cx="1011936" cy="256032"/>
           </a:xfrm>
           <a:prstGeom prst="roundRect">
             <a:avLst>
@@ -20599,8 +20810,8 @@
         </p:nvSpPr>
         <p:spPr>
           <a:xfrm>
-            <a:off x="1692656" y="4443984"/>
-            <a:ext cx="483616" cy="256032"/>
+            <a:off x="1494536" y="4443984"/>
+            <a:ext cx="1011936" cy="256032"/>
           </a:xfrm>
           <a:prstGeom prst="rect">
             <a:avLst/>
@@ -20624,7 +20835,7 @@
                 <a:ea typeface="Calibri" pitchFamily="34" charset="-122"/>
                 <a:cs typeface="Calibri" pitchFamily="34" charset="-120"/>
               </a:rPr>
-              <a:t>init</a:t>
+              <a:t>layout check</a:t>
             </a:r>
             <a:endParaRPr lang="en-US" sz="1000" dirty="0"/>
           </a:p>
@@ -20638,8 +20849,8 @@
         </p:nvSpPr>
         <p:spPr>
           <a:xfrm>
-            <a:off x="2267712" y="4443984"/>
-            <a:ext cx="615696" cy="256032"/>
+            <a:off x="2597912" y="4443984"/>
+            <a:ext cx="1210056" cy="256032"/>
           </a:xfrm>
           <a:prstGeom prst="roundRect">
             <a:avLst>
@@ -20665,8 +20876,8 @@
         </p:nvSpPr>
         <p:spPr>
           <a:xfrm>
-            <a:off x="2267712" y="4443984"/>
-            <a:ext cx="615696" cy="256032"/>
+            <a:off x="2597912" y="4443984"/>
+            <a:ext cx="1210056" cy="256032"/>
           </a:xfrm>
           <a:prstGeom prst="rect">
             <a:avLst/>
@@ -20690,7 +20901,7 @@
                 <a:ea typeface="Calibri" pitchFamily="34" charset="-122"/>
                 <a:cs typeface="Calibri" pitchFamily="34" charset="-120"/>
               </a:rPr>
-              <a:t>update</a:t>
+              <a:t>layout scaffold</a:t>
             </a:r>
             <a:endParaRPr lang="en-US" sz="1000" dirty="0"/>
           </a:p>
@@ -20704,8 +20915,8 @@
         </p:nvSpPr>
         <p:spPr>
           <a:xfrm>
-            <a:off x="2974848" y="4443984"/>
-            <a:ext cx="813816" cy="256032"/>
+            <a:off x="3899408" y="4443984"/>
+            <a:ext cx="1011936" cy="256032"/>
           </a:xfrm>
           <a:prstGeom prst="roundRect">
             <a:avLst>
@@ -20731,8 +20942,8 @@
         </p:nvSpPr>
         <p:spPr>
           <a:xfrm>
-            <a:off x="2974848" y="4443984"/>
-            <a:ext cx="813816" cy="256032"/>
+            <a:off x="3899408" y="4443984"/>
+            <a:ext cx="1011936" cy="256032"/>
           </a:xfrm>
           <a:prstGeom prst="rect">
             <a:avLst/>
@@ -20756,7 +20967,7 @@
                 <a:ea typeface="Calibri" pitchFamily="34" charset="-122"/>
                 <a:cs typeface="Calibri" pitchFamily="34" charset="-120"/>
               </a:rPr>
-              <a:t>uninstall</a:t>
+              <a:t>layout adapt</a:t>
             </a:r>
             <a:endParaRPr lang="en-US" sz="1000" dirty="0"/>
           </a:p>
@@ -20770,8 +20981,8 @@
         </p:nvSpPr>
         <p:spPr>
           <a:xfrm>
-            <a:off x="3880104" y="4443984"/>
-            <a:ext cx="417576" cy="256032"/>
+            <a:off x="5002784" y="4443984"/>
+            <a:ext cx="1144016" cy="256032"/>
           </a:xfrm>
           <a:prstGeom prst="roundRect">
             <a:avLst>
@@ -20797,8 +21008,8 @@
         </p:nvSpPr>
         <p:spPr>
           <a:xfrm>
-            <a:off x="3880104" y="4443984"/>
-            <a:ext cx="417576" cy="256032"/>
+            <a:off x="5002784" y="4443984"/>
+            <a:ext cx="1144016" cy="256032"/>
           </a:xfrm>
           <a:prstGeom prst="rect">
             <a:avLst/>
@@ -20822,7 +21033,7 @@
                 <a:ea typeface="Calibri" pitchFamily="34" charset="-122"/>
                 <a:cs typeface="Calibri" pitchFamily="34" charset="-120"/>
               </a:rPr>
-              <a:t>new</a:t>
+              <a:t>layout convert</a:t>
             </a:r>
             <a:endParaRPr lang="en-US" sz="1000" dirty="0"/>
           </a:p>
@@ -20836,8 +21047,8 @@
         </p:nvSpPr>
         <p:spPr>
           <a:xfrm>
-            <a:off x="4389120" y="4443984"/>
-            <a:ext cx="1011936" cy="256032"/>
+            <a:off x="6238240" y="4443984"/>
+            <a:ext cx="483616" cy="256032"/>
           </a:xfrm>
           <a:prstGeom prst="roundRect">
             <a:avLst>
@@ -20863,8 +21074,8 @@
         </p:nvSpPr>
         <p:spPr>
           <a:xfrm>
-            <a:off x="4389120" y="4443984"/>
-            <a:ext cx="1011936" cy="256032"/>
+            <a:off x="6238240" y="4443984"/>
+            <a:ext cx="483616" cy="256032"/>
           </a:xfrm>
           <a:prstGeom prst="rect">
             <a:avLst/>
@@ -20888,7 +21099,7 @@
                 <a:ea typeface="Calibri" pitchFamily="34" charset="-122"/>
                 <a:cs typeface="Calibri" pitchFamily="34" charset="-120"/>
               </a:rPr>
-              <a:t>explore list</a:t>
+              <a:t>init</a:t>
             </a:r>
             <a:endParaRPr lang="en-US" sz="1000" dirty="0"/>
           </a:p>
@@ -20902,8 +21113,8 @@
         </p:nvSpPr>
         <p:spPr>
           <a:xfrm>
-            <a:off x="5492496" y="4443984"/>
-            <a:ext cx="945896" cy="256032"/>
+            <a:off x="6813296" y="4443984"/>
+            <a:ext cx="615696" cy="256032"/>
           </a:xfrm>
           <a:prstGeom prst="roundRect">
             <a:avLst>
@@ -20929,8 +21140,8 @@
         </p:nvSpPr>
         <p:spPr>
           <a:xfrm>
-            <a:off x="5492496" y="4443984"/>
-            <a:ext cx="945896" cy="256032"/>
+            <a:off x="6813296" y="4443984"/>
+            <a:ext cx="615696" cy="256032"/>
           </a:xfrm>
           <a:prstGeom prst="rect">
             <a:avLst/>
@@ -20954,7 +21165,7 @@
                 <a:ea typeface="Calibri" pitchFamily="34" charset="-122"/>
                 <a:cs typeface="Calibri" pitchFamily="34" charset="-120"/>
               </a:rPr>
-              <a:t>import bmad</a:t>
+              <a:t>update</a:t>
             </a:r>
             <a:endParaRPr lang="en-US" sz="1000" dirty="0"/>
           </a:p>
@@ -20968,8 +21179,8 @@
         </p:nvSpPr>
         <p:spPr>
           <a:xfrm>
-            <a:off x="6529832" y="4443984"/>
-            <a:ext cx="615696" cy="256032"/>
+            <a:off x="7520432" y="4443984"/>
+            <a:ext cx="813816" cy="256032"/>
           </a:xfrm>
           <a:prstGeom prst="roundRect">
             <a:avLst>
@@ -20995,8 +21206,8 @@
         </p:nvSpPr>
         <p:spPr>
           <a:xfrm>
-            <a:off x="6529832" y="4443984"/>
-            <a:ext cx="615696" cy="256032"/>
+            <a:off x="7520432" y="4443984"/>
+            <a:ext cx="813816" cy="256032"/>
           </a:xfrm>
           <a:prstGeom prst="rect">
             <a:avLst/>
@@ -21020,7 +21231,7 @@
                 <a:ea typeface="Calibri" pitchFamily="34" charset="-122"/>
                 <a:cs typeface="Calibri" pitchFamily="34" charset="-120"/>
               </a:rPr>
-              <a:t>status</a:t>
+              <a:t>uninstall</a:t>
             </a:r>
             <a:endParaRPr lang="en-US" sz="1000" dirty="0"/>
           </a:p>
@@ -21034,8 +21245,8 @@
         </p:nvSpPr>
         <p:spPr>
           <a:xfrm>
-            <a:off x="7236968" y="4443984"/>
-            <a:ext cx="483616" cy="256032"/>
+            <a:off x="8425688" y="4443984"/>
+            <a:ext cx="417576" cy="256032"/>
           </a:xfrm>
           <a:prstGeom prst="roundRect">
             <a:avLst>
@@ -21061,8 +21272,8 @@
         </p:nvSpPr>
         <p:spPr>
           <a:xfrm>
-            <a:off x="7236968" y="4443984"/>
-            <a:ext cx="483616" cy="256032"/>
+            <a:off x="8425688" y="4443984"/>
+            <a:ext cx="417576" cy="256032"/>
           </a:xfrm>
           <a:prstGeom prst="rect">
             <a:avLst/>
@@ -21086,7 +21297,7 @@
                 <a:ea typeface="Calibri" pitchFamily="34" charset="-122"/>
                 <a:cs typeface="Calibri" pitchFamily="34" charset="-120"/>
               </a:rPr>
-              <a:t>help</a:t>
+              <a:t>new</a:t>
             </a:r>
             <a:endParaRPr lang="en-US" sz="1000" dirty="0"/>
           </a:p>
@@ -21100,8 +21311,8 @@
         </p:nvSpPr>
         <p:spPr>
           <a:xfrm>
-            <a:off x="7812024" y="4443984"/>
-            <a:ext cx="549656" cy="256032"/>
+            <a:off x="8934704" y="4443984"/>
+            <a:ext cx="1011936" cy="256032"/>
           </a:xfrm>
           <a:prstGeom prst="roundRect">
             <a:avLst>
@@ -21127,8 +21338,8 @@
         </p:nvSpPr>
         <p:spPr>
           <a:xfrm>
-            <a:off x="7812024" y="4443984"/>
-            <a:ext cx="549656" cy="256032"/>
+            <a:off x="8934704" y="4443984"/>
+            <a:ext cx="1011936" cy="256032"/>
           </a:xfrm>
           <a:prstGeom prst="rect">
             <a:avLst/>
@@ -21152,7 +21363,7 @@
                 <a:ea typeface="Calibri" pitchFamily="34" charset="-122"/>
                 <a:cs typeface="Calibri" pitchFamily="34" charset="-120"/>
               </a:rPr>
-              <a:t>guide</a:t>
+              <a:t>explore list</a:t>
             </a:r>
             <a:endParaRPr lang="en-US" sz="1000" dirty="0"/>
           </a:p>
@@ -21166,8 +21377,8 @@
         </p:nvSpPr>
         <p:spPr>
           <a:xfrm>
-            <a:off x="8453120" y="4443984"/>
-            <a:ext cx="879856" cy="256032"/>
+            <a:off x="10038080" y="4443984"/>
+            <a:ext cx="945896" cy="256032"/>
           </a:xfrm>
           <a:prstGeom prst="roundRect">
             <a:avLst>
@@ -21193,8 +21404,8 @@
         </p:nvSpPr>
         <p:spPr>
           <a:xfrm>
-            <a:off x="8453120" y="4443984"/>
-            <a:ext cx="879856" cy="256032"/>
+            <a:off x="10038080" y="4443984"/>
+            <a:ext cx="945896" cy="256032"/>
           </a:xfrm>
           <a:prstGeom prst="rect">
             <a:avLst/>
@@ -21218,7 +21429,7 @@
                 <a:ea typeface="Calibri" pitchFamily="34" charset="-122"/>
                 <a:cs typeface="Calibri" pitchFamily="34" charset="-120"/>
               </a:rPr>
-              <a:t>statusline</a:t>
+              <a:t>import bmad</a:t>
             </a:r>
             <a:endParaRPr lang="en-US" sz="1000" dirty="0"/>
           </a:p>
@@ -21232,8 +21443,8 @@
         </p:nvSpPr>
         <p:spPr>
           <a:xfrm>
-            <a:off x="9424416" y="4443984"/>
-            <a:ext cx="813816" cy="256032"/>
+            <a:off x="11075416" y="4443984"/>
+            <a:ext cx="615696" cy="256032"/>
           </a:xfrm>
           <a:prstGeom prst="roundRect">
             <a:avLst>
@@ -21259,8 +21470,8 @@
         </p:nvSpPr>
         <p:spPr>
           <a:xfrm>
-            <a:off x="9424416" y="4443984"/>
-            <a:ext cx="813816" cy="256032"/>
+            <a:off x="11075416" y="4443984"/>
+            <a:ext cx="615696" cy="256032"/>
           </a:xfrm>
           <a:prstGeom prst="rect">
             <a:avLst/>
@@ -21284,7 +21495,7 @@
                 <a:ea typeface="Calibri" pitchFamily="34" charset="-122"/>
                 <a:cs typeface="Calibri" pitchFamily="34" charset="-120"/>
               </a:rPr>
-              <a:t>mcp serve</a:t>
+              <a:t>status</a:t>
             </a:r>
             <a:endParaRPr lang="en-US" sz="1000" dirty="0"/>
           </a:p>
@@ -21298,8 +21509,8 @@
         </p:nvSpPr>
         <p:spPr>
           <a:xfrm>
-            <a:off x="10329672" y="4443984"/>
-            <a:ext cx="813816" cy="256032"/>
+            <a:off x="457200" y="4791456"/>
+            <a:ext cx="483616" cy="256032"/>
           </a:xfrm>
           <a:prstGeom prst="roundRect">
             <a:avLst>
@@ -21325,8 +21536,8 @@
         </p:nvSpPr>
         <p:spPr>
           <a:xfrm>
-            <a:off x="10329672" y="4443984"/>
-            <a:ext cx="813816" cy="256032"/>
+            <a:off x="457200" y="4791456"/>
+            <a:ext cx="483616" cy="256032"/>
           </a:xfrm>
           <a:prstGeom prst="rect">
             <a:avLst/>
@@ -21350,7 +21561,7 @@
                 <a:ea typeface="Calibri" pitchFamily="34" charset="-122"/>
                 <a:cs typeface="Calibri" pitchFamily="34" charset="-120"/>
               </a:rPr>
-              <a:t>mcp check</a:t>
+              <a:t>help</a:t>
             </a:r>
             <a:endParaRPr lang="en-US" sz="1000" dirty="0"/>
           </a:p>
@@ -21364,8 +21575,8 @@
         </p:nvSpPr>
         <p:spPr>
           <a:xfrm>
-            <a:off x="457200" y="4791456"/>
-            <a:ext cx="879856" cy="256032"/>
+            <a:off x="1032256" y="4791456"/>
+            <a:ext cx="549656" cy="256032"/>
           </a:xfrm>
           <a:prstGeom prst="roundRect">
             <a:avLst>
@@ -21391,8 +21602,8 @@
         </p:nvSpPr>
         <p:spPr>
           <a:xfrm>
-            <a:off x="457200" y="4791456"/>
-            <a:ext cx="879856" cy="256032"/>
+            <a:off x="1032256" y="4791456"/>
+            <a:ext cx="549656" cy="256032"/>
           </a:xfrm>
           <a:prstGeom prst="rect">
             <a:avLst/>
@@ -21416,7 +21627,7 @@
                 <a:ea typeface="Calibri" pitchFamily="34" charset="-122"/>
                 <a:cs typeface="Calibri" pitchFamily="34" charset="-120"/>
               </a:rPr>
-              <a:t>inbox list</a:t>
+              <a:t>guide</a:t>
             </a:r>
             <a:endParaRPr lang="en-US" sz="1000" dirty="0"/>
           </a:p>
@@ -21430,7 +21641,7 @@
         </p:nvSpPr>
         <p:spPr>
           <a:xfrm>
-            <a:off x="1428496" y="4791456"/>
+            <a:off x="1673352" y="4791456"/>
             <a:ext cx="879856" cy="256032"/>
           </a:xfrm>
           <a:prstGeom prst="roundRect">
@@ -21457,7 +21668,7 @@
         </p:nvSpPr>
         <p:spPr>
           <a:xfrm>
-            <a:off x="1428496" y="4791456"/>
+            <a:off x="1673352" y="4791456"/>
             <a:ext cx="879856" cy="256032"/>
           </a:xfrm>
           <a:prstGeom prst="rect">
@@ -21482,7 +21693,7 @@
                 <a:ea typeface="Calibri" pitchFamily="34" charset="-122"/>
                 <a:cs typeface="Calibri" pitchFamily="34" charset="-120"/>
               </a:rPr>
-              <a:t>inbox done</a:t>
+              <a:t>statusline</a:t>
             </a:r>
             <a:endParaRPr lang="en-US" sz="1000" dirty="0"/>
           </a:p>
@@ -21496,8 +21707,8 @@
         </p:nvSpPr>
         <p:spPr>
           <a:xfrm>
-            <a:off x="2399792" y="4791456"/>
-            <a:ext cx="945896" cy="256032"/>
+            <a:off x="2644648" y="4791456"/>
+            <a:ext cx="813816" cy="256032"/>
           </a:xfrm>
           <a:prstGeom prst="roundRect">
             <a:avLst>
@@ -21523,8 +21734,8 @@
         </p:nvSpPr>
         <p:spPr>
           <a:xfrm>
-            <a:off x="2399792" y="4791456"/>
-            <a:ext cx="945896" cy="256032"/>
+            <a:off x="2644648" y="4791456"/>
+            <a:ext cx="813816" cy="256032"/>
           </a:xfrm>
           <a:prstGeom prst="rect">
             <a:avLst/>
@@ -21548,7 +21759,7 @@
                 <a:ea typeface="Calibri" pitchFamily="34" charset="-122"/>
                 <a:cs typeface="Calibri" pitchFamily="34" charset="-120"/>
               </a:rPr>
-              <a:t>events list</a:t>
+              <a:t>mcp serve</a:t>
             </a:r>
             <a:endParaRPr lang="en-US" sz="1000" dirty="0"/>
           </a:p>
@@ -21562,8 +21773,8 @@
         </p:nvSpPr>
         <p:spPr>
           <a:xfrm>
-            <a:off x="3437128" y="4791456"/>
-            <a:ext cx="1011936" cy="256032"/>
+            <a:off x="3549904" y="4791456"/>
+            <a:ext cx="813816" cy="256032"/>
           </a:xfrm>
           <a:prstGeom prst="roundRect">
             <a:avLst>
@@ -21589,8 +21800,8 @@
         </p:nvSpPr>
         <p:spPr>
           <a:xfrm>
-            <a:off x="3437128" y="4791456"/>
-            <a:ext cx="1011936" cy="256032"/>
+            <a:off x="3549904" y="4791456"/>
+            <a:ext cx="813816" cy="256032"/>
           </a:xfrm>
           <a:prstGeom prst="rect">
             <a:avLst/>
@@ -21614,7 +21825,7 @@
                 <a:ea typeface="Calibri" pitchFamily="34" charset="-122"/>
                 <a:cs typeface="Calibri" pitchFamily="34" charset="-120"/>
               </a:rPr>
-              <a:t>events flush</a:t>
+              <a:t>mcp check</a:t>
             </a:r>
             <a:endParaRPr lang="en-US" sz="1000" dirty="0"/>
           </a:p>
@@ -21628,8 +21839,8 @@
         </p:nvSpPr>
         <p:spPr>
           <a:xfrm>
-            <a:off x="4540504" y="4791456"/>
-            <a:ext cx="1077976" cy="256032"/>
+            <a:off x="4455160" y="4791456"/>
+            <a:ext cx="879856" cy="256032"/>
           </a:xfrm>
           <a:prstGeom prst="roundRect">
             <a:avLst>
@@ -21655,8 +21866,8 @@
         </p:nvSpPr>
         <p:spPr>
           <a:xfrm>
-            <a:off x="4540504" y="4791456"/>
-            <a:ext cx="1077976" cy="256032"/>
+            <a:off x="4455160" y="4791456"/>
+            <a:ext cx="879856" cy="256032"/>
           </a:xfrm>
           <a:prstGeom prst="rect">
             <a:avLst/>
@@ -21680,7 +21891,7 @@
                 <a:ea typeface="Calibri" pitchFamily="34" charset="-122"/>
                 <a:cs typeface="Calibri" pitchFamily="34" charset="-120"/>
               </a:rPr>
-              <a:t>release check</a:t>
+              <a:t>inbox list</a:t>
             </a:r>
             <a:endParaRPr lang="en-US" sz="1000" dirty="0"/>
           </a:p>
@@ -21694,8 +21905,8 @@
         </p:nvSpPr>
         <p:spPr>
           <a:xfrm>
-            <a:off x="5709920" y="4791456"/>
-            <a:ext cx="813816" cy="256032"/>
+            <a:off x="5426456" y="4791456"/>
+            <a:ext cx="879856" cy="256032"/>
           </a:xfrm>
           <a:prstGeom prst="roundRect">
             <a:avLst>
@@ -21721,8 +21932,8 @@
         </p:nvSpPr>
         <p:spPr>
           <a:xfrm>
-            <a:off x="5709920" y="4791456"/>
-            <a:ext cx="813816" cy="256032"/>
+            <a:off x="5426456" y="4791456"/>
+            <a:ext cx="879856" cy="256032"/>
           </a:xfrm>
           <a:prstGeom prst="rect">
             <a:avLst/>
@@ -21746,7 +21957,7 @@
                 <a:ea typeface="Calibri" pitchFamily="34" charset="-122"/>
                 <a:cs typeface="Calibri" pitchFamily="34" charset="-120"/>
               </a:rPr>
-              <a:t>track set</a:t>
+              <a:t>inbox done</a:t>
             </a:r>
             <a:endParaRPr lang="en-US" sz="1000" dirty="0"/>
           </a:p>
@@ -21760,8 +21971,8 @@
         </p:nvSpPr>
         <p:spPr>
           <a:xfrm>
-            <a:off x="6615176" y="4791456"/>
-            <a:ext cx="483616" cy="256032"/>
+            <a:off x="6397752" y="4791456"/>
+            <a:ext cx="945896" cy="256032"/>
           </a:xfrm>
           <a:prstGeom prst="roundRect">
             <a:avLst>
@@ -21787,8 +21998,8 @@
         </p:nvSpPr>
         <p:spPr>
           <a:xfrm>
-            <a:off x="6615176" y="4791456"/>
-            <a:ext cx="483616" cy="256032"/>
+            <a:off x="6397752" y="4791456"/>
+            <a:ext cx="945896" cy="256032"/>
           </a:xfrm>
           <a:prstGeom prst="rect">
             <a:avLst/>
@@ -21812,7 +22023,7 @@
                 <a:ea typeface="Calibri" pitchFamily="34" charset="-122"/>
                 <a:cs typeface="Calibri" pitchFamily="34" charset="-120"/>
               </a:rPr>
-              <a:t>next</a:t>
+              <a:t>events list</a:t>
             </a:r>
             <a:endParaRPr lang="en-US" sz="1000" dirty="0"/>
           </a:p>
@@ -21826,7 +22037,7 @@
         </p:nvSpPr>
         <p:spPr>
           <a:xfrm>
-            <a:off x="7190232" y="4791456"/>
+            <a:off x="7435088" y="4791456"/>
             <a:ext cx="1011936" cy="256032"/>
           </a:xfrm>
           <a:prstGeom prst="roundRect">
@@ -21853,7 +22064,7 @@
         </p:nvSpPr>
         <p:spPr>
           <a:xfrm>
-            <a:off x="7190232" y="4791456"/>
+            <a:off x="7435088" y="4791456"/>
             <a:ext cx="1011936" cy="256032"/>
           </a:xfrm>
           <a:prstGeom prst="rect">
@@ -21878,7 +22089,7 @@
                 <a:ea typeface="Calibri" pitchFamily="34" charset="-122"/>
                 <a:cs typeface="Calibri" pitchFamily="34" charset="-120"/>
               </a:rPr>
-              <a:t>instructions</a:t>
+              <a:t>events flush</a:t>
             </a:r>
             <a:endParaRPr lang="en-US" sz="1000" dirty="0"/>
           </a:p>
@@ -21892,8 +22103,8 @@
         </p:nvSpPr>
         <p:spPr>
           <a:xfrm>
-            <a:off x="8293608" y="4791456"/>
-            <a:ext cx="681736" cy="256032"/>
+            <a:off x="8538464" y="4791456"/>
+            <a:ext cx="1077976" cy="256032"/>
           </a:xfrm>
           <a:prstGeom prst="roundRect">
             <a:avLst>
@@ -21919,8 +22130,8 @@
         </p:nvSpPr>
         <p:spPr>
           <a:xfrm>
-            <a:off x="8293608" y="4791456"/>
-            <a:ext cx="681736" cy="256032"/>
+            <a:off x="8538464" y="4791456"/>
+            <a:ext cx="1077976" cy="256032"/>
           </a:xfrm>
           <a:prstGeom prst="rect">
             <a:avLst/>
@@ -21944,7 +22155,7 @@
                 <a:ea typeface="Calibri" pitchFamily="34" charset="-122"/>
                 <a:cs typeface="Calibri" pitchFamily="34" charset="-120"/>
               </a:rPr>
-              <a:t>approve</a:t>
+              <a:t>release check</a:t>
             </a:r>
             <a:endParaRPr lang="en-US" sz="1000" dirty="0"/>
           </a:p>
@@ -21958,8 +22169,8 @@
         </p:nvSpPr>
         <p:spPr>
           <a:xfrm>
-            <a:off x="9066784" y="4791456"/>
-            <a:ext cx="615696" cy="256032"/>
+            <a:off x="9707880" y="4791456"/>
+            <a:ext cx="813816" cy="256032"/>
           </a:xfrm>
           <a:prstGeom prst="roundRect">
             <a:avLst>
@@ -21985,8 +22196,8 @@
         </p:nvSpPr>
         <p:spPr>
           <a:xfrm>
-            <a:off x="9066784" y="4791456"/>
-            <a:ext cx="615696" cy="256032"/>
+            <a:off x="9707880" y="4791456"/>
+            <a:ext cx="813816" cy="256032"/>
           </a:xfrm>
           <a:prstGeom prst="rect">
             <a:avLst/>
@@ -22010,7 +22221,7 @@
                 <a:ea typeface="Calibri" pitchFamily="34" charset="-122"/>
                 <a:cs typeface="Calibri" pitchFamily="34" charset="-120"/>
               </a:rPr>
-              <a:t>reject</a:t>
+              <a:t>track set</a:t>
             </a:r>
             <a:endParaRPr lang="en-US" sz="1000" dirty="0"/>
           </a:p>
@@ -22024,8 +22235,8 @@
         </p:nvSpPr>
         <p:spPr>
           <a:xfrm>
-            <a:off x="9773920" y="4791456"/>
-            <a:ext cx="549656" cy="256032"/>
+            <a:off x="10613136" y="4791456"/>
+            <a:ext cx="483616" cy="256032"/>
           </a:xfrm>
           <a:prstGeom prst="roundRect">
             <a:avLst>
@@ -22051,8 +22262,8 @@
         </p:nvSpPr>
         <p:spPr>
           <a:xfrm>
-            <a:off x="9773920" y="4791456"/>
-            <a:ext cx="549656" cy="256032"/>
+            <a:off x="10613136" y="4791456"/>
+            <a:ext cx="483616" cy="256032"/>
           </a:xfrm>
           <a:prstGeom prst="rect">
             <a:avLst/>
@@ -22076,7 +22287,7 @@
                 <a:ea typeface="Calibri" pitchFamily="34" charset="-122"/>
                 <a:cs typeface="Calibri" pitchFamily="34" charset="-120"/>
               </a:rPr>
-              <a:t>waive</a:t>
+              <a:t>next</a:t>
             </a:r>
             <a:endParaRPr lang="en-US" sz="1000" dirty="0"/>
           </a:p>
@@ -22090,8 +22301,8 @@
         </p:nvSpPr>
         <p:spPr>
           <a:xfrm>
-            <a:off x="10415016" y="4791456"/>
-            <a:ext cx="747776" cy="256032"/>
+            <a:off x="457200" y="5138928"/>
+            <a:ext cx="1011936" cy="256032"/>
           </a:xfrm>
           <a:prstGeom prst="roundRect">
             <a:avLst>
@@ -22117,8 +22328,8 @@
         </p:nvSpPr>
         <p:spPr>
           <a:xfrm>
-            <a:off x="10415016" y="4791456"/>
-            <a:ext cx="747776" cy="256032"/>
+            <a:off x="457200" y="5138928"/>
+            <a:ext cx="1011936" cy="256032"/>
           </a:xfrm>
           <a:prstGeom prst="rect">
             <a:avLst/>
@@ -22142,7 +22353,7 @@
                 <a:ea typeface="Calibri" pitchFamily="34" charset="-122"/>
                 <a:cs typeface="Calibri" pitchFamily="34" charset="-120"/>
               </a:rPr>
-              <a:t>takeover</a:t>
+              <a:t>instructions</a:t>
             </a:r>
             <a:endParaRPr lang="en-US" sz="1000" dirty="0"/>
           </a:p>
@@ -22156,8 +22367,8 @@
         </p:nvSpPr>
         <p:spPr>
           <a:xfrm>
-            <a:off x="457200" y="5138928"/>
-            <a:ext cx="1210056" cy="256032"/>
+            <a:off x="1560576" y="5138928"/>
+            <a:ext cx="681736" cy="256032"/>
           </a:xfrm>
           <a:prstGeom prst="roundRect">
             <a:avLst>
@@ -22183,8 +22394,8 @@
         </p:nvSpPr>
         <p:spPr>
           <a:xfrm>
-            <a:off x="457200" y="5138928"/>
-            <a:ext cx="1210056" cy="256032"/>
+            <a:off x="1560576" y="5138928"/>
+            <a:ext cx="681736" cy="256032"/>
           </a:xfrm>
           <a:prstGeom prst="rect">
             <a:avLst/>
@@ -22208,7 +22419,7 @@
                 <a:ea typeface="Calibri" pitchFamily="34" charset="-122"/>
                 <a:cs typeface="Calibri" pitchFamily="34" charset="-120"/>
               </a:rPr>
-              <a:t>release-control</a:t>
+              <a:t>approve</a:t>
             </a:r>
             <a:endParaRPr lang="en-US" sz="1000" dirty="0"/>
           </a:p>
@@ -22222,7 +22433,7 @@
         </p:nvSpPr>
         <p:spPr>
           <a:xfrm>
-            <a:off x="1758696" y="5138928"/>
+            <a:off x="2333752" y="5138928"/>
             <a:ext cx="615696" cy="256032"/>
           </a:xfrm>
           <a:prstGeom prst="roundRect">
@@ -22249,7 +22460,7 @@
         </p:nvSpPr>
         <p:spPr>
           <a:xfrm>
-            <a:off x="1758696" y="5138928"/>
+            <a:off x="2333752" y="5138928"/>
             <a:ext cx="615696" cy="256032"/>
           </a:xfrm>
           <a:prstGeom prst="rect">
@@ -22274,7 +22485,7 @@
                 <a:ea typeface="Calibri" pitchFamily="34" charset="-122"/>
                 <a:cs typeface="Calibri" pitchFamily="34" charset="-120"/>
               </a:rPr>
-              <a:t>rework</a:t>
+              <a:t>reject</a:t>
             </a:r>
             <a:endParaRPr lang="en-US" sz="1000" dirty="0"/>
           </a:p>
@@ -22288,8 +22499,8 @@
         </p:nvSpPr>
         <p:spPr>
           <a:xfrm>
-            <a:off x="2465832" y="5138928"/>
-            <a:ext cx="1276096" cy="256032"/>
+            <a:off x="3040888" y="5138928"/>
+            <a:ext cx="549656" cy="256032"/>
           </a:xfrm>
           <a:prstGeom prst="roundRect">
             <a:avLst>
@@ -22315,8 +22526,8 @@
         </p:nvSpPr>
         <p:spPr>
           <a:xfrm>
-            <a:off x="2465832" y="5138928"/>
-            <a:ext cx="1276096" cy="256032"/>
+            <a:off x="3040888" y="5138928"/>
+            <a:ext cx="549656" cy="256032"/>
           </a:xfrm>
           <a:prstGeom prst="rect">
             <a:avLst/>
@@ -22340,7 +22551,7 @@
                 <a:ea typeface="Calibri" pitchFamily="34" charset="-122"/>
                 <a:cs typeface="Calibri" pitchFamily="34" charset="-120"/>
               </a:rPr>
-              <a:t>approvals verify</a:t>
+              <a:t>waive</a:t>
             </a:r>
             <a:endParaRPr lang="en-US" sz="1000" dirty="0"/>
           </a:p>
@@ -22354,8 +22565,8 @@
         </p:nvSpPr>
         <p:spPr>
           <a:xfrm>
-            <a:off x="3833368" y="5138928"/>
-            <a:ext cx="549656" cy="256032"/>
+            <a:off x="3681984" y="5138928"/>
+            <a:ext cx="747776" cy="256032"/>
           </a:xfrm>
           <a:prstGeom prst="roundRect">
             <a:avLst>
@@ -22381,8 +22592,8 @@
         </p:nvSpPr>
         <p:spPr>
           <a:xfrm>
-            <a:off x="3833368" y="5138928"/>
-            <a:ext cx="549656" cy="256032"/>
+            <a:off x="3681984" y="5138928"/>
+            <a:ext cx="747776" cy="256032"/>
           </a:xfrm>
           <a:prstGeom prst="rect">
             <a:avLst/>
@@ -22406,7 +22617,7 @@
                 <a:ea typeface="Calibri" pitchFamily="34" charset="-122"/>
                 <a:cs typeface="Calibri" pitchFamily="34" charset="-120"/>
               </a:rPr>
-              <a:t>tests</a:t>
+              <a:t>takeover</a:t>
             </a:r>
             <a:endParaRPr lang="en-US" sz="1000" dirty="0"/>
           </a:p>
@@ -22420,8 +22631,8 @@
         </p:nvSpPr>
         <p:spPr>
           <a:xfrm>
-            <a:off x="4474464" y="5138928"/>
-            <a:ext cx="615696" cy="256032"/>
+            <a:off x="4521200" y="5138928"/>
+            <a:ext cx="1210056" cy="256032"/>
           </a:xfrm>
           <a:prstGeom prst="roundRect">
             <a:avLst>
@@ -22447,8 +22658,8 @@
         </p:nvSpPr>
         <p:spPr>
           <a:xfrm>
-            <a:off x="4474464" y="5138928"/>
-            <a:ext cx="615696" cy="256032"/>
+            <a:off x="4521200" y="5138928"/>
+            <a:ext cx="1210056" cy="256032"/>
           </a:xfrm>
           <a:prstGeom prst="rect">
             <a:avLst/>
@@ -22472,7 +22683,7 @@
                 <a:ea typeface="Calibri" pitchFamily="34" charset="-122"/>
                 <a:cs typeface="Calibri" pitchFamily="34" charset="-120"/>
               </a:rPr>
-              <a:t>verify</a:t>
+              <a:t>release-control</a:t>
             </a:r>
             <a:endParaRPr lang="en-US" sz="1000" dirty="0"/>
           </a:p>
@@ -22486,7 +22697,7 @@
         </p:nvSpPr>
         <p:spPr>
           <a:xfrm>
-            <a:off x="5181600" y="5138928"/>
+            <a:off x="5822696" y="5138928"/>
             <a:ext cx="615696" cy="256032"/>
           </a:xfrm>
           <a:prstGeom prst="roundRect">
@@ -22513,7 +22724,7 @@
         </p:nvSpPr>
         <p:spPr>
           <a:xfrm>
-            <a:off x="5181600" y="5138928"/>
+            <a:off x="5822696" y="5138928"/>
             <a:ext cx="615696" cy="256032"/>
           </a:xfrm>
           <a:prstGeom prst="rect">
@@ -22538,7 +22749,7 @@
                 <a:ea typeface="Calibri" pitchFamily="34" charset="-122"/>
                 <a:cs typeface="Calibri" pitchFamily="34" charset="-120"/>
               </a:rPr>
-              <a:t>review</a:t>
+              <a:t>rework</a:t>
             </a:r>
             <a:endParaRPr lang="en-US" sz="1000" dirty="0"/>
           </a:p>
@@ -22552,8 +22763,8 @@
         </p:nvSpPr>
         <p:spPr>
           <a:xfrm>
-            <a:off x="5888736" y="5138928"/>
-            <a:ext cx="747776" cy="256032"/>
+            <a:off x="6529832" y="5138928"/>
+            <a:ext cx="1276096" cy="256032"/>
           </a:xfrm>
           <a:prstGeom prst="roundRect">
             <a:avLst>
@@ -22579,8 +22790,8 @@
         </p:nvSpPr>
         <p:spPr>
           <a:xfrm>
-            <a:off x="5888736" y="5138928"/>
-            <a:ext cx="747776" cy="256032"/>
+            <a:off x="6529832" y="5138928"/>
+            <a:ext cx="1276096" cy="256032"/>
           </a:xfrm>
           <a:prstGeom prst="rect">
             <a:avLst/>
@@ -22604,7 +22815,7 @@
                 <a:ea typeface="Calibri" pitchFamily="34" charset="-122"/>
                 <a:cs typeface="Calibri" pitchFamily="34" charset="-120"/>
               </a:rPr>
-              <a:t>validate</a:t>
+              <a:t>approvals verify</a:t>
             </a:r>
             <a:endParaRPr lang="en-US" sz="1000" dirty="0"/>
           </a:p>
@@ -22618,8 +22829,8 @@
         </p:nvSpPr>
         <p:spPr>
           <a:xfrm>
-            <a:off x="6727952" y="5138928"/>
-            <a:ext cx="681736" cy="256032"/>
+            <a:off x="7897368" y="5138928"/>
+            <a:ext cx="549656" cy="256032"/>
           </a:xfrm>
           <a:prstGeom prst="roundRect">
             <a:avLst>
@@ -22645,8 +22856,8 @@
         </p:nvSpPr>
         <p:spPr>
           <a:xfrm>
-            <a:off x="6727952" y="5138928"/>
-            <a:ext cx="681736" cy="256032"/>
+            <a:off x="7897368" y="5138928"/>
+            <a:ext cx="549656" cy="256032"/>
           </a:xfrm>
           <a:prstGeom prst="rect">
             <a:avLst/>
@@ -22670,7 +22881,7 @@
                 <a:ea typeface="Calibri" pitchFamily="34" charset="-122"/>
                 <a:cs typeface="Calibri" pitchFamily="34" charset="-120"/>
               </a:rPr>
-              <a:t>archive</a:t>
+              <a:t>tests</a:t>
             </a:r>
             <a:endParaRPr lang="en-US" sz="1000" dirty="0"/>
           </a:p>
@@ -22684,8 +22895,8 @@
         </p:nvSpPr>
         <p:spPr>
           <a:xfrm>
-            <a:off x="7501128" y="5138928"/>
-            <a:ext cx="549656" cy="256032"/>
+            <a:off x="8538464" y="5138928"/>
+            <a:ext cx="615696" cy="256032"/>
           </a:xfrm>
           <a:prstGeom prst="roundRect">
             <a:avLst>
@@ -22711,8 +22922,8 @@
         </p:nvSpPr>
         <p:spPr>
           <a:xfrm>
-            <a:off x="7501128" y="5138928"/>
-            <a:ext cx="549656" cy="256032"/>
+            <a:off x="8538464" y="5138928"/>
+            <a:ext cx="615696" cy="256032"/>
           </a:xfrm>
           <a:prstGeom prst="rect">
             <a:avLst/>
@@ -22736,7 +22947,7 @@
                 <a:ea typeface="Calibri" pitchFamily="34" charset="-122"/>
                 <a:cs typeface="Calibri" pitchFamily="34" charset="-120"/>
               </a:rPr>
-              <a:t>audit</a:t>
+              <a:t>verify</a:t>
             </a:r>
             <a:endParaRPr lang="en-US" sz="1000" dirty="0"/>
           </a:p>
@@ -22750,7 +22961,7 @@
         </p:nvSpPr>
         <p:spPr>
           <a:xfrm>
-            <a:off x="8142224" y="5138928"/>
+            <a:off x="9245600" y="5138928"/>
             <a:ext cx="615696" cy="256032"/>
           </a:xfrm>
           <a:prstGeom prst="roundRect">
@@ -22777,7 +22988,7 @@
         </p:nvSpPr>
         <p:spPr>
           <a:xfrm>
-            <a:off x="8142224" y="5138928"/>
+            <a:off x="9245600" y="5138928"/>
             <a:ext cx="615696" cy="256032"/>
           </a:xfrm>
           <a:prstGeom prst="rect">
@@ -22802,7 +23013,7 @@
                 <a:ea typeface="Calibri" pitchFamily="34" charset="-122"/>
                 <a:cs typeface="Calibri" pitchFamily="34" charset="-120"/>
               </a:rPr>
-              <a:t>report</a:t>
+              <a:t>review</a:t>
             </a:r>
             <a:endParaRPr lang="en-US" sz="1000" dirty="0"/>
           </a:p>
@@ -22816,8 +23027,8 @@
         </p:nvSpPr>
         <p:spPr>
           <a:xfrm>
-            <a:off x="8849360" y="5138928"/>
-            <a:ext cx="813816" cy="256032"/>
+            <a:off x="9952736" y="5138928"/>
+            <a:ext cx="747776" cy="256032"/>
           </a:xfrm>
           <a:prstGeom prst="roundRect">
             <a:avLst>
@@ -22843,8 +23054,8 @@
         </p:nvSpPr>
         <p:spPr>
           <a:xfrm>
-            <a:off x="8849360" y="5138928"/>
-            <a:ext cx="813816" cy="256032"/>
+            <a:off x="9952736" y="5138928"/>
+            <a:ext cx="747776" cy="256032"/>
           </a:xfrm>
           <a:prstGeom prst="rect">
             <a:avLst/>
@@ -22868,7 +23079,7 @@
                 <a:ea typeface="Calibri" pitchFamily="34" charset="-122"/>
                 <a:cs typeface="Calibri" pitchFamily="34" charset="-120"/>
               </a:rPr>
-              <a:t>dashboard</a:t>
+              <a:t>validate</a:t>
             </a:r>
             <a:endParaRPr lang="en-US" sz="1000" dirty="0"/>
           </a:p>
@@ -22882,8 +23093,8 @@
         </p:nvSpPr>
         <p:spPr>
           <a:xfrm>
-            <a:off x="9754616" y="5138928"/>
-            <a:ext cx="417576" cy="256032"/>
+            <a:off x="10791952" y="5138928"/>
+            <a:ext cx="681736" cy="256032"/>
           </a:xfrm>
           <a:prstGeom prst="roundRect">
             <a:avLst>
@@ -22909,8 +23120,8 @@
         </p:nvSpPr>
         <p:spPr>
           <a:xfrm>
-            <a:off x="9754616" y="5138928"/>
-            <a:ext cx="417576" cy="256032"/>
+            <a:off x="10791952" y="5138928"/>
+            <a:ext cx="681736" cy="256032"/>
           </a:xfrm>
           <a:prstGeom prst="rect">
             <a:avLst/>
@@ -22934,7 +23145,7 @@
                 <a:ea typeface="Calibri" pitchFamily="34" charset="-122"/>
                 <a:cs typeface="Calibri" pitchFamily="34" charset="-120"/>
               </a:rPr>
-              <a:t>log</a:t>
+              <a:t>archive</a:t>
             </a:r>
             <a:endParaRPr lang="en-US" sz="1000" dirty="0"/>
           </a:p>
@@ -22948,8 +23159,8 @@
         </p:nvSpPr>
         <p:spPr>
           <a:xfrm>
-            <a:off x="10263632" y="5138928"/>
-            <a:ext cx="681736" cy="256032"/>
+            <a:off x="457200" y="5486400"/>
+            <a:ext cx="549656" cy="256032"/>
           </a:xfrm>
           <a:prstGeom prst="roundRect">
             <a:avLst>
@@ -22975,8 +23186,8 @@
         </p:nvSpPr>
         <p:spPr>
           <a:xfrm>
-            <a:off x="10263632" y="5138928"/>
-            <a:ext cx="681736" cy="256032"/>
+            <a:off x="457200" y="5486400"/>
+            <a:ext cx="549656" cy="256032"/>
           </a:xfrm>
           <a:prstGeom prst="rect">
             <a:avLst/>
@@ -23000,7 +23211,7 @@
                 <a:ea typeface="Calibri" pitchFamily="34" charset="-122"/>
                 <a:cs typeface="Calibri" pitchFamily="34" charset="-120"/>
               </a:rPr>
-              <a:t>license</a:t>
+              <a:t>audit</a:t>
             </a:r>
             <a:endParaRPr lang="en-US" sz="1000" dirty="0"/>
           </a:p>
@@ -23014,7 +23225,7 @@
         </p:nvSpPr>
         <p:spPr>
           <a:xfrm>
-            <a:off x="11036808" y="5138928"/>
+            <a:off x="1098296" y="5486400"/>
             <a:ext cx="615696" cy="256032"/>
           </a:xfrm>
           <a:prstGeom prst="roundRect">
@@ -23041,7 +23252,7 @@
         </p:nvSpPr>
         <p:spPr>
           <a:xfrm>
-            <a:off x="11036808" y="5138928"/>
+            <a:off x="1098296" y="5486400"/>
             <a:ext cx="615696" cy="256032"/>
           </a:xfrm>
           <a:prstGeom prst="rect">
@@ -23066,7 +23277,7 @@
                 <a:ea typeface="Calibri" pitchFamily="34" charset="-122"/>
                 <a:cs typeface="Calibri" pitchFamily="34" charset="-120"/>
               </a:rPr>
-              <a:t>doctor</a:t>
+              <a:t>report</a:t>
             </a:r>
             <a:endParaRPr lang="en-US" sz="1000" dirty="0"/>
           </a:p>
@@ -23080,8 +23291,8 @@
         </p:nvSpPr>
         <p:spPr>
           <a:xfrm>
-            <a:off x="457200" y="5486400"/>
-            <a:ext cx="1011936" cy="256032"/>
+            <a:off x="1805432" y="5486400"/>
+            <a:ext cx="813816" cy="256032"/>
           </a:xfrm>
           <a:prstGeom prst="roundRect">
             <a:avLst>
@@ -23107,8 +23318,8 @@
         </p:nvSpPr>
         <p:spPr>
           <a:xfrm>
-            <a:off x="457200" y="5486400"/>
-            <a:ext cx="1011936" cy="256032"/>
+            <a:off x="1805432" y="5486400"/>
+            <a:ext cx="813816" cy="256032"/>
           </a:xfrm>
           <a:prstGeom prst="rect">
             <a:avLst/>
@@ -23132,7 +23343,7 @@
                 <a:ea typeface="Calibri" pitchFamily="34" charset="-122"/>
                 <a:cs typeface="Calibri" pitchFamily="34" charset="-120"/>
               </a:rPr>
-              <a:t>plugin build</a:t>
+              <a:t>dashboard</a:t>
             </a:r>
             <a:endParaRPr lang="en-US" sz="1000" dirty="0"/>
           </a:p>
@@ -23146,8 +23357,8 @@
         </p:nvSpPr>
         <p:spPr>
           <a:xfrm>
-            <a:off x="1560576" y="5486400"/>
-            <a:ext cx="549656" cy="256032"/>
+            <a:off x="2710688" y="5486400"/>
+            <a:ext cx="417576" cy="256032"/>
           </a:xfrm>
           <a:prstGeom prst="roundRect">
             <a:avLst>
@@ -23173,8 +23384,8 @@
         </p:nvSpPr>
         <p:spPr>
           <a:xfrm>
-            <a:off x="1560576" y="5486400"/>
-            <a:ext cx="549656" cy="256032"/>
+            <a:off x="2710688" y="5486400"/>
+            <a:ext cx="417576" cy="256032"/>
           </a:xfrm>
           <a:prstGeom prst="rect">
             <a:avLst/>
@@ -23198,7 +23409,7 @@
                 <a:ea typeface="Calibri" pitchFamily="34" charset="-122"/>
                 <a:cs typeface="Calibri" pitchFamily="34" charset="-120"/>
               </a:rPr>
-              <a:t>trace</a:t>
+              <a:t>log</a:t>
             </a:r>
             <a:endParaRPr lang="en-US" sz="1000" dirty="0"/>
           </a:p>
@@ -23212,8 +23423,8 @@
         </p:nvSpPr>
         <p:spPr>
           <a:xfrm>
-            <a:off x="2201672" y="5486400"/>
-            <a:ext cx="483616" cy="256032"/>
+            <a:off x="3219704" y="5486400"/>
+            <a:ext cx="681736" cy="256032"/>
           </a:xfrm>
           <a:prstGeom prst="roundRect">
             <a:avLst>
@@ -23239,8 +23450,8 @@
         </p:nvSpPr>
         <p:spPr>
           <a:xfrm>
-            <a:off x="2201672" y="5486400"/>
-            <a:ext cx="483616" cy="256032"/>
+            <a:off x="3219704" y="5486400"/>
+            <a:ext cx="681736" cy="256032"/>
           </a:xfrm>
           <a:prstGeom prst="rect">
             <a:avLst/>
@@ -23264,7 +23475,7 @@
                 <a:ea typeface="Calibri" pitchFamily="34" charset="-122"/>
                 <a:cs typeface="Calibri" pitchFamily="34" charset="-120"/>
               </a:rPr>
-              <a:t>hook</a:t>
+              <a:t>license</a:t>
             </a:r>
             <a:endParaRPr lang="en-US" sz="1000" dirty="0"/>
           </a:p>
@@ -23278,8 +23489,8 @@
         </p:nvSpPr>
         <p:spPr>
           <a:xfrm>
-            <a:off x="2776728" y="5486400"/>
-            <a:ext cx="747776" cy="256032"/>
+            <a:off x="3992880" y="5486400"/>
+            <a:ext cx="615696" cy="256032"/>
           </a:xfrm>
           <a:prstGeom prst="roundRect">
             <a:avLst>
@@ -23305,7 +23516,271 @@
         </p:nvSpPr>
         <p:spPr>
           <a:xfrm>
-            <a:off x="2776728" y="5486400"/>
+            <a:off x="3992880" y="5486400"/>
+            <a:ext cx="615696" cy="256032"/>
+          </a:xfrm>
+          <a:prstGeom prst="rect">
+            <a:avLst/>
+          </a:prstGeom>
+          <a:noFill/>
+          <a:ln/>
+        </p:spPr>
+        <p:txBody>
+          <a:bodyPr wrap="square" lIns="0" tIns="0" rIns="0" bIns="0" rtlCol="0" anchor="ctr"/>
+          <a:lstStyle/>
+          <a:p>
+            <a:pPr algn="ctr" indent="0" marL="0">
+              <a:buNone/>
+            </a:pPr>
+            <a:r>
+              <a:rPr lang="en-US" sz="1000" dirty="0">
+                <a:solidFill>
+                  <a:srgbClr val="1F2430"/>
+                </a:solidFill>
+                <a:latin typeface="Calibri" pitchFamily="34" charset="0"/>
+                <a:ea typeface="Calibri" pitchFamily="34" charset="-122"/>
+                <a:cs typeface="Calibri" pitchFamily="34" charset="-120"/>
+              </a:rPr>
+              <a:t>doctor</a:t>
+            </a:r>
+            <a:endParaRPr lang="en-US" sz="1000" dirty="0"/>
+          </a:p>
+        </p:txBody>
+      </p:sp>
+      <p:sp>
+        <p:nvSpPr>
+          <p:cNvPr id="142" name="Shape 140"/>
+          <p:cNvSpPr/>
+          <p:nvPr/>
+        </p:nvSpPr>
+        <p:spPr>
+          <a:xfrm>
+            <a:off x="4700016" y="5486400"/>
+            <a:ext cx="1011936" cy="256032"/>
+          </a:xfrm>
+          <a:prstGeom prst="roundRect">
+            <a:avLst>
+              <a:gd name="adj" fmla="val 50000"/>
+            </a:avLst>
+          </a:prstGeom>
+          <a:solidFill>
+            <a:srgbClr val="F3F5F8"/>
+          </a:solidFill>
+          <a:ln w="12700">
+            <a:solidFill>
+              <a:srgbClr val="F3F5F8"/>
+            </a:solidFill>
+            <a:prstDash val="solid"/>
+          </a:ln>
+        </p:spPr>
+      </p:sp>
+      <p:sp>
+        <p:nvSpPr>
+          <p:cNvPr id="143" name="Text 141"/>
+          <p:cNvSpPr txBox="1"/>
+          <p:nvPr/>
+        </p:nvSpPr>
+        <p:spPr>
+          <a:xfrm>
+            <a:off x="4700016" y="5486400"/>
+            <a:ext cx="1011936" cy="256032"/>
+          </a:xfrm>
+          <a:prstGeom prst="rect">
+            <a:avLst/>
+          </a:prstGeom>
+          <a:noFill/>
+          <a:ln/>
+        </p:spPr>
+        <p:txBody>
+          <a:bodyPr wrap="square" lIns="0" tIns="0" rIns="0" bIns="0" rtlCol="0" anchor="ctr"/>
+          <a:lstStyle/>
+          <a:p>
+            <a:pPr algn="ctr" indent="0" marL="0">
+              <a:buNone/>
+            </a:pPr>
+            <a:r>
+              <a:rPr lang="en-US" sz="1000" dirty="0">
+                <a:solidFill>
+                  <a:srgbClr val="1F2430"/>
+                </a:solidFill>
+                <a:latin typeface="Calibri" pitchFamily="34" charset="0"/>
+                <a:ea typeface="Calibri" pitchFamily="34" charset="-122"/>
+                <a:cs typeface="Calibri" pitchFamily="34" charset="-120"/>
+              </a:rPr>
+              <a:t>plugin build</a:t>
+            </a:r>
+            <a:endParaRPr lang="en-US" sz="1000" dirty="0"/>
+          </a:p>
+        </p:txBody>
+      </p:sp>
+      <p:sp>
+        <p:nvSpPr>
+          <p:cNvPr id="144" name="Shape 142"/>
+          <p:cNvSpPr/>
+          <p:nvPr/>
+        </p:nvSpPr>
+        <p:spPr>
+          <a:xfrm>
+            <a:off x="5803392" y="5486400"/>
+            <a:ext cx="549656" cy="256032"/>
+          </a:xfrm>
+          <a:prstGeom prst="roundRect">
+            <a:avLst>
+              <a:gd name="adj" fmla="val 50000"/>
+            </a:avLst>
+          </a:prstGeom>
+          <a:solidFill>
+            <a:srgbClr val="F3F5F8"/>
+          </a:solidFill>
+          <a:ln w="12700">
+            <a:solidFill>
+              <a:srgbClr val="F3F5F8"/>
+            </a:solidFill>
+            <a:prstDash val="solid"/>
+          </a:ln>
+        </p:spPr>
+      </p:sp>
+      <p:sp>
+        <p:nvSpPr>
+          <p:cNvPr id="145" name="Text 143"/>
+          <p:cNvSpPr txBox="1"/>
+          <p:nvPr/>
+        </p:nvSpPr>
+        <p:spPr>
+          <a:xfrm>
+            <a:off x="5803392" y="5486400"/>
+            <a:ext cx="549656" cy="256032"/>
+          </a:xfrm>
+          <a:prstGeom prst="rect">
+            <a:avLst/>
+          </a:prstGeom>
+          <a:noFill/>
+          <a:ln/>
+        </p:spPr>
+        <p:txBody>
+          <a:bodyPr wrap="square" lIns="0" tIns="0" rIns="0" bIns="0" rtlCol="0" anchor="ctr"/>
+          <a:lstStyle/>
+          <a:p>
+            <a:pPr algn="ctr" indent="0" marL="0">
+              <a:buNone/>
+            </a:pPr>
+            <a:r>
+              <a:rPr lang="en-US" sz="1000" dirty="0">
+                <a:solidFill>
+                  <a:srgbClr val="1F2430"/>
+                </a:solidFill>
+                <a:latin typeface="Calibri" pitchFamily="34" charset="0"/>
+                <a:ea typeface="Calibri" pitchFamily="34" charset="-122"/>
+                <a:cs typeface="Calibri" pitchFamily="34" charset="-120"/>
+              </a:rPr>
+              <a:t>trace</a:t>
+            </a:r>
+            <a:endParaRPr lang="en-US" sz="1000" dirty="0"/>
+          </a:p>
+        </p:txBody>
+      </p:sp>
+      <p:sp>
+        <p:nvSpPr>
+          <p:cNvPr id="146" name="Shape 144"/>
+          <p:cNvSpPr/>
+          <p:nvPr/>
+        </p:nvSpPr>
+        <p:spPr>
+          <a:xfrm>
+            <a:off x="6444488" y="5486400"/>
+            <a:ext cx="483616" cy="256032"/>
+          </a:xfrm>
+          <a:prstGeom prst="roundRect">
+            <a:avLst>
+              <a:gd name="adj" fmla="val 50000"/>
+            </a:avLst>
+          </a:prstGeom>
+          <a:solidFill>
+            <a:srgbClr val="F3F5F8"/>
+          </a:solidFill>
+          <a:ln w="12700">
+            <a:solidFill>
+              <a:srgbClr val="F3F5F8"/>
+            </a:solidFill>
+            <a:prstDash val="solid"/>
+          </a:ln>
+        </p:spPr>
+      </p:sp>
+      <p:sp>
+        <p:nvSpPr>
+          <p:cNvPr id="147" name="Text 145"/>
+          <p:cNvSpPr txBox="1"/>
+          <p:nvPr/>
+        </p:nvSpPr>
+        <p:spPr>
+          <a:xfrm>
+            <a:off x="6444488" y="5486400"/>
+            <a:ext cx="483616" cy="256032"/>
+          </a:xfrm>
+          <a:prstGeom prst="rect">
+            <a:avLst/>
+          </a:prstGeom>
+          <a:noFill/>
+          <a:ln/>
+        </p:spPr>
+        <p:txBody>
+          <a:bodyPr wrap="square" lIns="0" tIns="0" rIns="0" bIns="0" rtlCol="0" anchor="ctr"/>
+          <a:lstStyle/>
+          <a:p>
+            <a:pPr algn="ctr" indent="0" marL="0">
+              <a:buNone/>
+            </a:pPr>
+            <a:r>
+              <a:rPr lang="en-US" sz="1000" dirty="0">
+                <a:solidFill>
+                  <a:srgbClr val="1F2430"/>
+                </a:solidFill>
+                <a:latin typeface="Calibri" pitchFamily="34" charset="0"/>
+                <a:ea typeface="Calibri" pitchFamily="34" charset="-122"/>
+                <a:cs typeface="Calibri" pitchFamily="34" charset="-120"/>
+              </a:rPr>
+              <a:t>hook</a:t>
+            </a:r>
+            <a:endParaRPr lang="en-US" sz="1000" dirty="0"/>
+          </a:p>
+        </p:txBody>
+      </p:sp>
+      <p:sp>
+        <p:nvSpPr>
+          <p:cNvPr id="148" name="Shape 146"/>
+          <p:cNvSpPr/>
+          <p:nvPr/>
+        </p:nvSpPr>
+        <p:spPr>
+          <a:xfrm>
+            <a:off x="7019544" y="5486400"/>
+            <a:ext cx="747776" cy="256032"/>
+          </a:xfrm>
+          <a:prstGeom prst="roundRect">
+            <a:avLst>
+              <a:gd name="adj" fmla="val 50000"/>
+            </a:avLst>
+          </a:prstGeom>
+          <a:solidFill>
+            <a:srgbClr val="F3F5F8"/>
+          </a:solidFill>
+          <a:ln w="12700">
+            <a:solidFill>
+              <a:srgbClr val="F3F5F8"/>
+            </a:solidFill>
+            <a:prstDash val="solid"/>
+          </a:ln>
+        </p:spPr>
+      </p:sp>
+      <p:sp>
+        <p:nvSpPr>
+          <p:cNvPr id="149" name="Text 147"/>
+          <p:cNvSpPr txBox="1"/>
+          <p:nvPr/>
+        </p:nvSpPr>
+        <p:spPr>
+          <a:xfrm>
+            <a:off x="7019544" y="5486400"/>
             <a:ext cx="747776" cy="256032"/>
           </a:xfrm>
           <a:prstGeom prst="rect">
@@ -25976,7 +26451,7 @@
                 <a:ea typeface="Courier New" pitchFamily="34" charset="-122"/>
                 <a:cs typeface="Courier New" pitchFamily="34" charset="-120"/>
               </a:rPr>
-              <a:t>  sdlc 0.10.0, license: community</a:t>
+              <a:t>  sdlc 0.11.0, license: community</a:t>
             </a:r>
             <a:endParaRPr lang="en-US" sz="1000" dirty="0"/>
           </a:p>
@@ -26027,7 +26502,7 @@
                 <a:ea typeface="Courier New" pitchFamily="34" charset="-122"/>
                 <a:cs typeface="Courier New" pitchFamily="34" charset="-120"/>
               </a:rPr>
-              <a:t>  files: 64 created, 0 updated, 0</a:t>
+              <a:t>  files: 67 created, 0 updated, 0</a:t>
             </a:r>
             <a:endParaRPr lang="en-US" sz="1000" dirty="0"/>
           </a:p>

</xml_diff>

<commit_message>
fix: agents cannot weaken the review policy or the artifact rules (0.11.1)
- The review policy (REVIEW.md, its usual places or the path in
  review.policy), the sdlc schema in openspec/schemas/sdlc/ and
  openspec/config.yaml are guard files: an agent's edits and shell writes
  are denied, also in warn mode; sdlc init and layout scaffold still
  write them.
- The adopt workflow proposes review policy changes to the person instead
  of editing the policy.
</commit_message>
<xml_diff>
--- a/docs/demo/sdlc-calculator-demo.en.pptx
+++ b/docs/demo/sdlc-calculator-demo.en.pptx
@@ -6659,7 +6659,7 @@
                 <a:ea typeface="Courier New" pitchFamily="34" charset="-122"/>
                 <a:cs typeface="Courier New" pitchFamily="34" charset="-120"/>
               </a:rPr>
-              <a:t>  code-owner (794602e2105c)</a:t>
+              <a:t>  code-owner (fda718d788b8)</a:t>
             </a:r>
             <a:endParaRPr lang="en-US" sz="1000" dirty="0"/>
           </a:p>
@@ -7340,7 +7340,7 @@
                 <a:ea typeface="Courier New" pitchFamily="34" charset="-122"/>
                 <a:cs typeface="Courier New" pitchFamily="34" charset="-120"/>
               </a:rPr>
-              <a:t>  release-manager (794602e2105c)</a:t>
+              <a:t>  release-manager (fda718d788b8)</a:t>
             </a:r>
             <a:endParaRPr lang="en-US" sz="1000" dirty="0"/>
           </a:p>
@@ -7640,7 +7640,7 @@
                 <a:ea typeface="Courier New" pitchFamily="34" charset="-122"/>
                 <a:cs typeface="Courier New" pitchFamily="34" charset="-120"/>
               </a:rPr>
-              <a:t>✓ basic-arithmetic/intent alice valid 2b809052</a:t>
+              <a:t>✓ basic-arithmetic/intent alice valid 16180068</a:t>
             </a:r>
             <a:endParaRPr lang="en-US" sz="1000" dirty="0"/>
           </a:p>
@@ -7657,7 +7657,7 @@
                 <a:ea typeface="Courier New" pitchFamily="34" charset="-122"/>
                 <a:cs typeface="Courier New" pitchFamily="34" charset="-120"/>
               </a:rPr>
-              <a:t>✓ basic-arithmetic/spec alice valid 2bef4479</a:t>
+              <a:t>✓ basic-arithmetic/spec alice valid 83fc80dd</a:t>
             </a:r>
             <a:endParaRPr lang="en-US" sz="1000" dirty="0"/>
           </a:p>
@@ -7674,7 +7674,7 @@
                 <a:ea typeface="Courier New" pitchFamily="34" charset="-122"/>
                 <a:cs typeface="Courier New" pitchFamily="34" charset="-120"/>
               </a:rPr>
-              <a:t>✗ basic-arithmetic/plan bob wrong-signer 2bef4479</a:t>
+              <a:t>✗ basic-arithmetic/plan bob wrong-signer 83fc80dd</a:t>
             </a:r>
             <a:endParaRPr lang="en-US" sz="1000" dirty="0"/>
           </a:p>
@@ -7691,7 +7691,7 @@
                 <a:ea typeface="Courier New" pitchFamily="34" charset="-122"/>
                 <a:cs typeface="Courier New" pitchFamily="34" charset="-120"/>
               </a:rPr>
-              <a:t>✓ basic-arithmetic/review carol valid 8f916d32</a:t>
+              <a:t>✓ basic-arithmetic/review carol valid 3782ae14</a:t>
             </a:r>
             <a:endParaRPr lang="en-US" sz="1000" dirty="0"/>
           </a:p>
@@ -7708,7 +7708,7 @@
                 <a:ea typeface="Courier New" pitchFamily="34" charset="-122"/>
                 <a:cs typeface="Courier New" pitchFamily="34" charset="-120"/>
               </a:rPr>
-              <a:t>✓ basic-arithmetic/release alice valid ea758646</a:t>
+              <a:t>✓ basic-arithmetic/release alice valid c11195b6</a:t>
             </a:r>
             <a:endParaRPr lang="en-US" sz="1000" dirty="0"/>
           </a:p>
@@ -7725,7 +7725,7 @@
                 <a:ea typeface="Courier New" pitchFamily="34" charset="-122"/>
                 <a:cs typeface="Courier New" pitchFamily="34" charset="-120"/>
               </a:rPr>
-              <a:t>✓ openspec/roles.yaml alice@calc.example valid 6514c2cc</a:t>
+              <a:t>✓ openspec/roles.yaml alice@calc.example valid 2f8830ef</a:t>
             </a:r>
             <a:endParaRPr lang="en-US" sz="1000" dirty="0"/>
           </a:p>
@@ -14145,7 +14145,7 @@
                 <a:ea typeface="Courier New" pitchFamily="34" charset="-122"/>
                 <a:cs typeface="Courier New" pitchFamily="34" charset="-120"/>
               </a:rPr>
-              <a:t>  archived) · sdlc 0.11.0, license:</a:t>
+              <a:t>  archived) · sdlc 0.11.1, license:</a:t>
             </a:r>
             <a:endParaRPr lang="en-US" sz="1000" dirty="0"/>
           </a:p>
@@ -14298,7 +14298,7 @@
                 <a:ea typeface="Courier New" pitchFamily="34" charset="-122"/>
                 <a:cs typeface="Courier New" pitchFamily="34" charset="-120"/>
               </a:rPr>
-              <a:t>  intent 4 · spec 9 · plan 9 · review 3;</a:t>
+              <a:t>  intent 3 · spec 8 · plan 9 · review 3;</a:t>
             </a:r>
             <a:endParaRPr lang="en-US" sz="1000" dirty="0"/>
           </a:p>
@@ -14332,7 +14332,7 @@
                 <a:ea typeface="Courier New" pitchFamily="34" charset="-122"/>
                 <a:cs typeface="Courier New" pitchFamily="34" charset="-120"/>
               </a:rPr>
-              <a:t>  recorded with sdlc 0.11.0; licenses:</a:t>
+              <a:t>  recorded with sdlc 0.11.1; licenses:</a:t>
             </a:r>
             <a:endParaRPr lang="en-US" sz="1000" dirty="0"/>
           </a:p>
@@ -14649,7 +14649,7 @@
                 <a:ea typeface="Courier New" pitchFamily="34" charset="-122"/>
                 <a:cs typeface="Courier New" pitchFamily="34" charset="-120"/>
               </a:rPr>
-              <a:t>2026-10-07T20:04:38.093Z  gate.review.await</a:t>
+              <a:t>2026-10-08T06:37:08.475Z  gate.review.await</a:t>
             </a:r>
             <a:endParaRPr lang="en-US" sz="1000" dirty="0"/>
           </a:p>
@@ -14683,7 +14683,7 @@
                 <a:ea typeface="Courier New" pitchFamily="34" charset="-122"/>
                 <a:cs typeface="Courier New" pitchFamily="34" charset="-120"/>
               </a:rPr>
-              <a:t>  sha256:794602e2105c13b0465c4edcf3dd269ebf</a:t>
+              <a:t>  sha256:fda718d788b83c13e8184a62fb1b24b1b5</a:t>
             </a:r>
             <a:endParaRPr lang="en-US" sz="1000" dirty="0"/>
           </a:p>
@@ -14700,7 +14700,7 @@
                 <a:ea typeface="Courier New" pitchFamily="34" charset="-122"/>
                 <a:cs typeface="Courier New" pitchFamily="34" charset="-120"/>
               </a:rPr>
-              <a:t>  3d7dc4ac9ee2d9aee4f1ea229023ec [sdlc</a:t>
+              <a:t>  e3a2a7fc69809bc3e958dd14af3986 [sdlc</a:t>
             </a:r>
             <a:endParaRPr lang="en-US" sz="1000" dirty="0"/>
           </a:p>
@@ -14717,7 +14717,7 @@
                 <a:ea typeface="Courier New" pitchFamily="34" charset="-122"/>
                 <a:cs typeface="Courier New" pitchFamily="34" charset="-120"/>
               </a:rPr>
-              <a:t>  0.11.0 · community]</a:t>
+              <a:t>  0.11.1 · community]</a:t>
             </a:r>
             <a:endParaRPr lang="en-US" sz="1000" dirty="0"/>
           </a:p>
@@ -14734,7 +14734,7 @@
                 <a:ea typeface="Courier New" pitchFamily="34" charset="-122"/>
                 <a:cs typeface="Courier New" pitchFamily="34" charset="-120"/>
               </a:rPr>
-              <a:t>2026-10-07T20:04:41.234Z  gate.review.appro</a:t>
+              <a:t>2026-10-08T06:37:11.297Z  gate.review.appro</a:t>
             </a:r>
             <a:endParaRPr lang="en-US" sz="1000" dirty="0"/>
           </a:p>
@@ -14785,7 +14785,7 @@
                 <a:ea typeface="Courier New" pitchFamily="34" charset="-122"/>
                 <a:cs typeface="Courier New" pitchFamily="34" charset="-120"/>
               </a:rPr>
-              <a:t>  [sdlc 0.11.0 · community]</a:t>
+              <a:t>  [sdlc 0.11.1 · community]</a:t>
             </a:r>
             <a:endParaRPr lang="en-US" sz="1000" dirty="0"/>
           </a:p>
@@ -14802,7 +14802,7 @@
                 <a:ea typeface="Courier New" pitchFamily="34" charset="-122"/>
                 <a:cs typeface="Courier New" pitchFamily="34" charset="-120"/>
               </a:rPr>
-              <a:t>2026-10-07T20:04:45.854Z  gate.release.appr</a:t>
+              <a:t>2026-10-08T06:37:15.533Z  gate.release.appr</a:t>
             </a:r>
             <a:endParaRPr lang="en-US" sz="1000" dirty="0"/>
           </a:p>
@@ -14853,7 +14853,7 @@
                 <a:ea typeface="Courier New" pitchFamily="34" charset="-122"/>
                 <a:cs typeface="Courier New" pitchFamily="34" charset="-120"/>
               </a:rPr>
-              <a:t>  release-manager [sdlc 0.11.0 · community]</a:t>
+              <a:t>  release-manager [sdlc 0.11.1 · community]</a:t>
             </a:r>
             <a:endParaRPr lang="en-US" sz="1000" dirty="0"/>
           </a:p>
@@ -16030,7 +16030,7 @@
                 <a:ea typeface="Courier New" pitchFamily="34" charset="-122"/>
                 <a:cs typeface="Courier New" pitchFamily="34" charset="-120"/>
               </a:rPr>
-              <a:t>✓ test (1.1s)</a:t>
+              <a:t>✓ test (0.9s)</a:t>
             </a:r>
             <a:endParaRPr lang="en-US" sz="1000" dirty="0"/>
           </a:p>
@@ -16047,7 +16047,7 @@
                 <a:ea typeface="Courier New" pitchFamily="34" charset="-122"/>
                 <a:cs typeface="Courier New" pitchFamily="34" charset="-120"/>
               </a:rPr>
-              <a:t>✓ ci-green (ci/pipeline_status, 0.6s)</a:t>
+              <a:t>✓ ci-green (ci/pipeline_status, 0.5s)</a:t>
             </a:r>
             <a:endParaRPr lang="en-US" sz="1000" dirty="0"/>
           </a:p>
@@ -16483,7 +16483,7 @@
                 <a:ea typeface="Courier New" pitchFamily="34" charset="-122"/>
                 <a:cs typeface="Courier New" pitchFamily="34" charset="-120"/>
               </a:rPr>
-              <a:t>      "id": "20261007T200527818Z-ci-green-a</a:t>
+              <a:t>      "id": "20261008T063753150Z-ci-green-1</a:t>
             </a:r>
             <a:endParaRPr lang="en-US" sz="1000" dirty="0"/>
           </a:p>
@@ -16500,7 +16500,7 @@
                 <a:ea typeface="Courier New" pitchFamily="34" charset="-122"/>
                 <a:cs typeface="Courier New" pitchFamily="34" charset="-120"/>
               </a:rPr>
-              <a:t>  b5c0d",</a:t>
+              <a:t>  9bd91",</a:t>
             </a:r>
             <a:endParaRPr lang="en-US" sz="1000" dirty="0"/>
           </a:p>
@@ -16636,7 +16636,7 @@
                 <a:ea typeface="Courier New" pitchFamily="34" charset="-122"/>
                 <a:cs typeface="Courier New" pitchFamily="34" charset="-120"/>
               </a:rPr>
-              <a:t>        "ref": "0b6a530445076524df168fb2551</a:t>
+              <a:t>        "ref": "91532c7ef2228edea69b5a326c3</a:t>
             </a:r>
             <a:endParaRPr lang="en-US" sz="1000" dirty="0"/>
           </a:p>
@@ -16653,7 +16653,7 @@
                 <a:ea typeface="Courier New" pitchFamily="34" charset="-122"/>
                 <a:cs typeface="Courier New" pitchFamily="34" charset="-120"/>
               </a:rPr>
-              <a:t>  fa0504e5a1ac4",</a:t>
+              <a:t>  7e6f8195304f5",</a:t>
             </a:r>
             <a:endParaRPr lang="en-US" sz="1000" dirty="0"/>
           </a:p>
@@ -26451,7 +26451,7 @@
                 <a:ea typeface="Courier New" pitchFamily="34" charset="-122"/>
                 <a:cs typeface="Courier New" pitchFamily="34" charset="-120"/>
               </a:rPr>
-              <a:t>  sdlc 0.11.0, license: community</a:t>
+              <a:t>  sdlc 0.11.1, license: community</a:t>
             </a:r>
             <a:endParaRPr lang="en-US" sz="1000" dirty="0"/>
           </a:p>

</xml_diff>

<commit_message>
feat: Cursor IDE as a tool (0.13.0)
- sdlc init --tools cursor writes the workflows as skills with thin
  commands, the subagents, an always-applied rule about the process, the
  sdlc MCP server (--mcp) and Cursor's own hooks (.cursor/hooks.json).
- The hooks deny edits before the plan is approved, a person's decisions
  in the agent's shell, deletes and edits of protected files and folders,
  and clearing the agent marker; the project is found from the workspace
  roots; every tool goes through preToolUse; when sdlc has nothing to say
  it answers an explicit allow.
- CURSOR_AGENT=1 marks the agent's terminal: sdlc approve refuses there,
  and commits from it carry SDLC-Agent: cursor.
- sdlc doctor checks the hooks and says that separation of duties in
  Cursor rests on CURSOR_AGENT, and on Windows that Git Bash terminals can
  break Cursor's hooks.
</commit_message>
<xml_diff>
--- a/docs/demo/sdlc-calculator-demo.en.pptx
+++ b/docs/demo/sdlc-calculator-demo.en.pptx
@@ -6660,7 +6660,7 @@
                 <a:ea typeface="Courier New" pitchFamily="34" charset="-122"/>
                 <a:cs typeface="Courier New" pitchFamily="34" charset="-120"/>
               </a:rPr>
-              <a:t>  code-owner (015cf69a73e1)</a:t>
+              <a:t>  code-owner (29b1dbba496e)</a:t>
             </a:r>
             <a:endParaRPr lang="en-US" sz="1000" dirty="0"/>
           </a:p>
@@ -6745,7 +6745,7 @@
                 <a:ea typeface="Courier New" pitchFamily="34" charset="-122"/>
                 <a:cs typeface="Courier New" pitchFamily="34" charset="-120"/>
               </a:rPr>
-              <a:t>  "SDLC-Approval: basic-arithmetic:review:0</a:t>
+              <a:t>  "SDLC-Approval: basic-arithmetic:review:2</a:t>
             </a:r>
             <a:endParaRPr lang="en-US" sz="1000" dirty="0"/>
           </a:p>
@@ -6762,7 +6762,7 @@
                 <a:ea typeface="Courier New" pitchFamily="34" charset="-122"/>
                 <a:cs typeface="Courier New" pitchFamily="34" charset="-120"/>
               </a:rPr>
-              <a:t>  15cf69a73e1"</a:t>
+              <a:t>  9b1dbba496e"</a:t>
             </a:r>
             <a:endParaRPr lang="en-US" sz="1000" dirty="0"/>
           </a:p>
@@ -7443,7 +7443,7 @@
                 <a:ea typeface="Courier New" pitchFamily="34" charset="-122"/>
                 <a:cs typeface="Courier New" pitchFamily="34" charset="-120"/>
               </a:rPr>
-              <a:t>  release-manager (015cf69a73e1)</a:t>
+              <a:t>  release-manager (29b1dbba496e)</a:t>
             </a:r>
             <a:endParaRPr lang="en-US" sz="1000" dirty="0"/>
           </a:p>
@@ -7511,7 +7511,7 @@
                 <a:ea typeface="Courier New" pitchFamily="34" charset="-122"/>
                 <a:cs typeface="Courier New" pitchFamily="34" charset="-120"/>
               </a:rPr>
-              <a:t>  gate" -m "SDLC-Approval: basic-arithmetic:release:015cf69a73e1"</a:t>
+              <a:t>  gate" -m "SDLC-Approval: basic-arithmetic:release:29b1dbba496e"</a:t>
             </a:r>
             <a:endParaRPr lang="en-US" sz="1000" dirty="0"/>
           </a:p>
@@ -7811,7 +7811,7 @@
                 <a:ea typeface="Courier New" pitchFamily="34" charset="-122"/>
                 <a:cs typeface="Courier New" pitchFamily="34" charset="-120"/>
               </a:rPr>
-              <a:t>✓ basic-arithmetic/intent alice valid 8cfdef5c</a:t>
+              <a:t>✓ basic-arithmetic/intent alice valid 5986f269</a:t>
             </a:r>
             <a:endParaRPr lang="en-US" sz="1000" dirty="0"/>
           </a:p>
@@ -7828,7 +7828,7 @@
                 <a:ea typeface="Courier New" pitchFamily="34" charset="-122"/>
                 <a:cs typeface="Courier New" pitchFamily="34" charset="-120"/>
               </a:rPr>
-              <a:t>✓ basic-arithmetic/spec alice valid 5891a520</a:t>
+              <a:t>✓ basic-arithmetic/spec alice valid 085df546</a:t>
             </a:r>
             <a:endParaRPr lang="en-US" sz="1000" dirty="0"/>
           </a:p>
@@ -7845,7 +7845,7 @@
                 <a:ea typeface="Courier New" pitchFamily="34" charset="-122"/>
                 <a:cs typeface="Courier New" pitchFamily="34" charset="-120"/>
               </a:rPr>
-              <a:t>✗ basic-arithmetic/plan bob wrong-signer 5891a520</a:t>
+              <a:t>✗ basic-arithmetic/plan bob wrong-signer 085df546</a:t>
             </a:r>
             <a:endParaRPr lang="en-US" sz="1000" dirty="0"/>
           </a:p>
@@ -7862,7 +7862,7 @@
                 <a:ea typeface="Courier New" pitchFamily="34" charset="-122"/>
                 <a:cs typeface="Courier New" pitchFamily="34" charset="-120"/>
               </a:rPr>
-              <a:t>✓ basic-arithmetic/review carol valid 07a01500</a:t>
+              <a:t>✓ basic-arithmetic/review carol valid 699847b1</a:t>
             </a:r>
             <a:endParaRPr lang="en-US" sz="1000" dirty="0"/>
           </a:p>
@@ -7879,7 +7879,7 @@
                 <a:ea typeface="Courier New" pitchFamily="34" charset="-122"/>
                 <a:cs typeface="Courier New" pitchFamily="34" charset="-120"/>
               </a:rPr>
-              <a:t>✓ basic-arithmetic/release alice valid 4b9f8a00</a:t>
+              <a:t>✓ basic-arithmetic/release alice valid 5a612384</a:t>
             </a:r>
             <a:endParaRPr lang="en-US" sz="1000" dirty="0"/>
           </a:p>
@@ -7896,7 +7896,7 @@
                 <a:ea typeface="Courier New" pitchFamily="34" charset="-122"/>
                 <a:cs typeface="Courier New" pitchFamily="34" charset="-120"/>
               </a:rPr>
-              <a:t>✓ openspec/roles.yaml alice@calc.example valid a53165de</a:t>
+              <a:t>✓ openspec/roles.yaml alice@calc.example valid 9b596928</a:t>
             </a:r>
             <a:endParaRPr lang="en-US" sz="1000" dirty="0"/>
           </a:p>
@@ -14382,7 +14382,7 @@
                 <a:ea typeface="Courier New" pitchFamily="34" charset="-122"/>
                 <a:cs typeface="Courier New" pitchFamily="34" charset="-120"/>
               </a:rPr>
-              <a:t>  archived) · sdlc 0.12.0, license:</a:t>
+              <a:t>  archived) · sdlc 0.13.0, license:</a:t>
             </a:r>
             <a:endParaRPr lang="en-US" sz="1000" dirty="0"/>
           </a:p>
@@ -14569,7 +14569,7 @@
                 <a:ea typeface="Courier New" pitchFamily="34" charset="-122"/>
                 <a:cs typeface="Courier New" pitchFamily="34" charset="-120"/>
               </a:rPr>
-              <a:t>  intent 3 · plan 11 · review 3; rework</a:t>
+              <a:t>  intent 3 · plan 12 · review 3; rework</a:t>
             </a:r>
             <a:endParaRPr lang="en-US" sz="1000" dirty="0"/>
           </a:p>
@@ -14903,7 +14903,7 @@
                 <a:ea typeface="Courier New" pitchFamily="34" charset="-122"/>
                 <a:cs typeface="Courier New" pitchFamily="34" charset="-120"/>
               </a:rPr>
-              <a:t>2026-10-08T18:05:20.873Z  gate.review.await</a:t>
+              <a:t>2026-10-08T20:23:00.314Z  gate.review.await</a:t>
             </a:r>
             <a:endParaRPr lang="en-US" sz="1000" dirty="0"/>
           </a:p>
@@ -14937,7 +14937,7 @@
                 <a:ea typeface="Courier New" pitchFamily="34" charset="-122"/>
                 <a:cs typeface="Courier New" pitchFamily="34" charset="-120"/>
               </a:rPr>
-              <a:t>  sha256:015cf69a73e188c763cff17b8a014f4818</a:t>
+              <a:t>  sha256:29b1dbba496e041498a058028b98136d93</a:t>
             </a:r>
             <a:endParaRPr lang="en-US" sz="1000" dirty="0"/>
           </a:p>
@@ -14954,7 +14954,7 @@
                 <a:ea typeface="Courier New" pitchFamily="34" charset="-122"/>
                 <a:cs typeface="Courier New" pitchFamily="34" charset="-120"/>
               </a:rPr>
-              <a:t>  b9d1376d24e5184ebf2225a7e3facc [sdlc</a:t>
+              <a:t>  d86655c53e4f94210285298afc8b7b [sdlc</a:t>
             </a:r>
             <a:endParaRPr lang="en-US" sz="1000" dirty="0"/>
           </a:p>
@@ -14971,7 +14971,7 @@
                 <a:ea typeface="Courier New" pitchFamily="34" charset="-122"/>
                 <a:cs typeface="Courier New" pitchFamily="34" charset="-120"/>
               </a:rPr>
-              <a:t>  0.12.0 · community]</a:t>
+              <a:t>  0.13.0 · community]</a:t>
             </a:r>
             <a:endParaRPr lang="en-US" sz="1000" dirty="0"/>
           </a:p>
@@ -14988,7 +14988,7 @@
                 <a:ea typeface="Courier New" pitchFamily="34" charset="-122"/>
                 <a:cs typeface="Courier New" pitchFamily="34" charset="-120"/>
               </a:rPr>
-              <a:t>2026-10-08T18:05:23.694Z  gate.review.appro</a:t>
+              <a:t>2026-10-08T20:23:03.413Z  gate.review.appro</a:t>
             </a:r>
             <a:endParaRPr lang="en-US" sz="1000" dirty="0"/>
           </a:p>
@@ -15039,7 +15039,7 @@
                 <a:ea typeface="Courier New" pitchFamily="34" charset="-122"/>
                 <a:cs typeface="Courier New" pitchFamily="34" charset="-120"/>
               </a:rPr>
-              <a:t>  [sdlc 0.12.0 · community]</a:t>
+              <a:t>  [sdlc 0.13.0 · community]</a:t>
             </a:r>
             <a:endParaRPr lang="en-US" sz="1000" dirty="0"/>
           </a:p>
@@ -15056,7 +15056,7 @@
                 <a:ea typeface="Courier New" pitchFamily="34" charset="-122"/>
                 <a:cs typeface="Courier New" pitchFamily="34" charset="-120"/>
               </a:rPr>
-              <a:t>2026-10-08T18:05:29.269Z  gate.release.appr</a:t>
+              <a:t>2026-10-08T20:23:09.449Z  gate.release.appr</a:t>
             </a:r>
             <a:endParaRPr lang="en-US" sz="1000" dirty="0"/>
           </a:p>
@@ -15107,7 +15107,7 @@
                 <a:ea typeface="Courier New" pitchFamily="34" charset="-122"/>
                 <a:cs typeface="Courier New" pitchFamily="34" charset="-120"/>
               </a:rPr>
-              <a:t>  release-manager [sdlc 0.12.0 · community]</a:t>
+              <a:t>  release-manager [sdlc 0.13.0 · community]</a:t>
             </a:r>
             <a:endParaRPr lang="en-US" sz="1000" dirty="0"/>
           </a:p>
@@ -16737,7 +16737,7 @@
                 <a:ea typeface="Courier New" pitchFamily="34" charset="-122"/>
                 <a:cs typeface="Courier New" pitchFamily="34" charset="-120"/>
               </a:rPr>
-              <a:t>      "id": "20261008T180609887Z-ci-green-6</a:t>
+              <a:t>      "id": "20261008T202353353Z-ci-green-e</a:t>
             </a:r>
             <a:endParaRPr lang="en-US" sz="1000" dirty="0"/>
           </a:p>
@@ -16754,7 +16754,7 @@
                 <a:ea typeface="Courier New" pitchFamily="34" charset="-122"/>
                 <a:cs typeface="Courier New" pitchFamily="34" charset="-120"/>
               </a:rPr>
-              <a:t>  70cfe",</a:t>
+              <a:t>  a4554",</a:t>
             </a:r>
             <a:endParaRPr lang="en-US" sz="1000" dirty="0"/>
           </a:p>
@@ -16890,7 +16890,7 @@
                 <a:ea typeface="Courier New" pitchFamily="34" charset="-122"/>
                 <a:cs typeface="Courier New" pitchFamily="34" charset="-120"/>
               </a:rPr>
-              <a:t>        "ref": "87d968ae0c990e15c352fd2bf1a</a:t>
+              <a:t>        "ref": "9ff236a0b14f8f0d5f07bfe9331</a:t>
             </a:r>
             <a:endParaRPr lang="en-US" sz="1000" dirty="0"/>
           </a:p>
@@ -16907,7 +16907,7 @@
                 <a:ea typeface="Courier New" pitchFamily="34" charset="-122"/>
                 <a:cs typeface="Courier New" pitchFamily="34" charset="-120"/>
               </a:rPr>
-              <a:t>  bd52742b741f0",</a:t>
+              <a:t>  c51dd6f7a0cc8",</a:t>
             </a:r>
             <a:endParaRPr lang="en-US" sz="1000" dirty="0"/>
           </a:p>
@@ -26969,7 +26969,7 @@
                 <a:ea typeface="Courier New" pitchFamily="34" charset="-122"/>
                 <a:cs typeface="Courier New" pitchFamily="34" charset="-120"/>
               </a:rPr>
-              <a:t>  sdlc 0.12.0, license: community</a:t>
+              <a:t>  sdlc 0.13.0, license: community</a:t>
             </a:r>
             <a:endParaRPr lang="en-US" sz="1000" dirty="0"/>
           </a:p>

</xml_diff>

<commit_message>
feat: the team's MCP servers in Cursor (0.13.1)
- sdlc update lays the team's MCP registry (mcp.servers) out into
  .cursor/mcp.json too: stdio as { command, args, env }, http as
  { url, headers }, secrets as Cursor's ${env:VAR}, next to the sdlc
  server; servers added by hand stay.
</commit_message>
<xml_diff>
--- a/docs/demo/sdlc-calculator-demo.en.pptx
+++ b/docs/demo/sdlc-calculator-demo.en.pptx
@@ -6660,7 +6660,7 @@
                 <a:ea typeface="Courier New" pitchFamily="34" charset="-122"/>
                 <a:cs typeface="Courier New" pitchFamily="34" charset="-120"/>
               </a:rPr>
-              <a:t>  code-owner (29b1dbba496e)</a:t>
+              <a:t>  code-owner (0e1f099045b8)</a:t>
             </a:r>
             <a:endParaRPr lang="en-US" sz="1000" dirty="0"/>
           </a:p>
@@ -6745,7 +6745,7 @@
                 <a:ea typeface="Courier New" pitchFamily="34" charset="-122"/>
                 <a:cs typeface="Courier New" pitchFamily="34" charset="-120"/>
               </a:rPr>
-              <a:t>  "SDLC-Approval: basic-arithmetic:review:2</a:t>
+              <a:t>  "SDLC-Approval: basic-arithmetic:review:0</a:t>
             </a:r>
             <a:endParaRPr lang="en-US" sz="1000" dirty="0"/>
           </a:p>
@@ -6762,7 +6762,7 @@
                 <a:ea typeface="Courier New" pitchFamily="34" charset="-122"/>
                 <a:cs typeface="Courier New" pitchFamily="34" charset="-120"/>
               </a:rPr>
-              <a:t>  9b1dbba496e"</a:t>
+              <a:t>  e1f099045b8"</a:t>
             </a:r>
             <a:endParaRPr lang="en-US" sz="1000" dirty="0"/>
           </a:p>
@@ -7443,7 +7443,7 @@
                 <a:ea typeface="Courier New" pitchFamily="34" charset="-122"/>
                 <a:cs typeface="Courier New" pitchFamily="34" charset="-120"/>
               </a:rPr>
-              <a:t>  release-manager (29b1dbba496e)</a:t>
+              <a:t>  release-manager (0e1f099045b8)</a:t>
             </a:r>
             <a:endParaRPr lang="en-US" sz="1000" dirty="0"/>
           </a:p>
@@ -7511,7 +7511,7 @@
                 <a:ea typeface="Courier New" pitchFamily="34" charset="-122"/>
                 <a:cs typeface="Courier New" pitchFamily="34" charset="-120"/>
               </a:rPr>
-              <a:t>  gate" -m "SDLC-Approval: basic-arithmetic:release:29b1dbba496e"</a:t>
+              <a:t>  gate" -m "SDLC-Approval: basic-arithmetic:release:0e1f099045b8"</a:t>
             </a:r>
             <a:endParaRPr lang="en-US" sz="1000" dirty="0"/>
           </a:p>
@@ -7811,7 +7811,7 @@
                 <a:ea typeface="Courier New" pitchFamily="34" charset="-122"/>
                 <a:cs typeface="Courier New" pitchFamily="34" charset="-120"/>
               </a:rPr>
-              <a:t>✓ basic-arithmetic/intent alice valid 5986f269</a:t>
+              <a:t>✓ basic-arithmetic/intent alice valid cfb73c63</a:t>
             </a:r>
             <a:endParaRPr lang="en-US" sz="1000" dirty="0"/>
           </a:p>
@@ -7828,7 +7828,7 @@
                 <a:ea typeface="Courier New" pitchFamily="34" charset="-122"/>
                 <a:cs typeface="Courier New" pitchFamily="34" charset="-120"/>
               </a:rPr>
-              <a:t>✓ basic-arithmetic/spec alice valid 085df546</a:t>
+              <a:t>✓ basic-arithmetic/spec alice valid bb4a18dc</a:t>
             </a:r>
             <a:endParaRPr lang="en-US" sz="1000" dirty="0"/>
           </a:p>
@@ -7845,7 +7845,7 @@
                 <a:ea typeface="Courier New" pitchFamily="34" charset="-122"/>
                 <a:cs typeface="Courier New" pitchFamily="34" charset="-120"/>
               </a:rPr>
-              <a:t>✗ basic-arithmetic/plan bob wrong-signer 085df546</a:t>
+              <a:t>✗ basic-arithmetic/plan bob wrong-signer bb4a18dc</a:t>
             </a:r>
             <a:endParaRPr lang="en-US" sz="1000" dirty="0"/>
           </a:p>
@@ -7862,7 +7862,7 @@
                 <a:ea typeface="Courier New" pitchFamily="34" charset="-122"/>
                 <a:cs typeface="Courier New" pitchFamily="34" charset="-120"/>
               </a:rPr>
-              <a:t>✓ basic-arithmetic/review carol valid 699847b1</a:t>
+              <a:t>✓ basic-arithmetic/review carol valid 5d27bce0</a:t>
             </a:r>
             <a:endParaRPr lang="en-US" sz="1000" dirty="0"/>
           </a:p>
@@ -7879,7 +7879,7 @@
                 <a:ea typeface="Courier New" pitchFamily="34" charset="-122"/>
                 <a:cs typeface="Courier New" pitchFamily="34" charset="-120"/>
               </a:rPr>
-              <a:t>✓ basic-arithmetic/release alice valid 5a612384</a:t>
+              <a:t>✓ basic-arithmetic/release alice valid 0ccb2085</a:t>
             </a:r>
             <a:endParaRPr lang="en-US" sz="1000" dirty="0"/>
           </a:p>
@@ -7896,7 +7896,7 @@
                 <a:ea typeface="Courier New" pitchFamily="34" charset="-122"/>
                 <a:cs typeface="Courier New" pitchFamily="34" charset="-120"/>
               </a:rPr>
-              <a:t>✓ openspec/roles.yaml alice@calc.example valid 9b596928</a:t>
+              <a:t>✓ openspec/roles.yaml alice@calc.example valid 267e0793</a:t>
             </a:r>
             <a:endParaRPr lang="en-US" sz="1000" dirty="0"/>
           </a:p>
@@ -14382,7 +14382,7 @@
                 <a:ea typeface="Courier New" pitchFamily="34" charset="-122"/>
                 <a:cs typeface="Courier New" pitchFamily="34" charset="-120"/>
               </a:rPr>
-              <a:t>  archived) · sdlc 0.13.0, license:</a:t>
+              <a:t>  archived) · sdlc 0.13.1, license:</a:t>
             </a:r>
             <a:endParaRPr lang="en-US" sz="1000" dirty="0"/>
           </a:p>
@@ -14569,7 +14569,7 @@
                 <a:ea typeface="Courier New" pitchFamily="34" charset="-122"/>
                 <a:cs typeface="Courier New" pitchFamily="34" charset="-120"/>
               </a:rPr>
-              <a:t>  intent 3 · plan 12 · review 3; rework</a:t>
+              <a:t>  intent 2 · plan 11 · review 3; rework</a:t>
             </a:r>
             <a:endParaRPr lang="en-US" sz="1000" dirty="0"/>
           </a:p>
@@ -14903,7 +14903,7 @@
                 <a:ea typeface="Courier New" pitchFamily="34" charset="-122"/>
                 <a:cs typeface="Courier New" pitchFamily="34" charset="-120"/>
               </a:rPr>
-              <a:t>2026-10-08T20:23:00.314Z  gate.review.await</a:t>
+              <a:t>2026-10-09T05:56:16.077Z  gate.review.await</a:t>
             </a:r>
             <a:endParaRPr lang="en-US" sz="1000" dirty="0"/>
           </a:p>
@@ -14937,7 +14937,7 @@
                 <a:ea typeface="Courier New" pitchFamily="34" charset="-122"/>
                 <a:cs typeface="Courier New" pitchFamily="34" charset="-120"/>
               </a:rPr>
-              <a:t>  sha256:29b1dbba496e041498a058028b98136d93</a:t>
+              <a:t>  sha256:0e1f099045b84ebdb864864f068bd06dfa</a:t>
             </a:r>
             <a:endParaRPr lang="en-US" sz="1000" dirty="0"/>
           </a:p>
@@ -14954,7 +14954,7 @@
                 <a:ea typeface="Courier New" pitchFamily="34" charset="-122"/>
                 <a:cs typeface="Courier New" pitchFamily="34" charset="-120"/>
               </a:rPr>
-              <a:t>  d86655c53e4f94210285298afc8b7b [sdlc</a:t>
+              <a:t>  abcd3d9bc533080a14cc9b465a281a [sdlc</a:t>
             </a:r>
             <a:endParaRPr lang="en-US" sz="1000" dirty="0"/>
           </a:p>
@@ -14971,7 +14971,7 @@
                 <a:ea typeface="Courier New" pitchFamily="34" charset="-122"/>
                 <a:cs typeface="Courier New" pitchFamily="34" charset="-120"/>
               </a:rPr>
-              <a:t>  0.13.0 · community]</a:t>
+              <a:t>  0.13.1 · community]</a:t>
             </a:r>
             <a:endParaRPr lang="en-US" sz="1000" dirty="0"/>
           </a:p>
@@ -14988,7 +14988,7 @@
                 <a:ea typeface="Courier New" pitchFamily="34" charset="-122"/>
                 <a:cs typeface="Courier New" pitchFamily="34" charset="-120"/>
               </a:rPr>
-              <a:t>2026-10-08T20:23:03.413Z  gate.review.appro</a:t>
+              <a:t>2026-10-09T05:56:18.902Z  gate.review.appro</a:t>
             </a:r>
             <a:endParaRPr lang="en-US" sz="1000" dirty="0"/>
           </a:p>
@@ -15039,7 +15039,7 @@
                 <a:ea typeface="Courier New" pitchFamily="34" charset="-122"/>
                 <a:cs typeface="Courier New" pitchFamily="34" charset="-120"/>
               </a:rPr>
-              <a:t>  [sdlc 0.13.0 · community]</a:t>
+              <a:t>  [sdlc 0.13.1 · community]</a:t>
             </a:r>
             <a:endParaRPr lang="en-US" sz="1000" dirty="0"/>
           </a:p>
@@ -15056,7 +15056,7 @@
                 <a:ea typeface="Courier New" pitchFamily="34" charset="-122"/>
                 <a:cs typeface="Courier New" pitchFamily="34" charset="-120"/>
               </a:rPr>
-              <a:t>2026-10-08T20:23:09.449Z  gate.release.appr</a:t>
+              <a:t>2026-10-09T05:56:24.322Z  gate.release.appr</a:t>
             </a:r>
             <a:endParaRPr lang="en-US" sz="1000" dirty="0"/>
           </a:p>
@@ -15107,7 +15107,7 @@
                 <a:ea typeface="Courier New" pitchFamily="34" charset="-122"/>
                 <a:cs typeface="Courier New" pitchFamily="34" charset="-120"/>
               </a:rPr>
-              <a:t>  release-manager [sdlc 0.13.0 · community]</a:t>
+              <a:t>  release-manager [sdlc 0.13.1 · community]</a:t>
             </a:r>
             <a:endParaRPr lang="en-US" sz="1000" dirty="0"/>
           </a:p>
@@ -16284,7 +16284,7 @@
                 <a:ea typeface="Courier New" pitchFamily="34" charset="-122"/>
                 <a:cs typeface="Courier New" pitchFamily="34" charset="-120"/>
               </a:rPr>
-              <a:t>✓ test (1.0s)</a:t>
+              <a:t>✓ test (0.9s)</a:t>
             </a:r>
             <a:endParaRPr lang="en-US" sz="1000" dirty="0"/>
           </a:p>
@@ -16737,7 +16737,7 @@
                 <a:ea typeface="Courier New" pitchFamily="34" charset="-122"/>
                 <a:cs typeface="Courier New" pitchFamily="34" charset="-120"/>
               </a:rPr>
-              <a:t>      "id": "20261008T202353353Z-ci-green-e</a:t>
+              <a:t>      "id": "20261009T055704551Z-ci-green-7</a:t>
             </a:r>
             <a:endParaRPr lang="en-US" sz="1000" dirty="0"/>
           </a:p>
@@ -16754,7 +16754,7 @@
                 <a:ea typeface="Courier New" pitchFamily="34" charset="-122"/>
                 <a:cs typeface="Courier New" pitchFamily="34" charset="-120"/>
               </a:rPr>
-              <a:t>  a4554",</a:t>
+              <a:t>  9856f",</a:t>
             </a:r>
             <a:endParaRPr lang="en-US" sz="1000" dirty="0"/>
           </a:p>
@@ -16890,7 +16890,7 @@
                 <a:ea typeface="Courier New" pitchFamily="34" charset="-122"/>
                 <a:cs typeface="Courier New" pitchFamily="34" charset="-120"/>
               </a:rPr>
-              <a:t>        "ref": "9ff236a0b14f8f0d5f07bfe9331</a:t>
+              <a:t>        "ref": "c6f8a841edea1fbba4dc3db098c</a:t>
             </a:r>
             <a:endParaRPr lang="en-US" sz="1000" dirty="0"/>
           </a:p>
@@ -16907,7 +16907,7 @@
                 <a:ea typeface="Courier New" pitchFamily="34" charset="-122"/>
                 <a:cs typeface="Courier New" pitchFamily="34" charset="-120"/>
               </a:rPr>
-              <a:t>  c51dd6f7a0cc8",</a:t>
+              <a:t>  cc2b484c9a2f3",</a:t>
             </a:r>
             <a:endParaRPr lang="en-US" sz="1000" dirty="0"/>
           </a:p>
@@ -26969,7 +26969,7 @@
                 <a:ea typeface="Courier New" pitchFamily="34" charset="-122"/>
                 <a:cs typeface="Courier New" pitchFamily="34" charset="-120"/>
               </a:rPr>
-              <a:t>  sdlc 0.13.0, license: community</a:t>
+              <a:t>  sdlc 0.13.1, license: community</a:t>
             </a:r>
             <a:endParaRPr lang="en-US" sz="1000" dirty="0"/>
           </a:p>

</xml_diff>

<commit_message>
fix: more shell writes count for the plan gate; the second layer covers every spelling (0.14.2)
- In every tool, git checkout -- <paths>, git restore, git mv, git apply
  and patch (the files the patch names), downloads (curl -o, wget -O,
  Invoke-WebRequest -OutFile), file writes in node -e and python -c, and
  commands inside iex and Start-Process count as edits for the plan gate.
  Branch switches, staged-only restores, git apply --check, reads and
  discarded downloads do not.
- With cli: sdlc, Codex's command rules and the permissions.deny rules of
  Qwen Code and GigaCode also cover the package's older alias and the
  Windows .cmd shims, and refuse sdlc adopt --apply; uninstall removes
  these entries too.
- A table-header-looking line inside a TOML multi-line string in
  .codex/config.toml is no longer taken for a table.
</commit_message>
<xml_diff>
--- a/docs/demo/sdlc-calculator-demo.en.pptx
+++ b/docs/demo/sdlc-calculator-demo.en.pptx
@@ -5112,7 +5112,7 @@
                 <a:ea typeface="Courier New" pitchFamily="34" charset="-122"/>
                 <a:cs typeface="Courier New" pitchFamily="34" charset="-120"/>
               </a:rPr>
-              <a:t>✓ test (1.0s)</a:t>
+              <a:t>✓ test (1.1s)</a:t>
             </a:r>
             <a:endParaRPr lang="en-US" sz="1000" dirty="0"/>
           </a:p>
@@ -6660,7 +6660,7 @@
                 <a:ea typeface="Courier New" pitchFamily="34" charset="-122"/>
                 <a:cs typeface="Courier New" pitchFamily="34" charset="-120"/>
               </a:rPr>
-              <a:t>  code-owner (4344ec8e9412)</a:t>
+              <a:t>  code-owner (b5150d6137dd)</a:t>
             </a:r>
             <a:endParaRPr lang="en-US" sz="1000" dirty="0"/>
           </a:p>
@@ -6745,7 +6745,7 @@
                 <a:ea typeface="Courier New" pitchFamily="34" charset="-122"/>
                 <a:cs typeface="Courier New" pitchFamily="34" charset="-120"/>
               </a:rPr>
-              <a:t>  "SDLC-Approval: basic-arithmetic:review:4</a:t>
+              <a:t>  "SDLC-Approval: basic-arithmetic:review:b</a:t>
             </a:r>
             <a:endParaRPr lang="en-US" sz="1000" dirty="0"/>
           </a:p>
@@ -6762,7 +6762,7 @@
                 <a:ea typeface="Courier New" pitchFamily="34" charset="-122"/>
                 <a:cs typeface="Courier New" pitchFamily="34" charset="-120"/>
               </a:rPr>
-              <a:t>  344ec8e9412"</a:t>
+              <a:t>  5150d6137dd"</a:t>
             </a:r>
             <a:endParaRPr lang="en-US" sz="1000" dirty="0"/>
           </a:p>
@@ -7443,7 +7443,7 @@
                 <a:ea typeface="Courier New" pitchFamily="34" charset="-122"/>
                 <a:cs typeface="Courier New" pitchFamily="34" charset="-120"/>
               </a:rPr>
-              <a:t>  release-manager (4344ec8e9412)</a:t>
+              <a:t>  release-manager (b5150d6137dd)</a:t>
             </a:r>
             <a:endParaRPr lang="en-US" sz="1000" dirty="0"/>
           </a:p>
@@ -7511,7 +7511,7 @@
                 <a:ea typeface="Courier New" pitchFamily="34" charset="-122"/>
                 <a:cs typeface="Courier New" pitchFamily="34" charset="-120"/>
               </a:rPr>
-              <a:t>  gate" -m "SDLC-Approval: basic-arithmetic:release:4344ec8e9412"</a:t>
+              <a:t>  gate" -m "SDLC-Approval: basic-arithmetic:release:b5150d6137dd"</a:t>
             </a:r>
             <a:endParaRPr lang="en-US" sz="1000" dirty="0"/>
           </a:p>
@@ -7811,7 +7811,7 @@
                 <a:ea typeface="Courier New" pitchFamily="34" charset="-122"/>
                 <a:cs typeface="Courier New" pitchFamily="34" charset="-120"/>
               </a:rPr>
-              <a:t>✓ basic-arithmetic/intent alice valid 2ca9c9ea</a:t>
+              <a:t>✓ basic-arithmetic/intent alice valid 1e787adc</a:t>
             </a:r>
             <a:endParaRPr lang="en-US" sz="1000" dirty="0"/>
           </a:p>
@@ -7828,7 +7828,7 @@
                 <a:ea typeface="Courier New" pitchFamily="34" charset="-122"/>
                 <a:cs typeface="Courier New" pitchFamily="34" charset="-120"/>
               </a:rPr>
-              <a:t>✓ basic-arithmetic/spec alice valid 62a342b3</a:t>
+              <a:t>✓ basic-arithmetic/spec alice valid ec113afc</a:t>
             </a:r>
             <a:endParaRPr lang="en-US" sz="1000" dirty="0"/>
           </a:p>
@@ -7845,7 +7845,7 @@
                 <a:ea typeface="Courier New" pitchFamily="34" charset="-122"/>
                 <a:cs typeface="Courier New" pitchFamily="34" charset="-120"/>
               </a:rPr>
-              <a:t>✗ basic-arithmetic/plan bob wrong-signer 62a342b3</a:t>
+              <a:t>✗ basic-arithmetic/plan bob wrong-signer ec113afc</a:t>
             </a:r>
             <a:endParaRPr lang="en-US" sz="1000" dirty="0"/>
           </a:p>
@@ -7862,7 +7862,7 @@
                 <a:ea typeface="Courier New" pitchFamily="34" charset="-122"/>
                 <a:cs typeface="Courier New" pitchFamily="34" charset="-120"/>
               </a:rPr>
-              <a:t>✓ basic-arithmetic/review carol valid 3bc25613</a:t>
+              <a:t>✓ basic-arithmetic/review carol valid 8c573d98</a:t>
             </a:r>
             <a:endParaRPr lang="en-US" sz="1000" dirty="0"/>
           </a:p>
@@ -7879,7 +7879,7 @@
                 <a:ea typeface="Courier New" pitchFamily="34" charset="-122"/>
                 <a:cs typeface="Courier New" pitchFamily="34" charset="-120"/>
               </a:rPr>
-              <a:t>✓ basic-arithmetic/release alice valid 15001de1</a:t>
+              <a:t>✓ basic-arithmetic/release alice valid f31564de</a:t>
             </a:r>
             <a:endParaRPr lang="en-US" sz="1000" dirty="0"/>
           </a:p>
@@ -7896,7 +7896,7 @@
                 <a:ea typeface="Courier New" pitchFamily="34" charset="-122"/>
                 <a:cs typeface="Courier New" pitchFamily="34" charset="-120"/>
               </a:rPr>
-              <a:t>✓ openspec/roles.yaml alice@calc.example valid 0166ab36</a:t>
+              <a:t>✓ openspec/roles.yaml alice@calc.example valid b724cb74</a:t>
             </a:r>
             <a:endParaRPr lang="en-US" sz="1000" dirty="0"/>
           </a:p>
@@ -14382,7 +14382,7 @@
                 <a:ea typeface="Courier New" pitchFamily="34" charset="-122"/>
                 <a:cs typeface="Courier New" pitchFamily="34" charset="-120"/>
               </a:rPr>
-              <a:t>  archived) · sdlc 0.14.1, license:</a:t>
+              <a:t>  archived) · sdlc 0.14.2, license:</a:t>
             </a:r>
             <a:endParaRPr lang="en-US" sz="1000" dirty="0"/>
           </a:p>
@@ -14569,7 +14569,7 @@
                 <a:ea typeface="Courier New" pitchFamily="34" charset="-122"/>
                 <a:cs typeface="Courier New" pitchFamily="34" charset="-120"/>
               </a:rPr>
-              <a:t>  intent 3 · plan 11 · review 3; rework</a:t>
+              <a:t>  intent 3 · plan 12 · review 3; rework</a:t>
             </a:r>
             <a:endParaRPr lang="en-US" sz="1000" dirty="0"/>
           </a:p>
@@ -14903,7 +14903,7 @@
                 <a:ea typeface="Courier New" pitchFamily="34" charset="-122"/>
                 <a:cs typeface="Courier New" pitchFamily="34" charset="-120"/>
               </a:rPr>
-              <a:t>2026-10-09T13:49:37.473Z  gate.review.await</a:t>
+              <a:t>2026-10-09T15:00:00.078Z  gate.review.await</a:t>
             </a:r>
             <a:endParaRPr lang="en-US" sz="1000" dirty="0"/>
           </a:p>
@@ -14937,7 +14937,7 @@
                 <a:ea typeface="Courier New" pitchFamily="34" charset="-122"/>
                 <a:cs typeface="Courier New" pitchFamily="34" charset="-120"/>
               </a:rPr>
-              <a:t>  sha256:4344ec8e9412e6d81a6e67181ed17789f3</a:t>
+              <a:t>  sha256:b5150d6137dd8ae8058337fff0df61f546</a:t>
             </a:r>
             <a:endParaRPr lang="en-US" sz="1000" dirty="0"/>
           </a:p>
@@ -14954,7 +14954,7 @@
                 <a:ea typeface="Courier New" pitchFamily="34" charset="-122"/>
                 <a:cs typeface="Courier New" pitchFamily="34" charset="-120"/>
               </a:rPr>
-              <a:t>  43509bddbffd59407e4021b607ee52 [sdlc</a:t>
+              <a:t>  d71b9d76ac9636700467f2bb73a9d6 [sdlc</a:t>
             </a:r>
             <a:endParaRPr lang="en-US" sz="1000" dirty="0"/>
           </a:p>
@@ -14971,7 +14971,7 @@
                 <a:ea typeface="Courier New" pitchFamily="34" charset="-122"/>
                 <a:cs typeface="Courier New" pitchFamily="34" charset="-120"/>
               </a:rPr>
-              <a:t>  0.14.1 · community]</a:t>
+              <a:t>  0.14.2 · community]</a:t>
             </a:r>
             <a:endParaRPr lang="en-US" sz="1000" dirty="0"/>
           </a:p>
@@ -14988,7 +14988,7 @@
                 <a:ea typeface="Courier New" pitchFamily="34" charset="-122"/>
                 <a:cs typeface="Courier New" pitchFamily="34" charset="-120"/>
               </a:rPr>
-              <a:t>2026-10-09T13:49:40.949Z  gate.review.appro</a:t>
+              <a:t>2026-10-09T15:00:03.458Z  gate.review.appro</a:t>
             </a:r>
             <a:endParaRPr lang="en-US" sz="1000" dirty="0"/>
           </a:p>
@@ -15039,7 +15039,7 @@
                 <a:ea typeface="Courier New" pitchFamily="34" charset="-122"/>
                 <a:cs typeface="Courier New" pitchFamily="34" charset="-120"/>
               </a:rPr>
-              <a:t>  [sdlc 0.14.1 · community]</a:t>
+              <a:t>  [sdlc 0.14.2 · community]</a:t>
             </a:r>
             <a:endParaRPr lang="en-US" sz="1000" dirty="0"/>
           </a:p>
@@ -15056,7 +15056,7 @@
                 <a:ea typeface="Courier New" pitchFamily="34" charset="-122"/>
                 <a:cs typeface="Courier New" pitchFamily="34" charset="-120"/>
               </a:rPr>
-              <a:t>2026-10-09T13:49:47.957Z  gate.release.appr</a:t>
+              <a:t>2026-10-09T15:00:09.402Z  gate.release.appr</a:t>
             </a:r>
             <a:endParaRPr lang="en-US" sz="1000" dirty="0"/>
           </a:p>
@@ -15107,7 +15107,7 @@
                 <a:ea typeface="Courier New" pitchFamily="34" charset="-122"/>
                 <a:cs typeface="Courier New" pitchFamily="34" charset="-120"/>
               </a:rPr>
-              <a:t>  release-manager [sdlc 0.14.1 · community]</a:t>
+              <a:t>  release-manager [sdlc 0.14.2 · community]</a:t>
             </a:r>
             <a:endParaRPr lang="en-US" sz="1000" dirty="0"/>
           </a:p>
@@ -16301,7 +16301,7 @@
                 <a:ea typeface="Courier New" pitchFamily="34" charset="-122"/>
                 <a:cs typeface="Courier New" pitchFamily="34" charset="-120"/>
               </a:rPr>
-              <a:t>✓ ci-green (ci/pipeline_status, 0.5s)</a:t>
+              <a:t>✓ ci-green (ci/pipeline_status, 0.6s)</a:t>
             </a:r>
             <a:endParaRPr lang="en-US" sz="1000" dirty="0"/>
           </a:p>
@@ -16737,7 +16737,7 @@
                 <a:ea typeface="Courier New" pitchFamily="34" charset="-122"/>
                 <a:cs typeface="Courier New" pitchFamily="34" charset="-120"/>
               </a:rPr>
-              <a:t>      "id": "20261009T135033553Z-ci-green-0</a:t>
+              <a:t>      "id": "20261009T150055272Z-ci-green-9</a:t>
             </a:r>
             <a:endParaRPr lang="en-US" sz="1000" dirty="0"/>
           </a:p>
@@ -16754,7 +16754,7 @@
                 <a:ea typeface="Courier New" pitchFamily="34" charset="-122"/>
                 <a:cs typeface="Courier New" pitchFamily="34" charset="-120"/>
               </a:rPr>
-              <a:t>  89eef",</a:t>
+              <a:t>  777b2",</a:t>
             </a:r>
             <a:endParaRPr lang="en-US" sz="1000" dirty="0"/>
           </a:p>
@@ -16890,7 +16890,7 @@
                 <a:ea typeface="Courier New" pitchFamily="34" charset="-122"/>
                 <a:cs typeface="Courier New" pitchFamily="34" charset="-120"/>
               </a:rPr>
-              <a:t>        "ref": "45b70ca257d53f9e59a5b447da6</a:t>
+              <a:t>        "ref": "58dea8abcf1e8b3b1eb9c2e4179</a:t>
             </a:r>
             <a:endParaRPr lang="en-US" sz="1000" dirty="0"/>
           </a:p>
@@ -16907,7 +16907,7 @@
                 <a:ea typeface="Courier New" pitchFamily="34" charset="-122"/>
                 <a:cs typeface="Courier New" pitchFamily="34" charset="-120"/>
               </a:rPr>
-              <a:t>  b3fd870493732",</a:t>
+              <a:t>  d9c0edffc7417",</a:t>
             </a:r>
             <a:endParaRPr lang="en-US" sz="1000" dirty="0"/>
           </a:p>
@@ -26969,7 +26969,7 @@
                 <a:ea typeface="Courier New" pitchFamily="34" charset="-122"/>
                 <a:cs typeface="Courier New" pitchFamily="34" charset="-120"/>
               </a:rPr>
-              <a:t>  sdlc 0.14.1, license: community</a:t>
+              <a:t>  sdlc 0.14.2, license: community</a:t>
             </a:r>
             <a:endParaRPr lang="en-US" sz="1000" dirty="0"/>
           </a:p>

</xml_diff>

<commit_message>
fix: a failing hook blocks the call in Codex, Qwen Code and GigaCode (0.14.3)
- Codex lets a tool call through when its hook exits non-zero (exit 2
  too), crashes, prints bad JSON or times out; only a JSON deny blocks
  (checked live with codex-cli 0.158.0 on Windows). Qwen Code documents
  the same.
- When the pre-tool hook fails to load or throws, the sdlc command now
  answers that deny itself for these tools, as Claude Code's guard and
  the OpenCode plugin already block a hook that cannot run. A CLI that is
  not installed still lets the call through; sdlc doctor warns about it.
</commit_message>
<xml_diff>
--- a/docs/demo/sdlc-calculator-demo.en.pptx
+++ b/docs/demo/sdlc-calculator-demo.en.pptx
@@ -5112,7 +5112,7 @@
                 <a:ea typeface="Courier New" pitchFamily="34" charset="-122"/>
                 <a:cs typeface="Courier New" pitchFamily="34" charset="-120"/>
               </a:rPr>
-              <a:t>✓ test (1.1s)</a:t>
+              <a:t>✓ test (0.9s)</a:t>
             </a:r>
             <a:endParaRPr lang="en-US" sz="1000" dirty="0"/>
           </a:p>
@@ -6660,7 +6660,7 @@
                 <a:ea typeface="Courier New" pitchFamily="34" charset="-122"/>
                 <a:cs typeface="Courier New" pitchFamily="34" charset="-120"/>
               </a:rPr>
-              <a:t>  code-owner (b5150d6137dd)</a:t>
+              <a:t>  code-owner (66331c0a36bf)</a:t>
             </a:r>
             <a:endParaRPr lang="en-US" sz="1000" dirty="0"/>
           </a:p>
@@ -6745,7 +6745,7 @@
                 <a:ea typeface="Courier New" pitchFamily="34" charset="-122"/>
                 <a:cs typeface="Courier New" pitchFamily="34" charset="-120"/>
               </a:rPr>
-              <a:t>  "SDLC-Approval: basic-arithmetic:review:b</a:t>
+              <a:t>  "SDLC-Approval: basic-arithmetic:review:6</a:t>
             </a:r>
             <a:endParaRPr lang="en-US" sz="1000" dirty="0"/>
           </a:p>
@@ -6762,7 +6762,7 @@
                 <a:ea typeface="Courier New" pitchFamily="34" charset="-122"/>
                 <a:cs typeface="Courier New" pitchFamily="34" charset="-120"/>
               </a:rPr>
-              <a:t>  5150d6137dd"</a:t>
+              <a:t>  6331c0a36bf"</a:t>
             </a:r>
             <a:endParaRPr lang="en-US" sz="1000" dirty="0"/>
           </a:p>
@@ -7443,7 +7443,7 @@
                 <a:ea typeface="Courier New" pitchFamily="34" charset="-122"/>
                 <a:cs typeface="Courier New" pitchFamily="34" charset="-120"/>
               </a:rPr>
-              <a:t>  release-manager (b5150d6137dd)</a:t>
+              <a:t>  release-manager (66331c0a36bf)</a:t>
             </a:r>
             <a:endParaRPr lang="en-US" sz="1000" dirty="0"/>
           </a:p>
@@ -7511,7 +7511,7 @@
                 <a:ea typeface="Courier New" pitchFamily="34" charset="-122"/>
                 <a:cs typeface="Courier New" pitchFamily="34" charset="-120"/>
               </a:rPr>
-              <a:t>  gate" -m "SDLC-Approval: basic-arithmetic:release:b5150d6137dd"</a:t>
+              <a:t>  gate" -m "SDLC-Approval: basic-arithmetic:release:66331c0a36bf"</a:t>
             </a:r>
             <a:endParaRPr lang="en-US" sz="1000" dirty="0"/>
           </a:p>
@@ -7811,7 +7811,7 @@
                 <a:ea typeface="Courier New" pitchFamily="34" charset="-122"/>
                 <a:cs typeface="Courier New" pitchFamily="34" charset="-120"/>
               </a:rPr>
-              <a:t>✓ basic-arithmetic/intent alice valid 1e787adc</a:t>
+              <a:t>✓ basic-arithmetic/intent alice valid c909f64a</a:t>
             </a:r>
             <a:endParaRPr lang="en-US" sz="1000" dirty="0"/>
           </a:p>
@@ -7828,7 +7828,7 @@
                 <a:ea typeface="Courier New" pitchFamily="34" charset="-122"/>
                 <a:cs typeface="Courier New" pitchFamily="34" charset="-120"/>
               </a:rPr>
-              <a:t>✓ basic-arithmetic/spec alice valid ec113afc</a:t>
+              <a:t>✓ basic-arithmetic/spec alice valid ebad5874</a:t>
             </a:r>
             <a:endParaRPr lang="en-US" sz="1000" dirty="0"/>
           </a:p>
@@ -7845,7 +7845,7 @@
                 <a:ea typeface="Courier New" pitchFamily="34" charset="-122"/>
                 <a:cs typeface="Courier New" pitchFamily="34" charset="-120"/>
               </a:rPr>
-              <a:t>✗ basic-arithmetic/plan bob wrong-signer ec113afc</a:t>
+              <a:t>✗ basic-arithmetic/plan bob wrong-signer ebad5874</a:t>
             </a:r>
             <a:endParaRPr lang="en-US" sz="1000" dirty="0"/>
           </a:p>
@@ -7862,7 +7862,7 @@
                 <a:ea typeface="Courier New" pitchFamily="34" charset="-122"/>
                 <a:cs typeface="Courier New" pitchFamily="34" charset="-120"/>
               </a:rPr>
-              <a:t>✓ basic-arithmetic/review carol valid 8c573d98</a:t>
+              <a:t>✓ basic-arithmetic/review carol valid 2491789c</a:t>
             </a:r>
             <a:endParaRPr lang="en-US" sz="1000" dirty="0"/>
           </a:p>
@@ -7879,7 +7879,7 @@
                 <a:ea typeface="Courier New" pitchFamily="34" charset="-122"/>
                 <a:cs typeface="Courier New" pitchFamily="34" charset="-120"/>
               </a:rPr>
-              <a:t>✓ basic-arithmetic/release alice valid f31564de</a:t>
+              <a:t>✓ basic-arithmetic/release alice valid 943fdf96</a:t>
             </a:r>
             <a:endParaRPr lang="en-US" sz="1000" dirty="0"/>
           </a:p>
@@ -7896,7 +7896,7 @@
                 <a:ea typeface="Courier New" pitchFamily="34" charset="-122"/>
                 <a:cs typeface="Courier New" pitchFamily="34" charset="-120"/>
               </a:rPr>
-              <a:t>✓ openspec/roles.yaml alice@calc.example valid b724cb74</a:t>
+              <a:t>✓ openspec/roles.yaml alice@calc.example valid 73863a57</a:t>
             </a:r>
             <a:endParaRPr lang="en-US" sz="1000" dirty="0"/>
           </a:p>
@@ -14382,7 +14382,7 @@
                 <a:ea typeface="Courier New" pitchFamily="34" charset="-122"/>
                 <a:cs typeface="Courier New" pitchFamily="34" charset="-120"/>
               </a:rPr>
-              <a:t>  archived) · sdlc 0.14.2, license:</a:t>
+              <a:t>  archived) · sdlc 0.14.3, license:</a:t>
             </a:r>
             <a:endParaRPr lang="en-US" sz="1000" dirty="0"/>
           </a:p>
@@ -14569,7 +14569,7 @@
                 <a:ea typeface="Courier New" pitchFamily="34" charset="-122"/>
                 <a:cs typeface="Courier New" pitchFamily="34" charset="-120"/>
               </a:rPr>
-              <a:t>  intent 3 · plan 12 · review 3; rework</a:t>
+              <a:t>  intent 2 · plan 10 · review 3; rework</a:t>
             </a:r>
             <a:endParaRPr lang="en-US" sz="1000" dirty="0"/>
           </a:p>
@@ -14903,7 +14903,7 @@
                 <a:ea typeface="Courier New" pitchFamily="34" charset="-122"/>
                 <a:cs typeface="Courier New" pitchFamily="34" charset="-120"/>
               </a:rPr>
-              <a:t>2026-10-09T15:00:00.078Z  gate.review.await</a:t>
+              <a:t>2026-10-09T16:52:27.697Z  gate.review.await</a:t>
             </a:r>
             <a:endParaRPr lang="en-US" sz="1000" dirty="0"/>
           </a:p>
@@ -14937,7 +14937,7 @@
                 <a:ea typeface="Courier New" pitchFamily="34" charset="-122"/>
                 <a:cs typeface="Courier New" pitchFamily="34" charset="-120"/>
               </a:rPr>
-              <a:t>  sha256:b5150d6137dd8ae8058337fff0df61f546</a:t>
+              <a:t>  sha256:66331c0a36bf8fb897033d727e9074d6e0</a:t>
             </a:r>
             <a:endParaRPr lang="en-US" sz="1000" dirty="0"/>
           </a:p>
@@ -14954,7 +14954,7 @@
                 <a:ea typeface="Courier New" pitchFamily="34" charset="-122"/>
                 <a:cs typeface="Courier New" pitchFamily="34" charset="-120"/>
               </a:rPr>
-              <a:t>  d71b9d76ac9636700467f2bb73a9d6 [sdlc</a:t>
+              <a:t>  c3cf4d5a4dda288f48c3f8e2b76297 [sdlc</a:t>
             </a:r>
             <a:endParaRPr lang="en-US" sz="1000" dirty="0"/>
           </a:p>
@@ -14971,7 +14971,7 @@
                 <a:ea typeface="Courier New" pitchFamily="34" charset="-122"/>
                 <a:cs typeface="Courier New" pitchFamily="34" charset="-120"/>
               </a:rPr>
-              <a:t>  0.14.2 · community]</a:t>
+              <a:t>  0.14.3 · community]</a:t>
             </a:r>
             <a:endParaRPr lang="en-US" sz="1000" dirty="0"/>
           </a:p>
@@ -14988,7 +14988,7 @@
                 <a:ea typeface="Courier New" pitchFamily="34" charset="-122"/>
                 <a:cs typeface="Courier New" pitchFamily="34" charset="-120"/>
               </a:rPr>
-              <a:t>2026-10-09T15:00:03.458Z  gate.review.appro</a:t>
+              <a:t>2026-10-09T16:52:30.543Z  gate.review.appro</a:t>
             </a:r>
             <a:endParaRPr lang="en-US" sz="1000" dirty="0"/>
           </a:p>
@@ -15039,7 +15039,7 @@
                 <a:ea typeface="Courier New" pitchFamily="34" charset="-122"/>
                 <a:cs typeface="Courier New" pitchFamily="34" charset="-120"/>
               </a:rPr>
-              <a:t>  [sdlc 0.14.2 · community]</a:t>
+              <a:t>  [sdlc 0.14.3 · community]</a:t>
             </a:r>
             <a:endParaRPr lang="en-US" sz="1000" dirty="0"/>
           </a:p>
@@ -15056,7 +15056,7 @@
                 <a:ea typeface="Courier New" pitchFamily="34" charset="-122"/>
                 <a:cs typeface="Courier New" pitchFamily="34" charset="-120"/>
               </a:rPr>
-              <a:t>2026-10-09T15:00:09.402Z  gate.release.appr</a:t>
+              <a:t>2026-10-09T16:52:35.934Z  gate.release.appr</a:t>
             </a:r>
             <a:endParaRPr lang="en-US" sz="1000" dirty="0"/>
           </a:p>
@@ -15107,7 +15107,7 @@
                 <a:ea typeface="Courier New" pitchFamily="34" charset="-122"/>
                 <a:cs typeface="Courier New" pitchFamily="34" charset="-120"/>
               </a:rPr>
-              <a:t>  release-manager [sdlc 0.14.2 · community]</a:t>
+              <a:t>  release-manager [sdlc 0.14.3 · community]</a:t>
             </a:r>
             <a:endParaRPr lang="en-US" sz="1000" dirty="0"/>
           </a:p>
@@ -16284,7 +16284,7 @@
                 <a:ea typeface="Courier New" pitchFamily="34" charset="-122"/>
                 <a:cs typeface="Courier New" pitchFamily="34" charset="-120"/>
               </a:rPr>
-              <a:t>✓ test (1.0s)</a:t>
+              <a:t>✓ test (0.9s)</a:t>
             </a:r>
             <a:endParaRPr lang="en-US" sz="1000" dirty="0"/>
           </a:p>
@@ -16301,7 +16301,7 @@
                 <a:ea typeface="Courier New" pitchFamily="34" charset="-122"/>
                 <a:cs typeface="Courier New" pitchFamily="34" charset="-120"/>
               </a:rPr>
-              <a:t>✓ ci-green (ci/pipeline_status, 0.6s)</a:t>
+              <a:t>✓ ci-green (ci/pipeline_status, 0.5s)</a:t>
             </a:r>
             <a:endParaRPr lang="en-US" sz="1000" dirty="0"/>
           </a:p>
@@ -16737,7 +16737,7 @@
                 <a:ea typeface="Courier New" pitchFamily="34" charset="-122"/>
                 <a:cs typeface="Courier New" pitchFamily="34" charset="-120"/>
               </a:rPr>
-              <a:t>      "id": "20261009T150055272Z-ci-green-9</a:t>
+              <a:t>      "id": "20261009T165315835Z-ci-green-0</a:t>
             </a:r>
             <a:endParaRPr lang="en-US" sz="1000" dirty="0"/>
           </a:p>
@@ -16754,7 +16754,7 @@
                 <a:ea typeface="Courier New" pitchFamily="34" charset="-122"/>
                 <a:cs typeface="Courier New" pitchFamily="34" charset="-120"/>
               </a:rPr>
-              <a:t>  777b2",</a:t>
+              <a:t>  6538c",</a:t>
             </a:r>
             <a:endParaRPr lang="en-US" sz="1000" dirty="0"/>
           </a:p>
@@ -16890,7 +16890,7 @@
                 <a:ea typeface="Courier New" pitchFamily="34" charset="-122"/>
                 <a:cs typeface="Courier New" pitchFamily="34" charset="-120"/>
               </a:rPr>
-              <a:t>        "ref": "58dea8abcf1e8b3b1eb9c2e4179</a:t>
+              <a:t>        "ref": "3d8af713e07451edcf4dd6f28ea</a:t>
             </a:r>
             <a:endParaRPr lang="en-US" sz="1000" dirty="0"/>
           </a:p>
@@ -16907,7 +16907,7 @@
                 <a:ea typeface="Courier New" pitchFamily="34" charset="-122"/>
                 <a:cs typeface="Courier New" pitchFamily="34" charset="-120"/>
               </a:rPr>
-              <a:t>  d9c0edffc7417",</a:t>
+              <a:t>  620a6df876044",</a:t>
             </a:r>
             <a:endParaRPr lang="en-US" sz="1000" dirty="0"/>
           </a:p>
@@ -26969,7 +26969,7 @@
                 <a:ea typeface="Courier New" pitchFamily="34" charset="-122"/>
                 <a:cs typeface="Courier New" pitchFamily="34" charset="-120"/>
               </a:rPr>
-              <a:t>  sdlc 0.14.2, license: community</a:t>
+              <a:t>  sdlc 0.14.3, license: community</a:t>
             </a:r>
             <a:endParaRPr lang="en-US" sz="1000" dirty="0"/>
           </a:p>

</xml_diff>

<commit_message>
fix: no code of an npm pack runs on any npm; Linux CI (0.14.4)
- npm 10 runs a package's prepare script when npm pack is given a folder
  or a git spec, even with --ignore-scripts, so with npm 10 a team pack
  listed as npm: ./folder or npm: github:... could run its code during
  sdlc team sync. An npm pack is now only a registry package or a .tgz;
  a folder or a repository is refused when the configuration is read
  (a repository belongs in a git: pack), a folder is never handed to npm,
  and npm runs with npm_config_ignore_scripts=true.
- A test wrote a team's own git hook without the executable bit, which
  Linux ignores; the product was not affected.
- Every push and pull request is tested on Linux with npm 10 and npm 11.
</commit_message>
<xml_diff>
--- a/docs/demo/sdlc-calculator-demo.en.pptx
+++ b/docs/demo/sdlc-calculator-demo.en.pptx
@@ -5112,7 +5112,7 @@
                 <a:ea typeface="Courier New" pitchFamily="34" charset="-122"/>
                 <a:cs typeface="Courier New" pitchFamily="34" charset="-120"/>
               </a:rPr>
-              <a:t>✓ test (0.9s)</a:t>
+              <a:t>✓ test (1.1s)</a:t>
             </a:r>
             <a:endParaRPr lang="en-US" sz="1000" dirty="0"/>
           </a:p>
@@ -6660,7 +6660,7 @@
                 <a:ea typeface="Courier New" pitchFamily="34" charset="-122"/>
                 <a:cs typeface="Courier New" pitchFamily="34" charset="-120"/>
               </a:rPr>
-              <a:t>  code-owner (66331c0a36bf)</a:t>
+              <a:t>  code-owner (7f64adb98975)</a:t>
             </a:r>
             <a:endParaRPr lang="en-US" sz="1000" dirty="0"/>
           </a:p>
@@ -6745,7 +6745,7 @@
                 <a:ea typeface="Courier New" pitchFamily="34" charset="-122"/>
                 <a:cs typeface="Courier New" pitchFamily="34" charset="-120"/>
               </a:rPr>
-              <a:t>  "SDLC-Approval: basic-arithmetic:review:6</a:t>
+              <a:t>  "SDLC-Approval: basic-arithmetic:review:7</a:t>
             </a:r>
             <a:endParaRPr lang="en-US" sz="1000" dirty="0"/>
           </a:p>
@@ -6762,7 +6762,7 @@
                 <a:ea typeface="Courier New" pitchFamily="34" charset="-122"/>
                 <a:cs typeface="Courier New" pitchFamily="34" charset="-120"/>
               </a:rPr>
-              <a:t>  6331c0a36bf"</a:t>
+              <a:t>  f64adb98975"</a:t>
             </a:r>
             <a:endParaRPr lang="en-US" sz="1000" dirty="0"/>
           </a:p>
@@ -7443,7 +7443,7 @@
                 <a:ea typeface="Courier New" pitchFamily="34" charset="-122"/>
                 <a:cs typeface="Courier New" pitchFamily="34" charset="-120"/>
               </a:rPr>
-              <a:t>  release-manager (66331c0a36bf)</a:t>
+              <a:t>  release-manager (7f64adb98975)</a:t>
             </a:r>
             <a:endParaRPr lang="en-US" sz="1000" dirty="0"/>
           </a:p>
@@ -7511,7 +7511,7 @@
                 <a:ea typeface="Courier New" pitchFamily="34" charset="-122"/>
                 <a:cs typeface="Courier New" pitchFamily="34" charset="-120"/>
               </a:rPr>
-              <a:t>  gate" -m "SDLC-Approval: basic-arithmetic:release:66331c0a36bf"</a:t>
+              <a:t>  gate" -m "SDLC-Approval: basic-arithmetic:release:7f64adb98975"</a:t>
             </a:r>
             <a:endParaRPr lang="en-US" sz="1000" dirty="0"/>
           </a:p>
@@ -7811,7 +7811,7 @@
                 <a:ea typeface="Courier New" pitchFamily="34" charset="-122"/>
                 <a:cs typeface="Courier New" pitchFamily="34" charset="-120"/>
               </a:rPr>
-              <a:t>✓ basic-arithmetic/intent alice valid c909f64a</a:t>
+              <a:t>✓ basic-arithmetic/intent alice valid ce9d8230</a:t>
             </a:r>
             <a:endParaRPr lang="en-US" sz="1000" dirty="0"/>
           </a:p>
@@ -7828,7 +7828,7 @@
                 <a:ea typeface="Courier New" pitchFamily="34" charset="-122"/>
                 <a:cs typeface="Courier New" pitchFamily="34" charset="-120"/>
               </a:rPr>
-              <a:t>✓ basic-arithmetic/spec alice valid ebad5874</a:t>
+              <a:t>✓ basic-arithmetic/spec alice valid 425f0638</a:t>
             </a:r>
             <a:endParaRPr lang="en-US" sz="1000" dirty="0"/>
           </a:p>
@@ -7845,7 +7845,7 @@
                 <a:ea typeface="Courier New" pitchFamily="34" charset="-122"/>
                 <a:cs typeface="Courier New" pitchFamily="34" charset="-120"/>
               </a:rPr>
-              <a:t>✗ basic-arithmetic/plan bob wrong-signer ebad5874</a:t>
+              <a:t>✗ basic-arithmetic/plan bob wrong-signer 425f0638</a:t>
             </a:r>
             <a:endParaRPr lang="en-US" sz="1000" dirty="0"/>
           </a:p>
@@ -7862,7 +7862,7 @@
                 <a:ea typeface="Courier New" pitchFamily="34" charset="-122"/>
                 <a:cs typeface="Courier New" pitchFamily="34" charset="-120"/>
               </a:rPr>
-              <a:t>✓ basic-arithmetic/review carol valid 2491789c</a:t>
+              <a:t>✓ basic-arithmetic/review carol valid eebf83f3</a:t>
             </a:r>
             <a:endParaRPr lang="en-US" sz="1000" dirty="0"/>
           </a:p>
@@ -7879,7 +7879,7 @@
                 <a:ea typeface="Courier New" pitchFamily="34" charset="-122"/>
                 <a:cs typeface="Courier New" pitchFamily="34" charset="-120"/>
               </a:rPr>
-              <a:t>✓ basic-arithmetic/release alice valid 943fdf96</a:t>
+              <a:t>✓ basic-arithmetic/release alice valid 490bb26b</a:t>
             </a:r>
             <a:endParaRPr lang="en-US" sz="1000" dirty="0"/>
           </a:p>
@@ -7896,7 +7896,7 @@
                 <a:ea typeface="Courier New" pitchFamily="34" charset="-122"/>
                 <a:cs typeface="Courier New" pitchFamily="34" charset="-120"/>
               </a:rPr>
-              <a:t>✓ openspec/roles.yaml alice@calc.example valid 73863a57</a:t>
+              <a:t>✓ openspec/roles.yaml alice@calc.example valid 8f5a9e39</a:t>
             </a:r>
             <a:endParaRPr lang="en-US" sz="1000" dirty="0"/>
           </a:p>
@@ -14382,7 +14382,7 @@
                 <a:ea typeface="Courier New" pitchFamily="34" charset="-122"/>
                 <a:cs typeface="Courier New" pitchFamily="34" charset="-120"/>
               </a:rPr>
-              <a:t>  archived) · sdlc 0.14.3, license:</a:t>
+              <a:t>  archived) · sdlc 0.14.4, license:</a:t>
             </a:r>
             <a:endParaRPr lang="en-US" sz="1000" dirty="0"/>
           </a:p>
@@ -14569,7 +14569,7 @@
                 <a:ea typeface="Courier New" pitchFamily="34" charset="-122"/>
                 <a:cs typeface="Courier New" pitchFamily="34" charset="-120"/>
               </a:rPr>
-              <a:t>  intent 2 · plan 10 · review 3; rework</a:t>
+              <a:t>  intent 3 · plan 11 · review 3; rework</a:t>
             </a:r>
             <a:endParaRPr lang="en-US" sz="1000" dirty="0"/>
           </a:p>
@@ -14903,7 +14903,7 @@
                 <a:ea typeface="Courier New" pitchFamily="34" charset="-122"/>
                 <a:cs typeface="Courier New" pitchFamily="34" charset="-120"/>
               </a:rPr>
-              <a:t>2026-10-09T16:52:27.697Z  gate.review.await</a:t>
+              <a:t>2026-10-09T19:44:19.499Z  gate.review.await</a:t>
             </a:r>
             <a:endParaRPr lang="en-US" sz="1000" dirty="0"/>
           </a:p>
@@ -14937,7 +14937,7 @@
                 <a:ea typeface="Courier New" pitchFamily="34" charset="-122"/>
                 <a:cs typeface="Courier New" pitchFamily="34" charset="-120"/>
               </a:rPr>
-              <a:t>  sha256:66331c0a36bf8fb897033d727e9074d6e0</a:t>
+              <a:t>  sha256:7f64adb98975582b9196364477c348c9fd</a:t>
             </a:r>
             <a:endParaRPr lang="en-US" sz="1000" dirty="0"/>
           </a:p>
@@ -14954,7 +14954,7 @@
                 <a:ea typeface="Courier New" pitchFamily="34" charset="-122"/>
                 <a:cs typeface="Courier New" pitchFamily="34" charset="-120"/>
               </a:rPr>
-              <a:t>  c3cf4d5a4dda288f48c3f8e2b76297 [sdlc</a:t>
+              <a:t>  a808eec3db9d899da48a469abb01d7 [sdlc</a:t>
             </a:r>
             <a:endParaRPr lang="en-US" sz="1000" dirty="0"/>
           </a:p>
@@ -14971,7 +14971,7 @@
                 <a:ea typeface="Courier New" pitchFamily="34" charset="-122"/>
                 <a:cs typeface="Courier New" pitchFamily="34" charset="-120"/>
               </a:rPr>
-              <a:t>  0.14.3 · community]</a:t>
+              <a:t>  0.14.4 · community]</a:t>
             </a:r>
             <a:endParaRPr lang="en-US" sz="1000" dirty="0"/>
           </a:p>
@@ -14988,7 +14988,7 @@
                 <a:ea typeface="Courier New" pitchFamily="34" charset="-122"/>
                 <a:cs typeface="Courier New" pitchFamily="34" charset="-120"/>
               </a:rPr>
-              <a:t>2026-10-09T16:52:30.543Z  gate.review.appro</a:t>
+              <a:t>2026-10-09T19:44:22.589Z  gate.review.appro</a:t>
             </a:r>
             <a:endParaRPr lang="en-US" sz="1000" dirty="0"/>
           </a:p>
@@ -15039,7 +15039,7 @@
                 <a:ea typeface="Courier New" pitchFamily="34" charset="-122"/>
                 <a:cs typeface="Courier New" pitchFamily="34" charset="-120"/>
               </a:rPr>
-              <a:t>  [sdlc 0.14.3 · community]</a:t>
+              <a:t>  [sdlc 0.14.4 · community]</a:t>
             </a:r>
             <a:endParaRPr lang="en-US" sz="1000" dirty="0"/>
           </a:p>
@@ -15056,7 +15056,7 @@
                 <a:ea typeface="Courier New" pitchFamily="34" charset="-122"/>
                 <a:cs typeface="Courier New" pitchFamily="34" charset="-120"/>
               </a:rPr>
-              <a:t>2026-10-09T16:52:35.934Z  gate.release.appr</a:t>
+              <a:t>2026-10-09T19:44:28.712Z  gate.release.appr</a:t>
             </a:r>
             <a:endParaRPr lang="en-US" sz="1000" dirty="0"/>
           </a:p>
@@ -15107,7 +15107,7 @@
                 <a:ea typeface="Courier New" pitchFamily="34" charset="-122"/>
                 <a:cs typeface="Courier New" pitchFamily="34" charset="-120"/>
               </a:rPr>
-              <a:t>  release-manager [sdlc 0.14.3 · community]</a:t>
+              <a:t>  release-manager [sdlc 0.14.4 · community]</a:t>
             </a:r>
             <a:endParaRPr lang="en-US" sz="1000" dirty="0"/>
           </a:p>
@@ -16737,7 +16737,7 @@
                 <a:ea typeface="Courier New" pitchFamily="34" charset="-122"/>
                 <a:cs typeface="Courier New" pitchFamily="34" charset="-120"/>
               </a:rPr>
-              <a:t>      "id": "20261009T165315835Z-ci-green-0</a:t>
+              <a:t>      "id": "20261009T194511481Z-ci-green-e</a:t>
             </a:r>
             <a:endParaRPr lang="en-US" sz="1000" dirty="0"/>
           </a:p>
@@ -16754,7 +16754,7 @@
                 <a:ea typeface="Courier New" pitchFamily="34" charset="-122"/>
                 <a:cs typeface="Courier New" pitchFamily="34" charset="-120"/>
               </a:rPr>
-              <a:t>  6538c",</a:t>
+              <a:t>  2d8c0",</a:t>
             </a:r>
             <a:endParaRPr lang="en-US" sz="1000" dirty="0"/>
           </a:p>
@@ -16890,7 +16890,7 @@
                 <a:ea typeface="Courier New" pitchFamily="34" charset="-122"/>
                 <a:cs typeface="Courier New" pitchFamily="34" charset="-120"/>
               </a:rPr>
-              <a:t>        "ref": "3d8af713e07451edcf4dd6f28ea</a:t>
+              <a:t>        "ref": "89d37e0a3465b9f5c72ebd0e377</a:t>
             </a:r>
             <a:endParaRPr lang="en-US" sz="1000" dirty="0"/>
           </a:p>
@@ -16907,7 +16907,7 @@
                 <a:ea typeface="Courier New" pitchFamily="34" charset="-122"/>
                 <a:cs typeface="Courier New" pitchFamily="34" charset="-120"/>
               </a:rPr>
-              <a:t>  620a6df876044",</a:t>
+              <a:t>  edd835a2c2f8d",</a:t>
             </a:r>
             <a:endParaRPr lang="en-US" sz="1000" dirty="0"/>
           </a:p>
@@ -26969,7 +26969,7 @@
                 <a:ea typeface="Courier New" pitchFamily="34" charset="-122"/>
                 <a:cs typeface="Courier New" pitchFamily="34" charset="-120"/>
               </a:rPr>
-              <a:t>  sdlc 0.14.3, license: community</a:t>
+              <a:t>  sdlc 0.14.4, license: community</a:t>
             </a:r>
             <a:endParaRPr lang="en-US" sz="1000" dirty="0"/>
           </a:p>

</xml_diff>

<commit_message>
docs: a course for every role; help and the docs know every supported tool (0.14.5)
- sdlc in practice (docs/en/course): twelve modules of short lessons
  for the product owner, tech lead, developer, QA, code owner, release
  manager, platform engineer, engineering manager and an auditor: a new
  project and the conversion of an existing one, with Claude Code and MCP
  servers for GitHub, a knowledge base and Telegram. Commands checked
  against the CLI, outputs from real runs; written to be cut into videos.
- sdlc help --json gives each workflow's invocation for all six tools;
  the text help shows the tools the project is set up for and never fails
  on a broken sdlc.yaml. The health and team workflows have a title and a
  description instead of their key names.
- The documentation covers every supported tool, with a supported-tools
  table in the user guide.
</commit_message>
<xml_diff>
--- a/docs/demo/sdlc-calculator-demo.en.pptx
+++ b/docs/demo/sdlc-calculator-demo.en.pptx
@@ -5112,7 +5112,7 @@
                 <a:ea typeface="Courier New" pitchFamily="34" charset="-122"/>
                 <a:cs typeface="Courier New" pitchFamily="34" charset="-120"/>
               </a:rPr>
-              <a:t>✓ test (1.1s)</a:t>
+              <a:t>✓ test (0.9s)</a:t>
             </a:r>
             <a:endParaRPr lang="en-US" sz="1000" dirty="0"/>
           </a:p>
@@ -6660,7 +6660,7 @@
                 <a:ea typeface="Courier New" pitchFamily="34" charset="-122"/>
                 <a:cs typeface="Courier New" pitchFamily="34" charset="-120"/>
               </a:rPr>
-              <a:t>  code-owner (7f64adb98975)</a:t>
+              <a:t>  code-owner (7f2e33b07f21)</a:t>
             </a:r>
             <a:endParaRPr lang="en-US" sz="1000" dirty="0"/>
           </a:p>
@@ -6762,7 +6762,7 @@
                 <a:ea typeface="Courier New" pitchFamily="34" charset="-122"/>
                 <a:cs typeface="Courier New" pitchFamily="34" charset="-120"/>
               </a:rPr>
-              <a:t>  f64adb98975"</a:t>
+              <a:t>  f2e33b07f21"</a:t>
             </a:r>
             <a:endParaRPr lang="en-US" sz="1000" dirty="0"/>
           </a:p>
@@ -7443,7 +7443,7 @@
                 <a:ea typeface="Courier New" pitchFamily="34" charset="-122"/>
                 <a:cs typeface="Courier New" pitchFamily="34" charset="-120"/>
               </a:rPr>
-              <a:t>  release-manager (7f64adb98975)</a:t>
+              <a:t>  release-manager (7f2e33b07f21)</a:t>
             </a:r>
             <a:endParaRPr lang="en-US" sz="1000" dirty="0"/>
           </a:p>
@@ -7511,7 +7511,7 @@
                 <a:ea typeface="Courier New" pitchFamily="34" charset="-122"/>
                 <a:cs typeface="Courier New" pitchFamily="34" charset="-120"/>
               </a:rPr>
-              <a:t>  gate" -m "SDLC-Approval: basic-arithmetic:release:7f64adb98975"</a:t>
+              <a:t>  gate" -m "SDLC-Approval: basic-arithmetic:release:7f2e33b07f21"</a:t>
             </a:r>
             <a:endParaRPr lang="en-US" sz="1000" dirty="0"/>
           </a:p>
@@ -7811,7 +7811,7 @@
                 <a:ea typeface="Courier New" pitchFamily="34" charset="-122"/>
                 <a:cs typeface="Courier New" pitchFamily="34" charset="-120"/>
               </a:rPr>
-              <a:t>✓ basic-arithmetic/intent alice valid ce9d8230</a:t>
+              <a:t>✓ basic-arithmetic/intent alice valid 68068be4</a:t>
             </a:r>
             <a:endParaRPr lang="en-US" sz="1000" dirty="0"/>
           </a:p>
@@ -7828,7 +7828,7 @@
                 <a:ea typeface="Courier New" pitchFamily="34" charset="-122"/>
                 <a:cs typeface="Courier New" pitchFamily="34" charset="-120"/>
               </a:rPr>
-              <a:t>✓ basic-arithmetic/spec alice valid 425f0638</a:t>
+              <a:t>✓ basic-arithmetic/spec alice valid 657b5c53</a:t>
             </a:r>
             <a:endParaRPr lang="en-US" sz="1000" dirty="0"/>
           </a:p>
@@ -7845,7 +7845,7 @@
                 <a:ea typeface="Courier New" pitchFamily="34" charset="-122"/>
                 <a:cs typeface="Courier New" pitchFamily="34" charset="-120"/>
               </a:rPr>
-              <a:t>✗ basic-arithmetic/plan bob wrong-signer 425f0638</a:t>
+              <a:t>✗ basic-arithmetic/plan bob wrong-signer 657b5c53</a:t>
             </a:r>
             <a:endParaRPr lang="en-US" sz="1000" dirty="0"/>
           </a:p>
@@ -7862,7 +7862,7 @@
                 <a:ea typeface="Courier New" pitchFamily="34" charset="-122"/>
                 <a:cs typeface="Courier New" pitchFamily="34" charset="-120"/>
               </a:rPr>
-              <a:t>✓ basic-arithmetic/review carol valid eebf83f3</a:t>
+              <a:t>✓ basic-arithmetic/review carol valid 0acc4321</a:t>
             </a:r>
             <a:endParaRPr lang="en-US" sz="1000" dirty="0"/>
           </a:p>
@@ -7879,7 +7879,7 @@
                 <a:ea typeface="Courier New" pitchFamily="34" charset="-122"/>
                 <a:cs typeface="Courier New" pitchFamily="34" charset="-120"/>
               </a:rPr>
-              <a:t>✓ basic-arithmetic/release alice valid 490bb26b</a:t>
+              <a:t>✓ basic-arithmetic/release alice valid 768bdbcc</a:t>
             </a:r>
             <a:endParaRPr lang="en-US" sz="1000" dirty="0"/>
           </a:p>
@@ -7896,7 +7896,7 @@
                 <a:ea typeface="Courier New" pitchFamily="34" charset="-122"/>
                 <a:cs typeface="Courier New" pitchFamily="34" charset="-120"/>
               </a:rPr>
-              <a:t>✓ openspec/roles.yaml alice@calc.example valid 8f5a9e39</a:t>
+              <a:t>✓ openspec/roles.yaml alice@calc.example valid b131b70d</a:t>
             </a:r>
             <a:endParaRPr lang="en-US" sz="1000" dirty="0"/>
           </a:p>
@@ -14382,7 +14382,7 @@
                 <a:ea typeface="Courier New" pitchFamily="34" charset="-122"/>
                 <a:cs typeface="Courier New" pitchFamily="34" charset="-120"/>
               </a:rPr>
-              <a:t>  archived) · sdlc 0.14.4, license:</a:t>
+              <a:t>  archived) · sdlc 0.14.5, license:</a:t>
             </a:r>
             <a:endParaRPr lang="en-US" sz="1000" dirty="0"/>
           </a:p>
@@ -14903,7 +14903,7 @@
                 <a:ea typeface="Courier New" pitchFamily="34" charset="-122"/>
                 <a:cs typeface="Courier New" pitchFamily="34" charset="-120"/>
               </a:rPr>
-              <a:t>2026-10-09T19:44:19.499Z  gate.review.await</a:t>
+              <a:t>2026-10-09T21:29:25.383Z  gate.review.await</a:t>
             </a:r>
             <a:endParaRPr lang="en-US" sz="1000" dirty="0"/>
           </a:p>
@@ -14937,7 +14937,7 @@
                 <a:ea typeface="Courier New" pitchFamily="34" charset="-122"/>
                 <a:cs typeface="Courier New" pitchFamily="34" charset="-120"/>
               </a:rPr>
-              <a:t>  sha256:7f64adb98975582b9196364477c348c9fd</a:t>
+              <a:t>  sha256:7f2e33b07f21c8d5b17934994b95a599ab</a:t>
             </a:r>
             <a:endParaRPr lang="en-US" sz="1000" dirty="0"/>
           </a:p>
@@ -14954,7 +14954,7 @@
                 <a:ea typeface="Courier New" pitchFamily="34" charset="-122"/>
                 <a:cs typeface="Courier New" pitchFamily="34" charset="-120"/>
               </a:rPr>
-              <a:t>  a808eec3db9d899da48a469abb01d7 [sdlc</a:t>
+              <a:t>  c149f46ca1ab5677b168e1f0322784 [sdlc</a:t>
             </a:r>
             <a:endParaRPr lang="en-US" sz="1000" dirty="0"/>
           </a:p>
@@ -14971,7 +14971,7 @@
                 <a:ea typeface="Courier New" pitchFamily="34" charset="-122"/>
                 <a:cs typeface="Courier New" pitchFamily="34" charset="-120"/>
               </a:rPr>
-              <a:t>  0.14.4 · community]</a:t>
+              <a:t>  0.14.5 · community]</a:t>
             </a:r>
             <a:endParaRPr lang="en-US" sz="1000" dirty="0"/>
           </a:p>
@@ -14988,7 +14988,7 @@
                 <a:ea typeface="Courier New" pitchFamily="34" charset="-122"/>
                 <a:cs typeface="Courier New" pitchFamily="34" charset="-120"/>
               </a:rPr>
-              <a:t>2026-10-09T19:44:22.589Z  gate.review.appro</a:t>
+              <a:t>2026-10-09T21:29:28.216Z  gate.review.appro</a:t>
             </a:r>
             <a:endParaRPr lang="en-US" sz="1000" dirty="0"/>
           </a:p>
@@ -15039,7 +15039,7 @@
                 <a:ea typeface="Courier New" pitchFamily="34" charset="-122"/>
                 <a:cs typeface="Courier New" pitchFamily="34" charset="-120"/>
               </a:rPr>
-              <a:t>  [sdlc 0.14.4 · community]</a:t>
+              <a:t>  [sdlc 0.14.5 · community]</a:t>
             </a:r>
             <a:endParaRPr lang="en-US" sz="1000" dirty="0"/>
           </a:p>
@@ -15056,7 +15056,7 @@
                 <a:ea typeface="Courier New" pitchFamily="34" charset="-122"/>
                 <a:cs typeface="Courier New" pitchFamily="34" charset="-120"/>
               </a:rPr>
-              <a:t>2026-10-09T19:44:28.712Z  gate.release.appr</a:t>
+              <a:t>2026-10-09T21:29:33.745Z  gate.release.appr</a:t>
             </a:r>
             <a:endParaRPr lang="en-US" sz="1000" dirty="0"/>
           </a:p>
@@ -15107,7 +15107,7 @@
                 <a:ea typeface="Courier New" pitchFamily="34" charset="-122"/>
                 <a:cs typeface="Courier New" pitchFamily="34" charset="-120"/>
               </a:rPr>
-              <a:t>  release-manager [sdlc 0.14.4 · community]</a:t>
+              <a:t>  release-manager [sdlc 0.14.5 · community]</a:t>
             </a:r>
             <a:endParaRPr lang="en-US" sz="1000" dirty="0"/>
           </a:p>
@@ -16284,7 +16284,7 @@
                 <a:ea typeface="Courier New" pitchFamily="34" charset="-122"/>
                 <a:cs typeface="Courier New" pitchFamily="34" charset="-120"/>
               </a:rPr>
-              <a:t>✓ test (0.9s)</a:t>
+              <a:t>✓ test (1.0s)</a:t>
             </a:r>
             <a:endParaRPr lang="en-US" sz="1000" dirty="0"/>
           </a:p>
@@ -16737,7 +16737,7 @@
                 <a:ea typeface="Courier New" pitchFamily="34" charset="-122"/>
                 <a:cs typeface="Courier New" pitchFamily="34" charset="-120"/>
               </a:rPr>
-              <a:t>      "id": "20261009T194511481Z-ci-green-e</a:t>
+              <a:t>      "id": "20261009T213014111Z-ci-green-5</a:t>
             </a:r>
             <a:endParaRPr lang="en-US" sz="1000" dirty="0"/>
           </a:p>
@@ -16754,7 +16754,7 @@
                 <a:ea typeface="Courier New" pitchFamily="34" charset="-122"/>
                 <a:cs typeface="Courier New" pitchFamily="34" charset="-120"/>
               </a:rPr>
-              <a:t>  2d8c0",</a:t>
+              <a:t>  4ac44",</a:t>
             </a:r>
             <a:endParaRPr lang="en-US" sz="1000" dirty="0"/>
           </a:p>
@@ -16890,7 +16890,7 @@
                 <a:ea typeface="Courier New" pitchFamily="34" charset="-122"/>
                 <a:cs typeface="Courier New" pitchFamily="34" charset="-120"/>
               </a:rPr>
-              <a:t>        "ref": "89d37e0a3465b9f5c72ebd0e377</a:t>
+              <a:t>        "ref": "29d0896091df3e0c2abc6824c88</a:t>
             </a:r>
             <a:endParaRPr lang="en-US" sz="1000" dirty="0"/>
           </a:p>
@@ -16907,7 +16907,7 @@
                 <a:ea typeface="Courier New" pitchFamily="34" charset="-122"/>
                 <a:cs typeface="Courier New" pitchFamily="34" charset="-120"/>
               </a:rPr>
-              <a:t>  edd835a2c2f8d",</a:t>
+              <a:t>  a70ac4517a4b4",</a:t>
             </a:r>
             <a:endParaRPr lang="en-US" sz="1000" dirty="0"/>
           </a:p>
@@ -26969,7 +26969,7 @@
                 <a:ea typeface="Courier New" pitchFamily="34" charset="-122"/>
                 <a:cs typeface="Courier New" pitchFamily="34" charset="-120"/>
               </a:rPr>
-              <a:t>  sdlc 0.14.4, license: community</a:t>
+              <a:t>  sdlc 0.14.5, license: community</a:t>
             </a:r>
             <a:endParaRPr lang="en-US" sz="1000" dirty="0"/>
           </a:p>

</xml_diff>

<commit_message>
feat: the plan gate by the files of the plan; takeover holds every planned path (0.14.6)
- With several active changes, the agent may edit code, or write it
  through the shell, only in files an approved plan lists under "Files
  that change"; any other file meets the plan gate. With one active
  change nothing changes. Editing plan.md after its approval voids it.
- The takeover holds plain list items and globs, not only paths in
  backticks, and a plan whose list names no path holds the whole
  project. Takeover, rework and the untouched-planned warning share one
  parser; plan drift keeps its wider reading of the whole plan.
- The Next line and the status line agree with sdlc next after a review
  or release approval.
- The documentation, the course and the handbook describe the new rules.
</commit_message>
<xml_diff>
--- a/docs/demo/sdlc-calculator-demo.en.pptx
+++ b/docs/demo/sdlc-calculator-demo.en.pptx
@@ -5112,7 +5112,7 @@
                 <a:ea typeface="Courier New" pitchFamily="34" charset="-122"/>
                 <a:cs typeface="Courier New" pitchFamily="34" charset="-120"/>
               </a:rPr>
-              <a:t>✓ test (0.9s)</a:t>
+              <a:t>✓ test (1.0s)</a:t>
             </a:r>
             <a:endParaRPr lang="en-US" sz="1000" dirty="0"/>
           </a:p>
@@ -6660,7 +6660,7 @@
                 <a:ea typeface="Courier New" pitchFamily="34" charset="-122"/>
                 <a:cs typeface="Courier New" pitchFamily="34" charset="-120"/>
               </a:rPr>
-              <a:t>  code-owner (7f2e33b07f21)</a:t>
+              <a:t>  code-owner (2274a74f2a51)</a:t>
             </a:r>
             <a:endParaRPr lang="en-US" sz="1000" dirty="0"/>
           </a:p>
@@ -6745,7 +6745,7 @@
                 <a:ea typeface="Courier New" pitchFamily="34" charset="-122"/>
                 <a:cs typeface="Courier New" pitchFamily="34" charset="-120"/>
               </a:rPr>
-              <a:t>  "SDLC-Approval: basic-arithmetic:review:7</a:t>
+              <a:t>  "SDLC-Approval: basic-arithmetic:review:2</a:t>
             </a:r>
             <a:endParaRPr lang="en-US" sz="1000" dirty="0"/>
           </a:p>
@@ -6762,7 +6762,7 @@
                 <a:ea typeface="Courier New" pitchFamily="34" charset="-122"/>
                 <a:cs typeface="Courier New" pitchFamily="34" charset="-120"/>
               </a:rPr>
-              <a:t>  f2e33b07f21"</a:t>
+              <a:t>  274a74f2a51"</a:t>
             </a:r>
             <a:endParaRPr lang="en-US" sz="1000" dirty="0"/>
           </a:p>
@@ -6779,7 +6779,7 @@
                 <a:ea typeface="Courier New" pitchFamily="34" charset="-122"/>
                 <a:cs typeface="Courier New" pitchFamily="34" charset="-120"/>
               </a:rPr>
-              <a:t>Next: person — Carol Hughes (code-owner)</a:t>
+              <a:t>Next: agent — All gates are satisfied:</a:t>
             </a:r>
             <a:endParaRPr lang="en-US" sz="1000" dirty="0"/>
           </a:p>
@@ -6796,7 +6796,7 @@
                 <a:ea typeface="Courier New" pitchFamily="34" charset="-122"/>
                 <a:cs typeface="Courier New" pitchFamily="34" charset="-120"/>
               </a:rPr>
-              <a:t>  must read review.md and the diff, then</a:t>
+              <a:t>  archive the change to merge its delta</a:t>
             </a:r>
             <a:endParaRPr lang="en-US" sz="1000" dirty="0"/>
           </a:p>
@@ -6813,7 +6813,7 @@
                 <a:ea typeface="Courier New" pitchFamily="34" charset="-122"/>
                 <a:cs typeface="Courier New" pitchFamily="34" charset="-120"/>
               </a:rPr>
-              <a:t>  approve the review gate: sdlc approve</a:t>
+              <a:t>  specs into openspec/specs/.</a:t>
             </a:r>
             <a:endParaRPr lang="en-US" sz="1000" dirty="0"/>
           </a:p>
@@ -6830,7 +6830,7 @@
                 <a:ea typeface="Courier New" pitchFamily="34" charset="-122"/>
                 <a:cs typeface="Courier New" pitchFamily="34" charset="-120"/>
               </a:rPr>
-              <a:t>  review --change basic-arithmetic</a:t>
+              <a:t>  (/sdlc:archive)</a:t>
             </a:r>
             <a:endParaRPr lang="en-US" sz="1000" dirty="0"/>
           </a:p>
@@ -7443,7 +7443,7 @@
                 <a:ea typeface="Courier New" pitchFamily="34" charset="-122"/>
                 <a:cs typeface="Courier New" pitchFamily="34" charset="-120"/>
               </a:rPr>
-              <a:t>  release-manager (7f2e33b07f21)</a:t>
+              <a:t>  release-manager (2274a74f2a51)</a:t>
             </a:r>
             <a:endParaRPr lang="en-US" sz="1000" dirty="0"/>
           </a:p>
@@ -7511,7 +7511,7 @@
                 <a:ea typeface="Courier New" pitchFamily="34" charset="-122"/>
                 <a:cs typeface="Courier New" pitchFamily="34" charset="-120"/>
               </a:rPr>
-              <a:t>  gate" -m "SDLC-Approval: basic-arithmetic:release:7f2e33b07f21"</a:t>
+              <a:t>  gate" -m "SDLC-Approval: basic-arithmetic:release:2274a74f2a51"</a:t>
             </a:r>
             <a:endParaRPr lang="en-US" sz="1000" dirty="0"/>
           </a:p>
@@ -7528,7 +7528,7 @@
                 <a:ea typeface="Courier New" pitchFamily="34" charset="-122"/>
                 <a:cs typeface="Courier New" pitchFamily="34" charset="-120"/>
               </a:rPr>
-              <a:t>Next: person — Carol Hughes (code-owner) must read review.md and the</a:t>
+              <a:t>Next: agent — All gates are satisfied: archive the change to merge</a:t>
             </a:r>
             <a:endParaRPr lang="en-US" sz="1000" dirty="0"/>
           </a:p>
@@ -7545,24 +7545,7 @@
                 <a:ea typeface="Courier New" pitchFamily="34" charset="-122"/>
                 <a:cs typeface="Courier New" pitchFamily="34" charset="-120"/>
               </a:rPr>
-              <a:t>  diff, then approve the review gate: sdlc approve review --change</a:t>
-            </a:r>
-            <a:endParaRPr lang="en-US" sz="1000" dirty="0"/>
-          </a:p>
-          <a:p>
-            <a:pPr indent="0" marL="0">
-              <a:buNone/>
-            </a:pPr>
-            <a:r>
-              <a:rPr lang="en-US" sz="1000" dirty="0">
-                <a:solidFill>
-                  <a:srgbClr val="E8EEF2"/>
-                </a:solidFill>
-                <a:latin typeface="Courier New" pitchFamily="34" charset="0"/>
-                <a:ea typeface="Courier New" pitchFamily="34" charset="-122"/>
-                <a:cs typeface="Courier New" pitchFamily="34" charset="-120"/>
-              </a:rPr>
-              <a:t>  basic-arithmetic</a:t>
+              <a:t>  its delta specs into openspec/specs/. (/sdlc:archive)</a:t>
             </a:r>
             <a:endParaRPr lang="en-US" sz="1000" dirty="0"/>
           </a:p>
@@ -7811,7 +7794,7 @@
                 <a:ea typeface="Courier New" pitchFamily="34" charset="-122"/>
                 <a:cs typeface="Courier New" pitchFamily="34" charset="-120"/>
               </a:rPr>
-              <a:t>✓ basic-arithmetic/intent alice valid 68068be4</a:t>
+              <a:t>✓ basic-arithmetic/intent alice valid 2590a7eb</a:t>
             </a:r>
             <a:endParaRPr lang="en-US" sz="1000" dirty="0"/>
           </a:p>
@@ -7828,7 +7811,7 @@
                 <a:ea typeface="Courier New" pitchFamily="34" charset="-122"/>
                 <a:cs typeface="Courier New" pitchFamily="34" charset="-120"/>
               </a:rPr>
-              <a:t>✓ basic-arithmetic/spec alice valid 657b5c53</a:t>
+              <a:t>✓ basic-arithmetic/spec alice valid d5691689</a:t>
             </a:r>
             <a:endParaRPr lang="en-US" sz="1000" dirty="0"/>
           </a:p>
@@ -7845,7 +7828,7 @@
                 <a:ea typeface="Courier New" pitchFamily="34" charset="-122"/>
                 <a:cs typeface="Courier New" pitchFamily="34" charset="-120"/>
               </a:rPr>
-              <a:t>✗ basic-arithmetic/plan bob wrong-signer 657b5c53</a:t>
+              <a:t>✗ basic-arithmetic/plan bob wrong-signer d5691689</a:t>
             </a:r>
             <a:endParaRPr lang="en-US" sz="1000" dirty="0"/>
           </a:p>
@@ -7862,7 +7845,7 @@
                 <a:ea typeface="Courier New" pitchFamily="34" charset="-122"/>
                 <a:cs typeface="Courier New" pitchFamily="34" charset="-120"/>
               </a:rPr>
-              <a:t>✓ basic-arithmetic/review carol valid 0acc4321</a:t>
+              <a:t>✓ basic-arithmetic/review carol valid db7936f0</a:t>
             </a:r>
             <a:endParaRPr lang="en-US" sz="1000" dirty="0"/>
           </a:p>
@@ -7879,7 +7862,7 @@
                 <a:ea typeface="Courier New" pitchFamily="34" charset="-122"/>
                 <a:cs typeface="Courier New" pitchFamily="34" charset="-120"/>
               </a:rPr>
-              <a:t>✓ basic-arithmetic/release alice valid 768bdbcc</a:t>
+              <a:t>✓ basic-arithmetic/release alice valid ff47894c</a:t>
             </a:r>
             <a:endParaRPr lang="en-US" sz="1000" dirty="0"/>
           </a:p>
@@ -7896,7 +7879,7 @@
                 <a:ea typeface="Courier New" pitchFamily="34" charset="-122"/>
                 <a:cs typeface="Courier New" pitchFamily="34" charset="-120"/>
               </a:rPr>
-              <a:t>✓ openspec/roles.yaml alice@calc.example valid b131b70d</a:t>
+              <a:t>✓ openspec/roles.yaml alice@calc.example valid 125efdd7</a:t>
             </a:r>
             <a:endParaRPr lang="en-US" sz="1000" dirty="0"/>
           </a:p>
@@ -8528,7 +8511,7 @@
                 <a:ea typeface="Courier New" pitchFamily="34" charset="-122"/>
                 <a:cs typeface="Courier New" pitchFamily="34" charset="-120"/>
               </a:rPr>
-              <a:t>  openspec\changes\archive\2026-10-09-basic</a:t>
+              <a:t>  openspec\changes\archive\2026-10-11-basic</a:t>
             </a:r>
             <a:endParaRPr lang="en-US" sz="1000" dirty="0"/>
           </a:p>
@@ -14382,7 +14365,7 @@
                 <a:ea typeface="Courier New" pitchFamily="34" charset="-122"/>
                 <a:cs typeface="Courier New" pitchFamily="34" charset="-120"/>
               </a:rPr>
-              <a:t>  archived) · sdlc 0.14.5, license:</a:t>
+              <a:t>  archived) · sdlc 0.14.6, license:</a:t>
             </a:r>
             <a:endParaRPr lang="en-US" sz="1000" dirty="0"/>
           </a:p>
@@ -14903,7 +14886,7 @@
                 <a:ea typeface="Courier New" pitchFamily="34" charset="-122"/>
                 <a:cs typeface="Courier New" pitchFamily="34" charset="-120"/>
               </a:rPr>
-              <a:t>2026-10-09T21:29:25.383Z  gate.review.await</a:t>
+              <a:t>2026-10-11T16:13:26.327Z  gate.review.await</a:t>
             </a:r>
             <a:endParaRPr lang="en-US" sz="1000" dirty="0"/>
           </a:p>
@@ -14937,7 +14920,7 @@
                 <a:ea typeface="Courier New" pitchFamily="34" charset="-122"/>
                 <a:cs typeface="Courier New" pitchFamily="34" charset="-120"/>
               </a:rPr>
-              <a:t>  sha256:7f2e33b07f21c8d5b17934994b95a599ab</a:t>
+              <a:t>  sha256:2274a74f2a51361ceedad8742901ba17c7</a:t>
             </a:r>
             <a:endParaRPr lang="en-US" sz="1000" dirty="0"/>
           </a:p>
@@ -14954,7 +14937,7 @@
                 <a:ea typeface="Courier New" pitchFamily="34" charset="-122"/>
                 <a:cs typeface="Courier New" pitchFamily="34" charset="-120"/>
               </a:rPr>
-              <a:t>  c149f46ca1ab5677b168e1f0322784 [sdlc</a:t>
+              <a:t>  a9e041d0e702149896634b139fb1dc [sdlc</a:t>
             </a:r>
             <a:endParaRPr lang="en-US" sz="1000" dirty="0"/>
           </a:p>
@@ -14971,7 +14954,7 @@
                 <a:ea typeface="Courier New" pitchFamily="34" charset="-122"/>
                 <a:cs typeface="Courier New" pitchFamily="34" charset="-120"/>
               </a:rPr>
-              <a:t>  0.14.5 · community]</a:t>
+              <a:t>  0.14.6 · community]</a:t>
             </a:r>
             <a:endParaRPr lang="en-US" sz="1000" dirty="0"/>
           </a:p>
@@ -14988,7 +14971,7 @@
                 <a:ea typeface="Courier New" pitchFamily="34" charset="-122"/>
                 <a:cs typeface="Courier New" pitchFamily="34" charset="-120"/>
               </a:rPr>
-              <a:t>2026-10-09T21:29:28.216Z  gate.review.appro</a:t>
+              <a:t>2026-10-11T16:13:29.357Z  gate.review.appro</a:t>
             </a:r>
             <a:endParaRPr lang="en-US" sz="1000" dirty="0"/>
           </a:p>
@@ -15039,7 +15022,7 @@
                 <a:ea typeface="Courier New" pitchFamily="34" charset="-122"/>
                 <a:cs typeface="Courier New" pitchFamily="34" charset="-120"/>
               </a:rPr>
-              <a:t>  [sdlc 0.14.5 · community]</a:t>
+              <a:t>  [sdlc 0.14.6 · community]</a:t>
             </a:r>
             <a:endParaRPr lang="en-US" sz="1000" dirty="0"/>
           </a:p>
@@ -15056,7 +15039,7 @@
                 <a:ea typeface="Courier New" pitchFamily="34" charset="-122"/>
                 <a:cs typeface="Courier New" pitchFamily="34" charset="-120"/>
               </a:rPr>
-              <a:t>2026-10-09T21:29:33.745Z  gate.release.appr</a:t>
+              <a:t>2026-10-11T16:13:34.852Z  gate.release.appr</a:t>
             </a:r>
             <a:endParaRPr lang="en-US" sz="1000" dirty="0"/>
           </a:p>
@@ -15107,7 +15090,7 @@
                 <a:ea typeface="Courier New" pitchFamily="34" charset="-122"/>
                 <a:cs typeface="Courier New" pitchFamily="34" charset="-120"/>
               </a:rPr>
-              <a:t>  release-manager [sdlc 0.14.5 · community]</a:t>
+              <a:t>  release-manager [sdlc 0.14.6 · community]</a:t>
             </a:r>
             <a:endParaRPr lang="en-US" sz="1000" dirty="0"/>
           </a:p>
@@ -16737,7 +16720,7 @@
                 <a:ea typeface="Courier New" pitchFamily="34" charset="-122"/>
                 <a:cs typeface="Courier New" pitchFamily="34" charset="-120"/>
               </a:rPr>
-              <a:t>      "id": "20261009T213014111Z-ci-green-5</a:t>
+              <a:t>      "id": "20261011T161417493Z-ci-green-2</a:t>
             </a:r>
             <a:endParaRPr lang="en-US" sz="1000" dirty="0"/>
           </a:p>
@@ -16754,7 +16737,7 @@
                 <a:ea typeface="Courier New" pitchFamily="34" charset="-122"/>
                 <a:cs typeface="Courier New" pitchFamily="34" charset="-120"/>
               </a:rPr>
-              <a:t>  4ac44",</a:t>
+              <a:t>  bbb10",</a:t>
             </a:r>
             <a:endParaRPr lang="en-US" sz="1000" dirty="0"/>
           </a:p>
@@ -16890,7 +16873,7 @@
                 <a:ea typeface="Courier New" pitchFamily="34" charset="-122"/>
                 <a:cs typeface="Courier New" pitchFamily="34" charset="-120"/>
               </a:rPr>
-              <a:t>        "ref": "29d0896091df3e0c2abc6824c88</a:t>
+              <a:t>        "ref": "47aa7231182575c55eb588f0871</a:t>
             </a:r>
             <a:endParaRPr lang="en-US" sz="1000" dirty="0"/>
           </a:p>
@@ -16907,7 +16890,7 @@
                 <a:ea typeface="Courier New" pitchFamily="34" charset="-122"/>
                 <a:cs typeface="Courier New" pitchFamily="34" charset="-120"/>
               </a:rPr>
-              <a:t>  a70ac4517a4b4",</a:t>
+              <a:t>  9e28535ed9910",</a:t>
             </a:r>
             <a:endParaRPr lang="en-US" sz="1000" dirty="0"/>
           </a:p>
@@ -26969,7 +26952,7 @@
                 <a:ea typeface="Courier New" pitchFamily="34" charset="-122"/>
                 <a:cs typeface="Courier New" pitchFamily="34" charset="-120"/>
               </a:rPr>
-              <a:t>  sdlc 0.14.5, license: community</a:t>
+              <a:t>  sdlc 0.14.6, license: community</a:t>
             </a:r>
             <a:endParaRPr lang="en-US" sz="1000" dirty="0"/>
           </a:p>
@@ -33794,7 +33777,7 @@
                 <a:ea typeface="Courier New" pitchFamily="34" charset="-122"/>
                 <a:cs typeface="Courier New" pitchFamily="34" charset="-120"/>
               </a:rPr>
-              <a:t>  (df7cf643b6a1)</a:t>
+              <a:t>  (ca0a7835fb5a)</a:t>
             </a:r>
             <a:endParaRPr lang="en-US" sz="1000" dirty="0"/>
           </a:p>
@@ -33930,7 +33913,7 @@
                 <a:ea typeface="Courier New" pitchFamily="34" charset="-122"/>
                 <a:cs typeface="Courier New" pitchFamily="34" charset="-120"/>
               </a:rPr>
-              <a:t>  df7cf643b6a1"</a:t>
+              <a:t>  ca0a7835fb5a"</a:t>
             </a:r>
             <a:endParaRPr lang="en-US" sz="1000" dirty="0"/>
           </a:p>

</xml_diff>

<commit_message>
feat: team skills for every tool; Cursor's user-level hooks guarded (0.14.7)
- An accepted team skill is installed into the skills folder of every
  configured tool: .claude/skills (OpenCode reads it too), .opencode/skills
  in an OpenCode-only project, .cursor/skills, .agents/skills (Codex CLI),
  .qwen/skills and .gigacode/skills. The hook guards every copy, sdlc team
  check checks every copy, and team.json records all folders (dirs) while
  older records with only dir still read.
- Cursor's user-level hooks (~/.cursor/hooks.json) are the guard's
  configuration: an agent cannot edit them or write them through the
  shell, like the user settings of the other tools.
</commit_message>
<xml_diff>
--- a/docs/demo/sdlc-calculator-demo.en.pptx
+++ b/docs/demo/sdlc-calculator-demo.en.pptx
@@ -6660,7 +6660,7 @@
                 <a:ea typeface="Courier New" pitchFamily="34" charset="-122"/>
                 <a:cs typeface="Courier New" pitchFamily="34" charset="-120"/>
               </a:rPr>
-              <a:t>  code-owner (2274a74f2a51)</a:t>
+              <a:t>  code-owner (a0bc17763e43)</a:t>
             </a:r>
             <a:endParaRPr lang="en-US" sz="1000" dirty="0"/>
           </a:p>
@@ -6745,7 +6745,7 @@
                 <a:ea typeface="Courier New" pitchFamily="34" charset="-122"/>
                 <a:cs typeface="Courier New" pitchFamily="34" charset="-120"/>
               </a:rPr>
-              <a:t>  "SDLC-Approval: basic-arithmetic:review:2</a:t>
+              <a:t>  "SDLC-Approval: basic-arithmetic:review:a</a:t>
             </a:r>
             <a:endParaRPr lang="en-US" sz="1000" dirty="0"/>
           </a:p>
@@ -6762,7 +6762,7 @@
                 <a:ea typeface="Courier New" pitchFamily="34" charset="-122"/>
                 <a:cs typeface="Courier New" pitchFamily="34" charset="-120"/>
               </a:rPr>
-              <a:t>  274a74f2a51"</a:t>
+              <a:t>  0bc17763e43"</a:t>
             </a:r>
             <a:endParaRPr lang="en-US" sz="1000" dirty="0"/>
           </a:p>
@@ -7443,7 +7443,7 @@
                 <a:ea typeface="Courier New" pitchFamily="34" charset="-122"/>
                 <a:cs typeface="Courier New" pitchFamily="34" charset="-120"/>
               </a:rPr>
-              <a:t>  release-manager (2274a74f2a51)</a:t>
+              <a:t>  release-manager (a0bc17763e43)</a:t>
             </a:r>
             <a:endParaRPr lang="en-US" sz="1000" dirty="0"/>
           </a:p>
@@ -7511,7 +7511,7 @@
                 <a:ea typeface="Courier New" pitchFamily="34" charset="-122"/>
                 <a:cs typeface="Courier New" pitchFamily="34" charset="-120"/>
               </a:rPr>
-              <a:t>  gate" -m "SDLC-Approval: basic-arithmetic:release:2274a74f2a51"</a:t>
+              <a:t>  gate" -m "SDLC-Approval: basic-arithmetic:release:a0bc17763e43"</a:t>
             </a:r>
             <a:endParaRPr lang="en-US" sz="1000" dirty="0"/>
           </a:p>
@@ -7794,7 +7794,7 @@
                 <a:ea typeface="Courier New" pitchFamily="34" charset="-122"/>
                 <a:cs typeface="Courier New" pitchFamily="34" charset="-120"/>
               </a:rPr>
-              <a:t>✓ basic-arithmetic/intent alice valid 2590a7eb</a:t>
+              <a:t>✓ basic-arithmetic/intent alice valid 7b23c1f3</a:t>
             </a:r>
             <a:endParaRPr lang="en-US" sz="1000" dirty="0"/>
           </a:p>
@@ -7811,7 +7811,7 @@
                 <a:ea typeface="Courier New" pitchFamily="34" charset="-122"/>
                 <a:cs typeface="Courier New" pitchFamily="34" charset="-120"/>
               </a:rPr>
-              <a:t>✓ basic-arithmetic/spec alice valid d5691689</a:t>
+              <a:t>✓ basic-arithmetic/spec alice valid 0abaa1a3</a:t>
             </a:r>
             <a:endParaRPr lang="en-US" sz="1000" dirty="0"/>
           </a:p>
@@ -7828,7 +7828,7 @@
                 <a:ea typeface="Courier New" pitchFamily="34" charset="-122"/>
                 <a:cs typeface="Courier New" pitchFamily="34" charset="-120"/>
               </a:rPr>
-              <a:t>✗ basic-arithmetic/plan bob wrong-signer d5691689</a:t>
+              <a:t>✗ basic-arithmetic/plan bob wrong-signer 0abaa1a3</a:t>
             </a:r>
             <a:endParaRPr lang="en-US" sz="1000" dirty="0"/>
           </a:p>
@@ -7845,7 +7845,7 @@
                 <a:ea typeface="Courier New" pitchFamily="34" charset="-122"/>
                 <a:cs typeface="Courier New" pitchFamily="34" charset="-120"/>
               </a:rPr>
-              <a:t>✓ basic-arithmetic/review carol valid db7936f0</a:t>
+              <a:t>✓ basic-arithmetic/review carol valid e1f24962</a:t>
             </a:r>
             <a:endParaRPr lang="en-US" sz="1000" dirty="0"/>
           </a:p>
@@ -7862,7 +7862,7 @@
                 <a:ea typeface="Courier New" pitchFamily="34" charset="-122"/>
                 <a:cs typeface="Courier New" pitchFamily="34" charset="-120"/>
               </a:rPr>
-              <a:t>✓ basic-arithmetic/release alice valid ff47894c</a:t>
+              <a:t>✓ basic-arithmetic/release alice valid 66be5a87</a:t>
             </a:r>
             <a:endParaRPr lang="en-US" sz="1000" dirty="0"/>
           </a:p>
@@ -7879,7 +7879,7 @@
                 <a:ea typeface="Courier New" pitchFamily="34" charset="-122"/>
                 <a:cs typeface="Courier New" pitchFamily="34" charset="-120"/>
               </a:rPr>
-              <a:t>✓ openspec/roles.yaml alice@calc.example valid 125efdd7</a:t>
+              <a:t>✓ openspec/roles.yaml alice@calc.example valid 319d380c</a:t>
             </a:r>
             <a:endParaRPr lang="en-US" sz="1000" dirty="0"/>
           </a:p>
@@ -14365,7 +14365,7 @@
                 <a:ea typeface="Courier New" pitchFamily="34" charset="-122"/>
                 <a:cs typeface="Courier New" pitchFamily="34" charset="-120"/>
               </a:rPr>
-              <a:t>  archived) · sdlc 0.14.6, license:</a:t>
+              <a:t>  archived) · sdlc 0.14.7, license:</a:t>
             </a:r>
             <a:endParaRPr lang="en-US" sz="1000" dirty="0"/>
           </a:p>
@@ -14552,7 +14552,7 @@
                 <a:ea typeface="Courier New" pitchFamily="34" charset="-122"/>
                 <a:cs typeface="Courier New" pitchFamily="34" charset="-120"/>
               </a:rPr>
-              <a:t>  intent 3 · plan 11 · review 3; rework</a:t>
+              <a:t>  intent 2 · plan 11 · review 3; rework</a:t>
             </a:r>
             <a:endParaRPr lang="en-US" sz="1000" dirty="0"/>
           </a:p>
@@ -14886,7 +14886,7 @@
                 <a:ea typeface="Courier New" pitchFamily="34" charset="-122"/>
                 <a:cs typeface="Courier New" pitchFamily="34" charset="-120"/>
               </a:rPr>
-              <a:t>2026-10-11T16:13:26.327Z  gate.review.await</a:t>
+              <a:t>2026-10-11T17:31:02.746Z  gate.review.await</a:t>
             </a:r>
             <a:endParaRPr lang="en-US" sz="1000" dirty="0"/>
           </a:p>
@@ -14920,7 +14920,7 @@
                 <a:ea typeface="Courier New" pitchFamily="34" charset="-122"/>
                 <a:cs typeface="Courier New" pitchFamily="34" charset="-120"/>
               </a:rPr>
-              <a:t>  sha256:2274a74f2a51361ceedad8742901ba17c7</a:t>
+              <a:t>  sha256:a0bc17763e4332b307ea1435a7268b67ea</a:t>
             </a:r>
             <a:endParaRPr lang="en-US" sz="1000" dirty="0"/>
           </a:p>
@@ -14937,7 +14937,7 @@
                 <a:ea typeface="Courier New" pitchFamily="34" charset="-122"/>
                 <a:cs typeface="Courier New" pitchFamily="34" charset="-120"/>
               </a:rPr>
-              <a:t>  a9e041d0e702149896634b139fb1dc [sdlc</a:t>
+              <a:t>  0778acd66fdbe2c28977751a7ef077 [sdlc</a:t>
             </a:r>
             <a:endParaRPr lang="en-US" sz="1000" dirty="0"/>
           </a:p>
@@ -14954,7 +14954,7 @@
                 <a:ea typeface="Courier New" pitchFamily="34" charset="-122"/>
                 <a:cs typeface="Courier New" pitchFamily="34" charset="-120"/>
               </a:rPr>
-              <a:t>  0.14.6 · community]</a:t>
+              <a:t>  0.14.7 · community]</a:t>
             </a:r>
             <a:endParaRPr lang="en-US" sz="1000" dirty="0"/>
           </a:p>
@@ -14971,7 +14971,7 @@
                 <a:ea typeface="Courier New" pitchFamily="34" charset="-122"/>
                 <a:cs typeface="Courier New" pitchFamily="34" charset="-120"/>
               </a:rPr>
-              <a:t>2026-10-11T16:13:29.357Z  gate.review.appro</a:t>
+              <a:t>2026-10-11T17:31:05.733Z  gate.review.appro</a:t>
             </a:r>
             <a:endParaRPr lang="en-US" sz="1000" dirty="0"/>
           </a:p>
@@ -15022,7 +15022,7 @@
                 <a:ea typeface="Courier New" pitchFamily="34" charset="-122"/>
                 <a:cs typeface="Courier New" pitchFamily="34" charset="-120"/>
               </a:rPr>
-              <a:t>  [sdlc 0.14.6 · community]</a:t>
+              <a:t>  [sdlc 0.14.7 · community]</a:t>
             </a:r>
             <a:endParaRPr lang="en-US" sz="1000" dirty="0"/>
           </a:p>
@@ -15039,7 +15039,7 @@
                 <a:ea typeface="Courier New" pitchFamily="34" charset="-122"/>
                 <a:cs typeface="Courier New" pitchFamily="34" charset="-120"/>
               </a:rPr>
-              <a:t>2026-10-11T16:13:34.852Z  gate.release.appr</a:t>
+              <a:t>2026-10-11T17:31:11.157Z  gate.release.appr</a:t>
             </a:r>
             <a:endParaRPr lang="en-US" sz="1000" dirty="0"/>
           </a:p>
@@ -15090,7 +15090,7 @@
                 <a:ea typeface="Courier New" pitchFamily="34" charset="-122"/>
                 <a:cs typeface="Courier New" pitchFamily="34" charset="-120"/>
               </a:rPr>
-              <a:t>  release-manager [sdlc 0.14.6 · community]</a:t>
+              <a:t>  release-manager [sdlc 0.14.7 · community]</a:t>
             </a:r>
             <a:endParaRPr lang="en-US" sz="1000" dirty="0"/>
           </a:p>
@@ -16720,7 +16720,7 @@
                 <a:ea typeface="Courier New" pitchFamily="34" charset="-122"/>
                 <a:cs typeface="Courier New" pitchFamily="34" charset="-120"/>
               </a:rPr>
-              <a:t>      "id": "20261011T161417493Z-ci-green-2</a:t>
+              <a:t>      "id": "20261011T173152343Z-ci-green-0</a:t>
             </a:r>
             <a:endParaRPr lang="en-US" sz="1000" dirty="0"/>
           </a:p>
@@ -16737,7 +16737,7 @@
                 <a:ea typeface="Courier New" pitchFamily="34" charset="-122"/>
                 <a:cs typeface="Courier New" pitchFamily="34" charset="-120"/>
               </a:rPr>
-              <a:t>  bbb10",</a:t>
+              <a:t>  1b96e",</a:t>
             </a:r>
             <a:endParaRPr lang="en-US" sz="1000" dirty="0"/>
           </a:p>
@@ -16873,7 +16873,7 @@
                 <a:ea typeface="Courier New" pitchFamily="34" charset="-122"/>
                 <a:cs typeface="Courier New" pitchFamily="34" charset="-120"/>
               </a:rPr>
-              <a:t>        "ref": "47aa7231182575c55eb588f0871</a:t>
+              <a:t>        "ref": "5ea7e36f5375dcc3503b1be8c99</a:t>
             </a:r>
             <a:endParaRPr lang="en-US" sz="1000" dirty="0"/>
           </a:p>
@@ -16890,7 +16890,7 @@
                 <a:ea typeface="Courier New" pitchFamily="34" charset="-122"/>
                 <a:cs typeface="Courier New" pitchFamily="34" charset="-120"/>
               </a:rPr>
-              <a:t>  9e28535ed9910",</a:t>
+              <a:t>  4411ddd532154",</a:t>
             </a:r>
             <a:endParaRPr lang="en-US" sz="1000" dirty="0"/>
           </a:p>
@@ -26952,7 +26952,7 @@
                 <a:ea typeface="Courier New" pitchFamily="34" charset="-122"/>
                 <a:cs typeface="Courier New" pitchFamily="34" charset="-120"/>
               </a:rPr>
-              <a:t>  sdlc 0.14.6, license: community</a:t>
+              <a:t>  sdlc 0.14.7, license: community</a:t>
             </a:r>
             <a:endParaRPr lang="en-US" sz="1000" dirty="0"/>
           </a:p>

</xml_diff>

<commit_message>
feat: events as a ready message; next after a rework; verify --list shows MCP checks (0.15.0)
- A receiver in events may set message: <argument>; sdlc then calls the
  tool with the static args plus one line of text and without the event
  object, so a Telegram bot's send_message(chat_id, text) takes events
  directly. The text names the project, change, gate and people by name
  from roles.yaml, in the command's locale; never an email, a note, a
  command or its output. It is built when the event is queued.
- After a rework or a rejection, once the agent has changed the gate's
  artifacts, the gate waits for a person again: next names them, next
  --me lists it and the awaiting event is sent. A rejected review works
  the same way. Older records keep their behaviour.
- sdlc verify --list shows the verify.mcp checks next to the commands.
- The guide, the course and the handbook describe these changes.
</commit_message>
<xml_diff>
--- a/docs/demo/sdlc-calculator-demo.en.pptx
+++ b/docs/demo/sdlc-calculator-demo.en.pptx
@@ -5112,7 +5112,7 @@
                 <a:ea typeface="Courier New" pitchFamily="34" charset="-122"/>
                 <a:cs typeface="Courier New" pitchFamily="34" charset="-120"/>
               </a:rPr>
-              <a:t>✓ test (1.0s)</a:t>
+              <a:t>✓ test (0.9s)</a:t>
             </a:r>
             <a:endParaRPr lang="en-US" sz="1000" dirty="0"/>
           </a:p>
@@ -6660,7 +6660,7 @@
                 <a:ea typeface="Courier New" pitchFamily="34" charset="-122"/>
                 <a:cs typeface="Courier New" pitchFamily="34" charset="-120"/>
               </a:rPr>
-              <a:t>  code-owner (a0bc17763e43)</a:t>
+              <a:t>  code-owner (c3289403791c)</a:t>
             </a:r>
             <a:endParaRPr lang="en-US" sz="1000" dirty="0"/>
           </a:p>
@@ -6745,7 +6745,7 @@
                 <a:ea typeface="Courier New" pitchFamily="34" charset="-122"/>
                 <a:cs typeface="Courier New" pitchFamily="34" charset="-120"/>
               </a:rPr>
-              <a:t>  "SDLC-Approval: basic-arithmetic:review:a</a:t>
+              <a:t>  "SDLC-Approval: basic-arithmetic:review:c</a:t>
             </a:r>
             <a:endParaRPr lang="en-US" sz="1000" dirty="0"/>
           </a:p>
@@ -6762,7 +6762,7 @@
                 <a:ea typeface="Courier New" pitchFamily="34" charset="-122"/>
                 <a:cs typeface="Courier New" pitchFamily="34" charset="-120"/>
               </a:rPr>
-              <a:t>  0bc17763e43"</a:t>
+              <a:t>  3289403791c"</a:t>
             </a:r>
             <a:endParaRPr lang="en-US" sz="1000" dirty="0"/>
           </a:p>
@@ -7443,7 +7443,7 @@
                 <a:ea typeface="Courier New" pitchFamily="34" charset="-122"/>
                 <a:cs typeface="Courier New" pitchFamily="34" charset="-120"/>
               </a:rPr>
-              <a:t>  release-manager (a0bc17763e43)</a:t>
+              <a:t>  release-manager (c3289403791c)</a:t>
             </a:r>
             <a:endParaRPr lang="en-US" sz="1000" dirty="0"/>
           </a:p>
@@ -7511,7 +7511,7 @@
                 <a:ea typeface="Courier New" pitchFamily="34" charset="-122"/>
                 <a:cs typeface="Courier New" pitchFamily="34" charset="-120"/>
               </a:rPr>
-              <a:t>  gate" -m "SDLC-Approval: basic-arithmetic:release:a0bc17763e43"</a:t>
+              <a:t>  gate" -m "SDLC-Approval: basic-arithmetic:release:c3289403791c"</a:t>
             </a:r>
             <a:endParaRPr lang="en-US" sz="1000" dirty="0"/>
           </a:p>
@@ -7794,7 +7794,7 @@
                 <a:ea typeface="Courier New" pitchFamily="34" charset="-122"/>
                 <a:cs typeface="Courier New" pitchFamily="34" charset="-120"/>
               </a:rPr>
-              <a:t>✓ basic-arithmetic/intent alice valid 7b23c1f3</a:t>
+              <a:t>✓ basic-arithmetic/intent alice valid 092cd6b1</a:t>
             </a:r>
             <a:endParaRPr lang="en-US" sz="1000" dirty="0"/>
           </a:p>
@@ -7811,7 +7811,7 @@
                 <a:ea typeface="Courier New" pitchFamily="34" charset="-122"/>
                 <a:cs typeface="Courier New" pitchFamily="34" charset="-120"/>
               </a:rPr>
-              <a:t>✓ basic-arithmetic/spec alice valid 0abaa1a3</a:t>
+              <a:t>✓ basic-arithmetic/spec alice valid 0afcb046</a:t>
             </a:r>
             <a:endParaRPr lang="en-US" sz="1000" dirty="0"/>
           </a:p>
@@ -7828,7 +7828,7 @@
                 <a:ea typeface="Courier New" pitchFamily="34" charset="-122"/>
                 <a:cs typeface="Courier New" pitchFamily="34" charset="-120"/>
               </a:rPr>
-              <a:t>✗ basic-arithmetic/plan bob wrong-signer 0abaa1a3</a:t>
+              <a:t>✗ basic-arithmetic/plan bob wrong-signer 0afcb046</a:t>
             </a:r>
             <a:endParaRPr lang="en-US" sz="1000" dirty="0"/>
           </a:p>
@@ -7845,7 +7845,7 @@
                 <a:ea typeface="Courier New" pitchFamily="34" charset="-122"/>
                 <a:cs typeface="Courier New" pitchFamily="34" charset="-120"/>
               </a:rPr>
-              <a:t>✓ basic-arithmetic/review carol valid e1f24962</a:t>
+              <a:t>✓ basic-arithmetic/review carol valid ce5b594d</a:t>
             </a:r>
             <a:endParaRPr lang="en-US" sz="1000" dirty="0"/>
           </a:p>
@@ -7862,7 +7862,7 @@
                 <a:ea typeface="Courier New" pitchFamily="34" charset="-122"/>
                 <a:cs typeface="Courier New" pitchFamily="34" charset="-120"/>
               </a:rPr>
-              <a:t>✓ basic-arithmetic/release alice valid 66be5a87</a:t>
+              <a:t>✓ basic-arithmetic/release alice valid 1c8e641e</a:t>
             </a:r>
             <a:endParaRPr lang="en-US" sz="1000" dirty="0"/>
           </a:p>
@@ -7879,7 +7879,7 @@
                 <a:ea typeface="Courier New" pitchFamily="34" charset="-122"/>
                 <a:cs typeface="Courier New" pitchFamily="34" charset="-120"/>
               </a:rPr>
-              <a:t>✓ openspec/roles.yaml alice@calc.example valid 319d380c</a:t>
+              <a:t>✓ openspec/roles.yaml alice@calc.example valid 14ee937d</a:t>
             </a:r>
             <a:endParaRPr lang="en-US" sz="1000" dirty="0"/>
           </a:p>
@@ -14365,7 +14365,7 @@
                 <a:ea typeface="Courier New" pitchFamily="34" charset="-122"/>
                 <a:cs typeface="Courier New" pitchFamily="34" charset="-120"/>
               </a:rPr>
-              <a:t>  archived) · sdlc 0.14.7, license:</a:t>
+              <a:t>  archived) · sdlc 0.15.0, license:</a:t>
             </a:r>
             <a:endParaRPr lang="en-US" sz="1000" dirty="0"/>
           </a:p>
@@ -14552,7 +14552,7 @@
                 <a:ea typeface="Courier New" pitchFamily="34" charset="-122"/>
                 <a:cs typeface="Courier New" pitchFamily="34" charset="-120"/>
               </a:rPr>
-              <a:t>  intent 2 · plan 11 · review 3; rework</a:t>
+              <a:t>  intent 3 · spec 1 · plan 11 · review 3;</a:t>
             </a:r>
             <a:endParaRPr lang="en-US" sz="1000" dirty="0"/>
           </a:p>
@@ -14569,7 +14569,7 @@
                 <a:ea typeface="Courier New" pitchFamily="34" charset="-122"/>
                 <a:cs typeface="Courier New" pitchFamily="34" charset="-120"/>
               </a:rPr>
-              <a:t>  reasons: missing-requirement 1</a:t>
+              <a:t>  rework reasons: missing-requirement 1</a:t>
             </a:r>
             <a:endParaRPr lang="en-US" sz="1000" dirty="0"/>
           </a:p>
@@ -14852,7 +14852,7 @@
                 <a:ea typeface="Courier New" pitchFamily="34" charset="-122"/>
                 <a:cs typeface="Courier New" pitchFamily="34" charset="-120"/>
               </a:rPr>
-              <a:t>(last 15 of 44 entries; --limit to see</a:t>
+              <a:t>(last 15 of 45 entries; --limit to see</a:t>
             </a:r>
             <a:endParaRPr lang="en-US" sz="1000" dirty="0"/>
           </a:p>
@@ -14886,7 +14886,7 @@
                 <a:ea typeface="Courier New" pitchFamily="34" charset="-122"/>
                 <a:cs typeface="Courier New" pitchFamily="34" charset="-120"/>
               </a:rPr>
-              <a:t>2026-10-11T17:31:02.746Z  gate.review.await</a:t>
+              <a:t>2026-10-11T18:46:33.939Z  gate.review.await</a:t>
             </a:r>
             <a:endParaRPr lang="en-US" sz="1000" dirty="0"/>
           </a:p>
@@ -14920,7 +14920,7 @@
                 <a:ea typeface="Courier New" pitchFamily="34" charset="-122"/>
                 <a:cs typeface="Courier New" pitchFamily="34" charset="-120"/>
               </a:rPr>
-              <a:t>  sha256:a0bc17763e4332b307ea1435a7268b67ea</a:t>
+              <a:t>  sha256:c3289403791c5c9047737a9b7d4a0e7cb9</a:t>
             </a:r>
             <a:endParaRPr lang="en-US" sz="1000" dirty="0"/>
           </a:p>
@@ -14937,7 +14937,7 @@
                 <a:ea typeface="Courier New" pitchFamily="34" charset="-122"/>
                 <a:cs typeface="Courier New" pitchFamily="34" charset="-120"/>
               </a:rPr>
-              <a:t>  0778acd66fdbe2c28977751a7ef077 [sdlc</a:t>
+              <a:t>  28d813abfdda02a1bf29080209a8be [sdlc</a:t>
             </a:r>
             <a:endParaRPr lang="en-US" sz="1000" dirty="0"/>
           </a:p>
@@ -14954,7 +14954,7 @@
                 <a:ea typeface="Courier New" pitchFamily="34" charset="-122"/>
                 <a:cs typeface="Courier New" pitchFamily="34" charset="-120"/>
               </a:rPr>
-              <a:t>  0.14.7 · community]</a:t>
+              <a:t>  0.15.0 · community]</a:t>
             </a:r>
             <a:endParaRPr lang="en-US" sz="1000" dirty="0"/>
           </a:p>
@@ -14971,7 +14971,7 @@
                 <a:ea typeface="Courier New" pitchFamily="34" charset="-122"/>
                 <a:cs typeface="Courier New" pitchFamily="34" charset="-120"/>
               </a:rPr>
-              <a:t>2026-10-11T17:31:05.733Z  gate.review.appro</a:t>
+              <a:t>2026-10-11T18:46:36.890Z  gate.review.appro</a:t>
             </a:r>
             <a:endParaRPr lang="en-US" sz="1000" dirty="0"/>
           </a:p>
@@ -15022,7 +15022,7 @@
                 <a:ea typeface="Courier New" pitchFamily="34" charset="-122"/>
                 <a:cs typeface="Courier New" pitchFamily="34" charset="-120"/>
               </a:rPr>
-              <a:t>  [sdlc 0.14.7 · community]</a:t>
+              <a:t>  [sdlc 0.15.0 · community]</a:t>
             </a:r>
             <a:endParaRPr lang="en-US" sz="1000" dirty="0"/>
           </a:p>
@@ -15039,7 +15039,7 @@
                 <a:ea typeface="Courier New" pitchFamily="34" charset="-122"/>
                 <a:cs typeface="Courier New" pitchFamily="34" charset="-120"/>
               </a:rPr>
-              <a:t>2026-10-11T17:31:11.157Z  gate.release.appr</a:t>
+              <a:t>2026-10-11T18:46:42.064Z  gate.release.appr</a:t>
             </a:r>
             <a:endParaRPr lang="en-US" sz="1000" dirty="0"/>
           </a:p>
@@ -15090,7 +15090,7 @@
                 <a:ea typeface="Courier New" pitchFamily="34" charset="-122"/>
                 <a:cs typeface="Courier New" pitchFamily="34" charset="-120"/>
               </a:rPr>
-              <a:t>  release-manager [sdlc 0.14.7 · community]</a:t>
+              <a:t>  release-manager [sdlc 0.15.0 · community]</a:t>
             </a:r>
             <a:endParaRPr lang="en-US" sz="1000" dirty="0"/>
           </a:p>
@@ -16720,7 +16720,7 @@
                 <a:ea typeface="Courier New" pitchFamily="34" charset="-122"/>
                 <a:cs typeface="Courier New" pitchFamily="34" charset="-120"/>
               </a:rPr>
-              <a:t>      "id": "20261011T173152343Z-ci-green-0</a:t>
+              <a:t>      "id": "20261011T184723201Z-ci-green-b</a:t>
             </a:r>
             <a:endParaRPr lang="en-US" sz="1000" dirty="0"/>
           </a:p>
@@ -16737,7 +16737,7 @@
                 <a:ea typeface="Courier New" pitchFamily="34" charset="-122"/>
                 <a:cs typeface="Courier New" pitchFamily="34" charset="-120"/>
               </a:rPr>
-              <a:t>  1b96e",</a:t>
+              <a:t>  47656",</a:t>
             </a:r>
             <a:endParaRPr lang="en-US" sz="1000" dirty="0"/>
           </a:p>
@@ -16873,7 +16873,7 @@
                 <a:ea typeface="Courier New" pitchFamily="34" charset="-122"/>
                 <a:cs typeface="Courier New" pitchFamily="34" charset="-120"/>
               </a:rPr>
-              <a:t>        "ref": "5ea7e36f5375dcc3503b1be8c99</a:t>
+              <a:t>        "ref": "171520b4e27bb6452f9a787e7c1</a:t>
             </a:r>
             <a:endParaRPr lang="en-US" sz="1000" dirty="0"/>
           </a:p>
@@ -16890,7 +16890,7 @@
                 <a:ea typeface="Courier New" pitchFamily="34" charset="-122"/>
                 <a:cs typeface="Courier New" pitchFamily="34" charset="-120"/>
               </a:rPr>
-              <a:t>  4411ddd532154",</a:t>
+              <a:t>  b2e6a86434c44",</a:t>
             </a:r>
             <a:endParaRPr lang="en-US" sz="1000" dirty="0"/>
           </a:p>
@@ -26952,7 +26952,7 @@
                 <a:ea typeface="Courier New" pitchFamily="34" charset="-122"/>
                 <a:cs typeface="Courier New" pitchFamily="34" charset="-120"/>
               </a:rPr>
-              <a:t>  sdlc 0.14.7, license: community</a:t>
+              <a:t>  sdlc 0.15.0, license: community</a:t>
             </a:r>
             <a:endParaRPr lang="en-US" sz="1000" dirty="0"/>
           </a:p>

</xml_diff>

<commit_message>
feat: CI checks wait for a pending run; mcp check --strict; doctor checks registry variables; no duplicate backlog sources (0.15.1)
- verify.mcp and release.mcp checks may set wait_while and wait_seconds:
  while the answer matches wait_while the CLI asks again, and past the
  time the check fails as still pending. Without wait_while: one call.
- sdlc mcp check --strict exits 1 when a registry server cannot be
  reached; without --strict the exit code stays 0.
- sdlc doctor warns when a ${VAR} of the MCP registry is not set, naming
  the server and the variable, never a value.
- sdlc backlog add refuses a second open item with the same source and
  names the first; --allow-duplicate adds it anyway.
- The test suite uses one temporary root per run and removes it at the
  end, instead of leaving its folders behind.
</commit_message>
<xml_diff>
--- a/docs/demo/sdlc-calculator-demo.en.pptx
+++ b/docs/demo/sdlc-calculator-demo.en.pptx
@@ -5112,7 +5112,7 @@
                 <a:ea typeface="Courier New" pitchFamily="34" charset="-122"/>
                 <a:cs typeface="Courier New" pitchFamily="34" charset="-120"/>
               </a:rPr>
-              <a:t>✓ test (0.9s)</a:t>
+              <a:t>✓ test (1.6s)</a:t>
             </a:r>
             <a:endParaRPr lang="en-US" sz="1000" dirty="0"/>
           </a:p>
@@ -6660,7 +6660,7 @@
                 <a:ea typeface="Courier New" pitchFamily="34" charset="-122"/>
                 <a:cs typeface="Courier New" pitchFamily="34" charset="-120"/>
               </a:rPr>
-              <a:t>  code-owner (c3289403791c)</a:t>
+              <a:t>  code-owner (e1c1c2823fb1)</a:t>
             </a:r>
             <a:endParaRPr lang="en-US" sz="1000" dirty="0"/>
           </a:p>
@@ -6745,7 +6745,7 @@
                 <a:ea typeface="Courier New" pitchFamily="34" charset="-122"/>
                 <a:cs typeface="Courier New" pitchFamily="34" charset="-120"/>
               </a:rPr>
-              <a:t>  "SDLC-Approval: basic-arithmetic:review:c</a:t>
+              <a:t>  "SDLC-Approval: basic-arithmetic:review:e</a:t>
             </a:r>
             <a:endParaRPr lang="en-US" sz="1000" dirty="0"/>
           </a:p>
@@ -6762,7 +6762,7 @@
                 <a:ea typeface="Courier New" pitchFamily="34" charset="-122"/>
                 <a:cs typeface="Courier New" pitchFamily="34" charset="-120"/>
               </a:rPr>
-              <a:t>  3289403791c"</a:t>
+              <a:t>  1c1c2823fb1"</a:t>
             </a:r>
             <a:endParaRPr lang="en-US" sz="1000" dirty="0"/>
           </a:p>
@@ -7443,7 +7443,7 @@
                 <a:ea typeface="Courier New" pitchFamily="34" charset="-122"/>
                 <a:cs typeface="Courier New" pitchFamily="34" charset="-120"/>
               </a:rPr>
-              <a:t>  release-manager (c3289403791c)</a:t>
+              <a:t>  release-manager (e1c1c2823fb1)</a:t>
             </a:r>
             <a:endParaRPr lang="en-US" sz="1000" dirty="0"/>
           </a:p>
@@ -7511,7 +7511,7 @@
                 <a:ea typeface="Courier New" pitchFamily="34" charset="-122"/>
                 <a:cs typeface="Courier New" pitchFamily="34" charset="-120"/>
               </a:rPr>
-              <a:t>  gate" -m "SDLC-Approval: basic-arithmetic:release:c3289403791c"</a:t>
+              <a:t>  gate" -m "SDLC-Approval: basic-arithmetic:release:e1c1c2823fb1"</a:t>
             </a:r>
             <a:endParaRPr lang="en-US" sz="1000" dirty="0"/>
           </a:p>
@@ -7794,7 +7794,7 @@
                 <a:ea typeface="Courier New" pitchFamily="34" charset="-122"/>
                 <a:cs typeface="Courier New" pitchFamily="34" charset="-120"/>
               </a:rPr>
-              <a:t>✓ basic-arithmetic/intent alice valid 092cd6b1</a:t>
+              <a:t>✓ basic-arithmetic/intent alice valid 79d5cf54</a:t>
             </a:r>
             <a:endParaRPr lang="en-US" sz="1000" dirty="0"/>
           </a:p>
@@ -7811,7 +7811,7 @@
                 <a:ea typeface="Courier New" pitchFamily="34" charset="-122"/>
                 <a:cs typeface="Courier New" pitchFamily="34" charset="-120"/>
               </a:rPr>
-              <a:t>✓ basic-arithmetic/spec alice valid 0afcb046</a:t>
+              <a:t>✓ basic-arithmetic/spec alice valid d692bf3d</a:t>
             </a:r>
             <a:endParaRPr lang="en-US" sz="1000" dirty="0"/>
           </a:p>
@@ -7828,7 +7828,7 @@
                 <a:ea typeface="Courier New" pitchFamily="34" charset="-122"/>
                 <a:cs typeface="Courier New" pitchFamily="34" charset="-120"/>
               </a:rPr>
-              <a:t>✗ basic-arithmetic/plan bob wrong-signer 0afcb046</a:t>
+              <a:t>✗ basic-arithmetic/plan bob wrong-signer d692bf3d</a:t>
             </a:r>
             <a:endParaRPr lang="en-US" sz="1000" dirty="0"/>
           </a:p>
@@ -7845,7 +7845,7 @@
                 <a:ea typeface="Courier New" pitchFamily="34" charset="-122"/>
                 <a:cs typeface="Courier New" pitchFamily="34" charset="-120"/>
               </a:rPr>
-              <a:t>✓ basic-arithmetic/review carol valid ce5b594d</a:t>
+              <a:t>✓ basic-arithmetic/review carol valid f2ddd540</a:t>
             </a:r>
             <a:endParaRPr lang="en-US" sz="1000" dirty="0"/>
           </a:p>
@@ -7862,7 +7862,7 @@
                 <a:ea typeface="Courier New" pitchFamily="34" charset="-122"/>
                 <a:cs typeface="Courier New" pitchFamily="34" charset="-120"/>
               </a:rPr>
-              <a:t>✓ basic-arithmetic/release alice valid 1c8e641e</a:t>
+              <a:t>✓ basic-arithmetic/release alice valid f7c6dd57</a:t>
             </a:r>
             <a:endParaRPr lang="en-US" sz="1000" dirty="0"/>
           </a:p>
@@ -7879,7 +7879,7 @@
                 <a:ea typeface="Courier New" pitchFamily="34" charset="-122"/>
                 <a:cs typeface="Courier New" pitchFamily="34" charset="-120"/>
               </a:rPr>
-              <a:t>✓ openspec/roles.yaml alice@calc.example valid 14ee937d</a:t>
+              <a:t>✓ openspec/roles.yaml alice@calc.example valid 083a05f5</a:t>
             </a:r>
             <a:endParaRPr lang="en-US" sz="1000" dirty="0"/>
           </a:p>
@@ -14365,7 +14365,7 @@
                 <a:ea typeface="Courier New" pitchFamily="34" charset="-122"/>
                 <a:cs typeface="Courier New" pitchFamily="34" charset="-120"/>
               </a:rPr>
-              <a:t>  archived) · sdlc 0.15.0, license:</a:t>
+              <a:t>  archived) · sdlc 0.15.1, license:</a:t>
             </a:r>
             <a:endParaRPr lang="en-US" sz="1000" dirty="0"/>
           </a:p>
@@ -14552,7 +14552,7 @@
                 <a:ea typeface="Courier New" pitchFamily="34" charset="-122"/>
                 <a:cs typeface="Courier New" pitchFamily="34" charset="-120"/>
               </a:rPr>
-              <a:t>  intent 3 · spec 1 · plan 11 · review 3;</a:t>
+              <a:t>  intent 3 · spec 1 · plan 16 · review 4;</a:t>
             </a:r>
             <a:endParaRPr lang="en-US" sz="1000" dirty="0"/>
           </a:p>
@@ -14886,7 +14886,7 @@
                 <a:ea typeface="Courier New" pitchFamily="34" charset="-122"/>
                 <a:cs typeface="Courier New" pitchFamily="34" charset="-120"/>
               </a:rPr>
-              <a:t>2026-10-11T18:46:33.939Z  gate.review.await</a:t>
+              <a:t>2026-10-11T21:22:55.364Z  gate.review.await</a:t>
             </a:r>
             <a:endParaRPr lang="en-US" sz="1000" dirty="0"/>
           </a:p>
@@ -14920,7 +14920,7 @@
                 <a:ea typeface="Courier New" pitchFamily="34" charset="-122"/>
                 <a:cs typeface="Courier New" pitchFamily="34" charset="-120"/>
               </a:rPr>
-              <a:t>  sha256:c3289403791c5c9047737a9b7d4a0e7cb9</a:t>
+              <a:t>  sha256:e1c1c2823fb1fafd37a6b1212db0069924</a:t>
             </a:r>
             <a:endParaRPr lang="en-US" sz="1000" dirty="0"/>
           </a:p>
@@ -14937,7 +14937,7 @@
                 <a:ea typeface="Courier New" pitchFamily="34" charset="-122"/>
                 <a:cs typeface="Courier New" pitchFamily="34" charset="-120"/>
               </a:rPr>
-              <a:t>  28d813abfdda02a1bf29080209a8be [sdlc</a:t>
+              <a:t>  c8ad140fe1f11f4e874178e42f2f23 [sdlc</a:t>
             </a:r>
             <a:endParaRPr lang="en-US" sz="1000" dirty="0"/>
           </a:p>
@@ -14954,7 +14954,7 @@
                 <a:ea typeface="Courier New" pitchFamily="34" charset="-122"/>
                 <a:cs typeface="Courier New" pitchFamily="34" charset="-120"/>
               </a:rPr>
-              <a:t>  0.15.0 · community]</a:t>
+              <a:t>  0.15.1 · community]</a:t>
             </a:r>
             <a:endParaRPr lang="en-US" sz="1000" dirty="0"/>
           </a:p>
@@ -14971,7 +14971,7 @@
                 <a:ea typeface="Courier New" pitchFamily="34" charset="-122"/>
                 <a:cs typeface="Courier New" pitchFamily="34" charset="-120"/>
               </a:rPr>
-              <a:t>2026-10-11T18:46:36.890Z  gate.review.appro</a:t>
+              <a:t>2026-10-11T21:22:59.088Z  gate.review.appro</a:t>
             </a:r>
             <a:endParaRPr lang="en-US" sz="1000" dirty="0"/>
           </a:p>
@@ -15022,7 +15022,7 @@
                 <a:ea typeface="Courier New" pitchFamily="34" charset="-122"/>
                 <a:cs typeface="Courier New" pitchFamily="34" charset="-120"/>
               </a:rPr>
-              <a:t>  [sdlc 0.15.0 · community]</a:t>
+              <a:t>  [sdlc 0.15.1 · community]</a:t>
             </a:r>
             <a:endParaRPr lang="en-US" sz="1000" dirty="0"/>
           </a:p>
@@ -15039,7 +15039,7 @@
                 <a:ea typeface="Courier New" pitchFamily="34" charset="-122"/>
                 <a:cs typeface="Courier New" pitchFamily="34" charset="-120"/>
               </a:rPr>
-              <a:t>2026-10-11T18:46:42.064Z  gate.release.appr</a:t>
+              <a:t>2026-10-11T21:23:07.697Z  gate.release.appr</a:t>
             </a:r>
             <a:endParaRPr lang="en-US" sz="1000" dirty="0"/>
           </a:p>
@@ -15090,7 +15090,7 @@
                 <a:ea typeface="Courier New" pitchFamily="34" charset="-122"/>
                 <a:cs typeface="Courier New" pitchFamily="34" charset="-120"/>
               </a:rPr>
-              <a:t>  release-manager [sdlc 0.15.0 · community]</a:t>
+              <a:t>  release-manager [sdlc 0.15.1 · community]</a:t>
             </a:r>
             <a:endParaRPr lang="en-US" sz="1000" dirty="0"/>
           </a:p>
@@ -16267,7 +16267,7 @@
                 <a:ea typeface="Courier New" pitchFamily="34" charset="-122"/>
                 <a:cs typeface="Courier New" pitchFamily="34" charset="-120"/>
               </a:rPr>
-              <a:t>✓ test (1.0s)</a:t>
+              <a:t>✓ test (1.5s)</a:t>
             </a:r>
             <a:endParaRPr lang="en-US" sz="1000" dirty="0"/>
           </a:p>
@@ -16284,7 +16284,7 @@
                 <a:ea typeface="Courier New" pitchFamily="34" charset="-122"/>
                 <a:cs typeface="Courier New" pitchFamily="34" charset="-120"/>
               </a:rPr>
-              <a:t>✓ ci-green (ci/pipeline_status, 0.5s)</a:t>
+              <a:t>✓ ci-green (ci/pipeline_status, 0.6s)</a:t>
             </a:r>
             <a:endParaRPr lang="en-US" sz="1000" dirty="0"/>
           </a:p>
@@ -16720,7 +16720,7 @@
                 <a:ea typeface="Courier New" pitchFamily="34" charset="-122"/>
                 <a:cs typeface="Courier New" pitchFamily="34" charset="-120"/>
               </a:rPr>
-              <a:t>      "id": "20261011T184723201Z-ci-green-b</a:t>
+              <a:t>      "id": "20261011T212355314Z-ci-green-f</a:t>
             </a:r>
             <a:endParaRPr lang="en-US" sz="1000" dirty="0"/>
           </a:p>
@@ -16737,7 +16737,7 @@
                 <a:ea typeface="Courier New" pitchFamily="34" charset="-122"/>
                 <a:cs typeface="Courier New" pitchFamily="34" charset="-120"/>
               </a:rPr>
-              <a:t>  47656",</a:t>
+              <a:t>  9d97a",</a:t>
             </a:r>
             <a:endParaRPr lang="en-US" sz="1000" dirty="0"/>
           </a:p>
@@ -16873,7 +16873,7 @@
                 <a:ea typeface="Courier New" pitchFamily="34" charset="-122"/>
                 <a:cs typeface="Courier New" pitchFamily="34" charset="-120"/>
               </a:rPr>
-              <a:t>        "ref": "171520b4e27bb6452f9a787e7c1</a:t>
+              <a:t>        "ref": "742f9726f5779dce767a51f6aa6</a:t>
             </a:r>
             <a:endParaRPr lang="en-US" sz="1000" dirty="0"/>
           </a:p>
@@ -16890,7 +16890,7 @@
                 <a:ea typeface="Courier New" pitchFamily="34" charset="-122"/>
                 <a:cs typeface="Courier New" pitchFamily="34" charset="-120"/>
               </a:rPr>
-              <a:t>  b2e6a86434c44",</a:t>
+              <a:t>  8d52fd29910aa",</a:t>
             </a:r>
             <a:endParaRPr lang="en-US" sz="1000" dirty="0"/>
           </a:p>
@@ -26952,7 +26952,7 @@
                 <a:ea typeface="Courier New" pitchFamily="34" charset="-122"/>
                 <a:cs typeface="Courier New" pitchFamily="34" charset="-120"/>
               </a:rPr>
-              <a:t>  sdlc 0.15.0, license: community</a:t>
+              <a:t>  sdlc 0.15.1, license: community</a:t>
             </a:r>
             <a:endParaRPr lang="en-US" sz="1000" dirty="0"/>
           </a:p>

</xml_diff>

<commit_message>
fix: the Next: line and the status line are as fresh as sdlc next (0.15.3)
- After a later code change and a new sdlc verify, the Next: line said
  "archive" while a code owner had to re-approve the review, and the
  status line said "Done" while the code was unverified. The Next: line,
  the status line, sdlc instructions and the waits recorded by sdlc events
  evaluated the change without the worktree fingerprint and trusted the
  recorded verification and approvals. They now check it, as sdlc next
  and sdlc status do; the status line takes about 0.3 s longer.
- The gate.<g>.awaiting event is now recorded for a review approval that
  went stale after a code change.

SDLC-Agent: claude-code
</commit_message>
<xml_diff>
--- a/docs/demo/sdlc-calculator-demo.en.pptx
+++ b/docs/demo/sdlc-calculator-demo.en.pptx
@@ -5112,7 +5112,7 @@
                 <a:ea typeface="Courier New" pitchFamily="34" charset="-122"/>
                 <a:cs typeface="Courier New" pitchFamily="34" charset="-120"/>
               </a:rPr>
-              <a:t>✓ test (1.3s)</a:t>
+              <a:t>✓ test (1.1s)</a:t>
             </a:r>
             <a:endParaRPr lang="en-US" sz="1000" dirty="0"/>
           </a:p>
@@ -6660,7 +6660,7 @@
                 <a:ea typeface="Courier New" pitchFamily="34" charset="-122"/>
                 <a:cs typeface="Courier New" pitchFamily="34" charset="-120"/>
               </a:rPr>
-              <a:t>  code-owner (c7066ff3fb7e)</a:t>
+              <a:t>  code-owner (724adef414cd)</a:t>
             </a:r>
             <a:endParaRPr lang="en-US" sz="1000" dirty="0"/>
           </a:p>
@@ -6745,7 +6745,7 @@
                 <a:ea typeface="Courier New" pitchFamily="34" charset="-122"/>
                 <a:cs typeface="Courier New" pitchFamily="34" charset="-120"/>
               </a:rPr>
-              <a:t>  "SDLC-Approval: basic-arithmetic:review:c</a:t>
+              <a:t>  "SDLC-Approval: basic-arithmetic:review:7</a:t>
             </a:r>
             <a:endParaRPr lang="en-US" sz="1000" dirty="0"/>
           </a:p>
@@ -6762,7 +6762,7 @@
                 <a:ea typeface="Courier New" pitchFamily="34" charset="-122"/>
                 <a:cs typeface="Courier New" pitchFamily="34" charset="-120"/>
               </a:rPr>
-              <a:t>  7066ff3fb7e"</a:t>
+              <a:t>  24adef414cd"</a:t>
             </a:r>
             <a:endParaRPr lang="en-US" sz="1000" dirty="0"/>
           </a:p>
@@ -7443,7 +7443,7 @@
                 <a:ea typeface="Courier New" pitchFamily="34" charset="-122"/>
                 <a:cs typeface="Courier New" pitchFamily="34" charset="-120"/>
               </a:rPr>
-              <a:t>  release-manager (c7066ff3fb7e)</a:t>
+              <a:t>  release-manager (724adef414cd)</a:t>
             </a:r>
             <a:endParaRPr lang="en-US" sz="1000" dirty="0"/>
           </a:p>
@@ -7511,7 +7511,7 @@
                 <a:ea typeface="Courier New" pitchFamily="34" charset="-122"/>
                 <a:cs typeface="Courier New" pitchFamily="34" charset="-120"/>
               </a:rPr>
-              <a:t>  gate" -m "SDLC-Approval: basic-arithmetic:release:c7066ff3fb7e"</a:t>
+              <a:t>  gate" -m "SDLC-Approval: basic-arithmetic:release:724adef414cd"</a:t>
             </a:r>
             <a:endParaRPr lang="en-US" sz="1000" dirty="0"/>
           </a:p>
@@ -7794,7 +7794,7 @@
                 <a:ea typeface="Courier New" pitchFamily="34" charset="-122"/>
                 <a:cs typeface="Courier New" pitchFamily="34" charset="-120"/>
               </a:rPr>
-              <a:t>✓ basic-arithmetic/intent alice valid 9629c043 trailer: missing</a:t>
+              <a:t>✓ basic-arithmetic/intent alice valid f67a90de trailer: missing</a:t>
             </a:r>
             <a:endParaRPr lang="en-US" sz="1000" dirty="0"/>
           </a:p>
@@ -7811,7 +7811,7 @@
                 <a:ea typeface="Courier New" pitchFamily="34" charset="-122"/>
                 <a:cs typeface="Courier New" pitchFamily="34" charset="-120"/>
               </a:rPr>
-              <a:t>✓ basic-arithmetic/spec alice valid d7a3a605 trailer: missing</a:t>
+              <a:t>✓ basic-arithmetic/spec alice valid 49d44168 trailer: missing</a:t>
             </a:r>
             <a:endParaRPr lang="en-US" sz="1000" dirty="0"/>
           </a:p>
@@ -7828,7 +7828,7 @@
                 <a:ea typeface="Courier New" pitchFamily="34" charset="-122"/>
                 <a:cs typeface="Courier New" pitchFamily="34" charset="-120"/>
               </a:rPr>
-              <a:t>✗ basic-arithmetic/plan bob wrong-signer d7a3a605 trailer: missing</a:t>
+              <a:t>✗ basic-arithmetic/plan bob wrong-signer 49d44168 trailer: missing</a:t>
             </a:r>
             <a:endParaRPr lang="en-US" sz="1000" dirty="0"/>
           </a:p>
@@ -7845,7 +7845,7 @@
                 <a:ea typeface="Courier New" pitchFamily="34" charset="-122"/>
                 <a:cs typeface="Courier New" pitchFamily="34" charset="-120"/>
               </a:rPr>
-              <a:t>✓ basic-arithmetic/review carol valid 1fa2ecb2 trailer: missing</a:t>
+              <a:t>✓ basic-arithmetic/review carol valid 7dd9d0f2 trailer: missing</a:t>
             </a:r>
             <a:endParaRPr lang="en-US" sz="1000" dirty="0"/>
           </a:p>
@@ -7862,7 +7862,7 @@
                 <a:ea typeface="Courier New" pitchFamily="34" charset="-122"/>
                 <a:cs typeface="Courier New" pitchFamily="34" charset="-120"/>
               </a:rPr>
-              <a:t>✓ basic-arithmetic/release alice valid 2677e607 trailer: missing</a:t>
+              <a:t>✓ basic-arithmetic/release alice valid ebca62f0 trailer: missing</a:t>
             </a:r>
             <a:endParaRPr lang="en-US" sz="1000" dirty="0"/>
           </a:p>
@@ -7879,7 +7879,7 @@
                 <a:ea typeface="Courier New" pitchFamily="34" charset="-122"/>
                 <a:cs typeface="Courier New" pitchFamily="34" charset="-120"/>
               </a:rPr>
-              <a:t>✓ openspec/roles.yaml alice@calc.example valid 1860bdef</a:t>
+              <a:t>✓ openspec/roles.yaml alice@calc.example valid c1afb48f</a:t>
             </a:r>
             <a:endParaRPr lang="en-US" sz="1000" dirty="0"/>
           </a:p>
@@ -14365,7 +14365,7 @@
                 <a:ea typeface="Courier New" pitchFamily="34" charset="-122"/>
                 <a:cs typeface="Courier New" pitchFamily="34" charset="-120"/>
               </a:rPr>
-              <a:t>  archived) · sdlc 0.15.2, license:</a:t>
+              <a:t>  archived) · sdlc 0.15.3, license:</a:t>
             </a:r>
             <a:endParaRPr lang="en-US" sz="1000" dirty="0"/>
           </a:p>
@@ -14552,7 +14552,7 @@
                 <a:ea typeface="Courier New" pitchFamily="34" charset="-122"/>
                 <a:cs typeface="Courier New" pitchFamily="34" charset="-120"/>
               </a:rPr>
-              <a:t>  intent 3 · spec 1 · plan 14 · review 4;</a:t>
+              <a:t>  intent 3 · spec 1 · plan 14 · review 3;</a:t>
             </a:r>
             <a:endParaRPr lang="en-US" sz="1000" dirty="0"/>
           </a:p>
@@ -14886,7 +14886,7 @@
                 <a:ea typeface="Courier New" pitchFamily="34" charset="-122"/>
                 <a:cs typeface="Courier New" pitchFamily="34" charset="-120"/>
               </a:rPr>
-              <a:t>2026-10-12T07:20:46.860Z  gate.review.await</a:t>
+              <a:t>2026-10-12T09:04:23.328Z  gate.review.await</a:t>
             </a:r>
             <a:endParaRPr lang="en-US" sz="1000" dirty="0"/>
           </a:p>
@@ -14920,7 +14920,7 @@
                 <a:ea typeface="Courier New" pitchFamily="34" charset="-122"/>
                 <a:cs typeface="Courier New" pitchFamily="34" charset="-120"/>
               </a:rPr>
-              <a:t>  sha256:c7066ff3fb7e573844f9dbfd0792c7df2e</a:t>
+              <a:t>  sha256:724adef414cda8539deaf284827111a968</a:t>
             </a:r>
             <a:endParaRPr lang="en-US" sz="1000" dirty="0"/>
           </a:p>
@@ -14937,7 +14937,7 @@
                 <a:ea typeface="Courier New" pitchFamily="34" charset="-122"/>
                 <a:cs typeface="Courier New" pitchFamily="34" charset="-120"/>
               </a:rPr>
-              <a:t>  aa3f1f39b751f97ac72b6b26a7f55f [sdlc</a:t>
+              <a:t>  0234750270208b185d3da916bdd232 [sdlc</a:t>
             </a:r>
             <a:endParaRPr lang="en-US" sz="1000" dirty="0"/>
           </a:p>
@@ -14954,7 +14954,7 @@
                 <a:ea typeface="Courier New" pitchFamily="34" charset="-122"/>
                 <a:cs typeface="Courier New" pitchFamily="34" charset="-120"/>
               </a:rPr>
-              <a:t>  0.15.2 · community]</a:t>
+              <a:t>  0.15.3 · community]</a:t>
             </a:r>
             <a:endParaRPr lang="en-US" sz="1000" dirty="0"/>
           </a:p>
@@ -14971,7 +14971,7 @@
                 <a:ea typeface="Courier New" pitchFamily="34" charset="-122"/>
                 <a:cs typeface="Courier New" pitchFamily="34" charset="-120"/>
               </a:rPr>
-              <a:t>2026-10-12T07:20:50.566Z  gate.review.appro</a:t>
+              <a:t>2026-10-12T09:04:26.395Z  gate.review.appro</a:t>
             </a:r>
             <a:endParaRPr lang="en-US" sz="1000" dirty="0"/>
           </a:p>
@@ -15022,7 +15022,7 @@
                 <a:ea typeface="Courier New" pitchFamily="34" charset="-122"/>
                 <a:cs typeface="Courier New" pitchFamily="34" charset="-120"/>
               </a:rPr>
-              <a:t>  [sdlc 0.15.2 · community]</a:t>
+              <a:t>  [sdlc 0.15.3 · community]</a:t>
             </a:r>
             <a:endParaRPr lang="en-US" sz="1000" dirty="0"/>
           </a:p>
@@ -15039,7 +15039,7 @@
                 <a:ea typeface="Courier New" pitchFamily="34" charset="-122"/>
                 <a:cs typeface="Courier New" pitchFamily="34" charset="-120"/>
               </a:rPr>
-              <a:t>2026-10-12T07:20:57.597Z  gate.release.appr</a:t>
+              <a:t>2026-10-12T09:04:32.636Z  gate.release.appr</a:t>
             </a:r>
             <a:endParaRPr lang="en-US" sz="1000" dirty="0"/>
           </a:p>
@@ -15090,7 +15090,7 @@
                 <a:ea typeface="Courier New" pitchFamily="34" charset="-122"/>
                 <a:cs typeface="Courier New" pitchFamily="34" charset="-120"/>
               </a:rPr>
-              <a:t>  release-manager [sdlc 0.15.2 · community]</a:t>
+              <a:t>  release-manager [sdlc 0.15.3 · community]</a:t>
             </a:r>
             <a:endParaRPr lang="en-US" sz="1000" dirty="0"/>
           </a:p>
@@ -16267,7 +16267,7 @@
                 <a:ea typeface="Courier New" pitchFamily="34" charset="-122"/>
                 <a:cs typeface="Courier New" pitchFamily="34" charset="-120"/>
               </a:rPr>
-              <a:t>✓ test (1.2s)</a:t>
+              <a:t>✓ test (1.0s)</a:t>
             </a:r>
             <a:endParaRPr lang="en-US" sz="1000" dirty="0"/>
           </a:p>
@@ -16284,7 +16284,7 @@
                 <a:ea typeface="Courier New" pitchFamily="34" charset="-122"/>
                 <a:cs typeface="Courier New" pitchFamily="34" charset="-120"/>
               </a:rPr>
-              <a:t>✓ ci-green (ci/pipeline_status, 0.6s)</a:t>
+              <a:t>✓ ci-green (ci/pipeline_status, 0.5s)</a:t>
             </a:r>
             <a:endParaRPr lang="en-US" sz="1000" dirty="0"/>
           </a:p>
@@ -16720,7 +16720,7 @@
                 <a:ea typeface="Courier New" pitchFamily="34" charset="-122"/>
                 <a:cs typeface="Courier New" pitchFamily="34" charset="-120"/>
               </a:rPr>
-              <a:t>      "id": "20261012T072149508Z-ci-green-8</a:t>
+              <a:t>      "id": "20261012T090522387Z-ci-green-4</a:t>
             </a:r>
             <a:endParaRPr lang="en-US" sz="1000" dirty="0"/>
           </a:p>
@@ -16737,7 +16737,7 @@
                 <a:ea typeface="Courier New" pitchFamily="34" charset="-122"/>
                 <a:cs typeface="Courier New" pitchFamily="34" charset="-120"/>
               </a:rPr>
-              <a:t>  54112",</a:t>
+              <a:t>  6b9d2",</a:t>
             </a:r>
             <a:endParaRPr lang="en-US" sz="1000" dirty="0"/>
           </a:p>
@@ -16873,7 +16873,7 @@
                 <a:ea typeface="Courier New" pitchFamily="34" charset="-122"/>
                 <a:cs typeface="Courier New" pitchFamily="34" charset="-120"/>
               </a:rPr>
-              <a:t>        "ref": "a35190ab2ca95fa1c423ec1f006</a:t>
+              <a:t>        "ref": "69515169f3b043c5e81f622dd31</a:t>
             </a:r>
             <a:endParaRPr lang="en-US" sz="1000" dirty="0"/>
           </a:p>
@@ -16890,7 +16890,7 @@
                 <a:ea typeface="Courier New" pitchFamily="34" charset="-122"/>
                 <a:cs typeface="Courier New" pitchFamily="34" charset="-120"/>
               </a:rPr>
-              <a:t>  379c623918baf",</a:t>
+              <a:t>  6042997801b5c",</a:t>
             </a:r>
             <a:endParaRPr lang="en-US" sz="1000" dirty="0"/>
           </a:p>
@@ -26952,7 +26952,7 @@
                 <a:ea typeface="Courier New" pitchFamily="34" charset="-122"/>
                 <a:cs typeface="Courier New" pitchFamily="34" charset="-120"/>
               </a:rPr>
-              <a:t>  sdlc 0.15.2, license: community</a:t>
+              <a:t>  sdlc 0.15.3, license: community</a:t>
             </a:r>
             <a:endParaRPr lang="en-US" sz="1000" dirty="0"/>
           </a:p>

</xml_diff>

<commit_message>
fix: GigaCode commits named gigacode; output warnings; BMAD path boundary; approvals before the archive commit (0.15.4)
- The git hook is written for the project's tools: with GigaCode and not
  Qwen Code, a commit from a QWEN_CODE=1 shell carries SDLC-Agent:
  gigacode. With both tools it stays qwen (set SDLC_AGENT=gigacode).
- sdlc report --out, sdlc dashboard --out and sdlc audit --export warn
  when they write inside the project, outside openspec/ and not ignored
  by git: such a file makes the verification of active changes stale.
  audit --export --json has a top-level warnings array.
- sdlc import bmad refuses a path outside the project, or a link to one,
  with path_outside_project in both modes; --change used to read and
  import such a folder.
- sdlc approvals verify, right after sdlc archive and before the move is
  committed, reports approvals committed while the change was active as
  they are, not as not-committed.

SDLC-Agent: claude-code
</commit_message>
<xml_diff>
--- a/docs/demo/sdlc-calculator-demo.en.pptx
+++ b/docs/demo/sdlc-calculator-demo.en.pptx
@@ -5112,7 +5112,7 @@
                 <a:ea typeface="Courier New" pitchFamily="34" charset="-122"/>
                 <a:cs typeface="Courier New" pitchFamily="34" charset="-120"/>
               </a:rPr>
-              <a:t>✓ test (1.1s)</a:t>
+              <a:t>✓ test (1.0s)</a:t>
             </a:r>
             <a:endParaRPr lang="en-US" sz="1000" dirty="0"/>
           </a:p>
@@ -6660,7 +6660,7 @@
                 <a:ea typeface="Courier New" pitchFamily="34" charset="-122"/>
                 <a:cs typeface="Courier New" pitchFamily="34" charset="-120"/>
               </a:rPr>
-              <a:t>  code-owner (724adef414cd)</a:t>
+              <a:t>  code-owner (a926d27ef760)</a:t>
             </a:r>
             <a:endParaRPr lang="en-US" sz="1000" dirty="0"/>
           </a:p>
@@ -6745,7 +6745,7 @@
                 <a:ea typeface="Courier New" pitchFamily="34" charset="-122"/>
                 <a:cs typeface="Courier New" pitchFamily="34" charset="-120"/>
               </a:rPr>
-              <a:t>  "SDLC-Approval: basic-arithmetic:review:7</a:t>
+              <a:t>  "SDLC-Approval: basic-arithmetic:review:a</a:t>
             </a:r>
             <a:endParaRPr lang="en-US" sz="1000" dirty="0"/>
           </a:p>
@@ -6762,7 +6762,7 @@
                 <a:ea typeface="Courier New" pitchFamily="34" charset="-122"/>
                 <a:cs typeface="Courier New" pitchFamily="34" charset="-120"/>
               </a:rPr>
-              <a:t>  24adef414cd"</a:t>
+              <a:t>  926d27ef760"</a:t>
             </a:r>
             <a:endParaRPr lang="en-US" sz="1000" dirty="0"/>
           </a:p>
@@ -7443,7 +7443,7 @@
                 <a:ea typeface="Courier New" pitchFamily="34" charset="-122"/>
                 <a:cs typeface="Courier New" pitchFamily="34" charset="-120"/>
               </a:rPr>
-              <a:t>  release-manager (724adef414cd)</a:t>
+              <a:t>  release-manager (a926d27ef760)</a:t>
             </a:r>
             <a:endParaRPr lang="en-US" sz="1000" dirty="0"/>
           </a:p>
@@ -7511,7 +7511,7 @@
                 <a:ea typeface="Courier New" pitchFamily="34" charset="-122"/>
                 <a:cs typeface="Courier New" pitchFamily="34" charset="-120"/>
               </a:rPr>
-              <a:t>  gate" -m "SDLC-Approval: basic-arithmetic:release:724adef414cd"</a:t>
+              <a:t>  gate" -m "SDLC-Approval: basic-arithmetic:release:a926d27ef760"</a:t>
             </a:r>
             <a:endParaRPr lang="en-US" sz="1000" dirty="0"/>
           </a:p>
@@ -7794,7 +7794,7 @@
                 <a:ea typeface="Courier New" pitchFamily="34" charset="-122"/>
                 <a:cs typeface="Courier New" pitchFamily="34" charset="-120"/>
               </a:rPr>
-              <a:t>✓ basic-arithmetic/intent alice valid f67a90de trailer: missing</a:t>
+              <a:t>✓ basic-arithmetic/intent alice valid a5357fd4 trailer: missing</a:t>
             </a:r>
             <a:endParaRPr lang="en-US" sz="1000" dirty="0"/>
           </a:p>
@@ -7811,7 +7811,7 @@
                 <a:ea typeface="Courier New" pitchFamily="34" charset="-122"/>
                 <a:cs typeface="Courier New" pitchFamily="34" charset="-120"/>
               </a:rPr>
-              <a:t>✓ basic-arithmetic/spec alice valid 49d44168 trailer: missing</a:t>
+              <a:t>✓ basic-arithmetic/spec alice valid 5b5d78ae trailer: missing</a:t>
             </a:r>
             <a:endParaRPr lang="en-US" sz="1000" dirty="0"/>
           </a:p>
@@ -7828,7 +7828,7 @@
                 <a:ea typeface="Courier New" pitchFamily="34" charset="-122"/>
                 <a:cs typeface="Courier New" pitchFamily="34" charset="-120"/>
               </a:rPr>
-              <a:t>✗ basic-arithmetic/plan bob wrong-signer 49d44168 trailer: missing</a:t>
+              <a:t>✗ basic-arithmetic/plan bob wrong-signer 5b5d78ae trailer: missing</a:t>
             </a:r>
             <a:endParaRPr lang="en-US" sz="1000" dirty="0"/>
           </a:p>
@@ -7845,7 +7845,7 @@
                 <a:ea typeface="Courier New" pitchFamily="34" charset="-122"/>
                 <a:cs typeface="Courier New" pitchFamily="34" charset="-120"/>
               </a:rPr>
-              <a:t>✓ basic-arithmetic/review carol valid 7dd9d0f2 trailer: missing</a:t>
+              <a:t>✓ basic-arithmetic/review carol valid 803956c6 trailer: missing</a:t>
             </a:r>
             <a:endParaRPr lang="en-US" sz="1000" dirty="0"/>
           </a:p>
@@ -7862,7 +7862,7 @@
                 <a:ea typeface="Courier New" pitchFamily="34" charset="-122"/>
                 <a:cs typeface="Courier New" pitchFamily="34" charset="-120"/>
               </a:rPr>
-              <a:t>✓ basic-arithmetic/release alice valid ebca62f0 trailer: missing</a:t>
+              <a:t>✓ basic-arithmetic/release alice valid e6660de3 trailer: missing</a:t>
             </a:r>
             <a:endParaRPr lang="en-US" sz="1000" dirty="0"/>
           </a:p>
@@ -7879,7 +7879,7 @@
                 <a:ea typeface="Courier New" pitchFamily="34" charset="-122"/>
                 <a:cs typeface="Courier New" pitchFamily="34" charset="-120"/>
               </a:rPr>
-              <a:t>✓ openspec/roles.yaml alice@calc.example valid c1afb48f</a:t>
+              <a:t>✓ openspec/roles.yaml alice@calc.example valid e84d864b</a:t>
             </a:r>
             <a:endParaRPr lang="en-US" sz="1000" dirty="0"/>
           </a:p>
@@ -14365,7 +14365,7 @@
                 <a:ea typeface="Courier New" pitchFamily="34" charset="-122"/>
                 <a:cs typeface="Courier New" pitchFamily="34" charset="-120"/>
               </a:rPr>
-              <a:t>  archived) · sdlc 0.15.3, license:</a:t>
+              <a:t>  archived) · sdlc 0.15.4, license:</a:t>
             </a:r>
             <a:endParaRPr lang="en-US" sz="1000" dirty="0"/>
           </a:p>
@@ -14552,7 +14552,7 @@
                 <a:ea typeface="Courier New" pitchFamily="34" charset="-122"/>
                 <a:cs typeface="Courier New" pitchFamily="34" charset="-120"/>
               </a:rPr>
-              <a:t>  intent 3 · spec 1 · plan 14 · review 3;</a:t>
+              <a:t>  intent 3 · spec 1 · plan 13 · review 3;</a:t>
             </a:r>
             <a:endParaRPr lang="en-US" sz="1000" dirty="0"/>
           </a:p>
@@ -14886,7 +14886,7 @@
                 <a:ea typeface="Courier New" pitchFamily="34" charset="-122"/>
                 <a:cs typeface="Courier New" pitchFamily="34" charset="-120"/>
               </a:rPr>
-              <a:t>2026-10-12T09:04:23.328Z  gate.review.await</a:t>
+              <a:t>2026-10-12T10:37:49.467Z  gate.review.await</a:t>
             </a:r>
             <a:endParaRPr lang="en-US" sz="1000" dirty="0"/>
           </a:p>
@@ -14920,7 +14920,7 @@
                 <a:ea typeface="Courier New" pitchFamily="34" charset="-122"/>
                 <a:cs typeface="Courier New" pitchFamily="34" charset="-120"/>
               </a:rPr>
-              <a:t>  sha256:724adef414cda8539deaf284827111a968</a:t>
+              <a:t>  sha256:a926d27ef7602348df7c9ff8d297a9a9b2</a:t>
             </a:r>
             <a:endParaRPr lang="en-US" sz="1000" dirty="0"/>
           </a:p>
@@ -14937,7 +14937,7 @@
                 <a:ea typeface="Courier New" pitchFamily="34" charset="-122"/>
                 <a:cs typeface="Courier New" pitchFamily="34" charset="-120"/>
               </a:rPr>
-              <a:t>  0234750270208b185d3da916bdd232 [sdlc</a:t>
+              <a:t>  04d040d0163779271132d900e1977d [sdlc</a:t>
             </a:r>
             <a:endParaRPr lang="en-US" sz="1000" dirty="0"/>
           </a:p>
@@ -14954,7 +14954,7 @@
                 <a:ea typeface="Courier New" pitchFamily="34" charset="-122"/>
                 <a:cs typeface="Courier New" pitchFamily="34" charset="-120"/>
               </a:rPr>
-              <a:t>  0.15.3 · community]</a:t>
+              <a:t>  0.15.4 · community]</a:t>
             </a:r>
             <a:endParaRPr lang="en-US" sz="1000" dirty="0"/>
           </a:p>
@@ -14971,7 +14971,7 @@
                 <a:ea typeface="Courier New" pitchFamily="34" charset="-122"/>
                 <a:cs typeface="Courier New" pitchFamily="34" charset="-120"/>
               </a:rPr>
-              <a:t>2026-10-12T09:04:26.395Z  gate.review.appro</a:t>
+              <a:t>2026-10-12T10:37:52.517Z  gate.review.appro</a:t>
             </a:r>
             <a:endParaRPr lang="en-US" sz="1000" dirty="0"/>
           </a:p>
@@ -15022,7 +15022,7 @@
                 <a:ea typeface="Courier New" pitchFamily="34" charset="-122"/>
                 <a:cs typeface="Courier New" pitchFamily="34" charset="-120"/>
               </a:rPr>
-              <a:t>  [sdlc 0.15.3 · community]</a:t>
+              <a:t>  [sdlc 0.15.4 · community]</a:t>
             </a:r>
             <a:endParaRPr lang="en-US" sz="1000" dirty="0"/>
           </a:p>
@@ -15039,7 +15039,7 @@
                 <a:ea typeface="Courier New" pitchFamily="34" charset="-122"/>
                 <a:cs typeface="Courier New" pitchFamily="34" charset="-120"/>
               </a:rPr>
-              <a:t>2026-10-12T09:04:32.636Z  gate.release.appr</a:t>
+              <a:t>2026-10-12T10:37:58.642Z  gate.release.appr</a:t>
             </a:r>
             <a:endParaRPr lang="en-US" sz="1000" dirty="0"/>
           </a:p>
@@ -15090,7 +15090,7 @@
                 <a:ea typeface="Courier New" pitchFamily="34" charset="-122"/>
                 <a:cs typeface="Courier New" pitchFamily="34" charset="-120"/>
               </a:rPr>
-              <a:t>  release-manager [sdlc 0.15.3 · community]</a:t>
+              <a:t>  release-manager [sdlc 0.15.4 · community]</a:t>
             </a:r>
             <a:endParaRPr lang="en-US" sz="1000" dirty="0"/>
           </a:p>
@@ -16720,7 +16720,7 @@
                 <a:ea typeface="Courier New" pitchFamily="34" charset="-122"/>
                 <a:cs typeface="Courier New" pitchFamily="34" charset="-120"/>
               </a:rPr>
-              <a:t>      "id": "20261012T090522387Z-ci-green-4</a:t>
+              <a:t>      "id": "20261012T103845856Z-ci-green-c</a:t>
             </a:r>
             <a:endParaRPr lang="en-US" sz="1000" dirty="0"/>
           </a:p>
@@ -16737,7 +16737,7 @@
                 <a:ea typeface="Courier New" pitchFamily="34" charset="-122"/>
                 <a:cs typeface="Courier New" pitchFamily="34" charset="-120"/>
               </a:rPr>
-              <a:t>  6b9d2",</a:t>
+              <a:t>  5ba35",</a:t>
             </a:r>
             <a:endParaRPr lang="en-US" sz="1000" dirty="0"/>
           </a:p>
@@ -16873,7 +16873,7 @@
                 <a:ea typeface="Courier New" pitchFamily="34" charset="-122"/>
                 <a:cs typeface="Courier New" pitchFamily="34" charset="-120"/>
               </a:rPr>
-              <a:t>        "ref": "69515169f3b043c5e81f622dd31</a:t>
+              <a:t>        "ref": "f070fd3e991dbee7473eb016ca0</a:t>
             </a:r>
             <a:endParaRPr lang="en-US" sz="1000" dirty="0"/>
           </a:p>
@@ -16890,7 +16890,7 @@
                 <a:ea typeface="Courier New" pitchFamily="34" charset="-122"/>
                 <a:cs typeface="Courier New" pitchFamily="34" charset="-120"/>
               </a:rPr>
-              <a:t>  6042997801b5c",</a:t>
+              <a:t>  a8bebfdb56c1c",</a:t>
             </a:r>
             <a:endParaRPr lang="en-US" sz="1000" dirty="0"/>
           </a:p>
@@ -26952,7 +26952,7 @@
                 <a:ea typeface="Courier New" pitchFamily="34" charset="-122"/>
                 <a:cs typeface="Courier New" pitchFamily="34" charset="-120"/>
               </a:rPr>
-              <a:t>  sdlc 0.15.3, license: community</a:t>
+              <a:t>  sdlc 0.15.4, license: community</a:t>
             </a:r>
             <a:endParaRPr lang="en-US" sz="1000" dirty="0"/>
           </a:p>

</xml_diff>

<commit_message>
feat: $any in MCP checks; mcp check shows tool arguments; log and health windows (0.16.0)
- In expect and wait_while of a verify.mcp or release.mcp check,
  { $any: <pattern> } in place of a list matches when at least one item
  of the answer's list contains the pattern, for example one successful
  CI run among several. Plain lists keep their exact meaning; another
  key that starts with $ is an invalid configuration.
- sdlc mcp check gives each tool's arguments from its input schema: an
  args map in the JSON, and one tool per line with --args.
- sdlc log --event <name> (with * for any text) and --since <date>.
- sdlc health --since <date> or --days <n> looks at another window for
  one run, named in the JSON, and records no health signals.

SDLC-Agent: claude-code
</commit_message>
<xml_diff>
--- a/docs/demo/sdlc-calculator-demo.en.pptx
+++ b/docs/demo/sdlc-calculator-demo.en.pptx
@@ -6660,7 +6660,7 @@
                 <a:ea typeface="Courier New" pitchFamily="34" charset="-122"/>
                 <a:cs typeface="Courier New" pitchFamily="34" charset="-120"/>
               </a:rPr>
-              <a:t>  code-owner (a926d27ef760)</a:t>
+              <a:t>  code-owner (2d4e1179f87b)</a:t>
             </a:r>
             <a:endParaRPr lang="en-US" sz="1000" dirty="0"/>
           </a:p>
@@ -6745,7 +6745,7 @@
                 <a:ea typeface="Courier New" pitchFamily="34" charset="-122"/>
                 <a:cs typeface="Courier New" pitchFamily="34" charset="-120"/>
               </a:rPr>
-              <a:t>  "SDLC-Approval: basic-arithmetic:review:a</a:t>
+              <a:t>  "SDLC-Approval: basic-arithmetic:review:2</a:t>
             </a:r>
             <a:endParaRPr lang="en-US" sz="1000" dirty="0"/>
           </a:p>
@@ -6762,7 +6762,7 @@
                 <a:ea typeface="Courier New" pitchFamily="34" charset="-122"/>
                 <a:cs typeface="Courier New" pitchFamily="34" charset="-120"/>
               </a:rPr>
-              <a:t>  926d27ef760"</a:t>
+              <a:t>  d4e1179f87b"</a:t>
             </a:r>
             <a:endParaRPr lang="en-US" sz="1000" dirty="0"/>
           </a:p>
@@ -7443,7 +7443,7 @@
                 <a:ea typeface="Courier New" pitchFamily="34" charset="-122"/>
                 <a:cs typeface="Courier New" pitchFamily="34" charset="-120"/>
               </a:rPr>
-              <a:t>  release-manager (a926d27ef760)</a:t>
+              <a:t>  release-manager (2d4e1179f87b)</a:t>
             </a:r>
             <a:endParaRPr lang="en-US" sz="1000" dirty="0"/>
           </a:p>
@@ -7511,7 +7511,7 @@
                 <a:ea typeface="Courier New" pitchFamily="34" charset="-122"/>
                 <a:cs typeface="Courier New" pitchFamily="34" charset="-120"/>
               </a:rPr>
-              <a:t>  gate" -m "SDLC-Approval: basic-arithmetic:release:a926d27ef760"</a:t>
+              <a:t>  gate" -m "SDLC-Approval: basic-arithmetic:release:2d4e1179f87b"</a:t>
             </a:r>
             <a:endParaRPr lang="en-US" sz="1000" dirty="0"/>
           </a:p>
@@ -7794,7 +7794,7 @@
                 <a:ea typeface="Courier New" pitchFamily="34" charset="-122"/>
                 <a:cs typeface="Courier New" pitchFamily="34" charset="-120"/>
               </a:rPr>
-              <a:t>✓ basic-arithmetic/intent alice valid a5357fd4 trailer: missing</a:t>
+              <a:t>✓ basic-arithmetic/intent alice valid 2fc6af5f trailer: missing</a:t>
             </a:r>
             <a:endParaRPr lang="en-US" sz="1000" dirty="0"/>
           </a:p>
@@ -7811,7 +7811,7 @@
                 <a:ea typeface="Courier New" pitchFamily="34" charset="-122"/>
                 <a:cs typeface="Courier New" pitchFamily="34" charset="-120"/>
               </a:rPr>
-              <a:t>✓ basic-arithmetic/spec alice valid 5b5d78ae trailer: missing</a:t>
+              <a:t>✓ basic-arithmetic/spec alice valid 20ad1c9c trailer: missing</a:t>
             </a:r>
             <a:endParaRPr lang="en-US" sz="1000" dirty="0"/>
           </a:p>
@@ -7828,7 +7828,7 @@
                 <a:ea typeface="Courier New" pitchFamily="34" charset="-122"/>
                 <a:cs typeface="Courier New" pitchFamily="34" charset="-120"/>
               </a:rPr>
-              <a:t>✗ basic-arithmetic/plan bob wrong-signer 5b5d78ae trailer: missing</a:t>
+              <a:t>✗ basic-arithmetic/plan bob wrong-signer 20ad1c9c trailer: missing</a:t>
             </a:r>
             <a:endParaRPr lang="en-US" sz="1000" dirty="0"/>
           </a:p>
@@ -7845,7 +7845,7 @@
                 <a:ea typeface="Courier New" pitchFamily="34" charset="-122"/>
                 <a:cs typeface="Courier New" pitchFamily="34" charset="-120"/>
               </a:rPr>
-              <a:t>✓ basic-arithmetic/review carol valid 803956c6 trailer: missing</a:t>
+              <a:t>✓ basic-arithmetic/review carol valid dd6163e1 trailer: missing</a:t>
             </a:r>
             <a:endParaRPr lang="en-US" sz="1000" dirty="0"/>
           </a:p>
@@ -7862,7 +7862,7 @@
                 <a:ea typeface="Courier New" pitchFamily="34" charset="-122"/>
                 <a:cs typeface="Courier New" pitchFamily="34" charset="-120"/>
               </a:rPr>
-              <a:t>✓ basic-arithmetic/release alice valid e6660de3 trailer: missing</a:t>
+              <a:t>✓ basic-arithmetic/release alice valid 6c4ca7e5 trailer: missing</a:t>
             </a:r>
             <a:endParaRPr lang="en-US" sz="1000" dirty="0"/>
           </a:p>
@@ -7879,7 +7879,7 @@
                 <a:ea typeface="Courier New" pitchFamily="34" charset="-122"/>
                 <a:cs typeface="Courier New" pitchFamily="34" charset="-120"/>
               </a:rPr>
-              <a:t>✓ openspec/roles.yaml alice@calc.example valid e84d864b</a:t>
+              <a:t>✓ openspec/roles.yaml alice@calc.example valid 3af4e9c1</a:t>
             </a:r>
             <a:endParaRPr lang="en-US" sz="1000" dirty="0"/>
           </a:p>
@@ -14365,7 +14365,7 @@
                 <a:ea typeface="Courier New" pitchFamily="34" charset="-122"/>
                 <a:cs typeface="Courier New" pitchFamily="34" charset="-120"/>
               </a:rPr>
-              <a:t>  archived) · sdlc 0.15.4, license:</a:t>
+              <a:t>  archived) · sdlc 0.16.0, license:</a:t>
             </a:r>
             <a:endParaRPr lang="en-US" sz="1000" dirty="0"/>
           </a:p>
@@ -14886,7 +14886,7 @@
                 <a:ea typeface="Courier New" pitchFamily="34" charset="-122"/>
                 <a:cs typeface="Courier New" pitchFamily="34" charset="-120"/>
               </a:rPr>
-              <a:t>2026-10-12T10:37:49.467Z  gate.review.await</a:t>
+              <a:t>2026-10-12T11:44:46.776Z  gate.review.await</a:t>
             </a:r>
             <a:endParaRPr lang="en-US" sz="1000" dirty="0"/>
           </a:p>
@@ -14920,7 +14920,7 @@
                 <a:ea typeface="Courier New" pitchFamily="34" charset="-122"/>
                 <a:cs typeface="Courier New" pitchFamily="34" charset="-120"/>
               </a:rPr>
-              <a:t>  sha256:a926d27ef7602348df7c9ff8d297a9a9b2</a:t>
+              <a:t>  sha256:2d4e1179f87b8d8cf46235dfb3677acf9c</a:t>
             </a:r>
             <a:endParaRPr lang="en-US" sz="1000" dirty="0"/>
           </a:p>
@@ -14937,7 +14937,7 @@
                 <a:ea typeface="Courier New" pitchFamily="34" charset="-122"/>
                 <a:cs typeface="Courier New" pitchFamily="34" charset="-120"/>
               </a:rPr>
-              <a:t>  04d040d0163779271132d900e1977d [sdlc</a:t>
+              <a:t>  126eaf2527028066f0df56a62e87ad [sdlc</a:t>
             </a:r>
             <a:endParaRPr lang="en-US" sz="1000" dirty="0"/>
           </a:p>
@@ -14954,7 +14954,7 @@
                 <a:ea typeface="Courier New" pitchFamily="34" charset="-122"/>
                 <a:cs typeface="Courier New" pitchFamily="34" charset="-120"/>
               </a:rPr>
-              <a:t>  0.15.4 · community]</a:t>
+              <a:t>  0.16.0 · community]</a:t>
             </a:r>
             <a:endParaRPr lang="en-US" sz="1000" dirty="0"/>
           </a:p>
@@ -14971,7 +14971,7 @@
                 <a:ea typeface="Courier New" pitchFamily="34" charset="-122"/>
                 <a:cs typeface="Courier New" pitchFamily="34" charset="-120"/>
               </a:rPr>
-              <a:t>2026-10-12T10:37:52.517Z  gate.review.appro</a:t>
+              <a:t>2026-10-12T11:44:49.694Z  gate.review.appro</a:t>
             </a:r>
             <a:endParaRPr lang="en-US" sz="1000" dirty="0"/>
           </a:p>
@@ -15022,7 +15022,7 @@
                 <a:ea typeface="Courier New" pitchFamily="34" charset="-122"/>
                 <a:cs typeface="Courier New" pitchFamily="34" charset="-120"/>
               </a:rPr>
-              <a:t>  [sdlc 0.15.4 · community]</a:t>
+              <a:t>  [sdlc 0.16.0 · community]</a:t>
             </a:r>
             <a:endParaRPr lang="en-US" sz="1000" dirty="0"/>
           </a:p>
@@ -15039,7 +15039,7 @@
                 <a:ea typeface="Courier New" pitchFamily="34" charset="-122"/>
                 <a:cs typeface="Courier New" pitchFamily="34" charset="-120"/>
               </a:rPr>
-              <a:t>2026-10-12T10:37:58.642Z  gate.release.appr</a:t>
+              <a:t>2026-10-12T11:44:55.690Z  gate.release.appr</a:t>
             </a:r>
             <a:endParaRPr lang="en-US" sz="1000" dirty="0"/>
           </a:p>
@@ -15090,7 +15090,7 @@
                 <a:ea typeface="Courier New" pitchFamily="34" charset="-122"/>
                 <a:cs typeface="Courier New" pitchFamily="34" charset="-120"/>
               </a:rPr>
-              <a:t>  release-manager [sdlc 0.15.4 · community]</a:t>
+              <a:t>  release-manager [sdlc 0.16.0 · community]</a:t>
             </a:r>
             <a:endParaRPr lang="en-US" sz="1000" dirty="0"/>
           </a:p>
@@ -16720,7 +16720,7 @@
                 <a:ea typeface="Courier New" pitchFamily="34" charset="-122"/>
                 <a:cs typeface="Courier New" pitchFamily="34" charset="-120"/>
               </a:rPr>
-              <a:t>      "id": "20261012T103845856Z-ci-green-c</a:t>
+              <a:t>      "id": "20261012T114542613Z-ci-green-6</a:t>
             </a:r>
             <a:endParaRPr lang="en-US" sz="1000" dirty="0"/>
           </a:p>
@@ -16737,7 +16737,7 @@
                 <a:ea typeface="Courier New" pitchFamily="34" charset="-122"/>
                 <a:cs typeface="Courier New" pitchFamily="34" charset="-120"/>
               </a:rPr>
-              <a:t>  5ba35",</a:t>
+              <a:t>  848f2",</a:t>
             </a:r>
             <a:endParaRPr lang="en-US" sz="1000" dirty="0"/>
           </a:p>
@@ -16873,7 +16873,7 @@
                 <a:ea typeface="Courier New" pitchFamily="34" charset="-122"/>
                 <a:cs typeface="Courier New" pitchFamily="34" charset="-120"/>
               </a:rPr>
-              <a:t>        "ref": "f070fd3e991dbee7473eb016ca0</a:t>
+              <a:t>        "ref": "f9ea5b941e4556bfdc338cd5b2a</a:t>
             </a:r>
             <a:endParaRPr lang="en-US" sz="1000" dirty="0"/>
           </a:p>
@@ -16890,7 +16890,7 @@
                 <a:ea typeface="Courier New" pitchFamily="34" charset="-122"/>
                 <a:cs typeface="Courier New" pitchFamily="34" charset="-120"/>
               </a:rPr>
-              <a:t>  a8bebfdb56c1c",</a:t>
+              <a:t>  f1962d57b6b56",</a:t>
             </a:r>
             <a:endParaRPr lang="en-US" sz="1000" dirty="0"/>
           </a:p>
@@ -26952,7 +26952,7 @@
                 <a:ea typeface="Courier New" pitchFamily="34" charset="-122"/>
                 <a:cs typeface="Courier New" pitchFamily="34" charset="-120"/>
               </a:rPr>
-              <a:t>  sdlc 0.15.4, license: community</a:t>
+              <a:t>  sdlc 0.16.0, license: community</a:t>
             </a:r>
             <a:endParaRPr lang="en-US" sz="1000" dirty="0"/>
           </a:p>

</xml_diff>

<commit_message>
feat: init --roles; dashboard --watch; doctor --fix; rework notes in events, opt-in (0.16.1)
- sdlc init --roles writes the starter openspec/roles.yaml for the git
  identity and keeps an existing one. Only a person may run it: in an
  agent session the CLI refuses and the hook denies the command.
- sdlc dashboard --watch rebuilds the page after openspec/ changes;
  --serve host:port serves it with an auto-refresh.
- sdlc doctor --fix applies only what sdlc owns: missing generated files
  and an outdated stamp (as sdlc update, edited files kept), its own git
  hook, a starter REVIEW.md. Everything else is listed for a person.
- An event receiver with include_note: true also gets the note of a
  rejection or a rework: one line, at most 200 characters, secrets
  masked. Other receivers get exactly what they got before.
- The handbook names scripts/examples/dashboard-watch.mjs correctly
  again, and a test checks that the course names only existing files.

SDLC-Agent: claude-code
</commit_message>
<xml_diff>
--- a/docs/demo/sdlc-calculator-demo.en.pptx
+++ b/docs/demo/sdlc-calculator-demo.en.pptx
@@ -6660,7 +6660,7 @@
                 <a:ea typeface="Courier New" pitchFamily="34" charset="-122"/>
                 <a:cs typeface="Courier New" pitchFamily="34" charset="-120"/>
               </a:rPr>
-              <a:t>  code-owner (2d4e1179f87b)</a:t>
+              <a:t>  code-owner (ef784b84d0bc)</a:t>
             </a:r>
             <a:endParaRPr lang="en-US" sz="1000" dirty="0"/>
           </a:p>
@@ -6745,7 +6745,7 @@
                 <a:ea typeface="Courier New" pitchFamily="34" charset="-122"/>
                 <a:cs typeface="Courier New" pitchFamily="34" charset="-120"/>
               </a:rPr>
-              <a:t>  "SDLC-Approval: basic-arithmetic:review:2</a:t>
+              <a:t>  "SDLC-Approval: basic-arithmetic:review:e</a:t>
             </a:r>
             <a:endParaRPr lang="en-US" sz="1000" dirty="0"/>
           </a:p>
@@ -6762,7 +6762,7 @@
                 <a:ea typeface="Courier New" pitchFamily="34" charset="-122"/>
                 <a:cs typeface="Courier New" pitchFamily="34" charset="-120"/>
               </a:rPr>
-              <a:t>  d4e1179f87b"</a:t>
+              <a:t>  f784b84d0bc"</a:t>
             </a:r>
             <a:endParaRPr lang="en-US" sz="1000" dirty="0"/>
           </a:p>
@@ -7443,7 +7443,7 @@
                 <a:ea typeface="Courier New" pitchFamily="34" charset="-122"/>
                 <a:cs typeface="Courier New" pitchFamily="34" charset="-120"/>
               </a:rPr>
-              <a:t>  release-manager (2d4e1179f87b)</a:t>
+              <a:t>  release-manager (ef784b84d0bc)</a:t>
             </a:r>
             <a:endParaRPr lang="en-US" sz="1000" dirty="0"/>
           </a:p>
@@ -7511,7 +7511,7 @@
                 <a:ea typeface="Courier New" pitchFamily="34" charset="-122"/>
                 <a:cs typeface="Courier New" pitchFamily="34" charset="-120"/>
               </a:rPr>
-              <a:t>  gate" -m "SDLC-Approval: basic-arithmetic:release:2d4e1179f87b"</a:t>
+              <a:t>  gate" -m "SDLC-Approval: basic-arithmetic:release:ef784b84d0bc"</a:t>
             </a:r>
             <a:endParaRPr lang="en-US" sz="1000" dirty="0"/>
           </a:p>
@@ -7794,7 +7794,7 @@
                 <a:ea typeface="Courier New" pitchFamily="34" charset="-122"/>
                 <a:cs typeface="Courier New" pitchFamily="34" charset="-120"/>
               </a:rPr>
-              <a:t>✓ basic-arithmetic/intent alice valid 2fc6af5f trailer: missing</a:t>
+              <a:t>✓ basic-arithmetic/intent alice valid b0f5e7fa trailer: missing</a:t>
             </a:r>
             <a:endParaRPr lang="en-US" sz="1000" dirty="0"/>
           </a:p>
@@ -7811,7 +7811,7 @@
                 <a:ea typeface="Courier New" pitchFamily="34" charset="-122"/>
                 <a:cs typeface="Courier New" pitchFamily="34" charset="-120"/>
               </a:rPr>
-              <a:t>✓ basic-arithmetic/spec alice valid 20ad1c9c trailer: missing</a:t>
+              <a:t>✓ basic-arithmetic/spec alice valid 094d1d1a trailer: missing</a:t>
             </a:r>
             <a:endParaRPr lang="en-US" sz="1000" dirty="0"/>
           </a:p>
@@ -7828,7 +7828,7 @@
                 <a:ea typeface="Courier New" pitchFamily="34" charset="-122"/>
                 <a:cs typeface="Courier New" pitchFamily="34" charset="-120"/>
               </a:rPr>
-              <a:t>✗ basic-arithmetic/plan bob wrong-signer 20ad1c9c trailer: missing</a:t>
+              <a:t>✗ basic-arithmetic/plan bob wrong-signer 094d1d1a trailer: missing</a:t>
             </a:r>
             <a:endParaRPr lang="en-US" sz="1000" dirty="0"/>
           </a:p>
@@ -7845,7 +7845,7 @@
                 <a:ea typeface="Courier New" pitchFamily="34" charset="-122"/>
                 <a:cs typeface="Courier New" pitchFamily="34" charset="-120"/>
               </a:rPr>
-              <a:t>✓ basic-arithmetic/review carol valid dd6163e1 trailer: missing</a:t>
+              <a:t>✓ basic-arithmetic/review carol valid a1a76515 trailer: missing</a:t>
             </a:r>
             <a:endParaRPr lang="en-US" sz="1000" dirty="0"/>
           </a:p>
@@ -7862,7 +7862,7 @@
                 <a:ea typeface="Courier New" pitchFamily="34" charset="-122"/>
                 <a:cs typeface="Courier New" pitchFamily="34" charset="-120"/>
               </a:rPr>
-              <a:t>✓ basic-arithmetic/release alice valid 6c4ca7e5 trailer: missing</a:t>
+              <a:t>✓ basic-arithmetic/release alice valid 6ffa4b4f trailer: missing</a:t>
             </a:r>
             <a:endParaRPr lang="en-US" sz="1000" dirty="0"/>
           </a:p>
@@ -7879,7 +7879,7 @@
                 <a:ea typeface="Courier New" pitchFamily="34" charset="-122"/>
                 <a:cs typeface="Courier New" pitchFamily="34" charset="-120"/>
               </a:rPr>
-              <a:t>✓ openspec/roles.yaml alice@calc.example valid 3af4e9c1</a:t>
+              <a:t>✓ openspec/roles.yaml alice@calc.example valid 608d2828</a:t>
             </a:r>
             <a:endParaRPr lang="en-US" sz="1000" dirty="0"/>
           </a:p>
@@ -14365,7 +14365,7 @@
                 <a:ea typeface="Courier New" pitchFamily="34" charset="-122"/>
                 <a:cs typeface="Courier New" pitchFamily="34" charset="-120"/>
               </a:rPr>
-              <a:t>  archived) · sdlc 0.16.0, license:</a:t>
+              <a:t>  archived) · sdlc 0.16.1, license:</a:t>
             </a:r>
             <a:endParaRPr lang="en-US" sz="1000" dirty="0"/>
           </a:p>
@@ -14552,7 +14552,7 @@
                 <a:ea typeface="Courier New" pitchFamily="34" charset="-122"/>
                 <a:cs typeface="Courier New" pitchFamily="34" charset="-120"/>
               </a:rPr>
-              <a:t>  intent 3 · spec 1 · plan 13 · review 3;</a:t>
+              <a:t>  intent 3 · spec 1 · plan 14 · review 3;</a:t>
             </a:r>
             <a:endParaRPr lang="en-US" sz="1000" dirty="0"/>
           </a:p>
@@ -14886,7 +14886,7 @@
                 <a:ea typeface="Courier New" pitchFamily="34" charset="-122"/>
                 <a:cs typeface="Courier New" pitchFamily="34" charset="-120"/>
               </a:rPr>
-              <a:t>2026-10-12T11:44:46.776Z  gate.review.await</a:t>
+              <a:t>2026-10-12T13:28:57.301Z  gate.review.await</a:t>
             </a:r>
             <a:endParaRPr lang="en-US" sz="1000" dirty="0"/>
           </a:p>
@@ -14920,7 +14920,7 @@
                 <a:ea typeface="Courier New" pitchFamily="34" charset="-122"/>
                 <a:cs typeface="Courier New" pitchFamily="34" charset="-120"/>
               </a:rPr>
-              <a:t>  sha256:2d4e1179f87b8d8cf46235dfb3677acf9c</a:t>
+              <a:t>  sha256:ef784b84d0bcd62dc8ae42dcd69860bc3b</a:t>
             </a:r>
             <a:endParaRPr lang="en-US" sz="1000" dirty="0"/>
           </a:p>
@@ -14937,7 +14937,7 @@
                 <a:ea typeface="Courier New" pitchFamily="34" charset="-122"/>
                 <a:cs typeface="Courier New" pitchFamily="34" charset="-120"/>
               </a:rPr>
-              <a:t>  126eaf2527028066f0df56a62e87ad [sdlc</a:t>
+              <a:t>  8c634ea7cbdd278188e451e973e362 [sdlc</a:t>
             </a:r>
             <a:endParaRPr lang="en-US" sz="1000" dirty="0"/>
           </a:p>
@@ -14954,7 +14954,7 @@
                 <a:ea typeface="Courier New" pitchFamily="34" charset="-122"/>
                 <a:cs typeface="Courier New" pitchFamily="34" charset="-120"/>
               </a:rPr>
-              <a:t>  0.16.0 · community]</a:t>
+              <a:t>  0.16.1 · community]</a:t>
             </a:r>
             <a:endParaRPr lang="en-US" sz="1000" dirty="0"/>
           </a:p>
@@ -14971,7 +14971,7 @@
                 <a:ea typeface="Courier New" pitchFamily="34" charset="-122"/>
                 <a:cs typeface="Courier New" pitchFamily="34" charset="-120"/>
               </a:rPr>
-              <a:t>2026-10-12T11:44:49.694Z  gate.review.appro</a:t>
+              <a:t>2026-10-12T13:29:00.443Z  gate.review.appro</a:t>
             </a:r>
             <a:endParaRPr lang="en-US" sz="1000" dirty="0"/>
           </a:p>
@@ -15022,7 +15022,7 @@
                 <a:ea typeface="Courier New" pitchFamily="34" charset="-122"/>
                 <a:cs typeface="Courier New" pitchFamily="34" charset="-120"/>
               </a:rPr>
-              <a:t>  [sdlc 0.16.0 · community]</a:t>
+              <a:t>  [sdlc 0.16.1 · community]</a:t>
             </a:r>
             <a:endParaRPr lang="en-US" sz="1000" dirty="0"/>
           </a:p>
@@ -15039,7 +15039,7 @@
                 <a:ea typeface="Courier New" pitchFamily="34" charset="-122"/>
                 <a:cs typeface="Courier New" pitchFamily="34" charset="-120"/>
               </a:rPr>
-              <a:t>2026-10-12T11:44:55.690Z  gate.release.appr</a:t>
+              <a:t>2026-10-12T13:29:06.827Z  gate.release.appr</a:t>
             </a:r>
             <a:endParaRPr lang="en-US" sz="1000" dirty="0"/>
           </a:p>
@@ -15090,7 +15090,7 @@
                 <a:ea typeface="Courier New" pitchFamily="34" charset="-122"/>
                 <a:cs typeface="Courier New" pitchFamily="34" charset="-120"/>
               </a:rPr>
-              <a:t>  release-manager [sdlc 0.16.0 · community]</a:t>
+              <a:t>  release-manager [sdlc 0.16.1 · community]</a:t>
             </a:r>
             <a:endParaRPr lang="en-US" sz="1000" dirty="0"/>
           </a:p>
@@ -16720,7 +16720,7 @@
                 <a:ea typeface="Courier New" pitchFamily="34" charset="-122"/>
                 <a:cs typeface="Courier New" pitchFamily="34" charset="-120"/>
               </a:rPr>
-              <a:t>      "id": "20261012T114542613Z-ci-green-6</a:t>
+              <a:t>      "id": "20261012T132955659Z-ci-green-6</a:t>
             </a:r>
             <a:endParaRPr lang="en-US" sz="1000" dirty="0"/>
           </a:p>
@@ -16737,7 +16737,7 @@
                 <a:ea typeface="Courier New" pitchFamily="34" charset="-122"/>
                 <a:cs typeface="Courier New" pitchFamily="34" charset="-120"/>
               </a:rPr>
-              <a:t>  848f2",</a:t>
+              <a:t>  768a3",</a:t>
             </a:r>
             <a:endParaRPr lang="en-US" sz="1000" dirty="0"/>
           </a:p>
@@ -16873,7 +16873,7 @@
                 <a:ea typeface="Courier New" pitchFamily="34" charset="-122"/>
                 <a:cs typeface="Courier New" pitchFamily="34" charset="-120"/>
               </a:rPr>
-              <a:t>        "ref": "f9ea5b941e4556bfdc338cd5b2a</a:t>
+              <a:t>        "ref": "0052ccc6d9d5285b83afc4233e7</a:t>
             </a:r>
             <a:endParaRPr lang="en-US" sz="1000" dirty="0"/>
           </a:p>
@@ -16890,7 +16890,7 @@
                 <a:ea typeface="Courier New" pitchFamily="34" charset="-122"/>
                 <a:cs typeface="Courier New" pitchFamily="34" charset="-120"/>
               </a:rPr>
-              <a:t>  f1962d57b6b56",</a:t>
+              <a:t>  489b640a86e61",</a:t>
             </a:r>
             <a:endParaRPr lang="en-US" sz="1000" dirty="0"/>
           </a:p>
@@ -26952,7 +26952,7 @@
                 <a:ea typeface="Courier New" pitchFamily="34" charset="-122"/>
                 <a:cs typeface="Courier New" pitchFamily="34" charset="-120"/>
               </a:rPr>
-              <a:t>  sdlc 0.16.0, license: community</a:t>
+              <a:t>  sdlc 0.16.1, license: community</a:t>
             </a:r>
             <a:endParaRPr lang="en-US" sz="1000" dirty="0"/>
           </a:p>

</xml_diff>

<commit_message>
fix: signing: required can pass after the roles.yaml key bootstrap; no history trick passes (0.16.3)
- A team that adds signing keys to an existing roles.yaml can now reach
  signing: required. Commits before any key are pre-signing; the commit
  that adds the first keys is checked against its own version and is
  bootstrap when a maintainer listed there signed it. Only one bootstrap
  is allowed; more than one is bootstrap-conflict.
- The roles.yaml history is read in full. A merge that takes a branch's
  roles.yaml passes as merge only when that branch grew from a base with
  keys; a stale branch cannot drop the keys or bring keys of its own.
- With --mode required, a roles.yaml deleted at HEAD is still checked; a
  shallow clone (shallow_history) or grafts (rewritten_history) are
  refused; replace objects are ignored; a git error fails closed.
- Docs: the bootstrap steps, fetch-depth: 0 in CI, and the limit of the
  check for a force-pushed history.

SDLC-Agent: claude-code
</commit_message>
<xml_diff>
--- a/docs/demo/sdlc-calculator-demo.en.pptx
+++ b/docs/demo/sdlc-calculator-demo.en.pptx
@@ -6660,7 +6660,7 @@
                 <a:ea typeface="Courier New" pitchFamily="34" charset="-122"/>
                 <a:cs typeface="Courier New" pitchFamily="34" charset="-120"/>
               </a:rPr>
-              <a:t>  code-owner (5a26fd14d3b1)</a:t>
+              <a:t>  code-owner (3fe67dd99150)</a:t>
             </a:r>
             <a:endParaRPr lang="en-US" sz="1000" dirty="0"/>
           </a:p>
@@ -6745,7 +6745,7 @@
                 <a:ea typeface="Courier New" pitchFamily="34" charset="-122"/>
                 <a:cs typeface="Courier New" pitchFamily="34" charset="-120"/>
               </a:rPr>
-              <a:t>  "SDLC-Approval: basic-arithmetic:review:5</a:t>
+              <a:t>  "SDLC-Approval: basic-arithmetic:review:3</a:t>
             </a:r>
             <a:endParaRPr lang="en-US" sz="1000" dirty="0"/>
           </a:p>
@@ -6762,7 +6762,7 @@
                 <a:ea typeface="Courier New" pitchFamily="34" charset="-122"/>
                 <a:cs typeface="Courier New" pitchFamily="34" charset="-120"/>
               </a:rPr>
-              <a:t>  a26fd14d3b1"</a:t>
+              <a:t>  fe67dd99150"</a:t>
             </a:r>
             <a:endParaRPr lang="en-US" sz="1000" dirty="0"/>
           </a:p>
@@ -7443,7 +7443,7 @@
                 <a:ea typeface="Courier New" pitchFamily="34" charset="-122"/>
                 <a:cs typeface="Courier New" pitchFamily="34" charset="-120"/>
               </a:rPr>
-              <a:t>  release-manager (5a26fd14d3b1)</a:t>
+              <a:t>  release-manager (3fe67dd99150)</a:t>
             </a:r>
             <a:endParaRPr lang="en-US" sz="1000" dirty="0"/>
           </a:p>
@@ -7511,7 +7511,7 @@
                 <a:ea typeface="Courier New" pitchFamily="34" charset="-122"/>
                 <a:cs typeface="Courier New" pitchFamily="34" charset="-120"/>
               </a:rPr>
-              <a:t>  gate" -m "SDLC-Approval: basic-arithmetic:release:5a26fd14d3b1"</a:t>
+              <a:t>  gate" -m "SDLC-Approval: basic-arithmetic:release:3fe67dd99150"</a:t>
             </a:r>
             <a:endParaRPr lang="en-US" sz="1000" dirty="0"/>
           </a:p>
@@ -7794,7 +7794,7 @@
                 <a:ea typeface="Courier New" pitchFamily="34" charset="-122"/>
                 <a:cs typeface="Courier New" pitchFamily="34" charset="-120"/>
               </a:rPr>
-              <a:t>✓ basic-arithmetic/intent alice valid dc1bb17a trailer: missing</a:t>
+              <a:t>✓ basic-arithmetic/intent alice valid 8e330ae7 trailer: missing</a:t>
             </a:r>
             <a:endParaRPr lang="en-US" sz="1000" dirty="0"/>
           </a:p>
@@ -7811,7 +7811,7 @@
                 <a:ea typeface="Courier New" pitchFamily="34" charset="-122"/>
                 <a:cs typeface="Courier New" pitchFamily="34" charset="-120"/>
               </a:rPr>
-              <a:t>✓ basic-arithmetic/spec alice valid 6cb23d80 trailer: missing</a:t>
+              <a:t>✓ basic-arithmetic/spec alice valid 107c224f trailer: missing</a:t>
             </a:r>
             <a:endParaRPr lang="en-US" sz="1000" dirty="0"/>
           </a:p>
@@ -7828,7 +7828,7 @@
                 <a:ea typeface="Courier New" pitchFamily="34" charset="-122"/>
                 <a:cs typeface="Courier New" pitchFamily="34" charset="-120"/>
               </a:rPr>
-              <a:t>✗ basic-arithmetic/plan bob wrong-signer 6cb23d80 trailer: missing</a:t>
+              <a:t>✗ basic-arithmetic/plan bob wrong-signer 107c224f trailer: missing</a:t>
             </a:r>
             <a:endParaRPr lang="en-US" sz="1000" dirty="0"/>
           </a:p>
@@ -7845,7 +7845,7 @@
                 <a:ea typeface="Courier New" pitchFamily="34" charset="-122"/>
                 <a:cs typeface="Courier New" pitchFamily="34" charset="-120"/>
               </a:rPr>
-              <a:t>✓ basic-arithmetic/review carol valid 5120b2b7 trailer: missing</a:t>
+              <a:t>✓ basic-arithmetic/review carol valid 6943d6be trailer: missing</a:t>
             </a:r>
             <a:endParaRPr lang="en-US" sz="1000" dirty="0"/>
           </a:p>
@@ -7862,7 +7862,7 @@
                 <a:ea typeface="Courier New" pitchFamily="34" charset="-122"/>
                 <a:cs typeface="Courier New" pitchFamily="34" charset="-120"/>
               </a:rPr>
-              <a:t>✓ basic-arithmetic/release alice valid 5aa2ca98 trailer: missing</a:t>
+              <a:t>✓ basic-arithmetic/release alice valid 1b26a563 trailer: missing</a:t>
             </a:r>
             <a:endParaRPr lang="en-US" sz="1000" dirty="0"/>
           </a:p>
@@ -7879,7 +7879,7 @@
                 <a:ea typeface="Courier New" pitchFamily="34" charset="-122"/>
                 <a:cs typeface="Courier New" pitchFamily="34" charset="-120"/>
               </a:rPr>
-              <a:t>✓ openspec/roles.yaml alice@calc.example valid dd79449c</a:t>
+              <a:t>✓ openspec/roles.yaml alice@calc.example bootstrap 04d0b1ec</a:t>
             </a:r>
             <a:endParaRPr lang="en-US" sz="1000" dirty="0"/>
           </a:p>
@@ -14365,7 +14365,7 @@
                 <a:ea typeface="Courier New" pitchFamily="34" charset="-122"/>
                 <a:cs typeface="Courier New" pitchFamily="34" charset="-120"/>
               </a:rPr>
-              <a:t>  archived) · sdlc 0.16.2, license:</a:t>
+              <a:t>  archived) · sdlc 0.16.3, license:</a:t>
             </a:r>
             <a:endParaRPr lang="en-US" sz="1000" dirty="0"/>
           </a:p>
@@ -14552,7 +14552,7 @@
                 <a:ea typeface="Courier New" pitchFamily="34" charset="-122"/>
                 <a:cs typeface="Courier New" pitchFamily="34" charset="-120"/>
               </a:rPr>
-              <a:t>  intent 3 · spec 1 · plan 14 · review 3;</a:t>
+              <a:t>  intent 3 · spec 1 · plan 13 · review 3;</a:t>
             </a:r>
             <a:endParaRPr lang="en-US" sz="1000" dirty="0"/>
           </a:p>
@@ -14886,7 +14886,7 @@
                 <a:ea typeface="Courier New" pitchFamily="34" charset="-122"/>
                 <a:cs typeface="Courier New" pitchFamily="34" charset="-120"/>
               </a:rPr>
-              <a:t>2026-10-12T14:45:35.851Z  gate.review.await</a:t>
+              <a:t>2026-10-12T17:54:32.408Z  gate.review.await</a:t>
             </a:r>
             <a:endParaRPr lang="en-US" sz="1000" dirty="0"/>
           </a:p>
@@ -14920,7 +14920,7 @@
                 <a:ea typeface="Courier New" pitchFamily="34" charset="-122"/>
                 <a:cs typeface="Courier New" pitchFamily="34" charset="-120"/>
               </a:rPr>
-              <a:t>  sha256:5a26fd14d3b15ccc118360026c58c0b693</a:t>
+              <a:t>  sha256:3fe67dd9915088930c7427061dc3c5e496</a:t>
             </a:r>
             <a:endParaRPr lang="en-US" sz="1000" dirty="0"/>
           </a:p>
@@ -14937,7 +14937,7 @@
                 <a:ea typeface="Courier New" pitchFamily="34" charset="-122"/>
                 <a:cs typeface="Courier New" pitchFamily="34" charset="-120"/>
               </a:rPr>
-              <a:t>  d03c7733c25a425a605e699faf6440 [sdlc</a:t>
+              <a:t>  c4f349ad9d3f4cd8fd094ebb77aa4a [sdlc</a:t>
             </a:r>
             <a:endParaRPr lang="en-US" sz="1000" dirty="0"/>
           </a:p>
@@ -14954,7 +14954,7 @@
                 <a:ea typeface="Courier New" pitchFamily="34" charset="-122"/>
                 <a:cs typeface="Courier New" pitchFamily="34" charset="-120"/>
               </a:rPr>
-              <a:t>  0.16.2 · community]</a:t>
+              <a:t>  0.16.3 · community]</a:t>
             </a:r>
             <a:endParaRPr lang="en-US" sz="1000" dirty="0"/>
           </a:p>
@@ -14971,7 +14971,7 @@
                 <a:ea typeface="Courier New" pitchFamily="34" charset="-122"/>
                 <a:cs typeface="Courier New" pitchFamily="34" charset="-120"/>
               </a:rPr>
-              <a:t>2026-10-12T14:45:38.933Z  gate.review.appro</a:t>
+              <a:t>2026-10-12T17:54:35.551Z  gate.review.appro</a:t>
             </a:r>
             <a:endParaRPr lang="en-US" sz="1000" dirty="0"/>
           </a:p>
@@ -15022,7 +15022,7 @@
                 <a:ea typeface="Courier New" pitchFamily="34" charset="-122"/>
                 <a:cs typeface="Courier New" pitchFamily="34" charset="-120"/>
               </a:rPr>
-              <a:t>  [sdlc 0.16.2 · community]</a:t>
+              <a:t>  [sdlc 0.16.3 · community]</a:t>
             </a:r>
             <a:endParaRPr lang="en-US" sz="1000" dirty="0"/>
           </a:p>
@@ -15039,7 +15039,7 @@
                 <a:ea typeface="Courier New" pitchFamily="34" charset="-122"/>
                 <a:cs typeface="Courier New" pitchFamily="34" charset="-120"/>
               </a:rPr>
-              <a:t>2026-10-12T14:45:45.198Z  gate.release.appr</a:t>
+              <a:t>2026-10-12T17:54:41.749Z  gate.release.appr</a:t>
             </a:r>
             <a:endParaRPr lang="en-US" sz="1000" dirty="0"/>
           </a:p>
@@ -15090,7 +15090,7 @@
                 <a:ea typeface="Courier New" pitchFamily="34" charset="-122"/>
                 <a:cs typeface="Courier New" pitchFamily="34" charset="-120"/>
               </a:rPr>
-              <a:t>  release-manager [sdlc 0.16.2 · community]</a:t>
+              <a:t>  release-manager [sdlc 0.16.3 · community]</a:t>
             </a:r>
             <a:endParaRPr lang="en-US" sz="1000" dirty="0"/>
           </a:p>
@@ -16720,7 +16720,7 @@
                 <a:ea typeface="Courier New" pitchFamily="34" charset="-122"/>
                 <a:cs typeface="Courier New" pitchFamily="34" charset="-120"/>
               </a:rPr>
-              <a:t>      "id": "20261012T144633255Z-ci-green-e</a:t>
+              <a:t>      "id": "20261012T175530725Z-ci-green-1</a:t>
             </a:r>
             <a:endParaRPr lang="en-US" sz="1000" dirty="0"/>
           </a:p>
@@ -16737,7 +16737,7 @@
                 <a:ea typeface="Courier New" pitchFamily="34" charset="-122"/>
                 <a:cs typeface="Courier New" pitchFamily="34" charset="-120"/>
               </a:rPr>
-              <a:t>  2ddd2",</a:t>
+              <a:t>  044be",</a:t>
             </a:r>
             <a:endParaRPr lang="en-US" sz="1000" dirty="0"/>
           </a:p>
@@ -16873,7 +16873,7 @@
                 <a:ea typeface="Courier New" pitchFamily="34" charset="-122"/>
                 <a:cs typeface="Courier New" pitchFamily="34" charset="-120"/>
               </a:rPr>
-              <a:t>        "ref": "280019eec5165fcbd633f583552</a:t>
+              <a:t>        "ref": "aab87b1053d604eadb8b3cb8dcd</a:t>
             </a:r>
             <a:endParaRPr lang="en-US" sz="1000" dirty="0"/>
           </a:p>
@@ -16890,7 +16890,7 @@
                 <a:ea typeface="Courier New" pitchFamily="34" charset="-122"/>
                 <a:cs typeface="Courier New" pitchFamily="34" charset="-120"/>
               </a:rPr>
-              <a:t>  f6c5d186a19a8",</a:t>
+              <a:t>  77474e4b0fd75",</a:t>
             </a:r>
             <a:endParaRPr lang="en-US" sz="1000" dirty="0"/>
           </a:p>
@@ -26952,7 +26952,7 @@
                 <a:ea typeface="Courier New" pitchFamily="34" charset="-122"/>
                 <a:cs typeface="Courier New" pitchFamily="34" charset="-120"/>
               </a:rPr>
-              <a:t>  sdlc 0.16.2, license: community</a:t>
+              <a:t>  sdlc 0.16.3, license: community</a:t>
             </a:r>
             <a:endParaRPr lang="en-US" sz="1000" dirty="0"/>
           </a:p>

</xml_diff>

<commit_message>
feat: decisions by role; verify.require_behaviour; an optional qa gate (0.18.0)
- With openspec/roles.yaml, sdlc team accept needs the maintainer role and
  sdlc backlog move/drop need product-owner; a person without the role is
  refused with missing_role and told who may. Without the file any person
  may decide, as before; an agent never.
- verify.require_behaviour: true makes the verify gate also need one
  behavioural row in verification.md per spec scenario; the reason names
  the uncovered scenarios and sdlc next asks the agent to fill the table.
- An optional qa gate between verify and review (gates.qa.required): a
  person with the qa role accepts the verification evidence; a new verify
  run makes the approval stale; sdlc reject qa sends the change back.
- sdlc team list shows when a newer draft of an accepted role waits.

SDLC-Agent: claude-code
</commit_message>
<xml_diff>
--- a/docs/demo/sdlc-calculator-demo.en.pptx
+++ b/docs/demo/sdlc-calculator-demo.en.pptx
@@ -5112,7 +5112,7 @@
                 <a:ea typeface="Courier New" pitchFamily="34" charset="-122"/>
                 <a:cs typeface="Courier New" pitchFamily="34" charset="-120"/>
               </a:rPr>
-              <a:t>✓ test (1.1s)</a:t>
+              <a:t>✓ test (1.2s)</a:t>
             </a:r>
             <a:endParaRPr lang="en-US" sz="1000" dirty="0"/>
           </a:p>
@@ -6660,7 +6660,7 @@
                 <a:ea typeface="Courier New" pitchFamily="34" charset="-122"/>
                 <a:cs typeface="Courier New" pitchFamily="34" charset="-120"/>
               </a:rPr>
-              <a:t>  code-owner (2f0312b7fcdc)</a:t>
+              <a:t>  code-owner (8cf5f98928e2)</a:t>
             </a:r>
             <a:endParaRPr lang="en-US" sz="1000" dirty="0"/>
           </a:p>
@@ -6745,7 +6745,7 @@
                 <a:ea typeface="Courier New" pitchFamily="34" charset="-122"/>
                 <a:cs typeface="Courier New" pitchFamily="34" charset="-120"/>
               </a:rPr>
-              <a:t>  "SDLC-Approval: basic-arithmetic:review:2</a:t>
+              <a:t>  "SDLC-Approval: basic-arithmetic:review:8</a:t>
             </a:r>
             <a:endParaRPr lang="en-US" sz="1000" dirty="0"/>
           </a:p>
@@ -6762,7 +6762,7 @@
                 <a:ea typeface="Courier New" pitchFamily="34" charset="-122"/>
                 <a:cs typeface="Courier New" pitchFamily="34" charset="-120"/>
               </a:rPr>
-              <a:t>  f0312b7fcdc"</a:t>
+              <a:t>  cf5f98928e2"</a:t>
             </a:r>
             <a:endParaRPr lang="en-US" sz="1000" dirty="0"/>
           </a:p>
@@ -7443,7 +7443,7 @@
                 <a:ea typeface="Courier New" pitchFamily="34" charset="-122"/>
                 <a:cs typeface="Courier New" pitchFamily="34" charset="-120"/>
               </a:rPr>
-              <a:t>  release-manager (2f0312b7fcdc)</a:t>
+              <a:t>  release-manager (8cf5f98928e2)</a:t>
             </a:r>
             <a:endParaRPr lang="en-US" sz="1000" dirty="0"/>
           </a:p>
@@ -7511,7 +7511,7 @@
                 <a:ea typeface="Courier New" pitchFamily="34" charset="-122"/>
                 <a:cs typeface="Courier New" pitchFamily="34" charset="-120"/>
               </a:rPr>
-              <a:t>  gate" -m "SDLC-Approval: basic-arithmetic:release:2f0312b7fcdc"</a:t>
+              <a:t>  gate" -m "SDLC-Approval: basic-arithmetic:release:8cf5f98928e2"</a:t>
             </a:r>
             <a:endParaRPr lang="en-US" sz="1000" dirty="0"/>
           </a:p>
@@ -7794,7 +7794,7 @@
                 <a:ea typeface="Courier New" pitchFamily="34" charset="-122"/>
                 <a:cs typeface="Courier New" pitchFamily="34" charset="-120"/>
               </a:rPr>
-              <a:t>✓ basic-arithmetic/intent alice valid 11893cb3 trailer: missing</a:t>
+              <a:t>✓ basic-arithmetic/intent alice valid ba203e76 trailer: missing</a:t>
             </a:r>
             <a:endParaRPr lang="en-US" sz="1000" dirty="0"/>
           </a:p>
@@ -7811,7 +7811,7 @@
                 <a:ea typeface="Courier New" pitchFamily="34" charset="-122"/>
                 <a:cs typeface="Courier New" pitchFamily="34" charset="-120"/>
               </a:rPr>
-              <a:t>✓ basic-arithmetic/spec alice valid 80d48b3a trailer: missing</a:t>
+              <a:t>✓ basic-arithmetic/spec alice valid 4c3be653 trailer: missing</a:t>
             </a:r>
             <a:endParaRPr lang="en-US" sz="1000" dirty="0"/>
           </a:p>
@@ -7828,7 +7828,7 @@
                 <a:ea typeface="Courier New" pitchFamily="34" charset="-122"/>
                 <a:cs typeface="Courier New" pitchFamily="34" charset="-120"/>
               </a:rPr>
-              <a:t>✗ basic-arithmetic/plan bob wrong-signer 80d48b3a trailer: missing</a:t>
+              <a:t>✗ basic-arithmetic/plan bob wrong-signer 4c3be653 trailer: missing</a:t>
             </a:r>
             <a:endParaRPr lang="en-US" sz="1000" dirty="0"/>
           </a:p>
@@ -7845,7 +7845,7 @@
                 <a:ea typeface="Courier New" pitchFamily="34" charset="-122"/>
                 <a:cs typeface="Courier New" pitchFamily="34" charset="-120"/>
               </a:rPr>
-              <a:t>✓ basic-arithmetic/review carol valid 32a5c38f trailer: missing</a:t>
+              <a:t>✓ basic-arithmetic/review carol valid 0e4833ee trailer: missing</a:t>
             </a:r>
             <a:endParaRPr lang="en-US" sz="1000" dirty="0"/>
           </a:p>
@@ -7862,7 +7862,7 @@
                 <a:ea typeface="Courier New" pitchFamily="34" charset="-122"/>
                 <a:cs typeface="Courier New" pitchFamily="34" charset="-120"/>
               </a:rPr>
-              <a:t>✓ basic-arithmetic/release alice valid a7c96875 trailer: missing</a:t>
+              <a:t>✓ basic-arithmetic/release alice valid d866a99f trailer: missing</a:t>
             </a:r>
             <a:endParaRPr lang="en-US" sz="1000" dirty="0"/>
           </a:p>
@@ -7879,7 +7879,7 @@
                 <a:ea typeface="Courier New" pitchFamily="34" charset="-122"/>
                 <a:cs typeface="Courier New" pitchFamily="34" charset="-120"/>
               </a:rPr>
-              <a:t>✓ openspec/roles.yaml alice@calc.example bootstrap 0d032022</a:t>
+              <a:t>✓ openspec/roles.yaml alice@calc.example bootstrap 137d1b62</a:t>
             </a:r>
             <a:endParaRPr lang="en-US" sz="1000" dirty="0"/>
           </a:p>
@@ -14365,7 +14365,7 @@
                 <a:ea typeface="Courier New" pitchFamily="34" charset="-122"/>
                 <a:cs typeface="Courier New" pitchFamily="34" charset="-120"/>
               </a:rPr>
-              <a:t>  archived) · sdlc 0.17.0, license:</a:t>
+              <a:t>  archived) · sdlc 0.18.0, license:</a:t>
             </a:r>
             <a:endParaRPr lang="en-US" sz="1000" dirty="0"/>
           </a:p>
@@ -14552,7 +14552,7 @@
                 <a:ea typeface="Courier New" pitchFamily="34" charset="-122"/>
                 <a:cs typeface="Courier New" pitchFamily="34" charset="-120"/>
               </a:rPr>
-              <a:t>  intent 3 · spec 1 · plan 15 · review 3;</a:t>
+              <a:t>  intent 3 · spec 1 · plan 16 · review 4;</a:t>
             </a:r>
             <a:endParaRPr lang="en-US" sz="1000" dirty="0"/>
           </a:p>
@@ -14886,7 +14886,7 @@
                 <a:ea typeface="Courier New" pitchFamily="34" charset="-122"/>
                 <a:cs typeface="Courier New" pitchFamily="34" charset="-120"/>
               </a:rPr>
-              <a:t>2026-10-13T07:51:23.383Z  gate.review.await</a:t>
+              <a:t>2026-10-13T09:59:43.531Z  gate.review.await</a:t>
             </a:r>
             <a:endParaRPr lang="en-US" sz="1000" dirty="0"/>
           </a:p>
@@ -14920,7 +14920,7 @@
                 <a:ea typeface="Courier New" pitchFamily="34" charset="-122"/>
                 <a:cs typeface="Courier New" pitchFamily="34" charset="-120"/>
               </a:rPr>
-              <a:t>  sha256:2f0312b7fcdcf82af2d8a8c11e7f0c0da5</a:t>
+              <a:t>  sha256:8cf5f98928e279a64a3de9693742f47c85</a:t>
             </a:r>
             <a:endParaRPr lang="en-US" sz="1000" dirty="0"/>
           </a:p>
@@ -14937,7 +14937,7 @@
                 <a:ea typeface="Courier New" pitchFamily="34" charset="-122"/>
                 <a:cs typeface="Courier New" pitchFamily="34" charset="-120"/>
               </a:rPr>
-              <a:t>  ef2bc5b8c4a439941d04ae52ba6a5f [sdlc</a:t>
+              <a:t>  fa9f5754dad3a412534e6b41ae457a [sdlc</a:t>
             </a:r>
             <a:endParaRPr lang="en-US" sz="1000" dirty="0"/>
           </a:p>
@@ -14954,7 +14954,7 @@
                 <a:ea typeface="Courier New" pitchFamily="34" charset="-122"/>
                 <a:cs typeface="Courier New" pitchFamily="34" charset="-120"/>
               </a:rPr>
-              <a:t>  0.17.0 · community]</a:t>
+              <a:t>  0.18.0 · community]</a:t>
             </a:r>
             <a:endParaRPr lang="en-US" sz="1000" dirty="0"/>
           </a:p>
@@ -14971,7 +14971,7 @@
                 <a:ea typeface="Courier New" pitchFamily="34" charset="-122"/>
                 <a:cs typeface="Courier New" pitchFamily="34" charset="-120"/>
               </a:rPr>
-              <a:t>2026-10-13T07:51:26.649Z  gate.review.appro</a:t>
+              <a:t>2026-10-13T09:59:47.632Z  gate.review.appro</a:t>
             </a:r>
             <a:endParaRPr lang="en-US" sz="1000" dirty="0"/>
           </a:p>
@@ -15022,7 +15022,7 @@
                 <a:ea typeface="Courier New" pitchFamily="34" charset="-122"/>
                 <a:cs typeface="Courier New" pitchFamily="34" charset="-120"/>
               </a:rPr>
-              <a:t>  [sdlc 0.17.0 · community]</a:t>
+              <a:t>  [sdlc 0.18.0 · community]</a:t>
             </a:r>
             <a:endParaRPr lang="en-US" sz="1000" dirty="0"/>
           </a:p>
@@ -15039,7 +15039,7 @@
                 <a:ea typeface="Courier New" pitchFamily="34" charset="-122"/>
                 <a:cs typeface="Courier New" pitchFamily="34" charset="-120"/>
               </a:rPr>
-              <a:t>2026-10-13T07:51:33.058Z  gate.release.appr</a:t>
+              <a:t>2026-10-13T09:59:55.096Z  gate.release.appr</a:t>
             </a:r>
             <a:endParaRPr lang="en-US" sz="1000" dirty="0"/>
           </a:p>
@@ -15090,7 +15090,7 @@
                 <a:ea typeface="Courier New" pitchFamily="34" charset="-122"/>
                 <a:cs typeface="Courier New" pitchFamily="34" charset="-120"/>
               </a:rPr>
-              <a:t>  release-manager [sdlc 0.17.0 · community]</a:t>
+              <a:t>  release-manager [sdlc 0.18.0 · community]</a:t>
             </a:r>
             <a:endParaRPr lang="en-US" sz="1000" dirty="0"/>
           </a:p>
@@ -15596,7 +15596,7 @@
         <p:spPr>
           <a:xfrm>
             <a:off x="7209536" y="6053328"/>
-            <a:ext cx="813816" cy="256032"/>
+            <a:ext cx="681736" cy="256032"/>
           </a:xfrm>
           <a:prstGeom prst="roundRect">
             <a:avLst>
@@ -15623,6 +15623,72 @@
         <p:spPr>
           <a:xfrm>
             <a:off x="7209536" y="6053328"/>
+            <a:ext cx="681736" cy="256032"/>
+          </a:xfrm>
+          <a:prstGeom prst="rect">
+            <a:avLst/>
+          </a:prstGeom>
+          <a:noFill/>
+          <a:ln/>
+        </p:spPr>
+        <p:txBody>
+          <a:bodyPr wrap="square" lIns="0" tIns="0" rIns="0" bIns="0" rtlCol="0" anchor="ctr"/>
+          <a:lstStyle/>
+          <a:p>
+            <a:pPr algn="ctr" indent="0" marL="0">
+              <a:buNone/>
+            </a:pPr>
+            <a:r>
+              <a:rPr lang="en-US" sz="1000" dirty="0">
+                <a:solidFill>
+                  <a:srgbClr val="5B6475"/>
+                </a:solidFill>
+                <a:latin typeface="Calibri" pitchFamily="34" charset="0"/>
+                <a:ea typeface="Calibri" pitchFamily="34" charset="-122"/>
+                <a:cs typeface="Calibri" pitchFamily="34" charset="-120"/>
+              </a:rPr>
+              <a:t>ci init</a:t>
+            </a:r>
+            <a:endParaRPr lang="en-US" sz="1000" dirty="0"/>
+          </a:p>
+        </p:txBody>
+      </p:sp>
+      <p:sp>
+        <p:nvSpPr>
+          <p:cNvPr id="40" name="Shape 38"/>
+          <p:cNvSpPr/>
+          <p:nvPr/>
+        </p:nvSpPr>
+        <p:spPr>
+          <a:xfrm>
+            <a:off x="7982712" y="6053328"/>
+            <a:ext cx="813816" cy="256032"/>
+          </a:xfrm>
+          <a:prstGeom prst="roundRect">
+            <a:avLst>
+              <a:gd name="adj" fmla="val 50000"/>
+            </a:avLst>
+          </a:prstGeom>
+          <a:solidFill>
+            <a:srgbClr val="F3F5F8"/>
+          </a:solidFill>
+          <a:ln w="12700">
+            <a:solidFill>
+              <a:srgbClr val="F3F5F8"/>
+            </a:solidFill>
+            <a:prstDash val="solid"/>
+          </a:ln>
+        </p:spPr>
+      </p:sp>
+      <p:sp>
+        <p:nvSpPr>
+          <p:cNvPr id="41" name="Text 39"/>
+          <p:cNvSpPr txBox="1"/>
+          <p:nvPr/>
+        </p:nvSpPr>
+        <p:spPr>
+          <a:xfrm>
+            <a:off x="7982712" y="6053328"/>
             <a:ext cx="813816" cy="256032"/>
           </a:xfrm>
           <a:prstGeom prst="rect">
@@ -16267,7 +16333,7 @@
                 <a:ea typeface="Courier New" pitchFamily="34" charset="-122"/>
                 <a:cs typeface="Courier New" pitchFamily="34" charset="-120"/>
               </a:rPr>
-              <a:t>✓ test (1.1s)</a:t>
+              <a:t>✓ test (1.4s)</a:t>
             </a:r>
             <a:endParaRPr lang="en-US" sz="1000" dirty="0"/>
           </a:p>
@@ -16284,7 +16350,7 @@
                 <a:ea typeface="Courier New" pitchFamily="34" charset="-122"/>
                 <a:cs typeface="Courier New" pitchFamily="34" charset="-120"/>
               </a:rPr>
-              <a:t>✓ ci-green (ci/pipeline_status, 0.6s)</a:t>
+              <a:t>✓ ci-green (ci/pipeline_status, 1.1s)</a:t>
             </a:r>
             <a:endParaRPr lang="en-US" sz="1000" dirty="0"/>
           </a:p>
@@ -16720,7 +16786,7 @@
                 <a:ea typeface="Courier New" pitchFamily="34" charset="-122"/>
                 <a:cs typeface="Courier New" pitchFamily="34" charset="-120"/>
               </a:rPr>
-              <a:t>      "id": "20261013T075223330Z-ci-green-f</a:t>
+              <a:t>      "id": "20261013T100107052Z-ci-green-f</a:t>
             </a:r>
             <a:endParaRPr lang="en-US" sz="1000" dirty="0"/>
           </a:p>
@@ -16737,7 +16803,7 @@
                 <a:ea typeface="Courier New" pitchFamily="34" charset="-122"/>
                 <a:cs typeface="Courier New" pitchFamily="34" charset="-120"/>
               </a:rPr>
-              <a:t>  fed13",</a:t>
+              <a:t>  7e08f",</a:t>
             </a:r>
             <a:endParaRPr lang="en-US" sz="1000" dirty="0"/>
           </a:p>
@@ -16873,7 +16939,7 @@
                 <a:ea typeface="Courier New" pitchFamily="34" charset="-122"/>
                 <a:cs typeface="Courier New" pitchFamily="34" charset="-120"/>
               </a:rPr>
-              <a:t>        "ref": "2a037004327e7616149ed05101a</a:t>
+              <a:t>        "ref": "29c7ed7fa8ad45fbc5631152cae</a:t>
             </a:r>
             <a:endParaRPr lang="en-US" sz="1000" dirty="0"/>
           </a:p>
@@ -16890,7 +16956,7 @@
                 <a:ea typeface="Courier New" pitchFamily="34" charset="-122"/>
                 <a:cs typeface="Courier New" pitchFamily="34" charset="-120"/>
               </a:rPr>
-              <a:t>  9f1aa1358dc93",</a:t>
+              <a:t>  3d2b45af2df33",</a:t>
             </a:r>
             <a:endParaRPr lang="en-US" sz="1000" dirty="0"/>
           </a:p>
@@ -27018,7 +27084,7 @@
                 <a:ea typeface="Courier New" pitchFamily="34" charset="-122"/>
                 <a:cs typeface="Courier New" pitchFamily="34" charset="-120"/>
               </a:rPr>
-              <a:t>  sdlc 0.17.0, license: community</a:t>
+              <a:t>  sdlc 0.18.0, license: community</a:t>
             </a:r>
             <a:endParaRPr lang="en-US" sz="1000" dirty="0"/>
           </a:p>

</xml_diff>

<commit_message>
feat: the judge gate; lenses, workflows and checks from extension packs (0.20.0)
- gates.<g>.judge names a judge (a command or an MCP tool, a rubric,
  max_loops). sdlc judge records a verdict bound to the digest of the
  gate's artifacts; until it passes, the gate is blocked and next asks
  the agent to run the judge or rework the artifacts. A passing verdict
  is evidence only, a person approves; after max_loops failures the loop
  stops and a person decides. A command judge runs as an agent.
- A pack may bring review lenses (required by review check), workflows
  (skills sdlc-<pack>-<id>, never replacing a built-in one) and verify
  checks (run as an agent). Nothing is in effect before a person runs
  sdlc team accept --pack, bound to the digest of the contents; packs
  with workflows or checks must be pinned; a person's sdlc command in a
  pack is refused.

SDLC-Agent: claude-code
</commit_message>
<xml_diff>
--- a/docs/demo/sdlc-calculator-demo.en.pptx
+++ b/docs/demo/sdlc-calculator-demo.en.pptx
@@ -5112,7 +5112,7 @@
                 <a:ea typeface="Courier New" pitchFamily="34" charset="-122"/>
                 <a:cs typeface="Courier New" pitchFamily="34" charset="-120"/>
               </a:rPr>
-              <a:t>✓ test (0.9s)</a:t>
+              <a:t>✓ test (2.2s)</a:t>
             </a:r>
             <a:endParaRPr lang="en-US" sz="1000" dirty="0"/>
           </a:p>
@@ -6660,7 +6660,7 @@
                 <a:ea typeface="Courier New" pitchFamily="34" charset="-122"/>
                 <a:cs typeface="Courier New" pitchFamily="34" charset="-120"/>
               </a:rPr>
-              <a:t>  code-owner (712099877b9e)</a:t>
+              <a:t>  code-owner (3d6ac2e55b7f)</a:t>
             </a:r>
             <a:endParaRPr lang="en-US" sz="1000" dirty="0"/>
           </a:p>
@@ -6745,7 +6745,7 @@
                 <a:ea typeface="Courier New" pitchFamily="34" charset="-122"/>
                 <a:cs typeface="Courier New" pitchFamily="34" charset="-120"/>
               </a:rPr>
-              <a:t>  "SDLC-Approval: basic-arithmetic:review:7</a:t>
+              <a:t>  "SDLC-Approval: basic-arithmetic:review:3</a:t>
             </a:r>
             <a:endParaRPr lang="en-US" sz="1000" dirty="0"/>
           </a:p>
@@ -6762,7 +6762,7 @@
                 <a:ea typeface="Courier New" pitchFamily="34" charset="-122"/>
                 <a:cs typeface="Courier New" pitchFamily="34" charset="-120"/>
               </a:rPr>
-              <a:t>  12099877b9e"</a:t>
+              <a:t>  d6ac2e55b7f"</a:t>
             </a:r>
             <a:endParaRPr lang="en-US" sz="1000" dirty="0"/>
           </a:p>
@@ -7443,7 +7443,7 @@
                 <a:ea typeface="Courier New" pitchFamily="34" charset="-122"/>
                 <a:cs typeface="Courier New" pitchFamily="34" charset="-120"/>
               </a:rPr>
-              <a:t>  release-manager (712099877b9e)</a:t>
+              <a:t>  release-manager (3d6ac2e55b7f)</a:t>
             </a:r>
             <a:endParaRPr lang="en-US" sz="1000" dirty="0"/>
           </a:p>
@@ -7511,7 +7511,7 @@
                 <a:ea typeface="Courier New" pitchFamily="34" charset="-122"/>
                 <a:cs typeface="Courier New" pitchFamily="34" charset="-120"/>
               </a:rPr>
-              <a:t>  gate" -m "SDLC-Approval: basic-arithmetic:release:712099877b9e"</a:t>
+              <a:t>  gate" -m "SDLC-Approval: basic-arithmetic:release:3d6ac2e55b7f"</a:t>
             </a:r>
             <a:endParaRPr lang="en-US" sz="1000" dirty="0"/>
           </a:p>
@@ -7794,7 +7794,7 @@
                 <a:ea typeface="Courier New" pitchFamily="34" charset="-122"/>
                 <a:cs typeface="Courier New" pitchFamily="34" charset="-120"/>
               </a:rPr>
-              <a:t>✓ basic-arithmetic/intent alice valid 2bb8417b trailer: missing</a:t>
+              <a:t>✓ basic-arithmetic/intent alice valid 41c6aa1c trailer: missing</a:t>
             </a:r>
             <a:endParaRPr lang="en-US" sz="1000" dirty="0"/>
           </a:p>
@@ -7811,7 +7811,7 @@
                 <a:ea typeface="Courier New" pitchFamily="34" charset="-122"/>
                 <a:cs typeface="Courier New" pitchFamily="34" charset="-120"/>
               </a:rPr>
-              <a:t>✓ basic-arithmetic/spec alice valid bb21d651 trailer: missing</a:t>
+              <a:t>✓ basic-arithmetic/spec alice valid 168e88e7 trailer: missing</a:t>
             </a:r>
             <a:endParaRPr lang="en-US" sz="1000" dirty="0"/>
           </a:p>
@@ -7828,7 +7828,7 @@
                 <a:ea typeface="Courier New" pitchFamily="34" charset="-122"/>
                 <a:cs typeface="Courier New" pitchFamily="34" charset="-120"/>
               </a:rPr>
-              <a:t>✗ basic-arithmetic/plan bob wrong-signer bb21d651 trailer: missing</a:t>
+              <a:t>✗ basic-arithmetic/plan bob wrong-signer 168e88e7 trailer: missing</a:t>
             </a:r>
             <a:endParaRPr lang="en-US" sz="1000" dirty="0"/>
           </a:p>
@@ -7845,7 +7845,7 @@
                 <a:ea typeface="Courier New" pitchFamily="34" charset="-122"/>
                 <a:cs typeface="Courier New" pitchFamily="34" charset="-120"/>
               </a:rPr>
-              <a:t>✓ basic-arithmetic/review carol valid b1bf9ce3 trailer: missing</a:t>
+              <a:t>✓ basic-arithmetic/review carol valid c6ddcb02 trailer: missing</a:t>
             </a:r>
             <a:endParaRPr lang="en-US" sz="1000" dirty="0"/>
           </a:p>
@@ -7862,7 +7862,7 @@
                 <a:ea typeface="Courier New" pitchFamily="34" charset="-122"/>
                 <a:cs typeface="Courier New" pitchFamily="34" charset="-120"/>
               </a:rPr>
-              <a:t>✓ basic-arithmetic/release alice valid eb6c00f8 trailer: missing</a:t>
+              <a:t>✓ basic-arithmetic/release alice valid 909490ea trailer: missing</a:t>
             </a:r>
             <a:endParaRPr lang="en-US" sz="1000" dirty="0"/>
           </a:p>
@@ -7879,7 +7879,7 @@
                 <a:ea typeface="Courier New" pitchFamily="34" charset="-122"/>
                 <a:cs typeface="Courier New" pitchFamily="34" charset="-120"/>
               </a:rPr>
-              <a:t>✓ openspec/roles.yaml alice@calc.example bootstrap 4ba7fa97</a:t>
+              <a:t>✓ openspec/roles.yaml alice@calc.example bootstrap 68932692</a:t>
             </a:r>
             <a:endParaRPr lang="en-US" sz="1000" dirty="0"/>
           </a:p>
@@ -14365,7 +14365,7 @@
                 <a:ea typeface="Courier New" pitchFamily="34" charset="-122"/>
                 <a:cs typeface="Courier New" pitchFamily="34" charset="-120"/>
               </a:rPr>
-              <a:t>  archived) · sdlc 0.19.0, license:</a:t>
+              <a:t>  archived) · sdlc 0.20.0, license:</a:t>
             </a:r>
             <a:endParaRPr lang="en-US" sz="1000" dirty="0"/>
           </a:p>
@@ -14552,7 +14552,7 @@
                 <a:ea typeface="Courier New" pitchFamily="34" charset="-122"/>
                 <a:cs typeface="Courier New" pitchFamily="34" charset="-120"/>
               </a:rPr>
-              <a:t>  intent 3 · spec 1 · plan 14 · review 3;</a:t>
+              <a:t>  intent 3 · spec 3 · plan 16 · review 3;</a:t>
             </a:r>
             <a:endParaRPr lang="en-US" sz="1000" dirty="0"/>
           </a:p>
@@ -14852,7 +14852,7 @@
                 <a:ea typeface="Courier New" pitchFamily="34" charset="-122"/>
                 <a:cs typeface="Courier New" pitchFamily="34" charset="-120"/>
               </a:rPr>
-              <a:t>(last 15 of 46 entries; --limit to see</a:t>
+              <a:t>(last 15 of 47 entries; --limit to see</a:t>
             </a:r>
             <a:endParaRPr lang="en-US" sz="1000" dirty="0"/>
           </a:p>
@@ -14886,7 +14886,7 @@
                 <a:ea typeface="Courier New" pitchFamily="34" charset="-122"/>
                 <a:cs typeface="Courier New" pitchFamily="34" charset="-120"/>
               </a:rPr>
-              <a:t>2026-10-13T12:39:06.473Z  gate.review.await</a:t>
+              <a:t>2026-10-13T16:48:05.251Z  gate.review.await</a:t>
             </a:r>
             <a:endParaRPr lang="en-US" sz="1000" dirty="0"/>
           </a:p>
@@ -14920,7 +14920,7 @@
                 <a:ea typeface="Courier New" pitchFamily="34" charset="-122"/>
                 <a:cs typeface="Courier New" pitchFamily="34" charset="-120"/>
               </a:rPr>
-              <a:t>  sha256:712099877b9e02aad7ba9df255d39cfea8</a:t>
+              <a:t>  sha256:3d6ac2e55b7fa3a198a9816633bd881d47</a:t>
             </a:r>
             <a:endParaRPr lang="en-US" sz="1000" dirty="0"/>
           </a:p>
@@ -14937,7 +14937,7 @@
                 <a:ea typeface="Courier New" pitchFamily="34" charset="-122"/>
                 <a:cs typeface="Courier New" pitchFamily="34" charset="-120"/>
               </a:rPr>
-              <a:t>  913e1c7bd04eae8189166e4031f9d1 [sdlc</a:t>
+              <a:t>  7ca917251a375d5c8c848e9ad14518 [sdlc</a:t>
             </a:r>
             <a:endParaRPr lang="en-US" sz="1000" dirty="0"/>
           </a:p>
@@ -14954,7 +14954,7 @@
                 <a:ea typeface="Courier New" pitchFamily="34" charset="-122"/>
                 <a:cs typeface="Courier New" pitchFamily="34" charset="-120"/>
               </a:rPr>
-              <a:t>  0.19.0 · community]</a:t>
+              <a:t>  0.20.0 · community]</a:t>
             </a:r>
             <a:endParaRPr lang="en-US" sz="1000" dirty="0"/>
           </a:p>
@@ -14971,7 +14971,7 @@
                 <a:ea typeface="Courier New" pitchFamily="34" charset="-122"/>
                 <a:cs typeface="Courier New" pitchFamily="34" charset="-120"/>
               </a:rPr>
-              <a:t>2026-10-13T12:39:09.723Z  gate.review.appro</a:t>
+              <a:t>2026-10-13T16:48:08.386Z  gate.review.appro</a:t>
             </a:r>
             <a:endParaRPr lang="en-US" sz="1000" dirty="0"/>
           </a:p>
@@ -15022,7 +15022,7 @@
                 <a:ea typeface="Courier New" pitchFamily="34" charset="-122"/>
                 <a:cs typeface="Courier New" pitchFamily="34" charset="-120"/>
               </a:rPr>
-              <a:t>  [sdlc 0.19.0 · community]</a:t>
+              <a:t>  [sdlc 0.20.0 · community]</a:t>
             </a:r>
             <a:endParaRPr lang="en-US" sz="1000" dirty="0"/>
           </a:p>
@@ -15039,7 +15039,7 @@
                 <a:ea typeface="Courier New" pitchFamily="34" charset="-122"/>
                 <a:cs typeface="Courier New" pitchFamily="34" charset="-120"/>
               </a:rPr>
-              <a:t>2026-10-13T12:39:16.238Z  gate.release.appr</a:t>
+              <a:t>2026-10-13T16:48:15.066Z  gate.release.appr</a:t>
             </a:r>
             <a:endParaRPr lang="en-US" sz="1000" dirty="0"/>
           </a:p>
@@ -15090,7 +15090,7 @@
                 <a:ea typeface="Courier New" pitchFamily="34" charset="-122"/>
                 <a:cs typeface="Courier New" pitchFamily="34" charset="-120"/>
               </a:rPr>
-              <a:t>  release-manager [sdlc 0.19.0 · community]</a:t>
+              <a:t>  release-manager [sdlc 0.20.0 · community]</a:t>
             </a:r>
             <a:endParaRPr lang="en-US" sz="1000" dirty="0"/>
           </a:p>
@@ -16871,7 +16871,7 @@
                 <a:ea typeface="Courier New" pitchFamily="34" charset="-122"/>
                 <a:cs typeface="Courier New" pitchFamily="34" charset="-120"/>
               </a:rPr>
-              <a:t>      "id": "20261013T124009491Z-ci-green-9</a:t>
+              <a:t>      "id": "20261013T164910740Z-ci-green-e</a:t>
             </a:r>
             <a:endParaRPr lang="en-US" sz="1000" dirty="0"/>
           </a:p>
@@ -16888,7 +16888,7 @@
                 <a:ea typeface="Courier New" pitchFamily="34" charset="-122"/>
                 <a:cs typeface="Courier New" pitchFamily="34" charset="-120"/>
               </a:rPr>
-              <a:t>  29a3f",</a:t>
+              <a:t>  1d607",</a:t>
             </a:r>
             <a:endParaRPr lang="en-US" sz="1000" dirty="0"/>
           </a:p>
@@ -17024,7 +17024,7 @@
                 <a:ea typeface="Courier New" pitchFamily="34" charset="-122"/>
                 <a:cs typeface="Courier New" pitchFamily="34" charset="-120"/>
               </a:rPr>
-              <a:t>        "ref": "2e1baac9ee53f63c0b027747d99</a:t>
+              <a:t>        "ref": "bb445e41c829a11fdf3f991ce99</a:t>
             </a:r>
             <a:endParaRPr lang="en-US" sz="1000" dirty="0"/>
           </a:p>
@@ -17041,7 +17041,7 @@
                 <a:ea typeface="Courier New" pitchFamily="34" charset="-122"/>
                 <a:cs typeface="Courier New" pitchFamily="34" charset="-120"/>
               </a:rPr>
-              <a:t>  6d5979c6ebe47",</a:t>
+              <a:t>  77e06b7879c35",</a:t>
             </a:r>
             <a:endParaRPr lang="en-US" sz="1000" dirty="0"/>
           </a:p>
@@ -19615,7 +19615,7 @@
                 <a:ea typeface="Cambria" pitchFamily="34" charset="-122"/>
                 <a:cs typeface="Cambria" pitchFamily="34" charset="-120"/>
               </a:rPr>
-              <a:t>111</a:t>
+              <a:t>112</a:t>
             </a:r>
             <a:endParaRPr lang="en-US" sz="6000" dirty="0"/>
           </a:p>
@@ -19720,7 +19720,7 @@
                 <a:ea typeface="Cambria" pitchFamily="34" charset="-122"/>
                 <a:cs typeface="Cambria" pitchFamily="34" charset="-120"/>
               </a:rPr>
-              <a:t>78</a:t>
+              <a:t>79</a:t>
             </a:r>
             <a:endParaRPr lang="en-US" sz="6000" dirty="0"/>
           </a:p>
@@ -19759,7 +19759,7 @@
                 <a:ea typeface="Calibri" pitchFamily="34" charset="-122"/>
                 <a:cs typeface="Calibri" pitchFamily="34" charset="-120"/>
               </a:rPr>
-              <a:t>of 78 commands</a:t>
+              <a:t>of 79 commands</a:t>
             </a:r>
             <a:endParaRPr lang="en-US" sz="1600" dirty="0"/>
           </a:p>
@@ -23614,7 +23614,7 @@
         <p:spPr>
           <a:xfrm>
             <a:off x="10547096" y="5138928"/>
-            <a:ext cx="747776" cy="256032"/>
+            <a:ext cx="549656" cy="256032"/>
           </a:xfrm>
           <a:prstGeom prst="roundRect">
             <a:avLst>
@@ -23641,7 +23641,7 @@
         <p:spPr>
           <a:xfrm>
             <a:off x="10547096" y="5138928"/>
-            <a:ext cx="747776" cy="256032"/>
+            <a:ext cx="549656" cy="256032"/>
           </a:xfrm>
           <a:prstGeom prst="rect">
             <a:avLst/>
@@ -23665,7 +23665,7 @@
                 <a:ea typeface="Calibri" pitchFamily="34" charset="-122"/>
                 <a:cs typeface="Calibri" pitchFamily="34" charset="-120"/>
               </a:rPr>
-              <a:t>takeover</a:t>
+              <a:t>judge</a:t>
             </a:r>
             <a:endParaRPr lang="en-US" sz="1000" dirty="0"/>
           </a:p>
@@ -23680,7 +23680,7 @@
         <p:spPr>
           <a:xfrm>
             <a:off x="457200" y="5486400"/>
-            <a:ext cx="1210056" cy="256032"/>
+            <a:ext cx="747776" cy="256032"/>
           </a:xfrm>
           <a:prstGeom prst="roundRect">
             <a:avLst>
@@ -23707,7 +23707,7 @@
         <p:spPr>
           <a:xfrm>
             <a:off x="457200" y="5486400"/>
-            <a:ext cx="1210056" cy="256032"/>
+            <a:ext cx="747776" cy="256032"/>
           </a:xfrm>
           <a:prstGeom prst="rect">
             <a:avLst/>
@@ -23731,7 +23731,7 @@
                 <a:ea typeface="Calibri" pitchFamily="34" charset="-122"/>
                 <a:cs typeface="Calibri" pitchFamily="34" charset="-120"/>
               </a:rPr>
-              <a:t>release-control</a:t>
+              <a:t>takeover</a:t>
             </a:r>
             <a:endParaRPr lang="en-US" sz="1000" dirty="0"/>
           </a:p>
@@ -23745,8 +23745,8 @@
         </p:nvSpPr>
         <p:spPr>
           <a:xfrm>
-            <a:off x="1758696" y="5486400"/>
-            <a:ext cx="615696" cy="256032"/>
+            <a:off x="1296416" y="5486400"/>
+            <a:ext cx="1210056" cy="256032"/>
           </a:xfrm>
           <a:prstGeom prst="roundRect">
             <a:avLst>
@@ -23772,8 +23772,8 @@
         </p:nvSpPr>
         <p:spPr>
           <a:xfrm>
-            <a:off x="1758696" y="5486400"/>
-            <a:ext cx="615696" cy="256032"/>
+            <a:off x="1296416" y="5486400"/>
+            <a:ext cx="1210056" cy="256032"/>
           </a:xfrm>
           <a:prstGeom prst="rect">
             <a:avLst/>
@@ -23797,7 +23797,7 @@
                 <a:ea typeface="Calibri" pitchFamily="34" charset="-122"/>
                 <a:cs typeface="Calibri" pitchFamily="34" charset="-120"/>
               </a:rPr>
-              <a:t>rework</a:t>
+              <a:t>release-control</a:t>
             </a:r>
             <a:endParaRPr lang="en-US" sz="1000" dirty="0"/>
           </a:p>
@@ -23811,8 +23811,8 @@
         </p:nvSpPr>
         <p:spPr>
           <a:xfrm>
-            <a:off x="2465832" y="5486400"/>
-            <a:ext cx="1276096" cy="256032"/>
+            <a:off x="2597912" y="5486400"/>
+            <a:ext cx="615696" cy="256032"/>
           </a:xfrm>
           <a:prstGeom prst="roundRect">
             <a:avLst>
@@ -23838,8 +23838,8 @@
         </p:nvSpPr>
         <p:spPr>
           <a:xfrm>
-            <a:off x="2465832" y="5486400"/>
-            <a:ext cx="1276096" cy="256032"/>
+            <a:off x="2597912" y="5486400"/>
+            <a:ext cx="615696" cy="256032"/>
           </a:xfrm>
           <a:prstGeom prst="rect">
             <a:avLst/>
@@ -23863,7 +23863,7 @@
                 <a:ea typeface="Calibri" pitchFamily="34" charset="-122"/>
                 <a:cs typeface="Calibri" pitchFamily="34" charset="-120"/>
               </a:rPr>
-              <a:t>approvals verify</a:t>
+              <a:t>rework</a:t>
             </a:r>
             <a:endParaRPr lang="en-US" sz="1000" dirty="0"/>
           </a:p>
@@ -23877,8 +23877,8 @@
         </p:nvSpPr>
         <p:spPr>
           <a:xfrm>
-            <a:off x="3833368" y="5486400"/>
-            <a:ext cx="549656" cy="256032"/>
+            <a:off x="3305048" y="5486400"/>
+            <a:ext cx="1276096" cy="256032"/>
           </a:xfrm>
           <a:prstGeom prst="roundRect">
             <a:avLst>
@@ -23904,8 +23904,8 @@
         </p:nvSpPr>
         <p:spPr>
           <a:xfrm>
-            <a:off x="3833368" y="5486400"/>
-            <a:ext cx="549656" cy="256032"/>
+            <a:off x="3305048" y="5486400"/>
+            <a:ext cx="1276096" cy="256032"/>
           </a:xfrm>
           <a:prstGeom prst="rect">
             <a:avLst/>
@@ -23929,7 +23929,7 @@
                 <a:ea typeface="Calibri" pitchFamily="34" charset="-122"/>
                 <a:cs typeface="Calibri" pitchFamily="34" charset="-120"/>
               </a:rPr>
-              <a:t>tests</a:t>
+              <a:t>approvals verify</a:t>
             </a:r>
             <a:endParaRPr lang="en-US" sz="1000" dirty="0"/>
           </a:p>
@@ -23943,8 +23943,8 @@
         </p:nvSpPr>
         <p:spPr>
           <a:xfrm>
-            <a:off x="4474464" y="5486400"/>
-            <a:ext cx="945896" cy="256032"/>
+            <a:off x="4672584" y="5486400"/>
+            <a:ext cx="549656" cy="256032"/>
           </a:xfrm>
           <a:prstGeom prst="roundRect">
             <a:avLst>
@@ -23970,8 +23970,8 @@
         </p:nvSpPr>
         <p:spPr>
           <a:xfrm>
-            <a:off x="4474464" y="5486400"/>
-            <a:ext cx="945896" cy="256032"/>
+            <a:off x="4672584" y="5486400"/>
+            <a:ext cx="549656" cy="256032"/>
           </a:xfrm>
           <a:prstGeom prst="rect">
             <a:avLst/>
@@ -23995,7 +23995,7 @@
                 <a:ea typeface="Calibri" pitchFamily="34" charset="-122"/>
                 <a:cs typeface="Calibri" pitchFamily="34" charset="-120"/>
               </a:rPr>
-              <a:t>task export</a:t>
+              <a:t>tests</a:t>
             </a:r>
             <a:endParaRPr lang="en-US" sz="1000" dirty="0"/>
           </a:p>
@@ -24009,8 +24009,8 @@
         </p:nvSpPr>
         <p:spPr>
           <a:xfrm>
-            <a:off x="5511800" y="5486400"/>
-            <a:ext cx="1342136" cy="256032"/>
+            <a:off x="5313680" y="5486400"/>
+            <a:ext cx="945896" cy="256032"/>
           </a:xfrm>
           <a:prstGeom prst="roundRect">
             <a:avLst>
@@ -24036,8 +24036,8 @@
         </p:nvSpPr>
         <p:spPr>
           <a:xfrm>
-            <a:off x="5511800" y="5486400"/>
-            <a:ext cx="1342136" cy="256032"/>
+            <a:off x="5313680" y="5486400"/>
+            <a:ext cx="945896" cy="256032"/>
           </a:xfrm>
           <a:prstGeom prst="rect">
             <a:avLst/>
@@ -24061,7 +24061,7 @@
                 <a:ea typeface="Calibri" pitchFamily="34" charset="-122"/>
                 <a:cs typeface="Calibri" pitchFamily="34" charset="-120"/>
               </a:rPr>
-              <a:t>task check-result</a:t>
+              <a:t>task export</a:t>
             </a:r>
             <a:endParaRPr lang="en-US" sz="1000" dirty="0"/>
           </a:p>
@@ -24075,8 +24075,8 @@
         </p:nvSpPr>
         <p:spPr>
           <a:xfrm>
-            <a:off x="6945376" y="5486400"/>
-            <a:ext cx="615696" cy="256032"/>
+            <a:off x="6351016" y="5486400"/>
+            <a:ext cx="1342136" cy="256032"/>
           </a:xfrm>
           <a:prstGeom prst="roundRect">
             <a:avLst>
@@ -24102,8 +24102,8 @@
         </p:nvSpPr>
         <p:spPr>
           <a:xfrm>
-            <a:off x="6945376" y="5486400"/>
-            <a:ext cx="615696" cy="256032"/>
+            <a:off x="6351016" y="5486400"/>
+            <a:ext cx="1342136" cy="256032"/>
           </a:xfrm>
           <a:prstGeom prst="rect">
             <a:avLst/>
@@ -24127,7 +24127,7 @@
                 <a:ea typeface="Calibri" pitchFamily="34" charset="-122"/>
                 <a:cs typeface="Calibri" pitchFamily="34" charset="-120"/>
               </a:rPr>
-              <a:t>verify</a:t>
+              <a:t>task check-result</a:t>
             </a:r>
             <a:endParaRPr lang="en-US" sz="1000" dirty="0"/>
           </a:p>
@@ -24141,7 +24141,7 @@
         </p:nvSpPr>
         <p:spPr>
           <a:xfrm>
-            <a:off x="7652512" y="5486400"/>
+            <a:off x="7784592" y="5486400"/>
             <a:ext cx="615696" cy="256032"/>
           </a:xfrm>
           <a:prstGeom prst="roundRect">
@@ -24168,7 +24168,7 @@
         </p:nvSpPr>
         <p:spPr>
           <a:xfrm>
-            <a:off x="7652512" y="5486400"/>
+            <a:off x="7784592" y="5486400"/>
             <a:ext cx="615696" cy="256032"/>
           </a:xfrm>
           <a:prstGeom prst="rect">
@@ -24193,7 +24193,7 @@
                 <a:ea typeface="Calibri" pitchFamily="34" charset="-122"/>
                 <a:cs typeface="Calibri" pitchFamily="34" charset="-120"/>
               </a:rPr>
-              <a:t>review</a:t>
+              <a:t>verify</a:t>
             </a:r>
             <a:endParaRPr lang="en-US" sz="1000" dirty="0"/>
           </a:p>
@@ -24207,8 +24207,8 @@
         </p:nvSpPr>
         <p:spPr>
           <a:xfrm>
-            <a:off x="8359648" y="5486400"/>
-            <a:ext cx="747776" cy="256032"/>
+            <a:off x="8491728" y="5486400"/>
+            <a:ext cx="615696" cy="256032"/>
           </a:xfrm>
           <a:prstGeom prst="roundRect">
             <a:avLst>
@@ -24234,8 +24234,8 @@
         </p:nvSpPr>
         <p:spPr>
           <a:xfrm>
-            <a:off x="8359648" y="5486400"/>
-            <a:ext cx="747776" cy="256032"/>
+            <a:off x="8491728" y="5486400"/>
+            <a:ext cx="615696" cy="256032"/>
           </a:xfrm>
           <a:prstGeom prst="rect">
             <a:avLst/>
@@ -24259,7 +24259,7 @@
                 <a:ea typeface="Calibri" pitchFamily="34" charset="-122"/>
                 <a:cs typeface="Calibri" pitchFamily="34" charset="-120"/>
               </a:rPr>
-              <a:t>validate</a:t>
+              <a:t>review</a:t>
             </a:r>
             <a:endParaRPr lang="en-US" sz="1000" dirty="0"/>
           </a:p>
@@ -24274,7 +24274,7 @@
         <p:spPr>
           <a:xfrm>
             <a:off x="9198864" y="5486400"/>
-            <a:ext cx="681736" cy="256032"/>
+            <a:ext cx="747776" cy="256032"/>
           </a:xfrm>
           <a:prstGeom prst="roundRect">
             <a:avLst>
@@ -24301,7 +24301,7 @@
         <p:spPr>
           <a:xfrm>
             <a:off x="9198864" y="5486400"/>
-            <a:ext cx="681736" cy="256032"/>
+            <a:ext cx="747776" cy="256032"/>
           </a:xfrm>
           <a:prstGeom prst="rect">
             <a:avLst/>
@@ -24325,7 +24325,7 @@
                 <a:ea typeface="Calibri" pitchFamily="34" charset="-122"/>
                 <a:cs typeface="Calibri" pitchFamily="34" charset="-120"/>
               </a:rPr>
-              <a:t>archive</a:t>
+              <a:t>validate</a:t>
             </a:r>
             <a:endParaRPr lang="en-US" sz="1000" dirty="0"/>
           </a:p>
@@ -24339,8 +24339,8 @@
         </p:nvSpPr>
         <p:spPr>
           <a:xfrm>
-            <a:off x="9972040" y="5486400"/>
-            <a:ext cx="549656" cy="256032"/>
+            <a:off x="10038080" y="5486400"/>
+            <a:ext cx="681736" cy="256032"/>
           </a:xfrm>
           <a:prstGeom prst="roundRect">
             <a:avLst>
@@ -24366,8 +24366,8 @@
         </p:nvSpPr>
         <p:spPr>
           <a:xfrm>
-            <a:off x="9972040" y="5486400"/>
-            <a:ext cx="549656" cy="256032"/>
+            <a:off x="10038080" y="5486400"/>
+            <a:ext cx="681736" cy="256032"/>
           </a:xfrm>
           <a:prstGeom prst="rect">
             <a:avLst/>
@@ -24391,7 +24391,7 @@
                 <a:ea typeface="Calibri" pitchFamily="34" charset="-122"/>
                 <a:cs typeface="Calibri" pitchFamily="34" charset="-120"/>
               </a:rPr>
-              <a:t>audit</a:t>
+              <a:t>archive</a:t>
             </a:r>
             <a:endParaRPr lang="en-US" sz="1000" dirty="0"/>
           </a:p>
@@ -24405,8 +24405,8 @@
         </p:nvSpPr>
         <p:spPr>
           <a:xfrm>
-            <a:off x="10613136" y="5486400"/>
-            <a:ext cx="813816" cy="256032"/>
+            <a:off x="10811256" y="5486400"/>
+            <a:ext cx="549656" cy="256032"/>
           </a:xfrm>
           <a:prstGeom prst="roundRect">
             <a:avLst>
@@ -24432,8 +24432,8 @@
         </p:nvSpPr>
         <p:spPr>
           <a:xfrm>
-            <a:off x="10613136" y="5486400"/>
-            <a:ext cx="813816" cy="256032"/>
+            <a:off x="10811256" y="5486400"/>
+            <a:ext cx="549656" cy="256032"/>
           </a:xfrm>
           <a:prstGeom prst="rect">
             <a:avLst/>
@@ -24457,7 +24457,7 @@
                 <a:ea typeface="Calibri" pitchFamily="34" charset="-122"/>
                 <a:cs typeface="Calibri" pitchFamily="34" charset="-120"/>
               </a:rPr>
-              <a:t>changelog</a:t>
+              <a:t>audit</a:t>
             </a:r>
             <a:endParaRPr lang="en-US" sz="1000" dirty="0"/>
           </a:p>
@@ -24472,7 +24472,7 @@
         <p:spPr>
           <a:xfrm>
             <a:off x="457200" y="5833872"/>
-            <a:ext cx="615696" cy="256032"/>
+            <a:ext cx="813816" cy="256032"/>
           </a:xfrm>
           <a:prstGeom prst="roundRect">
             <a:avLst>
@@ -24499,7 +24499,7 @@
         <p:spPr>
           <a:xfrm>
             <a:off x="457200" y="5833872"/>
-            <a:ext cx="615696" cy="256032"/>
+            <a:ext cx="813816" cy="256032"/>
           </a:xfrm>
           <a:prstGeom prst="rect">
             <a:avLst/>
@@ -24523,7 +24523,7 @@
                 <a:ea typeface="Calibri" pitchFamily="34" charset="-122"/>
                 <a:cs typeface="Calibri" pitchFamily="34" charset="-120"/>
               </a:rPr>
-              <a:t>report</a:t>
+              <a:t>changelog</a:t>
             </a:r>
             <a:endParaRPr lang="en-US" sz="1000" dirty="0"/>
           </a:p>
@@ -24537,8 +24537,8 @@
         </p:nvSpPr>
         <p:spPr>
           <a:xfrm>
-            <a:off x="1164336" y="5833872"/>
-            <a:ext cx="813816" cy="256032"/>
+            <a:off x="1362456" y="5833872"/>
+            <a:ext cx="615696" cy="256032"/>
           </a:xfrm>
           <a:prstGeom prst="roundRect">
             <a:avLst>
@@ -24564,8 +24564,8 @@
         </p:nvSpPr>
         <p:spPr>
           <a:xfrm>
-            <a:off x="1164336" y="5833872"/>
-            <a:ext cx="813816" cy="256032"/>
+            <a:off x="1362456" y="5833872"/>
+            <a:ext cx="615696" cy="256032"/>
           </a:xfrm>
           <a:prstGeom prst="rect">
             <a:avLst/>
@@ -24589,7 +24589,7 @@
                 <a:ea typeface="Calibri" pitchFamily="34" charset="-122"/>
                 <a:cs typeface="Calibri" pitchFamily="34" charset="-120"/>
               </a:rPr>
-              <a:t>dashboard</a:t>
+              <a:t>report</a:t>
             </a:r>
             <a:endParaRPr lang="en-US" sz="1000" dirty="0"/>
           </a:p>
@@ -24604,7 +24604,7 @@
         <p:spPr>
           <a:xfrm>
             <a:off x="2069592" y="5833872"/>
-            <a:ext cx="417576" cy="256032"/>
+            <a:ext cx="813816" cy="256032"/>
           </a:xfrm>
           <a:prstGeom prst="roundRect">
             <a:avLst>
@@ -24631,7 +24631,7 @@
         <p:spPr>
           <a:xfrm>
             <a:off x="2069592" y="5833872"/>
-            <a:ext cx="417576" cy="256032"/>
+            <a:ext cx="813816" cy="256032"/>
           </a:xfrm>
           <a:prstGeom prst="rect">
             <a:avLst/>
@@ -24655,7 +24655,7 @@
                 <a:ea typeface="Calibri" pitchFamily="34" charset="-122"/>
                 <a:cs typeface="Calibri" pitchFamily="34" charset="-120"/>
               </a:rPr>
-              <a:t>log</a:t>
+              <a:t>dashboard</a:t>
             </a:r>
             <a:endParaRPr lang="en-US" sz="1000" dirty="0"/>
           </a:p>
@@ -24669,8 +24669,8 @@
         </p:nvSpPr>
         <p:spPr>
           <a:xfrm>
-            <a:off x="2578608" y="5833872"/>
-            <a:ext cx="681736" cy="256032"/>
+            <a:off x="2974848" y="5833872"/>
+            <a:ext cx="417576" cy="256032"/>
           </a:xfrm>
           <a:prstGeom prst="roundRect">
             <a:avLst>
@@ -24696,8 +24696,8 @@
         </p:nvSpPr>
         <p:spPr>
           <a:xfrm>
-            <a:off x="2578608" y="5833872"/>
-            <a:ext cx="681736" cy="256032"/>
+            <a:off x="2974848" y="5833872"/>
+            <a:ext cx="417576" cy="256032"/>
           </a:xfrm>
           <a:prstGeom prst="rect">
             <a:avLst/>
@@ -24721,7 +24721,7 @@
                 <a:ea typeface="Calibri" pitchFamily="34" charset="-122"/>
                 <a:cs typeface="Calibri" pitchFamily="34" charset="-120"/>
               </a:rPr>
-              <a:t>license</a:t>
+              <a:t>log</a:t>
             </a:r>
             <a:endParaRPr lang="en-US" sz="1000" dirty="0"/>
           </a:p>
@@ -24735,8 +24735,8 @@
         </p:nvSpPr>
         <p:spPr>
           <a:xfrm>
-            <a:off x="3351784" y="5833872"/>
-            <a:ext cx="615696" cy="256032"/>
+            <a:off x="3483864" y="5833872"/>
+            <a:ext cx="681736" cy="256032"/>
           </a:xfrm>
           <a:prstGeom prst="roundRect">
             <a:avLst>
@@ -24762,8 +24762,8 @@
         </p:nvSpPr>
         <p:spPr>
           <a:xfrm>
-            <a:off x="3351784" y="5833872"/>
-            <a:ext cx="615696" cy="256032"/>
+            <a:off x="3483864" y="5833872"/>
+            <a:ext cx="681736" cy="256032"/>
           </a:xfrm>
           <a:prstGeom prst="rect">
             <a:avLst/>
@@ -24787,7 +24787,7 @@
                 <a:ea typeface="Calibri" pitchFamily="34" charset="-122"/>
                 <a:cs typeface="Calibri" pitchFamily="34" charset="-120"/>
               </a:rPr>
-              <a:t>doctor</a:t>
+              <a:t>license</a:t>
             </a:r>
             <a:endParaRPr lang="en-US" sz="1000" dirty="0"/>
           </a:p>
@@ -24801,7 +24801,7 @@
         </p:nvSpPr>
         <p:spPr>
           <a:xfrm>
-            <a:off x="4058920" y="5833872"/>
+            <a:off x="4257040" y="5833872"/>
             <a:ext cx="615696" cy="256032"/>
           </a:xfrm>
           <a:prstGeom prst="roundRect">
@@ -24828,7 +24828,7 @@
         </p:nvSpPr>
         <p:spPr>
           <a:xfrm>
-            <a:off x="4058920" y="5833872"/>
+            <a:off x="4257040" y="5833872"/>
             <a:ext cx="615696" cy="256032"/>
           </a:xfrm>
           <a:prstGeom prst="rect">
@@ -24853,7 +24853,7 @@
                 <a:ea typeface="Calibri" pitchFamily="34" charset="-122"/>
                 <a:cs typeface="Calibri" pitchFamily="34" charset="-120"/>
               </a:rPr>
-              <a:t>health</a:t>
+              <a:t>doctor</a:t>
             </a:r>
             <a:endParaRPr lang="en-US" sz="1000" dirty="0"/>
           </a:p>
@@ -24867,8 +24867,8 @@
         </p:nvSpPr>
         <p:spPr>
           <a:xfrm>
-            <a:off x="4766056" y="5833872"/>
-            <a:ext cx="1011936" cy="256032"/>
+            <a:off x="4964176" y="5833872"/>
+            <a:ext cx="615696" cy="256032"/>
           </a:xfrm>
           <a:prstGeom prst="roundRect">
             <a:avLst>
@@ -24894,8 +24894,8 @@
         </p:nvSpPr>
         <p:spPr>
           <a:xfrm>
-            <a:off x="4766056" y="5833872"/>
-            <a:ext cx="1011936" cy="256032"/>
+            <a:off x="4964176" y="5833872"/>
+            <a:ext cx="615696" cy="256032"/>
           </a:xfrm>
           <a:prstGeom prst="rect">
             <a:avLst/>
@@ -24919,7 +24919,7 @@
                 <a:ea typeface="Calibri" pitchFamily="34" charset="-122"/>
                 <a:cs typeface="Calibri" pitchFamily="34" charset="-120"/>
               </a:rPr>
-              <a:t>plugin build</a:t>
+              <a:t>health</a:t>
             </a:r>
             <a:endParaRPr lang="en-US" sz="1000" dirty="0"/>
           </a:p>
@@ -24933,8 +24933,8 @@
         </p:nvSpPr>
         <p:spPr>
           <a:xfrm>
-            <a:off x="5869432" y="5833872"/>
-            <a:ext cx="549656" cy="256032"/>
+            <a:off x="5671312" y="5833872"/>
+            <a:ext cx="1011936" cy="256032"/>
           </a:xfrm>
           <a:prstGeom prst="roundRect">
             <a:avLst>
@@ -24960,8 +24960,8 @@
         </p:nvSpPr>
         <p:spPr>
           <a:xfrm>
-            <a:off x="5869432" y="5833872"/>
-            <a:ext cx="549656" cy="256032"/>
+            <a:off x="5671312" y="5833872"/>
+            <a:ext cx="1011936" cy="256032"/>
           </a:xfrm>
           <a:prstGeom prst="rect">
             <a:avLst/>
@@ -24985,7 +24985,7 @@
                 <a:ea typeface="Calibri" pitchFamily="34" charset="-122"/>
                 <a:cs typeface="Calibri" pitchFamily="34" charset="-120"/>
               </a:rPr>
-              <a:t>trace</a:t>
+              <a:t>plugin build</a:t>
             </a:r>
             <a:endParaRPr lang="en-US" sz="1000" dirty="0"/>
           </a:p>
@@ -24999,8 +24999,8 @@
         </p:nvSpPr>
         <p:spPr>
           <a:xfrm>
-            <a:off x="6510528" y="5833872"/>
-            <a:ext cx="483616" cy="256032"/>
+            <a:off x="6774688" y="5833872"/>
+            <a:ext cx="549656" cy="256032"/>
           </a:xfrm>
           <a:prstGeom prst="roundRect">
             <a:avLst>
@@ -25026,8 +25026,8 @@
         </p:nvSpPr>
         <p:spPr>
           <a:xfrm>
-            <a:off x="6510528" y="5833872"/>
-            <a:ext cx="483616" cy="256032"/>
+            <a:off x="6774688" y="5833872"/>
+            <a:ext cx="549656" cy="256032"/>
           </a:xfrm>
           <a:prstGeom prst="rect">
             <a:avLst/>
@@ -25051,7 +25051,7 @@
                 <a:ea typeface="Calibri" pitchFamily="34" charset="-122"/>
                 <a:cs typeface="Calibri" pitchFamily="34" charset="-120"/>
               </a:rPr>
-              <a:t>hook</a:t>
+              <a:t>trace</a:t>
             </a:r>
             <a:endParaRPr lang="en-US" sz="1000" dirty="0"/>
           </a:p>
@@ -25065,8 +25065,8 @@
         </p:nvSpPr>
         <p:spPr>
           <a:xfrm>
-            <a:off x="7085584" y="5833872"/>
-            <a:ext cx="747776" cy="256032"/>
+            <a:off x="7415784" y="5833872"/>
+            <a:ext cx="483616" cy="256032"/>
           </a:xfrm>
           <a:prstGeom prst="roundRect">
             <a:avLst>
@@ -25092,7 +25092,73 @@
         </p:nvSpPr>
         <p:spPr>
           <a:xfrm>
-            <a:off x="7085584" y="5833872"/>
+            <a:off x="7415784" y="5833872"/>
+            <a:ext cx="483616" cy="256032"/>
+          </a:xfrm>
+          <a:prstGeom prst="rect">
+            <a:avLst/>
+          </a:prstGeom>
+          <a:noFill/>
+          <a:ln/>
+        </p:spPr>
+        <p:txBody>
+          <a:bodyPr wrap="square" lIns="0" tIns="0" rIns="0" bIns="0" rtlCol="0" anchor="ctr"/>
+          <a:lstStyle/>
+          <a:p>
+            <a:pPr algn="ctr" indent="0" marL="0">
+              <a:buNone/>
+            </a:pPr>
+            <a:r>
+              <a:rPr lang="en-US" sz="1000" dirty="0">
+                <a:solidFill>
+                  <a:srgbClr val="1F2430"/>
+                </a:solidFill>
+                <a:latin typeface="Calibri" pitchFamily="34" charset="0"/>
+                <a:ea typeface="Calibri" pitchFamily="34" charset="-122"/>
+                <a:cs typeface="Calibri" pitchFamily="34" charset="-120"/>
+              </a:rPr>
+              <a:t>hook</a:t>
+            </a:r>
+            <a:endParaRPr lang="en-US" sz="1000" dirty="0"/>
+          </a:p>
+        </p:txBody>
+      </p:sp>
+      <p:sp>
+        <p:nvSpPr>
+          <p:cNvPr id="172" name="Shape 170"/>
+          <p:cNvSpPr/>
+          <p:nvPr/>
+        </p:nvSpPr>
+        <p:spPr>
+          <a:xfrm>
+            <a:off x="7990840" y="5833872"/>
+            <a:ext cx="747776" cy="256032"/>
+          </a:xfrm>
+          <a:prstGeom prst="roundRect">
+            <a:avLst>
+              <a:gd name="adj" fmla="val 50000"/>
+            </a:avLst>
+          </a:prstGeom>
+          <a:solidFill>
+            <a:srgbClr val="F3F5F8"/>
+          </a:solidFill>
+          <a:ln w="12700">
+            <a:solidFill>
+              <a:srgbClr val="F3F5F8"/>
+            </a:solidFill>
+            <a:prstDash val="solid"/>
+          </a:ln>
+        </p:spPr>
+      </p:sp>
+      <p:sp>
+        <p:nvSpPr>
+          <p:cNvPr id="173" name="Text 171"/>
+          <p:cNvSpPr txBox="1"/>
+          <p:nvPr/>
+        </p:nvSpPr>
+        <p:spPr>
+          <a:xfrm>
+            <a:off x="7990840" y="5833872"/>
             <a:ext cx="747776" cy="256032"/>
           </a:xfrm>
           <a:prstGeom prst="rect">
@@ -27763,7 +27829,7 @@
                 <a:ea typeface="Courier New" pitchFamily="34" charset="-122"/>
                 <a:cs typeface="Courier New" pitchFamily="34" charset="-120"/>
               </a:rPr>
-              <a:t>  sdlc 0.19.0, license: community</a:t>
+              <a:t>  sdlc 0.20.0, license: community</a:t>
             </a:r>
             <a:endParaRPr lang="en-US" sz="1000" dirty="0"/>
           </a:p>
@@ -35001,6 +35067,72 @@
                 <a:cs typeface="Calibri" pitchFamily="34" charset="-120"/>
               </a:rPr>
               <a:t>explain</a:t>
+            </a:r>
+            <a:endParaRPr lang="en-US" sz="1000" dirty="0"/>
+          </a:p>
+        </p:txBody>
+      </p:sp>
+      <p:sp>
+        <p:nvSpPr>
+          <p:cNvPr id="39" name="Shape 37"/>
+          <p:cNvSpPr/>
+          <p:nvPr/>
+        </p:nvSpPr>
+        <p:spPr>
+          <a:xfrm>
+            <a:off x="4493768" y="6053328"/>
+            <a:ext cx="549656" cy="256032"/>
+          </a:xfrm>
+          <a:prstGeom prst="roundRect">
+            <a:avLst>
+              <a:gd name="adj" fmla="val 50000"/>
+            </a:avLst>
+          </a:prstGeom>
+          <a:solidFill>
+            <a:srgbClr val="F3F5F8"/>
+          </a:solidFill>
+          <a:ln w="12700">
+            <a:solidFill>
+              <a:srgbClr val="F3F5F8"/>
+            </a:solidFill>
+            <a:prstDash val="solid"/>
+          </a:ln>
+        </p:spPr>
+      </p:sp>
+      <p:sp>
+        <p:nvSpPr>
+          <p:cNvPr id="40" name="Text 38"/>
+          <p:cNvSpPr txBox="1"/>
+          <p:nvPr/>
+        </p:nvSpPr>
+        <p:spPr>
+          <a:xfrm>
+            <a:off x="4493768" y="6053328"/>
+            <a:ext cx="549656" cy="256032"/>
+          </a:xfrm>
+          <a:prstGeom prst="rect">
+            <a:avLst/>
+          </a:prstGeom>
+          <a:noFill/>
+          <a:ln/>
+        </p:spPr>
+        <p:txBody>
+          <a:bodyPr wrap="square" lIns="0" tIns="0" rIns="0" bIns="0" rtlCol="0" anchor="ctr"/>
+          <a:lstStyle/>
+          <a:p>
+            <a:pPr algn="ctr" indent="0" marL="0">
+              <a:buNone/>
+            </a:pPr>
+            <a:r>
+              <a:rPr lang="en-US" sz="1000" dirty="0">
+                <a:solidFill>
+                  <a:srgbClr val="5B6475"/>
+                </a:solidFill>
+                <a:latin typeface="Calibri" pitchFamily="34" charset="0"/>
+                <a:ea typeface="Calibri" pitchFamily="34" charset="-122"/>
+                <a:cs typeface="Calibri" pitchFamily="34" charset="-120"/>
+              </a:rPr>
+              <a:t>judge</a:t>
             </a:r>
             <a:endParaRPr lang="en-US" sz="1000" dirty="0"/>
           </a:p>

</xml_diff>

<commit_message>
fix: messages without doubled periods; team list shows the packs; docs checked against the CLI (0.20.1)
- A note, a reason or a judge's text that ends with a period no longer
  reads "..": the substitution drops it before the template's period;
  the message after max_loops has its colon.
- sdlc team list shows the packs: synced, waiting for a person or in
  effect, and what they bring.
- CHANGELOG: the 0.19.0 heading is back; a test checks the changelog's
  shape, another that every message key the code names exists.
- Docs: every command in the reference documents and in the command
  reference of the course and the handbook; lessons on the judge gate
  and on extension packs; the demo accepts a company pack.

SDLC-Agent: claude-code
</commit_message>
<xml_diff>
--- a/docs/demo/sdlc-calculator-demo.en.pptx
+++ b/docs/demo/sdlc-calculator-demo.en.pptx
@@ -5112,7 +5112,7 @@
                 <a:ea typeface="Courier New" pitchFamily="34" charset="-122"/>
                 <a:cs typeface="Courier New" pitchFamily="34" charset="-120"/>
               </a:rPr>
-              <a:t>✓ test (2.2s)</a:t>
+              <a:t>✓ test (1.0s)</a:t>
             </a:r>
             <a:endParaRPr lang="en-US" sz="1000" dirty="0"/>
           </a:p>
@@ -6660,7 +6660,7 @@
                 <a:ea typeface="Courier New" pitchFamily="34" charset="-122"/>
                 <a:cs typeface="Courier New" pitchFamily="34" charset="-120"/>
               </a:rPr>
-              <a:t>  code-owner (3d6ac2e55b7f)</a:t>
+              <a:t>  code-owner (5ab417be3f87)</a:t>
             </a:r>
             <a:endParaRPr lang="en-US" sz="1000" dirty="0"/>
           </a:p>
@@ -6745,7 +6745,7 @@
                 <a:ea typeface="Courier New" pitchFamily="34" charset="-122"/>
                 <a:cs typeface="Courier New" pitchFamily="34" charset="-120"/>
               </a:rPr>
-              <a:t>  "SDLC-Approval: basic-arithmetic:review:3</a:t>
+              <a:t>  "SDLC-Approval: basic-arithmetic:review:5</a:t>
             </a:r>
             <a:endParaRPr lang="en-US" sz="1000" dirty="0"/>
           </a:p>
@@ -6762,7 +6762,7 @@
                 <a:ea typeface="Courier New" pitchFamily="34" charset="-122"/>
                 <a:cs typeface="Courier New" pitchFamily="34" charset="-120"/>
               </a:rPr>
-              <a:t>  d6ac2e55b7f"</a:t>
+              <a:t>  ab417be3f87"</a:t>
             </a:r>
             <a:endParaRPr lang="en-US" sz="1000" dirty="0"/>
           </a:p>
@@ -7443,7 +7443,7 @@
                 <a:ea typeface="Courier New" pitchFamily="34" charset="-122"/>
                 <a:cs typeface="Courier New" pitchFamily="34" charset="-120"/>
               </a:rPr>
-              <a:t>  release-manager (3d6ac2e55b7f)</a:t>
+              <a:t>  release-manager (5ab417be3f87)</a:t>
             </a:r>
             <a:endParaRPr lang="en-US" sz="1000" dirty="0"/>
           </a:p>
@@ -7511,7 +7511,7 @@
                 <a:ea typeface="Courier New" pitchFamily="34" charset="-122"/>
                 <a:cs typeface="Courier New" pitchFamily="34" charset="-120"/>
               </a:rPr>
-              <a:t>  gate" -m "SDLC-Approval: basic-arithmetic:release:3d6ac2e55b7f"</a:t>
+              <a:t>  gate" -m "SDLC-Approval: basic-arithmetic:release:5ab417be3f87"</a:t>
             </a:r>
             <a:endParaRPr lang="en-US" sz="1000" dirty="0"/>
           </a:p>
@@ -7794,7 +7794,7 @@
                 <a:ea typeface="Courier New" pitchFamily="34" charset="-122"/>
                 <a:cs typeface="Courier New" pitchFamily="34" charset="-120"/>
               </a:rPr>
-              <a:t>✓ basic-arithmetic/intent alice valid 41c6aa1c trailer: missing</a:t>
+              <a:t>✓ basic-arithmetic/intent alice valid 7fe457dd trailer: missing</a:t>
             </a:r>
             <a:endParaRPr lang="en-US" sz="1000" dirty="0"/>
           </a:p>
@@ -7811,7 +7811,7 @@
                 <a:ea typeface="Courier New" pitchFamily="34" charset="-122"/>
                 <a:cs typeface="Courier New" pitchFamily="34" charset="-120"/>
               </a:rPr>
-              <a:t>✓ basic-arithmetic/spec alice valid 168e88e7 trailer: missing</a:t>
+              <a:t>✓ basic-arithmetic/spec alice valid d653583b trailer: missing</a:t>
             </a:r>
             <a:endParaRPr lang="en-US" sz="1000" dirty="0"/>
           </a:p>
@@ -7828,7 +7828,7 @@
                 <a:ea typeface="Courier New" pitchFamily="34" charset="-122"/>
                 <a:cs typeface="Courier New" pitchFamily="34" charset="-120"/>
               </a:rPr>
-              <a:t>✗ basic-arithmetic/plan bob wrong-signer 168e88e7 trailer: missing</a:t>
+              <a:t>✗ basic-arithmetic/plan bob wrong-signer d653583b trailer: missing</a:t>
             </a:r>
             <a:endParaRPr lang="en-US" sz="1000" dirty="0"/>
           </a:p>
@@ -7845,7 +7845,7 @@
                 <a:ea typeface="Courier New" pitchFamily="34" charset="-122"/>
                 <a:cs typeface="Courier New" pitchFamily="34" charset="-120"/>
               </a:rPr>
-              <a:t>✓ basic-arithmetic/review carol valid c6ddcb02 trailer: missing</a:t>
+              <a:t>✓ basic-arithmetic/review carol valid e8d625cd trailer: missing</a:t>
             </a:r>
             <a:endParaRPr lang="en-US" sz="1000" dirty="0"/>
           </a:p>
@@ -7862,7 +7862,7 @@
                 <a:ea typeface="Courier New" pitchFamily="34" charset="-122"/>
                 <a:cs typeface="Courier New" pitchFamily="34" charset="-120"/>
               </a:rPr>
-              <a:t>✓ basic-arithmetic/release alice valid 909490ea trailer: missing</a:t>
+              <a:t>✓ basic-arithmetic/release alice valid 6b7cb787 trailer: missing</a:t>
             </a:r>
             <a:endParaRPr lang="en-US" sz="1000" dirty="0"/>
           </a:p>
@@ -7879,7 +7879,7 @@
                 <a:ea typeface="Courier New" pitchFamily="34" charset="-122"/>
                 <a:cs typeface="Courier New" pitchFamily="34" charset="-120"/>
               </a:rPr>
-              <a:t>✓ openspec/roles.yaml alice@calc.example bootstrap 68932692</a:t>
+              <a:t>✓ openspec/roles.yaml alice@calc.example bootstrap f0877292</a:t>
             </a:r>
             <a:endParaRPr lang="en-US" sz="1000" dirty="0"/>
           </a:p>
@@ -14365,7 +14365,7 @@
                 <a:ea typeface="Courier New" pitchFamily="34" charset="-122"/>
                 <a:cs typeface="Courier New" pitchFamily="34" charset="-120"/>
               </a:rPr>
-              <a:t>  archived) · sdlc 0.20.0, license:</a:t>
+              <a:t>  archived) · sdlc 0.20.1, license:</a:t>
             </a:r>
             <a:endParaRPr lang="en-US" sz="1000" dirty="0"/>
           </a:p>
@@ -14552,7 +14552,7 @@
                 <a:ea typeface="Courier New" pitchFamily="34" charset="-122"/>
                 <a:cs typeface="Courier New" pitchFamily="34" charset="-120"/>
               </a:rPr>
-              <a:t>  intent 3 · spec 3 · plan 16 · review 3;</a:t>
+              <a:t>  intent 3 · spec 3 · plan 17 · review 3;</a:t>
             </a:r>
             <a:endParaRPr lang="en-US" sz="1000" dirty="0"/>
           </a:p>
@@ -14886,7 +14886,7 @@
                 <a:ea typeface="Courier New" pitchFamily="34" charset="-122"/>
                 <a:cs typeface="Courier New" pitchFamily="34" charset="-120"/>
               </a:rPr>
-              <a:t>2026-10-13T16:48:05.251Z  gate.review.await</a:t>
+              <a:t>2026-10-13T18:27:35.445Z  gate.review.await</a:t>
             </a:r>
             <a:endParaRPr lang="en-US" sz="1000" dirty="0"/>
           </a:p>
@@ -14920,7 +14920,7 @@
                 <a:ea typeface="Courier New" pitchFamily="34" charset="-122"/>
                 <a:cs typeface="Courier New" pitchFamily="34" charset="-120"/>
               </a:rPr>
-              <a:t>  sha256:3d6ac2e55b7fa3a198a9816633bd881d47</a:t>
+              <a:t>  sha256:5ab417be3f87eb6876366c042b2b2487b7</a:t>
             </a:r>
             <a:endParaRPr lang="en-US" sz="1000" dirty="0"/>
           </a:p>
@@ -14937,7 +14937,7 @@
                 <a:ea typeface="Courier New" pitchFamily="34" charset="-122"/>
                 <a:cs typeface="Courier New" pitchFamily="34" charset="-120"/>
               </a:rPr>
-              <a:t>  7ca917251a375d5c8c848e9ad14518 [sdlc</a:t>
+              <a:t>  d6372c58e8c4fed9e00d32419bc60f [sdlc</a:t>
             </a:r>
             <a:endParaRPr lang="en-US" sz="1000" dirty="0"/>
           </a:p>
@@ -14954,7 +14954,7 @@
                 <a:ea typeface="Courier New" pitchFamily="34" charset="-122"/>
                 <a:cs typeface="Courier New" pitchFamily="34" charset="-120"/>
               </a:rPr>
-              <a:t>  0.20.0 · community]</a:t>
+              <a:t>  0.20.1 · community]</a:t>
             </a:r>
             <a:endParaRPr lang="en-US" sz="1000" dirty="0"/>
           </a:p>
@@ -14971,7 +14971,7 @@
                 <a:ea typeface="Courier New" pitchFamily="34" charset="-122"/>
                 <a:cs typeface="Courier New" pitchFamily="34" charset="-120"/>
               </a:rPr>
-              <a:t>2026-10-13T16:48:08.386Z  gate.review.appro</a:t>
+              <a:t>2026-10-13T18:27:38.626Z  gate.review.appro</a:t>
             </a:r>
             <a:endParaRPr lang="en-US" sz="1000" dirty="0"/>
           </a:p>
@@ -15022,7 +15022,7 @@
                 <a:ea typeface="Courier New" pitchFamily="34" charset="-122"/>
                 <a:cs typeface="Courier New" pitchFamily="34" charset="-120"/>
               </a:rPr>
-              <a:t>  [sdlc 0.20.0 · community]</a:t>
+              <a:t>  [sdlc 0.20.1 · community]</a:t>
             </a:r>
             <a:endParaRPr lang="en-US" sz="1000" dirty="0"/>
           </a:p>
@@ -15039,7 +15039,7 @@
                 <a:ea typeface="Courier New" pitchFamily="34" charset="-122"/>
                 <a:cs typeface="Courier New" pitchFamily="34" charset="-120"/>
               </a:rPr>
-              <a:t>2026-10-13T16:48:15.066Z  gate.release.appr</a:t>
+              <a:t>2026-10-13T18:27:45.529Z  gate.release.appr</a:t>
             </a:r>
             <a:endParaRPr lang="en-US" sz="1000" dirty="0"/>
           </a:p>
@@ -15090,7 +15090,7 @@
                 <a:ea typeface="Courier New" pitchFamily="34" charset="-122"/>
                 <a:cs typeface="Courier New" pitchFamily="34" charset="-120"/>
               </a:rPr>
-              <a:t>  release-manager [sdlc 0.20.0 · community]</a:t>
+              <a:t>  release-manager [sdlc 0.20.1 · community]</a:t>
             </a:r>
             <a:endParaRPr lang="en-US" sz="1000" dirty="0"/>
           </a:p>
@@ -16871,7 +16871,7 @@
                 <a:ea typeface="Courier New" pitchFamily="34" charset="-122"/>
                 <a:cs typeface="Courier New" pitchFamily="34" charset="-120"/>
               </a:rPr>
-              <a:t>      "id": "20261013T164910740Z-ci-green-e</a:t>
+              <a:t>      "id": "20261013T182840359Z-ci-green-0</a:t>
             </a:r>
             <a:endParaRPr lang="en-US" sz="1000" dirty="0"/>
           </a:p>
@@ -16888,7 +16888,7 @@
                 <a:ea typeface="Courier New" pitchFamily="34" charset="-122"/>
                 <a:cs typeface="Courier New" pitchFamily="34" charset="-120"/>
               </a:rPr>
-              <a:t>  1d607",</a:t>
+              <a:t>  64f21",</a:t>
             </a:r>
             <a:endParaRPr lang="en-US" sz="1000" dirty="0"/>
           </a:p>
@@ -17024,7 +17024,7 @@
                 <a:ea typeface="Courier New" pitchFamily="34" charset="-122"/>
                 <a:cs typeface="Courier New" pitchFamily="34" charset="-120"/>
               </a:rPr>
-              <a:t>        "ref": "bb445e41c829a11fdf3f991ce99</a:t>
+              <a:t>        "ref": "75913b7a3c2de306871d4186787</a:t>
             </a:r>
             <a:endParaRPr lang="en-US" sz="1000" dirty="0"/>
           </a:p>
@@ -17041,7 +17041,7 @@
                 <a:ea typeface="Courier New" pitchFamily="34" charset="-122"/>
                 <a:cs typeface="Courier New" pitchFamily="34" charset="-120"/>
               </a:rPr>
-              <a:t>  77e06b7879c35",</a:t>
+              <a:t>  45c1d232898b0",</a:t>
             </a:r>
             <a:endParaRPr lang="en-US" sz="1000" dirty="0"/>
           </a:p>
@@ -19615,7 +19615,7 @@
                 <a:ea typeface="Cambria" pitchFamily="34" charset="-122"/>
                 <a:cs typeface="Cambria" pitchFamily="34" charset="-120"/>
               </a:rPr>
-              <a:t>112</a:t>
+              <a:t>114</a:t>
             </a:r>
             <a:endParaRPr lang="en-US" sz="6000" dirty="0"/>
           </a:p>
@@ -27829,7 +27829,7 @@
                 <a:ea typeface="Courier New" pitchFamily="34" charset="-122"/>
                 <a:cs typeface="Courier New" pitchFamily="34" charset="-120"/>
               </a:rPr>
-              <a:t>  sdlc 0.20.0, license: community</a:t>
+              <a:t>  sdlc 0.20.1, license: community</a:t>
             </a:r>
             <a:endParaRPr lang="en-US" sz="1000" dirty="0"/>
           </a:p>

</xml_diff>

<commit_message>
fix: status in the reader's language and the project's tools; a neutral approval line (0.20.2)
- sdlc status shows who approved a gate through the catalog (an English
  word was left in other languages) and, with no active change, names
  only the project's own tools to start one.
- The approval line in other languages no longer assumes the approver's
  gender.

SDLC-Agent: claude-code
</commit_message>
<xml_diff>
--- a/docs/demo/sdlc-calculator-demo.en.pptx
+++ b/docs/demo/sdlc-calculator-demo.en.pptx
@@ -6660,7 +6660,7 @@
                 <a:ea typeface="Courier New" pitchFamily="34" charset="-122"/>
                 <a:cs typeface="Courier New" pitchFamily="34" charset="-120"/>
               </a:rPr>
-              <a:t>  code-owner (5ab417be3f87)</a:t>
+              <a:t>  code-owner (9fb2796df945)</a:t>
             </a:r>
             <a:endParaRPr lang="en-US" sz="1000" dirty="0"/>
           </a:p>
@@ -6745,7 +6745,7 @@
                 <a:ea typeface="Courier New" pitchFamily="34" charset="-122"/>
                 <a:cs typeface="Courier New" pitchFamily="34" charset="-120"/>
               </a:rPr>
-              <a:t>  "SDLC-Approval: basic-arithmetic:review:5</a:t>
+              <a:t>  "SDLC-Approval: basic-arithmetic:review:9</a:t>
             </a:r>
             <a:endParaRPr lang="en-US" sz="1000" dirty="0"/>
           </a:p>
@@ -6762,7 +6762,7 @@
                 <a:ea typeface="Courier New" pitchFamily="34" charset="-122"/>
                 <a:cs typeface="Courier New" pitchFamily="34" charset="-120"/>
               </a:rPr>
-              <a:t>  ab417be3f87"</a:t>
+              <a:t>  fb2796df945"</a:t>
             </a:r>
             <a:endParaRPr lang="en-US" sz="1000" dirty="0"/>
           </a:p>
@@ -7443,7 +7443,7 @@
                 <a:ea typeface="Courier New" pitchFamily="34" charset="-122"/>
                 <a:cs typeface="Courier New" pitchFamily="34" charset="-120"/>
               </a:rPr>
-              <a:t>  release-manager (5ab417be3f87)</a:t>
+              <a:t>  release-manager (9fb2796df945)</a:t>
             </a:r>
             <a:endParaRPr lang="en-US" sz="1000" dirty="0"/>
           </a:p>
@@ -7511,7 +7511,7 @@
                 <a:ea typeface="Courier New" pitchFamily="34" charset="-122"/>
                 <a:cs typeface="Courier New" pitchFamily="34" charset="-120"/>
               </a:rPr>
-              <a:t>  gate" -m "SDLC-Approval: basic-arithmetic:release:5ab417be3f87"</a:t>
+              <a:t>  gate" -m "SDLC-Approval: basic-arithmetic:release:9fb2796df945"</a:t>
             </a:r>
             <a:endParaRPr lang="en-US" sz="1000" dirty="0"/>
           </a:p>
@@ -7794,7 +7794,7 @@
                 <a:ea typeface="Courier New" pitchFamily="34" charset="-122"/>
                 <a:cs typeface="Courier New" pitchFamily="34" charset="-120"/>
               </a:rPr>
-              <a:t>✓ basic-arithmetic/intent alice valid 7fe457dd trailer: missing</a:t>
+              <a:t>✓ basic-arithmetic/intent alice valid bfea444f trailer: missing</a:t>
             </a:r>
             <a:endParaRPr lang="en-US" sz="1000" dirty="0"/>
           </a:p>
@@ -7811,7 +7811,7 @@
                 <a:ea typeface="Courier New" pitchFamily="34" charset="-122"/>
                 <a:cs typeface="Courier New" pitchFamily="34" charset="-120"/>
               </a:rPr>
-              <a:t>✓ basic-arithmetic/spec alice valid d653583b trailer: missing</a:t>
+              <a:t>✓ basic-arithmetic/spec alice valid 45ddf0d1 trailer: missing</a:t>
             </a:r>
             <a:endParaRPr lang="en-US" sz="1000" dirty="0"/>
           </a:p>
@@ -7828,7 +7828,7 @@
                 <a:ea typeface="Courier New" pitchFamily="34" charset="-122"/>
                 <a:cs typeface="Courier New" pitchFamily="34" charset="-120"/>
               </a:rPr>
-              <a:t>✗ basic-arithmetic/plan bob wrong-signer d653583b trailer: missing</a:t>
+              <a:t>✗ basic-arithmetic/plan bob wrong-signer 45ddf0d1 trailer: missing</a:t>
             </a:r>
             <a:endParaRPr lang="en-US" sz="1000" dirty="0"/>
           </a:p>
@@ -7845,7 +7845,7 @@
                 <a:ea typeface="Courier New" pitchFamily="34" charset="-122"/>
                 <a:cs typeface="Courier New" pitchFamily="34" charset="-120"/>
               </a:rPr>
-              <a:t>✓ basic-arithmetic/review carol valid e8d625cd trailer: missing</a:t>
+              <a:t>✓ basic-arithmetic/review carol valid 4504ffa9 trailer: missing</a:t>
             </a:r>
             <a:endParaRPr lang="en-US" sz="1000" dirty="0"/>
           </a:p>
@@ -7862,7 +7862,7 @@
                 <a:ea typeface="Courier New" pitchFamily="34" charset="-122"/>
                 <a:cs typeface="Courier New" pitchFamily="34" charset="-120"/>
               </a:rPr>
-              <a:t>✓ basic-arithmetic/release alice valid 6b7cb787 trailer: missing</a:t>
+              <a:t>✓ basic-arithmetic/release alice valid 2bb25c09 trailer: missing</a:t>
             </a:r>
             <a:endParaRPr lang="en-US" sz="1000" dirty="0"/>
           </a:p>
@@ -7879,7 +7879,7 @@
                 <a:ea typeface="Courier New" pitchFamily="34" charset="-122"/>
                 <a:cs typeface="Courier New" pitchFamily="34" charset="-120"/>
               </a:rPr>
-              <a:t>✓ openspec/roles.yaml alice@calc.example bootstrap f0877292</a:t>
+              <a:t>✓ openspec/roles.yaml alice@calc.example bootstrap 4fbf901c</a:t>
             </a:r>
             <a:endParaRPr lang="en-US" sz="1000" dirty="0"/>
           </a:p>
@@ -14365,7 +14365,7 @@
                 <a:ea typeface="Courier New" pitchFamily="34" charset="-122"/>
                 <a:cs typeface="Courier New" pitchFamily="34" charset="-120"/>
               </a:rPr>
-              <a:t>  archived) · sdlc 0.20.1, license:</a:t>
+              <a:t>  archived) · sdlc 0.20.2, license:</a:t>
             </a:r>
             <a:endParaRPr lang="en-US" sz="1000" dirty="0"/>
           </a:p>
@@ -14886,7 +14886,7 @@
                 <a:ea typeface="Courier New" pitchFamily="34" charset="-122"/>
                 <a:cs typeface="Courier New" pitchFamily="34" charset="-120"/>
               </a:rPr>
-              <a:t>2026-10-13T18:27:35.445Z  gate.review.await</a:t>
+              <a:t>2026-10-13T20:35:39.116Z  gate.review.await</a:t>
             </a:r>
             <a:endParaRPr lang="en-US" sz="1000" dirty="0"/>
           </a:p>
@@ -14920,7 +14920,7 @@
                 <a:ea typeface="Courier New" pitchFamily="34" charset="-122"/>
                 <a:cs typeface="Courier New" pitchFamily="34" charset="-120"/>
               </a:rPr>
-              <a:t>  sha256:5ab417be3f87eb6876366c042b2b2487b7</a:t>
+              <a:t>  sha256:9fb2796df945c38c8c710c434879f8c3f5</a:t>
             </a:r>
             <a:endParaRPr lang="en-US" sz="1000" dirty="0"/>
           </a:p>
@@ -14937,7 +14937,7 @@
                 <a:ea typeface="Courier New" pitchFamily="34" charset="-122"/>
                 <a:cs typeface="Courier New" pitchFamily="34" charset="-120"/>
               </a:rPr>
-              <a:t>  d6372c58e8c4fed9e00d32419bc60f [sdlc</a:t>
+              <a:t>  2c643accd70824fb5cace7d17eadcf [sdlc</a:t>
             </a:r>
             <a:endParaRPr lang="en-US" sz="1000" dirty="0"/>
           </a:p>
@@ -14954,7 +14954,7 @@
                 <a:ea typeface="Courier New" pitchFamily="34" charset="-122"/>
                 <a:cs typeface="Courier New" pitchFamily="34" charset="-120"/>
               </a:rPr>
-              <a:t>  0.20.1 · community]</a:t>
+              <a:t>  0.20.2 · community]</a:t>
             </a:r>
             <a:endParaRPr lang="en-US" sz="1000" dirty="0"/>
           </a:p>
@@ -14971,7 +14971,7 @@
                 <a:ea typeface="Courier New" pitchFamily="34" charset="-122"/>
                 <a:cs typeface="Courier New" pitchFamily="34" charset="-120"/>
               </a:rPr>
-              <a:t>2026-10-13T18:27:38.626Z  gate.review.appro</a:t>
+              <a:t>2026-10-13T20:35:42.332Z  gate.review.appro</a:t>
             </a:r>
             <a:endParaRPr lang="en-US" sz="1000" dirty="0"/>
           </a:p>
@@ -15022,7 +15022,7 @@
                 <a:ea typeface="Courier New" pitchFamily="34" charset="-122"/>
                 <a:cs typeface="Courier New" pitchFamily="34" charset="-120"/>
               </a:rPr>
-              <a:t>  [sdlc 0.20.1 · community]</a:t>
+              <a:t>  [sdlc 0.20.2 · community]</a:t>
             </a:r>
             <a:endParaRPr lang="en-US" sz="1000" dirty="0"/>
           </a:p>
@@ -15039,7 +15039,7 @@
                 <a:ea typeface="Courier New" pitchFamily="34" charset="-122"/>
                 <a:cs typeface="Courier New" pitchFamily="34" charset="-120"/>
               </a:rPr>
-              <a:t>2026-10-13T18:27:45.529Z  gate.release.appr</a:t>
+              <a:t>2026-10-13T20:35:48.790Z  gate.release.appr</a:t>
             </a:r>
             <a:endParaRPr lang="en-US" sz="1000" dirty="0"/>
           </a:p>
@@ -15090,7 +15090,7 @@
                 <a:ea typeface="Courier New" pitchFamily="34" charset="-122"/>
                 <a:cs typeface="Courier New" pitchFamily="34" charset="-120"/>
               </a:rPr>
-              <a:t>  release-manager [sdlc 0.20.1 · community]</a:t>
+              <a:t>  release-manager [sdlc 0.20.2 · community]</a:t>
             </a:r>
             <a:endParaRPr lang="en-US" sz="1000" dirty="0"/>
           </a:p>
@@ -16418,7 +16418,7 @@
                 <a:ea typeface="Courier New" pitchFamily="34" charset="-122"/>
                 <a:cs typeface="Courier New" pitchFamily="34" charset="-120"/>
               </a:rPr>
-              <a:t>✓ test (1.0s)</a:t>
+              <a:t>✓ test (1.1s)</a:t>
             </a:r>
             <a:endParaRPr lang="en-US" sz="1000" dirty="0"/>
           </a:p>
@@ -16435,7 +16435,7 @@
                 <a:ea typeface="Courier New" pitchFamily="34" charset="-122"/>
                 <a:cs typeface="Courier New" pitchFamily="34" charset="-120"/>
               </a:rPr>
-              <a:t>✓ ci-green (ci/pipeline_status, 0.5s)</a:t>
+              <a:t>✓ ci-green (ci/pipeline_status, 0.6s)</a:t>
             </a:r>
             <a:endParaRPr lang="en-US" sz="1000" dirty="0"/>
           </a:p>
@@ -16871,7 +16871,7 @@
                 <a:ea typeface="Courier New" pitchFamily="34" charset="-122"/>
                 <a:cs typeface="Courier New" pitchFamily="34" charset="-120"/>
               </a:rPr>
-              <a:t>      "id": "20261013T182840359Z-ci-green-0</a:t>
+              <a:t>      "id": "20261013T203645800Z-ci-green-0</a:t>
             </a:r>
             <a:endParaRPr lang="en-US" sz="1000" dirty="0"/>
           </a:p>
@@ -16888,7 +16888,7 @@
                 <a:ea typeface="Courier New" pitchFamily="34" charset="-122"/>
                 <a:cs typeface="Courier New" pitchFamily="34" charset="-120"/>
               </a:rPr>
-              <a:t>  64f21",</a:t>
+              <a:t>  ca42d",</a:t>
             </a:r>
             <a:endParaRPr lang="en-US" sz="1000" dirty="0"/>
           </a:p>
@@ -17024,7 +17024,7 @@
                 <a:ea typeface="Courier New" pitchFamily="34" charset="-122"/>
                 <a:cs typeface="Courier New" pitchFamily="34" charset="-120"/>
               </a:rPr>
-              <a:t>        "ref": "75913b7a3c2de306871d4186787</a:t>
+              <a:t>        "ref": "142f97e9ee790e40de651669171</a:t>
             </a:r>
             <a:endParaRPr lang="en-US" sz="1000" dirty="0"/>
           </a:p>
@@ -17041,7 +17041,7 @@
                 <a:ea typeface="Courier New" pitchFamily="34" charset="-122"/>
                 <a:cs typeface="Courier New" pitchFamily="34" charset="-120"/>
               </a:rPr>
-              <a:t>  45c1d232898b0",</a:t>
+              <a:t>  c0c74d535ad0e",</a:t>
             </a:r>
             <a:endParaRPr lang="en-US" sz="1000" dirty="0"/>
           </a:p>
@@ -27829,7 +27829,7 @@
                 <a:ea typeface="Courier New" pitchFamily="34" charset="-122"/>
                 <a:cs typeface="Courier New" pitchFamily="34" charset="-120"/>
               </a:rPr>
-              <a:t>  sdlc 0.20.1, license: community</a:t>
+              <a:t>  sdlc 0.20.2, license: community</a:t>
             </a:r>
             <a:endParaRPr lang="en-US" sz="1000" dirty="0"/>
           </a:p>

</xml_diff>

<commit_message>
fix: credentials after Bearer/Basic, the stage and the daily summary in the reader's terms (0.20.3)
- A literal credential after Bearer, Basic, Token or Bot in the MCP
  registry is refused whatever its shape, and an agent edit that adds a
  credential after Bearer or Basic is denied.
- sdlc next and the Claude Code status line name the stage in the
  reader's language, as sdlc status does.
- The daily summary text names the active changes and the changes
  waiting for people separately.
- A plan-gate denial points to its guide section once; sdlc next after a
  debate no longer names the next step as an agent's.
- Docs: the status line reads the session on stdin; mcp check exits 1
  only with --strict; unknown_person is the --json code; the guide warns
  that an audit export inside the project, not git-ignored, makes the
  verification stale.

SDLC-Agent: claude-code
</commit_message>
<xml_diff>
--- a/docs/demo/sdlc-calculator-demo.en.pptx
+++ b/docs/demo/sdlc-calculator-demo.en.pptx
@@ -6660,7 +6660,7 @@
                 <a:ea typeface="Courier New" pitchFamily="34" charset="-122"/>
                 <a:cs typeface="Courier New" pitchFamily="34" charset="-120"/>
               </a:rPr>
-              <a:t>  code-owner (9fb2796df945)</a:t>
+              <a:t>  code-owner (6fe1207efb8e)</a:t>
             </a:r>
             <a:endParaRPr lang="en-US" sz="1000" dirty="0"/>
           </a:p>
@@ -6745,7 +6745,7 @@
                 <a:ea typeface="Courier New" pitchFamily="34" charset="-122"/>
                 <a:cs typeface="Courier New" pitchFamily="34" charset="-120"/>
               </a:rPr>
-              <a:t>  "SDLC-Approval: basic-arithmetic:review:9</a:t>
+              <a:t>  "SDLC-Approval: basic-arithmetic:review:6</a:t>
             </a:r>
             <a:endParaRPr lang="en-US" sz="1000" dirty="0"/>
           </a:p>
@@ -6762,7 +6762,7 @@
                 <a:ea typeface="Courier New" pitchFamily="34" charset="-122"/>
                 <a:cs typeface="Courier New" pitchFamily="34" charset="-120"/>
               </a:rPr>
-              <a:t>  fb2796df945"</a:t>
+              <a:t>  fe1207efb8e"</a:t>
             </a:r>
             <a:endParaRPr lang="en-US" sz="1000" dirty="0"/>
           </a:p>
@@ -7443,7 +7443,7 @@
                 <a:ea typeface="Courier New" pitchFamily="34" charset="-122"/>
                 <a:cs typeface="Courier New" pitchFamily="34" charset="-120"/>
               </a:rPr>
-              <a:t>  release-manager (9fb2796df945)</a:t>
+              <a:t>  release-manager (6fe1207efb8e)</a:t>
             </a:r>
             <a:endParaRPr lang="en-US" sz="1000" dirty="0"/>
           </a:p>
@@ -7511,7 +7511,7 @@
                 <a:ea typeface="Courier New" pitchFamily="34" charset="-122"/>
                 <a:cs typeface="Courier New" pitchFamily="34" charset="-120"/>
               </a:rPr>
-              <a:t>  gate" -m "SDLC-Approval: basic-arithmetic:release:9fb2796df945"</a:t>
+              <a:t>  gate" -m "SDLC-Approval: basic-arithmetic:release:6fe1207efb8e"</a:t>
             </a:r>
             <a:endParaRPr lang="en-US" sz="1000" dirty="0"/>
           </a:p>
@@ -7794,7 +7794,7 @@
                 <a:ea typeface="Courier New" pitchFamily="34" charset="-122"/>
                 <a:cs typeface="Courier New" pitchFamily="34" charset="-120"/>
               </a:rPr>
-              <a:t>✓ basic-arithmetic/intent alice valid bfea444f trailer: missing</a:t>
+              <a:t>✓ basic-arithmetic/intent alice valid d07fd095 trailer: missing</a:t>
             </a:r>
             <a:endParaRPr lang="en-US" sz="1000" dirty="0"/>
           </a:p>
@@ -7811,7 +7811,7 @@
                 <a:ea typeface="Courier New" pitchFamily="34" charset="-122"/>
                 <a:cs typeface="Courier New" pitchFamily="34" charset="-120"/>
               </a:rPr>
-              <a:t>✓ basic-arithmetic/spec alice valid 45ddf0d1 trailer: missing</a:t>
+              <a:t>✓ basic-arithmetic/spec alice valid d1469aa1 trailer: missing</a:t>
             </a:r>
             <a:endParaRPr lang="en-US" sz="1000" dirty="0"/>
           </a:p>
@@ -7828,7 +7828,7 @@
                 <a:ea typeface="Courier New" pitchFamily="34" charset="-122"/>
                 <a:cs typeface="Courier New" pitchFamily="34" charset="-120"/>
               </a:rPr>
-              <a:t>✗ basic-arithmetic/plan bob wrong-signer 45ddf0d1 trailer: missing</a:t>
+              <a:t>✗ basic-arithmetic/plan bob wrong-signer d1469aa1 trailer: missing</a:t>
             </a:r>
             <a:endParaRPr lang="en-US" sz="1000" dirty="0"/>
           </a:p>
@@ -7845,7 +7845,7 @@
                 <a:ea typeface="Courier New" pitchFamily="34" charset="-122"/>
                 <a:cs typeface="Courier New" pitchFamily="34" charset="-120"/>
               </a:rPr>
-              <a:t>✓ basic-arithmetic/review carol valid 4504ffa9 trailer: missing</a:t>
+              <a:t>✓ basic-arithmetic/review carol valid 24f02c2c trailer: missing</a:t>
             </a:r>
             <a:endParaRPr lang="en-US" sz="1000" dirty="0"/>
           </a:p>
@@ -7862,7 +7862,7 @@
                 <a:ea typeface="Courier New" pitchFamily="34" charset="-122"/>
                 <a:cs typeface="Courier New" pitchFamily="34" charset="-120"/>
               </a:rPr>
-              <a:t>✓ basic-arithmetic/release alice valid 2bb25c09 trailer: missing</a:t>
+              <a:t>✓ basic-arithmetic/release alice valid 39083661 trailer: missing</a:t>
             </a:r>
             <a:endParaRPr lang="en-US" sz="1000" dirty="0"/>
           </a:p>
@@ -7879,7 +7879,7 @@
                 <a:ea typeface="Courier New" pitchFamily="34" charset="-122"/>
                 <a:cs typeface="Courier New" pitchFamily="34" charset="-120"/>
               </a:rPr>
-              <a:t>✓ openspec/roles.yaml alice@calc.example bootstrap 4fbf901c</a:t>
+              <a:t>✓ openspec/roles.yaml alice@calc.example bootstrap c1f3d67d</a:t>
             </a:r>
             <a:endParaRPr lang="en-US" sz="1000" dirty="0"/>
           </a:p>
@@ -8511,7 +8511,7 @@
                 <a:ea typeface="Courier New" pitchFamily="34" charset="-122"/>
                 <a:cs typeface="Courier New" pitchFamily="34" charset="-120"/>
               </a:rPr>
-              <a:t>  openspec\changes\archive\2026-10-13-basic</a:t>
+              <a:t>  openspec\changes\archive\2026-10-14-basic</a:t>
             </a:r>
             <a:endParaRPr lang="en-US" sz="1000" dirty="0"/>
           </a:p>
@@ -14365,7 +14365,7 @@
                 <a:ea typeface="Courier New" pitchFamily="34" charset="-122"/>
                 <a:cs typeface="Courier New" pitchFamily="34" charset="-120"/>
               </a:rPr>
-              <a:t>  archived) · sdlc 0.20.2, license:</a:t>
+              <a:t>  archived) · sdlc 0.20.3, license:</a:t>
             </a:r>
             <a:endParaRPr lang="en-US" sz="1000" dirty="0"/>
           </a:p>
@@ -14552,7 +14552,7 @@
                 <a:ea typeface="Courier New" pitchFamily="34" charset="-122"/>
                 <a:cs typeface="Courier New" pitchFamily="34" charset="-120"/>
               </a:rPr>
-              <a:t>  intent 3 · spec 3 · plan 17 · review 3;</a:t>
+              <a:t>  intent 3 · spec 3 · plan 16 · review 3;</a:t>
             </a:r>
             <a:endParaRPr lang="en-US" sz="1000" dirty="0"/>
           </a:p>
@@ -14886,7 +14886,7 @@
                 <a:ea typeface="Courier New" pitchFamily="34" charset="-122"/>
                 <a:cs typeface="Courier New" pitchFamily="34" charset="-120"/>
               </a:rPr>
-              <a:t>2026-10-13T20:35:39.116Z  gate.review.await</a:t>
+              <a:t>2026-10-14T10:32:30.587Z  gate.review.await</a:t>
             </a:r>
             <a:endParaRPr lang="en-US" sz="1000" dirty="0"/>
           </a:p>
@@ -14920,7 +14920,7 @@
                 <a:ea typeface="Courier New" pitchFamily="34" charset="-122"/>
                 <a:cs typeface="Courier New" pitchFamily="34" charset="-120"/>
               </a:rPr>
-              <a:t>  sha256:9fb2796df945c38c8c710c434879f8c3f5</a:t>
+              <a:t>  sha256:6fe1207efb8ef41b5efedff0ce30e74846</a:t>
             </a:r>
             <a:endParaRPr lang="en-US" sz="1000" dirty="0"/>
           </a:p>
@@ -14937,7 +14937,7 @@
                 <a:ea typeface="Courier New" pitchFamily="34" charset="-122"/>
                 <a:cs typeface="Courier New" pitchFamily="34" charset="-120"/>
               </a:rPr>
-              <a:t>  2c643accd70824fb5cace7d17eadcf [sdlc</a:t>
+              <a:t>  88a9279510cdd27fe2a73b0f11f4ad [sdlc</a:t>
             </a:r>
             <a:endParaRPr lang="en-US" sz="1000" dirty="0"/>
           </a:p>
@@ -14954,7 +14954,7 @@
                 <a:ea typeface="Courier New" pitchFamily="34" charset="-122"/>
                 <a:cs typeface="Courier New" pitchFamily="34" charset="-120"/>
               </a:rPr>
-              <a:t>  0.20.2 · community]</a:t>
+              <a:t>  0.20.3 · community]</a:t>
             </a:r>
             <a:endParaRPr lang="en-US" sz="1000" dirty="0"/>
           </a:p>
@@ -14971,7 +14971,7 @@
                 <a:ea typeface="Courier New" pitchFamily="34" charset="-122"/>
                 <a:cs typeface="Courier New" pitchFamily="34" charset="-120"/>
               </a:rPr>
-              <a:t>2026-10-13T20:35:42.332Z  gate.review.appro</a:t>
+              <a:t>2026-10-14T10:32:33.820Z  gate.review.appro</a:t>
             </a:r>
             <a:endParaRPr lang="en-US" sz="1000" dirty="0"/>
           </a:p>
@@ -15022,7 +15022,7 @@
                 <a:ea typeface="Courier New" pitchFamily="34" charset="-122"/>
                 <a:cs typeface="Courier New" pitchFamily="34" charset="-120"/>
               </a:rPr>
-              <a:t>  [sdlc 0.20.2 · community]</a:t>
+              <a:t>  [sdlc 0.20.3 · community]</a:t>
             </a:r>
             <a:endParaRPr lang="en-US" sz="1000" dirty="0"/>
           </a:p>
@@ -15039,7 +15039,7 @@
                 <a:ea typeface="Courier New" pitchFamily="34" charset="-122"/>
                 <a:cs typeface="Courier New" pitchFamily="34" charset="-120"/>
               </a:rPr>
-              <a:t>2026-10-13T20:35:48.790Z  gate.release.appr</a:t>
+              <a:t>2026-10-14T10:32:40.341Z  gate.release.appr</a:t>
             </a:r>
             <a:endParaRPr lang="en-US" sz="1000" dirty="0"/>
           </a:p>
@@ -15090,7 +15090,7 @@
                 <a:ea typeface="Courier New" pitchFamily="34" charset="-122"/>
                 <a:cs typeface="Courier New" pitchFamily="34" charset="-120"/>
               </a:rPr>
-              <a:t>  release-manager [sdlc 0.20.2 · community]</a:t>
+              <a:t>  release-manager [sdlc 0.20.3 · community]</a:t>
             </a:r>
             <a:endParaRPr lang="en-US" sz="1000" dirty="0"/>
           </a:p>
@@ -16418,7 +16418,7 @@
                 <a:ea typeface="Courier New" pitchFamily="34" charset="-122"/>
                 <a:cs typeface="Courier New" pitchFamily="34" charset="-120"/>
               </a:rPr>
-              <a:t>✓ test (1.1s)</a:t>
+              <a:t>✓ test (1.0s)</a:t>
             </a:r>
             <a:endParaRPr lang="en-US" sz="1000" dirty="0"/>
           </a:p>
@@ -16435,7 +16435,7 @@
                 <a:ea typeface="Courier New" pitchFamily="34" charset="-122"/>
                 <a:cs typeface="Courier New" pitchFamily="34" charset="-120"/>
               </a:rPr>
-              <a:t>✓ ci-green (ci/pipeline_status, 0.6s)</a:t>
+              <a:t>✓ ci-green (ci/pipeline_status, 0.5s)</a:t>
             </a:r>
             <a:endParaRPr lang="en-US" sz="1000" dirty="0"/>
           </a:p>
@@ -16871,7 +16871,7 @@
                 <a:ea typeface="Courier New" pitchFamily="34" charset="-122"/>
                 <a:cs typeface="Courier New" pitchFamily="34" charset="-120"/>
               </a:rPr>
-              <a:t>      "id": "20261013T203645800Z-ci-green-0</a:t>
+              <a:t>      "id": "20261014T103334891Z-ci-green-e</a:t>
             </a:r>
             <a:endParaRPr lang="en-US" sz="1000" dirty="0"/>
           </a:p>
@@ -16888,7 +16888,7 @@
                 <a:ea typeface="Courier New" pitchFamily="34" charset="-122"/>
                 <a:cs typeface="Courier New" pitchFamily="34" charset="-120"/>
               </a:rPr>
-              <a:t>  ca42d",</a:t>
+              <a:t>  d62fc",</a:t>
             </a:r>
             <a:endParaRPr lang="en-US" sz="1000" dirty="0"/>
           </a:p>
@@ -17024,7 +17024,7 @@
                 <a:ea typeface="Courier New" pitchFamily="34" charset="-122"/>
                 <a:cs typeface="Courier New" pitchFamily="34" charset="-120"/>
               </a:rPr>
-              <a:t>        "ref": "142f97e9ee790e40de651669171</a:t>
+              <a:t>        "ref": "a5ef3f4aff403e94f01fcaa581a</a:t>
             </a:r>
             <a:endParaRPr lang="en-US" sz="1000" dirty="0"/>
           </a:p>
@@ -17041,7 +17041,7 @@
                 <a:ea typeface="Courier New" pitchFamily="34" charset="-122"/>
                 <a:cs typeface="Courier New" pitchFamily="34" charset="-120"/>
               </a:rPr>
-              <a:t>  c0c74d535ad0e",</a:t>
+              <a:t>  2a9e814b197fa",</a:t>
             </a:r>
             <a:endParaRPr lang="en-US" sz="1000" dirty="0"/>
           </a:p>
@@ -27829,7 +27829,7 @@
                 <a:ea typeface="Courier New" pitchFamily="34" charset="-122"/>
                 <a:cs typeface="Courier New" pitchFamily="34" charset="-120"/>
               </a:rPr>
-              <a:t>  sdlc 0.20.2, license: community</a:t>
+              <a:t>  sdlc 0.20.3, license: community</a:t>
             </a:r>
             <a:endParaRPr lang="en-US" sz="1000" dirty="0"/>
           </a:p>
@@ -34620,7 +34620,7 @@
                 <a:ea typeface="Courier New" pitchFamily="34" charset="-122"/>
                 <a:cs typeface="Courier New" pitchFamily="34" charset="-120"/>
               </a:rPr>
-              <a:t>  (3f005a0f65e9)</a:t>
+              <a:t>  (308be1b4f21d)</a:t>
             </a:r>
             <a:endParaRPr lang="en-US" sz="1000" dirty="0"/>
           </a:p>
@@ -34756,7 +34756,7 @@
                 <a:ea typeface="Courier New" pitchFamily="34" charset="-122"/>
                 <a:cs typeface="Courier New" pitchFamily="34" charset="-120"/>
               </a:rPr>
-              <a:t>  3f005a0f65e9"</a:t>
+              <a:t>  308be1b4f21d"</a:t>
             </a:r>
             <a:endParaRPr lang="en-US" sz="1000" dirty="0"/>
           </a:p>

</xml_diff>

<commit_message>
docs: the documentation and the built-in guide cover the executor registry and the task board (0.21.1)
- README, the overview and roles lessons and the command references of
  the course and the handbook describe the executor registry, executor
  tokens and the task board; every CLI command is in the references.
- sdlc guide explains the registry and tokens, the board tools over MCP,
  the registry and the board file among the records agents cannot edit,
  and how to hand tasks to a swarm.
- Fixed: the docs said MCP offers only read tools and that executor tokens
  came in 0.20.x; a glossary row held two terms.

SDLC-Agent: claude-code
</commit_message>
<xml_diff>
--- a/docs/demo/sdlc-calculator-demo.en.pptx
+++ b/docs/demo/sdlc-calculator-demo.en.pptx
@@ -6660,7 +6660,7 @@
                 <a:ea typeface="Courier New" pitchFamily="34" charset="-122"/>
                 <a:cs typeface="Courier New" pitchFamily="34" charset="-120"/>
               </a:rPr>
-              <a:t>  code-owner (68f3d1d6f609)</a:t>
+              <a:t>  code-owner (6c914d1d9eb7)</a:t>
             </a:r>
             <a:endParaRPr lang="en-US" sz="1000" dirty="0"/>
           </a:p>
@@ -6762,7 +6762,7 @@
                 <a:ea typeface="Courier New" pitchFamily="34" charset="-122"/>
                 <a:cs typeface="Courier New" pitchFamily="34" charset="-120"/>
               </a:rPr>
-              <a:t>  8f3d1d6f609"</a:t>
+              <a:t>  c914d1d9eb7"</a:t>
             </a:r>
             <a:endParaRPr lang="en-US" sz="1000" dirty="0"/>
           </a:p>
@@ -7443,7 +7443,7 @@
                 <a:ea typeface="Courier New" pitchFamily="34" charset="-122"/>
                 <a:cs typeface="Courier New" pitchFamily="34" charset="-120"/>
               </a:rPr>
-              <a:t>  release-manager (68f3d1d6f609)</a:t>
+              <a:t>  release-manager (6c914d1d9eb7)</a:t>
             </a:r>
             <a:endParaRPr lang="en-US" sz="1000" dirty="0"/>
           </a:p>
@@ -7511,7 +7511,7 @@
                 <a:ea typeface="Courier New" pitchFamily="34" charset="-122"/>
                 <a:cs typeface="Courier New" pitchFamily="34" charset="-120"/>
               </a:rPr>
-              <a:t>  gate" -m "SDLC-Approval: basic-arithmetic:release:68f3d1d6f609"</a:t>
+              <a:t>  gate" -m "SDLC-Approval: basic-arithmetic:release:6c914d1d9eb7"</a:t>
             </a:r>
             <a:endParaRPr lang="en-US" sz="1000" dirty="0"/>
           </a:p>
@@ -7794,7 +7794,7 @@
                 <a:ea typeface="Courier New" pitchFamily="34" charset="-122"/>
                 <a:cs typeface="Courier New" pitchFamily="34" charset="-120"/>
               </a:rPr>
-              <a:t>✓ basic-arithmetic/intent alice valid aa29dfa0 trailer: missing</a:t>
+              <a:t>✓ basic-arithmetic/intent alice valid 4129aa86 trailer: missing</a:t>
             </a:r>
             <a:endParaRPr lang="en-US" sz="1000" dirty="0"/>
           </a:p>
@@ -7811,7 +7811,7 @@
                 <a:ea typeface="Courier New" pitchFamily="34" charset="-122"/>
                 <a:cs typeface="Courier New" pitchFamily="34" charset="-120"/>
               </a:rPr>
-              <a:t>✓ basic-arithmetic/spec alice valid 07aae0ea trailer: missing</a:t>
+              <a:t>✓ basic-arithmetic/spec alice valid c8de7833 trailer: missing</a:t>
             </a:r>
             <a:endParaRPr lang="en-US" sz="1000" dirty="0"/>
           </a:p>
@@ -7828,7 +7828,7 @@
                 <a:ea typeface="Courier New" pitchFamily="34" charset="-122"/>
                 <a:cs typeface="Courier New" pitchFamily="34" charset="-120"/>
               </a:rPr>
-              <a:t>✗ basic-arithmetic/plan bob wrong-signer 07aae0ea trailer: missing</a:t>
+              <a:t>✗ basic-arithmetic/plan bob wrong-signer c8de7833 trailer: missing</a:t>
             </a:r>
             <a:endParaRPr lang="en-US" sz="1000" dirty="0"/>
           </a:p>
@@ -7845,7 +7845,7 @@
                 <a:ea typeface="Courier New" pitchFamily="34" charset="-122"/>
                 <a:cs typeface="Courier New" pitchFamily="34" charset="-120"/>
               </a:rPr>
-              <a:t>✓ basic-arithmetic/review carol valid ef3a9334 trailer: missing</a:t>
+              <a:t>✓ basic-arithmetic/review carol valid 3bffe27b trailer: missing</a:t>
             </a:r>
             <a:endParaRPr lang="en-US" sz="1000" dirty="0"/>
           </a:p>
@@ -7862,7 +7862,7 @@
                 <a:ea typeface="Courier New" pitchFamily="34" charset="-122"/>
                 <a:cs typeface="Courier New" pitchFamily="34" charset="-120"/>
               </a:rPr>
-              <a:t>✓ basic-arithmetic/release alice valid 493c4116 trailer: missing</a:t>
+              <a:t>✓ basic-arithmetic/release alice valid f1bbfdef trailer: missing</a:t>
             </a:r>
             <a:endParaRPr lang="en-US" sz="1000" dirty="0"/>
           </a:p>
@@ -7879,7 +7879,7 @@
                 <a:ea typeface="Courier New" pitchFamily="34" charset="-122"/>
                 <a:cs typeface="Courier New" pitchFamily="34" charset="-120"/>
               </a:rPr>
-              <a:t>✓ openspec/roles.yaml alice@calc.example bootstrap a531106e</a:t>
+              <a:t>✓ openspec/roles.yaml alice@calc.example bootstrap 1ce051cb</a:t>
             </a:r>
             <a:endParaRPr lang="en-US" sz="1000" dirty="0"/>
           </a:p>
@@ -14365,7 +14365,7 @@
                 <a:ea typeface="Courier New" pitchFamily="34" charset="-122"/>
                 <a:cs typeface="Courier New" pitchFamily="34" charset="-120"/>
               </a:rPr>
-              <a:t>  archived) · sdlc 0.21.0, license:</a:t>
+              <a:t>  archived) · sdlc 0.21.1, license:</a:t>
             </a:r>
             <a:endParaRPr lang="en-US" sz="1000" dirty="0"/>
           </a:p>
@@ -14552,7 +14552,7 @@
                 <a:ea typeface="Courier New" pitchFamily="34" charset="-122"/>
                 <a:cs typeface="Courier New" pitchFamily="34" charset="-120"/>
               </a:rPr>
-              <a:t>  intent 3 · spec 3 · plan 17 · review 3;</a:t>
+              <a:t>  intent 3 · spec 3 · plan 18 · review 3;</a:t>
             </a:r>
             <a:endParaRPr lang="en-US" sz="1000" dirty="0"/>
           </a:p>
@@ -14886,7 +14886,7 @@
                 <a:ea typeface="Courier New" pitchFamily="34" charset="-122"/>
                 <a:cs typeface="Courier New" pitchFamily="34" charset="-120"/>
               </a:rPr>
-              <a:t>2026-10-14T17:26:25.035Z  gate.review.await</a:t>
+              <a:t>2026-10-14T20:18:24.238Z  gate.review.await</a:t>
             </a:r>
             <a:endParaRPr lang="en-US" sz="1000" dirty="0"/>
           </a:p>
@@ -14920,7 +14920,7 @@
                 <a:ea typeface="Courier New" pitchFamily="34" charset="-122"/>
                 <a:cs typeface="Courier New" pitchFamily="34" charset="-120"/>
               </a:rPr>
-              <a:t>  sha256:68f3d1d6f609ae3cfc12ad5fee55a000a6</a:t>
+              <a:t>  sha256:6c914d1d9eb78e477dde5ae396dfb67010</a:t>
             </a:r>
             <a:endParaRPr lang="en-US" sz="1000" dirty="0"/>
           </a:p>
@@ -14937,7 +14937,7 @@
                 <a:ea typeface="Courier New" pitchFamily="34" charset="-122"/>
                 <a:cs typeface="Courier New" pitchFamily="34" charset="-120"/>
               </a:rPr>
-              <a:t>  8a4c368438c5c1ddacd57fe5cd389f [sdlc</a:t>
+              <a:t>  d7985d68d5d091a42889b2b979e686 [sdlc</a:t>
             </a:r>
             <a:endParaRPr lang="en-US" sz="1000" dirty="0"/>
           </a:p>
@@ -14954,7 +14954,7 @@
                 <a:ea typeface="Courier New" pitchFamily="34" charset="-122"/>
                 <a:cs typeface="Courier New" pitchFamily="34" charset="-120"/>
               </a:rPr>
-              <a:t>  0.21.0 · community]</a:t>
+              <a:t>  0.21.1 · community]</a:t>
             </a:r>
             <a:endParaRPr lang="en-US" sz="1000" dirty="0"/>
           </a:p>
@@ -14971,7 +14971,7 @@
                 <a:ea typeface="Courier New" pitchFamily="34" charset="-122"/>
                 <a:cs typeface="Courier New" pitchFamily="34" charset="-120"/>
               </a:rPr>
-              <a:t>2026-10-14T17:26:28.376Z  gate.review.appro</a:t>
+              <a:t>2026-10-14T20:18:27.607Z  gate.review.appro</a:t>
             </a:r>
             <a:endParaRPr lang="en-US" sz="1000" dirty="0"/>
           </a:p>
@@ -15022,7 +15022,7 @@
                 <a:ea typeface="Courier New" pitchFamily="34" charset="-122"/>
                 <a:cs typeface="Courier New" pitchFamily="34" charset="-120"/>
               </a:rPr>
-              <a:t>  [sdlc 0.21.0 · community]</a:t>
+              <a:t>  [sdlc 0.21.1 · community]</a:t>
             </a:r>
             <a:endParaRPr lang="en-US" sz="1000" dirty="0"/>
           </a:p>
@@ -15039,7 +15039,7 @@
                 <a:ea typeface="Courier New" pitchFamily="34" charset="-122"/>
                 <a:cs typeface="Courier New" pitchFamily="34" charset="-120"/>
               </a:rPr>
-              <a:t>2026-10-14T17:26:35.518Z  gate.release.appr</a:t>
+              <a:t>2026-10-14T20:18:34.743Z  gate.release.appr</a:t>
             </a:r>
             <a:endParaRPr lang="en-US" sz="1000" dirty="0"/>
           </a:p>
@@ -15090,7 +15090,7 @@
                 <a:ea typeface="Courier New" pitchFamily="34" charset="-122"/>
                 <a:cs typeface="Courier New" pitchFamily="34" charset="-120"/>
               </a:rPr>
-              <a:t>  release-manager [sdlc 0.21.0 · community]</a:t>
+              <a:t>  release-manager [sdlc 0.21.1 · community]</a:t>
             </a:r>
             <a:endParaRPr lang="en-US" sz="1000" dirty="0"/>
           </a:p>
@@ -16418,7 +16418,7 @@
                 <a:ea typeface="Courier New" pitchFamily="34" charset="-122"/>
                 <a:cs typeface="Courier New" pitchFamily="34" charset="-120"/>
               </a:rPr>
-              <a:t>✓ test (1.1s)</a:t>
+              <a:t>✓ test (1.0s)</a:t>
             </a:r>
             <a:endParaRPr lang="en-US" sz="1000" dirty="0"/>
           </a:p>
@@ -16435,7 +16435,7 @@
                 <a:ea typeface="Courier New" pitchFamily="34" charset="-122"/>
                 <a:cs typeface="Courier New" pitchFamily="34" charset="-120"/>
               </a:rPr>
-              <a:t>✓ ci-green (ci/pipeline_status, 0.5s)</a:t>
+              <a:t>✓ ci-green (ci/pipeline_status, 0.6s)</a:t>
             </a:r>
             <a:endParaRPr lang="en-US" sz="1000" dirty="0"/>
           </a:p>
@@ -16871,7 +16871,7 @@
                 <a:ea typeface="Courier New" pitchFamily="34" charset="-122"/>
                 <a:cs typeface="Courier New" pitchFamily="34" charset="-120"/>
               </a:rPr>
-              <a:t>      "id": "20261014T172731682Z-ci-green-5</a:t>
+              <a:t>      "id": "20261014T201934378Z-ci-green-7</a:t>
             </a:r>
             <a:endParaRPr lang="en-US" sz="1000" dirty="0"/>
           </a:p>
@@ -16888,7 +16888,7 @@
                 <a:ea typeface="Courier New" pitchFamily="34" charset="-122"/>
                 <a:cs typeface="Courier New" pitchFamily="34" charset="-120"/>
               </a:rPr>
-              <a:t>  552ba",</a:t>
+              <a:t>  7a21f",</a:t>
             </a:r>
             <a:endParaRPr lang="en-US" sz="1000" dirty="0"/>
           </a:p>
@@ -17024,7 +17024,7 @@
                 <a:ea typeface="Courier New" pitchFamily="34" charset="-122"/>
                 <a:cs typeface="Courier New" pitchFamily="34" charset="-120"/>
               </a:rPr>
-              <a:t>        "ref": "e27ad9feb0f2d717a3eb584c84b</a:t>
+              <a:t>        "ref": "acb81fcd99955f97414e0c9808e</a:t>
             </a:r>
             <a:endParaRPr lang="en-US" sz="1000" dirty="0"/>
           </a:p>
@@ -17041,7 +17041,7 @@
                 <a:ea typeface="Courier New" pitchFamily="34" charset="-122"/>
                 <a:cs typeface="Courier New" pitchFamily="34" charset="-120"/>
               </a:rPr>
-              <a:t>  eb4b3c4190bb1",</a:t>
+              <a:t>  9305aa686a625",</a:t>
             </a:r>
             <a:endParaRPr lang="en-US" sz="1000" dirty="0"/>
           </a:p>
@@ -27763,7 +27763,7 @@
                 <a:ea typeface="Courier New" pitchFamily="34" charset="-122"/>
                 <a:cs typeface="Courier New" pitchFamily="34" charset="-120"/>
               </a:rPr>
-              <a:t>  sdlc 0.21.0, license: community</a:t>
+              <a:t>  sdlc 0.21.1, license: community</a:t>
             </a:r>
             <a:endParaRPr lang="en-US" sz="1000" dirty="0"/>
           </a:p>

</xml_diff>

<commit_message>
fix: sdlc guide as plain text in a terminal; stage and gate names stay English identifiers (0.21.2)
- sdlc guide prints readable plain text in a person's terminal: headings
  underlined, tables as aligned columns, code indented, no Markdown
  marks. Agent sessions still get Markdown; --markdown forces it; --json
  is unchanged.
- The names of the stages and the gates are not translated: stage titles
  start with the English stage name and its gates ("Plan (intent)"), and
  messages, the report and the built-in guide name the gates as intent,
  spec, plan, verify, qa, review and release.

SDLC-Agent: claude-code
</commit_message>
<xml_diff>
--- a/docs/demo/sdlc-calculator-demo.en.pptx
+++ b/docs/demo/sdlc-calculator-demo.en.pptx
@@ -5112,7 +5112,7 @@
                 <a:ea typeface="Courier New" pitchFamily="34" charset="-122"/>
                 <a:cs typeface="Courier New" pitchFamily="34" charset="-120"/>
               </a:rPr>
-              <a:t>✓ test (1.0s)</a:t>
+              <a:t>✓ test (1.8s)</a:t>
             </a:r>
             <a:endParaRPr lang="en-US" sz="1000" dirty="0"/>
           </a:p>
@@ -6660,7 +6660,7 @@
                 <a:ea typeface="Courier New" pitchFamily="34" charset="-122"/>
                 <a:cs typeface="Courier New" pitchFamily="34" charset="-120"/>
               </a:rPr>
-              <a:t>  code-owner (6c914d1d9eb7)</a:t>
+              <a:t>  code-owner (90f082115905)</a:t>
             </a:r>
             <a:endParaRPr lang="en-US" sz="1000" dirty="0"/>
           </a:p>
@@ -6745,7 +6745,7 @@
                 <a:ea typeface="Courier New" pitchFamily="34" charset="-122"/>
                 <a:cs typeface="Courier New" pitchFamily="34" charset="-120"/>
               </a:rPr>
-              <a:t>  "SDLC-Approval: basic-arithmetic:review:6</a:t>
+              <a:t>  "SDLC-Approval: basic-arithmetic:review:9</a:t>
             </a:r>
             <a:endParaRPr lang="en-US" sz="1000" dirty="0"/>
           </a:p>
@@ -6762,7 +6762,7 @@
                 <a:ea typeface="Courier New" pitchFamily="34" charset="-122"/>
                 <a:cs typeface="Courier New" pitchFamily="34" charset="-120"/>
               </a:rPr>
-              <a:t>  c914d1d9eb7"</a:t>
+              <a:t>  0f082115905"</a:t>
             </a:r>
             <a:endParaRPr lang="en-US" sz="1000" dirty="0"/>
           </a:p>
@@ -7443,7 +7443,7 @@
                 <a:ea typeface="Courier New" pitchFamily="34" charset="-122"/>
                 <a:cs typeface="Courier New" pitchFamily="34" charset="-120"/>
               </a:rPr>
-              <a:t>  release-manager (6c914d1d9eb7)</a:t>
+              <a:t>  release-manager (90f082115905)</a:t>
             </a:r>
             <a:endParaRPr lang="en-US" sz="1000" dirty="0"/>
           </a:p>
@@ -7511,7 +7511,7 @@
                 <a:ea typeface="Courier New" pitchFamily="34" charset="-122"/>
                 <a:cs typeface="Courier New" pitchFamily="34" charset="-120"/>
               </a:rPr>
-              <a:t>  gate" -m "SDLC-Approval: basic-arithmetic:release:6c914d1d9eb7"</a:t>
+              <a:t>  gate" -m "SDLC-Approval: basic-arithmetic:release:90f082115905"</a:t>
             </a:r>
             <a:endParaRPr lang="en-US" sz="1000" dirty="0"/>
           </a:p>
@@ -7794,7 +7794,7 @@
                 <a:ea typeface="Courier New" pitchFamily="34" charset="-122"/>
                 <a:cs typeface="Courier New" pitchFamily="34" charset="-120"/>
               </a:rPr>
-              <a:t>✓ basic-arithmetic/intent alice valid 4129aa86 trailer: missing</a:t>
+              <a:t>✓ basic-arithmetic/intent alice valid 68fc158c trailer: missing</a:t>
             </a:r>
             <a:endParaRPr lang="en-US" sz="1000" dirty="0"/>
           </a:p>
@@ -7811,7 +7811,7 @@
                 <a:ea typeface="Courier New" pitchFamily="34" charset="-122"/>
                 <a:cs typeface="Courier New" pitchFamily="34" charset="-120"/>
               </a:rPr>
-              <a:t>✓ basic-arithmetic/spec alice valid c8de7833 trailer: missing</a:t>
+              <a:t>✓ basic-arithmetic/spec alice valid 86b70b05 trailer: missing</a:t>
             </a:r>
             <a:endParaRPr lang="en-US" sz="1000" dirty="0"/>
           </a:p>
@@ -7828,7 +7828,7 @@
                 <a:ea typeface="Courier New" pitchFamily="34" charset="-122"/>
                 <a:cs typeface="Courier New" pitchFamily="34" charset="-120"/>
               </a:rPr>
-              <a:t>✗ basic-arithmetic/plan bob wrong-signer c8de7833 trailer: missing</a:t>
+              <a:t>✗ basic-arithmetic/plan bob wrong-signer 86b70b05 trailer: missing</a:t>
             </a:r>
             <a:endParaRPr lang="en-US" sz="1000" dirty="0"/>
           </a:p>
@@ -7845,7 +7845,7 @@
                 <a:ea typeface="Courier New" pitchFamily="34" charset="-122"/>
                 <a:cs typeface="Courier New" pitchFamily="34" charset="-120"/>
               </a:rPr>
-              <a:t>✓ basic-arithmetic/review carol valid 3bffe27b trailer: missing</a:t>
+              <a:t>✓ basic-arithmetic/review carol valid 54a2da1f trailer: missing</a:t>
             </a:r>
             <a:endParaRPr lang="en-US" sz="1000" dirty="0"/>
           </a:p>
@@ -7862,7 +7862,7 @@
                 <a:ea typeface="Courier New" pitchFamily="34" charset="-122"/>
                 <a:cs typeface="Courier New" pitchFamily="34" charset="-120"/>
               </a:rPr>
-              <a:t>✓ basic-arithmetic/release alice valid f1bbfdef trailer: missing</a:t>
+              <a:t>✓ basic-arithmetic/release alice valid 7d74f6f0 trailer: missing</a:t>
             </a:r>
             <a:endParaRPr lang="en-US" sz="1000" dirty="0"/>
           </a:p>
@@ -7879,7 +7879,7 @@
                 <a:ea typeface="Courier New" pitchFamily="34" charset="-122"/>
                 <a:cs typeface="Courier New" pitchFamily="34" charset="-120"/>
               </a:rPr>
-              <a:t>✓ openspec/roles.yaml alice@calc.example bootstrap 1ce051cb</a:t>
+              <a:t>✓ openspec/roles.yaml alice@calc.example bootstrap b0556580</a:t>
             </a:r>
             <a:endParaRPr lang="en-US" sz="1000" dirty="0"/>
           </a:p>
@@ -8511,7 +8511,7 @@
                 <a:ea typeface="Courier New" pitchFamily="34" charset="-122"/>
                 <a:cs typeface="Courier New" pitchFamily="34" charset="-120"/>
               </a:rPr>
-              <a:t>  openspec\changes\archive\2026-10-14-basic</a:t>
+              <a:t>  openspec\changes\archive\2026-10-15-basic</a:t>
             </a:r>
             <a:endParaRPr lang="en-US" sz="1000" dirty="0"/>
           </a:p>
@@ -14365,7 +14365,7 @@
                 <a:ea typeface="Courier New" pitchFamily="34" charset="-122"/>
                 <a:cs typeface="Courier New" pitchFamily="34" charset="-120"/>
               </a:rPr>
-              <a:t>  archived) · sdlc 0.21.1, license:</a:t>
+              <a:t>  archived) · sdlc 0.21.2, license:</a:t>
             </a:r>
             <a:endParaRPr lang="en-US" sz="1000" dirty="0"/>
           </a:p>
@@ -14552,7 +14552,7 @@
                 <a:ea typeface="Courier New" pitchFamily="34" charset="-122"/>
                 <a:cs typeface="Courier New" pitchFamily="34" charset="-120"/>
               </a:rPr>
-              <a:t>  intent 3 · spec 3 · plan 18 · review 3;</a:t>
+              <a:t>  intent 3 · spec 3 · plan 17 · review 3;</a:t>
             </a:r>
             <a:endParaRPr lang="en-US" sz="1000" dirty="0"/>
           </a:p>
@@ -14886,7 +14886,7 @@
                 <a:ea typeface="Courier New" pitchFamily="34" charset="-122"/>
                 <a:cs typeface="Courier New" pitchFamily="34" charset="-120"/>
               </a:rPr>
-              <a:t>2026-10-14T20:18:24.238Z  gate.review.await</a:t>
+              <a:t>2026-10-15T13:31:50.558Z  gate.review.await</a:t>
             </a:r>
             <a:endParaRPr lang="en-US" sz="1000" dirty="0"/>
           </a:p>
@@ -14920,7 +14920,7 @@
                 <a:ea typeface="Courier New" pitchFamily="34" charset="-122"/>
                 <a:cs typeface="Courier New" pitchFamily="34" charset="-120"/>
               </a:rPr>
-              <a:t>  sha256:6c914d1d9eb78e477dde5ae396dfb67010</a:t>
+              <a:t>  sha256:90f082115905738bbf88908e8f9bddeb43</a:t>
             </a:r>
             <a:endParaRPr lang="en-US" sz="1000" dirty="0"/>
           </a:p>
@@ -14937,7 +14937,7 @@
                 <a:ea typeface="Courier New" pitchFamily="34" charset="-122"/>
                 <a:cs typeface="Courier New" pitchFamily="34" charset="-120"/>
               </a:rPr>
-              <a:t>  d7985d68d5d091a42889b2b979e686 [sdlc</a:t>
+              <a:t>  7cd3e676da99ba381bb6c7378fe339 [sdlc</a:t>
             </a:r>
             <a:endParaRPr lang="en-US" sz="1000" dirty="0"/>
           </a:p>
@@ -14954,7 +14954,7 @@
                 <a:ea typeface="Courier New" pitchFamily="34" charset="-122"/>
                 <a:cs typeface="Courier New" pitchFamily="34" charset="-120"/>
               </a:rPr>
-              <a:t>  0.21.1 · community]</a:t>
+              <a:t>  0.21.2 · community]</a:t>
             </a:r>
             <a:endParaRPr lang="en-US" sz="1000" dirty="0"/>
           </a:p>
@@ -14971,7 +14971,7 @@
                 <a:ea typeface="Courier New" pitchFamily="34" charset="-122"/>
                 <a:cs typeface="Courier New" pitchFamily="34" charset="-120"/>
               </a:rPr>
-              <a:t>2026-10-14T20:18:27.607Z  gate.review.appro</a:t>
+              <a:t>2026-10-15T13:31:53.746Z  gate.review.appro</a:t>
             </a:r>
             <a:endParaRPr lang="en-US" sz="1000" dirty="0"/>
           </a:p>
@@ -15022,7 +15022,7 @@
                 <a:ea typeface="Courier New" pitchFamily="34" charset="-122"/>
                 <a:cs typeface="Courier New" pitchFamily="34" charset="-120"/>
               </a:rPr>
-              <a:t>  [sdlc 0.21.1 · community]</a:t>
+              <a:t>  [sdlc 0.21.2 · community]</a:t>
             </a:r>
             <a:endParaRPr lang="en-US" sz="1000" dirty="0"/>
           </a:p>
@@ -15039,7 +15039,7 @@
                 <a:ea typeface="Courier New" pitchFamily="34" charset="-122"/>
                 <a:cs typeface="Courier New" pitchFamily="34" charset="-120"/>
               </a:rPr>
-              <a:t>2026-10-14T20:18:34.743Z  gate.release.appr</a:t>
+              <a:t>2026-10-15T13:32:00.709Z  gate.release.appr</a:t>
             </a:r>
             <a:endParaRPr lang="en-US" sz="1000" dirty="0"/>
           </a:p>
@@ -15090,7 +15090,7 @@
                 <a:ea typeface="Courier New" pitchFamily="34" charset="-122"/>
                 <a:cs typeface="Courier New" pitchFamily="34" charset="-120"/>
               </a:rPr>
-              <a:t>  release-manager [sdlc 0.21.1 · community]</a:t>
+              <a:t>  release-manager [sdlc 0.21.2 · community]</a:t>
             </a:r>
             <a:endParaRPr lang="en-US" sz="1000" dirty="0"/>
           </a:p>
@@ -16418,7 +16418,7 @@
                 <a:ea typeface="Courier New" pitchFamily="34" charset="-122"/>
                 <a:cs typeface="Courier New" pitchFamily="34" charset="-120"/>
               </a:rPr>
-              <a:t>✓ test (1.0s)</a:t>
+              <a:t>✓ test (1.3s)</a:t>
             </a:r>
             <a:endParaRPr lang="en-US" sz="1000" dirty="0"/>
           </a:p>
@@ -16435,7 +16435,7 @@
                 <a:ea typeface="Courier New" pitchFamily="34" charset="-122"/>
                 <a:cs typeface="Courier New" pitchFamily="34" charset="-120"/>
               </a:rPr>
-              <a:t>✓ ci-green (ci/pipeline_status, 0.6s)</a:t>
+              <a:t>✓ ci-green (ci/pipeline_status, 0.7s)</a:t>
             </a:r>
             <a:endParaRPr lang="en-US" sz="1000" dirty="0"/>
           </a:p>
@@ -16871,7 +16871,7 @@
                 <a:ea typeface="Courier New" pitchFamily="34" charset="-122"/>
                 <a:cs typeface="Courier New" pitchFamily="34" charset="-120"/>
               </a:rPr>
-              <a:t>      "id": "20261014T201934378Z-ci-green-7</a:t>
+              <a:t>      "id": "20261015T133307841Z-ci-green-a</a:t>
             </a:r>
             <a:endParaRPr lang="en-US" sz="1000" dirty="0"/>
           </a:p>
@@ -16888,7 +16888,7 @@
                 <a:ea typeface="Courier New" pitchFamily="34" charset="-122"/>
                 <a:cs typeface="Courier New" pitchFamily="34" charset="-120"/>
               </a:rPr>
-              <a:t>  7a21f",</a:t>
+              <a:t>  89bdd",</a:t>
             </a:r>
             <a:endParaRPr lang="en-US" sz="1000" dirty="0"/>
           </a:p>
@@ -17024,7 +17024,7 @@
                 <a:ea typeface="Courier New" pitchFamily="34" charset="-122"/>
                 <a:cs typeface="Courier New" pitchFamily="34" charset="-120"/>
               </a:rPr>
-              <a:t>        "ref": "acb81fcd99955f97414e0c9808e</a:t>
+              <a:t>        "ref": "fa0e1a35a96e7955e17570afef7</a:t>
             </a:r>
             <a:endParaRPr lang="en-US" sz="1000" dirty="0"/>
           </a:p>
@@ -17041,7 +17041,7 @@
                 <a:ea typeface="Courier New" pitchFamily="34" charset="-122"/>
                 <a:cs typeface="Courier New" pitchFamily="34" charset="-120"/>
               </a:rPr>
-              <a:t>  9305aa686a625",</a:t>
+              <a:t>  14a335bdfea66",</a:t>
             </a:r>
             <a:endParaRPr lang="en-US" sz="1000" dirty="0"/>
           </a:p>
@@ -27763,7 +27763,7 @@
                 <a:ea typeface="Courier New" pitchFamily="34" charset="-122"/>
                 <a:cs typeface="Courier New" pitchFamily="34" charset="-120"/>
               </a:rPr>
-              <a:t>  sdlc 0.21.1, license: community</a:t>
+              <a:t>  sdlc 0.21.2, license: community</a:t>
             </a:r>
             <a:endParaRPr lang="en-US" sz="1000" dirty="0"/>
           </a:p>
@@ -34554,7 +34554,7 @@
                 <a:ea typeface="Courier New" pitchFamily="34" charset="-122"/>
                 <a:cs typeface="Courier New" pitchFamily="34" charset="-120"/>
               </a:rPr>
-              <a:t>  (308be1b4f21d)</a:t>
+              <a:t>  (2844213e9554)</a:t>
             </a:r>
             <a:endParaRPr lang="en-US" sz="1000" dirty="0"/>
           </a:p>
@@ -34690,7 +34690,7 @@
                 <a:ea typeface="Courier New" pitchFamily="34" charset="-122"/>
                 <a:cs typeface="Courier New" pitchFamily="34" charset="-120"/>
               </a:rPr>
-              <a:t>  308be1b4f21d"</a:t>
+              <a:t>  2844213e9554"</a:t>
             </a:r>
             <a:endParaRPr lang="en-US" sz="1000" dirty="0"/>
           </a:p>

</xml_diff>

<commit_message>
fix: guide tables fit the terminal width (0.21.3)
- A table in sdlc guide fits the terminal: the widest columns are
  narrowed and their cells wrap by words within the column. The width is
  the terminal's, or COLUMNS when the output is not a terminal; output to
  a file or a pipe keeps the natural width.

SDLC-Agent: claude-code
</commit_message>
<xml_diff>
--- a/docs/demo/sdlc-calculator-demo.en.pptx
+++ b/docs/demo/sdlc-calculator-demo.en.pptx
@@ -5112,7 +5112,7 @@
                 <a:ea typeface="Courier New" pitchFamily="34" charset="-122"/>
                 <a:cs typeface="Courier New" pitchFamily="34" charset="-120"/>
               </a:rPr>
-              <a:t>✓ test (1.8s)</a:t>
+              <a:t>✓ test (1.0s)</a:t>
             </a:r>
             <a:endParaRPr lang="en-US" sz="1000" dirty="0"/>
           </a:p>
@@ -5975,7 +5975,7 @@
                 <a:ea typeface="Courier New" pitchFamily="34" charset="-122"/>
                 <a:cs typeface="Courier New" pitchFamily="34" charset="-120"/>
               </a:rPr>
-              <a:t>  Bob Turner (bob): author_cannot_approve —</a:t>
+              <a:t>  Bob Turner (bob): distinct_approvers —</a:t>
             </a:r>
             <a:endParaRPr lang="en-US" sz="1000" dirty="0"/>
           </a:p>
@@ -5992,7 +5992,7 @@
                 <a:ea typeface="Courier New" pitchFamily="34" charset="-122"/>
                 <a:cs typeface="Courier New" pitchFamily="34" charset="-120"/>
               </a:rPr>
-              <a:t>  Bob Turner authored code in this change.;</a:t>
+              <a:t>  Bob Turner already approved the paired</a:t>
             </a:r>
             <a:endParaRPr lang="en-US" sz="1000" dirty="0"/>
           </a:p>
@@ -6009,24 +6009,7 @@
                 <a:ea typeface="Courier New" pitchFamily="34" charset="-122"/>
                 <a:cs typeface="Courier New" pitchFamily="34" charset="-120"/>
               </a:rPr>
-              <a:t>  distinct_approvers — Bob Turner already</a:t>
-            </a:r>
-            <a:endParaRPr lang="en-US" sz="1000" dirty="0"/>
-          </a:p>
-          <a:p>
-            <a:pPr indent="0" marL="0">
-              <a:buNone/>
-            </a:pPr>
-            <a:r>
-              <a:rPr lang="en-US" sz="1000" dirty="0">
-                <a:solidFill>
-                  <a:srgbClr val="E8EEF2"/>
-                </a:solidFill>
-                <a:latin typeface="Courier New" pitchFamily="34" charset="0"/>
-                <a:ea typeface="Courier New" pitchFamily="34" charset="-122"/>
-                <a:cs typeface="Courier New" pitchFamily="34" charset="-120"/>
-              </a:rPr>
-              <a:t>  approved the paired gate plan/review.</a:t>
+              <a:t>  gate plan/review.</a:t>
             </a:r>
             <a:endParaRPr lang="en-US" sz="1000" dirty="0"/>
           </a:p>
@@ -6309,7 +6292,7 @@
                 <a:ea typeface="Courier New" pitchFamily="34" charset="-122"/>
                 <a:cs typeface="Courier New" pitchFamily="34" charset="-120"/>
               </a:rPr>
-              <a:t>Bob Turner authored code in this change.</a:t>
+              <a:t>Bob Turner already approved the paired gate</a:t>
             </a:r>
             <a:endParaRPr lang="en-US" sz="1000" dirty="0"/>
           </a:p>
@@ -6326,24 +6309,7 @@
                 <a:ea typeface="Courier New" pitchFamily="34" charset="-122"/>
                 <a:cs typeface="Courier New" pitchFamily="34" charset="-120"/>
               </a:rPr>
-              <a:t>  Bob Turner already approved the paired</a:t>
-            </a:r>
-            <a:endParaRPr lang="en-US" sz="1000" dirty="0"/>
-          </a:p>
-          <a:p>
-            <a:pPr indent="0" marL="0">
-              <a:buNone/>
-            </a:pPr>
-            <a:r>
-              <a:rPr lang="en-US" sz="1000" dirty="0">
-                <a:solidFill>
-                  <a:srgbClr val="E8EEF2"/>
-                </a:solidFill>
-                <a:latin typeface="Courier New" pitchFamily="34" charset="0"/>
-                <a:ea typeface="Courier New" pitchFamily="34" charset="-122"/>
-                <a:cs typeface="Courier New" pitchFamily="34" charset="-120"/>
-              </a:rPr>
-              <a:t>  gate plan/review.</a:t>
+              <a:t>  plan/review.</a:t>
             </a:r>
             <a:endParaRPr lang="en-US" sz="1000" dirty="0"/>
           </a:p>
@@ -6660,7 +6626,7 @@
                 <a:ea typeface="Courier New" pitchFamily="34" charset="-122"/>
                 <a:cs typeface="Courier New" pitchFamily="34" charset="-120"/>
               </a:rPr>
-              <a:t>  code-owner (90f082115905)</a:t>
+              <a:t>  code-owner (85a91b18d257)</a:t>
             </a:r>
             <a:endParaRPr lang="en-US" sz="1000" dirty="0"/>
           </a:p>
@@ -6745,7 +6711,7 @@
                 <a:ea typeface="Courier New" pitchFamily="34" charset="-122"/>
                 <a:cs typeface="Courier New" pitchFamily="34" charset="-120"/>
               </a:rPr>
-              <a:t>  "SDLC-Approval: basic-arithmetic:review:9</a:t>
+              <a:t>  "SDLC-Approval: basic-arithmetic:review:8</a:t>
             </a:r>
             <a:endParaRPr lang="en-US" sz="1000" dirty="0"/>
           </a:p>
@@ -6762,7 +6728,7 @@
                 <a:ea typeface="Courier New" pitchFamily="34" charset="-122"/>
                 <a:cs typeface="Courier New" pitchFamily="34" charset="-120"/>
               </a:rPr>
-              <a:t>  0f082115905"</a:t>
+              <a:t>  5a91b18d257"</a:t>
             </a:r>
             <a:endParaRPr lang="en-US" sz="1000" dirty="0"/>
           </a:p>
@@ -7443,7 +7409,7 @@
                 <a:ea typeface="Courier New" pitchFamily="34" charset="-122"/>
                 <a:cs typeface="Courier New" pitchFamily="34" charset="-120"/>
               </a:rPr>
-              <a:t>  release-manager (90f082115905)</a:t>
+              <a:t>  release-manager (85a91b18d257)</a:t>
             </a:r>
             <a:endParaRPr lang="en-US" sz="1000" dirty="0"/>
           </a:p>
@@ -7511,7 +7477,7 @@
                 <a:ea typeface="Courier New" pitchFamily="34" charset="-122"/>
                 <a:cs typeface="Courier New" pitchFamily="34" charset="-120"/>
               </a:rPr>
-              <a:t>  gate" -m "SDLC-Approval: basic-arithmetic:release:90f082115905"</a:t>
+              <a:t>  gate" -m "SDLC-Approval: basic-arithmetic:release:85a91b18d257"</a:t>
             </a:r>
             <a:endParaRPr lang="en-US" sz="1000" dirty="0"/>
           </a:p>
@@ -7794,7 +7760,7 @@
                 <a:ea typeface="Courier New" pitchFamily="34" charset="-122"/>
                 <a:cs typeface="Courier New" pitchFamily="34" charset="-120"/>
               </a:rPr>
-              <a:t>✓ basic-arithmetic/intent alice valid 68fc158c trailer: missing</a:t>
+              <a:t>✓ basic-arithmetic/intent alice valid 05413ba9 trailer: missing</a:t>
             </a:r>
             <a:endParaRPr lang="en-US" sz="1000" dirty="0"/>
           </a:p>
@@ -7811,7 +7777,7 @@
                 <a:ea typeface="Courier New" pitchFamily="34" charset="-122"/>
                 <a:cs typeface="Courier New" pitchFamily="34" charset="-120"/>
               </a:rPr>
-              <a:t>✓ basic-arithmetic/spec alice valid 86b70b05 trailer: missing</a:t>
+              <a:t>✓ basic-arithmetic/spec alice valid 1e84e4bf trailer: missing</a:t>
             </a:r>
             <a:endParaRPr lang="en-US" sz="1000" dirty="0"/>
           </a:p>
@@ -7828,7 +7794,7 @@
                 <a:ea typeface="Courier New" pitchFamily="34" charset="-122"/>
                 <a:cs typeface="Courier New" pitchFamily="34" charset="-120"/>
               </a:rPr>
-              <a:t>✗ basic-arithmetic/plan bob wrong-signer 86b70b05 trailer: missing</a:t>
+              <a:t>✗ basic-arithmetic/plan bob wrong-signer 1e84e4bf trailer: missing</a:t>
             </a:r>
             <a:endParaRPr lang="en-US" sz="1000" dirty="0"/>
           </a:p>
@@ -7845,7 +7811,7 @@
                 <a:ea typeface="Courier New" pitchFamily="34" charset="-122"/>
                 <a:cs typeface="Courier New" pitchFamily="34" charset="-120"/>
               </a:rPr>
-              <a:t>✓ basic-arithmetic/review carol valid 54a2da1f trailer: missing</a:t>
+              <a:t>✓ basic-arithmetic/review carol valid ec148dca trailer: missing</a:t>
             </a:r>
             <a:endParaRPr lang="en-US" sz="1000" dirty="0"/>
           </a:p>
@@ -7862,7 +7828,7 @@
                 <a:ea typeface="Courier New" pitchFamily="34" charset="-122"/>
                 <a:cs typeface="Courier New" pitchFamily="34" charset="-120"/>
               </a:rPr>
-              <a:t>✓ basic-arithmetic/release alice valid 7d74f6f0 trailer: missing</a:t>
+              <a:t>✓ basic-arithmetic/release alice valid 239c55a4 trailer: missing</a:t>
             </a:r>
             <a:endParaRPr lang="en-US" sz="1000" dirty="0"/>
           </a:p>
@@ -7879,7 +7845,7 @@
                 <a:ea typeface="Courier New" pitchFamily="34" charset="-122"/>
                 <a:cs typeface="Courier New" pitchFamily="34" charset="-120"/>
               </a:rPr>
-              <a:t>✓ openspec/roles.yaml alice@calc.example bootstrap b0556580</a:t>
+              <a:t>✓ openspec/roles.yaml marin@marin-ai.tech bootstrap a2bc9570</a:t>
             </a:r>
             <a:endParaRPr lang="en-US" sz="1000" dirty="0"/>
           </a:p>
@@ -11366,7 +11332,7 @@
                 <a:ea typeface="Calibri" pitchFamily="34" charset="-122"/>
                 <a:cs typeface="Calibri" pitchFamily="34" charset="-120"/>
               </a:rPr>
-              <a:t>Bob Turner authored code in this change. Bob Turner already approved …</a:t>
+              <a:t>Bob Turner already approved the paired gate plan/review.</a:t>
             </a:r>
             <a:endParaRPr lang="en-US" sz="1100" dirty="0"/>
           </a:p>
@@ -14365,7 +14331,7 @@
                 <a:ea typeface="Courier New" pitchFamily="34" charset="-122"/>
                 <a:cs typeface="Courier New" pitchFamily="34" charset="-120"/>
               </a:rPr>
-              <a:t>  archived) · sdlc 0.21.2, license:</a:t>
+              <a:t>  archived) · sdlc 0.21.3, license:</a:t>
             </a:r>
             <a:endParaRPr lang="en-US" sz="1000" dirty="0"/>
           </a:p>
@@ -14886,7 +14852,7 @@
                 <a:ea typeface="Courier New" pitchFamily="34" charset="-122"/>
                 <a:cs typeface="Courier New" pitchFamily="34" charset="-120"/>
               </a:rPr>
-              <a:t>2026-10-15T13:31:50.558Z  gate.review.await</a:t>
+              <a:t>2026-10-15T17:29:48.480Z  gate.review.await</a:t>
             </a:r>
             <a:endParaRPr lang="en-US" sz="1000" dirty="0"/>
           </a:p>
@@ -14920,7 +14886,7 @@
                 <a:ea typeface="Courier New" pitchFamily="34" charset="-122"/>
                 <a:cs typeface="Courier New" pitchFamily="34" charset="-120"/>
               </a:rPr>
-              <a:t>  sha256:90f082115905738bbf88908e8f9bddeb43</a:t>
+              <a:t>  sha256:85a91b18d25718bc3e1613fa277a1a7d78</a:t>
             </a:r>
             <a:endParaRPr lang="en-US" sz="1000" dirty="0"/>
           </a:p>
@@ -14937,7 +14903,7 @@
                 <a:ea typeface="Courier New" pitchFamily="34" charset="-122"/>
                 <a:cs typeface="Courier New" pitchFamily="34" charset="-120"/>
               </a:rPr>
-              <a:t>  7cd3e676da99ba381bb6c7378fe339 [sdlc</a:t>
+              <a:t>  05c549d49afe5093354cb1e81f92dc [sdlc</a:t>
             </a:r>
             <a:endParaRPr lang="en-US" sz="1000" dirty="0"/>
           </a:p>
@@ -14954,7 +14920,7 @@
                 <a:ea typeface="Courier New" pitchFamily="34" charset="-122"/>
                 <a:cs typeface="Courier New" pitchFamily="34" charset="-120"/>
               </a:rPr>
-              <a:t>  0.21.2 · community]</a:t>
+              <a:t>  0.21.3 · community]</a:t>
             </a:r>
             <a:endParaRPr lang="en-US" sz="1000" dirty="0"/>
           </a:p>
@@ -14971,7 +14937,7 @@
                 <a:ea typeface="Courier New" pitchFamily="34" charset="-122"/>
                 <a:cs typeface="Courier New" pitchFamily="34" charset="-120"/>
               </a:rPr>
-              <a:t>2026-10-15T13:31:53.746Z  gate.review.appro</a:t>
+              <a:t>2026-10-15T17:29:51.894Z  gate.review.appro</a:t>
             </a:r>
             <a:endParaRPr lang="en-US" sz="1000" dirty="0"/>
           </a:p>
@@ -15022,7 +14988,7 @@
                 <a:ea typeface="Courier New" pitchFamily="34" charset="-122"/>
                 <a:cs typeface="Courier New" pitchFamily="34" charset="-120"/>
               </a:rPr>
-              <a:t>  [sdlc 0.21.2 · community]</a:t>
+              <a:t>  [sdlc 0.21.3 · community]</a:t>
             </a:r>
             <a:endParaRPr lang="en-US" sz="1000" dirty="0"/>
           </a:p>
@@ -15039,7 +15005,7 @@
                 <a:ea typeface="Courier New" pitchFamily="34" charset="-122"/>
                 <a:cs typeface="Courier New" pitchFamily="34" charset="-120"/>
               </a:rPr>
-              <a:t>2026-10-15T13:32:00.709Z  gate.release.appr</a:t>
+              <a:t>2026-10-15T17:29:58.541Z  gate.release.appr</a:t>
             </a:r>
             <a:endParaRPr lang="en-US" sz="1000" dirty="0"/>
           </a:p>
@@ -15090,7 +15056,7 @@
                 <a:ea typeface="Courier New" pitchFamily="34" charset="-122"/>
                 <a:cs typeface="Courier New" pitchFamily="34" charset="-120"/>
               </a:rPr>
-              <a:t>  release-manager [sdlc 0.21.2 · community]</a:t>
+              <a:t>  release-manager [sdlc 0.21.3 · community]</a:t>
             </a:r>
             <a:endParaRPr lang="en-US" sz="1000" dirty="0"/>
           </a:p>
@@ -16418,7 +16384,7 @@
                 <a:ea typeface="Courier New" pitchFamily="34" charset="-122"/>
                 <a:cs typeface="Courier New" pitchFamily="34" charset="-120"/>
               </a:rPr>
-              <a:t>✓ test (1.3s)</a:t>
+              <a:t>✓ test (1.1s)</a:t>
             </a:r>
             <a:endParaRPr lang="en-US" sz="1000" dirty="0"/>
           </a:p>
@@ -16435,7 +16401,7 @@
                 <a:ea typeface="Courier New" pitchFamily="34" charset="-122"/>
                 <a:cs typeface="Courier New" pitchFamily="34" charset="-120"/>
               </a:rPr>
-              <a:t>✓ ci-green (ci/pipeline_status, 0.7s)</a:t>
+              <a:t>✓ ci-green (ci/pipeline_status, 0.6s)</a:t>
             </a:r>
             <a:endParaRPr lang="en-US" sz="1000" dirty="0"/>
           </a:p>
@@ -16871,7 +16837,7 @@
                 <a:ea typeface="Courier New" pitchFamily="34" charset="-122"/>
                 <a:cs typeface="Courier New" pitchFamily="34" charset="-120"/>
               </a:rPr>
-              <a:t>      "id": "20261015T133307841Z-ci-green-a</a:t>
+              <a:t>      "id": "20261015T173055421Z-ci-green-0</a:t>
             </a:r>
             <a:endParaRPr lang="en-US" sz="1000" dirty="0"/>
           </a:p>
@@ -16888,7 +16854,7 @@
                 <a:ea typeface="Courier New" pitchFamily="34" charset="-122"/>
                 <a:cs typeface="Courier New" pitchFamily="34" charset="-120"/>
               </a:rPr>
-              <a:t>  89bdd",</a:t>
+              <a:t>  57246",</a:t>
             </a:r>
             <a:endParaRPr lang="en-US" sz="1000" dirty="0"/>
           </a:p>
@@ -17024,7 +16990,7 @@
                 <a:ea typeface="Courier New" pitchFamily="34" charset="-122"/>
                 <a:cs typeface="Courier New" pitchFamily="34" charset="-120"/>
               </a:rPr>
-              <a:t>        "ref": "fa0e1a35a96e7955e17570afef7</a:t>
+              <a:t>        "ref": "89c909bf89d90205254ef2922bd</a:t>
             </a:r>
             <a:endParaRPr lang="en-US" sz="1000" dirty="0"/>
           </a:p>
@@ -17041,7 +17007,7 @@
                 <a:ea typeface="Courier New" pitchFamily="34" charset="-122"/>
                 <a:cs typeface="Courier New" pitchFamily="34" charset="-120"/>
               </a:rPr>
-              <a:t>  14a335bdfea66",</a:t>
+              <a:t>  2a93e6a194b82",</a:t>
             </a:r>
             <a:endParaRPr lang="en-US" sz="1000" dirty="0"/>
           </a:p>
@@ -27763,7 +27729,7 @@
                 <a:ea typeface="Courier New" pitchFamily="34" charset="-122"/>
                 <a:cs typeface="Courier New" pitchFamily="34" charset="-120"/>
               </a:rPr>
-              <a:t>  sdlc 0.21.2, license: community</a:t>
+              <a:t>  sdlc 0.21.3, license: community</a:t>
             </a:r>
             <a:endParaRPr lang="en-US" sz="1000" dirty="0"/>
           </a:p>

</xml_diff>

<commit_message>
fix: open rejections stay visible; the spec gate validates; no verify task cycle (0.22.1)
A greenfield team run found three defects. A qa rejection that sent a change back to build vanished from status and
next: an open rejection now stays on its gate row and its note reaches next until the gate is approved. The spec gate
approved deltas OpenSpec rejects: it now refuses errors and shows warnings, and validate no longer treats warnings as
invalid, so requirements in another language than English pass. The tasks template's "Run sdlc verify" task kept the
verify gate blocked by itself: the template drops it, and a passing verify ticks an old one once the rest is done.

The documentation gains a worked example of a team building an application from scratch.
</commit_message>
<xml_diff>
--- a/docs/demo/sdlc-calculator-demo.en.pptx
+++ b/docs/demo/sdlc-calculator-demo.en.pptx
@@ -6660,7 +6660,7 @@
                 <a:ea typeface="Courier New" pitchFamily="34" charset="-122"/>
                 <a:cs typeface="Courier New" pitchFamily="34" charset="-120"/>
               </a:rPr>
-              <a:t>  code-owner (4d278be092f3)</a:t>
+              <a:t>  code-owner (990501383609)</a:t>
             </a:r>
             <a:endParaRPr lang="en-US" sz="1000" dirty="0"/>
           </a:p>
@@ -6745,7 +6745,7 @@
                 <a:ea typeface="Courier New" pitchFamily="34" charset="-122"/>
                 <a:cs typeface="Courier New" pitchFamily="34" charset="-120"/>
               </a:rPr>
-              <a:t>  "SDLC-Approval: basic-arithmetic:review:4</a:t>
+              <a:t>  "SDLC-Approval: basic-arithmetic:review:9</a:t>
             </a:r>
             <a:endParaRPr lang="en-US" sz="1000" dirty="0"/>
           </a:p>
@@ -6762,7 +6762,7 @@
                 <a:ea typeface="Courier New" pitchFamily="34" charset="-122"/>
                 <a:cs typeface="Courier New" pitchFamily="34" charset="-120"/>
               </a:rPr>
-              <a:t>  d278be092f3"</a:t>
+              <a:t>  90501383609"</a:t>
             </a:r>
             <a:endParaRPr lang="en-US" sz="1000" dirty="0"/>
           </a:p>
@@ -7443,7 +7443,7 @@
                 <a:ea typeface="Courier New" pitchFamily="34" charset="-122"/>
                 <a:cs typeface="Courier New" pitchFamily="34" charset="-120"/>
               </a:rPr>
-              <a:t>  release-manager (4d278be092f3)</a:t>
+              <a:t>  release-manager (990501383609)</a:t>
             </a:r>
             <a:endParaRPr lang="en-US" sz="1000" dirty="0"/>
           </a:p>
@@ -7511,7 +7511,7 @@
                 <a:ea typeface="Courier New" pitchFamily="34" charset="-122"/>
                 <a:cs typeface="Courier New" pitchFamily="34" charset="-120"/>
               </a:rPr>
-              <a:t>  gate" -m "SDLC-Approval: basic-arithmetic:release:4d278be092f3"</a:t>
+              <a:t>  gate" -m "SDLC-Approval: basic-arithmetic:release:990501383609"</a:t>
             </a:r>
             <a:endParaRPr lang="en-US" sz="1000" dirty="0"/>
           </a:p>
@@ -7794,7 +7794,7 @@
                 <a:ea typeface="Courier New" pitchFamily="34" charset="-122"/>
                 <a:cs typeface="Courier New" pitchFamily="34" charset="-120"/>
               </a:rPr>
-              <a:t>✓ basic-arithmetic/intent alice valid 86dd9ebe trailer: missing</a:t>
+              <a:t>✓ basic-arithmetic/intent alice valid 0e4f2e14 trailer: missing</a:t>
             </a:r>
             <a:endParaRPr lang="en-US" sz="1000" dirty="0"/>
           </a:p>
@@ -7811,7 +7811,7 @@
                 <a:ea typeface="Courier New" pitchFamily="34" charset="-122"/>
                 <a:cs typeface="Courier New" pitchFamily="34" charset="-120"/>
               </a:rPr>
-              <a:t>✓ basic-arithmetic/spec alice valid 7acb4b39 trailer: missing</a:t>
+              <a:t>✓ basic-arithmetic/spec alice valid fc28e19b trailer: missing</a:t>
             </a:r>
             <a:endParaRPr lang="en-US" sz="1000" dirty="0"/>
           </a:p>
@@ -7828,7 +7828,7 @@
                 <a:ea typeface="Courier New" pitchFamily="34" charset="-122"/>
                 <a:cs typeface="Courier New" pitchFamily="34" charset="-120"/>
               </a:rPr>
-              <a:t>✗ basic-arithmetic/plan bob wrong-signer 7acb4b39 trailer: missing</a:t>
+              <a:t>✗ basic-arithmetic/plan bob wrong-signer fc28e19b trailer: missing</a:t>
             </a:r>
             <a:endParaRPr lang="en-US" sz="1000" dirty="0"/>
           </a:p>
@@ -7845,7 +7845,7 @@
                 <a:ea typeface="Courier New" pitchFamily="34" charset="-122"/>
                 <a:cs typeface="Courier New" pitchFamily="34" charset="-120"/>
               </a:rPr>
-              <a:t>✓ basic-arithmetic/review carol valid ee117e4c trailer: missing</a:t>
+              <a:t>✓ basic-arithmetic/review carol valid acebc1d1 trailer: missing</a:t>
             </a:r>
             <a:endParaRPr lang="en-US" sz="1000" dirty="0"/>
           </a:p>
@@ -7862,7 +7862,7 @@
                 <a:ea typeface="Courier New" pitchFamily="34" charset="-122"/>
                 <a:cs typeface="Courier New" pitchFamily="34" charset="-120"/>
               </a:rPr>
-              <a:t>✓ basic-arithmetic/release alice valid ecb36c66 trailer: missing</a:t>
+              <a:t>✓ basic-arithmetic/release alice valid a3ee48e3 trailer: missing</a:t>
             </a:r>
             <a:endParaRPr lang="en-US" sz="1000" dirty="0"/>
           </a:p>
@@ -7879,7 +7879,7 @@
                 <a:ea typeface="Courier New" pitchFamily="34" charset="-122"/>
                 <a:cs typeface="Courier New" pitchFamily="34" charset="-120"/>
               </a:rPr>
-              <a:t>✓ openspec/roles.yaml alice@calc.example bootstrap 6adc60f8</a:t>
+              <a:t>✓ openspec/roles.yaml alice@calc.example bootstrap dfe8bfd7</a:t>
             </a:r>
             <a:endParaRPr lang="en-US" sz="1000" dirty="0"/>
           </a:p>
@@ -8511,7 +8511,7 @@
                 <a:ea typeface="Courier New" pitchFamily="34" charset="-122"/>
                 <a:cs typeface="Courier New" pitchFamily="34" charset="-120"/>
               </a:rPr>
-              <a:t>  openspec\changes\archive\2026-10-15-basic</a:t>
+              <a:t>  openspec\changes\archive\2026-10-16-basic</a:t>
             </a:r>
             <a:endParaRPr lang="en-US" sz="1000" dirty="0"/>
           </a:p>
@@ -14365,7 +14365,7 @@
                 <a:ea typeface="Courier New" pitchFamily="34" charset="-122"/>
                 <a:cs typeface="Courier New" pitchFamily="34" charset="-120"/>
               </a:rPr>
-              <a:t>  archived) · sdlc 0.22.0, license:</a:t>
+              <a:t>  archived) · sdlc 0.22.1, license:</a:t>
             </a:r>
             <a:endParaRPr lang="en-US" sz="1000" dirty="0"/>
           </a:p>
@@ -14569,7 +14569,7 @@
                 <a:ea typeface="Courier New" pitchFamily="34" charset="-122"/>
                 <a:cs typeface="Courier New" pitchFamily="34" charset="-120"/>
               </a:rPr>
-              <a:t>  intent 3 · spec 3 · plan 16 · review 3;</a:t>
+              <a:t>  intent 3 · spec 4 · plan 17 · review 3;</a:t>
             </a:r>
             <a:endParaRPr lang="en-US" sz="1000" dirty="0"/>
           </a:p>
@@ -14886,7 +14886,7 @@
                 <a:ea typeface="Courier New" pitchFamily="34" charset="-122"/>
                 <a:cs typeface="Courier New" pitchFamily="34" charset="-120"/>
               </a:rPr>
-              <a:t>2026-10-16T01:45:11.492Z  gate.review.await</a:t>
+              <a:t>2026-10-16T10:44:15.433Z  gate.review.await</a:t>
             </a:r>
             <a:endParaRPr lang="en-US" sz="1000" dirty="0"/>
           </a:p>
@@ -14920,7 +14920,7 @@
                 <a:ea typeface="Courier New" pitchFamily="34" charset="-122"/>
                 <a:cs typeface="Courier New" pitchFamily="34" charset="-120"/>
               </a:rPr>
-              <a:t>  sha256:4d278be092f300aa70e2c69198d892919f</a:t>
+              <a:t>  sha256:990501383609b47bfb85bb3dea911af52c</a:t>
             </a:r>
             <a:endParaRPr lang="en-US" sz="1000" dirty="0"/>
           </a:p>
@@ -14937,7 +14937,7 @@
                 <a:ea typeface="Courier New" pitchFamily="34" charset="-122"/>
                 <a:cs typeface="Courier New" pitchFamily="34" charset="-120"/>
               </a:rPr>
-              <a:t>  24ca5e8bc7551724bba84b57c23af2 [sdlc</a:t>
+              <a:t>  fb8b71b4556739dcd68f393a6c023f [sdlc</a:t>
             </a:r>
             <a:endParaRPr lang="en-US" sz="1000" dirty="0"/>
           </a:p>
@@ -14954,7 +14954,7 @@
                 <a:ea typeface="Courier New" pitchFamily="34" charset="-122"/>
                 <a:cs typeface="Courier New" pitchFamily="34" charset="-120"/>
               </a:rPr>
-              <a:t>  0.22.0 · community]</a:t>
+              <a:t>  0.22.1 · community]</a:t>
             </a:r>
             <a:endParaRPr lang="en-US" sz="1000" dirty="0"/>
           </a:p>
@@ -14971,7 +14971,7 @@
                 <a:ea typeface="Courier New" pitchFamily="34" charset="-122"/>
                 <a:cs typeface="Courier New" pitchFamily="34" charset="-120"/>
               </a:rPr>
-              <a:t>2026-10-16T01:45:14.626Z  gate.review.appro</a:t>
+              <a:t>2026-10-16T10:44:18.600Z  gate.review.appro</a:t>
             </a:r>
             <a:endParaRPr lang="en-US" sz="1000" dirty="0"/>
           </a:p>
@@ -15022,7 +15022,7 @@
                 <a:ea typeface="Courier New" pitchFamily="34" charset="-122"/>
                 <a:cs typeface="Courier New" pitchFamily="34" charset="-120"/>
               </a:rPr>
-              <a:t>  [sdlc 0.22.0 · community]</a:t>
+              <a:t>  [sdlc 0.22.1 · community]</a:t>
             </a:r>
             <a:endParaRPr lang="en-US" sz="1000" dirty="0"/>
           </a:p>
@@ -15039,7 +15039,7 @@
                 <a:ea typeface="Courier New" pitchFamily="34" charset="-122"/>
                 <a:cs typeface="Courier New" pitchFamily="34" charset="-120"/>
               </a:rPr>
-              <a:t>2026-10-16T01:45:21.015Z  gate.release.appr</a:t>
+              <a:t>2026-10-16T10:44:24.994Z  gate.release.appr</a:t>
             </a:r>
             <a:endParaRPr lang="en-US" sz="1000" dirty="0"/>
           </a:p>
@@ -15090,7 +15090,7 @@
                 <a:ea typeface="Courier New" pitchFamily="34" charset="-122"/>
                 <a:cs typeface="Courier New" pitchFamily="34" charset="-120"/>
               </a:rPr>
-              <a:t>  release-manager [sdlc 0.22.0 · community]</a:t>
+              <a:t>  release-manager [sdlc 0.22.1 · community]</a:t>
             </a:r>
             <a:endParaRPr lang="en-US" sz="1000" dirty="0"/>
           </a:p>
@@ -16871,7 +16871,7 @@
                 <a:ea typeface="Courier New" pitchFamily="34" charset="-122"/>
                 <a:cs typeface="Courier New" pitchFamily="34" charset="-120"/>
               </a:rPr>
-              <a:t>      "id": "20261016T014615137Z-ci-green-2</a:t>
+              <a:t>      "id": "20261016T104518290Z-ci-green-1</a:t>
             </a:r>
             <a:endParaRPr lang="en-US" sz="1000" dirty="0"/>
           </a:p>
@@ -16888,7 +16888,7 @@
                 <a:ea typeface="Courier New" pitchFamily="34" charset="-122"/>
                 <a:cs typeface="Courier New" pitchFamily="34" charset="-120"/>
               </a:rPr>
-              <a:t>  1efff",</a:t>
+              <a:t>  a40c4",</a:t>
             </a:r>
             <a:endParaRPr lang="en-US" sz="1000" dirty="0"/>
           </a:p>
@@ -17024,7 +17024,7 @@
                 <a:ea typeface="Courier New" pitchFamily="34" charset="-122"/>
                 <a:cs typeface="Courier New" pitchFamily="34" charset="-120"/>
               </a:rPr>
-              <a:t>        "ref": "0e39097036f5c9332487f564dfe</a:t>
+              <a:t>        "ref": "27eabdd8b83dd62c5953e8f12c7</a:t>
             </a:r>
             <a:endParaRPr lang="en-US" sz="1000" dirty="0"/>
           </a:p>
@@ -17041,7 +17041,7 @@
                 <a:ea typeface="Courier New" pitchFamily="34" charset="-122"/>
                 <a:cs typeface="Courier New" pitchFamily="34" charset="-120"/>
               </a:rPr>
-              <a:t>  32c7552c57b79",</a:t>
+              <a:t>  913aa80a04eff",</a:t>
             </a:r>
             <a:endParaRPr lang="en-US" sz="1000" dirty="0"/>
           </a:p>
@@ -27697,7 +27697,7 @@
                 <a:ea typeface="Courier New" pitchFamily="34" charset="-122"/>
                 <a:cs typeface="Courier New" pitchFamily="34" charset="-120"/>
               </a:rPr>
-              <a:t>  sdlc 0.22.0, license: community</a:t>
+              <a:t>  sdlc 0.22.1, license: community</a:t>
             </a:r>
             <a:endParaRPr lang="en-US" sz="1000" dirty="0"/>
           </a:p>
@@ -34488,7 +34488,7 @@
                 <a:ea typeface="Courier New" pitchFamily="34" charset="-122"/>
                 <a:cs typeface="Courier New" pitchFamily="34" charset="-120"/>
               </a:rPr>
-              <a:t>  (2844213e9554)</a:t>
+              <a:t>  (3f632e3f37b9)</a:t>
             </a:r>
             <a:endParaRPr lang="en-US" sz="1000" dirty="0"/>
           </a:p>
@@ -34624,7 +34624,7 @@
                 <a:ea typeface="Courier New" pitchFamily="34" charset="-122"/>
                 <a:cs typeface="Courier New" pitchFamily="34" charset="-120"/>
               </a:rPr>
-              <a:t>  2844213e9554"</a:t>
+              <a:t>  3f632e3f37b9"</a:t>
             </a:r>
             <a:endParaRPr lang="en-US" sz="1000" dirty="0"/>
           </a:p>

</xml_diff>

<commit_message>
fix: dated people in the adoption draft; lint not run twice; the suggested track in sdlc new (0.22.4)
The smaller findings of adopting a large codebase and running changes on different tracks.

- The adoption draft shows each person's last commit; adopt --apply leaves out people with no commit in 12 months.
- sdlc new prints the track it suggests, why, and the command a person runs.
- Scaffolded documents take the project name from the manifest instead of the folder name.
- init does not add a verify command that pretest or posttest already runs.
- The audit plans the extra approvals of high-risk gates.
</commit_message>
<xml_diff>
--- a/docs/demo/sdlc-calculator-demo.en.pptx
+++ b/docs/demo/sdlc-calculator-demo.en.pptx
@@ -5112,7 +5112,7 @@
                 <a:ea typeface="Courier New" pitchFamily="34" charset="-122"/>
                 <a:cs typeface="Courier New" pitchFamily="34" charset="-120"/>
               </a:rPr>
-              <a:t>✓ test (1.0s)</a:t>
+              <a:t>✓ test (0.9s)</a:t>
             </a:r>
             <a:endParaRPr lang="en-US" sz="1000" dirty="0"/>
           </a:p>
@@ -6677,7 +6677,7 @@
                 <a:ea typeface="Courier New" pitchFamily="34" charset="-122"/>
                 <a:cs typeface="Courier New" pitchFamily="34" charset="-120"/>
               </a:rPr>
-              <a:t>  code-owner (deae0ff3a96f)</a:t>
+              <a:t>  code-owner (3f51023be410)</a:t>
             </a:r>
             <a:endParaRPr lang="en-US" sz="1000" dirty="0"/>
           </a:p>
@@ -6762,7 +6762,7 @@
                 <a:ea typeface="Courier New" pitchFamily="34" charset="-122"/>
                 <a:cs typeface="Courier New" pitchFamily="34" charset="-120"/>
               </a:rPr>
-              <a:t>  "SDLC-Approval: basic-arithmetic:review:d</a:t>
+              <a:t>  "SDLC-Approval: basic-arithmetic:review:3</a:t>
             </a:r>
             <a:endParaRPr lang="en-US" sz="1000" dirty="0"/>
           </a:p>
@@ -6779,7 +6779,7 @@
                 <a:ea typeface="Courier New" pitchFamily="34" charset="-122"/>
                 <a:cs typeface="Courier New" pitchFamily="34" charset="-120"/>
               </a:rPr>
-              <a:t>  eae0ff3a96f"</a:t>
+              <a:t>  f51023be410"</a:t>
             </a:r>
             <a:endParaRPr lang="en-US" sz="1000" dirty="0"/>
           </a:p>
@@ -7460,7 +7460,7 @@
                 <a:ea typeface="Courier New" pitchFamily="34" charset="-122"/>
                 <a:cs typeface="Courier New" pitchFamily="34" charset="-120"/>
               </a:rPr>
-              <a:t>  release-manager (deae0ff3a96f)</a:t>
+              <a:t>  release-manager (3f51023be410)</a:t>
             </a:r>
             <a:endParaRPr lang="en-US" sz="1000" dirty="0"/>
           </a:p>
@@ -7528,7 +7528,7 @@
                 <a:ea typeface="Courier New" pitchFamily="34" charset="-122"/>
                 <a:cs typeface="Courier New" pitchFamily="34" charset="-120"/>
               </a:rPr>
-              <a:t>  gate" -m "SDLC-Approval: basic-arithmetic:release:deae0ff3a96f"</a:t>
+              <a:t>  gate" -m "SDLC-Approval: basic-arithmetic:release:3f51023be410"</a:t>
             </a:r>
             <a:endParaRPr lang="en-US" sz="1000" dirty="0"/>
           </a:p>
@@ -7811,7 +7811,7 @@
                 <a:ea typeface="Courier New" pitchFamily="34" charset="-122"/>
                 <a:cs typeface="Courier New" pitchFamily="34" charset="-120"/>
               </a:rPr>
-              <a:t>✓ basic-arithmetic/intent alice valid 50716b90 trailer: missing</a:t>
+              <a:t>✓ basic-arithmetic/intent alice valid 2cb8d332 trailer: missing</a:t>
             </a:r>
             <a:endParaRPr lang="en-US" sz="1000" dirty="0"/>
           </a:p>
@@ -7828,7 +7828,7 @@
                 <a:ea typeface="Courier New" pitchFamily="34" charset="-122"/>
                 <a:cs typeface="Courier New" pitchFamily="34" charset="-120"/>
               </a:rPr>
-              <a:t>✓ basic-arithmetic/spec alice valid 02c182f4 trailer: missing</a:t>
+              <a:t>✓ basic-arithmetic/spec alice valid 2026497f trailer: missing</a:t>
             </a:r>
             <a:endParaRPr lang="en-US" sz="1000" dirty="0"/>
           </a:p>
@@ -7845,7 +7845,7 @@
                 <a:ea typeface="Courier New" pitchFamily="34" charset="-122"/>
                 <a:cs typeface="Courier New" pitchFamily="34" charset="-120"/>
               </a:rPr>
-              <a:t>✗ basic-arithmetic/plan bob wrong-signer 02c182f4 trailer: missing</a:t>
+              <a:t>✗ basic-arithmetic/plan bob wrong-signer 2026497f trailer: missing</a:t>
             </a:r>
             <a:endParaRPr lang="en-US" sz="1000" dirty="0"/>
           </a:p>
@@ -7862,7 +7862,7 @@
                 <a:ea typeface="Courier New" pitchFamily="34" charset="-122"/>
                 <a:cs typeface="Courier New" pitchFamily="34" charset="-120"/>
               </a:rPr>
-              <a:t>✓ basic-arithmetic/review carol valid 56b2bf8a trailer: missing</a:t>
+              <a:t>✓ basic-arithmetic/review carol valid 88b9c180 trailer: missing</a:t>
             </a:r>
             <a:endParaRPr lang="en-US" sz="1000" dirty="0"/>
           </a:p>
@@ -7879,7 +7879,7 @@
                 <a:ea typeface="Courier New" pitchFamily="34" charset="-122"/>
                 <a:cs typeface="Courier New" pitchFamily="34" charset="-120"/>
               </a:rPr>
-              <a:t>✓ basic-arithmetic/release alice valid 9d6cbcbf trailer: missing</a:t>
+              <a:t>✓ basic-arithmetic/release alice valid 33fa2d0e trailer: missing</a:t>
             </a:r>
             <a:endParaRPr lang="en-US" sz="1000" dirty="0"/>
           </a:p>
@@ -7896,7 +7896,7 @@
                 <a:ea typeface="Courier New" pitchFamily="34" charset="-122"/>
                 <a:cs typeface="Courier New" pitchFamily="34" charset="-120"/>
               </a:rPr>
-              <a:t>✓ openspec/roles.yaml alice@calc.example bootstrap 46bb5cd9</a:t>
+              <a:t>✓ openspec/roles.yaml alice@calc.example bootstrap 05189252</a:t>
             </a:r>
             <a:endParaRPr lang="en-US" sz="1000" dirty="0"/>
           </a:p>
@@ -8528,7 +8528,7 @@
                 <a:ea typeface="Courier New" pitchFamily="34" charset="-122"/>
                 <a:cs typeface="Courier New" pitchFamily="34" charset="-120"/>
               </a:rPr>
-              <a:t>  openspec\changes\archive\2026-10-16-basic</a:t>
+              <a:t>  openspec\changes\archive\2026-10-17-basic</a:t>
             </a:r>
             <a:endParaRPr lang="en-US" sz="1000" dirty="0"/>
           </a:p>
@@ -14382,7 +14382,7 @@
                 <a:ea typeface="Courier New" pitchFamily="34" charset="-122"/>
                 <a:cs typeface="Courier New" pitchFamily="34" charset="-120"/>
               </a:rPr>
-              <a:t>  archived) · sdlc 0.22.3, license:</a:t>
+              <a:t>  archived) · sdlc 0.22.4, license:</a:t>
             </a:r>
             <a:endParaRPr lang="en-US" sz="1000" dirty="0"/>
           </a:p>
@@ -14586,7 +14586,7 @@
                 <a:ea typeface="Courier New" pitchFamily="34" charset="-122"/>
                 <a:cs typeface="Courier New" pitchFamily="34" charset="-120"/>
               </a:rPr>
-              <a:t>  intent 3 · spec 4 · plan 17 · review 3;</a:t>
+              <a:t>  intent 3 · spec 4 · plan 16 · review 3;</a:t>
             </a:r>
             <a:endParaRPr lang="en-US" sz="1000" dirty="0"/>
           </a:p>
@@ -14903,7 +14903,7 @@
                 <a:ea typeface="Courier New" pitchFamily="34" charset="-122"/>
                 <a:cs typeface="Courier New" pitchFamily="34" charset="-120"/>
               </a:rPr>
-              <a:t>2026-10-17T01:42:20.093Z  gate.review.await</a:t>
+              <a:t>2026-10-17T07:50:34.581Z  gate.review.await</a:t>
             </a:r>
             <a:endParaRPr lang="en-US" sz="1000" dirty="0"/>
           </a:p>
@@ -14937,7 +14937,7 @@
                 <a:ea typeface="Courier New" pitchFamily="34" charset="-122"/>
                 <a:cs typeface="Courier New" pitchFamily="34" charset="-120"/>
               </a:rPr>
-              <a:t>  sha256:deae0ff3a96f174c6b0ad43a6d4536bc08</a:t>
+              <a:t>  sha256:3f51023be410c73488a732b3e04c954571</a:t>
             </a:r>
             <a:endParaRPr lang="en-US" sz="1000" dirty="0"/>
           </a:p>
@@ -14954,7 +14954,7 @@
                 <a:ea typeface="Courier New" pitchFamily="34" charset="-122"/>
                 <a:cs typeface="Courier New" pitchFamily="34" charset="-120"/>
               </a:rPr>
-              <a:t>  e797af8429c7f3d31eab554e3f8cd4 [sdlc</a:t>
+              <a:t>  701e4a1a7eced8a2873305cb36a9df [sdlc</a:t>
             </a:r>
             <a:endParaRPr lang="en-US" sz="1000" dirty="0"/>
           </a:p>
@@ -14971,7 +14971,7 @@
                 <a:ea typeface="Courier New" pitchFamily="34" charset="-122"/>
                 <a:cs typeface="Courier New" pitchFamily="34" charset="-120"/>
               </a:rPr>
-              <a:t>  0.22.3 · community]</a:t>
+              <a:t>  0.22.4 · community]</a:t>
             </a:r>
             <a:endParaRPr lang="en-US" sz="1000" dirty="0"/>
           </a:p>
@@ -14988,7 +14988,7 @@
                 <a:ea typeface="Courier New" pitchFamily="34" charset="-122"/>
                 <a:cs typeface="Courier New" pitchFamily="34" charset="-120"/>
               </a:rPr>
-              <a:t>2026-10-17T01:42:23.191Z  gate.review.appro</a:t>
+              <a:t>2026-10-17T07:50:37.614Z  gate.review.appro</a:t>
             </a:r>
             <a:endParaRPr lang="en-US" sz="1000" dirty="0"/>
           </a:p>
@@ -15039,7 +15039,7 @@
                 <a:ea typeface="Courier New" pitchFamily="34" charset="-122"/>
                 <a:cs typeface="Courier New" pitchFamily="34" charset="-120"/>
               </a:rPr>
-              <a:t>  [sdlc 0.22.3 · community]</a:t>
+              <a:t>  [sdlc 0.22.4 · community]</a:t>
             </a:r>
             <a:endParaRPr lang="en-US" sz="1000" dirty="0"/>
           </a:p>
@@ -15056,7 +15056,7 @@
                 <a:ea typeface="Courier New" pitchFamily="34" charset="-122"/>
                 <a:cs typeface="Courier New" pitchFamily="34" charset="-120"/>
               </a:rPr>
-              <a:t>2026-10-17T01:42:29.391Z  gate.release.appr</a:t>
+              <a:t>2026-10-17T07:50:43.926Z  gate.release.appr</a:t>
             </a:r>
             <a:endParaRPr lang="en-US" sz="1000" dirty="0"/>
           </a:p>
@@ -15107,7 +15107,7 @@
                 <a:ea typeface="Courier New" pitchFamily="34" charset="-122"/>
                 <a:cs typeface="Courier New" pitchFamily="34" charset="-120"/>
               </a:rPr>
-              <a:t>  release-manager [sdlc 0.22.3 · community]</a:t>
+              <a:t>  release-manager [sdlc 0.22.4 · community]</a:t>
             </a:r>
             <a:endParaRPr lang="en-US" sz="1000" dirty="0"/>
           </a:p>
@@ -16888,7 +16888,7 @@
                 <a:ea typeface="Courier New" pitchFamily="34" charset="-122"/>
                 <a:cs typeface="Courier New" pitchFamily="34" charset="-120"/>
               </a:rPr>
-              <a:t>      "id": "20261017T014326118Z-ci-green-4</a:t>
+              <a:t>      "id": "20261017T075139262Z-ci-green-a</a:t>
             </a:r>
             <a:endParaRPr lang="en-US" sz="1000" dirty="0"/>
           </a:p>
@@ -16905,7 +16905,7 @@
                 <a:ea typeface="Courier New" pitchFamily="34" charset="-122"/>
                 <a:cs typeface="Courier New" pitchFamily="34" charset="-120"/>
               </a:rPr>
-              <a:t>  729dc",</a:t>
+              <a:t>  1cde1",</a:t>
             </a:r>
             <a:endParaRPr lang="en-US" sz="1000" dirty="0"/>
           </a:p>
@@ -17041,7 +17041,7 @@
                 <a:ea typeface="Courier New" pitchFamily="34" charset="-122"/>
                 <a:cs typeface="Courier New" pitchFamily="34" charset="-120"/>
               </a:rPr>
-              <a:t>        "ref": "a9f6de164e96ab0ec0a1cddd002</a:t>
+              <a:t>        "ref": "700eaf8edbe2437631b97746f0a</a:t>
             </a:r>
             <a:endParaRPr lang="en-US" sz="1000" dirty="0"/>
           </a:p>
@@ -17058,7 +17058,7 @@
                 <a:ea typeface="Courier New" pitchFamily="34" charset="-122"/>
                 <a:cs typeface="Courier New" pitchFamily="34" charset="-120"/>
               </a:rPr>
-              <a:t>  ec9a9f7d7cdb8",</a:t>
+              <a:t>  d4bfe417c78ed",</a:t>
             </a:r>
             <a:endParaRPr lang="en-US" sz="1000" dirty="0"/>
           </a:p>
@@ -27648,7 +27648,7 @@
                 <a:ea typeface="Courier New" pitchFamily="34" charset="-122"/>
                 <a:cs typeface="Courier New" pitchFamily="34" charset="-120"/>
               </a:rPr>
-              <a:t>  sdlc 0.22.3, license: community</a:t>
+              <a:t>  sdlc 0.22.4, license: community</a:t>
             </a:r>
             <a:endParaRPr lang="en-US" sz="1000" dirty="0"/>
           </a:p>
@@ -34439,7 +34439,7 @@
                 <a:ea typeface="Courier New" pitchFamily="34" charset="-122"/>
                 <a:cs typeface="Courier New" pitchFamily="34" charset="-120"/>
               </a:rPr>
-              <a:t>  (3f632e3f37b9)</a:t>
+              <a:t>  (b6d7eb14bb6b)</a:t>
             </a:r>
             <a:endParaRPr lang="en-US" sz="1000" dirty="0"/>
           </a:p>
@@ -34575,7 +34575,7 @@
                 <a:ea typeface="Courier New" pitchFamily="34" charset="-122"/>
                 <a:cs typeface="Courier New" pitchFamily="34" charset="-120"/>
               </a:rPr>
-              <a:t>  3f632e3f37b9"</a:t>
+              <a:t>  b6d7eb14bb6b"</a:t>
             </a:r>
             <a:endParaRPr lang="en-US" sz="1000" dirty="0"/>
           </a:p>

</xml_diff>

<commit_message>
feat: settings changes by proposal: propose, show, apply (0.23.0)
The process files are protected, so an agent could only describe a settings change and a person retyped it by hand,
unchecked. A proposal makes it a reviewed, recorded decision.

- sdlc config propose --set <key>=<value> --reason (or --file, --target roles) validates the result with the CLI's
  parser and stores it against the file as it is; the file does not change. Agents may propose.
- sdlc config show lists proposals or shows the diff, the validation and the warnings when a proposal weakens the
  process.
- sdlc config apply and dismiss are a person's decisions (a maintainer with roles.yaml); a weakening needs --yes, and a
  proposal made before the file changed is stale.
- The sdlc-config workflow proposes and explains; the health and adoption workflows use it.
- A shorter README; the CLI and file reference moved to the guide.
</commit_message>
<xml_diff>
--- a/docs/demo/sdlc-calculator-demo.en.pptx
+++ b/docs/demo/sdlc-calculator-demo.en.pptx
@@ -5112,7 +5112,7 @@
                 <a:ea typeface="Courier New" pitchFamily="34" charset="-122"/>
                 <a:cs typeface="Courier New" pitchFamily="34" charset="-120"/>
               </a:rPr>
-              <a:t>✓ test (0.9s)</a:t>
+              <a:t>✓ test (1.0s)</a:t>
             </a:r>
             <a:endParaRPr lang="en-US" sz="1000" dirty="0"/>
           </a:p>
@@ -6677,7 +6677,7 @@
                 <a:ea typeface="Courier New" pitchFamily="34" charset="-122"/>
                 <a:cs typeface="Courier New" pitchFamily="34" charset="-120"/>
               </a:rPr>
-              <a:t>  code-owner (3f51023be410)</a:t>
+              <a:t>  code-owner (e6ae90721f15)</a:t>
             </a:r>
             <a:endParaRPr lang="en-US" sz="1000" dirty="0"/>
           </a:p>
@@ -6762,7 +6762,7 @@
                 <a:ea typeface="Courier New" pitchFamily="34" charset="-122"/>
                 <a:cs typeface="Courier New" pitchFamily="34" charset="-120"/>
               </a:rPr>
-              <a:t>  "SDLC-Approval: basic-arithmetic:review:3</a:t>
+              <a:t>  "SDLC-Approval: basic-arithmetic:review:e</a:t>
             </a:r>
             <a:endParaRPr lang="en-US" sz="1000" dirty="0"/>
           </a:p>
@@ -6779,7 +6779,7 @@
                 <a:ea typeface="Courier New" pitchFamily="34" charset="-122"/>
                 <a:cs typeface="Courier New" pitchFamily="34" charset="-120"/>
               </a:rPr>
-              <a:t>  f51023be410"</a:t>
+              <a:t>  6ae90721f15"</a:t>
             </a:r>
             <a:endParaRPr lang="en-US" sz="1000" dirty="0"/>
           </a:p>
@@ -7460,7 +7460,7 @@
                 <a:ea typeface="Courier New" pitchFamily="34" charset="-122"/>
                 <a:cs typeface="Courier New" pitchFamily="34" charset="-120"/>
               </a:rPr>
-              <a:t>  release-manager (3f51023be410)</a:t>
+              <a:t>  release-manager (e6ae90721f15)</a:t>
             </a:r>
             <a:endParaRPr lang="en-US" sz="1000" dirty="0"/>
           </a:p>
@@ -7528,7 +7528,7 @@
                 <a:ea typeface="Courier New" pitchFamily="34" charset="-122"/>
                 <a:cs typeface="Courier New" pitchFamily="34" charset="-120"/>
               </a:rPr>
-              <a:t>  gate" -m "SDLC-Approval: basic-arithmetic:release:3f51023be410"</a:t>
+              <a:t>  gate" -m "SDLC-Approval: basic-arithmetic:release:e6ae90721f15"</a:t>
             </a:r>
             <a:endParaRPr lang="en-US" sz="1000" dirty="0"/>
           </a:p>
@@ -7811,7 +7811,7 @@
                 <a:ea typeface="Courier New" pitchFamily="34" charset="-122"/>
                 <a:cs typeface="Courier New" pitchFamily="34" charset="-120"/>
               </a:rPr>
-              <a:t>✓ basic-arithmetic/intent alice valid 2cb8d332 trailer: missing</a:t>
+              <a:t>✓ basic-arithmetic/intent alice valid 718a76ed trailer: missing</a:t>
             </a:r>
             <a:endParaRPr lang="en-US" sz="1000" dirty="0"/>
           </a:p>
@@ -7828,7 +7828,7 @@
                 <a:ea typeface="Courier New" pitchFamily="34" charset="-122"/>
                 <a:cs typeface="Courier New" pitchFamily="34" charset="-120"/>
               </a:rPr>
-              <a:t>✓ basic-arithmetic/spec alice valid 2026497f trailer: missing</a:t>
+              <a:t>✓ basic-arithmetic/spec alice valid 07d07c3d trailer: missing</a:t>
             </a:r>
             <a:endParaRPr lang="en-US" sz="1000" dirty="0"/>
           </a:p>
@@ -7845,7 +7845,7 @@
                 <a:ea typeface="Courier New" pitchFamily="34" charset="-122"/>
                 <a:cs typeface="Courier New" pitchFamily="34" charset="-120"/>
               </a:rPr>
-              <a:t>✗ basic-arithmetic/plan bob wrong-signer 2026497f trailer: missing</a:t>
+              <a:t>✗ basic-arithmetic/plan bob wrong-signer 07d07c3d trailer: missing</a:t>
             </a:r>
             <a:endParaRPr lang="en-US" sz="1000" dirty="0"/>
           </a:p>
@@ -7862,7 +7862,7 @@
                 <a:ea typeface="Courier New" pitchFamily="34" charset="-122"/>
                 <a:cs typeface="Courier New" pitchFamily="34" charset="-120"/>
               </a:rPr>
-              <a:t>✓ basic-arithmetic/review carol valid 88b9c180 trailer: missing</a:t>
+              <a:t>✓ basic-arithmetic/review carol valid 206d8b9e trailer: missing</a:t>
             </a:r>
             <a:endParaRPr lang="en-US" sz="1000" dirty="0"/>
           </a:p>
@@ -7879,7 +7879,7 @@
                 <a:ea typeface="Courier New" pitchFamily="34" charset="-122"/>
                 <a:cs typeface="Courier New" pitchFamily="34" charset="-120"/>
               </a:rPr>
-              <a:t>✓ basic-arithmetic/release alice valid 33fa2d0e trailer: missing</a:t>
+              <a:t>✓ basic-arithmetic/release alice valid 0ef43b5c trailer: missing</a:t>
             </a:r>
             <a:endParaRPr lang="en-US" sz="1000" dirty="0"/>
           </a:p>
@@ -7896,7 +7896,7 @@
                 <a:ea typeface="Courier New" pitchFamily="34" charset="-122"/>
                 <a:cs typeface="Courier New" pitchFamily="34" charset="-120"/>
               </a:rPr>
-              <a:t>✓ openspec/roles.yaml alice@calc.example bootstrap 05189252</a:t>
+              <a:t>✓ openspec/roles.yaml alice@calc.example bootstrap c3169312</a:t>
             </a:r>
             <a:endParaRPr lang="en-US" sz="1000" dirty="0"/>
           </a:p>
@@ -14382,7 +14382,7 @@
                 <a:ea typeface="Courier New" pitchFamily="34" charset="-122"/>
                 <a:cs typeface="Courier New" pitchFamily="34" charset="-120"/>
               </a:rPr>
-              <a:t>  archived) · sdlc 0.22.4, license:</a:t>
+              <a:t>  archived) · sdlc 0.23.0, license:</a:t>
             </a:r>
             <a:endParaRPr lang="en-US" sz="1000" dirty="0"/>
           </a:p>
@@ -14552,7 +14552,7 @@
                 <a:ea typeface="Courier New" pitchFamily="34" charset="-122"/>
                 <a:cs typeface="Courier New" pitchFamily="34" charset="-120"/>
               </a:rPr>
-              <a:t>  agent log events: 31 of 61</a:t>
+              <a:t>  agent log events: 33 of 65</a:t>
             </a:r>
             <a:endParaRPr lang="en-US" sz="1000" dirty="0"/>
           </a:p>
@@ -14586,7 +14586,7 @@
                 <a:ea typeface="Courier New" pitchFamily="34" charset="-122"/>
                 <a:cs typeface="Courier New" pitchFamily="34" charset="-120"/>
               </a:rPr>
-              <a:t>  intent 3 · spec 4 · plan 16 · review 3;</a:t>
+              <a:t>  intent 3 · spec 4 · plan 17 · review 3;</a:t>
             </a:r>
             <a:endParaRPr lang="en-US" sz="1000" dirty="0"/>
           </a:p>
@@ -14869,7 +14869,7 @@
                 <a:ea typeface="Courier New" pitchFamily="34" charset="-122"/>
                 <a:cs typeface="Courier New" pitchFamily="34" charset="-120"/>
               </a:rPr>
-              <a:t>(last 15 of 61 entries; --limit to see</a:t>
+              <a:t>(last 15 of 65 entries; --limit to see</a:t>
             </a:r>
             <a:endParaRPr lang="en-US" sz="1000" dirty="0"/>
           </a:p>
@@ -14903,7 +14903,7 @@
                 <a:ea typeface="Courier New" pitchFamily="34" charset="-122"/>
                 <a:cs typeface="Courier New" pitchFamily="34" charset="-120"/>
               </a:rPr>
-              <a:t>2026-10-17T07:50:34.581Z  gate.review.await</a:t>
+              <a:t>2026-10-17T12:05:52.719Z  gate.review.await</a:t>
             </a:r>
             <a:endParaRPr lang="en-US" sz="1000" dirty="0"/>
           </a:p>
@@ -14937,7 +14937,7 @@
                 <a:ea typeface="Courier New" pitchFamily="34" charset="-122"/>
                 <a:cs typeface="Courier New" pitchFamily="34" charset="-120"/>
               </a:rPr>
-              <a:t>  sha256:3f51023be410c73488a732b3e04c954571</a:t>
+              <a:t>  sha256:e6ae90721f1568fc9534a6ac07557f1f70</a:t>
             </a:r>
             <a:endParaRPr lang="en-US" sz="1000" dirty="0"/>
           </a:p>
@@ -14954,7 +14954,7 @@
                 <a:ea typeface="Courier New" pitchFamily="34" charset="-122"/>
                 <a:cs typeface="Courier New" pitchFamily="34" charset="-120"/>
               </a:rPr>
-              <a:t>  701e4a1a7eced8a2873305cb36a9df [sdlc</a:t>
+              <a:t>  25fa920d7654a7a7356febf480dede [sdlc</a:t>
             </a:r>
             <a:endParaRPr lang="en-US" sz="1000" dirty="0"/>
           </a:p>
@@ -14971,7 +14971,7 @@
                 <a:ea typeface="Courier New" pitchFamily="34" charset="-122"/>
                 <a:cs typeface="Courier New" pitchFamily="34" charset="-120"/>
               </a:rPr>
-              <a:t>  0.22.4 · community]</a:t>
+              <a:t>  0.23.0 · community]</a:t>
             </a:r>
             <a:endParaRPr lang="en-US" sz="1000" dirty="0"/>
           </a:p>
@@ -14988,7 +14988,7 @@
                 <a:ea typeface="Courier New" pitchFamily="34" charset="-122"/>
                 <a:cs typeface="Courier New" pitchFamily="34" charset="-120"/>
               </a:rPr>
-              <a:t>2026-10-17T07:50:37.614Z  gate.review.appro</a:t>
+              <a:t>2026-10-17T12:05:55.671Z  gate.review.appro</a:t>
             </a:r>
             <a:endParaRPr lang="en-US" sz="1000" dirty="0"/>
           </a:p>
@@ -15039,7 +15039,7 @@
                 <a:ea typeface="Courier New" pitchFamily="34" charset="-122"/>
                 <a:cs typeface="Courier New" pitchFamily="34" charset="-120"/>
               </a:rPr>
-              <a:t>  [sdlc 0.22.4 · community]</a:t>
+              <a:t>  [sdlc 0.23.0 · community]</a:t>
             </a:r>
             <a:endParaRPr lang="en-US" sz="1000" dirty="0"/>
           </a:p>
@@ -15056,7 +15056,7 @@
                 <a:ea typeface="Courier New" pitchFamily="34" charset="-122"/>
                 <a:cs typeface="Courier New" pitchFamily="34" charset="-120"/>
               </a:rPr>
-              <a:t>2026-10-17T07:50:43.926Z  gate.release.appr</a:t>
+              <a:t>2026-10-17T12:06:02.095Z  gate.release.appr</a:t>
             </a:r>
             <a:endParaRPr lang="en-US" sz="1000" dirty="0"/>
           </a:p>
@@ -15107,7 +15107,7 @@
                 <a:ea typeface="Courier New" pitchFamily="34" charset="-122"/>
                 <a:cs typeface="Courier New" pitchFamily="34" charset="-120"/>
               </a:rPr>
-              <a:t>  release-manager [sdlc 0.22.4 · community]</a:t>
+              <a:t>  release-manager [sdlc 0.23.0 · community]</a:t>
             </a:r>
             <a:endParaRPr lang="en-US" sz="1000" dirty="0"/>
           </a:p>
@@ -16452,7 +16452,7 @@
                 <a:ea typeface="Courier New" pitchFamily="34" charset="-122"/>
                 <a:cs typeface="Courier New" pitchFamily="34" charset="-120"/>
               </a:rPr>
-              <a:t>✓ ci-green (ci/pipeline_status, 0.5s)</a:t>
+              <a:t>✓ ci-green (ci/pipeline_status, 0.7s)</a:t>
             </a:r>
             <a:endParaRPr lang="en-US" sz="1000" dirty="0"/>
           </a:p>
@@ -16888,7 +16888,7 @@
                 <a:ea typeface="Courier New" pitchFamily="34" charset="-122"/>
                 <a:cs typeface="Courier New" pitchFamily="34" charset="-120"/>
               </a:rPr>
-              <a:t>      "id": "20261017T075139262Z-ci-green-a</a:t>
+              <a:t>      "id": "20261017T120700861Z-ci-green-8</a:t>
             </a:r>
             <a:endParaRPr lang="en-US" sz="1000" dirty="0"/>
           </a:p>
@@ -16905,7 +16905,7 @@
                 <a:ea typeface="Courier New" pitchFamily="34" charset="-122"/>
                 <a:cs typeface="Courier New" pitchFamily="34" charset="-120"/>
               </a:rPr>
-              <a:t>  1cde1",</a:t>
+              <a:t>  6278b",</a:t>
             </a:r>
             <a:endParaRPr lang="en-US" sz="1000" dirty="0"/>
           </a:p>
@@ -17041,7 +17041,7 @@
                 <a:ea typeface="Courier New" pitchFamily="34" charset="-122"/>
                 <a:cs typeface="Courier New" pitchFamily="34" charset="-120"/>
               </a:rPr>
-              <a:t>        "ref": "700eaf8edbe2437631b97746f0a</a:t>
+              <a:t>        "ref": "a8d15a6aac9869e504b3773bc7e</a:t>
             </a:r>
             <a:endParaRPr lang="en-US" sz="1000" dirty="0"/>
           </a:p>
@@ -17058,7 +17058,7 @@
                 <a:ea typeface="Courier New" pitchFamily="34" charset="-122"/>
                 <a:cs typeface="Courier New" pitchFamily="34" charset="-120"/>
               </a:rPr>
-              <a:t>  d4bfe417c78ed",</a:t>
+              <a:t>  9ad692d73c039",</a:t>
             </a:r>
             <a:endParaRPr lang="en-US" sz="1000" dirty="0"/>
           </a:p>
@@ -19632,7 +19632,7 @@
                 <a:ea typeface="Cambria" pitchFamily="34" charset="-122"/>
                 <a:cs typeface="Cambria" pitchFamily="34" charset="-120"/>
               </a:rPr>
-              <a:t>131</a:t>
+              <a:t>136</a:t>
             </a:r>
             <a:endParaRPr lang="en-US" sz="6000" dirty="0"/>
           </a:p>
@@ -19737,7 +19737,7 @@
                 <a:ea typeface="Cambria" pitchFamily="34" charset="-122"/>
                 <a:cs typeface="Cambria" pitchFamily="34" charset="-120"/>
               </a:rPr>
-              <a:t>92</a:t>
+              <a:t>96</a:t>
             </a:r>
             <a:endParaRPr lang="en-US" sz="6000" dirty="0"/>
           </a:p>
@@ -19776,7 +19776,7 @@
                 <a:ea typeface="Calibri" pitchFamily="34" charset="-122"/>
                 <a:cs typeface="Calibri" pitchFamily="34" charset="-120"/>
               </a:rPr>
-              <a:t>of 92 commands</a:t>
+              <a:t>of 96 commands</a:t>
             </a:r>
             <a:endParaRPr lang="en-US" sz="1600" dirty="0"/>
           </a:p>
@@ -20067,7 +20067,7 @@
         <p:spPr>
           <a:xfrm>
             <a:off x="1098296" y="3749040"/>
-            <a:ext cx="945896" cy="256032"/>
+            <a:ext cx="1144016" cy="256032"/>
           </a:xfrm>
           <a:prstGeom prst="roundRect">
             <a:avLst>
@@ -20094,7 +20094,7 @@
         <p:spPr>
           <a:xfrm>
             <a:off x="1098296" y="3749040"/>
-            <a:ext cx="945896" cy="256032"/>
+            <a:ext cx="1144016" cy="256032"/>
           </a:xfrm>
           <a:prstGeom prst="rect">
             <a:avLst/>
@@ -20118,7 +20118,7 @@
                 <a:ea typeface="Calibri" pitchFamily="34" charset="-122"/>
                 <a:cs typeface="Calibri" pitchFamily="34" charset="-120"/>
               </a:rPr>
-              <a:t>roles check</a:t>
+              <a:t>config propose</a:t>
             </a:r>
             <a:endParaRPr lang="en-US" sz="1000" dirty="0"/>
           </a:p>
@@ -20132,8 +20132,8 @@
         </p:nvSpPr>
         <p:spPr>
           <a:xfrm>
-            <a:off x="2135632" y="3749040"/>
-            <a:ext cx="813816" cy="256032"/>
+            <a:off x="2333752" y="3749040"/>
+            <a:ext cx="945896" cy="256032"/>
           </a:xfrm>
           <a:prstGeom prst="roundRect">
             <a:avLst>
@@ -20159,8 +20159,8 @@
         </p:nvSpPr>
         <p:spPr>
           <a:xfrm>
-            <a:off x="2135632" y="3749040"/>
-            <a:ext cx="813816" cy="256032"/>
+            <a:off x="2333752" y="3749040"/>
+            <a:ext cx="945896" cy="256032"/>
           </a:xfrm>
           <a:prstGeom prst="rect">
             <a:avLst/>
@@ -20184,7 +20184,7 @@
                 <a:ea typeface="Calibri" pitchFamily="34" charset="-122"/>
                 <a:cs typeface="Calibri" pitchFamily="34" charset="-120"/>
               </a:rPr>
-              <a:t>roles who</a:t>
+              <a:t>config show</a:t>
             </a:r>
             <a:endParaRPr lang="en-US" sz="1000" dirty="0"/>
           </a:p>
@@ -20198,8 +20198,8 @@
         </p:nvSpPr>
         <p:spPr>
           <a:xfrm>
-            <a:off x="3040888" y="3749040"/>
-            <a:ext cx="1077976" cy="256032"/>
+            <a:off x="3371088" y="3749040"/>
+            <a:ext cx="1011936" cy="256032"/>
           </a:xfrm>
           <a:prstGeom prst="roundRect">
             <a:avLst>
@@ -20225,8 +20225,8 @@
         </p:nvSpPr>
         <p:spPr>
           <a:xfrm>
-            <a:off x="3040888" y="3749040"/>
-            <a:ext cx="1077976" cy="256032"/>
+            <a:off x="3371088" y="3749040"/>
+            <a:ext cx="1011936" cy="256032"/>
           </a:xfrm>
           <a:prstGeom prst="rect">
             <a:avLst/>
@@ -20250,7 +20250,7 @@
                 <a:ea typeface="Calibri" pitchFamily="34" charset="-122"/>
                 <a:cs typeface="Calibri" pitchFamily="34" charset="-120"/>
               </a:rPr>
-              <a:t>roles migrate</a:t>
+              <a:t>config apply</a:t>
             </a:r>
             <a:endParaRPr lang="en-US" sz="1000" dirty="0"/>
           </a:p>
@@ -20264,8 +20264,8 @@
         </p:nvSpPr>
         <p:spPr>
           <a:xfrm>
-            <a:off x="4210304" y="3749040"/>
-            <a:ext cx="681736" cy="256032"/>
+            <a:off x="4474464" y="3749040"/>
+            <a:ext cx="1144016" cy="256032"/>
           </a:xfrm>
           <a:prstGeom prst="roundRect">
             <a:avLst>
@@ -20291,8 +20291,8 @@
         </p:nvSpPr>
         <p:spPr>
           <a:xfrm>
-            <a:off x="4210304" y="3749040"/>
-            <a:ext cx="681736" cy="256032"/>
+            <a:off x="4474464" y="3749040"/>
+            <a:ext cx="1144016" cy="256032"/>
           </a:xfrm>
           <a:prstGeom prst="rect">
             <a:avLst/>
@@ -20316,7 +20316,7 @@
                 <a:ea typeface="Calibri" pitchFamily="34" charset="-122"/>
                 <a:cs typeface="Calibri" pitchFamily="34" charset="-120"/>
               </a:rPr>
-              <a:t>ci init</a:t>
+              <a:t>config dismiss</a:t>
             </a:r>
             <a:endParaRPr lang="en-US" sz="1000" dirty="0"/>
           </a:p>
@@ -20330,8 +20330,8 @@
         </p:nvSpPr>
         <p:spPr>
           <a:xfrm>
-            <a:off x="4983480" y="3749040"/>
-            <a:ext cx="813816" cy="256032"/>
+            <a:off x="5709920" y="3749040"/>
+            <a:ext cx="945896" cy="256032"/>
           </a:xfrm>
           <a:prstGeom prst="roundRect">
             <a:avLst>
@@ -20357,8 +20357,8 @@
         </p:nvSpPr>
         <p:spPr>
           <a:xfrm>
-            <a:off x="4983480" y="3749040"/>
-            <a:ext cx="813816" cy="256032"/>
+            <a:off x="5709920" y="3749040"/>
+            <a:ext cx="945896" cy="256032"/>
           </a:xfrm>
           <a:prstGeom prst="rect">
             <a:avLst/>
@@ -20382,7 +20382,7 @@
                 <a:ea typeface="Calibri" pitchFamily="34" charset="-122"/>
                 <a:cs typeface="Calibri" pitchFamily="34" charset="-120"/>
               </a:rPr>
-              <a:t>team sync</a:t>
+              <a:t>roles check</a:t>
             </a:r>
             <a:endParaRPr lang="en-US" sz="1000" dirty="0"/>
           </a:p>
@@ -20396,8 +20396,8 @@
         </p:nvSpPr>
         <p:spPr>
           <a:xfrm>
-            <a:off x="5888736" y="3749040"/>
-            <a:ext cx="945896" cy="256032"/>
+            <a:off x="6747256" y="3749040"/>
+            <a:ext cx="813816" cy="256032"/>
           </a:xfrm>
           <a:prstGeom prst="roundRect">
             <a:avLst>
@@ -20423,8 +20423,8 @@
         </p:nvSpPr>
         <p:spPr>
           <a:xfrm>
-            <a:off x="5888736" y="3749040"/>
-            <a:ext cx="945896" cy="256032"/>
+            <a:off x="6747256" y="3749040"/>
+            <a:ext cx="813816" cy="256032"/>
           </a:xfrm>
           <a:prstGeom prst="rect">
             <a:avLst/>
@@ -20448,7 +20448,7 @@
                 <a:ea typeface="Calibri" pitchFamily="34" charset="-122"/>
                 <a:cs typeface="Calibri" pitchFamily="34" charset="-120"/>
               </a:rPr>
-              <a:t>team accept</a:t>
+              <a:t>roles who</a:t>
             </a:r>
             <a:endParaRPr lang="en-US" sz="1000" dirty="0"/>
           </a:p>
@@ -20462,8 +20462,8 @@
         </p:nvSpPr>
         <p:spPr>
           <a:xfrm>
-            <a:off x="6926072" y="3749040"/>
-            <a:ext cx="813816" cy="256032"/>
+            <a:off x="7652512" y="3749040"/>
+            <a:ext cx="1077976" cy="256032"/>
           </a:xfrm>
           <a:prstGeom prst="roundRect">
             <a:avLst>
@@ -20489,8 +20489,8 @@
         </p:nvSpPr>
         <p:spPr>
           <a:xfrm>
-            <a:off x="6926072" y="3749040"/>
-            <a:ext cx="813816" cy="256032"/>
+            <a:off x="7652512" y="3749040"/>
+            <a:ext cx="1077976" cy="256032"/>
           </a:xfrm>
           <a:prstGeom prst="rect">
             <a:avLst/>
@@ -20514,7 +20514,7 @@
                 <a:ea typeface="Calibri" pitchFamily="34" charset="-122"/>
                 <a:cs typeface="Calibri" pitchFamily="34" charset="-120"/>
               </a:rPr>
-              <a:t>team list</a:t>
+              <a:t>roles migrate</a:t>
             </a:r>
             <a:endParaRPr lang="en-US" sz="1000" dirty="0"/>
           </a:p>
@@ -20528,8 +20528,8 @@
         </p:nvSpPr>
         <p:spPr>
           <a:xfrm>
-            <a:off x="7831328" y="3749040"/>
-            <a:ext cx="879856" cy="256032"/>
+            <a:off x="8821928" y="3749040"/>
+            <a:ext cx="681736" cy="256032"/>
           </a:xfrm>
           <a:prstGeom prst="roundRect">
             <a:avLst>
@@ -20555,8 +20555,8 @@
         </p:nvSpPr>
         <p:spPr>
           <a:xfrm>
-            <a:off x="7831328" y="3749040"/>
-            <a:ext cx="879856" cy="256032"/>
+            <a:off x="8821928" y="3749040"/>
+            <a:ext cx="681736" cy="256032"/>
           </a:xfrm>
           <a:prstGeom prst="rect">
             <a:avLst/>
@@ -20580,7 +20580,7 @@
                 <a:ea typeface="Calibri" pitchFamily="34" charset="-122"/>
                 <a:cs typeface="Calibri" pitchFamily="34" charset="-120"/>
               </a:rPr>
-              <a:t>team check</a:t>
+              <a:t>ci init</a:t>
             </a:r>
             <a:endParaRPr lang="en-US" sz="1000" dirty="0"/>
           </a:p>
@@ -20594,8 +20594,8 @@
         </p:nvSpPr>
         <p:spPr>
           <a:xfrm>
-            <a:off x="8802624" y="3749040"/>
-            <a:ext cx="1276096" cy="256032"/>
+            <a:off x="9595104" y="3749040"/>
+            <a:ext cx="813816" cy="256032"/>
           </a:xfrm>
           <a:prstGeom prst="roundRect">
             <a:avLst>
@@ -20621,8 +20621,8 @@
         </p:nvSpPr>
         <p:spPr>
           <a:xfrm>
-            <a:off x="8802624" y="3749040"/>
-            <a:ext cx="1276096" cy="256032"/>
+            <a:off x="9595104" y="3749040"/>
+            <a:ext cx="813816" cy="256032"/>
           </a:xfrm>
           <a:prstGeom prst="rect">
             <a:avLst/>
@@ -20646,7 +20646,7 @@
                 <a:ea typeface="Calibri" pitchFamily="34" charset="-122"/>
                 <a:cs typeface="Calibri" pitchFamily="34" charset="-120"/>
               </a:rPr>
-              <a:t>backlog epic add</a:t>
+              <a:t>team sync</a:t>
             </a:r>
             <a:endParaRPr lang="en-US" sz="1000" dirty="0"/>
           </a:p>
@@ -20660,8 +20660,8 @@
         </p:nvSpPr>
         <p:spPr>
           <a:xfrm>
-            <a:off x="10170160" y="3749040"/>
-            <a:ext cx="1342136" cy="256032"/>
+            <a:off x="10500360" y="3749040"/>
+            <a:ext cx="945896" cy="256032"/>
           </a:xfrm>
           <a:prstGeom prst="roundRect">
             <a:avLst>
@@ -20687,8 +20687,8 @@
         </p:nvSpPr>
         <p:spPr>
           <a:xfrm>
-            <a:off x="10170160" y="3749040"/>
-            <a:ext cx="1342136" cy="256032"/>
+            <a:off x="10500360" y="3749040"/>
+            <a:ext cx="945896" cy="256032"/>
           </a:xfrm>
           <a:prstGeom prst="rect">
             <a:avLst/>
@@ -20712,7 +20712,7 @@
                 <a:ea typeface="Calibri" pitchFamily="34" charset="-122"/>
                 <a:cs typeface="Calibri" pitchFamily="34" charset="-120"/>
               </a:rPr>
-              <a:t>backlog epic edit</a:t>
+              <a:t>team accept</a:t>
             </a:r>
             <a:endParaRPr lang="en-US" sz="1000" dirty="0"/>
           </a:p>
@@ -20727,7 +20727,7 @@
         <p:spPr>
           <a:xfrm>
             <a:off x="457200" y="4096512"/>
-            <a:ext cx="945896" cy="256032"/>
+            <a:ext cx="813816" cy="256032"/>
           </a:xfrm>
           <a:prstGeom prst="roundRect">
             <a:avLst>
@@ -20754,7 +20754,7 @@
         <p:spPr>
           <a:xfrm>
             <a:off x="457200" y="4096512"/>
-            <a:ext cx="945896" cy="256032"/>
+            <a:ext cx="813816" cy="256032"/>
           </a:xfrm>
           <a:prstGeom prst="rect">
             <a:avLst/>
@@ -20778,7 +20778,7 @@
                 <a:ea typeface="Calibri" pitchFamily="34" charset="-122"/>
                 <a:cs typeface="Calibri" pitchFamily="34" charset="-120"/>
               </a:rPr>
-              <a:t>backlog add</a:t>
+              <a:t>team list</a:t>
             </a:r>
             <a:endParaRPr lang="en-US" sz="1000" dirty="0"/>
           </a:p>
@@ -20792,8 +20792,8 @@
         </p:nvSpPr>
         <p:spPr>
           <a:xfrm>
-            <a:off x="1494536" y="4096512"/>
-            <a:ext cx="1011936" cy="256032"/>
+            <a:off x="1362456" y="4096512"/>
+            <a:ext cx="879856" cy="256032"/>
           </a:xfrm>
           <a:prstGeom prst="roundRect">
             <a:avLst>
@@ -20819,8 +20819,8 @@
         </p:nvSpPr>
         <p:spPr>
           <a:xfrm>
-            <a:off x="1494536" y="4096512"/>
-            <a:ext cx="1011936" cy="256032"/>
+            <a:off x="1362456" y="4096512"/>
+            <a:ext cx="879856" cy="256032"/>
           </a:xfrm>
           <a:prstGeom prst="rect">
             <a:avLst/>
@@ -20844,7 +20844,7 @@
                 <a:ea typeface="Calibri" pitchFamily="34" charset="-122"/>
                 <a:cs typeface="Calibri" pitchFamily="34" charset="-120"/>
               </a:rPr>
-              <a:t>backlog edit</a:t>
+              <a:t>team check</a:t>
             </a:r>
             <a:endParaRPr lang="en-US" sz="1000" dirty="0"/>
           </a:p>
@@ -20858,8 +20858,8 @@
         </p:nvSpPr>
         <p:spPr>
           <a:xfrm>
-            <a:off x="2597912" y="4096512"/>
-            <a:ext cx="1011936" cy="256032"/>
+            <a:off x="2333752" y="4096512"/>
+            <a:ext cx="1276096" cy="256032"/>
           </a:xfrm>
           <a:prstGeom prst="roundRect">
             <a:avLst>
@@ -20885,8 +20885,8 @@
         </p:nvSpPr>
         <p:spPr>
           <a:xfrm>
-            <a:off x="2597912" y="4096512"/>
-            <a:ext cx="1011936" cy="256032"/>
+            <a:off x="2333752" y="4096512"/>
+            <a:ext cx="1276096" cy="256032"/>
           </a:xfrm>
           <a:prstGeom prst="rect">
             <a:avLst/>
@@ -20910,7 +20910,7 @@
                 <a:ea typeface="Calibri" pitchFamily="34" charset="-122"/>
                 <a:cs typeface="Calibri" pitchFamily="34" charset="-120"/>
               </a:rPr>
-              <a:t>backlog list</a:t>
+              <a:t>backlog epic add</a:t>
             </a:r>
             <a:endParaRPr lang="en-US" sz="1000" dirty="0"/>
           </a:p>
@@ -20925,7 +20925,7 @@
         <p:spPr>
           <a:xfrm>
             <a:off x="3701288" y="4096512"/>
-            <a:ext cx="1011936" cy="256032"/>
+            <a:ext cx="1342136" cy="256032"/>
           </a:xfrm>
           <a:prstGeom prst="roundRect">
             <a:avLst>
@@ -20952,7 +20952,7 @@
         <p:spPr>
           <a:xfrm>
             <a:off x="3701288" y="4096512"/>
-            <a:ext cx="1011936" cy="256032"/>
+            <a:ext cx="1342136" cy="256032"/>
           </a:xfrm>
           <a:prstGeom prst="rect">
             <a:avLst/>
@@ -20976,7 +20976,7 @@
                 <a:ea typeface="Calibri" pitchFamily="34" charset="-122"/>
                 <a:cs typeface="Calibri" pitchFamily="34" charset="-120"/>
               </a:rPr>
-              <a:t>backlog next</a:t>
+              <a:t>backlog epic edit</a:t>
             </a:r>
             <a:endParaRPr lang="en-US" sz="1000" dirty="0"/>
           </a:p>
@@ -20990,8 +20990,8 @@
         </p:nvSpPr>
         <p:spPr>
           <a:xfrm>
-            <a:off x="4804664" y="4096512"/>
-            <a:ext cx="1077976" cy="256032"/>
+            <a:off x="5134864" y="4096512"/>
+            <a:ext cx="945896" cy="256032"/>
           </a:xfrm>
           <a:prstGeom prst="roundRect">
             <a:avLst>
@@ -21017,8 +21017,8 @@
         </p:nvSpPr>
         <p:spPr>
           <a:xfrm>
-            <a:off x="4804664" y="4096512"/>
-            <a:ext cx="1077976" cy="256032"/>
+            <a:off x="5134864" y="4096512"/>
+            <a:ext cx="945896" cy="256032"/>
           </a:xfrm>
           <a:prstGeom prst="rect">
             <a:avLst/>
@@ -21042,7 +21042,7 @@
                 <a:ea typeface="Calibri" pitchFamily="34" charset="-122"/>
                 <a:cs typeface="Calibri" pitchFamily="34" charset="-120"/>
               </a:rPr>
-              <a:t>backlog start</a:t>
+              <a:t>backlog add</a:t>
             </a:r>
             <a:endParaRPr lang="en-US" sz="1000" dirty="0"/>
           </a:p>
@@ -21056,7 +21056,7 @@
         </p:nvSpPr>
         <p:spPr>
           <a:xfrm>
-            <a:off x="5974080" y="4096512"/>
+            <a:off x="6172200" y="4096512"/>
             <a:ext cx="1011936" cy="256032"/>
           </a:xfrm>
           <a:prstGeom prst="roundRect">
@@ -21083,7 +21083,7 @@
         </p:nvSpPr>
         <p:spPr>
           <a:xfrm>
-            <a:off x="5974080" y="4096512"/>
+            <a:off x="6172200" y="4096512"/>
             <a:ext cx="1011936" cy="256032"/>
           </a:xfrm>
           <a:prstGeom prst="rect">
@@ -21108,7 +21108,7 @@
                 <a:ea typeface="Calibri" pitchFamily="34" charset="-122"/>
                 <a:cs typeface="Calibri" pitchFamily="34" charset="-120"/>
               </a:rPr>
-              <a:t>backlog link</a:t>
+              <a:t>backlog edit</a:t>
             </a:r>
             <a:endParaRPr lang="en-US" sz="1000" dirty="0"/>
           </a:p>
@@ -21122,7 +21122,7 @@
         </p:nvSpPr>
         <p:spPr>
           <a:xfrm>
-            <a:off x="7077456" y="4096512"/>
+            <a:off x="7275576" y="4096512"/>
             <a:ext cx="1011936" cy="256032"/>
           </a:xfrm>
           <a:prstGeom prst="roundRect">
@@ -21149,7 +21149,7 @@
         </p:nvSpPr>
         <p:spPr>
           <a:xfrm>
-            <a:off x="7077456" y="4096512"/>
+            <a:off x="7275576" y="4096512"/>
             <a:ext cx="1011936" cy="256032"/>
           </a:xfrm>
           <a:prstGeom prst="rect">
@@ -21174,7 +21174,7 @@
                 <a:ea typeface="Calibri" pitchFamily="34" charset="-122"/>
                 <a:cs typeface="Calibri" pitchFamily="34" charset="-120"/>
               </a:rPr>
-              <a:t>backlog move</a:t>
+              <a:t>backlog list</a:t>
             </a:r>
             <a:endParaRPr lang="en-US" sz="1000" dirty="0"/>
           </a:p>
@@ -21188,7 +21188,7 @@
         </p:nvSpPr>
         <p:spPr>
           <a:xfrm>
-            <a:off x="8180832" y="4096512"/>
+            <a:off x="8378952" y="4096512"/>
             <a:ext cx="1011936" cy="256032"/>
           </a:xfrm>
           <a:prstGeom prst="roundRect">
@@ -21215,7 +21215,7 @@
         </p:nvSpPr>
         <p:spPr>
           <a:xfrm>
-            <a:off x="8180832" y="4096512"/>
+            <a:off x="8378952" y="4096512"/>
             <a:ext cx="1011936" cy="256032"/>
           </a:xfrm>
           <a:prstGeom prst="rect">
@@ -21240,7 +21240,7 @@
                 <a:ea typeface="Calibri" pitchFamily="34" charset="-122"/>
                 <a:cs typeface="Calibri" pitchFamily="34" charset="-120"/>
               </a:rPr>
-              <a:t>backlog drop</a:t>
+              <a:t>backlog next</a:t>
             </a:r>
             <a:endParaRPr lang="en-US" sz="1000" dirty="0"/>
           </a:p>
@@ -21254,8 +21254,8 @@
         </p:nvSpPr>
         <p:spPr>
           <a:xfrm>
-            <a:off x="9284208" y="4096512"/>
-            <a:ext cx="1011936" cy="256032"/>
+            <a:off x="9482328" y="4096512"/>
+            <a:ext cx="1077976" cy="256032"/>
           </a:xfrm>
           <a:prstGeom prst="roundRect">
             <a:avLst>
@@ -21281,8 +21281,8 @@
         </p:nvSpPr>
         <p:spPr>
           <a:xfrm>
-            <a:off x="9284208" y="4096512"/>
-            <a:ext cx="1011936" cy="256032"/>
+            <a:off x="9482328" y="4096512"/>
+            <a:ext cx="1077976" cy="256032"/>
           </a:xfrm>
           <a:prstGeom prst="rect">
             <a:avLst/>
@@ -21306,7 +21306,7 @@
                 <a:ea typeface="Calibri" pitchFamily="34" charset="-122"/>
                 <a:cs typeface="Calibri" pitchFamily="34" charset="-120"/>
               </a:rPr>
-              <a:t>backlog done</a:t>
+              <a:t>backlog start</a:t>
             </a:r>
             <a:endParaRPr lang="en-US" sz="1000" dirty="0"/>
           </a:p>
@@ -21320,8 +21320,8 @@
         </p:nvSpPr>
         <p:spPr>
           <a:xfrm>
-            <a:off x="10387584" y="4096512"/>
-            <a:ext cx="1144016" cy="256032"/>
+            <a:off x="10651744" y="4096512"/>
+            <a:ext cx="1011936" cy="256032"/>
           </a:xfrm>
           <a:prstGeom prst="roundRect">
             <a:avLst>
@@ -21347,8 +21347,8 @@
         </p:nvSpPr>
         <p:spPr>
           <a:xfrm>
-            <a:off x="10387584" y="4096512"/>
-            <a:ext cx="1144016" cy="256032"/>
+            <a:off x="10651744" y="4096512"/>
+            <a:ext cx="1011936" cy="256032"/>
           </a:xfrm>
           <a:prstGeom prst="rect">
             <a:avLst/>
@@ -21372,7 +21372,7 @@
                 <a:ea typeface="Calibri" pitchFamily="34" charset="-122"/>
                 <a:cs typeface="Calibri" pitchFamily="34" charset="-120"/>
               </a:rPr>
-              <a:t>backlog import</a:t>
+              <a:t>backlog link</a:t>
             </a:r>
             <a:endParaRPr lang="en-US" sz="1000" dirty="0"/>
           </a:p>
@@ -21387,7 +21387,7 @@
         <p:spPr>
           <a:xfrm>
             <a:off x="457200" y="4443984"/>
-            <a:ext cx="813816" cy="256032"/>
+            <a:ext cx="1011936" cy="256032"/>
           </a:xfrm>
           <a:prstGeom prst="roundRect">
             <a:avLst>
@@ -21414,7 +21414,7 @@
         <p:spPr>
           <a:xfrm>
             <a:off x="457200" y="4443984"/>
-            <a:ext cx="813816" cy="256032"/>
+            <a:ext cx="1011936" cy="256032"/>
           </a:xfrm>
           <a:prstGeom prst="rect">
             <a:avLst/>
@@ -21438,7 +21438,7 @@
                 <a:ea typeface="Calibri" pitchFamily="34" charset="-122"/>
                 <a:cs typeface="Calibri" pitchFamily="34" charset="-120"/>
               </a:rPr>
-              <a:t>defer add</a:t>
+              <a:t>backlog move</a:t>
             </a:r>
             <a:endParaRPr lang="en-US" sz="1000" dirty="0"/>
           </a:p>
@@ -21452,8 +21452,8 @@
         </p:nvSpPr>
         <p:spPr>
           <a:xfrm>
-            <a:off x="1362456" y="4443984"/>
-            <a:ext cx="879856" cy="256032"/>
+            <a:off x="1560576" y="4443984"/>
+            <a:ext cx="1011936" cy="256032"/>
           </a:xfrm>
           <a:prstGeom prst="roundRect">
             <a:avLst>
@@ -21479,8 +21479,8 @@
         </p:nvSpPr>
         <p:spPr>
           <a:xfrm>
-            <a:off x="1362456" y="4443984"/>
-            <a:ext cx="879856" cy="256032"/>
+            <a:off x="1560576" y="4443984"/>
+            <a:ext cx="1011936" cy="256032"/>
           </a:xfrm>
           <a:prstGeom prst="rect">
             <a:avLst/>
@@ -21504,7 +21504,7 @@
                 <a:ea typeface="Calibri" pitchFamily="34" charset="-122"/>
                 <a:cs typeface="Calibri" pitchFamily="34" charset="-120"/>
               </a:rPr>
-              <a:t>defer list</a:t>
+              <a:t>backlog drop</a:t>
             </a:r>
             <a:endParaRPr lang="en-US" sz="1000" dirty="0"/>
           </a:p>
@@ -21518,8 +21518,8 @@
         </p:nvSpPr>
         <p:spPr>
           <a:xfrm>
-            <a:off x="2333752" y="4443984"/>
-            <a:ext cx="945896" cy="256032"/>
+            <a:off x="2663952" y="4443984"/>
+            <a:ext cx="1011936" cy="256032"/>
           </a:xfrm>
           <a:prstGeom prst="roundRect">
             <a:avLst>
@@ -21545,8 +21545,8 @@
         </p:nvSpPr>
         <p:spPr>
           <a:xfrm>
-            <a:off x="2333752" y="4443984"/>
-            <a:ext cx="945896" cy="256032"/>
+            <a:off x="2663952" y="4443984"/>
+            <a:ext cx="1011936" cy="256032"/>
           </a:xfrm>
           <a:prstGeom prst="rect">
             <a:avLst/>
@@ -21570,7 +21570,7 @@
                 <a:ea typeface="Calibri" pitchFamily="34" charset="-122"/>
                 <a:cs typeface="Calibri" pitchFamily="34" charset="-120"/>
               </a:rPr>
-              <a:t>defer close</a:t>
+              <a:t>backlog done</a:t>
             </a:r>
             <a:endParaRPr lang="en-US" sz="1000" dirty="0"/>
           </a:p>
@@ -21584,8 +21584,8 @@
         </p:nvSpPr>
         <p:spPr>
           <a:xfrm>
-            <a:off x="3371088" y="4443984"/>
-            <a:ext cx="1011936" cy="256032"/>
+            <a:off x="3767328" y="4443984"/>
+            <a:ext cx="1144016" cy="256032"/>
           </a:xfrm>
           <a:prstGeom prst="roundRect">
             <a:avLst>
@@ -21611,8 +21611,8 @@
         </p:nvSpPr>
         <p:spPr>
           <a:xfrm>
-            <a:off x="3371088" y="4443984"/>
-            <a:ext cx="1011936" cy="256032"/>
+            <a:off x="3767328" y="4443984"/>
+            <a:ext cx="1144016" cy="256032"/>
           </a:xfrm>
           <a:prstGeom prst="rect">
             <a:avLst/>
@@ -21636,7 +21636,7 @@
                 <a:ea typeface="Calibri" pitchFamily="34" charset="-122"/>
                 <a:cs typeface="Calibri" pitchFamily="34" charset="-120"/>
               </a:rPr>
-              <a:t>layout check</a:t>
+              <a:t>backlog import</a:t>
             </a:r>
             <a:endParaRPr lang="en-US" sz="1000" dirty="0"/>
           </a:p>
@@ -21650,8 +21650,8 @@
         </p:nvSpPr>
         <p:spPr>
           <a:xfrm>
-            <a:off x="4474464" y="4443984"/>
-            <a:ext cx="1210056" cy="256032"/>
+            <a:off x="5002784" y="4443984"/>
+            <a:ext cx="813816" cy="256032"/>
           </a:xfrm>
           <a:prstGeom prst="roundRect">
             <a:avLst>
@@ -21677,8 +21677,8 @@
         </p:nvSpPr>
         <p:spPr>
           <a:xfrm>
-            <a:off x="4474464" y="4443984"/>
-            <a:ext cx="1210056" cy="256032"/>
+            <a:off x="5002784" y="4443984"/>
+            <a:ext cx="813816" cy="256032"/>
           </a:xfrm>
           <a:prstGeom prst="rect">
             <a:avLst/>
@@ -21702,7 +21702,7 @@
                 <a:ea typeface="Calibri" pitchFamily="34" charset="-122"/>
                 <a:cs typeface="Calibri" pitchFamily="34" charset="-120"/>
               </a:rPr>
-              <a:t>layout scaffold</a:t>
+              <a:t>defer add</a:t>
             </a:r>
             <a:endParaRPr lang="en-US" sz="1000" dirty="0"/>
           </a:p>
@@ -21716,8 +21716,8 @@
         </p:nvSpPr>
         <p:spPr>
           <a:xfrm>
-            <a:off x="5775960" y="4443984"/>
-            <a:ext cx="1011936" cy="256032"/>
+            <a:off x="5908040" y="4443984"/>
+            <a:ext cx="879856" cy="256032"/>
           </a:xfrm>
           <a:prstGeom prst="roundRect">
             <a:avLst>
@@ -21743,8 +21743,8 @@
         </p:nvSpPr>
         <p:spPr>
           <a:xfrm>
-            <a:off x="5775960" y="4443984"/>
-            <a:ext cx="1011936" cy="256032"/>
+            <a:off x="5908040" y="4443984"/>
+            <a:ext cx="879856" cy="256032"/>
           </a:xfrm>
           <a:prstGeom prst="rect">
             <a:avLst/>
@@ -21768,7 +21768,7 @@
                 <a:ea typeface="Calibri" pitchFamily="34" charset="-122"/>
                 <a:cs typeface="Calibri" pitchFamily="34" charset="-120"/>
               </a:rPr>
-              <a:t>layout adapt</a:t>
+              <a:t>defer list</a:t>
             </a:r>
             <a:endParaRPr lang="en-US" sz="1000" dirty="0"/>
           </a:p>
@@ -21783,7 +21783,7 @@
         <p:spPr>
           <a:xfrm>
             <a:off x="6879336" y="4443984"/>
-            <a:ext cx="1144016" cy="256032"/>
+            <a:ext cx="945896" cy="256032"/>
           </a:xfrm>
           <a:prstGeom prst="roundRect">
             <a:avLst>
@@ -21810,7 +21810,7 @@
         <p:spPr>
           <a:xfrm>
             <a:off x="6879336" y="4443984"/>
-            <a:ext cx="1144016" cy="256032"/>
+            <a:ext cx="945896" cy="256032"/>
           </a:xfrm>
           <a:prstGeom prst="rect">
             <a:avLst/>
@@ -21834,7 +21834,7 @@
                 <a:ea typeface="Calibri" pitchFamily="34" charset="-122"/>
                 <a:cs typeface="Calibri" pitchFamily="34" charset="-120"/>
               </a:rPr>
-              <a:t>layout convert</a:t>
+              <a:t>defer close</a:t>
             </a:r>
             <a:endParaRPr lang="en-US" sz="1000" dirty="0"/>
           </a:p>
@@ -21848,8 +21848,8 @@
         </p:nvSpPr>
         <p:spPr>
           <a:xfrm>
-            <a:off x="8114792" y="4443984"/>
-            <a:ext cx="483616" cy="256032"/>
+            <a:off x="7916672" y="4443984"/>
+            <a:ext cx="1011936" cy="256032"/>
           </a:xfrm>
           <a:prstGeom prst="roundRect">
             <a:avLst>
@@ -21875,8 +21875,8 @@
         </p:nvSpPr>
         <p:spPr>
           <a:xfrm>
-            <a:off x="8114792" y="4443984"/>
-            <a:ext cx="483616" cy="256032"/>
+            <a:off x="7916672" y="4443984"/>
+            <a:ext cx="1011936" cy="256032"/>
           </a:xfrm>
           <a:prstGeom prst="rect">
             <a:avLst/>
@@ -21900,7 +21900,7 @@
                 <a:ea typeface="Calibri" pitchFamily="34" charset="-122"/>
                 <a:cs typeface="Calibri" pitchFamily="34" charset="-120"/>
               </a:rPr>
-              <a:t>init</a:t>
+              <a:t>layout check</a:t>
             </a:r>
             <a:endParaRPr lang="en-US" sz="1000" dirty="0"/>
           </a:p>
@@ -21914,8 +21914,8 @@
         </p:nvSpPr>
         <p:spPr>
           <a:xfrm>
-            <a:off x="8689848" y="4443984"/>
-            <a:ext cx="615696" cy="256032"/>
+            <a:off x="9020048" y="4443984"/>
+            <a:ext cx="1210056" cy="256032"/>
           </a:xfrm>
           <a:prstGeom prst="roundRect">
             <a:avLst>
@@ -21941,8 +21941,8 @@
         </p:nvSpPr>
         <p:spPr>
           <a:xfrm>
-            <a:off x="8689848" y="4443984"/>
-            <a:ext cx="615696" cy="256032"/>
+            <a:off x="9020048" y="4443984"/>
+            <a:ext cx="1210056" cy="256032"/>
           </a:xfrm>
           <a:prstGeom prst="rect">
             <a:avLst/>
@@ -21966,7 +21966,7 @@
                 <a:ea typeface="Calibri" pitchFamily="34" charset="-122"/>
                 <a:cs typeface="Calibri" pitchFamily="34" charset="-120"/>
               </a:rPr>
-              <a:t>update</a:t>
+              <a:t>layout scaffold</a:t>
             </a:r>
             <a:endParaRPr lang="en-US" sz="1000" dirty="0"/>
           </a:p>
@@ -21980,8 +21980,8 @@
         </p:nvSpPr>
         <p:spPr>
           <a:xfrm>
-            <a:off x="9396984" y="4443984"/>
-            <a:ext cx="813816" cy="256032"/>
+            <a:off x="10321544" y="4443984"/>
+            <a:ext cx="1011936" cy="256032"/>
           </a:xfrm>
           <a:prstGeom prst="roundRect">
             <a:avLst>
@@ -22007,8 +22007,8 @@
         </p:nvSpPr>
         <p:spPr>
           <a:xfrm>
-            <a:off x="9396984" y="4443984"/>
-            <a:ext cx="813816" cy="256032"/>
+            <a:off x="10321544" y="4443984"/>
+            <a:ext cx="1011936" cy="256032"/>
           </a:xfrm>
           <a:prstGeom prst="rect">
             <a:avLst/>
@@ -22032,7 +22032,7 @@
                 <a:ea typeface="Calibri" pitchFamily="34" charset="-122"/>
                 <a:cs typeface="Calibri" pitchFamily="34" charset="-120"/>
               </a:rPr>
-              <a:t>uninstall</a:t>
+              <a:t>layout adapt</a:t>
             </a:r>
             <a:endParaRPr lang="en-US" sz="1000" dirty="0"/>
           </a:p>
@@ -22046,8 +22046,8 @@
         </p:nvSpPr>
         <p:spPr>
           <a:xfrm>
-            <a:off x="10302240" y="4443984"/>
-            <a:ext cx="417576" cy="256032"/>
+            <a:off x="457200" y="4791456"/>
+            <a:ext cx="1144016" cy="256032"/>
           </a:xfrm>
           <a:prstGeom prst="roundRect">
             <a:avLst>
@@ -22073,8 +22073,8 @@
         </p:nvSpPr>
         <p:spPr>
           <a:xfrm>
-            <a:off x="10302240" y="4443984"/>
-            <a:ext cx="417576" cy="256032"/>
+            <a:off x="457200" y="4791456"/>
+            <a:ext cx="1144016" cy="256032"/>
           </a:xfrm>
           <a:prstGeom prst="rect">
             <a:avLst/>
@@ -22098,7 +22098,7 @@
                 <a:ea typeface="Calibri" pitchFamily="34" charset="-122"/>
                 <a:cs typeface="Calibri" pitchFamily="34" charset="-120"/>
               </a:rPr>
-              <a:t>new</a:t>
+              <a:t>layout convert</a:t>
             </a:r>
             <a:endParaRPr lang="en-US" sz="1000" dirty="0"/>
           </a:p>
@@ -22112,8 +22112,8 @@
         </p:nvSpPr>
         <p:spPr>
           <a:xfrm>
-            <a:off x="457200" y="4791456"/>
-            <a:ext cx="1011936" cy="256032"/>
+            <a:off x="1692656" y="4791456"/>
+            <a:ext cx="483616" cy="256032"/>
           </a:xfrm>
           <a:prstGeom prst="roundRect">
             <a:avLst>
@@ -22139,8 +22139,8 @@
         </p:nvSpPr>
         <p:spPr>
           <a:xfrm>
-            <a:off x="457200" y="4791456"/>
-            <a:ext cx="1011936" cy="256032"/>
+            <a:off x="1692656" y="4791456"/>
+            <a:ext cx="483616" cy="256032"/>
           </a:xfrm>
           <a:prstGeom prst="rect">
             <a:avLst/>
@@ -22164,7 +22164,7 @@
                 <a:ea typeface="Calibri" pitchFamily="34" charset="-122"/>
                 <a:cs typeface="Calibri" pitchFamily="34" charset="-120"/>
               </a:rPr>
-              <a:t>explore list</a:t>
+              <a:t>init</a:t>
             </a:r>
             <a:endParaRPr lang="en-US" sz="1000" dirty="0"/>
           </a:p>
@@ -22178,8 +22178,8 @@
         </p:nvSpPr>
         <p:spPr>
           <a:xfrm>
-            <a:off x="1560576" y="4791456"/>
-            <a:ext cx="945896" cy="256032"/>
+            <a:off x="2267712" y="4791456"/>
+            <a:ext cx="615696" cy="256032"/>
           </a:xfrm>
           <a:prstGeom prst="roundRect">
             <a:avLst>
@@ -22205,8 +22205,8 @@
         </p:nvSpPr>
         <p:spPr>
           <a:xfrm>
-            <a:off x="1560576" y="4791456"/>
-            <a:ext cx="945896" cy="256032"/>
+            <a:off x="2267712" y="4791456"/>
+            <a:ext cx="615696" cy="256032"/>
           </a:xfrm>
           <a:prstGeom prst="rect">
             <a:avLst/>
@@ -22230,7 +22230,7 @@
                 <a:ea typeface="Calibri" pitchFamily="34" charset="-122"/>
                 <a:cs typeface="Calibri" pitchFamily="34" charset="-120"/>
               </a:rPr>
-              <a:t>import bmad</a:t>
+              <a:t>update</a:t>
             </a:r>
             <a:endParaRPr lang="en-US" sz="1000" dirty="0"/>
           </a:p>
@@ -22244,8 +22244,8 @@
         </p:nvSpPr>
         <p:spPr>
           <a:xfrm>
-            <a:off x="2597912" y="4791456"/>
-            <a:ext cx="615696" cy="256032"/>
+            <a:off x="2974848" y="4791456"/>
+            <a:ext cx="813816" cy="256032"/>
           </a:xfrm>
           <a:prstGeom prst="roundRect">
             <a:avLst>
@@ -22271,8 +22271,8 @@
         </p:nvSpPr>
         <p:spPr>
           <a:xfrm>
-            <a:off x="2597912" y="4791456"/>
-            <a:ext cx="615696" cy="256032"/>
+            <a:off x="2974848" y="4791456"/>
+            <a:ext cx="813816" cy="256032"/>
           </a:xfrm>
           <a:prstGeom prst="rect">
             <a:avLst/>
@@ -22296,7 +22296,7 @@
                 <a:ea typeface="Calibri" pitchFamily="34" charset="-122"/>
                 <a:cs typeface="Calibri" pitchFamily="34" charset="-120"/>
               </a:rPr>
-              <a:t>status</a:t>
+              <a:t>uninstall</a:t>
             </a:r>
             <a:endParaRPr lang="en-US" sz="1000" dirty="0"/>
           </a:p>
@@ -22310,8 +22310,8 @@
         </p:nvSpPr>
         <p:spPr>
           <a:xfrm>
-            <a:off x="3305048" y="4791456"/>
-            <a:ext cx="681736" cy="256032"/>
+            <a:off x="3880104" y="4791456"/>
+            <a:ext cx="417576" cy="256032"/>
           </a:xfrm>
           <a:prstGeom prst="roundRect">
             <a:avLst>
@@ -22337,8 +22337,8 @@
         </p:nvSpPr>
         <p:spPr>
           <a:xfrm>
-            <a:off x="3305048" y="4791456"/>
-            <a:ext cx="681736" cy="256032"/>
+            <a:off x="3880104" y="4791456"/>
+            <a:ext cx="417576" cy="256032"/>
           </a:xfrm>
           <a:prstGeom prst="rect">
             <a:avLst/>
@@ -22362,7 +22362,7 @@
                 <a:ea typeface="Calibri" pitchFamily="34" charset="-122"/>
                 <a:cs typeface="Calibri" pitchFamily="34" charset="-120"/>
               </a:rPr>
-              <a:t>explain</a:t>
+              <a:t>new</a:t>
             </a:r>
             <a:endParaRPr lang="en-US" sz="1000" dirty="0"/>
           </a:p>
@@ -22376,8 +22376,8 @@
         </p:nvSpPr>
         <p:spPr>
           <a:xfrm>
-            <a:off x="4078224" y="4791456"/>
-            <a:ext cx="483616" cy="256032"/>
+            <a:off x="4389120" y="4791456"/>
+            <a:ext cx="1011936" cy="256032"/>
           </a:xfrm>
           <a:prstGeom prst="roundRect">
             <a:avLst>
@@ -22403,8 +22403,8 @@
         </p:nvSpPr>
         <p:spPr>
           <a:xfrm>
-            <a:off x="4078224" y="4791456"/>
-            <a:ext cx="483616" cy="256032"/>
+            <a:off x="4389120" y="4791456"/>
+            <a:ext cx="1011936" cy="256032"/>
           </a:xfrm>
           <a:prstGeom prst="rect">
             <a:avLst/>
@@ -22428,7 +22428,7 @@
                 <a:ea typeface="Calibri" pitchFamily="34" charset="-122"/>
                 <a:cs typeface="Calibri" pitchFamily="34" charset="-120"/>
               </a:rPr>
-              <a:t>help</a:t>
+              <a:t>explore list</a:t>
             </a:r>
             <a:endParaRPr lang="en-US" sz="1000" dirty="0"/>
           </a:p>
@@ -22442,8 +22442,8 @@
         </p:nvSpPr>
         <p:spPr>
           <a:xfrm>
-            <a:off x="4653280" y="4791456"/>
-            <a:ext cx="549656" cy="256032"/>
+            <a:off x="5492496" y="4791456"/>
+            <a:ext cx="945896" cy="256032"/>
           </a:xfrm>
           <a:prstGeom prst="roundRect">
             <a:avLst>
@@ -22469,8 +22469,8 @@
         </p:nvSpPr>
         <p:spPr>
           <a:xfrm>
-            <a:off x="4653280" y="4791456"/>
-            <a:ext cx="549656" cy="256032"/>
+            <a:off x="5492496" y="4791456"/>
+            <a:ext cx="945896" cy="256032"/>
           </a:xfrm>
           <a:prstGeom prst="rect">
             <a:avLst/>
@@ -22494,7 +22494,7 @@
                 <a:ea typeface="Calibri" pitchFamily="34" charset="-122"/>
                 <a:cs typeface="Calibri" pitchFamily="34" charset="-120"/>
               </a:rPr>
-              <a:t>guide</a:t>
+              <a:t>import bmad</a:t>
             </a:r>
             <a:endParaRPr lang="en-US" sz="1000" dirty="0"/>
           </a:p>
@@ -22508,8 +22508,8 @@
         </p:nvSpPr>
         <p:spPr>
           <a:xfrm>
-            <a:off x="5294376" y="4791456"/>
-            <a:ext cx="879856" cy="256032"/>
+            <a:off x="6529832" y="4791456"/>
+            <a:ext cx="615696" cy="256032"/>
           </a:xfrm>
           <a:prstGeom prst="roundRect">
             <a:avLst>
@@ -22535,8 +22535,8 @@
         </p:nvSpPr>
         <p:spPr>
           <a:xfrm>
-            <a:off x="5294376" y="4791456"/>
-            <a:ext cx="879856" cy="256032"/>
+            <a:off x="6529832" y="4791456"/>
+            <a:ext cx="615696" cy="256032"/>
           </a:xfrm>
           <a:prstGeom prst="rect">
             <a:avLst/>
@@ -22560,7 +22560,7 @@
                 <a:ea typeface="Calibri" pitchFamily="34" charset="-122"/>
                 <a:cs typeface="Calibri" pitchFamily="34" charset="-120"/>
               </a:rPr>
-              <a:t>statusline</a:t>
+              <a:t>status</a:t>
             </a:r>
             <a:endParaRPr lang="en-US" sz="1000" dirty="0"/>
           </a:p>
@@ -22574,8 +22574,8 @@
         </p:nvSpPr>
         <p:spPr>
           <a:xfrm>
-            <a:off x="6265672" y="4791456"/>
-            <a:ext cx="1011936" cy="256032"/>
+            <a:off x="7236968" y="4791456"/>
+            <a:ext cx="681736" cy="256032"/>
           </a:xfrm>
           <a:prstGeom prst="roundRect">
             <a:avLst>
@@ -22601,8 +22601,8 @@
         </p:nvSpPr>
         <p:spPr>
           <a:xfrm>
-            <a:off x="6265672" y="4791456"/>
-            <a:ext cx="1011936" cy="256032"/>
+            <a:off x="7236968" y="4791456"/>
+            <a:ext cx="681736" cy="256032"/>
           </a:xfrm>
           <a:prstGeom prst="rect">
             <a:avLst/>
@@ -22626,7 +22626,7 @@
                 <a:ea typeface="Calibri" pitchFamily="34" charset="-122"/>
                 <a:cs typeface="Calibri" pitchFamily="34" charset="-120"/>
               </a:rPr>
-              <a:t>context pull</a:t>
+              <a:t>explain</a:t>
             </a:r>
             <a:endParaRPr lang="en-US" sz="1000" dirty="0"/>
           </a:p>
@@ -22640,8 +22640,8 @@
         </p:nvSpPr>
         <p:spPr>
           <a:xfrm>
-            <a:off x="7369048" y="4791456"/>
-            <a:ext cx="813816" cy="256032"/>
+            <a:off x="8010144" y="4791456"/>
+            <a:ext cx="483616" cy="256032"/>
           </a:xfrm>
           <a:prstGeom prst="roundRect">
             <a:avLst>
@@ -22667,8 +22667,8 @@
         </p:nvSpPr>
         <p:spPr>
           <a:xfrm>
-            <a:off x="7369048" y="4791456"/>
-            <a:ext cx="813816" cy="256032"/>
+            <a:off x="8010144" y="4791456"/>
+            <a:ext cx="483616" cy="256032"/>
           </a:xfrm>
           <a:prstGeom prst="rect">
             <a:avLst/>
@@ -22692,7 +22692,7 @@
                 <a:ea typeface="Calibri" pitchFamily="34" charset="-122"/>
                 <a:cs typeface="Calibri" pitchFamily="34" charset="-120"/>
               </a:rPr>
-              <a:t>mcp serve</a:t>
+              <a:t>help</a:t>
             </a:r>
             <a:endParaRPr lang="en-US" sz="1000" dirty="0"/>
           </a:p>
@@ -22706,8 +22706,8 @@
         </p:nvSpPr>
         <p:spPr>
           <a:xfrm>
-            <a:off x="8274304" y="4791456"/>
-            <a:ext cx="813816" cy="256032"/>
+            <a:off x="8585200" y="4791456"/>
+            <a:ext cx="549656" cy="256032"/>
           </a:xfrm>
           <a:prstGeom prst="roundRect">
             <a:avLst>
@@ -22733,8 +22733,8 @@
         </p:nvSpPr>
         <p:spPr>
           <a:xfrm>
-            <a:off x="8274304" y="4791456"/>
-            <a:ext cx="813816" cy="256032"/>
+            <a:off x="8585200" y="4791456"/>
+            <a:ext cx="549656" cy="256032"/>
           </a:xfrm>
           <a:prstGeom prst="rect">
             <a:avLst/>
@@ -22758,7 +22758,7 @@
                 <a:ea typeface="Calibri" pitchFamily="34" charset="-122"/>
                 <a:cs typeface="Calibri" pitchFamily="34" charset="-120"/>
               </a:rPr>
-              <a:t>mcp check</a:t>
+              <a:t>guide</a:t>
             </a:r>
             <a:endParaRPr lang="en-US" sz="1000" dirty="0"/>
           </a:p>
@@ -22772,7 +22772,7 @@
         </p:nvSpPr>
         <p:spPr>
           <a:xfrm>
-            <a:off x="9179560" y="4791456"/>
+            <a:off x="9226296" y="4791456"/>
             <a:ext cx="879856" cy="256032"/>
           </a:xfrm>
           <a:prstGeom prst="roundRect">
@@ -22799,7 +22799,7 @@
         </p:nvSpPr>
         <p:spPr>
           <a:xfrm>
-            <a:off x="9179560" y="4791456"/>
+            <a:off x="9226296" y="4791456"/>
             <a:ext cx="879856" cy="256032"/>
           </a:xfrm>
           <a:prstGeom prst="rect">
@@ -22824,7 +22824,7 @@
                 <a:ea typeface="Calibri" pitchFamily="34" charset="-122"/>
                 <a:cs typeface="Calibri" pitchFamily="34" charset="-120"/>
               </a:rPr>
-              <a:t>inbox list</a:t>
+              <a:t>statusline</a:t>
             </a:r>
             <a:endParaRPr lang="en-US" sz="1000" dirty="0"/>
           </a:p>
@@ -22838,8 +22838,8 @@
         </p:nvSpPr>
         <p:spPr>
           <a:xfrm>
-            <a:off x="10150856" y="4791456"/>
-            <a:ext cx="879856" cy="256032"/>
+            <a:off x="10197592" y="4791456"/>
+            <a:ext cx="1011936" cy="256032"/>
           </a:xfrm>
           <a:prstGeom prst="roundRect">
             <a:avLst>
@@ -22865,8 +22865,8 @@
         </p:nvSpPr>
         <p:spPr>
           <a:xfrm>
-            <a:off x="10150856" y="4791456"/>
-            <a:ext cx="879856" cy="256032"/>
+            <a:off x="10197592" y="4791456"/>
+            <a:ext cx="1011936" cy="256032"/>
           </a:xfrm>
           <a:prstGeom prst="rect">
             <a:avLst/>
@@ -22890,7 +22890,7 @@
                 <a:ea typeface="Calibri" pitchFamily="34" charset="-122"/>
                 <a:cs typeface="Calibri" pitchFamily="34" charset="-120"/>
               </a:rPr>
-              <a:t>inbox done</a:t>
+              <a:t>context pull</a:t>
             </a:r>
             <a:endParaRPr lang="en-US" sz="1000" dirty="0"/>
           </a:p>
@@ -22905,7 +22905,7 @@
         <p:spPr>
           <a:xfrm>
             <a:off x="457200" y="5138928"/>
-            <a:ext cx="945896" cy="256032"/>
+            <a:ext cx="813816" cy="256032"/>
           </a:xfrm>
           <a:prstGeom prst="roundRect">
             <a:avLst>
@@ -22932,7 +22932,7 @@
         <p:spPr>
           <a:xfrm>
             <a:off x="457200" y="5138928"/>
-            <a:ext cx="945896" cy="256032"/>
+            <a:ext cx="813816" cy="256032"/>
           </a:xfrm>
           <a:prstGeom prst="rect">
             <a:avLst/>
@@ -22956,7 +22956,7 @@
                 <a:ea typeface="Calibri" pitchFamily="34" charset="-122"/>
                 <a:cs typeface="Calibri" pitchFamily="34" charset="-120"/>
               </a:rPr>
-              <a:t>events list</a:t>
+              <a:t>mcp serve</a:t>
             </a:r>
             <a:endParaRPr lang="en-US" sz="1000" dirty="0"/>
           </a:p>
@@ -22970,8 +22970,8 @@
         </p:nvSpPr>
         <p:spPr>
           <a:xfrm>
-            <a:off x="1494536" y="5138928"/>
-            <a:ext cx="1011936" cy="256032"/>
+            <a:off x="1362456" y="5138928"/>
+            <a:ext cx="813816" cy="256032"/>
           </a:xfrm>
           <a:prstGeom prst="roundRect">
             <a:avLst>
@@ -22997,8 +22997,8 @@
         </p:nvSpPr>
         <p:spPr>
           <a:xfrm>
-            <a:off x="1494536" y="5138928"/>
-            <a:ext cx="1011936" cy="256032"/>
+            <a:off x="1362456" y="5138928"/>
+            <a:ext cx="813816" cy="256032"/>
           </a:xfrm>
           <a:prstGeom prst="rect">
             <a:avLst/>
@@ -23022,7 +23022,7 @@
                 <a:ea typeface="Calibri" pitchFamily="34" charset="-122"/>
                 <a:cs typeface="Calibri" pitchFamily="34" charset="-120"/>
               </a:rPr>
-              <a:t>events flush</a:t>
+              <a:t>mcp check</a:t>
             </a:r>
             <a:endParaRPr lang="en-US" sz="1000" dirty="0"/>
           </a:p>
@@ -23036,8 +23036,8 @@
         </p:nvSpPr>
         <p:spPr>
           <a:xfrm>
-            <a:off x="2597912" y="5138928"/>
-            <a:ext cx="1144016" cy="256032"/>
+            <a:off x="2267712" y="5138928"/>
+            <a:ext cx="879856" cy="256032"/>
           </a:xfrm>
           <a:prstGeom prst="roundRect">
             <a:avLst>
@@ -23063,8 +23063,8 @@
         </p:nvSpPr>
         <p:spPr>
           <a:xfrm>
-            <a:off x="2597912" y="5138928"/>
-            <a:ext cx="1144016" cy="256032"/>
+            <a:off x="2267712" y="5138928"/>
+            <a:ext cx="879856" cy="256032"/>
           </a:xfrm>
           <a:prstGeom prst="rect">
             <a:avLst/>
@@ -23088,7 +23088,7 @@
                 <a:ea typeface="Calibri" pitchFamily="34" charset="-122"/>
                 <a:cs typeface="Calibri" pitchFamily="34" charset="-120"/>
               </a:rPr>
-              <a:t>events summary</a:t>
+              <a:t>inbox list</a:t>
             </a:r>
             <a:endParaRPr lang="en-US" sz="1000" dirty="0"/>
           </a:p>
@@ -23102,8 +23102,8 @@
         </p:nvSpPr>
         <p:spPr>
           <a:xfrm>
-            <a:off x="3833368" y="5138928"/>
-            <a:ext cx="1077976" cy="256032"/>
+            <a:off x="3239008" y="5138928"/>
+            <a:ext cx="879856" cy="256032"/>
           </a:xfrm>
           <a:prstGeom prst="roundRect">
             <a:avLst>
@@ -23129,8 +23129,8 @@
         </p:nvSpPr>
         <p:spPr>
           <a:xfrm>
-            <a:off x="3833368" y="5138928"/>
-            <a:ext cx="1077976" cy="256032"/>
+            <a:off x="3239008" y="5138928"/>
+            <a:ext cx="879856" cy="256032"/>
           </a:xfrm>
           <a:prstGeom prst="rect">
             <a:avLst/>
@@ -23154,7 +23154,7 @@
                 <a:ea typeface="Calibri" pitchFamily="34" charset="-122"/>
                 <a:cs typeface="Calibri" pitchFamily="34" charset="-120"/>
               </a:rPr>
-              <a:t>triage intake</a:t>
+              <a:t>inbox done</a:t>
             </a:r>
             <a:endParaRPr lang="en-US" sz="1000" dirty="0"/>
           </a:p>
@@ -23168,8 +23168,8 @@
         </p:nvSpPr>
         <p:spPr>
           <a:xfrm>
-            <a:off x="5002784" y="5138928"/>
-            <a:ext cx="1077976" cy="256032"/>
+            <a:off x="4210304" y="5138928"/>
+            <a:ext cx="945896" cy="256032"/>
           </a:xfrm>
           <a:prstGeom prst="roundRect">
             <a:avLst>
@@ -23195,8 +23195,8 @@
         </p:nvSpPr>
         <p:spPr>
           <a:xfrm>
-            <a:off x="5002784" y="5138928"/>
-            <a:ext cx="1077976" cy="256032"/>
+            <a:off x="4210304" y="5138928"/>
+            <a:ext cx="945896" cy="256032"/>
           </a:xfrm>
           <a:prstGeom prst="rect">
             <a:avLst/>
@@ -23220,7 +23220,7 @@
                 <a:ea typeface="Calibri" pitchFamily="34" charset="-122"/>
                 <a:cs typeface="Calibri" pitchFamily="34" charset="-120"/>
               </a:rPr>
-              <a:t>release check</a:t>
+              <a:t>events list</a:t>
             </a:r>
             <a:endParaRPr lang="en-US" sz="1000" dirty="0"/>
           </a:p>
@@ -23234,8 +23234,8 @@
         </p:nvSpPr>
         <p:spPr>
           <a:xfrm>
-            <a:off x="6172200" y="5138928"/>
-            <a:ext cx="813816" cy="256032"/>
+            <a:off x="5247640" y="5138928"/>
+            <a:ext cx="1011936" cy="256032"/>
           </a:xfrm>
           <a:prstGeom prst="roundRect">
             <a:avLst>
@@ -23261,8 +23261,8 @@
         </p:nvSpPr>
         <p:spPr>
           <a:xfrm>
-            <a:off x="6172200" y="5138928"/>
-            <a:ext cx="813816" cy="256032"/>
+            <a:off x="5247640" y="5138928"/>
+            <a:ext cx="1011936" cy="256032"/>
           </a:xfrm>
           <a:prstGeom prst="rect">
             <a:avLst/>
@@ -23286,7 +23286,7 @@
                 <a:ea typeface="Calibri" pitchFamily="34" charset="-122"/>
                 <a:cs typeface="Calibri" pitchFamily="34" charset="-120"/>
               </a:rPr>
-              <a:t>track set</a:t>
+              <a:t>events flush</a:t>
             </a:r>
             <a:endParaRPr lang="en-US" sz="1000" dirty="0"/>
           </a:p>
@@ -23300,8 +23300,8 @@
         </p:nvSpPr>
         <p:spPr>
           <a:xfrm>
-            <a:off x="7077456" y="5138928"/>
-            <a:ext cx="483616" cy="256032"/>
+            <a:off x="6351016" y="5138928"/>
+            <a:ext cx="1144016" cy="256032"/>
           </a:xfrm>
           <a:prstGeom prst="roundRect">
             <a:avLst>
@@ -23327,8 +23327,8 @@
         </p:nvSpPr>
         <p:spPr>
           <a:xfrm>
-            <a:off x="7077456" y="5138928"/>
-            <a:ext cx="483616" cy="256032"/>
+            <a:off x="6351016" y="5138928"/>
+            <a:ext cx="1144016" cy="256032"/>
           </a:xfrm>
           <a:prstGeom prst="rect">
             <a:avLst/>
@@ -23352,7 +23352,7 @@
                 <a:ea typeface="Calibri" pitchFamily="34" charset="-122"/>
                 <a:cs typeface="Calibri" pitchFamily="34" charset="-120"/>
               </a:rPr>
-              <a:t>next</a:t>
+              <a:t>events summary</a:t>
             </a:r>
             <a:endParaRPr lang="en-US" sz="1000" dirty="0"/>
           </a:p>
@@ -23366,8 +23366,8 @@
         </p:nvSpPr>
         <p:spPr>
           <a:xfrm>
-            <a:off x="7652512" y="5138928"/>
-            <a:ext cx="1011936" cy="256032"/>
+            <a:off x="7586472" y="5138928"/>
+            <a:ext cx="1077976" cy="256032"/>
           </a:xfrm>
           <a:prstGeom prst="roundRect">
             <a:avLst>
@@ -23393,8 +23393,8 @@
         </p:nvSpPr>
         <p:spPr>
           <a:xfrm>
-            <a:off x="7652512" y="5138928"/>
-            <a:ext cx="1011936" cy="256032"/>
+            <a:off x="7586472" y="5138928"/>
+            <a:ext cx="1077976" cy="256032"/>
           </a:xfrm>
           <a:prstGeom prst="rect">
             <a:avLst/>
@@ -23418,7 +23418,7 @@
                 <a:ea typeface="Calibri" pitchFamily="34" charset="-122"/>
                 <a:cs typeface="Calibri" pitchFamily="34" charset="-120"/>
               </a:rPr>
-              <a:t>instructions</a:t>
+              <a:t>triage intake</a:t>
             </a:r>
             <a:endParaRPr lang="en-US" sz="1000" dirty="0"/>
           </a:p>
@@ -23433,7 +23433,7 @@
         <p:spPr>
           <a:xfrm>
             <a:off x="8755888" y="5138928"/>
-            <a:ext cx="681736" cy="256032"/>
+            <a:ext cx="1077976" cy="256032"/>
           </a:xfrm>
           <a:prstGeom prst="roundRect">
             <a:avLst>
@@ -23460,7 +23460,7 @@
         <p:spPr>
           <a:xfrm>
             <a:off x="8755888" y="5138928"/>
-            <a:ext cx="681736" cy="256032"/>
+            <a:ext cx="1077976" cy="256032"/>
           </a:xfrm>
           <a:prstGeom prst="rect">
             <a:avLst/>
@@ -23484,7 +23484,7 @@
                 <a:ea typeface="Calibri" pitchFamily="34" charset="-122"/>
                 <a:cs typeface="Calibri" pitchFamily="34" charset="-120"/>
               </a:rPr>
-              <a:t>approve</a:t>
+              <a:t>release check</a:t>
             </a:r>
             <a:endParaRPr lang="en-US" sz="1000" dirty="0"/>
           </a:p>
@@ -23498,8 +23498,8 @@
         </p:nvSpPr>
         <p:spPr>
           <a:xfrm>
-            <a:off x="9529064" y="5138928"/>
-            <a:ext cx="615696" cy="256032"/>
+            <a:off x="9925304" y="5138928"/>
+            <a:ext cx="813816" cy="256032"/>
           </a:xfrm>
           <a:prstGeom prst="roundRect">
             <a:avLst>
@@ -23525,8 +23525,8 @@
         </p:nvSpPr>
         <p:spPr>
           <a:xfrm>
-            <a:off x="9529064" y="5138928"/>
-            <a:ext cx="615696" cy="256032"/>
+            <a:off x="9925304" y="5138928"/>
+            <a:ext cx="813816" cy="256032"/>
           </a:xfrm>
           <a:prstGeom prst="rect">
             <a:avLst/>
@@ -23550,7 +23550,7 @@
                 <a:ea typeface="Calibri" pitchFamily="34" charset="-122"/>
                 <a:cs typeface="Calibri" pitchFamily="34" charset="-120"/>
               </a:rPr>
-              <a:t>reject</a:t>
+              <a:t>track set</a:t>
             </a:r>
             <a:endParaRPr lang="en-US" sz="1000" dirty="0"/>
           </a:p>
@@ -23564,8 +23564,8 @@
         </p:nvSpPr>
         <p:spPr>
           <a:xfrm>
-            <a:off x="10236200" y="5138928"/>
-            <a:ext cx="549656" cy="256032"/>
+            <a:off x="10830560" y="5138928"/>
+            <a:ext cx="483616" cy="256032"/>
           </a:xfrm>
           <a:prstGeom prst="roundRect">
             <a:avLst>
@@ -23591,8 +23591,8 @@
         </p:nvSpPr>
         <p:spPr>
           <a:xfrm>
-            <a:off x="10236200" y="5138928"/>
-            <a:ext cx="549656" cy="256032"/>
+            <a:off x="10830560" y="5138928"/>
+            <a:ext cx="483616" cy="256032"/>
           </a:xfrm>
           <a:prstGeom prst="rect">
             <a:avLst/>
@@ -23616,7 +23616,7 @@
                 <a:ea typeface="Calibri" pitchFamily="34" charset="-122"/>
                 <a:cs typeface="Calibri" pitchFamily="34" charset="-120"/>
               </a:rPr>
-              <a:t>waive</a:t>
+              <a:t>next</a:t>
             </a:r>
             <a:endParaRPr lang="en-US" sz="1000" dirty="0"/>
           </a:p>
@@ -23630,8 +23630,8 @@
         </p:nvSpPr>
         <p:spPr>
           <a:xfrm>
-            <a:off x="10877296" y="5138928"/>
-            <a:ext cx="615696" cy="256032"/>
+            <a:off x="457200" y="5486400"/>
+            <a:ext cx="1011936" cy="256032"/>
           </a:xfrm>
           <a:prstGeom prst="roundRect">
             <a:avLst>
@@ -23657,8 +23657,8 @@
         </p:nvSpPr>
         <p:spPr>
           <a:xfrm>
-            <a:off x="10877296" y="5138928"/>
-            <a:ext cx="615696" cy="256032"/>
+            <a:off x="457200" y="5486400"/>
+            <a:ext cx="1011936" cy="256032"/>
           </a:xfrm>
           <a:prstGeom prst="rect">
             <a:avLst/>
@@ -23682,7 +23682,7 @@
                 <a:ea typeface="Calibri" pitchFamily="34" charset="-122"/>
                 <a:cs typeface="Calibri" pitchFamily="34" charset="-120"/>
               </a:rPr>
-              <a:t>answer</a:t>
+              <a:t>instructions</a:t>
             </a:r>
             <a:endParaRPr lang="en-US" sz="1000" dirty="0"/>
           </a:p>
@@ -23696,8 +23696,8 @@
         </p:nvSpPr>
         <p:spPr>
           <a:xfrm>
-            <a:off x="457200" y="5486400"/>
-            <a:ext cx="549656" cy="256032"/>
+            <a:off x="1560576" y="5486400"/>
+            <a:ext cx="681736" cy="256032"/>
           </a:xfrm>
           <a:prstGeom prst="roundRect">
             <a:avLst>
@@ -23723,8 +23723,8 @@
         </p:nvSpPr>
         <p:spPr>
           <a:xfrm>
-            <a:off x="457200" y="5486400"/>
-            <a:ext cx="549656" cy="256032"/>
+            <a:off x="1560576" y="5486400"/>
+            <a:ext cx="681736" cy="256032"/>
           </a:xfrm>
           <a:prstGeom prst="rect">
             <a:avLst/>
@@ -23748,7 +23748,7 @@
                 <a:ea typeface="Calibri" pitchFamily="34" charset="-122"/>
                 <a:cs typeface="Calibri" pitchFamily="34" charset="-120"/>
               </a:rPr>
-              <a:t>judge</a:t>
+              <a:t>approve</a:t>
             </a:r>
             <a:endParaRPr lang="en-US" sz="1000" dirty="0"/>
           </a:p>
@@ -23762,8 +23762,8 @@
         </p:nvSpPr>
         <p:spPr>
           <a:xfrm>
-            <a:off x="1098296" y="5486400"/>
-            <a:ext cx="747776" cy="256032"/>
+            <a:off x="2333752" y="5486400"/>
+            <a:ext cx="615696" cy="256032"/>
           </a:xfrm>
           <a:prstGeom prst="roundRect">
             <a:avLst>
@@ -23789,8 +23789,8 @@
         </p:nvSpPr>
         <p:spPr>
           <a:xfrm>
-            <a:off x="1098296" y="5486400"/>
-            <a:ext cx="747776" cy="256032"/>
+            <a:off x="2333752" y="5486400"/>
+            <a:ext cx="615696" cy="256032"/>
           </a:xfrm>
           <a:prstGeom prst="rect">
             <a:avLst/>
@@ -23814,7 +23814,7 @@
                 <a:ea typeface="Calibri" pitchFamily="34" charset="-122"/>
                 <a:cs typeface="Calibri" pitchFamily="34" charset="-120"/>
               </a:rPr>
-              <a:t>takeover</a:t>
+              <a:t>reject</a:t>
             </a:r>
             <a:endParaRPr lang="en-US" sz="1000" dirty="0"/>
           </a:p>
@@ -23828,8 +23828,8 @@
         </p:nvSpPr>
         <p:spPr>
           <a:xfrm>
-            <a:off x="1937512" y="5486400"/>
-            <a:ext cx="1210056" cy="256032"/>
+            <a:off x="3040888" y="5486400"/>
+            <a:ext cx="549656" cy="256032"/>
           </a:xfrm>
           <a:prstGeom prst="roundRect">
             <a:avLst>
@@ -23855,8 +23855,8 @@
         </p:nvSpPr>
         <p:spPr>
           <a:xfrm>
-            <a:off x="1937512" y="5486400"/>
-            <a:ext cx="1210056" cy="256032"/>
+            <a:off x="3040888" y="5486400"/>
+            <a:ext cx="549656" cy="256032"/>
           </a:xfrm>
           <a:prstGeom prst="rect">
             <a:avLst/>
@@ -23880,7 +23880,7 @@
                 <a:ea typeface="Calibri" pitchFamily="34" charset="-122"/>
                 <a:cs typeface="Calibri" pitchFamily="34" charset="-120"/>
               </a:rPr>
-              <a:t>release-control</a:t>
+              <a:t>waive</a:t>
             </a:r>
             <a:endParaRPr lang="en-US" sz="1000" dirty="0"/>
           </a:p>
@@ -23894,7 +23894,7 @@
         </p:nvSpPr>
         <p:spPr>
           <a:xfrm>
-            <a:off x="3239008" y="5486400"/>
+            <a:off x="3681984" y="5486400"/>
             <a:ext cx="615696" cy="256032"/>
           </a:xfrm>
           <a:prstGeom prst="roundRect">
@@ -23921,7 +23921,7 @@
         </p:nvSpPr>
         <p:spPr>
           <a:xfrm>
-            <a:off x="3239008" y="5486400"/>
+            <a:off x="3681984" y="5486400"/>
             <a:ext cx="615696" cy="256032"/>
           </a:xfrm>
           <a:prstGeom prst="rect">
@@ -23946,7 +23946,7 @@
                 <a:ea typeface="Calibri" pitchFamily="34" charset="-122"/>
                 <a:cs typeface="Calibri" pitchFamily="34" charset="-120"/>
               </a:rPr>
-              <a:t>rework</a:t>
+              <a:t>answer</a:t>
             </a:r>
             <a:endParaRPr lang="en-US" sz="1000" dirty="0"/>
           </a:p>
@@ -23960,8 +23960,8 @@
         </p:nvSpPr>
         <p:spPr>
           <a:xfrm>
-            <a:off x="3946144" y="5486400"/>
-            <a:ext cx="1276096" cy="256032"/>
+            <a:off x="4389120" y="5486400"/>
+            <a:ext cx="549656" cy="256032"/>
           </a:xfrm>
           <a:prstGeom prst="roundRect">
             <a:avLst>
@@ -23987,8 +23987,8 @@
         </p:nvSpPr>
         <p:spPr>
           <a:xfrm>
-            <a:off x="3946144" y="5486400"/>
-            <a:ext cx="1276096" cy="256032"/>
+            <a:off x="4389120" y="5486400"/>
+            <a:ext cx="549656" cy="256032"/>
           </a:xfrm>
           <a:prstGeom prst="rect">
             <a:avLst/>
@@ -24012,7 +24012,7 @@
                 <a:ea typeface="Calibri" pitchFamily="34" charset="-122"/>
                 <a:cs typeface="Calibri" pitchFamily="34" charset="-120"/>
               </a:rPr>
-              <a:t>approvals verify</a:t>
+              <a:t>judge</a:t>
             </a:r>
             <a:endParaRPr lang="en-US" sz="1000" dirty="0"/>
           </a:p>
@@ -24026,8 +24026,8 @@
         </p:nvSpPr>
         <p:spPr>
           <a:xfrm>
-            <a:off x="5313680" y="5486400"/>
-            <a:ext cx="549656" cy="256032"/>
+            <a:off x="5030216" y="5486400"/>
+            <a:ext cx="747776" cy="256032"/>
           </a:xfrm>
           <a:prstGeom prst="roundRect">
             <a:avLst>
@@ -24053,8 +24053,8 @@
         </p:nvSpPr>
         <p:spPr>
           <a:xfrm>
-            <a:off x="5313680" y="5486400"/>
-            <a:ext cx="549656" cy="256032"/>
+            <a:off x="5030216" y="5486400"/>
+            <a:ext cx="747776" cy="256032"/>
           </a:xfrm>
           <a:prstGeom prst="rect">
             <a:avLst/>
@@ -24078,7 +24078,7 @@
                 <a:ea typeface="Calibri" pitchFamily="34" charset="-122"/>
                 <a:cs typeface="Calibri" pitchFamily="34" charset="-120"/>
               </a:rPr>
-              <a:t>tests</a:t>
+              <a:t>takeover</a:t>
             </a:r>
             <a:endParaRPr lang="en-US" sz="1000" dirty="0"/>
           </a:p>
@@ -24092,8 +24092,8 @@
         </p:nvSpPr>
         <p:spPr>
           <a:xfrm>
-            <a:off x="5954776" y="5486400"/>
-            <a:ext cx="1540256" cy="256032"/>
+            <a:off x="5869432" y="5486400"/>
+            <a:ext cx="1210056" cy="256032"/>
           </a:xfrm>
           <a:prstGeom prst="roundRect">
             <a:avLst>
@@ -24119,8 +24119,8 @@
         </p:nvSpPr>
         <p:spPr>
           <a:xfrm>
-            <a:off x="5954776" y="5486400"/>
-            <a:ext cx="1540256" cy="256032"/>
+            <a:off x="5869432" y="5486400"/>
+            <a:ext cx="1210056" cy="256032"/>
           </a:xfrm>
           <a:prstGeom prst="rect">
             <a:avLst/>
@@ -24144,7 +24144,7 @@
                 <a:ea typeface="Calibri" pitchFamily="34" charset="-122"/>
                 <a:cs typeface="Calibri" pitchFamily="34" charset="-120"/>
               </a:rPr>
-              <a:t>task executors token</a:t>
+              <a:t>release-control</a:t>
             </a:r>
             <a:endParaRPr lang="en-US" sz="1000" dirty="0"/>
           </a:p>
@@ -24158,8 +24158,8 @@
         </p:nvSpPr>
         <p:spPr>
           <a:xfrm>
-            <a:off x="7586472" y="5486400"/>
-            <a:ext cx="945896" cy="256032"/>
+            <a:off x="7170928" y="5486400"/>
+            <a:ext cx="615696" cy="256032"/>
           </a:xfrm>
           <a:prstGeom prst="roundRect">
             <a:avLst>
@@ -24185,8 +24185,8 @@
         </p:nvSpPr>
         <p:spPr>
           <a:xfrm>
-            <a:off x="7586472" y="5486400"/>
-            <a:ext cx="945896" cy="256032"/>
+            <a:off x="7170928" y="5486400"/>
+            <a:ext cx="615696" cy="256032"/>
           </a:xfrm>
           <a:prstGeom prst="rect">
             <a:avLst/>
@@ -24210,7 +24210,7 @@
                 <a:ea typeface="Calibri" pitchFamily="34" charset="-122"/>
                 <a:cs typeface="Calibri" pitchFamily="34" charset="-120"/>
               </a:rPr>
-              <a:t>task export</a:t>
+              <a:t>rework</a:t>
             </a:r>
             <a:endParaRPr lang="en-US" sz="1000" dirty="0"/>
           </a:p>
@@ -24224,8 +24224,8 @@
         </p:nvSpPr>
         <p:spPr>
           <a:xfrm>
-            <a:off x="8623808" y="5486400"/>
-            <a:ext cx="1342136" cy="256032"/>
+            <a:off x="7878064" y="5486400"/>
+            <a:ext cx="1276096" cy="256032"/>
           </a:xfrm>
           <a:prstGeom prst="roundRect">
             <a:avLst>
@@ -24251,8 +24251,8 @@
         </p:nvSpPr>
         <p:spPr>
           <a:xfrm>
-            <a:off x="8623808" y="5486400"/>
-            <a:ext cx="1342136" cy="256032"/>
+            <a:off x="7878064" y="5486400"/>
+            <a:ext cx="1276096" cy="256032"/>
           </a:xfrm>
           <a:prstGeom prst="rect">
             <a:avLst/>
@@ -24276,7 +24276,7 @@
                 <a:ea typeface="Calibri" pitchFamily="34" charset="-122"/>
                 <a:cs typeface="Calibri" pitchFamily="34" charset="-120"/>
               </a:rPr>
-              <a:t>task check-result</a:t>
+              <a:t>approvals verify</a:t>
             </a:r>
             <a:endParaRPr lang="en-US" sz="1000" dirty="0"/>
           </a:p>
@@ -24290,8 +24290,8 @@
         </p:nvSpPr>
         <p:spPr>
           <a:xfrm>
-            <a:off x="10057384" y="5486400"/>
-            <a:ext cx="879856" cy="256032"/>
+            <a:off x="9245600" y="5486400"/>
+            <a:ext cx="549656" cy="256032"/>
           </a:xfrm>
           <a:prstGeom prst="roundRect">
             <a:avLst>
@@ -24317,8 +24317,8 @@
         </p:nvSpPr>
         <p:spPr>
           <a:xfrm>
-            <a:off x="10057384" y="5486400"/>
-            <a:ext cx="879856" cy="256032"/>
+            <a:off x="9245600" y="5486400"/>
+            <a:ext cx="549656" cy="256032"/>
           </a:xfrm>
           <a:prstGeom prst="rect">
             <a:avLst/>
@@ -24342,7 +24342,7 @@
                 <a:ea typeface="Calibri" pitchFamily="34" charset="-122"/>
                 <a:cs typeface="Calibri" pitchFamily="34" charset="-120"/>
               </a:rPr>
-              <a:t>board list</a:t>
+              <a:t>tests</a:t>
             </a:r>
             <a:endParaRPr lang="en-US" sz="1000" dirty="0"/>
           </a:p>
@@ -24356,8 +24356,8 @@
         </p:nvSpPr>
         <p:spPr>
           <a:xfrm>
-            <a:off x="457200" y="5833872"/>
-            <a:ext cx="1144016" cy="256032"/>
+            <a:off x="9886696" y="5486400"/>
+            <a:ext cx="1540256" cy="256032"/>
           </a:xfrm>
           <a:prstGeom prst="roundRect">
             <a:avLst>
@@ -24383,8 +24383,8 @@
         </p:nvSpPr>
         <p:spPr>
           <a:xfrm>
-            <a:off x="457200" y="5833872"/>
-            <a:ext cx="1144016" cy="256032"/>
+            <a:off x="9886696" y="5486400"/>
+            <a:ext cx="1540256" cy="256032"/>
           </a:xfrm>
           <a:prstGeom prst="rect">
             <a:avLst/>
@@ -24408,7 +24408,7 @@
                 <a:ea typeface="Calibri" pitchFamily="34" charset="-122"/>
                 <a:cs typeface="Calibri" pitchFamily="34" charset="-120"/>
               </a:rPr>
-              <a:t>board dispatch</a:t>
+              <a:t>task executors token</a:t>
             </a:r>
             <a:endParaRPr lang="en-US" sz="1000" dirty="0"/>
           </a:p>
@@ -24422,8 +24422,8 @@
         </p:nvSpPr>
         <p:spPr>
           <a:xfrm>
-            <a:off x="1692656" y="5833872"/>
-            <a:ext cx="1077976" cy="256032"/>
+            <a:off x="457200" y="5833872"/>
+            <a:ext cx="945896" cy="256032"/>
           </a:xfrm>
           <a:prstGeom prst="roundRect">
             <a:avLst>
@@ -24449,8 +24449,8 @@
         </p:nvSpPr>
         <p:spPr>
           <a:xfrm>
-            <a:off x="1692656" y="5833872"/>
-            <a:ext cx="1077976" cy="256032"/>
+            <a:off x="457200" y="5833872"/>
+            <a:ext cx="945896" cy="256032"/>
           </a:xfrm>
           <a:prstGeom prst="rect">
             <a:avLst/>
@@ -24474,7 +24474,7 @@
                 <a:ea typeface="Calibri" pitchFamily="34" charset="-122"/>
                 <a:cs typeface="Calibri" pitchFamily="34" charset="-120"/>
               </a:rPr>
-              <a:t>board auction</a:t>
+              <a:t>task export</a:t>
             </a:r>
             <a:endParaRPr lang="en-US" sz="1000" dirty="0"/>
           </a:p>
@@ -24488,8 +24488,8 @@
         </p:nvSpPr>
         <p:spPr>
           <a:xfrm>
-            <a:off x="2862072" y="5833872"/>
-            <a:ext cx="813816" cy="256032"/>
+            <a:off x="1494536" y="5833872"/>
+            <a:ext cx="1342136" cy="256032"/>
           </a:xfrm>
           <a:prstGeom prst="roundRect">
             <a:avLst>
@@ -24515,8 +24515,8 @@
         </p:nvSpPr>
         <p:spPr>
           <a:xfrm>
-            <a:off x="2862072" y="5833872"/>
-            <a:ext cx="813816" cy="256032"/>
+            <a:off x="1494536" y="5833872"/>
+            <a:ext cx="1342136" cy="256032"/>
           </a:xfrm>
           <a:prstGeom prst="rect">
             <a:avLst/>
@@ -24540,7 +24540,7 @@
                 <a:ea typeface="Calibri" pitchFamily="34" charset="-122"/>
                 <a:cs typeface="Calibri" pitchFamily="34" charset="-120"/>
               </a:rPr>
-              <a:t>board bid</a:t>
+              <a:t>task check-result</a:t>
             </a:r>
             <a:endParaRPr lang="en-US" sz="1000" dirty="0"/>
           </a:p>
@@ -24554,8 +24554,8 @@
         </p:nvSpPr>
         <p:spPr>
           <a:xfrm>
-            <a:off x="3767328" y="5833872"/>
-            <a:ext cx="945896" cy="256032"/>
+            <a:off x="2928112" y="5833872"/>
+            <a:ext cx="879856" cy="256032"/>
           </a:xfrm>
           <a:prstGeom prst="roundRect">
             <a:avLst>
@@ -24581,8 +24581,8 @@
         </p:nvSpPr>
         <p:spPr>
           <a:xfrm>
-            <a:off x="3767328" y="5833872"/>
-            <a:ext cx="945896" cy="256032"/>
+            <a:off x="2928112" y="5833872"/>
+            <a:ext cx="879856" cy="256032"/>
           </a:xfrm>
           <a:prstGeom prst="rect">
             <a:avLst/>
@@ -24606,7 +24606,7 @@
                 <a:ea typeface="Calibri" pitchFamily="34" charset="-122"/>
                 <a:cs typeface="Calibri" pitchFamily="34" charset="-120"/>
               </a:rPr>
-              <a:t>board award</a:t>
+              <a:t>board list</a:t>
             </a:r>
             <a:endParaRPr lang="en-US" sz="1000" dirty="0"/>
           </a:p>
@@ -24620,8 +24620,8 @@
         </p:nvSpPr>
         <p:spPr>
           <a:xfrm>
-            <a:off x="4804664" y="5833872"/>
-            <a:ext cx="945896" cy="256032"/>
+            <a:off x="3899408" y="5833872"/>
+            <a:ext cx="1144016" cy="256032"/>
           </a:xfrm>
           <a:prstGeom prst="roundRect">
             <a:avLst>
@@ -24647,8 +24647,8 @@
         </p:nvSpPr>
         <p:spPr>
           <a:xfrm>
-            <a:off x="4804664" y="5833872"/>
-            <a:ext cx="945896" cy="256032"/>
+            <a:off x="3899408" y="5833872"/>
+            <a:ext cx="1144016" cy="256032"/>
           </a:xfrm>
           <a:prstGeom prst="rect">
             <a:avLst/>
@@ -24672,7 +24672,7 @@
                 <a:ea typeface="Calibri" pitchFamily="34" charset="-122"/>
                 <a:cs typeface="Calibri" pitchFamily="34" charset="-120"/>
               </a:rPr>
-              <a:t>board claim</a:t>
+              <a:t>board dispatch</a:t>
             </a:r>
             <a:endParaRPr lang="en-US" sz="1000" dirty="0"/>
           </a:p>
@@ -24686,8 +24686,8 @@
         </p:nvSpPr>
         <p:spPr>
           <a:xfrm>
-            <a:off x="5842000" y="5833872"/>
-            <a:ext cx="1210056" cy="256032"/>
+            <a:off x="5134864" y="5833872"/>
+            <a:ext cx="1077976" cy="256032"/>
           </a:xfrm>
           <a:prstGeom prst="roundRect">
             <a:avLst>
@@ -24713,8 +24713,8 @@
         </p:nvSpPr>
         <p:spPr>
           <a:xfrm>
-            <a:off x="5842000" y="5833872"/>
-            <a:ext cx="1210056" cy="256032"/>
+            <a:off x="5134864" y="5833872"/>
+            <a:ext cx="1077976" cy="256032"/>
           </a:xfrm>
           <a:prstGeom prst="rect">
             <a:avLst/>
@@ -24738,7 +24738,7 @@
                 <a:ea typeface="Calibri" pitchFamily="34" charset="-122"/>
                 <a:cs typeface="Calibri" pitchFamily="34" charset="-120"/>
               </a:rPr>
-              <a:t>board heartbeat</a:t>
+              <a:t>board auction</a:t>
             </a:r>
             <a:endParaRPr lang="en-US" sz="1000" dirty="0"/>
           </a:p>
@@ -24752,8 +24752,8 @@
         </p:nvSpPr>
         <p:spPr>
           <a:xfrm>
-            <a:off x="7143496" y="5833872"/>
-            <a:ext cx="1077976" cy="256032"/>
+            <a:off x="6304280" y="5833872"/>
+            <a:ext cx="813816" cy="256032"/>
           </a:xfrm>
           <a:prstGeom prst="roundRect">
             <a:avLst>
@@ -24779,8 +24779,8 @@
         </p:nvSpPr>
         <p:spPr>
           <a:xfrm>
-            <a:off x="7143496" y="5833872"/>
-            <a:ext cx="1077976" cy="256032"/>
+            <a:off x="6304280" y="5833872"/>
+            <a:ext cx="813816" cy="256032"/>
           </a:xfrm>
           <a:prstGeom prst="rect">
             <a:avLst/>
@@ -24804,7 +24804,7 @@
                 <a:ea typeface="Calibri" pitchFamily="34" charset="-122"/>
                 <a:cs typeface="Calibri" pitchFamily="34" charset="-120"/>
               </a:rPr>
-              <a:t>board release</a:t>
+              <a:t>board bid</a:t>
             </a:r>
             <a:endParaRPr lang="en-US" sz="1000" dirty="0"/>
           </a:p>
@@ -24818,8 +24818,8 @@
         </p:nvSpPr>
         <p:spPr>
           <a:xfrm>
-            <a:off x="8312912" y="5833872"/>
-            <a:ext cx="1011936" cy="256032"/>
+            <a:off x="7209536" y="5833872"/>
+            <a:ext cx="945896" cy="256032"/>
           </a:xfrm>
           <a:prstGeom prst="roundRect">
             <a:avLst>
@@ -24845,8 +24845,8 @@
         </p:nvSpPr>
         <p:spPr>
           <a:xfrm>
-            <a:off x="8312912" y="5833872"/>
-            <a:ext cx="1011936" cy="256032"/>
+            <a:off x="7209536" y="5833872"/>
+            <a:ext cx="945896" cy="256032"/>
           </a:xfrm>
           <a:prstGeom prst="rect">
             <a:avLst/>
@@ -24870,7 +24870,7 @@
                 <a:ea typeface="Calibri" pitchFamily="34" charset="-122"/>
                 <a:cs typeface="Calibri" pitchFamily="34" charset="-120"/>
               </a:rPr>
-              <a:t>board submit</a:t>
+              <a:t>board award</a:t>
             </a:r>
             <a:endParaRPr lang="en-US" sz="1000" dirty="0"/>
           </a:p>
@@ -24884,8 +24884,8 @@
         </p:nvSpPr>
         <p:spPr>
           <a:xfrm>
-            <a:off x="9416288" y="5833872"/>
-            <a:ext cx="1011936" cy="256032"/>
+            <a:off x="8246872" y="5833872"/>
+            <a:ext cx="945896" cy="256032"/>
           </a:xfrm>
           <a:prstGeom prst="roundRect">
             <a:avLst>
@@ -24911,8 +24911,8 @@
         </p:nvSpPr>
         <p:spPr>
           <a:xfrm>
-            <a:off x="9416288" y="5833872"/>
-            <a:ext cx="1011936" cy="256032"/>
+            <a:off x="8246872" y="5833872"/>
+            <a:ext cx="945896" cy="256032"/>
           </a:xfrm>
           <a:prstGeom prst="rect">
             <a:avLst/>
@@ -24936,7 +24936,7 @@
                 <a:ea typeface="Calibri" pitchFamily="34" charset="-122"/>
                 <a:cs typeface="Calibri" pitchFamily="34" charset="-120"/>
               </a:rPr>
-              <a:t>board reopen</a:t>
+              <a:t>board claim</a:t>
             </a:r>
             <a:endParaRPr lang="en-US" sz="1000" dirty="0"/>
           </a:p>
@@ -24950,8 +24950,8 @@
         </p:nvSpPr>
         <p:spPr>
           <a:xfrm>
-            <a:off x="10519664" y="5833872"/>
-            <a:ext cx="615696" cy="256032"/>
+            <a:off x="9284208" y="5833872"/>
+            <a:ext cx="1210056" cy="256032"/>
           </a:xfrm>
           <a:prstGeom prst="roundRect">
             <a:avLst>
@@ -24977,8 +24977,8 @@
         </p:nvSpPr>
         <p:spPr>
           <a:xfrm>
-            <a:off x="10519664" y="5833872"/>
-            <a:ext cx="615696" cy="256032"/>
+            <a:off x="9284208" y="5833872"/>
+            <a:ext cx="1210056" cy="256032"/>
           </a:xfrm>
           <a:prstGeom prst="rect">
             <a:avLst/>
@@ -25002,7 +25002,73 @@
                 <a:ea typeface="Calibri" pitchFamily="34" charset="-122"/>
                 <a:cs typeface="Calibri" pitchFamily="34" charset="-120"/>
               </a:rPr>
-              <a:t>verify</a:t>
+              <a:t>board heartbeat</a:t>
+            </a:r>
+            <a:endParaRPr lang="en-US" sz="1000" dirty="0"/>
+          </a:p>
+        </p:txBody>
+      </p:sp>
+      <p:sp>
+        <p:nvSpPr>
+          <p:cNvPr id="168" name="Shape 166"/>
+          <p:cNvSpPr/>
+          <p:nvPr/>
+        </p:nvSpPr>
+        <p:spPr>
+          <a:xfrm>
+            <a:off x="10585704" y="5833872"/>
+            <a:ext cx="1077976" cy="256032"/>
+          </a:xfrm>
+          <a:prstGeom prst="roundRect">
+            <a:avLst>
+              <a:gd name="adj" fmla="val 50000"/>
+            </a:avLst>
+          </a:prstGeom>
+          <a:solidFill>
+            <a:srgbClr val="F3F5F8"/>
+          </a:solidFill>
+          <a:ln w="12700">
+            <a:solidFill>
+              <a:srgbClr val="F3F5F8"/>
+            </a:solidFill>
+            <a:prstDash val="solid"/>
+          </a:ln>
+        </p:spPr>
+      </p:sp>
+      <p:sp>
+        <p:nvSpPr>
+          <p:cNvPr id="169" name="Text 167"/>
+          <p:cNvSpPr txBox="1"/>
+          <p:nvPr/>
+        </p:nvSpPr>
+        <p:spPr>
+          <a:xfrm>
+            <a:off x="10585704" y="5833872"/>
+            <a:ext cx="1077976" cy="256032"/>
+          </a:xfrm>
+          <a:prstGeom prst="rect">
+            <a:avLst/>
+          </a:prstGeom>
+          <a:noFill/>
+          <a:ln/>
+        </p:spPr>
+        <p:txBody>
+          <a:bodyPr wrap="square" lIns="0" tIns="0" rIns="0" bIns="0" rtlCol="0" anchor="ctr"/>
+          <a:lstStyle/>
+          <a:p>
+            <a:pPr algn="ctr" indent="0" marL="0">
+              <a:buNone/>
+            </a:pPr>
+            <a:r>
+              <a:rPr lang="en-US" sz="1000" dirty="0">
+                <a:solidFill>
+                  <a:srgbClr val="1F2430"/>
+                </a:solidFill>
+                <a:latin typeface="Calibri" pitchFamily="34" charset="0"/>
+                <a:ea typeface="Calibri" pitchFamily="34" charset="-122"/>
+                <a:cs typeface="Calibri" pitchFamily="34" charset="-120"/>
+              </a:rPr>
+              <a:t>board release</a:t>
             </a:r>
             <a:endParaRPr lang="en-US" sz="1000" dirty="0"/>
           </a:p>
@@ -27648,7 +27714,7 @@
                 <a:ea typeface="Courier New" pitchFamily="34" charset="-122"/>
                 <a:cs typeface="Courier New" pitchFamily="34" charset="-120"/>
               </a:rPr>
-              <a:t>  sdlc 0.22.4, license: community</a:t>
+              <a:t>  sdlc 0.23.0, license: community</a:t>
             </a:r>
             <a:endParaRPr lang="en-US" sz="1000" dirty="0"/>
           </a:p>

</xml_diff>

<commit_message>
fix: records written before 0.23.2 stay readable (0.23.3)
0.23.2 made signing_key strict and re-validated stored records with the new rule: an old dismissed settings proposal
with a path as signing_key made config show and config propose fail, and a placeholder key in roles.yaml history
would make approvals verify fail. Closed proposals and past roles.yaml versions are history and are read as they are;
the current roles.yaml and open proposals stay strict.
</commit_message>
<xml_diff>
--- a/docs/demo/sdlc-calculator-demo.en.pptx
+++ b/docs/demo/sdlc-calculator-demo.en.pptx
@@ -6677,7 +6677,7 @@
                 <a:ea typeface="Courier New" pitchFamily="34" charset="-122"/>
                 <a:cs typeface="Courier New" pitchFamily="34" charset="-120"/>
               </a:rPr>
-              <a:t>  code-owner (9d42f5b6d4b3)</a:t>
+              <a:t>  code-owner (659b84ac1051)</a:t>
             </a:r>
             <a:endParaRPr lang="en-US" sz="1000" dirty="0"/>
           </a:p>
@@ -6762,7 +6762,7 @@
                 <a:ea typeface="Courier New" pitchFamily="34" charset="-122"/>
                 <a:cs typeface="Courier New" pitchFamily="34" charset="-120"/>
               </a:rPr>
-              <a:t>  "SDLC-Approval: basic-arithmetic:review:9</a:t>
+              <a:t>  "SDLC-Approval: basic-arithmetic:review:6</a:t>
             </a:r>
             <a:endParaRPr lang="en-US" sz="1000" dirty="0"/>
           </a:p>
@@ -6779,7 +6779,7 @@
                 <a:ea typeface="Courier New" pitchFamily="34" charset="-122"/>
                 <a:cs typeface="Courier New" pitchFamily="34" charset="-120"/>
               </a:rPr>
-              <a:t>  d42f5b6d4b3"</a:t>
+              <a:t>  59b84ac1051"</a:t>
             </a:r>
             <a:endParaRPr lang="en-US" sz="1000" dirty="0"/>
           </a:p>
@@ -7460,7 +7460,7 @@
                 <a:ea typeface="Courier New" pitchFamily="34" charset="-122"/>
                 <a:cs typeface="Courier New" pitchFamily="34" charset="-120"/>
               </a:rPr>
-              <a:t>  release-manager (9d42f5b6d4b3)</a:t>
+              <a:t>  release-manager (659b84ac1051)</a:t>
             </a:r>
             <a:endParaRPr lang="en-US" sz="1000" dirty="0"/>
           </a:p>
@@ -7528,7 +7528,7 @@
                 <a:ea typeface="Courier New" pitchFamily="34" charset="-122"/>
                 <a:cs typeface="Courier New" pitchFamily="34" charset="-120"/>
               </a:rPr>
-              <a:t>  gate" -m "SDLC-Approval: basic-arithmetic:release:9d42f5b6d4b3"</a:t>
+              <a:t>  gate" -m "SDLC-Approval: basic-arithmetic:release:659b84ac1051"</a:t>
             </a:r>
             <a:endParaRPr lang="en-US" sz="1000" dirty="0"/>
           </a:p>
@@ -7811,7 +7811,7 @@
                 <a:ea typeface="Courier New" pitchFamily="34" charset="-122"/>
                 <a:cs typeface="Courier New" pitchFamily="34" charset="-120"/>
               </a:rPr>
-              <a:t>✓ basic-arithmetic/intent alice valid 70e703af trailer: missing</a:t>
+              <a:t>✓ basic-arithmetic/intent alice valid 6d23bcc8 trailer: missing</a:t>
             </a:r>
             <a:endParaRPr lang="en-US" sz="1000" dirty="0"/>
           </a:p>
@@ -7828,7 +7828,7 @@
                 <a:ea typeface="Courier New" pitchFamily="34" charset="-122"/>
                 <a:cs typeface="Courier New" pitchFamily="34" charset="-120"/>
               </a:rPr>
-              <a:t>✓ basic-arithmetic/spec alice valid 570f14b2 trailer: missing</a:t>
+              <a:t>✓ basic-arithmetic/spec alice valid a37f8050 trailer: missing</a:t>
             </a:r>
             <a:endParaRPr lang="en-US" sz="1000" dirty="0"/>
           </a:p>
@@ -7845,7 +7845,7 @@
                 <a:ea typeface="Courier New" pitchFamily="34" charset="-122"/>
                 <a:cs typeface="Courier New" pitchFamily="34" charset="-120"/>
               </a:rPr>
-              <a:t>✗ basic-arithmetic/plan bob wrong-signer 570f14b2 trailer: missing</a:t>
+              <a:t>✗ basic-arithmetic/plan bob wrong-signer a37f8050 trailer: missing</a:t>
             </a:r>
             <a:endParaRPr lang="en-US" sz="1000" dirty="0"/>
           </a:p>
@@ -7862,7 +7862,7 @@
                 <a:ea typeface="Courier New" pitchFamily="34" charset="-122"/>
                 <a:cs typeface="Courier New" pitchFamily="34" charset="-120"/>
               </a:rPr>
-              <a:t>✓ basic-arithmetic/review carol valid a47f201e trailer: missing</a:t>
+              <a:t>✓ basic-arithmetic/review carol valid 13f0fca7 trailer: missing</a:t>
             </a:r>
             <a:endParaRPr lang="en-US" sz="1000" dirty="0"/>
           </a:p>
@@ -7879,7 +7879,7 @@
                 <a:ea typeface="Courier New" pitchFamily="34" charset="-122"/>
                 <a:cs typeface="Courier New" pitchFamily="34" charset="-120"/>
               </a:rPr>
-              <a:t>✓ basic-arithmetic/release alice valid b91bc189 trailer: missing</a:t>
+              <a:t>✓ basic-arithmetic/release alice valid 4a5d05fb trailer: missing</a:t>
             </a:r>
             <a:endParaRPr lang="en-US" sz="1000" dirty="0"/>
           </a:p>
@@ -7896,7 +7896,7 @@
                 <a:ea typeface="Courier New" pitchFamily="34" charset="-122"/>
                 <a:cs typeface="Courier New" pitchFamily="34" charset="-120"/>
               </a:rPr>
-              <a:t>✓ openspec/roles.yaml alice@calc.example bootstrap 3d92b77e</a:t>
+              <a:t>✓ openspec/roles.yaml alice@calc.example bootstrap cc9dd892</a:t>
             </a:r>
             <a:endParaRPr lang="en-US" sz="1000" dirty="0"/>
           </a:p>
@@ -14450,7 +14450,7 @@
                 <a:ea typeface="Courier New" pitchFamily="34" charset="-122"/>
                 <a:cs typeface="Courier New" pitchFamily="34" charset="-120"/>
               </a:rPr>
-              <a:t>  archived) · sdlc 0.23.2, license:</a:t>
+              <a:t>  archived) · sdlc 0.23.3, license:</a:t>
             </a:r>
             <a:endParaRPr lang="en-US" sz="1000" dirty="0"/>
           </a:p>
@@ -14971,7 +14971,7 @@
                 <a:ea typeface="Courier New" pitchFamily="34" charset="-122"/>
                 <a:cs typeface="Courier New" pitchFamily="34" charset="-120"/>
               </a:rPr>
-              <a:t>2026-10-18T07:40:53.720Z  gate.review.await</a:t>
+              <a:t>2026-10-18T10:02:12.747Z  gate.review.await</a:t>
             </a:r>
             <a:endParaRPr lang="en-US" sz="1000" dirty="0"/>
           </a:p>
@@ -15005,7 +15005,7 @@
                 <a:ea typeface="Courier New" pitchFamily="34" charset="-122"/>
                 <a:cs typeface="Courier New" pitchFamily="34" charset="-120"/>
               </a:rPr>
-              <a:t>  sha256:9d42f5b6d4b3d84999138004781b26bf1e</a:t>
+              <a:t>  sha256:659b84ac1051b4d6c45682c053da8bbf09</a:t>
             </a:r>
             <a:endParaRPr lang="en-US" sz="1000" dirty="0"/>
           </a:p>
@@ -15022,7 +15022,7 @@
                 <a:ea typeface="Courier New" pitchFamily="34" charset="-122"/>
                 <a:cs typeface="Courier New" pitchFamily="34" charset="-120"/>
               </a:rPr>
-              <a:t>  81ecdf1814b1080690b954aea061e2 [sdlc</a:t>
+              <a:t>  c74ff9a410578d0fefacf6c89cba62 [sdlc</a:t>
             </a:r>
             <a:endParaRPr lang="en-US" sz="1000" dirty="0"/>
           </a:p>
@@ -15039,7 +15039,7 @@
                 <a:ea typeface="Courier New" pitchFamily="34" charset="-122"/>
                 <a:cs typeface="Courier New" pitchFamily="34" charset="-120"/>
               </a:rPr>
-              <a:t>  0.23.2 · community]</a:t>
+              <a:t>  0.23.3 · community]</a:t>
             </a:r>
             <a:endParaRPr lang="en-US" sz="1000" dirty="0"/>
           </a:p>
@@ -15056,7 +15056,7 @@
                 <a:ea typeface="Courier New" pitchFamily="34" charset="-122"/>
                 <a:cs typeface="Courier New" pitchFamily="34" charset="-120"/>
               </a:rPr>
-              <a:t>2026-10-18T07:40:56.588Z  gate.review.appro</a:t>
+              <a:t>2026-10-18T10:02:15.829Z  gate.review.appro</a:t>
             </a:r>
             <a:endParaRPr lang="en-US" sz="1000" dirty="0"/>
           </a:p>
@@ -15107,7 +15107,7 @@
                 <a:ea typeface="Courier New" pitchFamily="34" charset="-122"/>
                 <a:cs typeface="Courier New" pitchFamily="34" charset="-120"/>
               </a:rPr>
-              <a:t>  [sdlc 0.23.2 · community]</a:t>
+              <a:t>  [sdlc 0.23.3 · community]</a:t>
             </a:r>
             <a:endParaRPr lang="en-US" sz="1000" dirty="0"/>
           </a:p>
@@ -15124,7 +15124,7 @@
                 <a:ea typeface="Courier New" pitchFamily="34" charset="-122"/>
                 <a:cs typeface="Courier New" pitchFamily="34" charset="-120"/>
               </a:rPr>
-              <a:t>2026-10-18T07:41:02.664Z  gate.release.appr</a:t>
+              <a:t>2026-10-18T10:02:22.085Z  gate.release.appr</a:t>
             </a:r>
             <a:endParaRPr lang="en-US" sz="1000" dirty="0"/>
           </a:p>
@@ -15175,7 +15175,7 @@
                 <a:ea typeface="Courier New" pitchFamily="34" charset="-122"/>
                 <a:cs typeface="Courier New" pitchFamily="34" charset="-120"/>
               </a:rPr>
-              <a:t>  release-manager [sdlc 0.23.2 · community]</a:t>
+              <a:t>  release-manager [sdlc 0.23.3 · community]</a:t>
             </a:r>
             <a:endParaRPr lang="en-US" sz="1000" dirty="0"/>
           </a:p>
@@ -16503,7 +16503,7 @@
                 <a:ea typeface="Courier New" pitchFamily="34" charset="-122"/>
                 <a:cs typeface="Courier New" pitchFamily="34" charset="-120"/>
               </a:rPr>
-              <a:t>✓ test (0.9s)</a:t>
+              <a:t>✓ test (1.0s)</a:t>
             </a:r>
             <a:endParaRPr lang="en-US" sz="1000" dirty="0"/>
           </a:p>
@@ -16956,7 +16956,7 @@
                 <a:ea typeface="Courier New" pitchFamily="34" charset="-122"/>
                 <a:cs typeface="Courier New" pitchFamily="34" charset="-120"/>
               </a:rPr>
-              <a:t>      "id": "20261018T074156793Z-ci-green-d</a:t>
+              <a:t>      "id": "20261018T100323658Z-ci-green-f</a:t>
             </a:r>
             <a:endParaRPr lang="en-US" sz="1000" dirty="0"/>
           </a:p>
@@ -16973,7 +16973,7 @@
                 <a:ea typeface="Courier New" pitchFamily="34" charset="-122"/>
                 <a:cs typeface="Courier New" pitchFamily="34" charset="-120"/>
               </a:rPr>
-              <a:t>  04ca9",</a:t>
+              <a:t>  b676c",</a:t>
             </a:r>
             <a:endParaRPr lang="en-US" sz="1000" dirty="0"/>
           </a:p>
@@ -17109,7 +17109,7 @@
                 <a:ea typeface="Courier New" pitchFamily="34" charset="-122"/>
                 <a:cs typeface="Courier New" pitchFamily="34" charset="-120"/>
               </a:rPr>
-              <a:t>        "ref": "be77f0dbb0a8758658e1211b191</a:t>
+              <a:t>        "ref": "7417fd068c650602e321b2c67f6</a:t>
             </a:r>
             <a:endParaRPr lang="en-US" sz="1000" dirty="0"/>
           </a:p>
@@ -17126,7 +17126,7 @@
                 <a:ea typeface="Courier New" pitchFamily="34" charset="-122"/>
                 <a:cs typeface="Courier New" pitchFamily="34" charset="-120"/>
               </a:rPr>
-              <a:t>  417752eb59660",</a:t>
+              <a:t>  252f9a12ddfd1",</a:t>
             </a:r>
             <a:endParaRPr lang="en-US" sz="1000" dirty="0"/>
           </a:p>
@@ -27782,7 +27782,7 @@
                 <a:ea typeface="Courier New" pitchFamily="34" charset="-122"/>
                 <a:cs typeface="Courier New" pitchFamily="34" charset="-120"/>
               </a:rPr>
-              <a:t>  sdlc 0.23.2, license: community</a:t>
+              <a:t>  sdlc 0.23.3, license: community</a:t>
             </a:r>
             <a:endParaRPr lang="en-US" sz="1000" dirty="0"/>
           </a:p>

</xml_diff>

<commit_message>
fix: artifacts land in the change folder, the submit fetches a pushed branch, a branch per claim (0.23.5)
The findings of handing a plan's tasks to an executor swarm: agents wrote artifacts at the repository root, a pushed
result branch was unknown to the board host, and a retry overwrote the rejected attempt.

- outputPath in the instructions JSON is relative to the project root (openspec/changes/<id>/plan.md).
- board submit and task check-result fetch a result branch from origin when the host lacks it; only a valid branch
  name, only from origin, into a private ref.
- Each claim gets its own result branch; previousAttempts keeps the head commit of each attempt.
- The board tools over MCP accept JSON numbers; board list no longer shows "executor/?".
</commit_message>
<xml_diff>
--- a/docs/demo/sdlc-calculator-demo.en.pptx
+++ b/docs/demo/sdlc-calculator-demo.en.pptx
@@ -6677,7 +6677,7 @@
                 <a:ea typeface="Courier New" pitchFamily="34" charset="-122"/>
                 <a:cs typeface="Courier New" pitchFamily="34" charset="-120"/>
               </a:rPr>
-              <a:t>  code-owner (e2e28d51fcfa)</a:t>
+              <a:t>  code-owner (bccd305cafc5)</a:t>
             </a:r>
             <a:endParaRPr lang="en-US" sz="1000" dirty="0"/>
           </a:p>
@@ -6762,7 +6762,7 @@
                 <a:ea typeface="Courier New" pitchFamily="34" charset="-122"/>
                 <a:cs typeface="Courier New" pitchFamily="34" charset="-120"/>
               </a:rPr>
-              <a:t>  "SDLC-Approval: basic-arithmetic:review:e</a:t>
+              <a:t>  "SDLC-Approval: basic-arithmetic:review:b</a:t>
             </a:r>
             <a:endParaRPr lang="en-US" sz="1000" dirty="0"/>
           </a:p>
@@ -6779,7 +6779,7 @@
                 <a:ea typeface="Courier New" pitchFamily="34" charset="-122"/>
                 <a:cs typeface="Courier New" pitchFamily="34" charset="-120"/>
               </a:rPr>
-              <a:t>  2e28d51fcfa"</a:t>
+              <a:t>  ccd305cafc5"</a:t>
             </a:r>
             <a:endParaRPr lang="en-US" sz="1000" dirty="0"/>
           </a:p>
@@ -7460,7 +7460,7 @@
                 <a:ea typeface="Courier New" pitchFamily="34" charset="-122"/>
                 <a:cs typeface="Courier New" pitchFamily="34" charset="-120"/>
               </a:rPr>
-              <a:t>  release-manager (e2e28d51fcfa)</a:t>
+              <a:t>  release-manager (bccd305cafc5)</a:t>
             </a:r>
             <a:endParaRPr lang="en-US" sz="1000" dirty="0"/>
           </a:p>
@@ -7528,7 +7528,7 @@
                 <a:ea typeface="Courier New" pitchFamily="34" charset="-122"/>
                 <a:cs typeface="Courier New" pitchFamily="34" charset="-120"/>
               </a:rPr>
-              <a:t>  gate" -m "SDLC-Approval: basic-arithmetic:release:e2e28d51fcfa"</a:t>
+              <a:t>  gate" -m "SDLC-Approval: basic-arithmetic:release:bccd305cafc5"</a:t>
             </a:r>
             <a:endParaRPr lang="en-US" sz="1000" dirty="0"/>
           </a:p>
@@ -7811,7 +7811,7 @@
                 <a:ea typeface="Courier New" pitchFamily="34" charset="-122"/>
                 <a:cs typeface="Courier New" pitchFamily="34" charset="-120"/>
               </a:rPr>
-              <a:t>✓ basic-arithmetic/intent alice valid cfa660cd trailer: missing</a:t>
+              <a:t>✓ basic-arithmetic/intent alice valid 442a8a44 trailer: missing</a:t>
             </a:r>
             <a:endParaRPr lang="en-US" sz="1000" dirty="0"/>
           </a:p>
@@ -7828,7 +7828,7 @@
                 <a:ea typeface="Courier New" pitchFamily="34" charset="-122"/>
                 <a:cs typeface="Courier New" pitchFamily="34" charset="-120"/>
               </a:rPr>
-              <a:t>✓ basic-arithmetic/spec alice valid 407fc91b trailer: missing</a:t>
+              <a:t>✓ basic-arithmetic/spec alice valid 1dc667d7 trailer: missing</a:t>
             </a:r>
             <a:endParaRPr lang="en-US" sz="1000" dirty="0"/>
           </a:p>
@@ -7845,7 +7845,7 @@
                 <a:ea typeface="Courier New" pitchFamily="34" charset="-122"/>
                 <a:cs typeface="Courier New" pitchFamily="34" charset="-120"/>
               </a:rPr>
-              <a:t>✗ basic-arithmetic/plan bob wrong-signer 407fc91b trailer: missing</a:t>
+              <a:t>✗ basic-arithmetic/plan bob wrong-signer 1dc667d7 trailer: missing</a:t>
             </a:r>
             <a:endParaRPr lang="en-US" sz="1000" dirty="0"/>
           </a:p>
@@ -7862,7 +7862,7 @@
                 <a:ea typeface="Courier New" pitchFamily="34" charset="-122"/>
                 <a:cs typeface="Courier New" pitchFamily="34" charset="-120"/>
               </a:rPr>
-              <a:t>✓ basic-arithmetic/review carol valid 0b0207fc trailer: missing</a:t>
+              <a:t>✓ basic-arithmetic/review carol valid 919fd04f trailer: missing</a:t>
             </a:r>
             <a:endParaRPr lang="en-US" sz="1000" dirty="0"/>
           </a:p>
@@ -7879,7 +7879,7 @@
                 <a:ea typeface="Courier New" pitchFamily="34" charset="-122"/>
                 <a:cs typeface="Courier New" pitchFamily="34" charset="-120"/>
               </a:rPr>
-              <a:t>✓ basic-arithmetic/release alice valid d11cf702 trailer: missing</a:t>
+              <a:t>✓ basic-arithmetic/release alice valid 73031a73 trailer: missing</a:t>
             </a:r>
             <a:endParaRPr lang="en-US" sz="1000" dirty="0"/>
           </a:p>
@@ -7896,7 +7896,7 @@
                 <a:ea typeface="Courier New" pitchFamily="34" charset="-122"/>
                 <a:cs typeface="Courier New" pitchFamily="34" charset="-120"/>
               </a:rPr>
-              <a:t>✓ openspec/roles.yaml alice@calc.example bootstrap 72ca21eb</a:t>
+              <a:t>✓ openspec/roles.yaml alice@calc.example bootstrap 1a0e1f22</a:t>
             </a:r>
             <a:endParaRPr lang="en-US" sz="1000" dirty="0"/>
           </a:p>
@@ -14382,7 +14382,7 @@
                 <a:ea typeface="Courier New" pitchFamily="34" charset="-122"/>
                 <a:cs typeface="Courier New" pitchFamily="34" charset="-120"/>
               </a:rPr>
-              <a:t>  archived) · sdlc 0.23.4, license:</a:t>
+              <a:t>  archived) · sdlc 0.23.5, license:</a:t>
             </a:r>
             <a:endParaRPr lang="en-US" sz="1000" dirty="0"/>
           </a:p>
@@ -14903,7 +14903,7 @@
                 <a:ea typeface="Courier New" pitchFamily="34" charset="-122"/>
                 <a:cs typeface="Courier New" pitchFamily="34" charset="-120"/>
               </a:rPr>
-              <a:t>2026-10-18T14:15:06.640Z  gate.review.await</a:t>
+              <a:t>2026-10-18T16:59:06.073Z  gate.review.await</a:t>
             </a:r>
             <a:endParaRPr lang="en-US" sz="1000" dirty="0"/>
           </a:p>
@@ -14937,7 +14937,7 @@
                 <a:ea typeface="Courier New" pitchFamily="34" charset="-122"/>
                 <a:cs typeface="Courier New" pitchFamily="34" charset="-120"/>
               </a:rPr>
-              <a:t>  sha256:e2e28d51fcfafdac544b25e0cda8b3addc</a:t>
+              <a:t>  sha256:bccd305cafc5d05c4aacd90063e1e6496f</a:t>
             </a:r>
             <a:endParaRPr lang="en-US" sz="1000" dirty="0"/>
           </a:p>
@@ -14954,7 +14954,7 @@
                 <a:ea typeface="Courier New" pitchFamily="34" charset="-122"/>
                 <a:cs typeface="Courier New" pitchFamily="34" charset="-120"/>
               </a:rPr>
-              <a:t>  b5c13463885a28fe4056adaa09ada7 [sdlc</a:t>
+              <a:t>  57806e25d0ff2f6c880d540e304f80 [sdlc</a:t>
             </a:r>
             <a:endParaRPr lang="en-US" sz="1000" dirty="0"/>
           </a:p>
@@ -14971,7 +14971,7 @@
                 <a:ea typeface="Courier New" pitchFamily="34" charset="-122"/>
                 <a:cs typeface="Courier New" pitchFamily="34" charset="-120"/>
               </a:rPr>
-              <a:t>  0.23.4 · community]</a:t>
+              <a:t>  0.23.5 · community]</a:t>
             </a:r>
             <a:endParaRPr lang="en-US" sz="1000" dirty="0"/>
           </a:p>
@@ -14988,7 +14988,7 @@
                 <a:ea typeface="Courier New" pitchFamily="34" charset="-122"/>
                 <a:cs typeface="Courier New" pitchFamily="34" charset="-120"/>
               </a:rPr>
-              <a:t>2026-10-18T14:15:09.755Z  gate.review.appro</a:t>
+              <a:t>2026-10-18T16:59:09.425Z  gate.review.appro</a:t>
             </a:r>
             <a:endParaRPr lang="en-US" sz="1000" dirty="0"/>
           </a:p>
@@ -15039,7 +15039,7 @@
                 <a:ea typeface="Courier New" pitchFamily="34" charset="-122"/>
                 <a:cs typeface="Courier New" pitchFamily="34" charset="-120"/>
               </a:rPr>
-              <a:t>  [sdlc 0.23.4 · community]</a:t>
+              <a:t>  [sdlc 0.23.5 · community]</a:t>
             </a:r>
             <a:endParaRPr lang="en-US" sz="1000" dirty="0"/>
           </a:p>
@@ -15056,7 +15056,7 @@
                 <a:ea typeface="Courier New" pitchFamily="34" charset="-122"/>
                 <a:cs typeface="Courier New" pitchFamily="34" charset="-120"/>
               </a:rPr>
-              <a:t>2026-10-18T14:15:16.373Z  gate.release.appr</a:t>
+              <a:t>2026-10-18T16:59:15.899Z  gate.release.appr</a:t>
             </a:r>
             <a:endParaRPr lang="en-US" sz="1000" dirty="0"/>
           </a:p>
@@ -15107,7 +15107,7 @@
                 <a:ea typeface="Courier New" pitchFamily="34" charset="-122"/>
                 <a:cs typeface="Courier New" pitchFamily="34" charset="-120"/>
               </a:rPr>
-              <a:t>  release-manager [sdlc 0.23.4 · community]</a:t>
+              <a:t>  release-manager [sdlc 0.23.5 · community]</a:t>
             </a:r>
             <a:endParaRPr lang="en-US" sz="1000" dirty="0"/>
           </a:p>
@@ -16452,7 +16452,7 @@
                 <a:ea typeface="Courier New" pitchFamily="34" charset="-122"/>
                 <a:cs typeface="Courier New" pitchFamily="34" charset="-120"/>
               </a:rPr>
-              <a:t>✓ ci-green (ci/pipeline_status, 0.6s)</a:t>
+              <a:t>✓ ci-green (ci/pipeline_status, 0.5s)</a:t>
             </a:r>
             <a:endParaRPr lang="en-US" sz="1000" dirty="0"/>
           </a:p>
@@ -16888,7 +16888,7 @@
                 <a:ea typeface="Courier New" pitchFamily="34" charset="-122"/>
                 <a:cs typeface="Courier New" pitchFamily="34" charset="-120"/>
               </a:rPr>
-              <a:t>      "id": "20261018T141613658Z-ci-green-a</a:t>
+              <a:t>      "id": "20261018T170013887Z-ci-green-d</a:t>
             </a:r>
             <a:endParaRPr lang="en-US" sz="1000" dirty="0"/>
           </a:p>
@@ -16905,7 +16905,7 @@
                 <a:ea typeface="Courier New" pitchFamily="34" charset="-122"/>
                 <a:cs typeface="Courier New" pitchFamily="34" charset="-120"/>
               </a:rPr>
-              <a:t>  ad74e",</a:t>
+              <a:t>  b57a1",</a:t>
             </a:r>
             <a:endParaRPr lang="en-US" sz="1000" dirty="0"/>
           </a:p>
@@ -17041,7 +17041,7 @@
                 <a:ea typeface="Courier New" pitchFamily="34" charset="-122"/>
                 <a:cs typeface="Courier New" pitchFamily="34" charset="-120"/>
               </a:rPr>
-              <a:t>        "ref": "808847017a4217cce2a75859527</a:t>
+              <a:t>        "ref": "128fc4a4b717c69392aad6930f1</a:t>
             </a:r>
             <a:endParaRPr lang="en-US" sz="1000" dirty="0"/>
           </a:p>
@@ -17058,7 +17058,7 @@
                 <a:ea typeface="Courier New" pitchFamily="34" charset="-122"/>
                 <a:cs typeface="Courier New" pitchFamily="34" charset="-120"/>
               </a:rPr>
-              <a:t>  6fcbc2ec74e64",</a:t>
+              <a:t>  9f358ceac95ce",</a:t>
             </a:r>
             <a:endParaRPr lang="en-US" sz="1000" dirty="0"/>
           </a:p>
@@ -27714,7 +27714,7 @@
                 <a:ea typeface="Courier New" pitchFamily="34" charset="-122"/>
                 <a:cs typeface="Courier New" pitchFamily="34" charset="-120"/>
               </a:rPr>
-              <a:t>  sdlc 0.23.4, license: community</a:t>
+              <a:t>  sdlc 0.23.5, license: community</a:t>
             </a:r>
             <a:endParaRPr lang="en-US" sz="1000" dirty="0"/>
           </a:p>

</xml_diff>

<commit_message>
fix: doctor finds Git Bash for Claude Code, init keeps untouched lines, one name per tool (0.23.6)
The findings of one team working with different agent tools: on Windows Claude Code could not run sdlc's hooks while
doctor said they were fine, a second init reformatted the settings, and the reviewer role lost the finding format.

- On Windows, doctor warns when Claude Code will not find Git Bash and names CLAUDE_CODE_GIT_BASH_PATH with the path.
- init and update change only the lines they set in openspec/sdlc.yaml.
- Hook decisions name Claude Code claude-code, like trailers and log events.
- A team role replacing a built-in subagent keeps the review.md finding format.
- doctor and the Codex guide explain headless codex exec and hooks; a denied shell write names its files.
- MCP over HTTP keeps idle connections for 65 s, so clients that pause between calls are not reset.
</commit_message>
<xml_diff>
--- a/docs/demo/sdlc-calculator-demo.en.pptx
+++ b/docs/demo/sdlc-calculator-demo.en.pptx
@@ -5112,7 +5112,7 @@
                 <a:ea typeface="Courier New" pitchFamily="34" charset="-122"/>
                 <a:cs typeface="Courier New" pitchFamily="34" charset="-120"/>
               </a:rPr>
-              <a:t>✓ test (1.0s)</a:t>
+              <a:t>✓ test (1.1s)</a:t>
             </a:r>
             <a:endParaRPr lang="en-US" sz="1000" dirty="0"/>
           </a:p>
@@ -6677,7 +6677,7 @@
                 <a:ea typeface="Courier New" pitchFamily="34" charset="-122"/>
                 <a:cs typeface="Courier New" pitchFamily="34" charset="-120"/>
               </a:rPr>
-              <a:t>  code-owner (bccd305cafc5)</a:t>
+              <a:t>  code-owner (26a7c377f3c8)</a:t>
             </a:r>
             <a:endParaRPr lang="en-US" sz="1000" dirty="0"/>
           </a:p>
@@ -6762,7 +6762,7 @@
                 <a:ea typeface="Courier New" pitchFamily="34" charset="-122"/>
                 <a:cs typeface="Courier New" pitchFamily="34" charset="-120"/>
               </a:rPr>
-              <a:t>  "SDLC-Approval: basic-arithmetic:review:b</a:t>
+              <a:t>  "SDLC-Approval: basic-arithmetic:review:2</a:t>
             </a:r>
             <a:endParaRPr lang="en-US" sz="1000" dirty="0"/>
           </a:p>
@@ -6779,7 +6779,7 @@
                 <a:ea typeface="Courier New" pitchFamily="34" charset="-122"/>
                 <a:cs typeface="Courier New" pitchFamily="34" charset="-120"/>
               </a:rPr>
-              <a:t>  ccd305cafc5"</a:t>
+              <a:t>  6a7c377f3c8"</a:t>
             </a:r>
             <a:endParaRPr lang="en-US" sz="1000" dirty="0"/>
           </a:p>
@@ -7460,7 +7460,7 @@
                 <a:ea typeface="Courier New" pitchFamily="34" charset="-122"/>
                 <a:cs typeface="Courier New" pitchFamily="34" charset="-120"/>
               </a:rPr>
-              <a:t>  release-manager (bccd305cafc5)</a:t>
+              <a:t>  release-manager (26a7c377f3c8)</a:t>
             </a:r>
             <a:endParaRPr lang="en-US" sz="1000" dirty="0"/>
           </a:p>
@@ -7528,7 +7528,7 @@
                 <a:ea typeface="Courier New" pitchFamily="34" charset="-122"/>
                 <a:cs typeface="Courier New" pitchFamily="34" charset="-120"/>
               </a:rPr>
-              <a:t>  gate" -m "SDLC-Approval: basic-arithmetic:release:bccd305cafc5"</a:t>
+              <a:t>  gate" -m "SDLC-Approval: basic-arithmetic:release:26a7c377f3c8"</a:t>
             </a:r>
             <a:endParaRPr lang="en-US" sz="1000" dirty="0"/>
           </a:p>
@@ -7811,7 +7811,7 @@
                 <a:ea typeface="Courier New" pitchFamily="34" charset="-122"/>
                 <a:cs typeface="Courier New" pitchFamily="34" charset="-120"/>
               </a:rPr>
-              <a:t>✓ basic-arithmetic/intent alice valid 442a8a44 trailer: missing</a:t>
+              <a:t>✓ basic-arithmetic/intent alice valid e78dbba3 trailer: missing</a:t>
             </a:r>
             <a:endParaRPr lang="en-US" sz="1000" dirty="0"/>
           </a:p>
@@ -7828,7 +7828,7 @@
                 <a:ea typeface="Courier New" pitchFamily="34" charset="-122"/>
                 <a:cs typeface="Courier New" pitchFamily="34" charset="-120"/>
               </a:rPr>
-              <a:t>✓ basic-arithmetic/spec alice valid 1dc667d7 trailer: missing</a:t>
+              <a:t>✓ basic-arithmetic/spec alice valid ed5a4b9f trailer: missing</a:t>
             </a:r>
             <a:endParaRPr lang="en-US" sz="1000" dirty="0"/>
           </a:p>
@@ -7845,7 +7845,7 @@
                 <a:ea typeface="Courier New" pitchFamily="34" charset="-122"/>
                 <a:cs typeface="Courier New" pitchFamily="34" charset="-120"/>
               </a:rPr>
-              <a:t>✗ basic-arithmetic/plan bob wrong-signer 1dc667d7 trailer: missing</a:t>
+              <a:t>✗ basic-arithmetic/plan bob wrong-signer ed5a4b9f trailer: missing</a:t>
             </a:r>
             <a:endParaRPr lang="en-US" sz="1000" dirty="0"/>
           </a:p>
@@ -7862,7 +7862,7 @@
                 <a:ea typeface="Courier New" pitchFamily="34" charset="-122"/>
                 <a:cs typeface="Courier New" pitchFamily="34" charset="-120"/>
               </a:rPr>
-              <a:t>✓ basic-arithmetic/review carol valid 919fd04f trailer: missing</a:t>
+              <a:t>✓ basic-arithmetic/review carol valid 5379c75a trailer: missing</a:t>
             </a:r>
             <a:endParaRPr lang="en-US" sz="1000" dirty="0"/>
           </a:p>
@@ -7879,7 +7879,7 @@
                 <a:ea typeface="Courier New" pitchFamily="34" charset="-122"/>
                 <a:cs typeface="Courier New" pitchFamily="34" charset="-120"/>
               </a:rPr>
-              <a:t>✓ basic-arithmetic/release alice valid 73031a73 trailer: missing</a:t>
+              <a:t>✓ basic-arithmetic/release alice valid 09355dfe trailer: missing</a:t>
             </a:r>
             <a:endParaRPr lang="en-US" sz="1000" dirty="0"/>
           </a:p>
@@ -7896,7 +7896,7 @@
                 <a:ea typeface="Courier New" pitchFamily="34" charset="-122"/>
                 <a:cs typeface="Courier New" pitchFamily="34" charset="-120"/>
               </a:rPr>
-              <a:t>✓ openspec/roles.yaml alice@calc.example bootstrap 1a0e1f22</a:t>
+              <a:t>✓ openspec/roles.yaml alice@calc.example bootstrap 52876c45</a:t>
             </a:r>
             <a:endParaRPr lang="en-US" sz="1000" dirty="0"/>
           </a:p>
@@ -14382,7 +14382,7 @@
                 <a:ea typeface="Courier New" pitchFamily="34" charset="-122"/>
                 <a:cs typeface="Courier New" pitchFamily="34" charset="-120"/>
               </a:rPr>
-              <a:t>  archived) · sdlc 0.23.5, license:</a:t>
+              <a:t>  archived) · sdlc 0.23.6, license:</a:t>
             </a:r>
             <a:endParaRPr lang="en-US" sz="1000" dirty="0"/>
           </a:p>
@@ -14903,7 +14903,7 @@
                 <a:ea typeface="Courier New" pitchFamily="34" charset="-122"/>
                 <a:cs typeface="Courier New" pitchFamily="34" charset="-120"/>
               </a:rPr>
-              <a:t>2026-10-18T16:59:06.073Z  gate.review.await</a:t>
+              <a:t>2026-10-18T21:26:39.897Z  gate.review.await</a:t>
             </a:r>
             <a:endParaRPr lang="en-US" sz="1000" dirty="0"/>
           </a:p>
@@ -14937,7 +14937,7 @@
                 <a:ea typeface="Courier New" pitchFamily="34" charset="-122"/>
                 <a:cs typeface="Courier New" pitchFamily="34" charset="-120"/>
               </a:rPr>
-              <a:t>  sha256:bccd305cafc5d05c4aacd90063e1e6496f</a:t>
+              <a:t>  sha256:26a7c377f3c870d9f1d2cf1af64fc6efb2</a:t>
             </a:r>
             <a:endParaRPr lang="en-US" sz="1000" dirty="0"/>
           </a:p>
@@ -14954,7 +14954,7 @@
                 <a:ea typeface="Courier New" pitchFamily="34" charset="-122"/>
                 <a:cs typeface="Courier New" pitchFamily="34" charset="-120"/>
               </a:rPr>
-              <a:t>  57806e25d0ff2f6c880d540e304f80 [sdlc</a:t>
+              <a:t>  5cd5f8430d9e59ec51c4dd7b5a9ea2 [sdlc</a:t>
             </a:r>
             <a:endParaRPr lang="en-US" sz="1000" dirty="0"/>
           </a:p>
@@ -14971,7 +14971,7 @@
                 <a:ea typeface="Courier New" pitchFamily="34" charset="-122"/>
                 <a:cs typeface="Courier New" pitchFamily="34" charset="-120"/>
               </a:rPr>
-              <a:t>  0.23.5 · community]</a:t>
+              <a:t>  0.23.6 · community]</a:t>
             </a:r>
             <a:endParaRPr lang="en-US" sz="1000" dirty="0"/>
           </a:p>
@@ -14988,7 +14988,7 @@
                 <a:ea typeface="Courier New" pitchFamily="34" charset="-122"/>
                 <a:cs typeface="Courier New" pitchFamily="34" charset="-120"/>
               </a:rPr>
-              <a:t>2026-10-18T16:59:09.425Z  gate.review.appro</a:t>
+              <a:t>2026-10-18T21:26:43.120Z  gate.review.appro</a:t>
             </a:r>
             <a:endParaRPr lang="en-US" sz="1000" dirty="0"/>
           </a:p>
@@ -15039,7 +15039,7 @@
                 <a:ea typeface="Courier New" pitchFamily="34" charset="-122"/>
                 <a:cs typeface="Courier New" pitchFamily="34" charset="-120"/>
               </a:rPr>
-              <a:t>  [sdlc 0.23.5 · community]</a:t>
+              <a:t>  [sdlc 0.23.6 · community]</a:t>
             </a:r>
             <a:endParaRPr lang="en-US" sz="1000" dirty="0"/>
           </a:p>
@@ -15056,7 +15056,7 @@
                 <a:ea typeface="Courier New" pitchFamily="34" charset="-122"/>
                 <a:cs typeface="Courier New" pitchFamily="34" charset="-120"/>
               </a:rPr>
-              <a:t>2026-10-18T16:59:15.899Z  gate.release.appr</a:t>
+              <a:t>2026-10-18T21:26:50.211Z  gate.release.appr</a:t>
             </a:r>
             <a:endParaRPr lang="en-US" sz="1000" dirty="0"/>
           </a:p>
@@ -15107,7 +15107,7 @@
                 <a:ea typeface="Courier New" pitchFamily="34" charset="-122"/>
                 <a:cs typeface="Courier New" pitchFamily="34" charset="-120"/>
               </a:rPr>
-              <a:t>  release-manager [sdlc 0.23.5 · community]</a:t>
+              <a:t>  release-manager [sdlc 0.23.6 · community]</a:t>
             </a:r>
             <a:endParaRPr lang="en-US" sz="1000" dirty="0"/>
           </a:p>
@@ -16435,7 +16435,7 @@
                 <a:ea typeface="Courier New" pitchFamily="34" charset="-122"/>
                 <a:cs typeface="Courier New" pitchFamily="34" charset="-120"/>
               </a:rPr>
-              <a:t>✓ test (1.0s)</a:t>
+              <a:t>✓ test (1.1s)</a:t>
             </a:r>
             <a:endParaRPr lang="en-US" sz="1000" dirty="0"/>
           </a:p>
@@ -16888,7 +16888,7 @@
                 <a:ea typeface="Courier New" pitchFamily="34" charset="-122"/>
                 <a:cs typeface="Courier New" pitchFamily="34" charset="-120"/>
               </a:rPr>
-              <a:t>      "id": "20261018T170013887Z-ci-green-d</a:t>
+              <a:t>      "id": "20261018T212749913Z-ci-green-5</a:t>
             </a:r>
             <a:endParaRPr lang="en-US" sz="1000" dirty="0"/>
           </a:p>
@@ -16905,7 +16905,7 @@
                 <a:ea typeface="Courier New" pitchFamily="34" charset="-122"/>
                 <a:cs typeface="Courier New" pitchFamily="34" charset="-120"/>
               </a:rPr>
-              <a:t>  b57a1",</a:t>
+              <a:t>  4c479",</a:t>
             </a:r>
             <a:endParaRPr lang="en-US" sz="1000" dirty="0"/>
           </a:p>
@@ -17041,7 +17041,7 @@
                 <a:ea typeface="Courier New" pitchFamily="34" charset="-122"/>
                 <a:cs typeface="Courier New" pitchFamily="34" charset="-120"/>
               </a:rPr>
-              <a:t>        "ref": "128fc4a4b717c69392aad6930f1</a:t>
+              <a:t>        "ref": "f6580cf0e863a96fee8bffb52e3</a:t>
             </a:r>
             <a:endParaRPr lang="en-US" sz="1000" dirty="0"/>
           </a:p>
@@ -17058,7 +17058,7 @@
                 <a:ea typeface="Courier New" pitchFamily="34" charset="-122"/>
                 <a:cs typeface="Courier New" pitchFamily="34" charset="-120"/>
               </a:rPr>
-              <a:t>  9f358ceac95ce",</a:t>
+              <a:t>  58c6cfa48431b",</a:t>
             </a:r>
             <a:endParaRPr lang="en-US" sz="1000" dirty="0"/>
           </a:p>
@@ -27714,7 +27714,7 @@
                 <a:ea typeface="Courier New" pitchFamily="34" charset="-122"/>
                 <a:cs typeface="Courier New" pitchFamily="34" charset="-120"/>
               </a:rPr>
-              <a:t>  sdlc 0.23.5, license: community</a:t>
+              <a:t>  sdlc 0.23.6, license: community</a:t>
             </a:r>
             <a:endParaRPr lang="en-US" sz="1000" dirty="0"/>
           </a:p>

</xml_diff>

<commit_message>
fix: next names merged tasks, ended waits are not sent, reads leave tracked files alone (0.23.7)
The findings of finishing a change with executors: next counted merged board tasks as open, the board host's log
blocked pulls silently, a wait event could reach the chat after the wait ended, and reading commands touched a
tracked ignore file.

- next names unticked tasks whose SDLC-Task commits are in HEAD; board list says when the log is uncommitted.
- Queued waits for gates that no longer wait on that digest are dropped when the queue is sent.
- Reading commands never create or rewrite tracked files; the queue's rule goes into .git/info/exclude if needed.
</commit_message>
<xml_diff>
--- a/docs/demo/sdlc-calculator-demo.en.pptx
+++ b/docs/demo/sdlc-calculator-demo.en.pptx
@@ -5112,7 +5112,7 @@
                 <a:ea typeface="Courier New" pitchFamily="34" charset="-122"/>
                 <a:cs typeface="Courier New" pitchFamily="34" charset="-120"/>
               </a:rPr>
-              <a:t>✓ test (1.1s)</a:t>
+              <a:t>✓ test (0.9s)</a:t>
             </a:r>
             <a:endParaRPr lang="en-US" sz="1000" dirty="0"/>
           </a:p>
@@ -6677,7 +6677,7 @@
                 <a:ea typeface="Courier New" pitchFamily="34" charset="-122"/>
                 <a:cs typeface="Courier New" pitchFamily="34" charset="-120"/>
               </a:rPr>
-              <a:t>  code-owner (26a7c377f3c8)</a:t>
+              <a:t>  code-owner (2acc7d469d49)</a:t>
             </a:r>
             <a:endParaRPr lang="en-US" sz="1000" dirty="0"/>
           </a:p>
@@ -6779,7 +6779,7 @@
                 <a:ea typeface="Courier New" pitchFamily="34" charset="-122"/>
                 <a:cs typeface="Courier New" pitchFamily="34" charset="-120"/>
               </a:rPr>
-              <a:t>  6a7c377f3c8"</a:t>
+              <a:t>  acc7d469d49"</a:t>
             </a:r>
             <a:endParaRPr lang="en-US" sz="1000" dirty="0"/>
           </a:p>
@@ -7460,7 +7460,7 @@
                 <a:ea typeface="Courier New" pitchFamily="34" charset="-122"/>
                 <a:cs typeface="Courier New" pitchFamily="34" charset="-120"/>
               </a:rPr>
-              <a:t>  release-manager (26a7c377f3c8)</a:t>
+              <a:t>  release-manager (2acc7d469d49)</a:t>
             </a:r>
             <a:endParaRPr lang="en-US" sz="1000" dirty="0"/>
           </a:p>
@@ -7528,7 +7528,7 @@
                 <a:ea typeface="Courier New" pitchFamily="34" charset="-122"/>
                 <a:cs typeface="Courier New" pitchFamily="34" charset="-120"/>
               </a:rPr>
-              <a:t>  gate" -m "SDLC-Approval: basic-arithmetic:release:26a7c377f3c8"</a:t>
+              <a:t>  gate" -m "SDLC-Approval: basic-arithmetic:release:2acc7d469d49"</a:t>
             </a:r>
             <a:endParaRPr lang="en-US" sz="1000" dirty="0"/>
           </a:p>
@@ -7811,7 +7811,7 @@
                 <a:ea typeface="Courier New" pitchFamily="34" charset="-122"/>
                 <a:cs typeface="Courier New" pitchFamily="34" charset="-120"/>
               </a:rPr>
-              <a:t>✓ basic-arithmetic/intent alice valid e78dbba3 trailer: missing</a:t>
+              <a:t>✓ basic-arithmetic/intent alice valid 49c7dc35 trailer: missing</a:t>
             </a:r>
             <a:endParaRPr lang="en-US" sz="1000" dirty="0"/>
           </a:p>
@@ -7828,7 +7828,7 @@
                 <a:ea typeface="Courier New" pitchFamily="34" charset="-122"/>
                 <a:cs typeface="Courier New" pitchFamily="34" charset="-120"/>
               </a:rPr>
-              <a:t>✓ basic-arithmetic/spec alice valid ed5a4b9f trailer: missing</a:t>
+              <a:t>✓ basic-arithmetic/spec alice valid 10dc23b1 trailer: missing</a:t>
             </a:r>
             <a:endParaRPr lang="en-US" sz="1000" dirty="0"/>
           </a:p>
@@ -7845,7 +7845,7 @@
                 <a:ea typeface="Courier New" pitchFamily="34" charset="-122"/>
                 <a:cs typeface="Courier New" pitchFamily="34" charset="-120"/>
               </a:rPr>
-              <a:t>✗ basic-arithmetic/plan bob wrong-signer ed5a4b9f trailer: missing</a:t>
+              <a:t>✗ basic-arithmetic/plan bob wrong-signer 10dc23b1 trailer: missing</a:t>
             </a:r>
             <a:endParaRPr lang="en-US" sz="1000" dirty="0"/>
           </a:p>
@@ -7862,7 +7862,7 @@
                 <a:ea typeface="Courier New" pitchFamily="34" charset="-122"/>
                 <a:cs typeface="Courier New" pitchFamily="34" charset="-120"/>
               </a:rPr>
-              <a:t>✓ basic-arithmetic/review carol valid 5379c75a trailer: missing</a:t>
+              <a:t>✓ basic-arithmetic/review carol valid b8fea448 trailer: missing</a:t>
             </a:r>
             <a:endParaRPr lang="en-US" sz="1000" dirty="0"/>
           </a:p>
@@ -7879,7 +7879,7 @@
                 <a:ea typeface="Courier New" pitchFamily="34" charset="-122"/>
                 <a:cs typeface="Courier New" pitchFamily="34" charset="-120"/>
               </a:rPr>
-              <a:t>✓ basic-arithmetic/release alice valid 09355dfe trailer: missing</a:t>
+              <a:t>✓ basic-arithmetic/release alice valid 7e5227ed trailer: missing</a:t>
             </a:r>
             <a:endParaRPr lang="en-US" sz="1000" dirty="0"/>
           </a:p>
@@ -7896,7 +7896,7 @@
                 <a:ea typeface="Courier New" pitchFamily="34" charset="-122"/>
                 <a:cs typeface="Courier New" pitchFamily="34" charset="-120"/>
               </a:rPr>
-              <a:t>✓ openspec/roles.yaml alice@calc.example bootstrap 52876c45</a:t>
+              <a:t>✓ openspec/roles.yaml alice@calc.example bootstrap f5d961d2</a:t>
             </a:r>
             <a:endParaRPr lang="en-US" sz="1000" dirty="0"/>
           </a:p>
@@ -14382,7 +14382,7 @@
                 <a:ea typeface="Courier New" pitchFamily="34" charset="-122"/>
                 <a:cs typeface="Courier New" pitchFamily="34" charset="-120"/>
               </a:rPr>
-              <a:t>  archived) · sdlc 0.23.6, license:</a:t>
+              <a:t>  archived) · sdlc 0.23.7, license:</a:t>
             </a:r>
             <a:endParaRPr lang="en-US" sz="1000" dirty="0"/>
           </a:p>
@@ -14903,7 +14903,7 @@
                 <a:ea typeface="Courier New" pitchFamily="34" charset="-122"/>
                 <a:cs typeface="Courier New" pitchFamily="34" charset="-120"/>
               </a:rPr>
-              <a:t>2026-10-18T21:26:39.897Z  gate.review.await</a:t>
+              <a:t>2026-10-19T02:06:56.015Z  gate.review.await</a:t>
             </a:r>
             <a:endParaRPr lang="en-US" sz="1000" dirty="0"/>
           </a:p>
@@ -14937,7 +14937,7 @@
                 <a:ea typeface="Courier New" pitchFamily="34" charset="-122"/>
                 <a:cs typeface="Courier New" pitchFamily="34" charset="-120"/>
               </a:rPr>
-              <a:t>  sha256:26a7c377f3c870d9f1d2cf1af64fc6efb2</a:t>
+              <a:t>  sha256:2acc7d469d49aff5749151d7235f4e6b62</a:t>
             </a:r>
             <a:endParaRPr lang="en-US" sz="1000" dirty="0"/>
           </a:p>
@@ -14954,7 +14954,7 @@
                 <a:ea typeface="Courier New" pitchFamily="34" charset="-122"/>
                 <a:cs typeface="Courier New" pitchFamily="34" charset="-120"/>
               </a:rPr>
-              <a:t>  5cd5f8430d9e59ec51c4dd7b5a9ea2 [sdlc</a:t>
+              <a:t>  a0ec60c31a0d099cb5ee5b97477490 [sdlc</a:t>
             </a:r>
             <a:endParaRPr lang="en-US" sz="1000" dirty="0"/>
           </a:p>
@@ -14971,7 +14971,7 @@
                 <a:ea typeface="Courier New" pitchFamily="34" charset="-122"/>
                 <a:cs typeface="Courier New" pitchFamily="34" charset="-120"/>
               </a:rPr>
-              <a:t>  0.23.6 · community]</a:t>
+              <a:t>  0.23.7 · community]</a:t>
             </a:r>
             <a:endParaRPr lang="en-US" sz="1000" dirty="0"/>
           </a:p>
@@ -14988,7 +14988,7 @@
                 <a:ea typeface="Courier New" pitchFamily="34" charset="-122"/>
                 <a:cs typeface="Courier New" pitchFamily="34" charset="-120"/>
               </a:rPr>
-              <a:t>2026-10-18T21:26:43.120Z  gate.review.appro</a:t>
+              <a:t>2026-10-19T02:06:59.086Z  gate.review.appro</a:t>
             </a:r>
             <a:endParaRPr lang="en-US" sz="1000" dirty="0"/>
           </a:p>
@@ -15039,7 +15039,7 @@
                 <a:ea typeface="Courier New" pitchFamily="34" charset="-122"/>
                 <a:cs typeface="Courier New" pitchFamily="34" charset="-120"/>
               </a:rPr>
-              <a:t>  [sdlc 0.23.6 · community]</a:t>
+              <a:t>  [sdlc 0.23.7 · community]</a:t>
             </a:r>
             <a:endParaRPr lang="en-US" sz="1000" dirty="0"/>
           </a:p>
@@ -15056,7 +15056,7 @@
                 <a:ea typeface="Courier New" pitchFamily="34" charset="-122"/>
                 <a:cs typeface="Courier New" pitchFamily="34" charset="-120"/>
               </a:rPr>
-              <a:t>2026-10-18T21:26:50.211Z  gate.release.appr</a:t>
+              <a:t>2026-10-19T02:07:06.409Z  gate.release.appr</a:t>
             </a:r>
             <a:endParaRPr lang="en-US" sz="1000" dirty="0"/>
           </a:p>
@@ -15107,7 +15107,7 @@
                 <a:ea typeface="Courier New" pitchFamily="34" charset="-122"/>
                 <a:cs typeface="Courier New" pitchFamily="34" charset="-120"/>
               </a:rPr>
-              <a:t>  release-manager [sdlc 0.23.6 · community]</a:t>
+              <a:t>  release-manager [sdlc 0.23.7 · community]</a:t>
             </a:r>
             <a:endParaRPr lang="en-US" sz="1000" dirty="0"/>
           </a:p>
@@ -16435,7 +16435,7 @@
                 <a:ea typeface="Courier New" pitchFamily="34" charset="-122"/>
                 <a:cs typeface="Courier New" pitchFamily="34" charset="-120"/>
               </a:rPr>
-              <a:t>✓ test (1.1s)</a:t>
+              <a:t>✓ test (1.0s)</a:t>
             </a:r>
             <a:endParaRPr lang="en-US" sz="1000" dirty="0"/>
           </a:p>
@@ -16888,7 +16888,7 @@
                 <a:ea typeface="Courier New" pitchFamily="34" charset="-122"/>
                 <a:cs typeface="Courier New" pitchFamily="34" charset="-120"/>
               </a:rPr>
-              <a:t>      "id": "20261018T212749913Z-ci-green-5</a:t>
+              <a:t>      "id": "20261019T020803519Z-ci-green-0</a:t>
             </a:r>
             <a:endParaRPr lang="en-US" sz="1000" dirty="0"/>
           </a:p>
@@ -16905,7 +16905,7 @@
                 <a:ea typeface="Courier New" pitchFamily="34" charset="-122"/>
                 <a:cs typeface="Courier New" pitchFamily="34" charset="-120"/>
               </a:rPr>
-              <a:t>  4c479",</a:t>
+              <a:t>  b1840",</a:t>
             </a:r>
             <a:endParaRPr lang="en-US" sz="1000" dirty="0"/>
           </a:p>
@@ -17041,7 +17041,7 @@
                 <a:ea typeface="Courier New" pitchFamily="34" charset="-122"/>
                 <a:cs typeface="Courier New" pitchFamily="34" charset="-120"/>
               </a:rPr>
-              <a:t>        "ref": "f6580cf0e863a96fee8bffb52e3</a:t>
+              <a:t>        "ref": "e00c0a68ae2556bb02ac241720b</a:t>
             </a:r>
             <a:endParaRPr lang="en-US" sz="1000" dirty="0"/>
           </a:p>
@@ -17058,7 +17058,7 @@
                 <a:ea typeface="Courier New" pitchFamily="34" charset="-122"/>
                 <a:cs typeface="Courier New" pitchFamily="34" charset="-120"/>
               </a:rPr>
-              <a:t>  58c6cfa48431b",</a:t>
+              <a:t>  12ec12baf2f15",</a:t>
             </a:r>
             <a:endParaRPr lang="en-US" sz="1000" dirty="0"/>
           </a:p>
@@ -27714,7 +27714,7 @@
                 <a:ea typeface="Courier New" pitchFamily="34" charset="-122"/>
                 <a:cs typeface="Courier New" pitchFamily="34" charset="-120"/>
               </a:rPr>
-              <a:t>  sdlc 0.23.6, license: community</a:t>
+              <a:t>  sdlc 0.23.7, license: community</a:t>
             </a:r>
             <a:endParaRPr lang="en-US" sz="1000" dirty="0"/>
           </a:p>

</xml_diff>